<commit_message>
docs: reescreve os títulos dos slides em tom de trabalho acadêmico
Co-Authored-By: Claude Opus 5 <noreply@anthropic.com>
</commit_message>
<xml_diff>
--- a/trabalhos/T1-Docker-Invite-People.pptx
+++ b/trabalhos/T1-Docker-Invite-People.pptx
@@ -11702,7 +11702,7 @@
                 </a:solidFill>
                 <a:latin typeface="Roboto"/>
               </a:rPr>
-              <a:t>Do diagrama</a:t>
+              <a:t>Docker e</a:t>
             </a:r>
           </a:p>
           <a:p>
@@ -11718,7 +11718,7 @@
                 </a:solidFill>
                 <a:latin typeface="Roboto"/>
               </a:rPr>
-              <a:t>à execução</a:t>
+              <a:t>conteinerização</a:t>
             </a:r>
           </a:p>
         </p:txBody>
@@ -11803,7 +11803,7 @@
                 </a:solidFill>
                 <a:latin typeface="Roboto"/>
               </a:rPr>
-              <a:t>Conteinerização como decisão de arquitetura sobre empacotamento e implantação</a:t>
+              <a:t>Como o empacotamento em containers se aplica ao projeto Invite People</a:t>
             </a:r>
           </a:p>
         </p:txBody>
@@ -12174,7 +12174,7 @@
                 </a:solidFill>
                 <a:latin typeface="Roboto"/>
               </a:rPr>
-              <a:t>NÃO EXISTE CONTAINER NO KERNEL</a:t>
+              <a:t>O QUE O KERNEL ENXERGA</a:t>
             </a:r>
           </a:p>
         </p:txBody>
@@ -12213,7 +12213,7 @@
                 </a:solidFill>
                 <a:latin typeface="Roboto"/>
               </a:rPr>
-              <a:t>O que existe é um processo comum</a:t>
+              <a:t>Um container é um processo</a:t>
             </a:r>
           </a:p>
           <a:p>
@@ -12229,7 +12229,7 @@
                 </a:solidFill>
                 <a:latin typeface="Roboto"/>
               </a:rPr>
-              <a:t>com a visão restringida</a:t>
+              <a:t>com a visão restringida por namespaces</a:t>
             </a:r>
           </a:p>
         </p:txBody>
@@ -12995,7 +12995,7 @@
                 </a:solidFill>
                 <a:latin typeface="Roboto"/>
               </a:rPr>
-              <a:t>DOIS MECANISMOS, DOIS PAPÉIS</a:t>
+              <a:t>NAMESPACES E CGROUPS</a:t>
             </a:r>
           </a:p>
         </p:txBody>
@@ -13929,7 +13929,7 @@
                 </a:solidFill>
                 <a:latin typeface="Roboto"/>
               </a:rPr>
-              <a:t>A IMAGEM POR DENTRO</a:t>
+              <a:t>ESTRUTURA DA IMAGEM</a:t>
             </a:r>
           </a:p>
         </p:txBody>
@@ -13968,7 +13968,23 @@
                 </a:solidFill>
                 <a:latin typeface="Roboto"/>
               </a:rPr>
-              <a:t>Camadas empilhadas, uma só de escrita</a:t>
+              <a:t>Camadas somente leitura</a:t>
+            </a:r>
+          </a:p>
+          <a:p>
+            <a:pPr>
+              <a:lnSpc>
+                <a:spcPct val="104000"/>
+              </a:lnSpc>
+            </a:pPr>
+            <a:r>
+              <a:rPr sz="3000" b="1" i="0">
+                <a:solidFill>
+                  <a:srgbClr val="21049A"/>
+                </a:solidFill>
+                <a:latin typeface="Roboto"/>
+              </a:rPr>
+              <a:t>e a camada de escrita</a:t>
             </a:r>
           </a:p>
         </p:txBody>
@@ -14831,7 +14847,23 @@
                 </a:solidFill>
                 <a:latin typeface="Roboto"/>
               </a:rPr>
-              <a:t>Do comando ao processo</a:t>
+              <a:t>CLI, dockerd, containerd,</a:t>
+            </a:r>
+          </a:p>
+          <a:p>
+            <a:pPr>
+              <a:lnSpc>
+                <a:spcPct val="104000"/>
+              </a:lnSpc>
+            </a:pPr>
+            <a:r>
+              <a:rPr sz="3000" b="1" i="0">
+                <a:solidFill>
+                  <a:srgbClr val="21049A"/>
+                </a:solidFill>
+                <a:latin typeface="Roboto"/>
+              </a:rPr>
+              <a:t>shim e runc</a:t>
             </a:r>
           </a:p>
         </p:txBody>
@@ -15875,7 +15907,7 @@
                 </a:solidFill>
                 <a:latin typeface="Roboto"/>
               </a:rPr>
-              <a:t>TRÊS PAREDES, EM ORDEM</a:t>
+              <a:t>RESTRIÇÃO DE PRIVILÉGIO</a:t>
             </a:r>
           </a:p>
         </p:txBody>
@@ -15914,7 +15946,7 @@
                 </a:solidFill>
                 <a:latin typeface="Roboto"/>
               </a:rPr>
-              <a:t>O que separa o container do host</a:t>
+              <a:t>Capabilities, seccomp e LSM</a:t>
             </a:r>
           </a:p>
         </p:txBody>
@@ -16594,7 +16626,7 @@
                 </a:solidFill>
                 <a:latin typeface="Roboto"/>
               </a:rPr>
-              <a:t>Docker é a implementação</a:t>
+              <a:t>Docker implementa as</a:t>
             </a:r>
           </a:p>
           <a:p>
@@ -16610,23 +16642,7 @@
                 </a:solidFill>
                 <a:latin typeface="Roboto"/>
               </a:rPr>
-              <a:t>de um padrão aberto,</a:t>
-            </a:r>
-          </a:p>
-          <a:p>
-            <a:pPr>
-              <a:lnSpc>
-                <a:spcPct val="106000"/>
-              </a:lnSpc>
-            </a:pPr>
-            <a:r>
-              <a:rPr sz="3450" b="1" i="0">
-                <a:solidFill>
-                  <a:srgbClr val="FFFFFF"/>
-                </a:solidFill>
-                <a:latin typeface="Roboto"/>
-              </a:rPr>
-              <a:t>não o padrão.</a:t>
+              <a:t>especificações da OCI</a:t>
             </a:r>
           </a:p>
         </p:txBody>
@@ -16665,7 +16681,7 @@
                 </a:solidFill>
                 <a:latin typeface="Roboto"/>
               </a:rPr>
-              <a:t>Fundada em 2015 sob a Linux Foundation, com a Runtime Spec, a Image Spec e a Distribution Spec. O runc é trocável por crun, gVisor ou Kata. O engine é trocável por Podman. É a substituibilidade por compatibilidade de interface da Aula 05, acontecendo dentro da própria pilha da ferramenta.</a:t>
+              <a:t>Fundada em 2015 sob a Linux Foundation, com a Runtime Spec, a Image Spec e a Distribution Spec. O runc é trocável por crun, gVisor ou Kata. O engine é trocável por Podman. É um exemplo da substituibilidade por compatibilidade de interface da Aula 05.</a:t>
             </a:r>
           </a:p>
         </p:txBody>
@@ -17125,7 +17141,7 @@
                 </a:solidFill>
                 <a:latin typeface="Roboto"/>
               </a:rPr>
-              <a:t>Do diagrama para o arquivo, com o número de cada task do board na tela.</a:t>
+              <a:t>Mapeamento entre os diagramas da Sprint 2 e o arquivo de compose, com o número de cada task.</a:t>
             </a:r>
           </a:p>
         </p:txBody>
@@ -17292,7 +17308,7 @@
                 </a:solidFill>
                 <a:latin typeface="Roboto"/>
               </a:rPr>
-              <a:t>VOCABULÁRIO ANTES DO MAPEAMENTO</a:t>
+              <a:t>VOCABULÁRIO</a:t>
             </a:r>
           </a:p>
         </p:txBody>
@@ -17331,7 +17347,7 @@
                 </a:solidFill>
                 <a:latin typeface="Roboto"/>
               </a:rPr>
-              <a:t>Cinco termos que não podem</a:t>
+              <a:t>Componente, artefato, nó,</a:t>
             </a:r>
           </a:p>
           <a:p>
@@ -17347,7 +17363,7 @@
                 </a:solidFill>
                 <a:latin typeface="Roboto"/>
               </a:rPr>
-              <a:t>ser trocados entre si</a:t>
+              <a:t>imagem e container</a:t>
             </a:r>
           </a:p>
         </p:txBody>
@@ -18307,7 +18323,7 @@
                 </a:solidFill>
                 <a:latin typeface="Roboto"/>
               </a:rPr>
-              <a:t>LAYER CONTRA TIER, AULA 03</a:t>
+              <a:t>CAMADA LÓGICA E TIER, AULA 03</a:t>
             </a:r>
           </a:p>
         </p:txBody>
@@ -20152,7 +20168,7 @@
                 </a:solidFill>
                 <a:latin typeface="Roboto"/>
               </a:rPr>
-              <a:t>A MODELAGEM CORRETA</a:t>
+              <a:t>MODELAGEM UML</a:t>
             </a:r>
           </a:p>
         </p:txBody>
@@ -21036,7 +21052,7 @@
                 </a:solidFill>
                 <a:latin typeface="Roboto"/>
               </a:rPr>
-              <a:t>Que conceito da disciplina esta frase define?</a:t>
+              <a:t>FARIAS, K. Aula 05, Arquiteturas Baseadas em Componentes.</a:t>
             </a:r>
           </a:p>
         </p:txBody>
@@ -21242,7 +21258,7 @@
                 </a:solidFill>
                 <a:latin typeface="Roboto"/>
               </a:rPr>
-              <a:t>O compose é a forma executável</a:t>
+              <a:t>Mapeamento dos componentes</a:t>
             </a:r>
           </a:p>
           <a:p>
@@ -21258,7 +21274,7 @@
                 </a:solidFill>
                 <a:latin typeface="Roboto"/>
               </a:rPr>
-              <a:t>do diagrama que temos que desenhar</a:t>
+              <a:t>para os nós do diagrama</a:t>
             </a:r>
           </a:p>
         </p:txBody>
@@ -22712,7 +22728,7 @@
                 </a:solidFill>
                 <a:latin typeface="Roboto"/>
               </a:rPr>
-              <a:t>NOTAÇÃO DE COMPONENTE SOBRE O ARQUIVO</a:t>
+              <a:t>INTERFACES NO ARQUIVO DE COMPOSE</a:t>
             </a:r>
           </a:p>
         </p:txBody>
@@ -22751,7 +22767,7 @@
                 </a:solidFill>
                 <a:latin typeface="Roboto"/>
               </a:rPr>
-              <a:t>Pirulito e soquete</a:t>
+              <a:t>Onde ficam a interface</a:t>
             </a:r>
           </a:p>
           <a:p>
@@ -22767,7 +22783,7 @@
                 </a:solidFill>
                 <a:latin typeface="Roboto"/>
               </a:rPr>
-              <a:t>estão no compose</a:t>
+              <a:t>provida e a requerida</a:t>
             </a:r>
           </a:p>
         </p:txBody>
@@ -24413,7 +24429,7 @@
                 </a:solidFill>
                 <a:latin typeface="Roboto"/>
               </a:rPr>
-              <a:t>Regra na wiki depende de revisão. Regra virando topologia é sustentada pela estrutura, contra a degradação arquitetural da Aula 02.</a:t>
+              <a:t>Uma regra escrita na wiki depende de alguém revisar. A mesma regra na topologia é verificada pela estrutura, o que reduz a degradação arquitetural da Aula 02.</a:t>
             </a:r>
           </a:p>
         </p:txBody>
@@ -24819,7 +24835,7 @@
                 </a:solidFill>
                 <a:latin typeface="Roboto"/>
               </a:rPr>
-              <a:t>A PERGUNTA QUE VOLTA PARA O PROJETO</a:t>
+              <a:t>CONSEQUÊNCIA PARA O PROJETO</a:t>
             </a:r>
           </a:p>
         </p:txBody>
@@ -25981,7 +25997,23 @@
                 </a:solidFill>
                 <a:latin typeface="Roboto"/>
               </a:rPr>
-              <a:t>Persistência é decisão declarada</a:t>
+              <a:t>Volume nomeado e persistência</a:t>
+            </a:r>
+          </a:p>
+          <a:p>
+            <a:pPr>
+              <a:lnSpc>
+                <a:spcPct val="104000"/>
+              </a:lnSpc>
+            </a:pPr>
+            <a:r>
+              <a:rPr sz="3000" b="1" i="0">
+                <a:solidFill>
+                  <a:srgbClr val="21049A"/>
+                </a:solidFill>
+                <a:latin typeface="Roboto"/>
+              </a:rPr>
+              <a:t>entre execuções</a:t>
             </a:r>
           </a:p>
         </p:txBody>
@@ -26825,7 +26857,7 @@
                 </a:solidFill>
                 <a:latin typeface="Roboto"/>
               </a:rPr>
-              <a:t>Removeram o dockershim</a:t>
+              <a:t>A remoção do dockershim</a:t>
             </a:r>
           </a:p>
           <a:p>
@@ -26841,23 +26873,7 @@
                 </a:solidFill>
                 <a:latin typeface="Roboto"/>
               </a:rPr>
-              <a:t>e nenhuma imagem parou</a:t>
-            </a:r>
-          </a:p>
-          <a:p>
-            <a:pPr>
-              <a:lnSpc>
-                <a:spcPct val="106000"/>
-              </a:lnSpc>
-            </a:pPr>
-            <a:r>
-              <a:rPr sz="3600" b="1" i="0">
-                <a:solidFill>
-                  <a:srgbClr val="FFFFFF"/>
-                </a:solidFill>
-                <a:latin typeface="Roboto"/>
-              </a:rPr>
-              <a:t>de funcionar.</a:t>
+              <a:t>no Kubernetes 1.24</a:t>
             </a:r>
           </a:p>
         </p:txBody>
@@ -26896,7 +26912,7 @@
                 </a:solidFill>
                 <a:latin typeface="Roboto"/>
               </a:rPr>
-              <a:t>O que saiu foi o adaptador embutido que falava com o Docker Engine, não o formato das imagens. Como imagem é OCI, nada quebrou. É substituição por compatibilidade de interface acontecendo em escala real, no vocabulário que a Aula 05 usa para componentes.</a:t>
+              <a:t>O que saiu foi o adaptador embutido que falava com o Docker Engine, não o formato das imagens. Como imagem é OCI, nada quebrou. É um caso real de substituição por compatibilidade de interface, no vocabulário da Aula 05.</a:t>
             </a:r>
           </a:p>
         </p:txBody>
@@ -27102,7 +27118,23 @@
                 </a:solidFill>
                 <a:latin typeface="Roboto"/>
               </a:rPr>
-              <a:t>No vocabulário da disciplina</a:t>
+              <a:t>Vantagens no vocabulário</a:t>
+            </a:r>
+          </a:p>
+          <a:p>
+            <a:pPr>
+              <a:lnSpc>
+                <a:spcPct val="104000"/>
+              </a:lnSpc>
+            </a:pPr>
+            <a:r>
+              <a:rPr sz="3000" b="1" i="0">
+                <a:solidFill>
+                  <a:srgbClr val="21049A"/>
+                </a:solidFill>
+                <a:latin typeface="Roboto"/>
+              </a:rPr>
+              <a:t>da Aula 03</a:t>
             </a:r>
           </a:p>
         </p:txBody>
@@ -28098,7 +28130,7 @@
                 </a:solidFill>
                 <a:latin typeface="Roboto"/>
               </a:rPr>
-              <a:t>O que conteinerizar custa</a:t>
+              <a:t>Limitações e custos</a:t>
             </a:r>
           </a:p>
         </p:txBody>
@@ -28868,7 +28900,7 @@
                 </a:solidFill>
                 <a:latin typeface="Roboto"/>
               </a:rPr>
-              <a:t>PELA SUPERFÍCIE DE ATAQUE</a:t>
+              <a:t>CONTAINER E MÁQUINA VIRTUAL</a:t>
             </a:r>
           </a:p>
         </p:txBody>
@@ -28907,7 +28939,7 @@
                 </a:solidFill>
                 <a:latin typeface="Roboto"/>
               </a:rPr>
-              <a:t>Container é fronteira de isolamento.</a:t>
+              <a:t>Comparação pela</a:t>
             </a:r>
           </a:p>
           <a:p>
@@ -28923,23 +28955,7 @@
                 </a:solidFill>
                 <a:latin typeface="Roboto"/>
               </a:rPr>
-              <a:t>Não é fronteira de segurança</a:t>
-            </a:r>
-          </a:p>
-          <a:p>
-            <a:pPr>
-              <a:lnSpc>
-                <a:spcPct val="104000"/>
-              </a:lnSpc>
-            </a:pPr>
-            <a:r>
-              <a:rPr sz="2400" b="1" i="0">
-                <a:solidFill>
-                  <a:srgbClr val="21049A"/>
-                </a:solidFill>
-                <a:latin typeface="Roboto"/>
-              </a:rPr>
-              <a:t>da mesma classe que uma VM.</a:t>
+              <a:t>superfície de ataque</a:t>
             </a:r>
           </a:p>
         </p:txBody>
@@ -29740,7 +29756,7 @@
                 </a:solidFill>
                 <a:latin typeface="Roboto"/>
               </a:rPr>
-              <a:t>A FRASE DEFINE COMPONENTE</a:t>
+              <a:t>DEFINIÇÃO DE COMPONENTE</a:t>
             </a:r>
           </a:p>
         </p:txBody>
@@ -29779,7 +29795,7 @@
                 </a:solidFill>
                 <a:latin typeface="Roboto"/>
               </a:rPr>
-              <a:t>E descreve, sem citar,</a:t>
+              <a:t>Como a definição se aplica</a:t>
             </a:r>
           </a:p>
           <a:p>
@@ -29795,7 +29811,7 @@
                 </a:solidFill>
                 <a:latin typeface="Roboto"/>
               </a:rPr>
-              <a:t>um serviço de container</a:t>
+              <a:t>a um serviço de container</a:t>
             </a:r>
           </a:p>
         </p:txBody>
@@ -30392,7 +30408,7 @@
                 </a:solidFill>
                 <a:latin typeface="Roboto"/>
               </a:rPr>
-              <a:t>O QUE MAIS ESTAVA NA MESA</a:t>
+              <a:t>ALTERNATIVAS CONSIDERADAS</a:t>
             </a:r>
           </a:p>
         </p:txBody>
@@ -30431,7 +30447,7 @@
                 </a:solidFill>
                 <a:latin typeface="Roboto"/>
               </a:rPr>
-              <a:t>Avaliação crítica exige alternativa</a:t>
+              <a:t>Comparação com as outras opções</a:t>
             </a:r>
           </a:p>
         </p:txBody>
@@ -31442,7 +31458,7 @@
                 </a:solidFill>
                 <a:latin typeface="Roboto"/>
               </a:rPr>
-              <a:t>Dois destes critérios</a:t>
+              <a:t>Critérios de contraindicação</a:t>
             </a:r>
           </a:p>
           <a:p>
@@ -31458,7 +31474,7 @@
                 </a:solidFill>
                 <a:latin typeface="Roboto"/>
               </a:rPr>
-              <a:t>descrevem o nosso caso</a:t>
+              <a:t>e a nossa situação</a:t>
             </a:r>
           </a:p>
         </p:txBody>
@@ -32014,7 +32030,7 @@
                 </a:solidFill>
                 <a:latin typeface="Roboto"/>
               </a:rPr>
-              <a:t>Não temos integração contínua definida. Não temos hospedagem decidida. Estamos na zona cinzenta.</a:t>
+              <a:t>Não temos integração contínua definida nem hospedagem decidida, então dois dos critérios ao lado se aplicam a nós.</a:t>
             </a:r>
           </a:p>
         </p:txBody>
@@ -32092,7 +32108,7 @@
                 </a:solidFill>
                 <a:latin typeface="Roboto"/>
               </a:rPr>
-              <a:t>O que sustenta a adoção é um motivo só, e ele basta: ambiente igual para quatro pessoas com stacks diferentes, com banco rodando sem instalação local, antes de escrever a primeira linha.</a:t>
+              <a:t>O motivo que resta é o ambiente igual para quatro integrantes com stacks diferentes, com o banco rodando sem instalação local, antes de escrever a primeira linha.</a:t>
             </a:r>
           </a:p>
         </p:txBody>
@@ -32105,7 +32121,7 @@
         </p:nvSpPr>
         <p:spPr>
           <a:xfrm>
-            <a:off x="6362700" y="3939921"/>
+            <a:off x="6362700" y="3726180"/>
             <a:ext cx="247650" cy="238354"/>
           </a:xfrm>
           <a:prstGeom prst="rect">
@@ -32144,7 +32160,7 @@
         </p:nvSpPr>
         <p:spPr>
           <a:xfrm>
-            <a:off x="6648450" y="3930396"/>
+            <a:off x="6648450" y="3716655"/>
             <a:ext cx="4857750" cy="95250"/>
           </a:xfrm>
           <a:prstGeom prst="rect">
@@ -33199,7 +33215,7 @@
                 </a:solidFill>
                 <a:latin typeface="Roboto"/>
               </a:rPr>
-              <a:t>Três frases</a:t>
+              <a:t>Recomendação do grupo</a:t>
             </a:r>
           </a:p>
         </p:txBody>
@@ -33433,7 +33449,7 @@
                 </a:solidFill>
                 <a:latin typeface="Roboto"/>
               </a:rPr>
-              <a:t>Conteinerizar barateia errar: a stack ainda não está decidida, e com Dockerfile a escolha de runtime e de banco vira uma linha de arquivo em vez de instalação em quatro notebooks.</a:t>
+              <a:t>A stack ainda não está decidida. Com Dockerfile, trocar runtime ou banco é editar uma linha de arquivo em vez de reinstalar em quatro notebooks.</a:t>
             </a:r>
           </a:p>
         </p:txBody>
@@ -33769,7 +33785,7 @@
                 </a:solidFill>
                 <a:latin typeface="Roboto"/>
               </a:rPr>
-              <a:t>ABRIMOS E FECHAMOS NO MESMO LUGAR</a:t>
+              <a:t>RETOMANDO A EVIDÊNCIA INICIAL</a:t>
             </a:r>
           </a:p>
         </p:txBody>
@@ -33808,7 +33824,23 @@
                 </a:solidFill>
                 <a:latin typeface="Roboto"/>
               </a:rPr>
-              <a:t>Do sintoma ao arquivo</a:t>
+              <a:t>Do problema de ambiente</a:t>
+            </a:r>
+          </a:p>
+          <a:p>
+            <a:pPr>
+              <a:lnSpc>
+                <a:spcPct val="104000"/>
+              </a:lnSpc>
+            </a:pPr>
+            <a:r>
+              <a:rPr sz="3000" b="1" i="0">
+                <a:solidFill>
+                  <a:srgbClr val="21049A"/>
+                </a:solidFill>
+                <a:latin typeface="Roboto"/>
+              </a:rPr>
+              <a:t>ao arquivo de compose</a:t>
             </a:r>
           </a:p>
         </p:txBody>
@@ -35968,7 +36000,7 @@
                 </a:solidFill>
                 <a:latin typeface="Roboto"/>
               </a:rPr>
-              <a:t>O TEMA NÃO VEIO DA MODA</a:t>
+              <a:t>ORIGEM DO TEMA</a:t>
             </a:r>
           </a:p>
         </p:txBody>
@@ -36007,7 +36039,7 @@
                 </a:solidFill>
                 <a:latin typeface="Roboto"/>
               </a:rPr>
-              <a:t>Está registrado no board</a:t>
+              <a:t>O tema saiu de um item</a:t>
             </a:r>
           </a:p>
           <a:p>
@@ -36023,7 +36055,7 @@
                 </a:solidFill>
                 <a:latin typeface="Roboto"/>
               </a:rPr>
-              <a:t>antes desta apresentação</a:t>
+              <a:t>da Sprint 2</a:t>
             </a:r>
           </a:p>
         </p:txBody>
@@ -37393,7 +37425,7 @@
                 </a:solidFill>
                 <a:latin typeface="Roboto"/>
               </a:rPr>
-              <a:t>CONTRATO E AGENDA</a:t>
+              <a:t>AGENDA</a:t>
             </a:r>
           </a:p>
         </p:txBody>
@@ -37432,7 +37464,7 @@
                 </a:solidFill>
                 <a:latin typeface="Roboto"/>
               </a:rPr>
-              <a:t>A implementação começa na Sprint 4.</a:t>
+              <a:t>Escopo e divisão</a:t>
             </a:r>
           </a:p>
           <a:p>
@@ -37448,7 +37480,7 @@
                 </a:solidFill>
                 <a:latin typeface="Roboto"/>
               </a:rPr>
-              <a:t>A demonstração de hoje é do ambiente.</a:t>
+              <a:t>da apresentação</a:t>
             </a:r>
           </a:p>
         </p:txBody>
@@ -38292,7 +38324,7 @@
                 </a:solidFill>
                 <a:latin typeface="Roboto"/>
               </a:rPr>
-              <a:t>Cada integrante responde pelo próprio bloco na arguição. Segurança e mecanismos de kernel são com o Tiago, em qualquer bloco.</a:t>
+              <a:t>A implementação do produto começa na Sprint 4, em 06/10, então a demonstração de hoje é do ambiente e não do produto. Cada integrante responde pelo próprio bloco na arguição.</a:t>
             </a:r>
           </a:p>
         </p:txBody>
@@ -38921,7 +38953,7 @@
                 </a:solidFill>
                 <a:latin typeface="Roboto"/>
               </a:rPr>
-              <a:t>POR QUE ISSO CONTA COMO EMERGENTE</a:t>
+              <a:t>LINHA DO TEMPO</a:t>
             </a:r>
           </a:p>
         </p:txBody>
@@ -38960,7 +38992,7 @@
                 </a:solidFill>
                 <a:latin typeface="Roboto"/>
               </a:rPr>
-              <a:t>O mecanismo é antigo</a:t>
+              <a:t>Do chroot à padronização OCI</a:t>
             </a:r>
           </a:p>
         </p:txBody>
@@ -39955,7 +39987,7 @@
                 </a:solidFill>
                 <a:latin typeface="Roboto"/>
               </a:rPr>
-              <a:t>O que é recente não é o isolamento. É a padronização e a estabilização da cadeia.</a:t>
+              <a:t>O isolamento de processos existe desde 1979. O que é recente é a padronização da cadeia de execução, a partir de 2015.</a:t>
             </a:r>
           </a:p>
         </p:txBody>

</xml_diff>

<commit_message>
docs: corrige a citação do slide 2, agora literal e atribuída a Sommerville
Co-Authored-By: Claude Opus 5 <noreply@anthropic.com>
</commit_message>
<xml_diff>
--- a/trabalhos/T1-Docker-Invite-People.pptx
+++ b/trabalhos/T1-Docker-Invite-People.pptx
@@ -17533,7 +17533,7 @@
                 </a:solidFill>
                 <a:latin typeface="Roboto"/>
               </a:rPr>
-              <a:t> é a abstração de um serviço, coesa e de baixo acoplamento.</a:t>
+              <a:t> é uma unidade coesa e de baixo acoplamento que denota a abstração de um serviço (Sommerville, 2004).</a:t>
             </a:r>
           </a:p>
         </p:txBody>
@@ -20961,13 +20961,13 @@
               </a:lnSpc>
             </a:pPr>
             <a:r>
-              <a:rPr sz="2850" b="0" i="0">
+              <a:rPr sz="2320" b="0" i="0">
                 <a:solidFill>
                   <a:srgbClr val="FFFFFF"/>
                 </a:solidFill>
                 <a:latin typeface="Roboto"/>
               </a:rPr>
-              <a:t>Unidade de composição com interfaces especificadas e dependências de contexto explícitas, que pode ser implantada de forma independente.</a:t>
+              <a:t>Um componente é uma unidade de composição com interfaces (contratos) especificadas e com dependências de contexto explícitas; um componente de software pode ser implantado de forma independente ou se combinar com outros.</a:t>
             </a:r>
           </a:p>
         </p:txBody>
@@ -21052,7 +21052,7 @@
                 </a:solidFill>
                 <a:latin typeface="Roboto"/>
               </a:rPr>
-              <a:t>FARIAS, K. Aula 05, Arquiteturas Baseadas em Componentes.</a:t>
+              <a:t>SOMMERVILLE, I. Engenharia de Software, 6ª ed., Addison Wesley, 2004. Citado na Aula 05, Arquiteturas Baseadas em Componentes.</a:t>
             </a:r>
           </a:p>
         </p:txBody>
@@ -35755,7 +35755,7 @@
                 </a:solidFill>
                 <a:latin typeface="Roboto"/>
               </a:rPr>
-              <a:t>SOMMERVILLE, I. Engenharia de Software. · FOWLER, M. Patterns of Enterprise Application Architecture.</a:t>
+              <a:t>SOMMERVILLE, I. Engenharia de Software. 6. ed. Addison Wesley, 2004. · FOWLER, M. Patterns of Enterprise Application Architecture.</a:t>
             </a:r>
           </a:p>
         </p:txBody>
@@ -35768,7 +35768,7 @@
         </p:nvSpPr>
         <p:spPr>
           <a:xfrm>
-            <a:off x="685800" y="4807458"/>
+            <a:off x="685800" y="5046345"/>
             <a:ext cx="247650" cy="266395"/>
           </a:xfrm>
           <a:prstGeom prst="rect">
@@ -35807,7 +35807,7 @@
         </p:nvSpPr>
         <p:spPr>
           <a:xfrm>
-            <a:off x="971550" y="4797933"/>
+            <a:off x="971550" y="5036820"/>
             <a:ext cx="9677400" cy="95250"/>
           </a:xfrm>
           <a:prstGeom prst="rect">

</xml_diff>

<commit_message>
docs: unifica os rotulos de secao do deck do T1 e corrige a retomada falsa no fecho
</commit_message>
<xml_diff>
--- a/trabalhos/T1-Docker-Invite-People.pptx
+++ b/trabalhos/T1-Docker-Invite-People.pptx
@@ -12675,7 +12675,7 @@
                 </a:solidFill>
                 <a:latin typeface="Roboto"/>
               </a:rPr>
-              <a:t>Bloco B · Arquitetura</a:t>
+              <a:t>01 · Arquitetura</a:t>
             </a:r>
           </a:p>
         </p:txBody>
@@ -12941,7 +12941,7 @@
                 </a:solidFill>
                 <a:latin typeface="Roboto"/>
               </a:rPr>
-              <a:t>Fundada em 2015 sob a Linux Foundation, com a Runtime Spec, a Image Spec e a Distribution Spec. O runc é trocável por crun, gVisor ou Kata. O engine é trocável por Podman. É um exemplo da substituibilidade por compatibilidade de interface da Aula 05.</a:t>
+              <a:t>Fundada em 2015 sob a Linux Foundation, com a Runtime Spec, a Image Spec e a Distribution Spec. O runc é trocável por crun, gVisor ou Kata. O engine é trocável por Podman. É a substituibilidade por compatibilidade de interface da Aula 05, e o Bloco D traz um caso real.</a:t>
             </a:r>
           </a:p>
         </p:txBody>
@@ -12980,7 +12980,7 @@
                 </a:solidFill>
                 <a:latin typeface="Roboto"/>
               </a:rPr>
-              <a:t>Bloco B · Arquitetura</a:t>
+              <a:t>01 · Arquitetura</a:t>
             </a:r>
           </a:p>
         </p:txBody>
@@ -13484,7 +13484,7 @@
                 </a:solidFill>
                 <a:latin typeface="Roboto"/>
               </a:rPr>
-              <a:t>Bloco C</a:t>
+              <a:t>02 · Aplicação no projeto</a:t>
             </a:r>
           </a:p>
         </p:txBody>
@@ -15391,7 +15391,7 @@
                 </a:solidFill>
                 <a:latin typeface="Roboto"/>
               </a:rPr>
-              <a:t>Bloco C · Aplicação</a:t>
+              <a:t>02 · Aplicação no projeto</a:t>
             </a:r>
           </a:p>
         </p:txBody>
@@ -16151,7 +16151,7 @@
                 </a:solidFill>
                 <a:latin typeface="Roboto"/>
               </a:rPr>
-              <a:t>Bloco C · Aplicação</a:t>
+              <a:t>02 · Aplicação no projeto</a:t>
             </a:r>
           </a:p>
         </p:txBody>
@@ -17660,7 +17660,7 @@
                 </a:solidFill>
                 <a:latin typeface="Roboto"/>
               </a:rPr>
-              <a:t>Bloco C · Aplicação</a:t>
+              <a:t>02 · Aplicação no projeto</a:t>
             </a:r>
           </a:p>
         </p:txBody>
@@ -18677,7 +18677,7 @@
                 </a:solidFill>
                 <a:latin typeface="Roboto"/>
               </a:rPr>
-              <a:t>Bloco C · Aplicação</a:t>
+              <a:t>02 · Aplicação no projeto</a:t>
             </a:r>
           </a:p>
         </p:txBody>
@@ -19533,7 +19533,7 @@
                 </a:solidFill>
                 <a:latin typeface="Roboto"/>
               </a:rPr>
-              <a:t>Bloco C · Aplicação</a:t>
+              <a:t>02 · Aplicação no projeto</a:t>
             </a:r>
           </a:p>
         </p:txBody>
@@ -20196,7 +20196,7 @@
                 </a:solidFill>
                 <a:latin typeface="Roboto"/>
               </a:rPr>
-              <a:t>Bloco C · Aplicação</a:t>
+              <a:t>02 · Aplicação no projeto</a:t>
             </a:r>
           </a:p>
         </p:txBody>
@@ -20700,7 +20700,7 @@
                 </a:solidFill>
                 <a:latin typeface="Roboto"/>
               </a:rPr>
-              <a:t>Bloco D</a:t>
+              <a:t>03 · Vantagens e desvantagens</a:t>
             </a:r>
           </a:p>
         </p:txBody>
@@ -20880,8 +20880,8 @@
         </p:nvSpPr>
         <p:spPr>
           <a:xfrm>
-            <a:off x="685800" y="2065020"/>
-            <a:ext cx="247650" cy="308458"/>
+            <a:off x="685800" y="2134172"/>
+            <a:ext cx="247650" cy="266395"/>
           </a:xfrm>
           <a:prstGeom prst="rect">
             <a:avLst/>
@@ -20900,7 +20900,7 @@
               </a:lnSpc>
             </a:pPr>
             <a:r>
-              <a:rPr sz="1520" b="1" i="0">
+              <a:rPr sz="1310" b="1" i="0">
                 <a:solidFill>
                   <a:srgbClr val="E94D1C"/>
                 </a:solidFill>
@@ -20919,7 +20919,7 @@
         </p:nvSpPr>
         <p:spPr>
           <a:xfrm>
-            <a:off x="971550" y="2055495"/>
+            <a:off x="971550" y="2124646"/>
             <a:ext cx="7677150" cy="95250"/>
           </a:xfrm>
           <a:prstGeom prst="rect">
@@ -20939,7 +20939,7 @@
               </a:lnSpc>
             </a:pPr>
             <a:r>
-              <a:rPr sz="1650" b="0" i="0">
+              <a:rPr sz="1420" b="0" i="0">
                 <a:solidFill>
                   <a:srgbClr val="1A1A1E"/>
                 </a:solidFill>
@@ -20958,8 +20958,8 @@
         </p:nvSpPr>
         <p:spPr>
           <a:xfrm>
-            <a:off x="685800" y="2903982"/>
-            <a:ext cx="247650" cy="308458"/>
+            <a:off x="685800" y="2840546"/>
+            <a:ext cx="247650" cy="266395"/>
           </a:xfrm>
           <a:prstGeom prst="rect">
             <a:avLst/>
@@ -20978,7 +20978,7 @@
               </a:lnSpc>
             </a:pPr>
             <a:r>
-              <a:rPr sz="1520" b="1" i="0">
+              <a:rPr sz="1310" b="1" i="0">
                 <a:solidFill>
                   <a:srgbClr val="E94D1C"/>
                 </a:solidFill>
@@ -20997,7 +20997,7 @@
         </p:nvSpPr>
         <p:spPr>
           <a:xfrm>
-            <a:off x="971550" y="2894457"/>
+            <a:off x="971550" y="2831021"/>
             <a:ext cx="7677150" cy="95250"/>
           </a:xfrm>
           <a:prstGeom prst="rect">
@@ -21017,7 +21017,7 @@
               </a:lnSpc>
             </a:pPr>
             <a:r>
-              <a:rPr sz="1650" b="0" i="0">
+              <a:rPr sz="1420" b="0" i="0">
                 <a:solidFill>
                   <a:srgbClr val="1A1A1E"/>
                 </a:solidFill>
@@ -21036,8 +21036,8 @@
         </p:nvSpPr>
         <p:spPr>
           <a:xfrm>
-            <a:off x="685800" y="3742944"/>
-            <a:ext cx="247650" cy="308458"/>
+            <a:off x="685800" y="3546920"/>
+            <a:ext cx="247650" cy="266395"/>
           </a:xfrm>
           <a:prstGeom prst="rect">
             <a:avLst/>
@@ -21056,7 +21056,7 @@
               </a:lnSpc>
             </a:pPr>
             <a:r>
-              <a:rPr sz="1520" b="1" i="0">
+              <a:rPr sz="1310" b="1" i="0">
                 <a:solidFill>
                   <a:srgbClr val="E94D1C"/>
                 </a:solidFill>
@@ -21075,7 +21075,7 @@
         </p:nvSpPr>
         <p:spPr>
           <a:xfrm>
-            <a:off x="971550" y="3733419"/>
+            <a:off x="971550" y="3537394"/>
             <a:ext cx="7677150" cy="95250"/>
           </a:xfrm>
           <a:prstGeom prst="rect">
@@ -21095,7 +21095,7 @@
               </a:lnSpc>
             </a:pPr>
             <a:r>
-              <a:rPr sz="1650" b="0" i="0">
+              <a:rPr sz="1420" b="0" i="0">
                 <a:solidFill>
                   <a:srgbClr val="1A1A1E"/>
                 </a:solidFill>
@@ -21114,8 +21114,8 @@
         </p:nvSpPr>
         <p:spPr>
           <a:xfrm>
-            <a:off x="685800" y="4581906"/>
-            <a:ext cx="247650" cy="308458"/>
+            <a:off x="685800" y="4014406"/>
+            <a:ext cx="247650" cy="266395"/>
           </a:xfrm>
           <a:prstGeom prst="rect">
             <a:avLst/>
@@ -21134,7 +21134,7 @@
               </a:lnSpc>
             </a:pPr>
             <a:r>
-              <a:rPr sz="1520" b="1" i="0">
+              <a:rPr sz="1310" b="1" i="0">
                 <a:solidFill>
                   <a:srgbClr val="E94D1C"/>
                 </a:solidFill>
@@ -21153,7 +21153,7 @@
         </p:nvSpPr>
         <p:spPr>
           <a:xfrm>
-            <a:off x="971550" y="4572381"/>
+            <a:off x="971550" y="4004882"/>
             <a:ext cx="7677150" cy="95250"/>
           </a:xfrm>
           <a:prstGeom prst="rect">
@@ -21173,7 +21173,7 @@
               </a:lnSpc>
             </a:pPr>
             <a:r>
-              <a:rPr sz="1650" b="0" i="0">
+              <a:rPr sz="1420" b="0" i="0">
                 <a:solidFill>
                   <a:srgbClr val="1A1A1E"/>
                 </a:solidFill>
@@ -21192,8 +21192,8 @@
         </p:nvSpPr>
         <p:spPr>
           <a:xfrm>
-            <a:off x="685800" y="5420868"/>
-            <a:ext cx="247650" cy="308458"/>
+            <a:off x="685800" y="4720780"/>
+            <a:ext cx="247650" cy="266395"/>
           </a:xfrm>
           <a:prstGeom prst="rect">
             <a:avLst/>
@@ -21212,7 +21212,7 @@
               </a:lnSpc>
             </a:pPr>
             <a:r>
-              <a:rPr sz="1520" b="1" i="0">
+              <a:rPr sz="1310" b="1" i="0">
                 <a:solidFill>
                   <a:srgbClr val="E94D1C"/>
                 </a:solidFill>
@@ -21231,7 +21231,7 @@
         </p:nvSpPr>
         <p:spPr>
           <a:xfrm>
-            <a:off x="971550" y="5411343"/>
+            <a:off x="971550" y="4711256"/>
             <a:ext cx="7677150" cy="95250"/>
           </a:xfrm>
           <a:prstGeom prst="rect">
@@ -21251,7 +21251,7 @@
               </a:lnSpc>
             </a:pPr>
             <a:r>
-              <a:rPr sz="1650" b="0" i="0">
+              <a:rPr sz="1420" b="0" i="0">
                 <a:solidFill>
                   <a:srgbClr val="1A1A1E"/>
                 </a:solidFill>
@@ -21264,13 +21264,91 @@
       </p:sp>
       <p:sp>
         <p:nvSpPr>
-          <p:cNvPr id="15" name="Donut 14"/>
+          <p:cNvPr id="15" name="TextBox 14"/>
+          <p:cNvSpPr txBox="1"/>
+          <p:nvPr/>
+        </p:nvSpPr>
+        <p:spPr>
+          <a:xfrm>
+            <a:off x="685800" y="5427154"/>
+            <a:ext cx="247650" cy="266395"/>
+          </a:xfrm>
+          <a:prstGeom prst="rect">
+            <a:avLst/>
+          </a:prstGeom>
+          <a:noFill/>
+        </p:spPr>
+        <p:txBody>
+          <a:bodyPr wrap="square" lIns="0" rIns="0" tIns="0" bIns="0" anchor="t">
+            <a:spAutoFit/>
+          </a:bodyPr>
+          <a:lstStyle/>
+          <a:p>
+            <a:pPr algn="l">
+              <a:lnSpc>
+                <a:spcPct val="120000"/>
+              </a:lnSpc>
+            </a:pPr>
+            <a:r>
+              <a:rPr sz="1310" b="1" i="0">
+                <a:solidFill>
+                  <a:srgbClr val="E94D1C"/>
+                </a:solidFill>
+                <a:latin typeface="Roboto"/>
+              </a:rPr>
+              <a:t>//</a:t>
+            </a:r>
+          </a:p>
+        </p:txBody>
+      </p:sp>
+      <p:sp>
+        <p:nvSpPr>
+          <p:cNvPr id="16" name="TextBox 15"/>
+          <p:cNvSpPr txBox="1"/>
+          <p:nvPr/>
+        </p:nvSpPr>
+        <p:spPr>
+          <a:xfrm>
+            <a:off x="971550" y="5417630"/>
+            <a:ext cx="7677150" cy="95250"/>
+          </a:xfrm>
+          <a:prstGeom prst="rect">
+            <a:avLst/>
+          </a:prstGeom>
+          <a:noFill/>
+        </p:spPr>
+        <p:txBody>
+          <a:bodyPr wrap="square" lIns="0" rIns="0" tIns="0" bIns="0" anchor="t">
+            <a:spAutoFit/>
+          </a:bodyPr>
+          <a:lstStyle/>
+          <a:p>
+            <a:pPr algn="l">
+              <a:lnSpc>
+                <a:spcPct val="130000"/>
+              </a:lnSpc>
+            </a:pPr>
+            <a:r>
+              <a:rPr sz="1420" b="0" i="0">
+                <a:solidFill>
+                  <a:srgbClr val="1A1A1E"/>
+                </a:solidFill>
+                <a:latin typeface="Roboto"/>
+              </a:rPr>
+              <a:t>A seção 01 é sobre Docker. O projeto volta na seção 02, onde essa pergunta é respondida.</a:t>
+            </a:r>
+          </a:p>
+        </p:txBody>
+      </p:sp>
+      <p:sp>
+        <p:nvSpPr>
+          <p:cNvPr id="17" name="Donut 16"/>
           <p:cNvSpPr/>
           <p:nvPr/>
         </p:nvSpPr>
         <p:spPr>
           <a:xfrm>
-            <a:off x="9124950" y="2055495"/>
+            <a:off x="9124950" y="2124646"/>
             <a:ext cx="142875" cy="142875"/>
           </a:xfrm>
           <a:prstGeom prst="donut">
@@ -21308,13 +21386,13 @@
       </p:sp>
       <p:sp>
         <p:nvSpPr>
-          <p:cNvPr id="16" name="TextBox 15"/>
-          <p:cNvSpPr txBox="1"/>
-          <p:nvPr/>
-        </p:nvSpPr>
-        <p:spPr>
-          <a:xfrm>
-            <a:off x="9372600" y="2065020"/>
+          <p:cNvPr id="18" name="TextBox 17"/>
+          <p:cNvSpPr txBox="1"/>
+          <p:nvPr/>
+        </p:nvSpPr>
+        <p:spPr>
+          <a:xfrm>
+            <a:off x="9372600" y="2134172"/>
             <a:ext cx="2133600" cy="182880"/>
           </a:xfrm>
           <a:prstGeom prst="rect">
@@ -21347,13 +21425,13 @@
       </p:sp>
       <p:sp>
         <p:nvSpPr>
-          <p:cNvPr id="17" name="Rectangle 16"/>
+          <p:cNvPr id="19" name="Rectangle 18"/>
           <p:cNvSpPr/>
           <p:nvPr/>
         </p:nvSpPr>
         <p:spPr>
           <a:xfrm>
-            <a:off x="9124950" y="2341245"/>
+            <a:off x="9124950" y="2410396"/>
             <a:ext cx="38100" cy="832104"/>
           </a:xfrm>
           <a:prstGeom prst="rect">
@@ -21391,13 +21469,13 @@
       </p:sp>
       <p:sp>
         <p:nvSpPr>
-          <p:cNvPr id="18" name="TextBox 17"/>
-          <p:cNvSpPr txBox="1"/>
-          <p:nvPr/>
-        </p:nvSpPr>
-        <p:spPr>
-          <a:xfrm>
-            <a:off x="9334500" y="2341245"/>
+          <p:cNvPr id="20" name="TextBox 19"/>
+          <p:cNvSpPr txBox="1"/>
+          <p:nvPr/>
+        </p:nvSpPr>
+        <p:spPr>
+          <a:xfrm>
+            <a:off x="9334500" y="2410396"/>
             <a:ext cx="2171700" cy="1403604"/>
           </a:xfrm>
           <a:prstGeom prst="rect">
@@ -21471,7 +21549,7 @@
       </p:sp>
       <p:sp>
         <p:nvSpPr>
-          <p:cNvPr id="19" name="TextBox 18"/>
+          <p:cNvPr id="21" name="TextBox 20"/>
           <p:cNvSpPr txBox="1"/>
           <p:nvPr/>
         </p:nvSpPr>
@@ -21503,14 +21581,14 @@
                 </a:solidFill>
                 <a:latin typeface="Roboto"/>
               </a:rPr>
-              <a:t>Bloco A · Introdução</a:t>
-            </a:r>
-          </a:p>
-        </p:txBody>
-      </p:sp>
-      <p:sp>
-        <p:nvSpPr>
-          <p:cNvPr id="20" name="TextBox 19"/>
+              <a:t>Introdução</a:t>
+            </a:r>
+          </a:p>
+        </p:txBody>
+      </p:sp>
+      <p:sp>
+        <p:nvSpPr>
+          <p:cNvPr id="22" name="TextBox 21"/>
           <p:cNvSpPr txBox="1"/>
           <p:nvPr/>
         </p:nvSpPr>
@@ -22407,7 +22485,7 @@
                 </a:solidFill>
                 <a:latin typeface="Roboto"/>
               </a:rPr>
-              <a:t>Bloco D · Demonstração</a:t>
+              <a:t>03 · Demonstração</a:t>
             </a:r>
           </a:p>
         </p:txBody>
@@ -22712,7 +22790,7 @@
                 </a:solidFill>
                 <a:latin typeface="Roboto"/>
               </a:rPr>
-              <a:t>Bloco D · Estudo de caso</a:t>
+              <a:t>03 · Estudo de caso</a:t>
             </a:r>
           </a:p>
         </p:txBody>
@@ -23724,7 +23802,7 @@
                 </a:solidFill>
                 <a:latin typeface="Roboto"/>
               </a:rPr>
-              <a:t>Bloco D · Vantagens</a:t>
+              <a:t>03 · Vantagens e desvantagens</a:t>
             </a:r>
           </a:p>
         </p:txBody>
@@ -24533,7 +24611,7 @@
                 </a:solidFill>
                 <a:latin typeface="Roboto"/>
               </a:rPr>
-              <a:t>Bloco D · Limitações</a:t>
+              <a:t>03 · Vantagens e desvantagens</a:t>
             </a:r>
           </a:p>
         </p:txBody>
@@ -25389,7 +25467,7 @@
                 </a:solidFill>
                 <a:latin typeface="Roboto"/>
               </a:rPr>
-              <a:t>Bloco D · Segurança</a:t>
+              <a:t>03 · Vantagens e desvantagens</a:t>
             </a:r>
           </a:p>
         </p:txBody>
@@ -26444,7 +26522,7 @@
                 </a:solidFill>
                 <a:latin typeface="Roboto"/>
               </a:rPr>
-              <a:t>Bloco D · Alternativas</a:t>
+              <a:t>03 · Vantagens e desvantagens</a:t>
             </a:r>
           </a:p>
         </p:txBody>
@@ -27378,7 +27456,7 @@
                 </a:solidFill>
                 <a:latin typeface="Roboto"/>
               </a:rPr>
-              <a:t>Bloco D · Honestidade</a:t>
+              <a:t>03 · Vantagens e desvantagens</a:t>
             </a:r>
           </a:p>
         </p:txBody>
@@ -28201,7 +28279,7 @@
                 </a:solidFill>
                 <a:latin typeface="Roboto"/>
               </a:rPr>
-              <a:t>Bloco D · Considerações finais</a:t>
+              <a:t>03 · Vantagens e desvantagens</a:t>
             </a:r>
           </a:p>
         </p:txBody>
@@ -28810,7 +28888,7 @@
                 </a:solidFill>
                 <a:latin typeface="Roboto"/>
               </a:rPr>
-              <a:t>Bloco D · Considerações finais</a:t>
+              <a:t>Considerações finais</a:t>
             </a:r>
           </a:p>
         </p:txBody>
@@ -28938,7 +29016,7 @@
                 </a:solidFill>
                 <a:latin typeface="Roboto"/>
               </a:rPr>
-              <a:t>RETOMANDO A EVIDÊNCIA INICIAL</a:t>
+              <a:t>ANTES E DEPOIS, NO NOSSO REPOSITÓRIO</a:t>
             </a:r>
           </a:p>
         </p:txBody>
@@ -29510,7 +29588,7 @@
                 </a:solidFill>
                 <a:latin typeface="Roboto"/>
               </a:rPr>
-              <a:t>Bloco D · Fecho</a:t>
+              <a:t>Considerações finais</a:t>
             </a:r>
           </a:p>
         </p:txBody>
@@ -30014,7 +30092,7 @@
                 </a:solidFill>
                 <a:latin typeface="Roboto"/>
               </a:rPr>
-              <a:t>Bloco B</a:t>
+              <a:t>01 · Definições e arquitetura</a:t>
             </a:r>
           </a:p>
         </p:txBody>
@@ -30777,7 +30855,7 @@
                 </a:solidFill>
                 <a:latin typeface="Roboto"/>
               </a:rPr>
-              <a:t>Bloco D · Fecho</a:t>
+              <a:t>Considerações finais</a:t>
             </a:r>
           </a:p>
         </p:txBody>
@@ -31607,7 +31685,7 @@
                 </a:solidFill>
                 <a:latin typeface="Roboto"/>
               </a:rPr>
-              <a:t>Bloco D · Fecho</a:t>
+              <a:t>Referências</a:t>
             </a:r>
           </a:p>
         </p:txBody>
@@ -32808,7 +32886,7 @@
                 </a:solidFill>
                 <a:latin typeface="Roboto"/>
               </a:rPr>
-              <a:t>Bloco B · Definições</a:t>
+              <a:t>01 · Definições</a:t>
             </a:r>
           </a:p>
         </p:txBody>
@@ -33336,7 +33414,7 @@
                 </a:solidFill>
                 <a:latin typeface="Roboto"/>
               </a:rPr>
-              <a:t>Bloco B · Definições</a:t>
+              <a:t>01 · Definições</a:t>
             </a:r>
           </a:p>
         </p:txBody>
@@ -34201,7 +34279,7 @@
                 </a:solidFill>
                 <a:latin typeface="Roboto"/>
               </a:rPr>
-              <a:t>Bloco B · Arquitetura</a:t>
+              <a:t>01 · Arquitetura</a:t>
             </a:r>
           </a:p>
         </p:txBody>
@@ -35135,7 +35213,7 @@
                 </a:solidFill>
                 <a:latin typeface="Roboto"/>
               </a:rPr>
-              <a:t>Bloco B · Arquitetura</a:t>
+              <a:t>01 · Arquitetura</a:t>
             </a:r>
           </a:p>
         </p:txBody>
@@ -36141,7 +36219,7 @@
                 </a:solidFill>
                 <a:latin typeface="Roboto"/>
               </a:rPr>
-              <a:t>Bloco B · Arquitetura</a:t>
+              <a:t>01 · Arquitetura</a:t>
             </a:r>
           </a:p>
         </p:txBody>
@@ -37318,7 +37396,7 @@
                 </a:solidFill>
                 <a:latin typeface="Roboto"/>
               </a:rPr>
-              <a:t>Bloco B · Arquitetura</a:t>
+              <a:t>01 · Arquitetura</a:t>
             </a:r>
           </a:p>
         </p:txBody>

</xml_diff>

<commit_message>
docs: tira o texto de agenda e o contrato de escopo do slide do projeto e liga ele ao divisor seguinte
</commit_message>
<xml_diff>
--- a/trabalhos/T1-Docker-Invite-People.pptx
+++ b/trabalhos/T1-Docker-Invite-People.pptx
@@ -20880,8 +20880,8 @@
         </p:nvSpPr>
         <p:spPr>
           <a:xfrm>
-            <a:off x="685800" y="2134172"/>
-            <a:ext cx="247650" cy="266395"/>
+            <a:off x="685800" y="2484501"/>
+            <a:ext cx="247650" cy="308458"/>
           </a:xfrm>
           <a:prstGeom prst="rect">
             <a:avLst/>
@@ -20900,7 +20900,7 @@
               </a:lnSpc>
             </a:pPr>
             <a:r>
-              <a:rPr sz="1310" b="1" i="0">
+              <a:rPr sz="1520" b="1" i="0">
                 <a:solidFill>
                   <a:srgbClr val="E94D1C"/>
                 </a:solidFill>
@@ -20919,7 +20919,7 @@
         </p:nvSpPr>
         <p:spPr>
           <a:xfrm>
-            <a:off x="971550" y="2124646"/>
+            <a:off x="971550" y="2474976"/>
             <a:ext cx="7677150" cy="95250"/>
           </a:xfrm>
           <a:prstGeom prst="rect">
@@ -20939,7 +20939,7 @@
               </a:lnSpc>
             </a:pPr>
             <a:r>
-              <a:rPr sz="1420" b="0" i="0">
+              <a:rPr sz="1650" b="0" i="0">
                 <a:solidFill>
                   <a:srgbClr val="1A1A1E"/>
                 </a:solidFill>
@@ -20958,8 +20958,8 @@
         </p:nvSpPr>
         <p:spPr>
           <a:xfrm>
-            <a:off x="685800" y="2840546"/>
-            <a:ext cx="247650" cy="266395"/>
+            <a:off x="685800" y="3323463"/>
+            <a:ext cx="247650" cy="308458"/>
           </a:xfrm>
           <a:prstGeom prst="rect">
             <a:avLst/>
@@ -20978,7 +20978,7 @@
               </a:lnSpc>
             </a:pPr>
             <a:r>
-              <a:rPr sz="1310" b="1" i="0">
+              <a:rPr sz="1520" b="1" i="0">
                 <a:solidFill>
                   <a:srgbClr val="E94D1C"/>
                 </a:solidFill>
@@ -20997,7 +20997,7 @@
         </p:nvSpPr>
         <p:spPr>
           <a:xfrm>
-            <a:off x="971550" y="2831021"/>
+            <a:off x="971550" y="3313938"/>
             <a:ext cx="7677150" cy="95250"/>
           </a:xfrm>
           <a:prstGeom prst="rect">
@@ -21017,7 +21017,7 @@
               </a:lnSpc>
             </a:pPr>
             <a:r>
-              <a:rPr sz="1420" b="0" i="0">
+              <a:rPr sz="1650" b="0" i="0">
                 <a:solidFill>
                   <a:srgbClr val="1A1A1E"/>
                 </a:solidFill>
@@ -21036,8 +21036,8 @@
         </p:nvSpPr>
         <p:spPr>
           <a:xfrm>
-            <a:off x="685800" y="3546920"/>
-            <a:ext cx="247650" cy="266395"/>
+            <a:off x="685800" y="4162425"/>
+            <a:ext cx="247650" cy="308458"/>
           </a:xfrm>
           <a:prstGeom prst="rect">
             <a:avLst/>
@@ -21056,7 +21056,7 @@
               </a:lnSpc>
             </a:pPr>
             <a:r>
-              <a:rPr sz="1310" b="1" i="0">
+              <a:rPr sz="1520" b="1" i="0">
                 <a:solidFill>
                   <a:srgbClr val="E94D1C"/>
                 </a:solidFill>
@@ -21075,7 +21075,7 @@
         </p:nvSpPr>
         <p:spPr>
           <a:xfrm>
-            <a:off x="971550" y="3537394"/>
+            <a:off x="971550" y="4152900"/>
             <a:ext cx="7677150" cy="95250"/>
           </a:xfrm>
           <a:prstGeom prst="rect">
@@ -21095,7 +21095,7 @@
               </a:lnSpc>
             </a:pPr>
             <a:r>
-              <a:rPr sz="1420" b="0" i="0">
+              <a:rPr sz="1650" b="0" i="0">
                 <a:solidFill>
                   <a:srgbClr val="1A1A1E"/>
                 </a:solidFill>
@@ -21114,8 +21114,8 @@
         </p:nvSpPr>
         <p:spPr>
           <a:xfrm>
-            <a:off x="685800" y="4014406"/>
-            <a:ext cx="247650" cy="266395"/>
+            <a:off x="685800" y="5001387"/>
+            <a:ext cx="247650" cy="308458"/>
           </a:xfrm>
           <a:prstGeom prst="rect">
             <a:avLst/>
@@ -21134,7 +21134,7 @@
               </a:lnSpc>
             </a:pPr>
             <a:r>
-              <a:rPr sz="1310" b="1" i="0">
+              <a:rPr sz="1520" b="1" i="0">
                 <a:solidFill>
                   <a:srgbClr val="E94D1C"/>
                 </a:solidFill>
@@ -21153,7 +21153,7 @@
         </p:nvSpPr>
         <p:spPr>
           <a:xfrm>
-            <a:off x="971550" y="4004882"/>
+            <a:off x="971550" y="4991862"/>
             <a:ext cx="7677150" cy="95250"/>
           </a:xfrm>
           <a:prstGeom prst="rect">
@@ -21173,7 +21173,7 @@
               </a:lnSpc>
             </a:pPr>
             <a:r>
-              <a:rPr sz="1420" b="0" i="0">
+              <a:rPr sz="1650" b="0" i="0">
                 <a:solidFill>
                   <a:srgbClr val="1A1A1E"/>
                 </a:solidFill>
@@ -21186,169 +21186,13 @@
       </p:sp>
       <p:sp>
         <p:nvSpPr>
-          <p:cNvPr id="13" name="TextBox 12"/>
-          <p:cNvSpPr txBox="1"/>
-          <p:nvPr/>
-        </p:nvSpPr>
-        <p:spPr>
-          <a:xfrm>
-            <a:off x="685800" y="4720780"/>
-            <a:ext cx="247650" cy="266395"/>
-          </a:xfrm>
-          <a:prstGeom prst="rect">
-            <a:avLst/>
-          </a:prstGeom>
-          <a:noFill/>
-        </p:spPr>
-        <p:txBody>
-          <a:bodyPr wrap="square" lIns="0" rIns="0" tIns="0" bIns="0" anchor="t">
-            <a:spAutoFit/>
-          </a:bodyPr>
-          <a:lstStyle/>
-          <a:p>
-            <a:pPr algn="l">
-              <a:lnSpc>
-                <a:spcPct val="120000"/>
-              </a:lnSpc>
-            </a:pPr>
-            <a:r>
-              <a:rPr sz="1310" b="1" i="0">
-                <a:solidFill>
-                  <a:srgbClr val="E94D1C"/>
-                </a:solidFill>
-                <a:latin typeface="Roboto"/>
-              </a:rPr>
-              <a:t>//</a:t>
-            </a:r>
-          </a:p>
-        </p:txBody>
-      </p:sp>
-      <p:sp>
-        <p:nvSpPr>
-          <p:cNvPr id="14" name="TextBox 13"/>
-          <p:cNvSpPr txBox="1"/>
-          <p:nvPr/>
-        </p:nvSpPr>
-        <p:spPr>
-          <a:xfrm>
-            <a:off x="971550" y="4711256"/>
-            <a:ext cx="7677150" cy="95250"/>
-          </a:xfrm>
-          <a:prstGeom prst="rect">
-            <a:avLst/>
-          </a:prstGeom>
-          <a:noFill/>
-        </p:spPr>
-        <p:txBody>
-          <a:bodyPr wrap="square" lIns="0" rIns="0" tIns="0" bIns="0" anchor="t">
-            <a:spAutoFit/>
-          </a:bodyPr>
-          <a:lstStyle/>
-          <a:p>
-            <a:pPr algn="l">
-              <a:lnSpc>
-                <a:spcPct val="130000"/>
-              </a:lnSpc>
-            </a:pPr>
-            <a:r>
-              <a:rPr sz="1420" b="0" i="0">
-                <a:solidFill>
-                  <a:srgbClr val="1A1A1E"/>
-                </a:solidFill>
-                <a:latin typeface="Roboto"/>
-              </a:rPr>
-              <a:t>A implementação do produto começa na Sprint 4, em 06/10. A demonstração do final é do ambiente, não do produto.</a:t>
-            </a:r>
-          </a:p>
-        </p:txBody>
-      </p:sp>
-      <p:sp>
-        <p:nvSpPr>
-          <p:cNvPr id="15" name="TextBox 14"/>
-          <p:cNvSpPr txBox="1"/>
-          <p:nvPr/>
-        </p:nvSpPr>
-        <p:spPr>
-          <a:xfrm>
-            <a:off x="685800" y="5427154"/>
-            <a:ext cx="247650" cy="266395"/>
-          </a:xfrm>
-          <a:prstGeom prst="rect">
-            <a:avLst/>
-          </a:prstGeom>
-          <a:noFill/>
-        </p:spPr>
-        <p:txBody>
-          <a:bodyPr wrap="square" lIns="0" rIns="0" tIns="0" bIns="0" anchor="t">
-            <a:spAutoFit/>
-          </a:bodyPr>
-          <a:lstStyle/>
-          <a:p>
-            <a:pPr algn="l">
-              <a:lnSpc>
-                <a:spcPct val="120000"/>
-              </a:lnSpc>
-            </a:pPr>
-            <a:r>
-              <a:rPr sz="1310" b="1" i="0">
-                <a:solidFill>
-                  <a:srgbClr val="E94D1C"/>
-                </a:solidFill>
-                <a:latin typeface="Roboto"/>
-              </a:rPr>
-              <a:t>//</a:t>
-            </a:r>
-          </a:p>
-        </p:txBody>
-      </p:sp>
-      <p:sp>
-        <p:nvSpPr>
-          <p:cNvPr id="16" name="TextBox 15"/>
-          <p:cNvSpPr txBox="1"/>
-          <p:nvPr/>
-        </p:nvSpPr>
-        <p:spPr>
-          <a:xfrm>
-            <a:off x="971550" y="5417630"/>
-            <a:ext cx="7677150" cy="95250"/>
-          </a:xfrm>
-          <a:prstGeom prst="rect">
-            <a:avLst/>
-          </a:prstGeom>
-          <a:noFill/>
-        </p:spPr>
-        <p:txBody>
-          <a:bodyPr wrap="square" lIns="0" rIns="0" tIns="0" bIns="0" anchor="t">
-            <a:spAutoFit/>
-          </a:bodyPr>
-          <a:lstStyle/>
-          <a:p>
-            <a:pPr algn="l">
-              <a:lnSpc>
-                <a:spcPct val="130000"/>
-              </a:lnSpc>
-            </a:pPr>
-            <a:r>
-              <a:rPr sz="1420" b="0" i="0">
-                <a:solidFill>
-                  <a:srgbClr val="1A1A1E"/>
-                </a:solidFill>
-                <a:latin typeface="Roboto"/>
-              </a:rPr>
-              <a:t>A seção 01 é sobre Docker. O projeto volta na seção 02, onde essa pergunta é respondida.</a:t>
-            </a:r>
-          </a:p>
-        </p:txBody>
-      </p:sp>
-      <p:sp>
-        <p:nvSpPr>
-          <p:cNvPr id="17" name="Donut 16"/>
+          <p:cNvPr id="13" name="Donut 12"/>
           <p:cNvSpPr/>
           <p:nvPr/>
         </p:nvSpPr>
         <p:spPr>
           <a:xfrm>
-            <a:off x="9124950" y="2124646"/>
+            <a:off x="9124950" y="2474976"/>
             <a:ext cx="142875" cy="142875"/>
           </a:xfrm>
           <a:prstGeom prst="donut">
@@ -21386,13 +21230,13 @@
       </p:sp>
       <p:sp>
         <p:nvSpPr>
-          <p:cNvPr id="18" name="TextBox 17"/>
-          <p:cNvSpPr txBox="1"/>
-          <p:nvPr/>
-        </p:nvSpPr>
-        <p:spPr>
-          <a:xfrm>
-            <a:off x="9372600" y="2134172"/>
+          <p:cNvPr id="14" name="TextBox 13"/>
+          <p:cNvSpPr txBox="1"/>
+          <p:nvPr/>
+        </p:nvSpPr>
+        <p:spPr>
+          <a:xfrm>
+            <a:off x="9372600" y="2484501"/>
             <a:ext cx="2133600" cy="182880"/>
           </a:xfrm>
           <a:prstGeom prst="rect">
@@ -21425,13 +21269,13 @@
       </p:sp>
       <p:sp>
         <p:nvSpPr>
-          <p:cNvPr id="19" name="Rectangle 18"/>
+          <p:cNvPr id="15" name="Rectangle 14"/>
           <p:cNvSpPr/>
           <p:nvPr/>
         </p:nvSpPr>
         <p:spPr>
           <a:xfrm>
-            <a:off x="9124950" y="2410396"/>
+            <a:off x="9124950" y="2760726"/>
             <a:ext cx="38100" cy="832104"/>
           </a:xfrm>
           <a:prstGeom prst="rect">
@@ -21469,13 +21313,13 @@
       </p:sp>
       <p:sp>
         <p:nvSpPr>
-          <p:cNvPr id="20" name="TextBox 19"/>
-          <p:cNvSpPr txBox="1"/>
-          <p:nvPr/>
-        </p:nvSpPr>
-        <p:spPr>
-          <a:xfrm>
-            <a:off x="9334500" y="2410396"/>
+          <p:cNvPr id="16" name="TextBox 15"/>
+          <p:cNvSpPr txBox="1"/>
+          <p:nvPr/>
+        </p:nvSpPr>
+        <p:spPr>
+          <a:xfrm>
+            <a:off x="9334500" y="2760726"/>
             <a:ext cx="2171700" cy="1403604"/>
           </a:xfrm>
           <a:prstGeom prst="rect">
@@ -21549,7 +21393,7 @@
       </p:sp>
       <p:sp>
         <p:nvSpPr>
-          <p:cNvPr id="21" name="TextBox 20"/>
+          <p:cNvPr id="17" name="TextBox 16"/>
           <p:cNvSpPr txBox="1"/>
           <p:nvPr/>
         </p:nvSpPr>
@@ -21588,7 +21432,7 @@
       </p:sp>
       <p:sp>
         <p:nvSpPr>
-          <p:cNvPr id="22" name="TextBox 21"/>
+          <p:cNvPr id="18" name="TextBox 17"/>
           <p:cNvSpPr txBox="1"/>
           <p:nvPr/>
         </p:nvSpPr>
@@ -30053,7 +29897,7 @@
                 </a:solidFill>
                 <a:latin typeface="Roboto"/>
               </a:rPr>
-              <a:t>O que o kernel faz quando alguém digita docker run, e por que a imagem é em camadas.</a:t>
+              <a:t>Antes de decidir onde cada parte roda, o que o kernel faz quando alguém digita docker run e por que a imagem é em camadas.</a:t>
             </a:r>
           </a:p>
         </p:txBody>

</xml_diff>

<commit_message>
docs: troca os titulos de slide em forma de slogan por frases que dizem o que o slide mostra
</commit_message>
<xml_diff>
--- a/trabalhos/T1-Docker-Invite-People.pptx
+++ b/trabalhos/T1-Docker-Invite-People.pptx
@@ -18844,7 +18844,7 @@
                 </a:solidFill>
                 <a:latin typeface="Roboto"/>
               </a:rPr>
-              <a:t>O que a fronteira garante</a:t>
+              <a:t>A fronteira aumenta a coesão</a:t>
             </a:r>
           </a:p>
           <a:p>
@@ -18860,7 +18860,7 @@
                 </a:solidFill>
                 <a:latin typeface="Roboto"/>
               </a:rPr>
-              <a:t>e o que ela não garante</a:t>
+              <a:t>e muda a forma do acoplamento</a:t>
             </a:r>
           </a:p>
         </p:txBody>
@@ -18899,7 +18899,7 @@
                 </a:solidFill>
                 <a:latin typeface="Roboto"/>
               </a:rPr>
-              <a:t>GARANTE</a:t>
+              <a:t>COESÃO</a:t>
             </a:r>
           </a:p>
         </p:txBody>
@@ -19294,7 +19294,7 @@
                 </a:solidFill>
                 <a:latin typeface="Roboto"/>
               </a:rPr>
-              <a:t>NÃO GARANTE</a:t>
+              <a:t>ACOPLAMENTO</a:t>
             </a:r>
           </a:p>
         </p:txBody>
@@ -19700,7 +19700,7 @@
                 </a:solidFill>
                 <a:latin typeface="Roboto"/>
               </a:rPr>
-              <a:t>Duas views sobre o mesmo Model,</a:t>
+              <a:t>O convite público e o painel</a:t>
             </a:r>
           </a:p>
           <a:p>
@@ -19716,7 +19716,7 @@
                 </a:solidFill>
                 <a:latin typeface="Roboto"/>
               </a:rPr>
-              <a:t>dois perfis de carga</a:t>
+              <a:t>têm cargas diferentes</a:t>
             </a:r>
           </a:p>
         </p:txBody>
@@ -22856,7 +22856,7 @@
                 </a:solidFill>
                 <a:latin typeface="Roboto"/>
               </a:rPr>
-              <a:t>O QUE ELE CREDITA A CAMADAS</a:t>
+              <a:t>NA AULA 03</a:t>
             </a:r>
           </a:p>
         </p:txBody>
@@ -23251,7 +23251,7 @@
                 </a:solidFill>
                 <a:latin typeface="Roboto"/>
               </a:rPr>
-              <a:t>O QUE CADA UMA VIRA AQUI</a:t>
+              <a:t>COM CONTAINER</a:t>
             </a:r>
           </a:p>
         </p:txBody>
@@ -26533,7 +26533,7 @@
                 </a:solidFill>
                 <a:latin typeface="Roboto"/>
               </a:rPr>
-              <a:t>Critérios de contraindicação</a:t>
+              <a:t>Quatro critérios para não conteinerizar,</a:t>
             </a:r>
           </a:p>
           <a:p>
@@ -26588,7 +26588,7 @@
                 </a:solidFill>
                 <a:latin typeface="Roboto"/>
               </a:rPr>
-              <a:t>QUANDO NÃO COMPENSA</a:t>
+              <a:t>OS QUATRO CRITÉRIOS</a:t>
             </a:r>
           </a:p>
         </p:txBody>
@@ -27428,7 +27428,7 @@
                 </a:solidFill>
                 <a:latin typeface="Roboto"/>
               </a:rPr>
-              <a:t>O BALANÇO DO TIME</a:t>
+              <a:t>GANHO E CUSTO</a:t>
             </a:r>
           </a:p>
         </p:txBody>
@@ -27467,7 +27467,7 @@
                 </a:solidFill>
                 <a:latin typeface="Roboto"/>
               </a:rPr>
-              <a:t>Ganho e custo, nos quatro atributos</a:t>
+              <a:t>Efeito nos quatro atributos</a:t>
             </a:r>
           </a:p>
           <a:p>
@@ -28860,7 +28860,7 @@
                 </a:solidFill>
                 <a:latin typeface="Roboto"/>
               </a:rPr>
-              <a:t>ANTES E DEPOIS, NO NOSSO REPOSITÓRIO</a:t>
+              <a:t>ANTES E DEPOIS</a:t>
             </a:r>
           </a:p>
         </p:txBody>
@@ -28899,7 +28899,7 @@
                 </a:solidFill>
                 <a:latin typeface="Roboto"/>
               </a:rPr>
-              <a:t>Do problema de ambiente</a:t>
+              <a:t>O que mudou no ambiente</a:t>
             </a:r>
           </a:p>
           <a:p>
@@ -28915,7 +28915,7 @@
                 </a:solidFill>
                 <a:latin typeface="Roboto"/>
               </a:rPr>
-              <a:t>ao arquivo de compose</a:t>
+              <a:t>do time</a:t>
             </a:r>
           </a:p>
         </p:txBody>
@@ -30827,7 +30827,7 @@
                 </a:solidFill>
                 <a:latin typeface="Roboto"/>
               </a:rPr>
-              <a:t>PARA CONSULTAR DEPOIS</a:t>
+              <a:t>FONTES CITADAS</a:t>
             </a:r>
           </a:p>
         </p:txBody>
@@ -31696,7 +31696,7 @@
                 </a:solidFill>
                 <a:latin typeface="Roboto"/>
               </a:rPr>
-              <a:t>Do chroot à padronização OCI</a:t>
+              <a:t>Marcos do isolamento de processos</a:t>
             </a:r>
           </a:p>
         </p:txBody>

</xml_diff>

<commit_message>
docs: tira do T1 os rotulos em negrito com glosa, os fragmentos curtos e os aforismos
</commit_message>
<xml_diff>
--- a/trabalhos/T1-Docker-Invite-People.pptx
+++ b/trabalhos/T1-Docker-Invite-People.pptx
@@ -12233,22 +12233,13 @@
               </a:lnSpc>
             </a:pPr>
             <a:r>
-              <a:rPr sz="1650" b="1" i="0">
+              <a:rPr sz="1650" b="0" i="0">
                 <a:solidFill>
                   <a:srgbClr val="1A1A1E"/>
                 </a:solidFill>
                 <a:latin typeface="Roboto"/>
               </a:rPr>
-              <a:t>Capabilities.</a:t>
-            </a:r>
-            <a:r>
-              <a:rPr sz="1650" b="0" i="0">
-                <a:solidFill>
-                  <a:srgbClr val="1A1A1E"/>
-                </a:solidFill>
-                <a:latin typeface="Roboto"/>
-              </a:rPr>
-              <a:t> O root do POSIX fatiado em privilégios independentes, derrubados e devolvidos um a um.</a:t>
+              <a:t>Capabilities fatiam o root do POSIX em privilégios independentes, que podem ser derrubados e devolvidos um a um.</a:t>
             </a:r>
           </a:p>
         </p:txBody>
@@ -12320,22 +12311,13 @@
               </a:lnSpc>
             </a:pPr>
             <a:r>
-              <a:rPr sz="1650" b="1" i="0">
+              <a:rPr sz="1650" b="0" i="0">
                 <a:solidFill>
                   <a:srgbClr val="1A1A1E"/>
                 </a:solidFill>
                 <a:latin typeface="Roboto"/>
               </a:rPr>
-              <a:t>Seccomp-bpf.</a:t>
-            </a:r>
-            <a:r>
-              <a:rPr sz="1650" b="0" i="0">
-                <a:solidFill>
-                  <a:srgbClr val="1A1A1E"/>
-                </a:solidFill>
-                <a:latin typeface="Roboto"/>
-              </a:rPr>
-              <a:t> O perfil padrão bloqueia parte das chamadas de sistema disponíveis.</a:t>
+              <a:t>O perfil padrão de seccomp-bpf bloqueia parte das chamadas de sistema disponíveis.</a:t>
             </a:r>
           </a:p>
         </p:txBody>
@@ -12407,22 +12389,13 @@
               </a:lnSpc>
             </a:pPr>
             <a:r>
-              <a:rPr sz="1650" b="1" i="0">
+              <a:rPr sz="1650" b="0" i="0">
                 <a:solidFill>
                   <a:srgbClr val="1A1A1E"/>
                 </a:solidFill>
                 <a:latin typeface="Roboto"/>
               </a:rPr>
-              <a:t>LSM.</a:t>
-            </a:r>
-            <a:r>
-              <a:rPr sz="1650" b="0" i="0">
-                <a:solidFill>
-                  <a:srgbClr val="1A1A1E"/>
-                </a:solidFill>
-                <a:latin typeface="Roboto"/>
-              </a:rPr>
-              <a:t> AppArmor ou SELinux por cima de tudo.</a:t>
+              <a:t>AppArmor ou SELinux entram por cima de tudo, como LSM.</a:t>
             </a:r>
           </a:p>
         </p:txBody>
@@ -18622,22 +18595,13 @@
               </a:lnSpc>
             </a:pPr>
             <a:r>
-              <a:rPr sz="1280" b="1" i="0">
+              <a:rPr sz="1280" b="0" i="0">
                 <a:solidFill>
                   <a:srgbClr val="1A1A1E"/>
                 </a:solidFill>
                 <a:latin typeface="Roboto"/>
               </a:rPr>
-              <a:t>As imagens são exemplo.</a:t>
-            </a:r>
-            <a:r>
-              <a:rPr sz="1280" b="0" i="0">
-                <a:solidFill>
-                  <a:srgbClr val="1A1A1E"/>
-                </a:solidFill>
-                <a:latin typeface="Roboto"/>
-              </a:rPr>
-              <a:t> A stack ainda não foi decidida, é assunto do ADR #63.</a:t>
+              <a:t>As imagens do arquivo são exemplo. A stack ainda não foi decidida e é assunto do ADR #63.</a:t>
             </a:r>
           </a:p>
         </p:txBody>
@@ -18872,7 +18836,7 @@
         </p:nvSpPr>
         <p:spPr>
           <a:xfrm>
-            <a:off x="685800" y="2193226"/>
+            <a:off x="685800" y="2061210"/>
             <a:ext cx="5143500" cy="182880"/>
           </a:xfrm>
           <a:prstGeom prst="rect">
@@ -18911,7 +18875,7 @@
         </p:nvSpPr>
         <p:spPr>
           <a:xfrm>
-            <a:off x="685800" y="2402776"/>
+            <a:off x="685800" y="2270760"/>
             <a:ext cx="419100" cy="28575"/>
           </a:xfrm>
           <a:prstGeom prst="rect">
@@ -18955,7 +18919,7 @@
         </p:nvSpPr>
         <p:spPr>
           <a:xfrm>
-            <a:off x="685800" y="2698052"/>
+            <a:off x="685800" y="2566035"/>
             <a:ext cx="247650" cy="294437"/>
           </a:xfrm>
           <a:prstGeom prst="rect">
@@ -18994,7 +18958,7 @@
         </p:nvSpPr>
         <p:spPr>
           <a:xfrm>
-            <a:off x="971550" y="2688526"/>
+            <a:off x="971550" y="2556510"/>
             <a:ext cx="4857750" cy="95250"/>
           </a:xfrm>
           <a:prstGeom prst="rect">
@@ -19020,7 +18984,7 @@
                 </a:solidFill>
                 <a:latin typeface="Roboto"/>
               </a:rPr>
-              <a:t>Mais coesão: uma responsabilidade por imagem.</a:t>
+              <a:t>A imagem passa a ter uma responsabilidade só, que é mais coesão.</a:t>
             </a:r>
           </a:p>
         </p:txBody>
@@ -19033,7 +18997,7 @@
         </p:nvSpPr>
         <p:spPr>
           <a:xfrm>
-            <a:off x="685800" y="3228784"/>
+            <a:off x="685800" y="3360801"/>
             <a:ext cx="247650" cy="294437"/>
           </a:xfrm>
           <a:prstGeom prst="rect">
@@ -19072,7 +19036,7 @@
         </p:nvSpPr>
         <p:spPr>
           <a:xfrm>
-            <a:off x="971550" y="3219260"/>
+            <a:off x="971550" y="3351276"/>
             <a:ext cx="4857750" cy="95250"/>
           </a:xfrm>
           <a:prstGeom prst="rect">
@@ -19111,7 +19075,7 @@
         </p:nvSpPr>
         <p:spPr>
           <a:xfrm>
-            <a:off x="685800" y="4023550"/>
+            <a:off x="685800" y="4155567"/>
             <a:ext cx="247650" cy="294437"/>
           </a:xfrm>
           <a:prstGeom prst="rect">
@@ -19150,7 +19114,7 @@
         </p:nvSpPr>
         <p:spPr>
           <a:xfrm>
-            <a:off x="971550" y="4014026"/>
+            <a:off x="971550" y="4146042"/>
             <a:ext cx="4857750" cy="95250"/>
           </a:xfrm>
           <a:prstGeom prst="rect">
@@ -19189,7 +19153,7 @@
         </p:nvSpPr>
         <p:spPr>
           <a:xfrm>
-            <a:off x="685800" y="4818316"/>
+            <a:off x="685800" y="4950333"/>
             <a:ext cx="247650" cy="294437"/>
           </a:xfrm>
           <a:prstGeom prst="rect">
@@ -19228,7 +19192,7 @@
         </p:nvSpPr>
         <p:spPr>
           <a:xfrm>
-            <a:off x="971550" y="4808792"/>
+            <a:off x="971550" y="4940808"/>
             <a:ext cx="4857750" cy="95250"/>
           </a:xfrm>
           <a:prstGeom prst="rect">
@@ -19267,7 +19231,7 @@
         </p:nvSpPr>
         <p:spPr>
           <a:xfrm>
-            <a:off x="6362700" y="2193226"/>
+            <a:off x="6362700" y="2061210"/>
             <a:ext cx="5143500" cy="182880"/>
           </a:xfrm>
           <a:prstGeom prst="rect">
@@ -19306,7 +19270,7 @@
         </p:nvSpPr>
         <p:spPr>
           <a:xfrm>
-            <a:off x="6362700" y="2402776"/>
+            <a:off x="6362700" y="2270760"/>
             <a:ext cx="419100" cy="28575"/>
           </a:xfrm>
           <a:prstGeom prst="rect">
@@ -19350,7 +19314,7 @@
         </p:nvSpPr>
         <p:spPr>
           <a:xfrm>
-            <a:off x="6362700" y="2698052"/>
+            <a:off x="6362700" y="2566035"/>
             <a:ext cx="247650" cy="294437"/>
           </a:xfrm>
           <a:prstGeom prst="rect">
@@ -19389,7 +19353,7 @@
         </p:nvSpPr>
         <p:spPr>
           <a:xfrm>
-            <a:off x="6648450" y="2688526"/>
+            <a:off x="6648450" y="2556510"/>
             <a:ext cx="4857750" cy="95250"/>
           </a:xfrm>
           <a:prstGeom prst="rect">
@@ -19415,7 +19379,7 @@
                 </a:solidFill>
                 <a:latin typeface="Roboto"/>
               </a:rPr>
-              <a:t>A regra entre as nossas três camadas. Elas ficam na mesma imagem do back-end.</a:t>
+              <a:t>Entre as nossas três camadas o acoplamento continua igual, porque elas ficam na mesma imagem do back-end.</a:t>
             </a:r>
           </a:p>
         </p:txBody>
@@ -19428,7 +19392,7 @@
         </p:nvSpPr>
         <p:spPr>
           <a:xfrm>
-            <a:off x="6362700" y="3492818"/>
+            <a:off x="6362700" y="3624834"/>
             <a:ext cx="247650" cy="294437"/>
           </a:xfrm>
           <a:prstGeom prst="rect">
@@ -19467,7 +19431,7 @@
         </p:nvSpPr>
         <p:spPr>
           <a:xfrm>
-            <a:off x="6648450" y="3483292"/>
+            <a:off x="6648450" y="3615309"/>
             <a:ext cx="4857750" cy="95250"/>
           </a:xfrm>
           <a:prstGeom prst="rect">
@@ -19493,7 +19457,7 @@
                 </a:solidFill>
                 <a:latin typeface="Roboto"/>
               </a:rPr>
-              <a:t>Redução de acoplamento. Ele muda de forma e passa a ter latência, falha parcial e ordem de subida.</a:t>
+              <a:t>Onde há separação, o acoplamento não some, muda de forma e passa a ter latência, falha parcial e ordem de subida.</a:t>
             </a:r>
           </a:p>
         </p:txBody>
@@ -24787,7 +24751,7 @@
                 </a:solidFill>
                 <a:latin typeface="Roboto"/>
               </a:rPr>
-              <a:t>Isola de verdade</a:t>
+              <a:t>Isolamento imposto em hardware</a:t>
             </a:r>
           </a:p>
         </p:txBody>
@@ -25153,7 +25117,7 @@
                 </a:solidFill>
                 <a:latin typeface="Roboto"/>
               </a:rPr>
-              <a:t>Escolhido, com o custo declarado</a:t>
+              <a:t>Ambiente igual para os quatro integrantes</a:t>
             </a:r>
           </a:p>
         </p:txBody>
@@ -25192,7 +25156,7 @@
                 </a:solidFill>
                 <a:latin typeface="Roboto"/>
               </a:rPr>
-              <a:t>Move complexidade em vez de apagá-la</a:t>
+              <a:t>Acrescenta uma camada de build e de orquestração</a:t>
             </a:r>
           </a:p>
         </p:txBody>
@@ -26327,7 +26291,7 @@
         </p:nvSpPr>
         <p:spPr>
           <a:xfrm>
-            <a:off x="685800" y="2028825"/>
+            <a:off x="685800" y="2117598"/>
             <a:ext cx="5143500" cy="182880"/>
           </a:xfrm>
           <a:prstGeom prst="rect">
@@ -26366,7 +26330,7 @@
         </p:nvSpPr>
         <p:spPr>
           <a:xfrm>
-            <a:off x="685800" y="2238375"/>
+            <a:off x="685800" y="2327148"/>
             <a:ext cx="419100" cy="28575"/>
           </a:xfrm>
           <a:prstGeom prst="rect">
@@ -26410,8 +26374,8 @@
         </p:nvSpPr>
         <p:spPr>
           <a:xfrm>
-            <a:off x="685800" y="2533650"/>
-            <a:ext cx="247650" cy="280416"/>
+            <a:off x="685800" y="2622423"/>
+            <a:ext cx="247650" cy="252374"/>
           </a:xfrm>
           <a:prstGeom prst="rect">
             <a:avLst/>
@@ -26430,7 +26394,7 @@
               </a:lnSpc>
             </a:pPr>
             <a:r>
-              <a:rPr sz="1380" b="1" i="0">
+              <a:rPr sz="1240" b="1" i="0">
                 <a:solidFill>
                   <a:srgbClr val="E94D1C"/>
                 </a:solidFill>
@@ -26449,7 +26413,7 @@
         </p:nvSpPr>
         <p:spPr>
           <a:xfrm>
-            <a:off x="971550" y="2524125"/>
+            <a:off x="971550" y="2612898"/>
             <a:ext cx="4857750" cy="95250"/>
           </a:xfrm>
           <a:prstGeom prst="rect">
@@ -26469,36 +26433,105 @@
               </a:lnSpc>
             </a:pPr>
             <a:r>
-              <a:rPr sz="1500" b="1" i="0">
+              <a:rPr sz="1350" b="0" i="0">
                 <a:solidFill>
                   <a:srgbClr val="1A1A1E"/>
                 </a:solidFill>
                 <a:latin typeface="Roboto"/>
               </a:rPr>
-              <a:t>Modularidade e reusabilidade.</a:t>
-            </a:r>
-            <a:r>
-              <a:rPr sz="1500" b="0" i="0">
+              <a:t>Cada imagem tem uma responsabilidade e uma fronteira declarada, que é a modularidade e a reusabilidade da Aula 03.</a:t>
+            </a:r>
+          </a:p>
+        </p:txBody>
+      </p:sp>
+      <p:sp>
+        <p:nvSpPr>
+          <p:cNvPr id="9" name="TextBox 8"/>
+          <p:cNvSpPr txBox="1"/>
+          <p:nvPr/>
+        </p:nvSpPr>
+        <p:spPr>
+          <a:xfrm>
+            <a:off x="685800" y="3510915"/>
+            <a:ext cx="247650" cy="252374"/>
+          </a:xfrm>
+          <a:prstGeom prst="rect">
+            <a:avLst/>
+          </a:prstGeom>
+          <a:noFill/>
+        </p:spPr>
+        <p:txBody>
+          <a:bodyPr wrap="square" lIns="0" rIns="0" tIns="0" bIns="0" anchor="t">
+            <a:spAutoFit/>
+          </a:bodyPr>
+          <a:lstStyle/>
+          <a:p>
+            <a:pPr algn="l">
+              <a:lnSpc>
+                <a:spcPct val="120000"/>
+              </a:lnSpc>
+            </a:pPr>
+            <a:r>
+              <a:rPr sz="1240" b="1" i="0">
+                <a:solidFill>
+                  <a:srgbClr val="E94D1C"/>
+                </a:solidFill>
+                <a:latin typeface="Roboto"/>
+              </a:rPr>
+              <a:t>//</a:t>
+            </a:r>
+          </a:p>
+        </p:txBody>
+      </p:sp>
+      <p:sp>
+        <p:nvSpPr>
+          <p:cNvPr id="10" name="TextBox 9"/>
+          <p:cNvSpPr txBox="1"/>
+          <p:nvPr/>
+        </p:nvSpPr>
+        <p:spPr>
+          <a:xfrm>
+            <a:off x="971550" y="3501390"/>
+            <a:ext cx="4857750" cy="95250"/>
+          </a:xfrm>
+          <a:prstGeom prst="rect">
+            <a:avLst/>
+          </a:prstGeom>
+          <a:noFill/>
+        </p:spPr>
+        <p:txBody>
+          <a:bodyPr wrap="square" lIns="0" rIns="0" tIns="0" bIns="0" anchor="t">
+            <a:spAutoFit/>
+          </a:bodyPr>
+          <a:lstStyle/>
+          <a:p>
+            <a:pPr algn="l">
+              <a:lnSpc>
+                <a:spcPct val="130000"/>
+              </a:lnSpc>
+            </a:pPr>
+            <a:r>
+              <a:rPr sz="1350" b="0" i="0">
                 <a:solidFill>
                   <a:srgbClr val="1A1A1E"/>
                 </a:solidFill>
                 <a:latin typeface="Roboto"/>
               </a:rPr>
-              <a:t> Uma responsabilidade por imagem, com fronteira declarada.</a:t>
-            </a:r>
-          </a:p>
-        </p:txBody>
-      </p:sp>
-      <p:sp>
-        <p:nvSpPr>
-          <p:cNvPr id="9" name="TextBox 8"/>
-          <p:cNvSpPr txBox="1"/>
-          <p:nvPr/>
-        </p:nvSpPr>
-        <p:spPr>
-          <a:xfrm>
-            <a:off x="685800" y="3284220"/>
-            <a:ext cx="247650" cy="280416"/>
+              <a:t>O ambiente vira arquivo legível, versionado junto com o código, e com isso ganha compreensibilidade.</a:t>
+            </a:r>
+          </a:p>
+        </p:txBody>
+      </p:sp>
+      <p:sp>
+        <p:nvSpPr>
+          <p:cNvPr id="11" name="TextBox 10"/>
+          <p:cNvSpPr txBox="1"/>
+          <p:nvPr/>
+        </p:nvSpPr>
+        <p:spPr>
+          <a:xfrm>
+            <a:off x="685800" y="4173093"/>
+            <a:ext cx="247650" cy="252374"/>
           </a:xfrm>
           <a:prstGeom prst="rect">
             <a:avLst/>
@@ -26517,7 +26550,7 @@
               </a:lnSpc>
             </a:pPr>
             <a:r>
-              <a:rPr sz="1380" b="1" i="0">
+              <a:rPr sz="1240" b="1" i="0">
                 <a:solidFill>
                   <a:srgbClr val="E94D1C"/>
                 </a:solidFill>
@@ -26530,13 +26563,13 @@
       </p:sp>
       <p:sp>
         <p:nvSpPr>
-          <p:cNvPr id="10" name="TextBox 9"/>
-          <p:cNvSpPr txBox="1"/>
-          <p:nvPr/>
-        </p:nvSpPr>
-        <p:spPr>
-          <a:xfrm>
-            <a:off x="971550" y="3274695"/>
+          <p:cNvPr id="12" name="TextBox 11"/>
+          <p:cNvSpPr txBox="1"/>
+          <p:nvPr/>
+        </p:nvSpPr>
+        <p:spPr>
+          <a:xfrm>
+            <a:off x="971550" y="4163568"/>
             <a:ext cx="4857750" cy="95250"/>
           </a:xfrm>
           <a:prstGeom prst="rect">
@@ -26556,36 +26589,105 @@
               </a:lnSpc>
             </a:pPr>
             <a:r>
-              <a:rPr sz="1500" b="1" i="0">
+              <a:rPr sz="1350" b="0" i="0">
                 <a:solidFill>
                   <a:srgbClr val="1A1A1E"/>
                 </a:solidFill>
                 <a:latin typeface="Roboto"/>
               </a:rPr>
-              <a:t>Compreensibilidade.</a:t>
-            </a:r>
-            <a:r>
-              <a:rPr sz="1500" b="0" i="0">
+              <a:t>Extensibilidade sai barata, porque trocar runtime ou banco é editar uma linha de arquivo.</a:t>
+            </a:r>
+          </a:p>
+        </p:txBody>
+      </p:sp>
+      <p:sp>
+        <p:nvSpPr>
+          <p:cNvPr id="13" name="TextBox 12"/>
+          <p:cNvSpPr txBox="1"/>
+          <p:nvPr/>
+        </p:nvSpPr>
+        <p:spPr>
+          <a:xfrm>
+            <a:off x="685800" y="4835271"/>
+            <a:ext cx="247650" cy="252374"/>
+          </a:xfrm>
+          <a:prstGeom prst="rect">
+            <a:avLst/>
+          </a:prstGeom>
+          <a:noFill/>
+        </p:spPr>
+        <p:txBody>
+          <a:bodyPr wrap="square" lIns="0" rIns="0" tIns="0" bIns="0" anchor="t">
+            <a:spAutoFit/>
+          </a:bodyPr>
+          <a:lstStyle/>
+          <a:p>
+            <a:pPr algn="l">
+              <a:lnSpc>
+                <a:spcPct val="120000"/>
+              </a:lnSpc>
+            </a:pPr>
+            <a:r>
+              <a:rPr sz="1240" b="1" i="0">
+                <a:solidFill>
+                  <a:srgbClr val="E94D1C"/>
+                </a:solidFill>
+                <a:latin typeface="Roboto"/>
+              </a:rPr>
+              <a:t>//</a:t>
+            </a:r>
+          </a:p>
+        </p:txBody>
+      </p:sp>
+      <p:sp>
+        <p:nvSpPr>
+          <p:cNvPr id="14" name="TextBox 13"/>
+          <p:cNvSpPr txBox="1"/>
+          <p:nvPr/>
+        </p:nvSpPr>
+        <p:spPr>
+          <a:xfrm>
+            <a:off x="971550" y="4825746"/>
+            <a:ext cx="4857750" cy="95250"/>
+          </a:xfrm>
+          <a:prstGeom prst="rect">
+            <a:avLst/>
+          </a:prstGeom>
+          <a:noFill/>
+        </p:spPr>
+        <p:txBody>
+          <a:bodyPr wrap="square" lIns="0" rIns="0" tIns="0" bIns="0" anchor="t">
+            <a:spAutoFit/>
+          </a:bodyPr>
+          <a:lstStyle/>
+          <a:p>
+            <a:pPr algn="l">
+              <a:lnSpc>
+                <a:spcPct val="130000"/>
+              </a:lnSpc>
+            </a:pPr>
+            <a:r>
+              <a:rPr sz="1350" b="0" i="0">
                 <a:solidFill>
                   <a:srgbClr val="1A1A1E"/>
                 </a:solidFill>
                 <a:latin typeface="Roboto"/>
               </a:rPr>
-              <a:t> O ambiente vira arquivo legível, versionado junto com o código.</a:t>
-            </a:r>
-          </a:p>
-        </p:txBody>
-      </p:sp>
-      <p:sp>
-        <p:nvSpPr>
-          <p:cNvPr id="11" name="TextBox 10"/>
-          <p:cNvSpPr txBox="1"/>
-          <p:nvPr/>
-        </p:nvSpPr>
-        <p:spPr>
-          <a:xfrm>
-            <a:off x="685800" y="4034790"/>
-            <a:ext cx="247650" cy="280416"/>
+              <a:t>A mesma imagem atravessa notebook, pipeline e a demonstração funcional do T3, o que ajuda a manutenibilidade.</a:t>
+            </a:r>
+          </a:p>
+        </p:txBody>
+      </p:sp>
+      <p:sp>
+        <p:nvSpPr>
+          <p:cNvPr id="15" name="TextBox 14"/>
+          <p:cNvSpPr txBox="1"/>
+          <p:nvPr/>
+        </p:nvSpPr>
+        <p:spPr>
+          <a:xfrm>
+            <a:off x="685800" y="5497449"/>
+            <a:ext cx="247650" cy="252374"/>
           </a:xfrm>
           <a:prstGeom prst="rect">
             <a:avLst/>
@@ -26604,7 +26706,7 @@
               </a:lnSpc>
             </a:pPr>
             <a:r>
-              <a:rPr sz="1380" b="1" i="0">
+              <a:rPr sz="1240" b="1" i="0">
                 <a:solidFill>
                   <a:srgbClr val="E94D1C"/>
                 </a:solidFill>
@@ -26617,13 +26719,13 @@
       </p:sp>
       <p:sp>
         <p:nvSpPr>
-          <p:cNvPr id="12" name="TextBox 11"/>
-          <p:cNvSpPr txBox="1"/>
-          <p:nvPr/>
-        </p:nvSpPr>
-        <p:spPr>
-          <a:xfrm>
-            <a:off x="971550" y="4025265"/>
+          <p:cNvPr id="16" name="TextBox 15"/>
+          <p:cNvSpPr txBox="1"/>
+          <p:nvPr/>
+        </p:nvSpPr>
+        <p:spPr>
+          <a:xfrm>
+            <a:off x="971550" y="5487924"/>
             <a:ext cx="4857750" cy="95250"/>
           </a:xfrm>
           <a:prstGeom prst="rect">
@@ -26643,196 +26745,13 @@
               </a:lnSpc>
             </a:pPr>
             <a:r>
-              <a:rPr sz="1500" b="1" i="0">
+              <a:rPr sz="1350" b="0" i="0">
                 <a:solidFill>
                   <a:srgbClr val="1A1A1E"/>
                 </a:solidFill>
                 <a:latin typeface="Roboto"/>
               </a:rPr>
-              <a:t>Extensibilidade.</a:t>
-            </a:r>
-            <a:r>
-              <a:rPr sz="1500" b="0" i="0">
-                <a:solidFill>
-                  <a:srgbClr val="1A1A1E"/>
-                </a:solidFill>
-                <a:latin typeface="Roboto"/>
-              </a:rPr>
-              <a:t> Trocar runtime ou banco é editar uma linha de arquivo.</a:t>
-            </a:r>
-          </a:p>
-        </p:txBody>
-      </p:sp>
-      <p:sp>
-        <p:nvSpPr>
-          <p:cNvPr id="13" name="TextBox 12"/>
-          <p:cNvSpPr txBox="1"/>
-          <p:nvPr/>
-        </p:nvSpPr>
-        <p:spPr>
-          <a:xfrm>
-            <a:off x="685800" y="4785360"/>
-            <a:ext cx="247650" cy="280416"/>
-          </a:xfrm>
-          <a:prstGeom prst="rect">
-            <a:avLst/>
-          </a:prstGeom>
-          <a:noFill/>
-        </p:spPr>
-        <p:txBody>
-          <a:bodyPr wrap="square" lIns="0" rIns="0" tIns="0" bIns="0" anchor="t">
-            <a:spAutoFit/>
-          </a:bodyPr>
-          <a:lstStyle/>
-          <a:p>
-            <a:pPr algn="l">
-              <a:lnSpc>
-                <a:spcPct val="120000"/>
-              </a:lnSpc>
-            </a:pPr>
-            <a:r>
-              <a:rPr sz="1380" b="1" i="0">
-                <a:solidFill>
-                  <a:srgbClr val="E94D1C"/>
-                </a:solidFill>
-                <a:latin typeface="Roboto"/>
-              </a:rPr>
-              <a:t>//</a:t>
-            </a:r>
-          </a:p>
-        </p:txBody>
-      </p:sp>
-      <p:sp>
-        <p:nvSpPr>
-          <p:cNvPr id="14" name="TextBox 13"/>
-          <p:cNvSpPr txBox="1"/>
-          <p:nvPr/>
-        </p:nvSpPr>
-        <p:spPr>
-          <a:xfrm>
-            <a:off x="971550" y="4775835"/>
-            <a:ext cx="4857750" cy="95250"/>
-          </a:xfrm>
-          <a:prstGeom prst="rect">
-            <a:avLst/>
-          </a:prstGeom>
-          <a:noFill/>
-        </p:spPr>
-        <p:txBody>
-          <a:bodyPr wrap="square" lIns="0" rIns="0" tIns="0" bIns="0" anchor="t">
-            <a:spAutoFit/>
-          </a:bodyPr>
-          <a:lstStyle/>
-          <a:p>
-            <a:pPr algn="l">
-              <a:lnSpc>
-                <a:spcPct val="130000"/>
-              </a:lnSpc>
-            </a:pPr>
-            <a:r>
-              <a:rPr sz="1500" b="1" i="0">
-                <a:solidFill>
-                  <a:srgbClr val="1A1A1E"/>
-                </a:solidFill>
-                <a:latin typeface="Roboto"/>
-              </a:rPr>
-              <a:t>Manutenibilidade.</a:t>
-            </a:r>
-            <a:r>
-              <a:rPr sz="1500" b="0" i="0">
-                <a:solidFill>
-                  <a:srgbClr val="1A1A1E"/>
-                </a:solidFill>
-                <a:latin typeface="Roboto"/>
-              </a:rPr>
-              <a:t> A mesma imagem atravessa notebook, pipeline e a demonstração funcional do T3.</a:t>
-            </a:r>
-          </a:p>
-        </p:txBody>
-      </p:sp>
-      <p:sp>
-        <p:nvSpPr>
-          <p:cNvPr id="15" name="TextBox 14"/>
-          <p:cNvSpPr txBox="1"/>
-          <p:nvPr/>
-        </p:nvSpPr>
-        <p:spPr>
-          <a:xfrm>
-            <a:off x="685800" y="5535930"/>
-            <a:ext cx="247650" cy="280416"/>
-          </a:xfrm>
-          <a:prstGeom prst="rect">
-            <a:avLst/>
-          </a:prstGeom>
-          <a:noFill/>
-        </p:spPr>
-        <p:txBody>
-          <a:bodyPr wrap="square" lIns="0" rIns="0" tIns="0" bIns="0" anchor="t">
-            <a:spAutoFit/>
-          </a:bodyPr>
-          <a:lstStyle/>
-          <a:p>
-            <a:pPr algn="l">
-              <a:lnSpc>
-                <a:spcPct val="120000"/>
-              </a:lnSpc>
-            </a:pPr>
-            <a:r>
-              <a:rPr sz="1380" b="1" i="0">
-                <a:solidFill>
-                  <a:srgbClr val="E94D1C"/>
-                </a:solidFill>
-                <a:latin typeface="Roboto"/>
-              </a:rPr>
-              <a:t>//</a:t>
-            </a:r>
-          </a:p>
-        </p:txBody>
-      </p:sp>
-      <p:sp>
-        <p:nvSpPr>
-          <p:cNvPr id="16" name="TextBox 15"/>
-          <p:cNvSpPr txBox="1"/>
-          <p:nvPr/>
-        </p:nvSpPr>
-        <p:spPr>
-          <a:xfrm>
-            <a:off x="971550" y="5526405"/>
-            <a:ext cx="4857750" cy="95250"/>
-          </a:xfrm>
-          <a:prstGeom prst="rect">
-            <a:avLst/>
-          </a:prstGeom>
-          <a:noFill/>
-        </p:spPr>
-        <p:txBody>
-          <a:bodyPr wrap="square" lIns="0" rIns="0" tIns="0" bIns="0" anchor="t">
-            <a:spAutoFit/>
-          </a:bodyPr>
-          <a:lstStyle/>
-          <a:p>
-            <a:pPr algn="l">
-              <a:lnSpc>
-                <a:spcPct val="130000"/>
-              </a:lnSpc>
-            </a:pPr>
-            <a:r>
-              <a:rPr sz="1500" b="1" i="0">
-                <a:solidFill>
-                  <a:srgbClr val="1A1A1E"/>
-                </a:solidFill>
-                <a:latin typeface="Roboto"/>
-              </a:rPr>
-              <a:t>Escalabilidade,</a:t>
-            </a:r>
-            <a:r>
-              <a:rPr sz="1500" b="0" i="0">
-                <a:solidFill>
-                  <a:srgbClr val="1A1A1E"/>
-                </a:solidFill>
-                <a:latin typeface="Roboto"/>
-              </a:rPr>
-              <a:t> de forma seletiva, e isso impõe que a aplicação seja mesmo sem estado.</a:t>
+              <a:t>A escalabilidade fica seletiva, e só vale se a aplicação for mesmo sem estado.</a:t>
             </a:r>
           </a:p>
         </p:txBody>
@@ -26845,7 +26764,7 @@
         </p:nvSpPr>
         <p:spPr>
           <a:xfrm>
-            <a:off x="6362700" y="2028825"/>
+            <a:off x="6362700" y="2117598"/>
             <a:ext cx="5143500" cy="182880"/>
           </a:xfrm>
           <a:prstGeom prst="rect">
@@ -26884,7 +26803,7 @@
         </p:nvSpPr>
         <p:spPr>
           <a:xfrm>
-            <a:off x="6362700" y="2238375"/>
+            <a:off x="6362700" y="2327148"/>
             <a:ext cx="419100" cy="28575"/>
           </a:xfrm>
           <a:prstGeom prst="rect">
@@ -26928,8 +26847,8 @@
         </p:nvSpPr>
         <p:spPr>
           <a:xfrm>
-            <a:off x="6362700" y="2533650"/>
-            <a:ext cx="247650" cy="280416"/>
+            <a:off x="6362700" y="2622423"/>
+            <a:ext cx="247650" cy="252374"/>
           </a:xfrm>
           <a:prstGeom prst="rect">
             <a:avLst/>
@@ -26948,7 +26867,7 @@
               </a:lnSpc>
             </a:pPr>
             <a:r>
-              <a:rPr sz="1380" b="1" i="0">
+              <a:rPr sz="1240" b="1" i="0">
                 <a:solidFill>
                   <a:srgbClr val="E94D1C"/>
                 </a:solidFill>
@@ -26967,7 +26886,7 @@
         </p:nvSpPr>
         <p:spPr>
           <a:xfrm>
-            <a:off x="6648450" y="2524125"/>
+            <a:off x="6648450" y="2612898"/>
             <a:ext cx="4857750" cy="95250"/>
           </a:xfrm>
           <a:prstGeom prst="rect">
@@ -26987,109 +26906,91 @@
               </a:lnSpc>
             </a:pPr>
             <a:r>
-              <a:rPr sz="1500" b="1" i="0">
+              <a:rPr sz="1350" b="0" i="0">
                 <a:solidFill>
                   <a:srgbClr val="1A1A1E"/>
                 </a:solidFill>
                 <a:latin typeface="Roboto"/>
               </a:rPr>
-              <a:t>Segurança.</a:t>
-            </a:r>
-            <a:r>
-              <a:rPr sz="1500" b="0" i="0">
+              <a:t>Segurança ganha isolamento e herda uma superfície nova, que é a imagem base e o privilégio de execução.</a:t>
+            </a:r>
+          </a:p>
+        </p:txBody>
+      </p:sp>
+      <p:sp>
+        <p:nvSpPr>
+          <p:cNvPr id="21" name="TextBox 20"/>
+          <p:cNvSpPr txBox="1"/>
+          <p:nvPr/>
+        </p:nvSpPr>
+        <p:spPr>
+          <a:xfrm>
+            <a:off x="6362700" y="3284601"/>
+            <a:ext cx="247650" cy="252374"/>
+          </a:xfrm>
+          <a:prstGeom prst="rect">
+            <a:avLst/>
+          </a:prstGeom>
+          <a:noFill/>
+        </p:spPr>
+        <p:txBody>
+          <a:bodyPr wrap="square" lIns="0" rIns="0" tIns="0" bIns="0" anchor="t">
+            <a:spAutoFit/>
+          </a:bodyPr>
+          <a:lstStyle/>
+          <a:p>
+            <a:pPr algn="l">
+              <a:lnSpc>
+                <a:spcPct val="120000"/>
+              </a:lnSpc>
+            </a:pPr>
+            <a:r>
+              <a:rPr sz="1240" b="1" i="0">
+                <a:solidFill>
+                  <a:srgbClr val="E94D1C"/>
+                </a:solidFill>
+                <a:latin typeface="Roboto"/>
+              </a:rPr>
+              <a:t>//</a:t>
+            </a:r>
+          </a:p>
+        </p:txBody>
+      </p:sp>
+      <p:sp>
+        <p:nvSpPr>
+          <p:cNvPr id="22" name="TextBox 21"/>
+          <p:cNvSpPr txBox="1"/>
+          <p:nvPr/>
+        </p:nvSpPr>
+        <p:spPr>
+          <a:xfrm>
+            <a:off x="6648450" y="3275076"/>
+            <a:ext cx="4857750" cy="95250"/>
+          </a:xfrm>
+          <a:prstGeom prst="rect">
+            <a:avLst/>
+          </a:prstGeom>
+          <a:noFill/>
+        </p:spPr>
+        <p:txBody>
+          <a:bodyPr wrap="square" lIns="0" rIns="0" tIns="0" bIns="0" anchor="t">
+            <a:spAutoFit/>
+          </a:bodyPr>
+          <a:lstStyle/>
+          <a:p>
+            <a:pPr algn="l">
+              <a:lnSpc>
+                <a:spcPct val="130000"/>
+              </a:lnSpc>
+            </a:pPr>
+            <a:r>
+              <a:rPr sz="1350" b="0" i="0">
                 <a:solidFill>
                   <a:srgbClr val="1A1A1E"/>
                 </a:solidFill>
                 <a:latin typeface="Roboto"/>
               </a:rPr>
-              <a:t> Ganha isolamento, e herda uma superfície nova: imagem base e privilégio de execução.</a:t>
-            </a:r>
-          </a:p>
-        </p:txBody>
-      </p:sp>
-      <p:sp>
-        <p:nvSpPr>
-          <p:cNvPr id="21" name="TextBox 20"/>
-          <p:cNvSpPr txBox="1"/>
-          <p:nvPr/>
-        </p:nvSpPr>
-        <p:spPr>
-          <a:xfrm>
-            <a:off x="6362700" y="3284220"/>
-            <a:ext cx="247650" cy="280416"/>
-          </a:xfrm>
-          <a:prstGeom prst="rect">
-            <a:avLst/>
-          </a:prstGeom>
-          <a:noFill/>
-        </p:spPr>
-        <p:txBody>
-          <a:bodyPr wrap="square" lIns="0" rIns="0" tIns="0" bIns="0" anchor="t">
-            <a:spAutoFit/>
-          </a:bodyPr>
-          <a:lstStyle/>
-          <a:p>
-            <a:pPr algn="l">
-              <a:lnSpc>
-                <a:spcPct val="120000"/>
-              </a:lnSpc>
-            </a:pPr>
-            <a:r>
-              <a:rPr sz="1380" b="1" i="0">
-                <a:solidFill>
-                  <a:srgbClr val="E94D1C"/>
-                </a:solidFill>
-                <a:latin typeface="Roboto"/>
-              </a:rPr>
-              <a:t>//</a:t>
-            </a:r>
-          </a:p>
-        </p:txBody>
-      </p:sp>
-      <p:sp>
-        <p:nvSpPr>
-          <p:cNvPr id="22" name="TextBox 21"/>
-          <p:cNvSpPr txBox="1"/>
-          <p:nvPr/>
-        </p:nvSpPr>
-        <p:spPr>
-          <a:xfrm>
-            <a:off x="6648450" y="3274695"/>
-            <a:ext cx="4857750" cy="95250"/>
-          </a:xfrm>
-          <a:prstGeom prst="rect">
-            <a:avLst/>
-          </a:prstGeom>
-          <a:noFill/>
-        </p:spPr>
-        <p:txBody>
-          <a:bodyPr wrap="square" lIns="0" rIns="0" tIns="0" bIns="0" anchor="t">
-            <a:spAutoFit/>
-          </a:bodyPr>
-          <a:lstStyle/>
-          <a:p>
-            <a:pPr algn="l">
-              <a:lnSpc>
-                <a:spcPct val="130000"/>
-              </a:lnSpc>
-            </a:pPr>
-            <a:r>
-              <a:rPr sz="1500" b="1" i="0">
-                <a:solidFill>
-                  <a:srgbClr val="1A1A1E"/>
-                </a:solidFill>
-                <a:latin typeface="Roboto"/>
-              </a:rPr>
-              <a:t>Desempenho.</a:t>
-            </a:r>
-            <a:r>
-              <a:rPr sz="1500" b="0" i="0">
-                <a:solidFill>
-                  <a:srgbClr val="1A1A1E"/>
-                </a:solidFill>
-                <a:latin typeface="Roboto"/>
-              </a:rPr>
-              <a:t> Principalmente I/O nas máquinas Windows. A Aula 03 já avisa que camada extra prejudica desempenho.</a:t>
+              <a:t>Desempenho custa, principalmente I/O nas máquinas Windows, e a Aula 03 já avisa que camada extra prejudica desempenho.</a:t>
             </a:r>
           </a:p>
         </p:txBody>
@@ -33168,7 +33069,7 @@
         </p:nvSpPr>
         <p:spPr>
           <a:xfrm>
-            <a:off x="685800" y="2722626"/>
+            <a:off x="685800" y="2590610"/>
             <a:ext cx="5143500" cy="182880"/>
           </a:xfrm>
           <a:prstGeom prst="rect">
@@ -33207,7 +33108,7 @@
         </p:nvSpPr>
         <p:spPr>
           <a:xfrm>
-            <a:off x="685800" y="2932176"/>
+            <a:off x="685800" y="2800160"/>
             <a:ext cx="419100" cy="28575"/>
           </a:xfrm>
           <a:prstGeom prst="rect">
@@ -33251,7 +33152,7 @@
         </p:nvSpPr>
         <p:spPr>
           <a:xfrm>
-            <a:off x="685800" y="3227451"/>
+            <a:off x="685800" y="3095434"/>
             <a:ext cx="247650" cy="294437"/>
           </a:xfrm>
           <a:prstGeom prst="rect">
@@ -33290,7 +33191,7 @@
         </p:nvSpPr>
         <p:spPr>
           <a:xfrm>
-            <a:off x="971550" y="3217926"/>
+            <a:off x="971550" y="3085910"/>
             <a:ext cx="4857750" cy="95250"/>
           </a:xfrm>
           <a:prstGeom prst="rect">
@@ -33329,7 +33230,7 @@
         </p:nvSpPr>
         <p:spPr>
           <a:xfrm>
-            <a:off x="685800" y="3758184"/>
+            <a:off x="685800" y="3626168"/>
             <a:ext cx="247650" cy="294437"/>
           </a:xfrm>
           <a:prstGeom prst="rect">
@@ -33368,7 +33269,7 @@
         </p:nvSpPr>
         <p:spPr>
           <a:xfrm>
-            <a:off x="971550" y="3748659"/>
+            <a:off x="971550" y="3616643"/>
             <a:ext cx="4857750" cy="95250"/>
           </a:xfrm>
           <a:prstGeom prst="rect">
@@ -33407,7 +33308,7 @@
         </p:nvSpPr>
         <p:spPr>
           <a:xfrm>
-            <a:off x="685800" y="4288917"/>
+            <a:off x="685800" y="4156901"/>
             <a:ext cx="247650" cy="294437"/>
           </a:xfrm>
           <a:prstGeom prst="rect">
@@ -33446,7 +33347,7 @@
         </p:nvSpPr>
         <p:spPr>
           <a:xfrm>
-            <a:off x="971550" y="4279392"/>
+            <a:off x="971550" y="4147376"/>
             <a:ext cx="4857750" cy="95250"/>
           </a:xfrm>
           <a:prstGeom prst="rect">
@@ -33485,7 +33386,7 @@
         </p:nvSpPr>
         <p:spPr>
           <a:xfrm>
-            <a:off x="6362700" y="2722626"/>
+            <a:off x="6362700" y="2590610"/>
             <a:ext cx="5143500" cy="182880"/>
           </a:xfrm>
           <a:prstGeom prst="rect">
@@ -33524,7 +33425,7 @@
         </p:nvSpPr>
         <p:spPr>
           <a:xfrm>
-            <a:off x="6362700" y="2932176"/>
+            <a:off x="6362700" y="2800160"/>
             <a:ext cx="419100" cy="28575"/>
           </a:xfrm>
           <a:prstGeom prst="rect">
@@ -33568,7 +33469,7 @@
         </p:nvSpPr>
         <p:spPr>
           <a:xfrm>
-            <a:off x="6362700" y="3227451"/>
+            <a:off x="6362700" y="3095434"/>
             <a:ext cx="247650" cy="294437"/>
           </a:xfrm>
           <a:prstGeom prst="rect">
@@ -33607,7 +33508,7 @@
         </p:nvSpPr>
         <p:spPr>
           <a:xfrm>
-            <a:off x="6648450" y="3217926"/>
+            <a:off x="6648450" y="3085910"/>
             <a:ext cx="4857750" cy="95250"/>
           </a:xfrm>
           <a:prstGeom prst="rect">
@@ -33633,7 +33534,7 @@
                 </a:solidFill>
                 <a:latin typeface="Roboto"/>
               </a:rPr>
-              <a:t>Não isolam. Contabilizam e limitam.</a:t>
+              <a:t>Não isolam nada, apenas contabilizam e limitam o consumo.</a:t>
             </a:r>
           </a:p>
         </p:txBody>
@@ -33646,7 +33547,7 @@
         </p:nvSpPr>
         <p:spPr>
           <a:xfrm>
-            <a:off x="6362700" y="3758184"/>
+            <a:off x="6362700" y="3890200"/>
             <a:ext cx="247650" cy="294437"/>
           </a:xfrm>
           <a:prstGeom prst="rect">
@@ -33685,7 +33586,7 @@
         </p:nvSpPr>
         <p:spPr>
           <a:xfrm>
-            <a:off x="6648450" y="3748659"/>
+            <a:off x="6648450" y="3880676"/>
             <a:ext cx="4857750" cy="95250"/>
           </a:xfrm>
           <a:prstGeom prst="rect">
@@ -33724,7 +33625,7 @@
         </p:nvSpPr>
         <p:spPr>
           <a:xfrm>
-            <a:off x="6362700" y="4552950"/>
+            <a:off x="6362700" y="4684966"/>
             <a:ext cx="247650" cy="294437"/>
           </a:xfrm>
           <a:prstGeom prst="rect">
@@ -33763,7 +33664,7 @@
         </p:nvSpPr>
         <p:spPr>
           <a:xfrm>
-            <a:off x="6648450" y="4543425"/>
+            <a:off x="6648450" y="4675442"/>
             <a:ext cx="4857750" cy="95250"/>
           </a:xfrm>
           <a:prstGeom prst="rect">

</xml_diff>

<commit_message>
docs: troca o rotulo vazio do slide 5 pela origem de cada definicao
</commit_message>
<xml_diff>
--- a/trabalhos/T1-Docker-Invite-People.pptx
+++ b/trabalhos/T1-Docker-Invite-People.pptx
@@ -31686,7 +31686,7 @@
                 </a:solidFill>
                 <a:latin typeface="Roboto"/>
               </a:rPr>
-              <a:t>CONTAINER · SÍNTESE DOS MECANISMOS</a:t>
+              <a:t>CONTAINER, PELO MECANISMO DO KERNEL</a:t>
             </a:r>
           </a:p>
         </p:txBody>
@@ -31847,7 +31847,7 @@
                 </a:solidFill>
                 <a:latin typeface="Roboto"/>
               </a:rPr>
-              <a:t>IMAGEM · OCI IMAGE SPEC</a:t>
+              <a:t>IMAGEM, PELA OCI IMAGE SPEC</a:t>
             </a:r>
           </a:p>
         </p:txBody>

</xml_diff>

<commit_message>
docs: abre as siglas e os numeros de caso de uso do T1 na primeira vez que aparecem
</commit_message>
<xml_diff>
--- a/trabalhos/T1-Docker-Invite-People.pptx
+++ b/trabalhos/T1-Docker-Invite-People.pptx
@@ -12174,7 +12174,7 @@
         </p:nvSpPr>
         <p:spPr>
           <a:xfrm>
-            <a:off x="685800" y="3042285"/>
+            <a:off x="685800" y="2903982"/>
             <a:ext cx="247650" cy="308458"/>
           </a:xfrm>
           <a:prstGeom prst="rect">
@@ -12213,7 +12213,7 @@
         </p:nvSpPr>
         <p:spPr>
           <a:xfrm>
-            <a:off x="971550" y="3032760"/>
+            <a:off x="971550" y="2894457"/>
             <a:ext cx="7677150" cy="95250"/>
           </a:xfrm>
           <a:prstGeom prst="rect">
@@ -12252,7 +12252,7 @@
         </p:nvSpPr>
         <p:spPr>
           <a:xfrm>
-            <a:off x="685800" y="3881247"/>
+            <a:off x="685800" y="3742944"/>
             <a:ext cx="247650" cy="308458"/>
           </a:xfrm>
           <a:prstGeom prst="rect">
@@ -12291,7 +12291,7 @@
         </p:nvSpPr>
         <p:spPr>
           <a:xfrm>
-            <a:off x="971550" y="3871722"/>
+            <a:off x="971550" y="3733419"/>
             <a:ext cx="7677150" cy="95250"/>
           </a:xfrm>
           <a:prstGeom prst="rect">
@@ -12330,7 +12330,7 @@
         </p:nvSpPr>
         <p:spPr>
           <a:xfrm>
-            <a:off x="685800" y="4720209"/>
+            <a:off x="685800" y="4581906"/>
             <a:ext cx="247650" cy="308458"/>
           </a:xfrm>
           <a:prstGeom prst="rect">
@@ -12369,7 +12369,7 @@
         </p:nvSpPr>
         <p:spPr>
           <a:xfrm>
-            <a:off x="971550" y="4710684"/>
+            <a:off x="971550" y="4572381"/>
             <a:ext cx="7677150" cy="95250"/>
           </a:xfrm>
           <a:prstGeom prst="rect">
@@ -12395,7 +12395,7 @@
                 </a:solidFill>
                 <a:latin typeface="Roboto"/>
               </a:rPr>
-              <a:t>AppArmor ou SELinux entram por cima de tudo, como LSM.</a:t>
+              <a:t>AppArmor ou SELinux entram por cima de tudo, pelo módulo de segurança do próprio kernel.</a:t>
             </a:r>
           </a:p>
         </p:txBody>
@@ -12408,7 +12408,7 @@
         </p:nvSpPr>
         <p:spPr>
           <a:xfrm>
-            <a:off x="9124950" y="3032760"/>
+            <a:off x="9124950" y="2894457"/>
             <a:ext cx="152400" cy="133350"/>
           </a:xfrm>
           <a:prstGeom prst="triangle">
@@ -12452,7 +12452,7 @@
         </p:nvSpPr>
         <p:spPr>
           <a:xfrm>
-            <a:off x="9193530" y="3089910"/>
+            <a:off x="9193530" y="2951607"/>
             <a:ext cx="15240" cy="38100"/>
           </a:xfrm>
           <a:prstGeom prst="rect">
@@ -12496,7 +12496,7 @@
         </p:nvSpPr>
         <p:spPr>
           <a:xfrm>
-            <a:off x="9372600" y="3042285"/>
+            <a:off x="9372600" y="2903982"/>
             <a:ext cx="2133600" cy="182880"/>
           </a:xfrm>
           <a:prstGeom prst="rect">
@@ -12535,7 +12535,7 @@
         </p:nvSpPr>
         <p:spPr>
           <a:xfrm>
-            <a:off x="9124950" y="3318510"/>
+            <a:off x="9124950" y="3180207"/>
             <a:ext cx="38100" cy="603504"/>
           </a:xfrm>
           <a:prstGeom prst="rect">
@@ -12579,7 +12579,7 @@
         </p:nvSpPr>
         <p:spPr>
           <a:xfrm>
-            <a:off x="9334500" y="3318510"/>
+            <a:off x="9334500" y="3180207"/>
             <a:ext cx="2171700" cy="1175004"/>
           </a:xfrm>
           <a:prstGeom prst="rect">
@@ -15306,7 +15306,7 @@
                 </a:solidFill>
                 <a:latin typeface="Roboto"/>
               </a:rPr>
-              <a:t>Nenhuma das três muda uma linha do projeto lógico. Todas mudam o empacotamento, e essa escolha é entrada do ADR #63. Cuidado com o vocabulário: Docker usa </a:t>
+              <a:t>Nenhuma das três muda uma linha do projeto lógico. Todas mudam o empacotamento, e essa escolha é entrada do ADR #63, o documento de decisões arquiteturais da Sprint 2. Cuidado com o vocabulário: Docker usa </a:t>
             </a:r>
             <a:r>
               <a:rPr sz="1280" b="0" i="1">
@@ -19692,7 +19692,7 @@
         </p:nvSpPr>
         <p:spPr>
           <a:xfrm>
-            <a:off x="685800" y="3042285"/>
+            <a:off x="685800" y="2903982"/>
             <a:ext cx="247650" cy="308458"/>
           </a:xfrm>
           <a:prstGeom prst="rect">
@@ -19731,7 +19731,7 @@
         </p:nvSpPr>
         <p:spPr>
           <a:xfrm>
-            <a:off x="971550" y="3032760"/>
+            <a:off x="971550" y="2894457"/>
             <a:ext cx="7581900" cy="95250"/>
           </a:xfrm>
           <a:prstGeom prst="rect">
@@ -19757,7 +19757,7 @@
                 </a:solidFill>
                 <a:latin typeface="Roboto"/>
               </a:rPr>
-              <a:t>A jornada da Marina descreve o link caindo no grupo da família. Pico no convite público (UC005), uma pessoa no painel (UC007).</a:t>
+              <a:t>Marina é a persona da anfitriã, e a jornada dela descreve o link caindo no grupo da família. Isso é pico no convite público, onde o convidado confirma presença, e uma pessoa só no painel, onde a anfitriã vê a lista.</a:t>
             </a:r>
           </a:p>
         </p:txBody>
@@ -19770,7 +19770,7 @@
         </p:nvSpPr>
         <p:spPr>
           <a:xfrm>
-            <a:off x="685800" y="3881247"/>
+            <a:off x="685800" y="4019550"/>
             <a:ext cx="247650" cy="308458"/>
           </a:xfrm>
           <a:prstGeom prst="rect">
@@ -19809,7 +19809,7 @@
         </p:nvSpPr>
         <p:spPr>
           <a:xfrm>
-            <a:off x="971550" y="3871722"/>
+            <a:off x="971550" y="4010025"/>
             <a:ext cx="7581900" cy="95250"/>
           </a:xfrm>
           <a:prstGeom prst="rect">
@@ -19848,7 +19848,7 @@
         </p:nvSpPr>
         <p:spPr>
           <a:xfrm>
-            <a:off x="685800" y="4443603"/>
+            <a:off x="685800" y="4581906"/>
             <a:ext cx="247650" cy="308458"/>
           </a:xfrm>
           <a:prstGeom prst="rect">
@@ -19887,7 +19887,7 @@
         </p:nvSpPr>
         <p:spPr>
           <a:xfrm>
-            <a:off x="971550" y="4434078"/>
+            <a:off x="971550" y="4572381"/>
             <a:ext cx="7581900" cy="95250"/>
           </a:xfrm>
           <a:prstGeom prst="rect">
@@ -19926,7 +19926,7 @@
         </p:nvSpPr>
         <p:spPr>
           <a:xfrm>
-            <a:off x="9124950" y="3032760"/>
+            <a:off x="9124950" y="2894457"/>
             <a:ext cx="142875" cy="142875"/>
           </a:xfrm>
           <a:prstGeom prst="donut">
@@ -19970,7 +19970,7 @@
         </p:nvSpPr>
         <p:spPr>
           <a:xfrm>
-            <a:off x="9372600" y="3042285"/>
+            <a:off x="9372600" y="2903982"/>
             <a:ext cx="2133600" cy="182880"/>
           </a:xfrm>
           <a:prstGeom prst="rect">
@@ -20009,7 +20009,7 @@
         </p:nvSpPr>
         <p:spPr>
           <a:xfrm>
-            <a:off x="9124950" y="3318510"/>
+            <a:off x="9124950" y="3180207"/>
             <a:ext cx="38100" cy="1033272"/>
           </a:xfrm>
           <a:prstGeom prst="rect">
@@ -20053,7 +20053,7 @@
         </p:nvSpPr>
         <p:spPr>
           <a:xfrm>
-            <a:off x="9334500" y="3318510"/>
+            <a:off x="9334500" y="3180207"/>
             <a:ext cx="2171700" cy="1604772"/>
           </a:xfrm>
           <a:prstGeom prst="rect">
@@ -21555,7 +21555,7 @@
                 </a:solidFill>
                 <a:latin typeface="Roboto"/>
               </a:rPr>
-              <a:t>Volume nomeado e persistência</a:t>
+              <a:t>O dado sobrevive ao container</a:t>
             </a:r>
           </a:p>
           <a:p>
@@ -21571,7 +21571,7 @@
                 </a:solidFill>
                 <a:latin typeface="Roboto"/>
               </a:rPr>
-              <a:t>entre execuções</a:t>
+              <a:t>se ficar num volume</a:t>
             </a:r>
           </a:p>
         </p:txBody>
@@ -22253,7 +22253,7 @@
                 </a:solidFill>
                 <a:latin typeface="Roboto"/>
               </a:rPr>
-              <a:t>A imagem de fundo do UC003 e o CSV do UC008 não podem morrer junto com o container. A decisão de implantação volta como restrição de projeto para as camadas de cima.</a:t>
+              <a:t>A imagem de fundo que a anfitriã envia ao personalizar o convite e o CSV de restrições alimentares que ela exporta não podem morrer junto com o container. A decisão de implantação volta como restrição de projeto para as camadas de cima.</a:t>
             </a:r>
           </a:p>
         </p:txBody>
@@ -31110,7 +31110,7 @@
                 </a:solidFill>
                 <a:latin typeface="Roboto"/>
               </a:rPr>
-              <a:t>OCI</a:t>
+              <a:t>primeiras especificações comuns de container</a:t>
             </a:r>
           </a:p>
         </p:txBody>
@@ -31660,7 +31660,7 @@
         </p:nvSpPr>
         <p:spPr>
           <a:xfrm>
-            <a:off x="685800" y="3253359"/>
+            <a:off x="685800" y="2723960"/>
             <a:ext cx="5143500" cy="182880"/>
           </a:xfrm>
           <a:prstGeom prst="rect">
@@ -31686,7 +31686,7 @@
                 </a:solidFill>
                 <a:latin typeface="Roboto"/>
               </a:rPr>
-              <a:t>CONTAINER, PELO MECANISMO DO KERNEL</a:t>
+              <a:t>O QUE É UM CONTAINER</a:t>
             </a:r>
           </a:p>
         </p:txBody>
@@ -31699,7 +31699,7 @@
         </p:nvSpPr>
         <p:spPr>
           <a:xfrm>
-            <a:off x="685800" y="3462909"/>
+            <a:off x="685800" y="2933510"/>
             <a:ext cx="419100" cy="28575"/>
           </a:xfrm>
           <a:prstGeom prst="rect">
@@ -31743,7 +31743,7 @@
         </p:nvSpPr>
         <p:spPr>
           <a:xfrm>
-            <a:off x="685800" y="3758184"/>
+            <a:off x="685800" y="3228784"/>
             <a:ext cx="247650" cy="294437"/>
           </a:xfrm>
           <a:prstGeom prst="rect">
@@ -31782,7 +31782,7 @@
         </p:nvSpPr>
         <p:spPr>
           <a:xfrm>
-            <a:off x="971550" y="3748659"/>
+            <a:off x="971550" y="3219260"/>
             <a:ext cx="4857750" cy="95250"/>
           </a:xfrm>
           <a:prstGeom prst="rect">
@@ -31821,7 +31821,85 @@
         </p:nvSpPr>
         <p:spPr>
           <a:xfrm>
-            <a:off x="6362700" y="3253359"/>
+            <a:off x="685800" y="4551616"/>
+            <a:ext cx="247650" cy="294437"/>
+          </a:xfrm>
+          <a:prstGeom prst="rect">
+            <a:avLst/>
+          </a:prstGeom>
+          <a:noFill/>
+        </p:spPr>
+        <p:txBody>
+          <a:bodyPr wrap="square" lIns="0" rIns="0" tIns="0" bIns="0" anchor="t">
+            <a:spAutoFit/>
+          </a:bodyPr>
+          <a:lstStyle/>
+          <a:p>
+            <a:pPr algn="l">
+              <a:lnSpc>
+                <a:spcPct val="120000"/>
+              </a:lnSpc>
+            </a:pPr>
+            <a:r>
+              <a:rPr sz="1450" b="1" i="0">
+                <a:solidFill>
+                  <a:srgbClr val="E94D1C"/>
+                </a:solidFill>
+                <a:latin typeface="Roboto"/>
+              </a:rPr>
+              <a:t>//</a:t>
+            </a:r>
+          </a:p>
+        </p:txBody>
+      </p:sp>
+      <p:sp>
+        <p:nvSpPr>
+          <p:cNvPr id="10" name="TextBox 9"/>
+          <p:cNvSpPr txBox="1"/>
+          <p:nvPr/>
+        </p:nvSpPr>
+        <p:spPr>
+          <a:xfrm>
+            <a:off x="971550" y="4542092"/>
+            <a:ext cx="4857750" cy="95250"/>
+          </a:xfrm>
+          <a:prstGeom prst="rect">
+            <a:avLst/>
+          </a:prstGeom>
+          <a:noFill/>
+        </p:spPr>
+        <p:txBody>
+          <a:bodyPr wrap="square" lIns="0" rIns="0" tIns="0" bIns="0" anchor="t">
+            <a:spAutoFit/>
+          </a:bodyPr>
+          <a:lstStyle/>
+          <a:p>
+            <a:pPr algn="l">
+              <a:lnSpc>
+                <a:spcPct val="130000"/>
+              </a:lnSpc>
+            </a:pPr>
+            <a:r>
+              <a:rPr sz="1580" b="0" i="0">
+                <a:solidFill>
+                  <a:srgbClr val="1A1A1E"/>
+                </a:solidFill>
+                <a:latin typeface="Roboto"/>
+              </a:rPr>
+              <a:t>Essa definição não é citação de livro. É a que o grupo montou a partir dos quatro mecanismos do Linux que os próximos slides mostram.</a:t>
+            </a:r>
+          </a:p>
+        </p:txBody>
+      </p:sp>
+      <p:sp>
+        <p:nvSpPr>
+          <p:cNvPr id="11" name="TextBox 10"/>
+          <p:cNvSpPr txBox="1"/>
+          <p:nvPr/>
+        </p:nvSpPr>
+        <p:spPr>
+          <a:xfrm>
+            <a:off x="6362700" y="2723960"/>
             <a:ext cx="5143500" cy="182880"/>
           </a:xfrm>
           <a:prstGeom prst="rect">
@@ -31847,20 +31925,20 @@
                 </a:solidFill>
                 <a:latin typeface="Roboto"/>
               </a:rPr>
-              <a:t>IMAGEM, PELA OCI IMAGE SPEC</a:t>
-            </a:r>
-          </a:p>
-        </p:txBody>
-      </p:sp>
-      <p:sp>
-        <p:nvSpPr>
-          <p:cNvPr id="10" name="Rectangle 9"/>
+              <a:t>O QUE É UMA IMAGEM</a:t>
+            </a:r>
+          </a:p>
+        </p:txBody>
+      </p:sp>
+      <p:sp>
+        <p:nvSpPr>
+          <p:cNvPr id="12" name="Rectangle 11"/>
           <p:cNvSpPr/>
           <p:nvPr/>
         </p:nvSpPr>
         <p:spPr>
           <a:xfrm>
-            <a:off x="6362700" y="3462909"/>
+            <a:off x="6362700" y="2933510"/>
             <a:ext cx="419100" cy="28575"/>
           </a:xfrm>
           <a:prstGeom prst="rect">
@@ -31898,13 +31976,13 @@
       </p:sp>
       <p:sp>
         <p:nvSpPr>
-          <p:cNvPr id="11" name="TextBox 10"/>
-          <p:cNvSpPr txBox="1"/>
-          <p:nvPr/>
-        </p:nvSpPr>
-        <p:spPr>
-          <a:xfrm>
-            <a:off x="6362700" y="3758184"/>
+          <p:cNvPr id="13" name="TextBox 12"/>
+          <p:cNvSpPr txBox="1"/>
+          <p:nvPr/>
+        </p:nvSpPr>
+        <p:spPr>
+          <a:xfrm>
+            <a:off x="6362700" y="3228784"/>
             <a:ext cx="247650" cy="294437"/>
           </a:xfrm>
           <a:prstGeom prst="rect">
@@ -31937,13 +32015,13 @@
       </p:sp>
       <p:sp>
         <p:nvSpPr>
-          <p:cNvPr id="12" name="TextBox 11"/>
-          <p:cNvSpPr txBox="1"/>
-          <p:nvPr/>
-        </p:nvSpPr>
-        <p:spPr>
-          <a:xfrm>
-            <a:off x="6648450" y="3748659"/>
+          <p:cNvPr id="14" name="TextBox 13"/>
+          <p:cNvSpPr txBox="1"/>
+          <p:nvPr/>
+        </p:nvSpPr>
+        <p:spPr>
+          <a:xfrm>
+            <a:off x="6648450" y="3219260"/>
             <a:ext cx="4857750" cy="95250"/>
           </a:xfrm>
           <a:prstGeom prst="rect">
@@ -31969,14 +32047,92 @@
                 </a:solidFill>
                 <a:latin typeface="Roboto"/>
               </a:rPr>
-              <a:t>Conjunto ordenado de camadas de sistema de arquivos mais a configuração de execução, identificado por digest.</a:t>
-            </a:r>
-          </a:p>
-        </p:txBody>
-      </p:sp>
-      <p:sp>
-        <p:nvSpPr>
-          <p:cNvPr id="13" name="TextBox 12"/>
+              <a:t>Conjunto ordenado de camadas de sistema de arquivos mais a configuração de execução, identificado por um digest, que é o hash do próprio conteúdo.</a:t>
+            </a:r>
+          </a:p>
+        </p:txBody>
+      </p:sp>
+      <p:sp>
+        <p:nvSpPr>
+          <p:cNvPr id="15" name="TextBox 14"/>
+          <p:cNvSpPr txBox="1"/>
+          <p:nvPr/>
+        </p:nvSpPr>
+        <p:spPr>
+          <a:xfrm>
+            <a:off x="6362700" y="4551616"/>
+            <a:ext cx="247650" cy="294437"/>
+          </a:xfrm>
+          <a:prstGeom prst="rect">
+            <a:avLst/>
+          </a:prstGeom>
+          <a:noFill/>
+        </p:spPr>
+        <p:txBody>
+          <a:bodyPr wrap="square" lIns="0" rIns="0" tIns="0" bIns="0" anchor="t">
+            <a:spAutoFit/>
+          </a:bodyPr>
+          <a:lstStyle/>
+          <a:p>
+            <a:pPr algn="l">
+              <a:lnSpc>
+                <a:spcPct val="120000"/>
+              </a:lnSpc>
+            </a:pPr>
+            <a:r>
+              <a:rPr sz="1450" b="1" i="0">
+                <a:solidFill>
+                  <a:srgbClr val="E94D1C"/>
+                </a:solidFill>
+                <a:latin typeface="Roboto"/>
+              </a:rPr>
+              <a:t>//</a:t>
+            </a:r>
+          </a:p>
+        </p:txBody>
+      </p:sp>
+      <p:sp>
+        <p:nvSpPr>
+          <p:cNvPr id="16" name="TextBox 15"/>
+          <p:cNvSpPr txBox="1"/>
+          <p:nvPr/>
+        </p:nvSpPr>
+        <p:spPr>
+          <a:xfrm>
+            <a:off x="6648450" y="4542092"/>
+            <a:ext cx="4857750" cy="95250"/>
+          </a:xfrm>
+          <a:prstGeom prst="rect">
+            <a:avLst/>
+          </a:prstGeom>
+          <a:noFill/>
+        </p:spPr>
+        <p:txBody>
+          <a:bodyPr wrap="square" lIns="0" rIns="0" tIns="0" bIns="0" anchor="t">
+            <a:spAutoFit/>
+          </a:bodyPr>
+          <a:lstStyle/>
+          <a:p>
+            <a:pPr algn="l">
+              <a:lnSpc>
+                <a:spcPct val="130000"/>
+              </a:lnSpc>
+            </a:pPr>
+            <a:r>
+              <a:rPr sz="1580" b="0" i="0">
+                <a:solidFill>
+                  <a:srgbClr val="1A1A1E"/>
+                </a:solidFill>
+                <a:latin typeface="Roboto"/>
+              </a:rPr>
+              <a:t>Essa é citação da Image Spec, um dos documentos da Open Container Initiative, a organização que padroniza o formato de imagem desde 2015.</a:t>
+            </a:r>
+          </a:p>
+        </p:txBody>
+      </p:sp>
+      <p:sp>
+        <p:nvSpPr>
+          <p:cNvPr id="17" name="TextBox 16"/>
           <p:cNvSpPr txBox="1"/>
           <p:nvPr/>
         </p:nvSpPr>
@@ -32015,7 +32171,7 @@
       </p:sp>
       <p:sp>
         <p:nvSpPr>
-          <p:cNvPr id="14" name="TextBox 13"/>
+          <p:cNvPr id="18" name="TextBox 17"/>
           <p:cNvSpPr txBox="1"/>
           <p:nvPr/>
         </p:nvSpPr>
@@ -33690,7 +33846,7 @@
                 </a:solidFill>
                 <a:latin typeface="Roboto"/>
               </a:rPr>
-              <a:t>Limite de CPU é throttling. Degrada latência de cauda, não a média, e por isso é mais difícil de diagnosticar.</a:t>
+              <a:t>Limite de CPU não mata, freia. Isso piora as requisições mais lentas e quase não mexe na média, por isso é mais difícil de perceber.</a:t>
             </a:r>
           </a:p>
         </p:txBody>
@@ -34696,7 +34852,7 @@
                 </a:solidFill>
                 <a:latin typeface="Roboto"/>
               </a:rPr>
-              <a:t>Um Dockerfile que copia um .env e faz RUN rm na instrução seguinte produz uma imagem em que o segredo continua legível. No nosso caso o segredo seria a senha do banco e o segredo de sessão do UC001.</a:t>
+              <a:t>Um Dockerfile que copia um .env e faz RUN rm na instrução seguinte produz uma imagem em que o segredo continua legível. No nosso caso o segredo seria a senha do banco e o segredo de sessão do login do anfitrião, o UC001.</a:t>
             </a:r>
           </a:p>
         </p:txBody>

</xml_diff>

<commit_message>
docs: enxuga a atribuicao de fonte do slide 5 e reescreve os dois titulos que exigiam decifracao
</commit_message>
<xml_diff>
--- a/trabalhos/T1-Docker-Invite-People.pptx
+++ b/trabalhos/T1-Docker-Invite-People.pptx
@@ -13623,7 +13623,7 @@
                 </a:solidFill>
                 <a:latin typeface="Roboto"/>
               </a:rPr>
-              <a:t>Layer é camada lógica.</a:t>
+              <a:t>As mesmas três camadas lógicas,</a:t>
             </a:r>
           </a:p>
           <a:p>
@@ -13639,7 +13639,7 @@
                 </a:solidFill>
                 <a:latin typeface="Roboto"/>
               </a:rPr>
-              <a:t>Tier é separação física.</a:t>
+              <a:t>empacotadas de três jeitos</a:t>
             </a:r>
           </a:p>
         </p:txBody>
@@ -15530,7 +15530,7 @@
                 </a:solidFill>
                 <a:latin typeface="Roboto"/>
               </a:rPr>
-              <a:t>Container é ambiente de execução,</a:t>
+              <a:t>No diagrama de implantação, o container</a:t>
             </a:r>
           </a:p>
           <a:p>
@@ -15546,7 +15546,7 @@
                 </a:solidFill>
                 <a:latin typeface="Roboto"/>
               </a:rPr>
-              <a:t>imagem é artefato</a:t>
+              <a:t>é um nó e a imagem é um artefato</a:t>
             </a:r>
           </a:p>
         </p:txBody>
@@ -31660,7 +31660,7 @@
         </p:nvSpPr>
         <p:spPr>
           <a:xfrm>
-            <a:off x="685800" y="2723960"/>
+            <a:off x="685800" y="3253359"/>
             <a:ext cx="5143500" cy="182880"/>
           </a:xfrm>
           <a:prstGeom prst="rect">
@@ -31686,7 +31686,7 @@
                 </a:solidFill>
                 <a:latin typeface="Roboto"/>
               </a:rPr>
-              <a:t>O QUE É UM CONTAINER</a:t>
+              <a:t>CONTAINER · DEFINIÇÃO DO GRUPO</a:t>
             </a:r>
           </a:p>
         </p:txBody>
@@ -31699,7 +31699,7 @@
         </p:nvSpPr>
         <p:spPr>
           <a:xfrm>
-            <a:off x="685800" y="2933510"/>
+            <a:off x="685800" y="3462909"/>
             <a:ext cx="419100" cy="28575"/>
           </a:xfrm>
           <a:prstGeom prst="rect">
@@ -31743,7 +31743,7 @@
         </p:nvSpPr>
         <p:spPr>
           <a:xfrm>
-            <a:off x="685800" y="3228784"/>
+            <a:off x="685800" y="3758184"/>
             <a:ext cx="247650" cy="294437"/>
           </a:xfrm>
           <a:prstGeom prst="rect">
@@ -31782,7 +31782,7 @@
         </p:nvSpPr>
         <p:spPr>
           <a:xfrm>
-            <a:off x="971550" y="3219260"/>
+            <a:off x="971550" y="3748659"/>
             <a:ext cx="4857750" cy="95250"/>
           </a:xfrm>
           <a:prstGeom prst="rect">
@@ -31821,8 +31821,8 @@
         </p:nvSpPr>
         <p:spPr>
           <a:xfrm>
-            <a:off x="685800" y="4551616"/>
-            <a:ext cx="247650" cy="294437"/>
+            <a:off x="6362700" y="3253359"/>
+            <a:ext cx="5143500" cy="182880"/>
           </a:xfrm>
           <a:prstGeom prst="rect">
             <a:avLst/>
@@ -31841,104 +31841,26 @@
               </a:lnSpc>
             </a:pPr>
             <a:r>
-              <a:rPr sz="1450" b="1" i="0">
+              <a:rPr sz="900" b="1" i="0" spc="120">
                 <a:solidFill>
                   <a:srgbClr val="E94D1C"/>
                 </a:solidFill>
                 <a:latin typeface="Roboto"/>
               </a:rPr>
-              <a:t>//</a:t>
-            </a:r>
-          </a:p>
-        </p:txBody>
-      </p:sp>
-      <p:sp>
-        <p:nvSpPr>
-          <p:cNvPr id="10" name="TextBox 9"/>
-          <p:cNvSpPr txBox="1"/>
-          <p:nvPr/>
-        </p:nvSpPr>
-        <p:spPr>
-          <a:xfrm>
-            <a:off x="971550" y="4542092"/>
-            <a:ext cx="4857750" cy="95250"/>
-          </a:xfrm>
-          <a:prstGeom prst="rect">
-            <a:avLst/>
-          </a:prstGeom>
-          <a:noFill/>
-        </p:spPr>
-        <p:txBody>
-          <a:bodyPr wrap="square" lIns="0" rIns="0" tIns="0" bIns="0" anchor="t">
-            <a:spAutoFit/>
-          </a:bodyPr>
-          <a:lstStyle/>
-          <a:p>
-            <a:pPr algn="l">
-              <a:lnSpc>
-                <a:spcPct val="130000"/>
-              </a:lnSpc>
-            </a:pPr>
-            <a:r>
-              <a:rPr sz="1580" b="0" i="0">
-                <a:solidFill>
-                  <a:srgbClr val="1A1A1E"/>
-                </a:solidFill>
-                <a:latin typeface="Roboto"/>
-              </a:rPr>
-              <a:t>Essa definição não é citação de livro. É a que o grupo montou a partir dos quatro mecanismos do Linux que os próximos slides mostram.</a:t>
-            </a:r>
-          </a:p>
-        </p:txBody>
-      </p:sp>
-      <p:sp>
-        <p:nvSpPr>
-          <p:cNvPr id="11" name="TextBox 10"/>
-          <p:cNvSpPr txBox="1"/>
-          <p:nvPr/>
-        </p:nvSpPr>
-        <p:spPr>
-          <a:xfrm>
-            <a:off x="6362700" y="2723960"/>
-            <a:ext cx="5143500" cy="182880"/>
-          </a:xfrm>
-          <a:prstGeom prst="rect">
-            <a:avLst/>
-          </a:prstGeom>
-          <a:noFill/>
-        </p:spPr>
-        <p:txBody>
-          <a:bodyPr wrap="square" lIns="0" rIns="0" tIns="0" bIns="0" anchor="t">
-            <a:spAutoFit/>
-          </a:bodyPr>
-          <a:lstStyle/>
-          <a:p>
-            <a:pPr algn="l">
-              <a:lnSpc>
-                <a:spcPct val="120000"/>
-              </a:lnSpc>
-            </a:pPr>
-            <a:r>
-              <a:rPr sz="900" b="1" i="0" spc="120">
-                <a:solidFill>
-                  <a:srgbClr val="E94D1C"/>
-                </a:solidFill>
-                <a:latin typeface="Roboto"/>
-              </a:rPr>
-              <a:t>O QUE É UMA IMAGEM</a:t>
-            </a:r>
-          </a:p>
-        </p:txBody>
-      </p:sp>
-      <p:sp>
-        <p:nvSpPr>
-          <p:cNvPr id="12" name="Rectangle 11"/>
+              <a:t>IMAGEM · OPEN CONTAINER INITIATIVE, IMAGE SPEC</a:t>
+            </a:r>
+          </a:p>
+        </p:txBody>
+      </p:sp>
+      <p:sp>
+        <p:nvSpPr>
+          <p:cNvPr id="10" name="Rectangle 9"/>
           <p:cNvSpPr/>
           <p:nvPr/>
         </p:nvSpPr>
         <p:spPr>
           <a:xfrm>
-            <a:off x="6362700" y="2933510"/>
+            <a:off x="6362700" y="3462909"/>
             <a:ext cx="419100" cy="28575"/>
           </a:xfrm>
           <a:prstGeom prst="rect">
@@ -31976,163 +31898,85 @@
       </p:sp>
       <p:sp>
         <p:nvSpPr>
+          <p:cNvPr id="11" name="TextBox 10"/>
+          <p:cNvSpPr txBox="1"/>
+          <p:nvPr/>
+        </p:nvSpPr>
+        <p:spPr>
+          <a:xfrm>
+            <a:off x="6362700" y="3758184"/>
+            <a:ext cx="247650" cy="294437"/>
+          </a:xfrm>
+          <a:prstGeom prst="rect">
+            <a:avLst/>
+          </a:prstGeom>
+          <a:noFill/>
+        </p:spPr>
+        <p:txBody>
+          <a:bodyPr wrap="square" lIns="0" rIns="0" tIns="0" bIns="0" anchor="t">
+            <a:spAutoFit/>
+          </a:bodyPr>
+          <a:lstStyle/>
+          <a:p>
+            <a:pPr algn="l">
+              <a:lnSpc>
+                <a:spcPct val="120000"/>
+              </a:lnSpc>
+            </a:pPr>
+            <a:r>
+              <a:rPr sz="1450" b="1" i="0">
+                <a:solidFill>
+                  <a:srgbClr val="E94D1C"/>
+                </a:solidFill>
+                <a:latin typeface="Roboto"/>
+              </a:rPr>
+              <a:t>//</a:t>
+            </a:r>
+          </a:p>
+        </p:txBody>
+      </p:sp>
+      <p:sp>
+        <p:nvSpPr>
+          <p:cNvPr id="12" name="TextBox 11"/>
+          <p:cNvSpPr txBox="1"/>
+          <p:nvPr/>
+        </p:nvSpPr>
+        <p:spPr>
+          <a:xfrm>
+            <a:off x="6648450" y="3748659"/>
+            <a:ext cx="4857750" cy="95250"/>
+          </a:xfrm>
+          <a:prstGeom prst="rect">
+            <a:avLst/>
+          </a:prstGeom>
+          <a:noFill/>
+        </p:spPr>
+        <p:txBody>
+          <a:bodyPr wrap="square" lIns="0" rIns="0" tIns="0" bIns="0" anchor="t">
+            <a:spAutoFit/>
+          </a:bodyPr>
+          <a:lstStyle/>
+          <a:p>
+            <a:pPr algn="l">
+              <a:lnSpc>
+                <a:spcPct val="130000"/>
+              </a:lnSpc>
+            </a:pPr>
+            <a:r>
+              <a:rPr sz="1580" b="0" i="0">
+                <a:solidFill>
+                  <a:srgbClr val="1A1A1E"/>
+                </a:solidFill>
+                <a:latin typeface="Roboto"/>
+              </a:rPr>
+              <a:t>Conjunto ordenado de camadas de sistema de arquivos mais a configuração de execução, identificado por um digest, que é o hash do próprio conteúdo.</a:t>
+            </a:r>
+          </a:p>
+        </p:txBody>
+      </p:sp>
+      <p:sp>
+        <p:nvSpPr>
           <p:cNvPr id="13" name="TextBox 12"/>
-          <p:cNvSpPr txBox="1"/>
-          <p:nvPr/>
-        </p:nvSpPr>
-        <p:spPr>
-          <a:xfrm>
-            <a:off x="6362700" y="3228784"/>
-            <a:ext cx="247650" cy="294437"/>
-          </a:xfrm>
-          <a:prstGeom prst="rect">
-            <a:avLst/>
-          </a:prstGeom>
-          <a:noFill/>
-        </p:spPr>
-        <p:txBody>
-          <a:bodyPr wrap="square" lIns="0" rIns="0" tIns="0" bIns="0" anchor="t">
-            <a:spAutoFit/>
-          </a:bodyPr>
-          <a:lstStyle/>
-          <a:p>
-            <a:pPr algn="l">
-              <a:lnSpc>
-                <a:spcPct val="120000"/>
-              </a:lnSpc>
-            </a:pPr>
-            <a:r>
-              <a:rPr sz="1450" b="1" i="0">
-                <a:solidFill>
-                  <a:srgbClr val="E94D1C"/>
-                </a:solidFill>
-                <a:latin typeface="Roboto"/>
-              </a:rPr>
-              <a:t>//</a:t>
-            </a:r>
-          </a:p>
-        </p:txBody>
-      </p:sp>
-      <p:sp>
-        <p:nvSpPr>
-          <p:cNvPr id="14" name="TextBox 13"/>
-          <p:cNvSpPr txBox="1"/>
-          <p:nvPr/>
-        </p:nvSpPr>
-        <p:spPr>
-          <a:xfrm>
-            <a:off x="6648450" y="3219260"/>
-            <a:ext cx="4857750" cy="95250"/>
-          </a:xfrm>
-          <a:prstGeom prst="rect">
-            <a:avLst/>
-          </a:prstGeom>
-          <a:noFill/>
-        </p:spPr>
-        <p:txBody>
-          <a:bodyPr wrap="square" lIns="0" rIns="0" tIns="0" bIns="0" anchor="t">
-            <a:spAutoFit/>
-          </a:bodyPr>
-          <a:lstStyle/>
-          <a:p>
-            <a:pPr algn="l">
-              <a:lnSpc>
-                <a:spcPct val="130000"/>
-              </a:lnSpc>
-            </a:pPr>
-            <a:r>
-              <a:rPr sz="1580" b="0" i="0">
-                <a:solidFill>
-                  <a:srgbClr val="1A1A1E"/>
-                </a:solidFill>
-                <a:latin typeface="Roboto"/>
-              </a:rPr>
-              <a:t>Conjunto ordenado de camadas de sistema de arquivos mais a configuração de execução, identificado por um digest, que é o hash do próprio conteúdo.</a:t>
-            </a:r>
-          </a:p>
-        </p:txBody>
-      </p:sp>
-      <p:sp>
-        <p:nvSpPr>
-          <p:cNvPr id="15" name="TextBox 14"/>
-          <p:cNvSpPr txBox="1"/>
-          <p:nvPr/>
-        </p:nvSpPr>
-        <p:spPr>
-          <a:xfrm>
-            <a:off x="6362700" y="4551616"/>
-            <a:ext cx="247650" cy="294437"/>
-          </a:xfrm>
-          <a:prstGeom prst="rect">
-            <a:avLst/>
-          </a:prstGeom>
-          <a:noFill/>
-        </p:spPr>
-        <p:txBody>
-          <a:bodyPr wrap="square" lIns="0" rIns="0" tIns="0" bIns="0" anchor="t">
-            <a:spAutoFit/>
-          </a:bodyPr>
-          <a:lstStyle/>
-          <a:p>
-            <a:pPr algn="l">
-              <a:lnSpc>
-                <a:spcPct val="120000"/>
-              </a:lnSpc>
-            </a:pPr>
-            <a:r>
-              <a:rPr sz="1450" b="1" i="0">
-                <a:solidFill>
-                  <a:srgbClr val="E94D1C"/>
-                </a:solidFill>
-                <a:latin typeface="Roboto"/>
-              </a:rPr>
-              <a:t>//</a:t>
-            </a:r>
-          </a:p>
-        </p:txBody>
-      </p:sp>
-      <p:sp>
-        <p:nvSpPr>
-          <p:cNvPr id="16" name="TextBox 15"/>
-          <p:cNvSpPr txBox="1"/>
-          <p:nvPr/>
-        </p:nvSpPr>
-        <p:spPr>
-          <a:xfrm>
-            <a:off x="6648450" y="4542092"/>
-            <a:ext cx="4857750" cy="95250"/>
-          </a:xfrm>
-          <a:prstGeom prst="rect">
-            <a:avLst/>
-          </a:prstGeom>
-          <a:noFill/>
-        </p:spPr>
-        <p:txBody>
-          <a:bodyPr wrap="square" lIns="0" rIns="0" tIns="0" bIns="0" anchor="t">
-            <a:spAutoFit/>
-          </a:bodyPr>
-          <a:lstStyle/>
-          <a:p>
-            <a:pPr algn="l">
-              <a:lnSpc>
-                <a:spcPct val="130000"/>
-              </a:lnSpc>
-            </a:pPr>
-            <a:r>
-              <a:rPr sz="1580" b="0" i="0">
-                <a:solidFill>
-                  <a:srgbClr val="1A1A1E"/>
-                </a:solidFill>
-                <a:latin typeface="Roboto"/>
-              </a:rPr>
-              <a:t>Essa é citação da Image Spec, um dos documentos da Open Container Initiative, a organização que padroniza o formato de imagem desde 2015.</a:t>
-            </a:r>
-          </a:p>
-        </p:txBody>
-      </p:sp>
-      <p:sp>
-        <p:nvSpPr>
-          <p:cNvPr id="17" name="TextBox 16"/>
           <p:cNvSpPr txBox="1"/>
           <p:nvPr/>
         </p:nvSpPr>
@@ -32171,7 +32015,7 @@
       </p:sp>
       <p:sp>
         <p:nvSpPr>
-          <p:cNvPr id="18" name="TextBox 17"/>
+          <p:cNvPr id="14" name="TextBox 13"/>
           <p:cNvSpPr txBox="1"/>
           <p:nvPr/>
         </p:nvSpPr>

</xml_diff>

<commit_message>
docs: reescreve o corpo dos slides do T1 em frases inteiras no lugar de fragmentos
</commit_message>
<xml_diff>
--- a/trabalhos/T1-Docker-Invite-People.pptx
+++ b/trabalhos/T1-Docker-Invite-People.pptx
@@ -19190,7 +19190,7 @@
                 </a:solidFill>
                 <a:latin typeface="Roboto"/>
               </a:rPr>
-              <a:t>Só o serviço de fronteira publica porta. O banco fica na rede interna sem mapeamento.</a:t>
+              <a:t>Só o serviço de fronteira publica porta, e o banco fica na rede interna sem mapeamento nenhum.</a:t>
             </a:r>
           </a:p>
         </p:txBody>
@@ -19910,7 +19910,7 @@
                 </a:solidFill>
                 <a:latin typeface="Roboto"/>
               </a:rPr>
-              <a:t>Replicar só o serviço público faz sentido. Replicar o painel não.</a:t>
+              <a:t>Replicar só o serviço público faz sentido, e replicar o painel não faz.</a:t>
             </a:r>
           </a:p>
         </p:txBody>
@@ -20993,7 +20993,7 @@
                 </a:solidFill>
                 <a:latin typeface="Roboto"/>
               </a:rPr>
-              <a:t>App web de convites virtuais, com confirmação de presença e consolidação de restrições alimentares.</a:t>
+              <a:t>É um app web de convites virtuais, onde o convidado confirma presença e o anfitrião consolida as restrições alimentares.</a:t>
             </a:r>
           </a:p>
         </p:txBody>
@@ -21076,7 +21076,7 @@
                 </a:solidFill>
                 <a:latin typeface="Roboto"/>
               </a:rPr>
-              <a:t>Duas superfícies sobre o mesmo Model: o convite público sem login e o painel do anfitrião.</a:t>
+              <a:t>São duas superfícies sobre o mesmo Model, o convite público, que não pede login, e o painel do anfitrião.</a:t>
             </a:r>
           </a:p>
         </p:txBody>
@@ -21159,7 +21159,7 @@
                 </a:solidFill>
                 <a:latin typeface="Roboto"/>
               </a:rPr>
-              <a:t>Arquitetura registrada no Guia da Arquitetura: MVC no front e três camadas no back.</a:t>
+              <a:t>A arquitetura já está registrada no Guia da Arquitetura, com MVC no front e três camadas no back.</a:t>
             </a:r>
           </a:p>
         </p:txBody>
@@ -21242,7 +21242,7 @@
                 </a:solidFill>
                 <a:latin typeface="Roboto"/>
               </a:rPr>
-              <a:t>Questão Norteadora da Sprint 2: como os componentes serão distribuídos e implantados no ambiente de execução?</a:t>
+              <a:t>A Questão Norteadora da Sprint 2 pergunta como os componentes serão distribuídos e implantados no ambiente de execução.</a:t>
             </a:r>
           </a:p>
         </p:txBody>
@@ -22877,7 +22877,7 @@
         </p:nvSpPr>
         <p:spPr>
           <a:xfrm>
-            <a:off x="704850" y="2860548"/>
+            <a:off x="704850" y="2583942"/>
             <a:ext cx="57150" cy="57150"/>
           </a:xfrm>
           <a:prstGeom prst="rect">
@@ -22921,7 +22921,7 @@
         </p:nvSpPr>
         <p:spPr>
           <a:xfrm>
-            <a:off x="971550" y="2751582"/>
+            <a:off x="971550" y="2474976"/>
             <a:ext cx="7772400" cy="95250"/>
           </a:xfrm>
           <a:prstGeom prst="rect">
@@ -22960,7 +22960,7 @@
         </p:nvSpPr>
         <p:spPr>
           <a:xfrm>
-            <a:off x="704850" y="3699510"/>
+            <a:off x="704850" y="3422904"/>
             <a:ext cx="57150" cy="57150"/>
           </a:xfrm>
           <a:prstGeom prst="rect">
@@ -23004,7 +23004,7 @@
         </p:nvSpPr>
         <p:spPr>
           <a:xfrm>
-            <a:off x="971550" y="3590544"/>
+            <a:off x="971550" y="3313938"/>
             <a:ext cx="7772400" cy="95250"/>
           </a:xfrm>
           <a:prstGeom prst="rect">
@@ -23043,7 +23043,7 @@
         </p:nvSpPr>
         <p:spPr>
           <a:xfrm>
-            <a:off x="704850" y="4538472"/>
+            <a:off x="704850" y="4261866"/>
             <a:ext cx="57150" cy="57150"/>
           </a:xfrm>
           <a:prstGeom prst="rect">
@@ -23087,7 +23087,7 @@
         </p:nvSpPr>
         <p:spPr>
           <a:xfrm>
-            <a:off x="971550" y="4429506"/>
+            <a:off x="971550" y="4152900"/>
             <a:ext cx="7772400" cy="95250"/>
           </a:xfrm>
           <a:prstGeom prst="rect">
@@ -23113,7 +23113,7 @@
                 </a:solidFill>
                 <a:latin typeface="Roboto"/>
               </a:rPr>
-              <a:t>Estado, que traz junto backup e upgrade de versão maior do banco.</a:t>
+              <a:t>Container com estado traz junto o problema de backup e o de upgrade de versão maior do banco, que não somem por estar em imagem.</a:t>
             </a:r>
           </a:p>
         </p:txBody>
@@ -23196,7 +23196,7 @@
                 </a:solidFill>
                 <a:latin typeface="Roboto"/>
               </a:rPr>
-              <a:t>Licenciamento do Docker Desktop.</a:t>
+              <a:t>O Docker Desktop é pago para empresa acima de certo porte, o que afeta quem for usar isto fora da faculdade.</a:t>
             </a:r>
           </a:p>
         </p:txBody>
@@ -23209,7 +23209,7 @@
         </p:nvSpPr>
         <p:spPr>
           <a:xfrm>
-            <a:off x="9124950" y="2751582"/>
+            <a:off x="9124950" y="2474976"/>
             <a:ext cx="152400" cy="133350"/>
           </a:xfrm>
           <a:prstGeom prst="triangle">
@@ -23253,7 +23253,7 @@
         </p:nvSpPr>
         <p:spPr>
           <a:xfrm>
-            <a:off x="9193530" y="2808732"/>
+            <a:off x="9193530" y="2532126"/>
             <a:ext cx="15240" cy="38100"/>
           </a:xfrm>
           <a:prstGeom prst="rect">
@@ -23297,7 +23297,7 @@
         </p:nvSpPr>
         <p:spPr>
           <a:xfrm>
-            <a:off x="9372600" y="2761107"/>
+            <a:off x="9372600" y="2484501"/>
             <a:ext cx="2133600" cy="182880"/>
           </a:xfrm>
           <a:prstGeom prst="rect">
@@ -23336,7 +23336,7 @@
         </p:nvSpPr>
         <p:spPr>
           <a:xfrm>
-            <a:off x="9124950" y="3037332"/>
+            <a:off x="9124950" y="2760726"/>
             <a:ext cx="38100" cy="804672"/>
           </a:xfrm>
           <a:prstGeom prst="rect">
@@ -23380,7 +23380,7 @@
         </p:nvSpPr>
         <p:spPr>
           <a:xfrm>
-            <a:off x="9334500" y="3037332"/>
+            <a:off x="9334500" y="2760726"/>
             <a:ext cx="2171700" cy="1376172"/>
           </a:xfrm>
           <a:prstGeom prst="rect">
@@ -23644,7 +23644,7 @@
         </p:nvSpPr>
         <p:spPr>
           <a:xfrm>
-            <a:off x="685800" y="2722626"/>
+            <a:off x="685800" y="2590610"/>
             <a:ext cx="5143500" cy="182880"/>
           </a:xfrm>
           <a:prstGeom prst="rect">
@@ -23683,7 +23683,7 @@
         </p:nvSpPr>
         <p:spPr>
           <a:xfrm>
-            <a:off x="685800" y="2932176"/>
+            <a:off x="685800" y="2800160"/>
             <a:ext cx="419100" cy="28575"/>
           </a:xfrm>
           <a:prstGeom prst="rect">
@@ -23727,7 +23727,7 @@
         </p:nvSpPr>
         <p:spPr>
           <a:xfrm>
-            <a:off x="704850" y="3321939"/>
+            <a:off x="704850" y="3189923"/>
             <a:ext cx="57150" cy="57150"/>
           </a:xfrm>
           <a:prstGeom prst="rect">
@@ -23771,7 +23771,7 @@
         </p:nvSpPr>
         <p:spPr>
           <a:xfrm>
-            <a:off x="971550" y="3217926"/>
+            <a:off x="971550" y="3085910"/>
             <a:ext cx="4857750" cy="95250"/>
           </a:xfrm>
           <a:prstGeom prst="rect">
@@ -23797,7 +23797,7 @@
                 </a:solidFill>
                 <a:latin typeface="Roboto"/>
               </a:rPr>
-              <a:t>Kernel próprio.</a:t>
+              <a:t>A máquina virtual tem kernel próprio.</a:t>
             </a:r>
           </a:p>
         </p:txBody>
@@ -23810,7 +23810,7 @@
         </p:nvSpPr>
         <p:spPr>
           <a:xfrm>
-            <a:off x="704850" y="3852672"/>
+            <a:off x="704850" y="3720656"/>
             <a:ext cx="57150" cy="57150"/>
           </a:xfrm>
           <a:prstGeom prst="rect">
@@ -23854,7 +23854,7 @@
         </p:nvSpPr>
         <p:spPr>
           <a:xfrm>
-            <a:off x="971550" y="3748659"/>
+            <a:off x="971550" y="3616643"/>
             <a:ext cx="4857750" cy="95250"/>
           </a:xfrm>
           <a:prstGeom prst="rect">
@@ -23880,7 +23880,7 @@
                 </a:solidFill>
                 <a:latin typeface="Roboto"/>
               </a:rPr>
-              <a:t>Fronteira imposta em hardware.</a:t>
+              <a:t>A fronteira entre ela e o host é imposta em hardware.</a:t>
             </a:r>
           </a:p>
         </p:txBody>
@@ -23893,7 +23893,7 @@
         </p:nvSpPr>
         <p:spPr>
           <a:xfrm>
-            <a:off x="704850" y="4383405"/>
+            <a:off x="704850" y="4515422"/>
             <a:ext cx="57150" cy="57150"/>
           </a:xfrm>
           <a:prstGeom prst="rect">
@@ -23937,7 +23937,7 @@
         </p:nvSpPr>
         <p:spPr>
           <a:xfrm>
-            <a:off x="971550" y="4279392"/>
+            <a:off x="971550" y="4411408"/>
             <a:ext cx="4857750" cy="95250"/>
           </a:xfrm>
           <a:prstGeom prst="rect">
@@ -23963,7 +23963,7 @@
                 </a:solidFill>
                 <a:latin typeface="Roboto"/>
               </a:rPr>
-              <a:t>Superfície relativamente estreita.</a:t>
+              <a:t>Por isso a superfície de ataque fica relativamente estreita.</a:t>
             </a:r>
           </a:p>
         </p:txBody>
@@ -23976,7 +23976,7 @@
         </p:nvSpPr>
         <p:spPr>
           <a:xfrm>
-            <a:off x="6362700" y="2722626"/>
+            <a:off x="6362700" y="2590610"/>
             <a:ext cx="5143500" cy="182880"/>
           </a:xfrm>
           <a:prstGeom prst="rect">
@@ -24015,7 +24015,7 @@
         </p:nvSpPr>
         <p:spPr>
           <a:xfrm>
-            <a:off x="6362700" y="2932176"/>
+            <a:off x="6362700" y="2800160"/>
             <a:ext cx="419100" cy="28575"/>
           </a:xfrm>
           <a:prstGeom prst="rect">
@@ -24059,7 +24059,7 @@
         </p:nvSpPr>
         <p:spPr>
           <a:xfrm>
-            <a:off x="6381750" y="3321939"/>
+            <a:off x="6381750" y="3189923"/>
             <a:ext cx="57150" cy="57150"/>
           </a:xfrm>
           <a:prstGeom prst="rect">
@@ -24103,7 +24103,7 @@
         </p:nvSpPr>
         <p:spPr>
           <a:xfrm>
-            <a:off x="6648450" y="3217926"/>
+            <a:off x="6648450" y="3085910"/>
             <a:ext cx="4857750" cy="95250"/>
           </a:xfrm>
           <a:prstGeom prst="rect">
@@ -24129,7 +24129,7 @@
                 </a:solidFill>
                 <a:latin typeface="Roboto"/>
               </a:rPr>
-              <a:t>Compartilha o kernel do host.</a:t>
+              <a:t>O container compartilha o kernel do host.</a:t>
             </a:r>
           </a:p>
         </p:txBody>
@@ -24142,7 +24142,7 @@
         </p:nvSpPr>
         <p:spPr>
           <a:xfrm>
-            <a:off x="6381750" y="3852672"/>
+            <a:off x="6381750" y="3720656"/>
             <a:ext cx="57150" cy="57150"/>
           </a:xfrm>
           <a:prstGeom prst="rect">
@@ -24186,7 +24186,7 @@
         </p:nvSpPr>
         <p:spPr>
           <a:xfrm>
-            <a:off x="6648450" y="3748659"/>
+            <a:off x="6648450" y="3616643"/>
             <a:ext cx="4857750" cy="95250"/>
           </a:xfrm>
           <a:prstGeom prst="rect">
@@ -24212,7 +24212,7 @@
                 </a:solidFill>
                 <a:latin typeface="Roboto"/>
               </a:rPr>
-              <a:t>A fronteira é a interface de chamadas de sistema, mais de trezentas, mais /proc, /sys e ioctl.</a:t>
+              <a:t>A fronteira dele é a interface de chamadas de sistema, que são mais de trezentas, somadas a /proc, /sys e ioctl.</a:t>
             </a:r>
           </a:p>
         </p:txBody>
@@ -24225,7 +24225,7 @@
         </p:nvSpPr>
         <p:spPr>
           <a:xfrm>
-            <a:off x="6381750" y="4647438"/>
+            <a:off x="6381750" y="4779455"/>
             <a:ext cx="57150" cy="57150"/>
           </a:xfrm>
           <a:prstGeom prst="rect">
@@ -24269,7 +24269,7 @@
         </p:nvSpPr>
         <p:spPr>
           <a:xfrm>
-            <a:off x="6648450" y="4543425"/>
+            <a:off x="6648450" y="4675442"/>
             <a:ext cx="4857750" cy="95250"/>
           </a:xfrm>
           <a:prstGeom prst="rect">
@@ -24295,7 +24295,7 @@
                 </a:solidFill>
                 <a:latin typeface="Roboto"/>
               </a:rPr>
-              <a:t>CVE-2019-5736 no runc: o processo de dentro sobrescrevia o binário do runtime pelo /proc/self/exe.</a:t>
+              <a:t>A CVE-2019-5736 mostrou o risco na prática, porque o processo de dentro conseguia sobrescrever o binário do runtime pelo /proc/self/exe.</a:t>
             </a:r>
           </a:p>
         </p:txBody>
@@ -25585,7 +25585,7 @@
         </p:nvSpPr>
         <p:spPr>
           <a:xfrm>
-            <a:off x="685800" y="2721292"/>
+            <a:off x="685800" y="2457260"/>
             <a:ext cx="5143500" cy="182880"/>
           </a:xfrm>
           <a:prstGeom prst="rect">
@@ -25624,7 +25624,7 @@
         </p:nvSpPr>
         <p:spPr>
           <a:xfrm>
-            <a:off x="685800" y="2930842"/>
+            <a:off x="685800" y="2666810"/>
             <a:ext cx="419100" cy="28575"/>
           </a:xfrm>
           <a:prstGeom prst="rect">
@@ -25668,7 +25668,7 @@
         </p:nvSpPr>
         <p:spPr>
           <a:xfrm>
-            <a:off x="704850" y="3320606"/>
+            <a:off x="704850" y="3056573"/>
             <a:ext cx="57150" cy="57150"/>
           </a:xfrm>
           <a:prstGeom prst="rect">
@@ -25712,7 +25712,7 @@
         </p:nvSpPr>
         <p:spPr>
           <a:xfrm>
-            <a:off x="971550" y="3216592"/>
+            <a:off x="971550" y="2952560"/>
             <a:ext cx="4857750" cy="95250"/>
           </a:xfrm>
           <a:prstGeom prst="rect">
@@ -25738,7 +25738,7 @@
                 </a:solidFill>
                 <a:latin typeface="Roboto"/>
               </a:rPr>
-              <a:t>Monolito num servidor que nunca escala.</a:t>
+              <a:t>O primeiro é o monolito que roda num servidor só e nunca vai escalar.</a:t>
             </a:r>
           </a:p>
         </p:txBody>
@@ -25751,7 +25751,7 @@
         </p:nvSpPr>
         <p:spPr>
           <a:xfrm>
-            <a:off x="704850" y="3851338"/>
+            <a:off x="704850" y="3851339"/>
             <a:ext cx="57150" cy="57150"/>
           </a:xfrm>
           <a:prstGeom prst="rect">
@@ -25795,7 +25795,7 @@
         </p:nvSpPr>
         <p:spPr>
           <a:xfrm>
-            <a:off x="971550" y="3747325"/>
+            <a:off x="971550" y="3747326"/>
             <a:ext cx="4857750" cy="95250"/>
           </a:xfrm>
           <a:prstGeom prst="rect">
@@ -25821,7 +25821,7 @@
                 </a:solidFill>
                 <a:latin typeface="Roboto"/>
               </a:rPr>
-              <a:t>Time sem integração contínua, que só ganha um passo de build a mais.</a:t>
+              <a:t>O segundo é o time sem integração contínua, que só ganha um passo de build a mais.</a:t>
             </a:r>
           </a:p>
         </p:txBody>
@@ -25904,7 +25904,7 @@
                 </a:solidFill>
                 <a:latin typeface="Roboto"/>
               </a:rPr>
-              <a:t>Aplicação sensível a latência de cauda.</a:t>
+              <a:t>O terceiro é a aplicação sensível a latência de cauda.</a:t>
             </a:r>
           </a:p>
         </p:txBody>
@@ -25917,7 +25917,7 @@
         </p:nvSpPr>
         <p:spPr>
           <a:xfrm>
-            <a:off x="704850" y="5176837"/>
+            <a:off x="704850" y="5440870"/>
             <a:ext cx="57150" cy="57150"/>
           </a:xfrm>
           <a:prstGeom prst="rect">
@@ -25961,7 +25961,7 @@
         </p:nvSpPr>
         <p:spPr>
           <a:xfrm>
-            <a:off x="971550" y="5072824"/>
+            <a:off x="971550" y="5336858"/>
             <a:ext cx="4857750" cy="95250"/>
           </a:xfrm>
           <a:prstGeom prst="rect">
@@ -25987,7 +25987,7 @@
                 </a:solidFill>
                 <a:latin typeface="Roboto"/>
               </a:rPr>
-              <a:t>Sistema dominado por estado.</a:t>
+              <a:t>O quarto é o sistema dominado por estado.</a:t>
             </a:r>
           </a:p>
         </p:txBody>
@@ -26000,7 +26000,7 @@
         </p:nvSpPr>
         <p:spPr>
           <a:xfrm>
-            <a:off x="6362700" y="2721292"/>
+            <a:off x="6362700" y="2457260"/>
             <a:ext cx="5143500" cy="182880"/>
           </a:xfrm>
           <a:prstGeom prst="rect">
@@ -26039,7 +26039,7 @@
         </p:nvSpPr>
         <p:spPr>
           <a:xfrm>
-            <a:off x="6362700" y="2930842"/>
+            <a:off x="6362700" y="2666810"/>
             <a:ext cx="419100" cy="28575"/>
           </a:xfrm>
           <a:prstGeom prst="rect">
@@ -26083,7 +26083,7 @@
         </p:nvSpPr>
         <p:spPr>
           <a:xfrm>
-            <a:off x="6381750" y="3320606"/>
+            <a:off x="6381750" y="3056573"/>
             <a:ext cx="57150" cy="57150"/>
           </a:xfrm>
           <a:prstGeom prst="rect">
@@ -26127,7 +26127,7 @@
         </p:nvSpPr>
         <p:spPr>
           <a:xfrm>
-            <a:off x="6648450" y="3216592"/>
+            <a:off x="6648450" y="2952560"/>
             <a:ext cx="4857750" cy="95250"/>
           </a:xfrm>
           <a:prstGeom prst="rect">
@@ -26166,7 +26166,7 @@
         </p:nvSpPr>
         <p:spPr>
           <a:xfrm>
-            <a:off x="6381750" y="4379404"/>
+            <a:off x="6381750" y="4115372"/>
             <a:ext cx="57150" cy="57150"/>
           </a:xfrm>
           <a:prstGeom prst="rect">
@@ -26210,7 +26210,7 @@
         </p:nvSpPr>
         <p:spPr>
           <a:xfrm>
-            <a:off x="6648450" y="4275392"/>
+            <a:off x="6648450" y="4011359"/>
             <a:ext cx="4857750" cy="95250"/>
           </a:xfrm>
           <a:prstGeom prst="rect">
@@ -27494,7 +27494,7 @@
                 </a:solidFill>
                 <a:latin typeface="Roboto"/>
               </a:rPr>
-              <a:t>Adotamos conteinerização como estratégia de empacotamento e de ambiente de desenvolvimento, registrada como troca.</a:t>
+              <a:t>O grupo recomenda adotar conteinerização como estratégia de empacotamento e de ambiente de desenvolvimento, com o custo declarado junto.</a:t>
             </a:r>
           </a:p>
         </p:txBody>
@@ -28064,7 +28064,7 @@
         </p:nvSpPr>
         <p:spPr>
           <a:xfrm>
-            <a:off x="685800" y="3120009"/>
+            <a:off x="685800" y="2987992"/>
             <a:ext cx="5143500" cy="182880"/>
           </a:xfrm>
           <a:prstGeom prst="rect">
@@ -28103,7 +28103,7 @@
         </p:nvSpPr>
         <p:spPr>
           <a:xfrm>
-            <a:off x="685800" y="3329559"/>
+            <a:off x="685800" y="3197542"/>
             <a:ext cx="419100" cy="28575"/>
           </a:xfrm>
           <a:prstGeom prst="rect">
@@ -28147,7 +28147,7 @@
         </p:nvSpPr>
         <p:spPr>
           <a:xfrm>
-            <a:off x="704850" y="3719322"/>
+            <a:off x="704850" y="3587306"/>
             <a:ext cx="57150" cy="57150"/>
           </a:xfrm>
           <a:prstGeom prst="rect">
@@ -28191,7 +28191,7 @@
         </p:nvSpPr>
         <p:spPr>
           <a:xfrm>
-            <a:off x="971550" y="3615309"/>
+            <a:off x="971550" y="3483292"/>
             <a:ext cx="4857750" cy="95250"/>
           </a:xfrm>
           <a:prstGeom prst="rect">
@@ -28217,7 +28217,7 @@
                 </a:solidFill>
                 <a:latin typeface="Roboto"/>
               </a:rPr>
-              <a:t>Uma linha de .gitattributes forçando LF nos scripts, porque o Git Bash quebra no Windows.</a:t>
+              <a:t>O repositório tem uma linha de .gitattributes forçando LF nos scripts, porque sem ela o Git Bash quebra no Windows.</a:t>
             </a:r>
           </a:p>
         </p:txBody>
@@ -28230,7 +28230,7 @@
         </p:nvSpPr>
         <p:spPr>
           <a:xfrm>
-            <a:off x="704850" y="4514088"/>
+            <a:off x="704850" y="4646104"/>
             <a:ext cx="57150" cy="57150"/>
           </a:xfrm>
           <a:prstGeom prst="rect">
@@ -28274,7 +28274,7 @@
         </p:nvSpPr>
         <p:spPr>
           <a:xfrm>
-            <a:off x="971550" y="4410075"/>
+            <a:off x="971550" y="4542092"/>
             <a:ext cx="4857750" cy="95250"/>
           </a:xfrm>
           <a:prstGeom prst="rect">
@@ -28313,7 +28313,7 @@
         </p:nvSpPr>
         <p:spPr>
           <a:xfrm>
-            <a:off x="6362700" y="3120009"/>
+            <a:off x="6362700" y="2987992"/>
             <a:ext cx="5143500" cy="182880"/>
           </a:xfrm>
           <a:prstGeom prst="rect">
@@ -28352,7 +28352,7 @@
         </p:nvSpPr>
         <p:spPr>
           <a:xfrm>
-            <a:off x="6362700" y="3329559"/>
+            <a:off x="6362700" y="3197542"/>
             <a:ext cx="419100" cy="28575"/>
           </a:xfrm>
           <a:prstGeom prst="rect">
@@ -28396,7 +28396,7 @@
         </p:nvSpPr>
         <p:spPr>
           <a:xfrm>
-            <a:off x="6381750" y="3719322"/>
+            <a:off x="6381750" y="3587306"/>
             <a:ext cx="57150" cy="57150"/>
           </a:xfrm>
           <a:prstGeom prst="rect">
@@ -28440,7 +28440,7 @@
         </p:nvSpPr>
         <p:spPr>
           <a:xfrm>
-            <a:off x="6648450" y="3615309"/>
+            <a:off x="6648450" y="3483292"/>
             <a:ext cx="4857750" cy="95250"/>
           </a:xfrm>
           <a:prstGeom prst="rect">
@@ -28466,7 +28466,7 @@
                 </a:solidFill>
                 <a:latin typeface="Roboto"/>
               </a:rPr>
-              <a:t>Um arquivo que descreve o ambiente inteiro e que qualquer um dos quatro sobe com um comando.</a:t>
+              <a:t>Existe um arquivo que descreve o ambiente inteiro e que qualquer um dos quatro sobe com um comando.</a:t>
             </a:r>
           </a:p>
         </p:txBody>
@@ -28479,7 +28479,7 @@
         </p:nvSpPr>
         <p:spPr>
           <a:xfrm>
-            <a:off x="6381750" y="4514088"/>
+            <a:off x="6381750" y="4646104"/>
             <a:ext cx="57150" cy="57150"/>
           </a:xfrm>
           <a:prstGeom prst="rect">
@@ -28523,7 +28523,7 @@
         </p:nvSpPr>
         <p:spPr>
           <a:xfrm>
-            <a:off x="6648450" y="4410075"/>
+            <a:off x="6648450" y="4542092"/>
             <a:ext cx="4857750" cy="95250"/>
           </a:xfrm>
           <a:prstGeom prst="rect">
@@ -28549,7 +28549,7 @@
                 </a:solidFill>
                 <a:latin typeface="Roboto"/>
               </a:rPr>
-              <a:t>E que vira o diagrama de implantação do item #60.</a:t>
+              <a:t>Esse mesmo arquivo é o que vira o diagrama de implantação do item #60.</a:t>
             </a:r>
           </a:p>
         </p:txBody>
@@ -33379,7 +33379,7 @@
         </p:nvSpPr>
         <p:spPr>
           <a:xfrm>
-            <a:off x="685800" y="2590610"/>
+            <a:off x="685800" y="2458593"/>
             <a:ext cx="5143500" cy="182880"/>
           </a:xfrm>
           <a:prstGeom prst="rect">
@@ -33418,7 +33418,7 @@
         </p:nvSpPr>
         <p:spPr>
           <a:xfrm>
-            <a:off x="685800" y="2800160"/>
+            <a:off x="685800" y="2668143"/>
             <a:ext cx="419100" cy="28575"/>
           </a:xfrm>
           <a:prstGeom prst="rect">
@@ -33462,7 +33462,7 @@
         </p:nvSpPr>
         <p:spPr>
           <a:xfrm>
-            <a:off x="704850" y="3189923"/>
+            <a:off x="704850" y="3057906"/>
             <a:ext cx="57150" cy="57150"/>
           </a:xfrm>
           <a:prstGeom prst="rect">
@@ -33506,7 +33506,7 @@
         </p:nvSpPr>
         <p:spPr>
           <a:xfrm>
-            <a:off x="971550" y="3085910"/>
+            <a:off x="971550" y="2953893"/>
             <a:ext cx="4857750" cy="95250"/>
           </a:xfrm>
           <a:prstGeom prst="rect">
@@ -33532,7 +33532,7 @@
                 </a:solidFill>
                 <a:latin typeface="Roboto"/>
               </a:rPr>
-              <a:t>mnt dá árvore de montagem própria.</a:t>
+              <a:t>O namespace mnt dá ao processo uma árvore de montagem própria.</a:t>
             </a:r>
           </a:p>
         </p:txBody>
@@ -33545,7 +33545,7 @@
         </p:nvSpPr>
         <p:spPr>
           <a:xfrm>
-            <a:off x="704850" y="3720656"/>
+            <a:off x="704850" y="3852672"/>
             <a:ext cx="57150" cy="57150"/>
           </a:xfrm>
           <a:prstGeom prst="rect">
@@ -33589,7 +33589,7 @@
         </p:nvSpPr>
         <p:spPr>
           <a:xfrm>
-            <a:off x="971550" y="3616643"/>
+            <a:off x="971550" y="3748659"/>
             <a:ext cx="4857750" cy="95250"/>
           </a:xfrm>
           <a:prstGeom prst="rect">
@@ -33615,7 +33615,7 @@
                 </a:solidFill>
                 <a:latin typeface="Roboto"/>
               </a:rPr>
-              <a:t>pid faz o processo virar PID 1 lá dentro.</a:t>
+              <a:t>O namespace pid faz o processo enxergar a si mesmo como PID 1.</a:t>
             </a:r>
           </a:p>
         </p:txBody>
@@ -33628,7 +33628,7 @@
         </p:nvSpPr>
         <p:spPr>
           <a:xfrm>
-            <a:off x="704850" y="4251389"/>
+            <a:off x="704850" y="4647438"/>
             <a:ext cx="57150" cy="57150"/>
           </a:xfrm>
           <a:prstGeom prst="rect">
@@ -33672,7 +33672,7 @@
         </p:nvSpPr>
         <p:spPr>
           <a:xfrm>
-            <a:off x="971550" y="4147376"/>
+            <a:off x="971550" y="4543425"/>
             <a:ext cx="4857750" cy="95250"/>
           </a:xfrm>
           <a:prstGeom prst="rect">
@@ -33698,7 +33698,7 @@
                 </a:solidFill>
                 <a:latin typeface="Roboto"/>
               </a:rPr>
-              <a:t>net dá pilha de rede própria, por isso dois containers escutam na mesma porta.</a:t>
+              <a:t>O namespace net dá uma pilha de rede própria, e é por isso que dois containers conseguem escutar na mesma porta.</a:t>
             </a:r>
           </a:p>
         </p:txBody>
@@ -33711,7 +33711,7 @@
         </p:nvSpPr>
         <p:spPr>
           <a:xfrm>
-            <a:off x="6362700" y="2590610"/>
+            <a:off x="6362700" y="2458593"/>
             <a:ext cx="5143500" cy="182880"/>
           </a:xfrm>
           <a:prstGeom prst="rect">
@@ -33750,7 +33750,7 @@
         </p:nvSpPr>
         <p:spPr>
           <a:xfrm>
-            <a:off x="6362700" y="2800160"/>
+            <a:off x="6362700" y="2668143"/>
             <a:ext cx="419100" cy="28575"/>
           </a:xfrm>
           <a:prstGeom prst="rect">
@@ -33794,7 +33794,7 @@
         </p:nvSpPr>
         <p:spPr>
           <a:xfrm>
-            <a:off x="6381750" y="3189923"/>
+            <a:off x="6381750" y="3057906"/>
             <a:ext cx="57150" cy="57150"/>
           </a:xfrm>
           <a:prstGeom prst="rect">
@@ -33838,7 +33838,7 @@
         </p:nvSpPr>
         <p:spPr>
           <a:xfrm>
-            <a:off x="6648450" y="3085910"/>
+            <a:off x="6648450" y="2953893"/>
             <a:ext cx="4857750" cy="95250"/>
           </a:xfrm>
           <a:prstGeom prst="rect">
@@ -33864,7 +33864,7 @@
                 </a:solidFill>
                 <a:latin typeface="Roboto"/>
               </a:rPr>
-              <a:t>Não isolam nada, apenas contabilizam e limitam o consumo.</a:t>
+              <a:t>Os cgroups não isolam nada, eles contabilizam e limitam o consumo de recursos.</a:t>
             </a:r>
           </a:p>
         </p:txBody>
@@ -33877,7 +33877,7 @@
         </p:nvSpPr>
         <p:spPr>
           <a:xfrm>
-            <a:off x="6381750" y="3984689"/>
+            <a:off x="6381750" y="3852672"/>
             <a:ext cx="57150" cy="57150"/>
           </a:xfrm>
           <a:prstGeom prst="rect">
@@ -33921,7 +33921,7 @@
         </p:nvSpPr>
         <p:spPr>
           <a:xfrm>
-            <a:off x="6648450" y="3880676"/>
+            <a:off x="6648450" y="3748659"/>
             <a:ext cx="4857750" cy="95250"/>
           </a:xfrm>
           <a:prstGeom prst="rect">
@@ -33947,7 +33947,7 @@
                 </a:solidFill>
                 <a:latin typeface="Roboto"/>
               </a:rPr>
-              <a:t>Estourar o limite de memória não deixa lento, o kernel mata o processo.</a:t>
+              <a:t>Quando o processo estoura o limite de memória ele não fica lento, o kernel mata ele.</a:t>
             </a:r>
           </a:p>
         </p:txBody>
@@ -33960,7 +33960,7 @@
         </p:nvSpPr>
         <p:spPr>
           <a:xfrm>
-            <a:off x="6381750" y="4779454"/>
+            <a:off x="6381750" y="4647438"/>
             <a:ext cx="57150" cy="57150"/>
           </a:xfrm>
           <a:prstGeom prst="rect">
@@ -34004,7 +34004,7 @@
         </p:nvSpPr>
         <p:spPr>
           <a:xfrm>
-            <a:off x="6648450" y="4675442"/>
+            <a:off x="6648450" y="4543425"/>
             <a:ext cx="4857750" cy="95250"/>
           </a:xfrm>
           <a:prstGeom prst="rect">
@@ -34030,7 +34030,7 @@
                 </a:solidFill>
                 <a:latin typeface="Roboto"/>
               </a:rPr>
-              <a:t>Limite de CPU não mata, freia. Isso piora as requisições mais lentas e quase não mexe na média, por isso é mais difícil de perceber.</a:t>
+              <a:t>O limite de CPU não mata, ele freia o processo, o que piora as requisições mais lentas e quase não mexe na média, por isso é mais difícil de perceber.</a:t>
             </a:r>
           </a:p>
         </p:txBody>

</xml_diff>

<commit_message>
docs: liga cada slide tecnico do T1 ao projeto e corrige a linha que ficou so no gerador dos artboards
</commit_message>
<xml_diff>
--- a/trabalhos/T1-Docker-Invite-People.pptx
+++ b/trabalhos/T1-Docker-Invite-People.pptx
@@ -23337,7 +23337,7 @@
         <p:spPr>
           <a:xfrm>
             <a:off x="9124950" y="2760726"/>
-            <a:ext cx="38100" cy="804672"/>
+            <a:ext cx="38100" cy="1636776"/>
           </a:xfrm>
           <a:prstGeom prst="rect">
             <a:avLst/>
@@ -23381,7 +23381,7 @@
         <p:spPr>
           <a:xfrm>
             <a:off x="9334500" y="2760726"/>
-            <a:ext cx="2171700" cy="1376172"/>
+            <a:ext cx="2171700" cy="2208276"/>
           </a:xfrm>
           <a:prstGeom prst="rect">
             <a:avLst/>
@@ -23409,7 +23409,45 @@
                 </a:solidFill>
                 <a:latin typeface="Roboto"/>
               </a:rPr>
-              <a:t>Nenhum número entra neste slide sem medição feita pelo time, com o modelo da máquina e a data.</a:t>
+              <a:t>Dos quatro, o do daemon como root é o que atinge o projeto hoje, porque os quatro integrantes rodam na própria máquina.</a:t>
+            </a:r>
+          </a:p>
+          <a:p>
+            <a:pPr>
+              <a:lnSpc>
+                <a:spcPct val="140000"/>
+              </a:lnSpc>
+              <a:spcAft>
+                <a:spcPts val="600"/>
+              </a:spcAft>
+            </a:pPr>
+            <a:r>
+              <a:rPr sz="1200" b="0" i="0">
+                <a:solidFill>
+                  <a:srgbClr val="3A3A44"/>
+                </a:solidFill>
+                <a:latin typeface="Roboto"/>
+              </a:rPr>
+              <a:t/>
+            </a:r>
+          </a:p>
+          <a:p>
+            <a:pPr>
+              <a:lnSpc>
+                <a:spcPct val="140000"/>
+              </a:lnSpc>
+              <a:spcAft>
+                <a:spcPts val="600"/>
+              </a:spcAft>
+            </a:pPr>
+            <a:r>
+              <a:rPr sz="1200" b="0" i="0">
+                <a:solidFill>
+                  <a:srgbClr val="3A3A44"/>
+                </a:solidFill>
+                <a:latin typeface="Roboto"/>
+              </a:rPr>
+              <a:t>Nenhum número de desempenho entra aqui sem medição feita pelo time.</a:t>
             </a:r>
           </a:p>
         </p:txBody>
@@ -23644,7 +23682,7 @@
         </p:nvSpPr>
         <p:spPr>
           <a:xfrm>
-            <a:off x="685800" y="2590610"/>
+            <a:off x="685800" y="2061210"/>
             <a:ext cx="5143500" cy="182880"/>
           </a:xfrm>
           <a:prstGeom prst="rect">
@@ -23683,7 +23721,7 @@
         </p:nvSpPr>
         <p:spPr>
           <a:xfrm>
-            <a:off x="685800" y="2800160"/>
+            <a:off x="685800" y="2270760"/>
             <a:ext cx="419100" cy="28575"/>
           </a:xfrm>
           <a:prstGeom prst="rect">
@@ -23727,7 +23765,7 @@
         </p:nvSpPr>
         <p:spPr>
           <a:xfrm>
-            <a:off x="704850" y="3189923"/>
+            <a:off x="704850" y="2660523"/>
             <a:ext cx="57150" cy="57150"/>
           </a:xfrm>
           <a:prstGeom prst="rect">
@@ -23771,7 +23809,7 @@
         </p:nvSpPr>
         <p:spPr>
           <a:xfrm>
-            <a:off x="971550" y="3085910"/>
+            <a:off x="971550" y="2556510"/>
             <a:ext cx="4857750" cy="95250"/>
           </a:xfrm>
           <a:prstGeom prst="rect">
@@ -23810,7 +23848,7 @@
         </p:nvSpPr>
         <p:spPr>
           <a:xfrm>
-            <a:off x="704850" y="3720656"/>
+            <a:off x="704850" y="3191256"/>
             <a:ext cx="57150" cy="57150"/>
           </a:xfrm>
           <a:prstGeom prst="rect">
@@ -23854,7 +23892,7 @@
         </p:nvSpPr>
         <p:spPr>
           <a:xfrm>
-            <a:off x="971550" y="3616643"/>
+            <a:off x="971550" y="3087243"/>
             <a:ext cx="4857750" cy="95250"/>
           </a:xfrm>
           <a:prstGeom prst="rect">
@@ -23893,7 +23931,7 @@
         </p:nvSpPr>
         <p:spPr>
           <a:xfrm>
-            <a:off x="704850" y="4515422"/>
+            <a:off x="704850" y="3986022"/>
             <a:ext cx="57150" cy="57150"/>
           </a:xfrm>
           <a:prstGeom prst="rect">
@@ -23937,7 +23975,7 @@
         </p:nvSpPr>
         <p:spPr>
           <a:xfrm>
-            <a:off x="971550" y="4411408"/>
+            <a:off x="971550" y="3882009"/>
             <a:ext cx="4857750" cy="95250"/>
           </a:xfrm>
           <a:prstGeom prst="rect">
@@ -23976,7 +24014,7 @@
         </p:nvSpPr>
         <p:spPr>
           <a:xfrm>
-            <a:off x="6362700" y="2590610"/>
+            <a:off x="6362700" y="2061210"/>
             <a:ext cx="5143500" cy="182880"/>
           </a:xfrm>
           <a:prstGeom prst="rect">
@@ -24015,7 +24053,7 @@
         </p:nvSpPr>
         <p:spPr>
           <a:xfrm>
-            <a:off x="6362700" y="2800160"/>
+            <a:off x="6362700" y="2270760"/>
             <a:ext cx="419100" cy="28575"/>
           </a:xfrm>
           <a:prstGeom prst="rect">
@@ -24059,7 +24097,7 @@
         </p:nvSpPr>
         <p:spPr>
           <a:xfrm>
-            <a:off x="6381750" y="3189923"/>
+            <a:off x="6381750" y="2660523"/>
             <a:ext cx="57150" cy="57150"/>
           </a:xfrm>
           <a:prstGeom prst="rect">
@@ -24103,7 +24141,7 @@
         </p:nvSpPr>
         <p:spPr>
           <a:xfrm>
-            <a:off x="6648450" y="3085910"/>
+            <a:off x="6648450" y="2556510"/>
             <a:ext cx="4857750" cy="95250"/>
           </a:xfrm>
           <a:prstGeom prst="rect">
@@ -24142,7 +24180,7 @@
         </p:nvSpPr>
         <p:spPr>
           <a:xfrm>
-            <a:off x="6381750" y="3720656"/>
+            <a:off x="6381750" y="3191256"/>
             <a:ext cx="57150" cy="57150"/>
           </a:xfrm>
           <a:prstGeom prst="rect">
@@ -24186,7 +24224,7 @@
         </p:nvSpPr>
         <p:spPr>
           <a:xfrm>
-            <a:off x="6648450" y="3616643"/>
+            <a:off x="6648450" y="3087243"/>
             <a:ext cx="4857750" cy="95250"/>
           </a:xfrm>
           <a:prstGeom prst="rect">
@@ -24225,7 +24263,7 @@
         </p:nvSpPr>
         <p:spPr>
           <a:xfrm>
-            <a:off x="6381750" y="4779455"/>
+            <a:off x="6381750" y="4250055"/>
             <a:ext cx="57150" cy="57150"/>
           </a:xfrm>
           <a:prstGeom prst="rect">
@@ -24269,7 +24307,7 @@
         </p:nvSpPr>
         <p:spPr>
           <a:xfrm>
-            <a:off x="6648450" y="4675442"/>
+            <a:off x="6648450" y="4146042"/>
             <a:ext cx="4857750" cy="95250"/>
           </a:xfrm>
           <a:prstGeom prst="rect">
@@ -24302,14 +24340,58 @@
       </p:sp>
       <p:sp>
         <p:nvSpPr>
-          <p:cNvPr id="21" name="TextBox 20"/>
+          <p:cNvPr id="21" name="Rectangle 20"/>
+          <p:cNvSpPr/>
+          <p:nvPr/>
+        </p:nvSpPr>
+        <p:spPr>
+          <a:xfrm>
+            <a:off x="6381750" y="5308854"/>
+            <a:ext cx="57150" cy="57150"/>
+          </a:xfrm>
+          <a:prstGeom prst="rect">
+            <a:avLst/>
+          </a:prstGeom>
+          <a:solidFill>
+            <a:srgbClr val="E94D1C"/>
+          </a:solidFill>
+          <a:ln>
+            <a:noFill/>
+          </a:ln>
+          <a:effectLst/>
+        </p:spPr>
+        <p:style>
+          <a:lnRef idx="1">
+            <a:schemeClr val="accent1"/>
+          </a:lnRef>
+          <a:fillRef idx="3">
+            <a:schemeClr val="accent1"/>
+          </a:fillRef>
+          <a:effectRef idx="2">
+            <a:schemeClr val="accent1"/>
+          </a:effectRef>
+          <a:fontRef idx="minor">
+            <a:schemeClr val="lt1"/>
+          </a:fontRef>
+        </p:style>
+        <p:txBody>
+          <a:bodyPr rtlCol="0" anchor="ctr" wrap="square" lIns="0" rIns="0" tIns="0" bIns="0"/>
+          <a:lstStyle/>
+          <a:p>
+            <a:pPr algn="ctr"/>
+          </a:p>
+        </p:txBody>
+      </p:sp>
+      <p:sp>
+        <p:nvSpPr>
+          <p:cNvPr id="22" name="TextBox 21"/>
           <p:cNvSpPr txBox="1"/>
           <p:nvPr/>
         </p:nvSpPr>
         <p:spPr>
           <a:xfrm>
-            <a:off x="685800" y="6324600"/>
-            <a:ext cx="6667500" cy="182880"/>
+            <a:off x="6648450" y="5204841"/>
+            <a:ext cx="4857750" cy="95250"/>
           </a:xfrm>
           <a:prstGeom prst="rect">
             <a:avLst/>
@@ -24324,6 +24406,45 @@
           <a:p>
             <a:pPr algn="l">
               <a:lnSpc>
+                <a:spcPct val="130000"/>
+              </a:lnSpc>
+            </a:pPr>
+            <a:r>
+              <a:rPr sz="1580" b="0" i="0">
+                <a:solidFill>
+                  <a:srgbClr val="1A1A1E"/>
+                </a:solidFill>
+                <a:latin typeface="Roboto"/>
+              </a:rPr>
+              <a:t>Por isso o ADR #63 precisa registrar que container não dá o mesmo isolamento de uma máquina virtual.</a:t>
+            </a:r>
+          </a:p>
+        </p:txBody>
+      </p:sp>
+      <p:sp>
+        <p:nvSpPr>
+          <p:cNvPr id="23" name="TextBox 22"/>
+          <p:cNvSpPr txBox="1"/>
+          <p:nvPr/>
+        </p:nvSpPr>
+        <p:spPr>
+          <a:xfrm>
+            <a:off x="685800" y="6324600"/>
+            <a:ext cx="6667500" cy="182880"/>
+          </a:xfrm>
+          <a:prstGeom prst="rect">
+            <a:avLst/>
+          </a:prstGeom>
+          <a:noFill/>
+        </p:spPr>
+        <p:txBody>
+          <a:bodyPr wrap="square" lIns="0" rIns="0" tIns="0" bIns="0" anchor="t">
+            <a:spAutoFit/>
+          </a:bodyPr>
+          <a:lstStyle/>
+          <a:p>
+            <a:pPr algn="l">
+              <a:lnSpc>
                 <a:spcPct val="120000"/>
               </a:lnSpc>
             </a:pPr>
@@ -24341,7 +24462,7 @@
       </p:sp>
       <p:sp>
         <p:nvSpPr>
-          <p:cNvPr id="22" name="TextBox 21"/>
+          <p:cNvPr id="24" name="TextBox 23"/>
           <p:cNvSpPr txBox="1"/>
           <p:nvPr/>
         </p:nvSpPr>
@@ -31960,7 +32081,7 @@
         </p:nvSpPr>
         <p:spPr>
           <a:xfrm>
-            <a:off x="685800" y="3253359"/>
+            <a:off x="685800" y="2723960"/>
             <a:ext cx="5143500" cy="182880"/>
           </a:xfrm>
           <a:prstGeom prst="rect">
@@ -31999,7 +32120,7 @@
         </p:nvSpPr>
         <p:spPr>
           <a:xfrm>
-            <a:off x="685800" y="3462909"/>
+            <a:off x="685800" y="2933510"/>
             <a:ext cx="419100" cy="28575"/>
           </a:xfrm>
           <a:prstGeom prst="rect">
@@ -32043,7 +32164,7 @@
         </p:nvSpPr>
         <p:spPr>
           <a:xfrm>
-            <a:off x="704850" y="3852672"/>
+            <a:off x="704850" y="3323273"/>
             <a:ext cx="57150" cy="57150"/>
           </a:xfrm>
           <a:prstGeom prst="rect">
@@ -32087,7 +32208,7 @@
         </p:nvSpPr>
         <p:spPr>
           <a:xfrm>
-            <a:off x="971550" y="3748659"/>
+            <a:off x="971550" y="3219260"/>
             <a:ext cx="4857750" cy="95250"/>
           </a:xfrm>
           <a:prstGeom prst="rect">
@@ -32126,7 +32247,7 @@
         </p:nvSpPr>
         <p:spPr>
           <a:xfrm>
-            <a:off x="6362700" y="3253359"/>
+            <a:off x="6362700" y="2723960"/>
             <a:ext cx="5143500" cy="182880"/>
           </a:xfrm>
           <a:prstGeom prst="rect">
@@ -32165,7 +32286,7 @@
         </p:nvSpPr>
         <p:spPr>
           <a:xfrm>
-            <a:off x="6362700" y="3462909"/>
+            <a:off x="6362700" y="2933510"/>
             <a:ext cx="419100" cy="28575"/>
           </a:xfrm>
           <a:prstGeom prst="rect">
@@ -32209,7 +32330,7 @@
         </p:nvSpPr>
         <p:spPr>
           <a:xfrm>
-            <a:off x="6381750" y="3852672"/>
+            <a:off x="6381750" y="3323273"/>
             <a:ext cx="57150" cy="57150"/>
           </a:xfrm>
           <a:prstGeom prst="rect">
@@ -32253,7 +32374,7 @@
         </p:nvSpPr>
         <p:spPr>
           <a:xfrm>
-            <a:off x="6648450" y="3748659"/>
+            <a:off x="6648450" y="3219260"/>
             <a:ext cx="4857750" cy="95250"/>
           </a:xfrm>
           <a:prstGeom prst="rect">
@@ -32286,14 +32407,58 @@
       </p:sp>
       <p:sp>
         <p:nvSpPr>
-          <p:cNvPr id="13" name="TextBox 12"/>
+          <p:cNvPr id="13" name="Rectangle 12"/>
+          <p:cNvSpPr/>
+          <p:nvPr/>
+        </p:nvSpPr>
+        <p:spPr>
+          <a:xfrm>
+            <a:off x="6381750" y="4646104"/>
+            <a:ext cx="57150" cy="57150"/>
+          </a:xfrm>
+          <a:prstGeom prst="rect">
+            <a:avLst/>
+          </a:prstGeom>
+          <a:solidFill>
+            <a:srgbClr val="E94D1C"/>
+          </a:solidFill>
+          <a:ln>
+            <a:noFill/>
+          </a:ln>
+          <a:effectLst/>
+        </p:spPr>
+        <p:style>
+          <a:lnRef idx="1">
+            <a:schemeClr val="accent1"/>
+          </a:lnRef>
+          <a:fillRef idx="3">
+            <a:schemeClr val="accent1"/>
+          </a:fillRef>
+          <a:effectRef idx="2">
+            <a:schemeClr val="accent1"/>
+          </a:effectRef>
+          <a:fontRef idx="minor">
+            <a:schemeClr val="lt1"/>
+          </a:fontRef>
+        </p:style>
+        <p:txBody>
+          <a:bodyPr rtlCol="0" anchor="ctr" wrap="square" lIns="0" rIns="0" tIns="0" bIns="0"/>
+          <a:lstStyle/>
+          <a:p>
+            <a:pPr algn="ctr"/>
+          </a:p>
+        </p:txBody>
+      </p:sp>
+      <p:sp>
+        <p:nvSpPr>
+          <p:cNvPr id="14" name="TextBox 13"/>
           <p:cNvSpPr txBox="1"/>
           <p:nvPr/>
         </p:nvSpPr>
         <p:spPr>
           <a:xfrm>
-            <a:off x="685800" y="6324600"/>
-            <a:ext cx="6667500" cy="182880"/>
+            <a:off x="6648450" y="4542092"/>
+            <a:ext cx="4857750" cy="95250"/>
           </a:xfrm>
           <a:prstGeom prst="rect">
             <a:avLst/>
@@ -32308,6 +32473,45 @@
           <a:p>
             <a:pPr algn="l">
               <a:lnSpc>
+                <a:spcPct val="130000"/>
+              </a:lnSpc>
+            </a:pPr>
+            <a:r>
+              <a:rPr sz="1580" b="0" i="0">
+                <a:solidFill>
+                  <a:srgbClr val="1A1A1E"/>
+                </a:solidFill>
+                <a:latin typeface="Roboto"/>
+              </a:rPr>
+              <a:t>São essas duas definições que decidem o desenho do item #60, com a imagem entrando como artefato e o container como nó.</a:t>
+            </a:r>
+          </a:p>
+        </p:txBody>
+      </p:sp>
+      <p:sp>
+        <p:nvSpPr>
+          <p:cNvPr id="15" name="TextBox 14"/>
+          <p:cNvSpPr txBox="1"/>
+          <p:nvPr/>
+        </p:nvSpPr>
+        <p:spPr>
+          <a:xfrm>
+            <a:off x="685800" y="6324600"/>
+            <a:ext cx="6667500" cy="182880"/>
+          </a:xfrm>
+          <a:prstGeom prst="rect">
+            <a:avLst/>
+          </a:prstGeom>
+          <a:noFill/>
+        </p:spPr>
+        <p:txBody>
+          <a:bodyPr wrap="square" lIns="0" rIns="0" tIns="0" bIns="0" anchor="t">
+            <a:spAutoFit/>
+          </a:bodyPr>
+          <a:lstStyle/>
+          <a:p>
+            <a:pPr algn="l">
+              <a:lnSpc>
                 <a:spcPct val="120000"/>
               </a:lnSpc>
             </a:pPr>
@@ -32325,7 +32529,7 @@
       </p:sp>
       <p:sp>
         <p:nvSpPr>
-          <p:cNvPr id="14" name="TextBox 13"/>
+          <p:cNvPr id="16" name="TextBox 15"/>
           <p:cNvSpPr txBox="1"/>
           <p:nvPr/>
         </p:nvSpPr>
@@ -32514,7 +32718,7 @@
         </p:nvSpPr>
         <p:spPr>
           <a:xfrm>
-            <a:off x="685800" y="2177415"/>
+            <a:off x="685800" y="2083118"/>
             <a:ext cx="10820400" cy="3286125"/>
           </a:xfrm>
           <a:prstGeom prst="roundRect">
@@ -32560,7 +32764,7 @@
         </p:nvSpPr>
         <p:spPr>
           <a:xfrm>
-            <a:off x="952500" y="2386965"/>
+            <a:off x="952500" y="2292668"/>
             <a:ext cx="323850" cy="28575"/>
           </a:xfrm>
           <a:prstGeom prst="roundRect">
@@ -32606,7 +32810,7 @@
         </p:nvSpPr>
         <p:spPr>
           <a:xfrm>
-            <a:off x="1371600" y="2329815"/>
+            <a:off x="1371600" y="2235518"/>
             <a:ext cx="1905000" cy="167640"/>
           </a:xfrm>
           <a:prstGeom prst="rect">
@@ -32645,7 +32849,7 @@
         </p:nvSpPr>
         <p:spPr>
           <a:xfrm>
-            <a:off x="952500" y="2672715"/>
+            <a:off x="952500" y="2578418"/>
             <a:ext cx="10287000" cy="228600"/>
           </a:xfrm>
           <a:prstGeom prst="rect">
@@ -32684,7 +32888,7 @@
         </p:nvSpPr>
         <p:spPr>
           <a:xfrm>
-            <a:off x="952500" y="2910840"/>
+            <a:off x="952500" y="2816542"/>
             <a:ext cx="10287000" cy="228600"/>
           </a:xfrm>
           <a:prstGeom prst="rect">
@@ -32723,7 +32927,7 @@
         </p:nvSpPr>
         <p:spPr>
           <a:xfrm>
-            <a:off x="952500" y="3148965"/>
+            <a:off x="952500" y="3054668"/>
             <a:ext cx="10287000" cy="228600"/>
           </a:xfrm>
           <a:prstGeom prst="rect">
@@ -32762,7 +32966,7 @@
         </p:nvSpPr>
         <p:spPr>
           <a:xfrm>
-            <a:off x="952500" y="3387090"/>
+            <a:off x="952500" y="3292792"/>
             <a:ext cx="10287000" cy="228600"/>
           </a:xfrm>
           <a:prstGeom prst="rect">
@@ -32801,7 +33005,7 @@
         </p:nvSpPr>
         <p:spPr>
           <a:xfrm>
-            <a:off x="952500" y="3625215"/>
+            <a:off x="952500" y="3530918"/>
             <a:ext cx="10287000" cy="228600"/>
           </a:xfrm>
           <a:prstGeom prst="rect">
@@ -32840,7 +33044,7 @@
         </p:nvSpPr>
         <p:spPr>
           <a:xfrm>
-            <a:off x="952500" y="3863340"/>
+            <a:off x="952500" y="3769042"/>
             <a:ext cx="10287000" cy="228600"/>
           </a:xfrm>
           <a:prstGeom prst="rect">
@@ -32879,7 +33083,7 @@
         </p:nvSpPr>
         <p:spPr>
           <a:xfrm>
-            <a:off x="952500" y="4101465"/>
+            <a:off x="952500" y="4007168"/>
             <a:ext cx="10287000" cy="228600"/>
           </a:xfrm>
           <a:prstGeom prst="rect">
@@ -32918,7 +33122,7 @@
         </p:nvSpPr>
         <p:spPr>
           <a:xfrm>
-            <a:off x="952500" y="4339590"/>
+            <a:off x="952500" y="4245292"/>
             <a:ext cx="10287000" cy="228600"/>
           </a:xfrm>
           <a:prstGeom prst="rect">
@@ -32957,7 +33161,7 @@
         </p:nvSpPr>
         <p:spPr>
           <a:xfrm>
-            <a:off x="952500" y="4577715"/>
+            <a:off x="952500" y="4483418"/>
             <a:ext cx="10287000" cy="228600"/>
           </a:xfrm>
           <a:prstGeom prst="rect">
@@ -32996,7 +33200,7 @@
         </p:nvSpPr>
         <p:spPr>
           <a:xfrm>
-            <a:off x="952500" y="4815840"/>
+            <a:off x="952500" y="4721542"/>
             <a:ext cx="10287000" cy="228600"/>
           </a:xfrm>
           <a:prstGeom prst="rect">
@@ -33035,7 +33239,7 @@
         </p:nvSpPr>
         <p:spPr>
           <a:xfrm>
-            <a:off x="952500" y="5053965"/>
+            <a:off x="952500" y="4959668"/>
             <a:ext cx="10287000" cy="228600"/>
           </a:xfrm>
           <a:prstGeom prst="rect">
@@ -33074,8 +33278,8 @@
         </p:nvSpPr>
         <p:spPr>
           <a:xfrm>
-            <a:off x="685800" y="5692140"/>
-            <a:ext cx="28575" cy="188595"/>
+            <a:off x="685800" y="5597842"/>
+            <a:ext cx="28575" cy="377190"/>
           </a:xfrm>
           <a:prstGeom prst="rect">
             <a:avLst/>
@@ -33118,7 +33322,7 @@
         </p:nvSpPr>
         <p:spPr>
           <a:xfrm>
-            <a:off x="876300" y="5673090"/>
+            <a:off x="876300" y="5578792"/>
             <a:ext cx="10629900" cy="666750"/>
           </a:xfrm>
           <a:prstGeom prst="rect">
@@ -33144,7 +33348,7 @@
                 </a:solidFill>
                 <a:latin typeface="Roboto"/>
               </a:rPr>
-              <a:t>Saída da distro docker-desktop do WSL. O mesmo processo tem PID 1 dentro do container e outro PID no host, que é o que o namespace de PID faz.</a:t>
+              <a:t>Saída da distro docker-desktop do WSL. O mesmo processo tem PID 1 dentro do container e outro PID no host, que é o que o namespace de PID faz. É por isso que no nosso diagrama de implantação o container aparece dentro do host, e não como máquina separada.</a:t>
             </a:r>
           </a:p>
         </p:txBody>
@@ -33379,7 +33583,7 @@
         </p:nvSpPr>
         <p:spPr>
           <a:xfrm>
-            <a:off x="685800" y="2458593"/>
+            <a:off x="685800" y="2061210"/>
             <a:ext cx="5143500" cy="182880"/>
           </a:xfrm>
           <a:prstGeom prst="rect">
@@ -33418,7 +33622,7 @@
         </p:nvSpPr>
         <p:spPr>
           <a:xfrm>
-            <a:off x="685800" y="2668143"/>
+            <a:off x="685800" y="2270760"/>
             <a:ext cx="419100" cy="28575"/>
           </a:xfrm>
           <a:prstGeom prst="rect">
@@ -33462,7 +33666,7 @@
         </p:nvSpPr>
         <p:spPr>
           <a:xfrm>
-            <a:off x="704850" y="3057906"/>
+            <a:off x="704850" y="2660523"/>
             <a:ext cx="57150" cy="57150"/>
           </a:xfrm>
           <a:prstGeom prst="rect">
@@ -33506,7 +33710,7 @@
         </p:nvSpPr>
         <p:spPr>
           <a:xfrm>
-            <a:off x="971550" y="2953893"/>
+            <a:off x="971550" y="2556510"/>
             <a:ext cx="4857750" cy="95250"/>
           </a:xfrm>
           <a:prstGeom prst="rect">
@@ -33545,7 +33749,7 @@
         </p:nvSpPr>
         <p:spPr>
           <a:xfrm>
-            <a:off x="704850" y="3852672"/>
+            <a:off x="704850" y="3455289"/>
             <a:ext cx="57150" cy="57150"/>
           </a:xfrm>
           <a:prstGeom prst="rect">
@@ -33589,7 +33793,7 @@
         </p:nvSpPr>
         <p:spPr>
           <a:xfrm>
-            <a:off x="971550" y="3748659"/>
+            <a:off x="971550" y="3351276"/>
             <a:ext cx="4857750" cy="95250"/>
           </a:xfrm>
           <a:prstGeom prst="rect">
@@ -33628,7 +33832,7 @@
         </p:nvSpPr>
         <p:spPr>
           <a:xfrm>
-            <a:off x="704850" y="4647438"/>
+            <a:off x="704850" y="4250055"/>
             <a:ext cx="57150" cy="57150"/>
           </a:xfrm>
           <a:prstGeom prst="rect">
@@ -33672,7 +33876,7 @@
         </p:nvSpPr>
         <p:spPr>
           <a:xfrm>
-            <a:off x="971550" y="4543425"/>
+            <a:off x="971550" y="4146042"/>
             <a:ext cx="4857750" cy="95250"/>
           </a:xfrm>
           <a:prstGeom prst="rect">
@@ -33705,53 +33909,14 @@
       </p:sp>
       <p:sp>
         <p:nvSpPr>
-          <p:cNvPr id="13" name="TextBox 12"/>
-          <p:cNvSpPr txBox="1"/>
-          <p:nvPr/>
-        </p:nvSpPr>
-        <p:spPr>
-          <a:xfrm>
-            <a:off x="6362700" y="2458593"/>
-            <a:ext cx="5143500" cy="182880"/>
-          </a:xfrm>
-          <a:prstGeom prst="rect">
-            <a:avLst/>
-          </a:prstGeom>
-          <a:noFill/>
-        </p:spPr>
-        <p:txBody>
-          <a:bodyPr wrap="square" lIns="0" rIns="0" tIns="0" bIns="0" anchor="t">
-            <a:spAutoFit/>
-          </a:bodyPr>
-          <a:lstStyle/>
-          <a:p>
-            <a:pPr algn="l">
-              <a:lnSpc>
-                <a:spcPct val="120000"/>
-              </a:lnSpc>
-            </a:pPr>
-            <a:r>
-              <a:rPr sz="900" b="1" i="0" spc="120">
-                <a:solidFill>
-                  <a:srgbClr val="E94D1C"/>
-                </a:solidFill>
-                <a:latin typeface="Roboto"/>
-              </a:rPr>
-              <a:t>CGROUPS V2</a:t>
-            </a:r>
-          </a:p>
-        </p:txBody>
-      </p:sp>
-      <p:sp>
-        <p:nvSpPr>
-          <p:cNvPr id="14" name="Rectangle 13"/>
+          <p:cNvPr id="13" name="Rectangle 12"/>
           <p:cNvSpPr/>
           <p:nvPr/>
         </p:nvSpPr>
         <p:spPr>
           <a:xfrm>
-            <a:off x="6362700" y="2668143"/>
-            <a:ext cx="419100" cy="28575"/>
+            <a:off x="704850" y="5308854"/>
+            <a:ext cx="57150" cy="57150"/>
           </a:xfrm>
           <a:prstGeom prst="rect">
             <a:avLst/>
@@ -33788,14 +33953,92 @@
       </p:sp>
       <p:sp>
         <p:nvSpPr>
-          <p:cNvPr id="15" name="Rectangle 14"/>
+          <p:cNvPr id="14" name="TextBox 13"/>
+          <p:cNvSpPr txBox="1"/>
+          <p:nvPr/>
+        </p:nvSpPr>
+        <p:spPr>
+          <a:xfrm>
+            <a:off x="971550" y="5204841"/>
+            <a:ext cx="4857750" cy="95250"/>
+          </a:xfrm>
+          <a:prstGeom prst="rect">
+            <a:avLst/>
+          </a:prstGeom>
+          <a:noFill/>
+        </p:spPr>
+        <p:txBody>
+          <a:bodyPr wrap="square" lIns="0" rIns="0" tIns="0" bIns="0" anchor="t">
+            <a:spAutoFit/>
+          </a:bodyPr>
+          <a:lstStyle/>
+          <a:p>
+            <a:pPr algn="l">
+              <a:lnSpc>
+                <a:spcPct val="130000"/>
+              </a:lnSpc>
+            </a:pPr>
+            <a:r>
+              <a:rPr sz="1580" b="0" i="0">
+                <a:solidFill>
+                  <a:srgbClr val="1A1A1E"/>
+                </a:solidFill>
+                <a:latin typeface="Roboto"/>
+              </a:rPr>
+              <a:t>Esse é o mecanismo que permite o front, a API e o banco do projeto rodarem no mesmo host sem conflito de porta.</a:t>
+            </a:r>
+          </a:p>
+        </p:txBody>
+      </p:sp>
+      <p:sp>
+        <p:nvSpPr>
+          <p:cNvPr id="15" name="TextBox 14"/>
+          <p:cNvSpPr txBox="1"/>
+          <p:nvPr/>
+        </p:nvSpPr>
+        <p:spPr>
+          <a:xfrm>
+            <a:off x="6362700" y="2061210"/>
+            <a:ext cx="5143500" cy="182880"/>
+          </a:xfrm>
+          <a:prstGeom prst="rect">
+            <a:avLst/>
+          </a:prstGeom>
+          <a:noFill/>
+        </p:spPr>
+        <p:txBody>
+          <a:bodyPr wrap="square" lIns="0" rIns="0" tIns="0" bIns="0" anchor="t">
+            <a:spAutoFit/>
+          </a:bodyPr>
+          <a:lstStyle/>
+          <a:p>
+            <a:pPr algn="l">
+              <a:lnSpc>
+                <a:spcPct val="120000"/>
+              </a:lnSpc>
+            </a:pPr>
+            <a:r>
+              <a:rPr sz="900" b="1" i="0" spc="120">
+                <a:solidFill>
+                  <a:srgbClr val="E94D1C"/>
+                </a:solidFill>
+                <a:latin typeface="Roboto"/>
+              </a:rPr>
+              <a:t>CGROUPS V2</a:t>
+            </a:r>
+          </a:p>
+        </p:txBody>
+      </p:sp>
+      <p:sp>
+        <p:nvSpPr>
+          <p:cNvPr id="16" name="Rectangle 15"/>
           <p:cNvSpPr/>
           <p:nvPr/>
         </p:nvSpPr>
         <p:spPr>
           <a:xfrm>
-            <a:off x="6381750" y="3057906"/>
-            <a:ext cx="57150" cy="57150"/>
+            <a:off x="6362700" y="2270760"/>
+            <a:ext cx="419100" cy="28575"/>
           </a:xfrm>
           <a:prstGeom prst="rect">
             <a:avLst/>
@@ -33832,52 +34075,13 @@
       </p:sp>
       <p:sp>
         <p:nvSpPr>
-          <p:cNvPr id="16" name="TextBox 15"/>
-          <p:cNvSpPr txBox="1"/>
-          <p:nvPr/>
-        </p:nvSpPr>
-        <p:spPr>
-          <a:xfrm>
-            <a:off x="6648450" y="2953893"/>
-            <a:ext cx="4857750" cy="95250"/>
-          </a:xfrm>
-          <a:prstGeom prst="rect">
-            <a:avLst/>
-          </a:prstGeom>
-          <a:noFill/>
-        </p:spPr>
-        <p:txBody>
-          <a:bodyPr wrap="square" lIns="0" rIns="0" tIns="0" bIns="0" anchor="t">
-            <a:spAutoFit/>
-          </a:bodyPr>
-          <a:lstStyle/>
-          <a:p>
-            <a:pPr algn="l">
-              <a:lnSpc>
-                <a:spcPct val="130000"/>
-              </a:lnSpc>
-            </a:pPr>
-            <a:r>
-              <a:rPr sz="1580" b="0" i="0">
-                <a:solidFill>
-                  <a:srgbClr val="1A1A1E"/>
-                </a:solidFill>
-                <a:latin typeface="Roboto"/>
-              </a:rPr>
-              <a:t>Os cgroups não isolam nada, eles contabilizam e limitam o consumo de recursos.</a:t>
-            </a:r>
-          </a:p>
-        </p:txBody>
-      </p:sp>
-      <p:sp>
-        <p:nvSpPr>
           <p:cNvPr id="17" name="Rectangle 16"/>
           <p:cNvSpPr/>
           <p:nvPr/>
         </p:nvSpPr>
         <p:spPr>
           <a:xfrm>
-            <a:off x="6381750" y="3852672"/>
+            <a:off x="6381750" y="2660523"/>
             <a:ext cx="57150" cy="57150"/>
           </a:xfrm>
           <a:prstGeom prst="rect">
@@ -33921,7 +34125,7 @@
         </p:nvSpPr>
         <p:spPr>
           <a:xfrm>
-            <a:off x="6648450" y="3748659"/>
+            <a:off x="6648450" y="2556510"/>
             <a:ext cx="4857750" cy="95250"/>
           </a:xfrm>
           <a:prstGeom prst="rect">
@@ -33947,7 +34151,7 @@
                 </a:solidFill>
                 <a:latin typeface="Roboto"/>
               </a:rPr>
-              <a:t>Quando o processo estoura o limite de memória ele não fica lento, o kernel mata ele.</a:t>
+              <a:t>Os cgroups não isolam nada, eles contabilizam e limitam o consumo de recursos.</a:t>
             </a:r>
           </a:p>
         </p:txBody>
@@ -33960,7 +34164,7 @@
         </p:nvSpPr>
         <p:spPr>
           <a:xfrm>
-            <a:off x="6381750" y="4647438"/>
+            <a:off x="6381750" y="3455289"/>
             <a:ext cx="57150" cy="57150"/>
           </a:xfrm>
           <a:prstGeom prst="rect">
@@ -34004,7 +34208,7 @@
         </p:nvSpPr>
         <p:spPr>
           <a:xfrm>
-            <a:off x="6648450" y="4543425"/>
+            <a:off x="6648450" y="3351276"/>
             <a:ext cx="4857750" cy="95250"/>
           </a:xfrm>
           <a:prstGeom prst="rect">
@@ -34030,21 +34234,65 @@
                 </a:solidFill>
                 <a:latin typeface="Roboto"/>
               </a:rPr>
-              <a:t>O limite de CPU não mata, ele freia o processo, o que piora as requisições mais lentas e quase não mexe na média, por isso é mais difícil de perceber.</a:t>
-            </a:r>
-          </a:p>
-        </p:txBody>
-      </p:sp>
-      <p:sp>
-        <p:nvSpPr>
-          <p:cNvPr id="21" name="TextBox 20"/>
+              <a:t>Quando o processo estoura o limite de memória ele não fica lento, o kernel mata ele.</a:t>
+            </a:r>
+          </a:p>
+        </p:txBody>
+      </p:sp>
+      <p:sp>
+        <p:nvSpPr>
+          <p:cNvPr id="21" name="Rectangle 20"/>
+          <p:cNvSpPr/>
+          <p:nvPr/>
+        </p:nvSpPr>
+        <p:spPr>
+          <a:xfrm>
+            <a:off x="6381750" y="4250055"/>
+            <a:ext cx="57150" cy="57150"/>
+          </a:xfrm>
+          <a:prstGeom prst="rect">
+            <a:avLst/>
+          </a:prstGeom>
+          <a:solidFill>
+            <a:srgbClr val="E94D1C"/>
+          </a:solidFill>
+          <a:ln>
+            <a:noFill/>
+          </a:ln>
+          <a:effectLst/>
+        </p:spPr>
+        <p:style>
+          <a:lnRef idx="1">
+            <a:schemeClr val="accent1"/>
+          </a:lnRef>
+          <a:fillRef idx="3">
+            <a:schemeClr val="accent1"/>
+          </a:fillRef>
+          <a:effectRef idx="2">
+            <a:schemeClr val="accent1"/>
+          </a:effectRef>
+          <a:fontRef idx="minor">
+            <a:schemeClr val="lt1"/>
+          </a:fontRef>
+        </p:style>
+        <p:txBody>
+          <a:bodyPr rtlCol="0" anchor="ctr" wrap="square" lIns="0" rIns="0" tIns="0" bIns="0"/>
+          <a:lstStyle/>
+          <a:p>
+            <a:pPr algn="ctr"/>
+          </a:p>
+        </p:txBody>
+      </p:sp>
+      <p:sp>
+        <p:nvSpPr>
+          <p:cNvPr id="22" name="TextBox 21"/>
           <p:cNvSpPr txBox="1"/>
           <p:nvPr/>
         </p:nvSpPr>
         <p:spPr>
           <a:xfrm>
-            <a:off x="685800" y="6324600"/>
-            <a:ext cx="6667500" cy="182880"/>
+            <a:off x="6648450" y="4146042"/>
+            <a:ext cx="4857750" cy="95250"/>
           </a:xfrm>
           <a:prstGeom prst="rect">
             <a:avLst/>
@@ -34059,6 +34307,45 @@
           <a:p>
             <a:pPr algn="l">
               <a:lnSpc>
+                <a:spcPct val="130000"/>
+              </a:lnSpc>
+            </a:pPr>
+            <a:r>
+              <a:rPr sz="1580" b="0" i="0">
+                <a:solidFill>
+                  <a:srgbClr val="1A1A1E"/>
+                </a:solidFill>
+                <a:latin typeface="Roboto"/>
+              </a:rPr>
+              <a:t>O limite de CPU não mata, ele freia o processo, o que piora as requisições mais lentas e quase não mexe na média, por isso é mais difícil de perceber.</a:t>
+            </a:r>
+          </a:p>
+        </p:txBody>
+      </p:sp>
+      <p:sp>
+        <p:nvSpPr>
+          <p:cNvPr id="23" name="TextBox 22"/>
+          <p:cNvSpPr txBox="1"/>
+          <p:nvPr/>
+        </p:nvSpPr>
+        <p:spPr>
+          <a:xfrm>
+            <a:off x="685800" y="6324600"/>
+            <a:ext cx="6667500" cy="182880"/>
+          </a:xfrm>
+          <a:prstGeom prst="rect">
+            <a:avLst/>
+          </a:prstGeom>
+          <a:noFill/>
+        </p:spPr>
+        <p:txBody>
+          <a:bodyPr wrap="square" lIns="0" rIns="0" tIns="0" bIns="0" anchor="t">
+            <a:spAutoFit/>
+          </a:bodyPr>
+          <a:lstStyle/>
+          <a:p>
+            <a:pPr algn="l">
+              <a:lnSpc>
                 <a:spcPct val="120000"/>
               </a:lnSpc>
             </a:pPr>
@@ -34076,7 +34363,7 @@
       </p:sp>
       <p:sp>
         <p:nvSpPr>
-          <p:cNvPr id="22" name="TextBox 21"/>
+          <p:cNvPr id="24" name="TextBox 23"/>
           <p:cNvSpPr txBox="1"/>
           <p:nvPr/>
         </p:nvSpPr>
@@ -36223,7 +36510,7 @@
                 </a:solidFill>
                 <a:latin typeface="Roboto"/>
               </a:rPr>
-              <a:t>O runc cria os namespaces, configura cgroups, aplica capabilities e seccomp, faz pivot_root, dá execve e sai.</a:t>
+              <a:t>Cada peça tem uma responsabilidade e pode ser trocada. É a substituibilidade da Aula 05, aplicada ao próprio Docker.</a:t>
             </a:r>
           </a:p>
         </p:txBody>

</xml_diff>

<commit_message>
docs: reescreve a nota do slide 2 sem termos que so aparecem no bloco 02
</commit_message>
<xml_diff>
--- a/trabalhos/T1-Docker-Invite-People.pptx
+++ b/trabalhos/T1-Docker-Invite-People.pptx
@@ -20923,7 +20923,7 @@
         </p:nvSpPr>
         <p:spPr>
           <a:xfrm>
-            <a:off x="704850" y="2583942"/>
+            <a:off x="704850" y="2445639"/>
             <a:ext cx="57150" cy="57150"/>
           </a:xfrm>
           <a:prstGeom prst="rect">
@@ -20967,7 +20967,7 @@
         </p:nvSpPr>
         <p:spPr>
           <a:xfrm>
-            <a:off x="971550" y="2474976"/>
+            <a:off x="971550" y="2336673"/>
             <a:ext cx="7677150" cy="95250"/>
           </a:xfrm>
           <a:prstGeom prst="rect">
@@ -21006,7 +21006,7 @@
         </p:nvSpPr>
         <p:spPr>
           <a:xfrm>
-            <a:off x="704850" y="3422904"/>
+            <a:off x="704850" y="3284601"/>
             <a:ext cx="57150" cy="57150"/>
           </a:xfrm>
           <a:prstGeom prst="rect">
@@ -21050,7 +21050,7 @@
         </p:nvSpPr>
         <p:spPr>
           <a:xfrm>
-            <a:off x="971550" y="3313938"/>
+            <a:off x="971550" y="3175635"/>
             <a:ext cx="7677150" cy="95250"/>
           </a:xfrm>
           <a:prstGeom prst="rect">
@@ -21089,7 +21089,7 @@
         </p:nvSpPr>
         <p:spPr>
           <a:xfrm>
-            <a:off x="704850" y="4261866"/>
+            <a:off x="704850" y="4123563"/>
             <a:ext cx="57150" cy="57150"/>
           </a:xfrm>
           <a:prstGeom prst="rect">
@@ -21133,7 +21133,7 @@
         </p:nvSpPr>
         <p:spPr>
           <a:xfrm>
-            <a:off x="971550" y="4152900"/>
+            <a:off x="971550" y="4014597"/>
             <a:ext cx="7677150" cy="95250"/>
           </a:xfrm>
           <a:prstGeom prst="rect">
@@ -21172,7 +21172,7 @@
         </p:nvSpPr>
         <p:spPr>
           <a:xfrm>
-            <a:off x="704850" y="5100828"/>
+            <a:off x="704850" y="4962525"/>
             <a:ext cx="57150" cy="57150"/>
           </a:xfrm>
           <a:prstGeom prst="rect">
@@ -21216,7 +21216,7 @@
         </p:nvSpPr>
         <p:spPr>
           <a:xfrm>
-            <a:off x="971550" y="4991862"/>
+            <a:off x="971550" y="4853559"/>
             <a:ext cx="7677150" cy="95250"/>
           </a:xfrm>
           <a:prstGeom prst="rect">
@@ -21242,7 +21242,7 @@
                 </a:solidFill>
                 <a:latin typeface="Roboto"/>
               </a:rPr>
-              <a:t>A Questão Norteadora da Sprint 2 pergunta como os componentes serão distribuídos e implantados no ambiente de execução.</a:t>
+              <a:t>A Questão Norteadora da Sprint 2, que é a pergunta que a sprint precisa responder, é como os componentes serão distribuídos e implantados no ambiente de execução.</a:t>
             </a:r>
           </a:p>
         </p:txBody>
@@ -21255,7 +21255,7 @@
         </p:nvSpPr>
         <p:spPr>
           <a:xfrm>
-            <a:off x="9124950" y="2474976"/>
+            <a:off x="9124950" y="2336673"/>
             <a:ext cx="142875" cy="142875"/>
           </a:xfrm>
           <a:prstGeom prst="donut">
@@ -21299,7 +21299,7 @@
         </p:nvSpPr>
         <p:spPr>
           <a:xfrm>
-            <a:off x="9372600" y="2484501"/>
+            <a:off x="9372600" y="2346198"/>
             <a:ext cx="2133600" cy="182880"/>
           </a:xfrm>
           <a:prstGeom prst="rect">
@@ -21338,8 +21338,8 @@
         </p:nvSpPr>
         <p:spPr>
           <a:xfrm>
-            <a:off x="9124950" y="2760726"/>
-            <a:ext cx="38100" cy="832104"/>
+            <a:off x="9124950" y="2622423"/>
+            <a:ext cx="38100" cy="1033272"/>
           </a:xfrm>
           <a:prstGeom prst="rect">
             <a:avLst/>
@@ -21382,8 +21382,8 @@
         </p:nvSpPr>
         <p:spPr>
           <a:xfrm>
-            <a:off x="9334500" y="2760726"/>
-            <a:ext cx="2171700" cy="1403604"/>
+            <a:off x="9334500" y="2622423"/>
+            <a:ext cx="2171700" cy="1604772"/>
           </a:xfrm>
           <a:prstGeom prst="rect">
             <a:avLst/>
@@ -21411,7 +21411,7 @@
                 </a:solidFill>
                 <a:latin typeface="Roboto"/>
               </a:rPr>
-              <a:t>Três camadas lógicas decididas.</a:t>
+              <a:t>As três camadas do back já estão decididas.</a:t>
             </a:r>
           </a:p>
           <a:p>
@@ -21449,7 +21449,7 @@
                 </a:solidFill>
                 <a:latin typeface="Roboto"/>
               </a:rPr>
-              <a:t>Nenhuma separação física decidida.</a:t>
+              <a:t>Falta decidir em quantos processos separados elas vão rodar.</a:t>
             </a:r>
           </a:p>
         </p:txBody>

</xml_diff>

<commit_message>
docs: padroniza front-end e back-end no deck e no roteiro do T1
</commit_message>
<xml_diff>
--- a/trabalhos/T1-Docker-Invite-People.pptx
+++ b/trabalhos/T1-Docker-Invite-People.pptx
@@ -13693,7 +13693,7 @@
                 </a:solidFill>
                 <a:latin typeface="Roboto"/>
               </a:rPr>
-              <a:t>AS TRÊS CAMADAS LÓGICAS FICAM SEMPRE NA MESMA IMAGEM. O QUE MUDA É ONDE FRONT E BANCO RODAM.</a:t>
+              <a:t>AS TRÊS CAMADAS LÓGICAS FICAM SEMPRE NA MESMA IMAGEM. O QUE MUDA É ONDE O FRONT-END E O BANCO RODAM.</a:t>
             </a:r>
           </a:p>
         </p:txBody>
@@ -13829,7 +13829,7 @@
                 </a:solidFill>
                 <a:latin typeface="Roboto"/>
               </a:rPr>
-              <a:t>front</a:t>
+              <a:t>front-end</a:t>
             </a:r>
           </a:p>
         </p:txBody>
@@ -14295,7 +14295,7 @@
                 </a:solidFill>
                 <a:latin typeface="Roboto"/>
               </a:rPr>
-              <a:t>front</a:t>
+              <a:t>front-end</a:t>
             </a:r>
           </a:p>
         </p:txBody>
@@ -14674,7 +14674,7 @@
                 </a:solidFill>
                 <a:latin typeface="Roboto"/>
               </a:rPr>
-              <a:t>front separado</a:t>
+              <a:t>front-end separado</a:t>
             </a:r>
           </a:p>
         </p:txBody>
@@ -14810,7 +14810,7 @@
                 </a:solidFill>
                 <a:latin typeface="Roboto"/>
               </a:rPr>
-              <a:t>front</a:t>
+              <a:t>front-end</a:t>
             </a:r>
           </a:p>
         </p:txBody>
@@ -17167,7 +17167,7 @@
                 </a:solidFill>
                 <a:latin typeface="Roboto"/>
               </a:rPr>
-              <a:t>front</a:t>
+              <a:t>front-end</a:t>
             </a:r>
           </a:p>
         </p:txBody>
@@ -19107,7 +19107,7 @@
                 </a:solidFill>
                 <a:latin typeface="Roboto"/>
               </a:rPr>
-              <a:t>O código do front não está na imagem da API, então a API não depende dele nem por acidente.</a:t>
+              <a:t>O código do front-end não está na imagem da API, então a API não depende dele nem por acidente.</a:t>
             </a:r>
           </a:p>
         </p:txBody>
@@ -20162,7 +20162,7 @@
                 </a:solidFill>
                 <a:latin typeface="Roboto"/>
               </a:rPr>
-              <a:t>Mesma imagem de front ou imagens separadas?</a:t>
+              <a:t>Mesma imagem de front-end ou imagens separadas?</a:t>
             </a:r>
           </a:p>
           <a:p>
@@ -21159,7 +21159,7 @@
                 </a:solidFill>
                 <a:latin typeface="Roboto"/>
               </a:rPr>
-              <a:t>A arquitetura já está registrada no Guia da Arquitetura, com MVC no front e três camadas no back.</a:t>
+              <a:t>A arquitetura já está registrada no Guia da Arquitetura, com MVC no front-end e três camadas no back-end.</a:t>
             </a:r>
           </a:p>
         </p:txBody>
@@ -21411,7 +21411,7 @@
                 </a:solidFill>
                 <a:latin typeface="Roboto"/>
               </a:rPr>
-              <a:t>As três camadas do back já estão decididas.</a:t>
+              <a:t>As três camadas do back-end já estão decididas.</a:t>
             </a:r>
           </a:p>
           <a:p>
@@ -33985,7 +33985,7 @@
                 </a:solidFill>
                 <a:latin typeface="Roboto"/>
               </a:rPr>
-              <a:t>Esse é o mecanismo que permite o front, a API e o banco do projeto rodarem no mesmo host sem conflito de porta.</a:t>
+              <a:t>Esse é o mecanismo que permite o front-end, a API e o banco do projeto rodarem no mesmo host sem conflito de porta.</a:t>
             </a:r>
           </a:p>
         </p:txBody>

</xml_diff>

<commit_message>
docs: tira dos slides do T1 o nome do apresentador e a duracao de cada bloco
</commit_message>
<xml_diff>
--- a/trabalhos/T1-Docker-Invite-People.pptx
+++ b/trabalhos/T1-Docker-Invite-People.pptx
@@ -13278,58 +13278,14 @@
       </p:sp>
       <p:sp>
         <p:nvSpPr>
-          <p:cNvPr id="8" name="Rectangle 7"/>
-          <p:cNvSpPr/>
-          <p:nvPr/>
-        </p:nvSpPr>
-        <p:spPr>
-          <a:xfrm>
-            <a:off x="914400" y="2895600"/>
-            <a:ext cx="38100" cy="171450"/>
-          </a:xfrm>
-          <a:prstGeom prst="rect">
-            <a:avLst/>
-          </a:prstGeom>
-          <a:solidFill>
-            <a:srgbClr val="E94D1C"/>
-          </a:solidFill>
-          <a:ln>
-            <a:noFill/>
-          </a:ln>
-          <a:effectLst/>
-        </p:spPr>
-        <p:style>
-          <a:lnRef idx="1">
-            <a:schemeClr val="accent1"/>
-          </a:lnRef>
-          <a:fillRef idx="3">
-            <a:schemeClr val="accent1"/>
-          </a:fillRef>
-          <a:effectRef idx="2">
-            <a:schemeClr val="accent1"/>
-          </a:effectRef>
-          <a:fontRef idx="minor">
-            <a:schemeClr val="lt1"/>
-          </a:fontRef>
-        </p:style>
-        <p:txBody>
-          <a:bodyPr rtlCol="0" anchor="ctr" wrap="square" lIns="0" rIns="0" tIns="0" bIns="0"/>
-          <a:lstStyle/>
-          <a:p>
-            <a:pPr algn="ctr"/>
-          </a:p>
-        </p:txBody>
-      </p:sp>
-      <p:sp>
-        <p:nvSpPr>
-          <p:cNvPr id="9" name="TextBox 8"/>
+          <p:cNvPr id="8" name="TextBox 7"/>
           <p:cNvSpPr txBox="1"/>
           <p:nvPr/>
         </p:nvSpPr>
         <p:spPr>
           <a:xfrm>
-            <a:off x="1066800" y="2857500"/>
-            <a:ext cx="6667500" cy="228600"/>
+            <a:off x="914400" y="3105150"/>
+            <a:ext cx="8191500" cy="1428750"/>
           </a:xfrm>
           <a:prstGeom prst="rect">
             <a:avLst/>
@@ -13344,31 +13300,31 @@
           <a:p>
             <a:pPr algn="l">
               <a:lnSpc>
-                <a:spcPct val="120000"/>
-              </a:lnSpc>
-            </a:pPr>
-            <a:r>
-              <a:rPr sz="1120" b="1" i="0" spc="160">
+                <a:spcPct val="105000"/>
+              </a:lnSpc>
+            </a:pPr>
+            <a:r>
+              <a:rPr sz="4050" b="1" i="0">
                 <a:solidFill>
                   <a:srgbClr val="FFFFFF"/>
                 </a:solidFill>
                 <a:latin typeface="Roboto"/>
               </a:rPr>
-              <a:t>GABRIEL · 6 MINUTOS</a:t>
-            </a:r>
-          </a:p>
-        </p:txBody>
-      </p:sp>
-      <p:sp>
-        <p:nvSpPr>
-          <p:cNvPr id="10" name="TextBox 9"/>
+              <a:t>Aplicação no Invite People</a:t>
+            </a:r>
+          </a:p>
+        </p:txBody>
+      </p:sp>
+      <p:sp>
+        <p:nvSpPr>
+          <p:cNvPr id="9" name="TextBox 8"/>
           <p:cNvSpPr txBox="1"/>
           <p:nvPr/>
         </p:nvSpPr>
         <p:spPr>
           <a:xfrm>
-            <a:off x="914400" y="3105150"/>
-            <a:ext cx="8191500" cy="1428750"/>
+            <a:off x="914400" y="4476750"/>
+            <a:ext cx="6858000" cy="1047750"/>
           </a:xfrm>
           <a:prstGeom prst="rect">
             <a:avLst/>
@@ -13383,31 +13339,31 @@
           <a:p>
             <a:pPr algn="l">
               <a:lnSpc>
-                <a:spcPct val="105000"/>
-              </a:lnSpc>
-            </a:pPr>
-            <a:r>
-              <a:rPr sz="4050" b="1" i="0">
-                <a:solidFill>
-                  <a:srgbClr val="FFFFFF"/>
-                </a:solidFill>
-                <a:latin typeface="Roboto"/>
-              </a:rPr>
-              <a:t>Aplicação no Invite People</a:t>
-            </a:r>
-          </a:p>
-        </p:txBody>
-      </p:sp>
-      <p:sp>
-        <p:nvSpPr>
-          <p:cNvPr id="11" name="TextBox 10"/>
+                <a:spcPct val="145000"/>
+              </a:lnSpc>
+            </a:pPr>
+            <a:r>
+              <a:rPr sz="1420" b="0" i="0">
+                <a:solidFill>
+                  <a:srgbClr val="E2DEF5"/>
+                </a:solidFill>
+                <a:latin typeface="Roboto"/>
+              </a:rPr>
+              <a:t>Mapeamento entre os diagramas da Sprint 2 e o arquivo de compose, com o número de cada task.</a:t>
+            </a:r>
+          </a:p>
+        </p:txBody>
+      </p:sp>
+      <p:sp>
+        <p:nvSpPr>
+          <p:cNvPr id="10" name="TextBox 9"/>
           <p:cNvSpPr txBox="1"/>
           <p:nvPr/>
         </p:nvSpPr>
         <p:spPr>
           <a:xfrm>
-            <a:off x="914400" y="4476750"/>
-            <a:ext cx="6858000" cy="1047750"/>
+            <a:off x="685800" y="6324600"/>
+            <a:ext cx="6667500" cy="182880"/>
           </a:xfrm>
           <a:prstGeom prst="rect">
             <a:avLst/>
@@ -13422,45 +13378,6 @@
           <a:p>
             <a:pPr algn="l">
               <a:lnSpc>
-                <a:spcPct val="145000"/>
-              </a:lnSpc>
-            </a:pPr>
-            <a:r>
-              <a:rPr sz="1420" b="0" i="0">
-                <a:solidFill>
-                  <a:srgbClr val="E2DEF5"/>
-                </a:solidFill>
-                <a:latin typeface="Roboto"/>
-              </a:rPr>
-              <a:t>Mapeamento entre os diagramas da Sprint 2 e o arquivo de compose, com o número de cada task.</a:t>
-            </a:r>
-          </a:p>
-        </p:txBody>
-      </p:sp>
-      <p:sp>
-        <p:nvSpPr>
-          <p:cNvPr id="12" name="TextBox 11"/>
-          <p:cNvSpPr txBox="1"/>
-          <p:nvPr/>
-        </p:nvSpPr>
-        <p:spPr>
-          <a:xfrm>
-            <a:off x="685800" y="6324600"/>
-            <a:ext cx="6667500" cy="182880"/>
-          </a:xfrm>
-          <a:prstGeom prst="rect">
-            <a:avLst/>
-          </a:prstGeom>
-          <a:noFill/>
-        </p:spPr>
-        <p:txBody>
-          <a:bodyPr wrap="square" lIns="0" rIns="0" tIns="0" bIns="0" anchor="t">
-            <a:spAutoFit/>
-          </a:bodyPr>
-          <a:lstStyle/>
-          <a:p>
-            <a:pPr algn="l">
-              <a:lnSpc>
                 <a:spcPct val="120000"/>
               </a:lnSpc>
             </a:pPr>
@@ -13478,7 +13395,7 @@
       </p:sp>
       <p:sp>
         <p:nvSpPr>
-          <p:cNvPr id="13" name="TextBox 12"/>
+          <p:cNvPr id="11" name="TextBox 10"/>
           <p:cNvSpPr txBox="1"/>
           <p:nvPr/>
         </p:nvSpPr>
@@ -20550,58 +20467,14 @@
       </p:sp>
       <p:sp>
         <p:nvSpPr>
-          <p:cNvPr id="8" name="Rectangle 7"/>
-          <p:cNvSpPr/>
-          <p:nvPr/>
-        </p:nvSpPr>
-        <p:spPr>
-          <a:xfrm>
-            <a:off x="914400" y="2895600"/>
-            <a:ext cx="38100" cy="171450"/>
-          </a:xfrm>
-          <a:prstGeom prst="rect">
-            <a:avLst/>
-          </a:prstGeom>
-          <a:solidFill>
-            <a:srgbClr val="E94D1C"/>
-          </a:solidFill>
-          <a:ln>
-            <a:noFill/>
-          </a:ln>
-          <a:effectLst/>
-        </p:spPr>
-        <p:style>
-          <a:lnRef idx="1">
-            <a:schemeClr val="accent1"/>
-          </a:lnRef>
-          <a:fillRef idx="3">
-            <a:schemeClr val="accent1"/>
-          </a:fillRef>
-          <a:effectRef idx="2">
-            <a:schemeClr val="accent1"/>
-          </a:effectRef>
-          <a:fontRef idx="minor">
-            <a:schemeClr val="lt1"/>
-          </a:fontRef>
-        </p:style>
-        <p:txBody>
-          <a:bodyPr rtlCol="0" anchor="ctr" wrap="square" lIns="0" rIns="0" tIns="0" bIns="0"/>
-          <a:lstStyle/>
-          <a:p>
-            <a:pPr algn="ctr"/>
-          </a:p>
-        </p:txBody>
-      </p:sp>
-      <p:sp>
-        <p:nvSpPr>
-          <p:cNvPr id="9" name="TextBox 8"/>
+          <p:cNvPr id="8" name="TextBox 7"/>
           <p:cNvSpPr txBox="1"/>
           <p:nvPr/>
         </p:nvSpPr>
         <p:spPr>
           <a:xfrm>
-            <a:off x="1066800" y="2857500"/>
-            <a:ext cx="6667500" cy="228600"/>
+            <a:off x="914400" y="3105150"/>
+            <a:ext cx="8191500" cy="1428750"/>
           </a:xfrm>
           <a:prstGeom prst="rect">
             <a:avLst/>
@@ -20616,31 +20489,31 @@
           <a:p>
             <a:pPr algn="l">
               <a:lnSpc>
-                <a:spcPct val="120000"/>
-              </a:lnSpc>
-            </a:pPr>
-            <a:r>
-              <a:rPr sz="1120" b="1" i="0" spc="160">
+                <a:spcPct val="105000"/>
+              </a:lnSpc>
+            </a:pPr>
+            <a:r>
+              <a:rPr sz="4050" b="1" i="0">
                 <a:solidFill>
                   <a:srgbClr val="FFFFFF"/>
                 </a:solidFill>
                 <a:latin typeface="Roboto"/>
               </a:rPr>
-              <a:t>ANDREAS, COM TIAGO NA SEGURANÇA · 7 MINUTOS</a:t>
-            </a:r>
-          </a:p>
-        </p:txBody>
-      </p:sp>
-      <p:sp>
-        <p:nvSpPr>
-          <p:cNvPr id="10" name="TextBox 9"/>
+              <a:t>Vantagens, desvantagens e demonstração</a:t>
+            </a:r>
+          </a:p>
+        </p:txBody>
+      </p:sp>
+      <p:sp>
+        <p:nvSpPr>
+          <p:cNvPr id="9" name="TextBox 8"/>
           <p:cNvSpPr txBox="1"/>
           <p:nvPr/>
         </p:nvSpPr>
         <p:spPr>
           <a:xfrm>
-            <a:off x="914400" y="3105150"/>
-            <a:ext cx="8191500" cy="1428750"/>
+            <a:off x="914400" y="4476750"/>
+            <a:ext cx="6858000" cy="1047750"/>
           </a:xfrm>
           <a:prstGeom prst="rect">
             <a:avLst/>
@@ -20655,31 +20528,31 @@
           <a:p>
             <a:pPr algn="l">
               <a:lnSpc>
-                <a:spcPct val="105000"/>
-              </a:lnSpc>
-            </a:pPr>
-            <a:r>
-              <a:rPr sz="4050" b="1" i="0">
-                <a:solidFill>
-                  <a:srgbClr val="FFFFFF"/>
-                </a:solidFill>
-                <a:latin typeface="Roboto"/>
-              </a:rPr>
-              <a:t>Vantagens, desvantagens e demonstração</a:t>
-            </a:r>
-          </a:p>
-        </p:txBody>
-      </p:sp>
-      <p:sp>
-        <p:nvSpPr>
-          <p:cNvPr id="11" name="TextBox 10"/>
+                <a:spcPct val="145000"/>
+              </a:lnSpc>
+            </a:pPr>
+            <a:r>
+              <a:rPr sz="1420" b="0" i="0">
+                <a:solidFill>
+                  <a:srgbClr val="E2DEF5"/>
+                </a:solidFill>
+                <a:latin typeface="Roboto"/>
+              </a:rPr>
+              <a:t>A demonstração é do ambiente e da topologia, não do produto. A implementação começa na Sprint 4.</a:t>
+            </a:r>
+          </a:p>
+        </p:txBody>
+      </p:sp>
+      <p:sp>
+        <p:nvSpPr>
+          <p:cNvPr id="10" name="TextBox 9"/>
           <p:cNvSpPr txBox="1"/>
           <p:nvPr/>
         </p:nvSpPr>
         <p:spPr>
           <a:xfrm>
-            <a:off x="914400" y="4476750"/>
-            <a:ext cx="6858000" cy="1047750"/>
+            <a:off x="685800" y="6324600"/>
+            <a:ext cx="6667500" cy="182880"/>
           </a:xfrm>
           <a:prstGeom prst="rect">
             <a:avLst/>
@@ -20694,45 +20567,6 @@
           <a:p>
             <a:pPr algn="l">
               <a:lnSpc>
-                <a:spcPct val="145000"/>
-              </a:lnSpc>
-            </a:pPr>
-            <a:r>
-              <a:rPr sz="1420" b="0" i="0">
-                <a:solidFill>
-                  <a:srgbClr val="E2DEF5"/>
-                </a:solidFill>
-                <a:latin typeface="Roboto"/>
-              </a:rPr>
-              <a:t>A demonstração é do ambiente e da topologia, não do produto. A implementação começa na Sprint 4.</a:t>
-            </a:r>
-          </a:p>
-        </p:txBody>
-      </p:sp>
-      <p:sp>
-        <p:nvSpPr>
-          <p:cNvPr id="12" name="TextBox 11"/>
-          <p:cNvSpPr txBox="1"/>
-          <p:nvPr/>
-        </p:nvSpPr>
-        <p:spPr>
-          <a:xfrm>
-            <a:off x="685800" y="6324600"/>
-            <a:ext cx="6667500" cy="182880"/>
-          </a:xfrm>
-          <a:prstGeom prst="rect">
-            <a:avLst/>
-          </a:prstGeom>
-          <a:noFill/>
-        </p:spPr>
-        <p:txBody>
-          <a:bodyPr wrap="square" lIns="0" rIns="0" tIns="0" bIns="0" anchor="t">
-            <a:spAutoFit/>
-          </a:bodyPr>
-          <a:lstStyle/>
-          <a:p>
-            <a:pPr algn="l">
-              <a:lnSpc>
                 <a:spcPct val="120000"/>
               </a:lnSpc>
             </a:pPr>
@@ -20750,7 +20584,7 @@
       </p:sp>
       <p:sp>
         <p:nvSpPr>
-          <p:cNvPr id="13" name="TextBox 12"/>
+          <p:cNvPr id="11" name="TextBox 10"/>
           <p:cNvSpPr txBox="1"/>
           <p:nvPr/>
         </p:nvSpPr>
@@ -21616,7 +21450,7 @@
                 </a:solidFill>
                 <a:latin typeface="Roboto"/>
               </a:rPr>
-              <a:t>DEMONSTRAÇÃO, 90 SEGUNDOS</a:t>
+              <a:t>DEMONSTRAÇÃO</a:t>
             </a:r>
           </a:p>
         </p:txBody>
@@ -23323,7 +23157,7 @@
                 </a:solidFill>
                 <a:latin typeface="Roboto"/>
               </a:rPr>
-              <a:t>REGRA</a:t>
+              <a:t>NO NOSSO CASO</a:t>
             </a:r>
           </a:p>
         </p:txBody>
@@ -23337,7 +23171,7 @@
         <p:spPr>
           <a:xfrm>
             <a:off x="9124950" y="2760726"/>
-            <a:ext cx="38100" cy="1636776"/>
+            <a:ext cx="38100" cy="1005840"/>
           </a:xfrm>
           <a:prstGeom prst="rect">
             <a:avLst/>
@@ -23381,7 +23215,7 @@
         <p:spPr>
           <a:xfrm>
             <a:off x="9334500" y="2760726"/>
-            <a:ext cx="2171700" cy="2208276"/>
+            <a:ext cx="2171700" cy="1577340"/>
           </a:xfrm>
           <a:prstGeom prst="rect">
             <a:avLst/>
@@ -23410,44 +23244,6 @@
                 <a:latin typeface="Roboto"/>
               </a:rPr>
               <a:t>Dos quatro, o do daemon como root é o que atinge o projeto hoje, porque os quatro integrantes rodam na própria máquina.</a:t>
-            </a:r>
-          </a:p>
-          <a:p>
-            <a:pPr>
-              <a:lnSpc>
-                <a:spcPct val="140000"/>
-              </a:lnSpc>
-              <a:spcAft>
-                <a:spcPts val="600"/>
-              </a:spcAft>
-            </a:pPr>
-            <a:r>
-              <a:rPr sz="1200" b="0" i="0">
-                <a:solidFill>
-                  <a:srgbClr val="3A3A44"/>
-                </a:solidFill>
-                <a:latin typeface="Roboto"/>
-              </a:rPr>
-              <a:t/>
-            </a:r>
-          </a:p>
-          <a:p>
-            <a:pPr>
-              <a:lnSpc>
-                <a:spcPct val="140000"/>
-              </a:lnSpc>
-              <a:spcAft>
-                <a:spcPts val="600"/>
-              </a:spcAft>
-            </a:pPr>
-            <a:r>
-              <a:rPr sz="1200" b="0" i="0">
-                <a:solidFill>
-                  <a:srgbClr val="3A3A44"/>
-                </a:solidFill>
-                <a:latin typeface="Roboto"/>
-              </a:rPr>
-              <a:t>Nenhum número de desempenho entra aqui sem medição feita pelo time.</a:t>
             </a:r>
           </a:p>
         </p:txBody>
@@ -29637,58 +29433,14 @@
       </p:sp>
       <p:sp>
         <p:nvSpPr>
-          <p:cNvPr id="8" name="Rectangle 7"/>
-          <p:cNvSpPr/>
-          <p:nvPr/>
-        </p:nvSpPr>
-        <p:spPr>
-          <a:xfrm>
-            <a:off x="914400" y="2895600"/>
-            <a:ext cx="38100" cy="171450"/>
-          </a:xfrm>
-          <a:prstGeom prst="rect">
-            <a:avLst/>
-          </a:prstGeom>
-          <a:solidFill>
-            <a:srgbClr val="E94D1C"/>
-          </a:solidFill>
-          <a:ln>
-            <a:noFill/>
-          </a:ln>
-          <a:effectLst/>
-        </p:spPr>
-        <p:style>
-          <a:lnRef idx="1">
-            <a:schemeClr val="accent1"/>
-          </a:lnRef>
-          <a:fillRef idx="3">
-            <a:schemeClr val="accent1"/>
-          </a:fillRef>
-          <a:effectRef idx="2">
-            <a:schemeClr val="accent1"/>
-          </a:effectRef>
-          <a:fontRef idx="minor">
-            <a:schemeClr val="lt1"/>
-          </a:fontRef>
-        </p:style>
-        <p:txBody>
-          <a:bodyPr rtlCol="0" anchor="ctr" wrap="square" lIns="0" rIns="0" tIns="0" bIns="0"/>
-          <a:lstStyle/>
-          <a:p>
-            <a:pPr algn="ctr"/>
-          </a:p>
-        </p:txBody>
-      </p:sp>
-      <p:sp>
-        <p:nvSpPr>
-          <p:cNvPr id="9" name="TextBox 8"/>
+          <p:cNvPr id="8" name="TextBox 7"/>
           <p:cNvSpPr txBox="1"/>
           <p:nvPr/>
         </p:nvSpPr>
         <p:spPr>
           <a:xfrm>
-            <a:off x="1066800" y="2857500"/>
-            <a:ext cx="6667500" cy="228600"/>
+            <a:off x="914400" y="3105150"/>
+            <a:ext cx="8191500" cy="1428750"/>
           </a:xfrm>
           <a:prstGeom prst="rect">
             <a:avLst/>
@@ -29703,31 +29455,31 @@
           <a:p>
             <a:pPr algn="l">
               <a:lnSpc>
-                <a:spcPct val="120000"/>
-              </a:lnSpc>
-            </a:pPr>
-            <a:r>
-              <a:rPr sz="1120" b="1" i="0" spc="160">
+                <a:spcPct val="105000"/>
+              </a:lnSpc>
+            </a:pPr>
+            <a:r>
+              <a:rPr sz="4050" b="1" i="0">
                 <a:solidFill>
                   <a:srgbClr val="FFFFFF"/>
                 </a:solidFill>
                 <a:latin typeface="Roboto"/>
               </a:rPr>
-              <a:t>TIAGO · 6 MINUTOS</a:t>
-            </a:r>
-          </a:p>
-        </p:txBody>
-      </p:sp>
-      <p:sp>
-        <p:nvSpPr>
-          <p:cNvPr id="10" name="TextBox 9"/>
+              <a:t>Definições e arquitetura</a:t>
+            </a:r>
+          </a:p>
+        </p:txBody>
+      </p:sp>
+      <p:sp>
+        <p:nvSpPr>
+          <p:cNvPr id="9" name="TextBox 8"/>
           <p:cNvSpPr txBox="1"/>
           <p:nvPr/>
         </p:nvSpPr>
         <p:spPr>
           <a:xfrm>
-            <a:off x="914400" y="3105150"/>
-            <a:ext cx="8191500" cy="1428750"/>
+            <a:off x="914400" y="4476750"/>
+            <a:ext cx="6858000" cy="1047750"/>
           </a:xfrm>
           <a:prstGeom prst="rect">
             <a:avLst/>
@@ -29742,31 +29494,31 @@
           <a:p>
             <a:pPr algn="l">
               <a:lnSpc>
-                <a:spcPct val="105000"/>
-              </a:lnSpc>
-            </a:pPr>
-            <a:r>
-              <a:rPr sz="4050" b="1" i="0">
-                <a:solidFill>
-                  <a:srgbClr val="FFFFFF"/>
-                </a:solidFill>
-                <a:latin typeface="Roboto"/>
-              </a:rPr>
-              <a:t>Definições e arquitetura</a:t>
-            </a:r>
-          </a:p>
-        </p:txBody>
-      </p:sp>
-      <p:sp>
-        <p:nvSpPr>
-          <p:cNvPr id="11" name="TextBox 10"/>
+                <a:spcPct val="145000"/>
+              </a:lnSpc>
+            </a:pPr>
+            <a:r>
+              <a:rPr sz="1420" b="0" i="0">
+                <a:solidFill>
+                  <a:srgbClr val="E2DEF5"/>
+                </a:solidFill>
+                <a:latin typeface="Roboto"/>
+              </a:rPr>
+              <a:t>Antes de decidir onde cada parte roda, o que o kernel faz quando alguém digita docker run e por que a imagem é em camadas.</a:t>
+            </a:r>
+          </a:p>
+        </p:txBody>
+      </p:sp>
+      <p:sp>
+        <p:nvSpPr>
+          <p:cNvPr id="10" name="TextBox 9"/>
           <p:cNvSpPr txBox="1"/>
           <p:nvPr/>
         </p:nvSpPr>
         <p:spPr>
           <a:xfrm>
-            <a:off x="914400" y="4476750"/>
-            <a:ext cx="6858000" cy="1047750"/>
+            <a:off x="685800" y="6324600"/>
+            <a:ext cx="6667500" cy="182880"/>
           </a:xfrm>
           <a:prstGeom prst="rect">
             <a:avLst/>
@@ -29781,45 +29533,6 @@
           <a:p>
             <a:pPr algn="l">
               <a:lnSpc>
-                <a:spcPct val="145000"/>
-              </a:lnSpc>
-            </a:pPr>
-            <a:r>
-              <a:rPr sz="1420" b="0" i="0">
-                <a:solidFill>
-                  <a:srgbClr val="E2DEF5"/>
-                </a:solidFill>
-                <a:latin typeface="Roboto"/>
-              </a:rPr>
-              <a:t>Antes de decidir onde cada parte roda, o que o kernel faz quando alguém digita docker run e por que a imagem é em camadas.</a:t>
-            </a:r>
-          </a:p>
-        </p:txBody>
-      </p:sp>
-      <p:sp>
-        <p:nvSpPr>
-          <p:cNvPr id="12" name="TextBox 11"/>
-          <p:cNvSpPr txBox="1"/>
-          <p:nvPr/>
-        </p:nvSpPr>
-        <p:spPr>
-          <a:xfrm>
-            <a:off x="685800" y="6324600"/>
-            <a:ext cx="6667500" cy="182880"/>
-          </a:xfrm>
-          <a:prstGeom prst="rect">
-            <a:avLst/>
-          </a:prstGeom>
-          <a:noFill/>
-        </p:spPr>
-        <p:txBody>
-          <a:bodyPr wrap="square" lIns="0" rIns="0" tIns="0" bIns="0" anchor="t">
-            <a:spAutoFit/>
-          </a:bodyPr>
-          <a:lstStyle/>
-          <a:p>
-            <a:pPr algn="l">
-              <a:lnSpc>
                 <a:spcPct val="120000"/>
               </a:lnSpc>
             </a:pPr>
@@ -29837,7 +29550,7 @@
       </p:sp>
       <p:sp>
         <p:nvSpPr>
-          <p:cNvPr id="13" name="TextBox 12"/>
+          <p:cNvPr id="11" name="TextBox 10"/>
           <p:cNvSpPr txBox="1"/>
           <p:nvPr/>
         </p:nvSpPr>

</xml_diff>

<commit_message>
docs: desfaz o ultimo titulo em paralelo e as cartolas que repetiam o titulo
</commit_message>
<xml_diff>
--- a/trabalhos/T1-Docker-Invite-People.pptx
+++ b/trabalhos/T1-Docker-Invite-People.pptx
@@ -12834,7 +12834,7 @@
                 </a:solidFill>
                 <a:latin typeface="Roboto"/>
               </a:rPr>
-              <a:t>OCI, FUNDADA EM 2015</a:t>
+              <a:t>PADRONIZAÇÃO, DESDE 2015</a:t>
             </a:r>
           </a:p>
         </p:txBody>
@@ -21489,7 +21489,7 @@
                 </a:solidFill>
                 <a:latin typeface="Roboto"/>
               </a:rPr>
-              <a:t>O dado sobrevive ao container</a:t>
+              <a:t>O que acontece com o dado</a:t>
             </a:r>
           </a:p>
           <a:p>
@@ -21505,7 +21505,7 @@
                 </a:solidFill>
                 <a:latin typeface="Roboto"/>
               </a:rPr>
-              <a:t>se ficar num volume</a:t>
+              <a:t>quando o container é derrubado</a:t>
             </a:r>
           </a:p>
         </p:txBody>
@@ -22659,7 +22659,7 @@
                 </a:solidFill>
                 <a:latin typeface="Roboto"/>
               </a:rPr>
-              <a:t>LIMITAÇÕES</a:t>
+              <a:t>DESVANTAGENS</a:t>
             </a:r>
           </a:p>
         </p:txBody>
@@ -27289,7 +27289,7 @@
                 </a:solidFill>
                 <a:latin typeface="Roboto"/>
               </a:rPr>
-              <a:t>RECOMENDAÇÃO PARA O ADR #63</a:t>
+              <a:t>ENTRADA PARA O ADR #63</a:t>
             </a:r>
           </a:p>
         </p:txBody>
@@ -32363,7 +32363,7 @@
                 </a:solidFill>
                 <a:latin typeface="Roboto"/>
               </a:rPr>
-              <a:t>O QUE O KERNEL ENXERGA</a:t>
+              <a:t>O PROCESSO VISTO DO HOST</a:t>
             </a:r>
           </a:p>
         </p:txBody>
@@ -33228,7 +33228,7 @@
                 </a:solidFill>
                 <a:latin typeface="Roboto"/>
               </a:rPr>
-              <a:t>NAMESPACES E CGROUPS</a:t>
+              <a:t>OS DOIS MECANISMOS DO KERNEL</a:t>
             </a:r>
           </a:p>
         </p:txBody>
@@ -33267,7 +33267,7 @@
                 </a:solidFill>
                 <a:latin typeface="Roboto"/>
               </a:rPr>
-              <a:t>Namespaces isolam a visão.</a:t>
+              <a:t>Namespaces e cgroups</a:t>
             </a:r>
           </a:p>
           <a:p>
@@ -33283,7 +33283,7 @@
                 </a:solidFill>
                 <a:latin typeface="Roboto"/>
               </a:rPr>
-              <a:t>Cgroups limitam o consumo.</a:t>
+              <a:t>fazem coisas diferentes</a:t>
             </a:r>
           </a:p>
         </p:txBody>

</xml_diff>

<commit_message>
docs: ancora a legenda do diagrama acima do rodape e reduz as citacoes de aula nos slides
</commit_message>
<xml_diff>
--- a/trabalhos/T1-Docker-Invite-People.pptx
+++ b/trabalhos/T1-Docker-Invite-People.pptx
@@ -12928,7 +12928,7 @@
                 </a:solidFill>
                 <a:latin typeface="Roboto"/>
               </a:rPr>
-              <a:t>Fundada em 2015 sob a Linux Foundation, com a Runtime Spec, a Image Spec e a Distribution Spec. O runc é trocável por crun, gVisor ou Kata. O engine é trocável por Podman. É a substituibilidade por compatibilidade de interface da Aula 05, e o Bloco D traz um caso real.</a:t>
+              <a:t>Fundada em 2015 sob a Linux Foundation, com a Runtime Spec, a Image Spec e a Distribution Spec. O runc é trocável por crun, gVisor ou Kata. O engine é trocável por Podman. É substituibilidade por compatibilidade de interface, e a seção 03 traz um caso real disso.</a:t>
             </a:r>
           </a:p>
         </p:txBody>
@@ -13516,7 +13516,7 @@
                 </a:solidFill>
                 <a:latin typeface="Roboto"/>
               </a:rPr>
-              <a:t>CAMADA LÓGICA E TIER, AULA 03</a:t>
+              <a:t>CAMADA LÓGICA E TIER</a:t>
             </a:r>
           </a:p>
         </p:txBody>
@@ -13584,7 +13584,7 @@
         </p:nvSpPr>
         <p:spPr>
           <a:xfrm>
-            <a:off x="857250" y="2562225"/>
+            <a:off x="857250" y="2457450"/>
             <a:ext cx="10001250" cy="182880"/>
           </a:xfrm>
           <a:prstGeom prst="rect">
@@ -13623,7 +13623,7 @@
         </p:nvSpPr>
         <p:spPr>
           <a:xfrm>
-            <a:off x="857250" y="2809875"/>
+            <a:off x="857250" y="2705100"/>
             <a:ext cx="2724150" cy="1504950"/>
           </a:xfrm>
           <a:prstGeom prst="roundRect">
@@ -13672,7 +13672,7 @@
         </p:nvSpPr>
         <p:spPr>
           <a:xfrm>
-            <a:off x="1009650" y="2886075"/>
+            <a:off x="1009650" y="2781300"/>
             <a:ext cx="2419350" cy="247650"/>
           </a:xfrm>
           <a:prstGeom prst="roundRect">
@@ -13720,7 +13720,7 @@
         </p:nvSpPr>
         <p:spPr>
           <a:xfrm>
-            <a:off x="1009650" y="2943225"/>
+            <a:off x="1009650" y="2838450"/>
             <a:ext cx="2419350" cy="198120"/>
           </a:xfrm>
           <a:prstGeom prst="rect">
@@ -13759,7 +13759,7 @@
         </p:nvSpPr>
         <p:spPr>
           <a:xfrm>
-            <a:off x="1009650" y="3171825"/>
+            <a:off x="1009650" y="3067050"/>
             <a:ext cx="2419350" cy="781050"/>
           </a:xfrm>
           <a:prstGeom prst="roundRect">
@@ -13807,7 +13807,7 @@
         </p:nvSpPr>
         <p:spPr>
           <a:xfrm>
-            <a:off x="1038225" y="3286125"/>
+            <a:off x="1038225" y="3181350"/>
             <a:ext cx="2362200" cy="182880"/>
           </a:xfrm>
           <a:prstGeom prst="rect">
@@ -13846,7 +13846,7 @@
         </p:nvSpPr>
         <p:spPr>
           <a:xfrm>
-            <a:off x="1038225" y="3514725"/>
+            <a:off x="1038225" y="3409950"/>
             <a:ext cx="2362200" cy="182880"/>
           </a:xfrm>
           <a:prstGeom prst="rect">
@@ -13885,7 +13885,7 @@
         </p:nvSpPr>
         <p:spPr>
           <a:xfrm>
-            <a:off x="1038225" y="3743325"/>
+            <a:off x="1038225" y="3638550"/>
             <a:ext cx="2362200" cy="182880"/>
           </a:xfrm>
           <a:prstGeom prst="rect">
@@ -13924,7 +13924,7 @@
         </p:nvSpPr>
         <p:spPr>
           <a:xfrm>
-            <a:off x="1009650" y="3990975"/>
+            <a:off x="1009650" y="3886200"/>
             <a:ext cx="2419350" cy="247650"/>
           </a:xfrm>
           <a:prstGeom prst="roundRect">
@@ -13972,7 +13972,7 @@
         </p:nvSpPr>
         <p:spPr>
           <a:xfrm>
-            <a:off x="1009650" y="4048125"/>
+            <a:off x="1009650" y="3943350"/>
             <a:ext cx="2419350" cy="198120"/>
           </a:xfrm>
           <a:prstGeom prst="rect">
@@ -14011,7 +14011,7 @@
         </p:nvSpPr>
         <p:spPr>
           <a:xfrm>
-            <a:off x="857250" y="4429125"/>
+            <a:off x="857250" y="4324350"/>
             <a:ext cx="2724150" cy="228600"/>
           </a:xfrm>
           <a:prstGeom prst="rect">
@@ -14050,7 +14050,7 @@
         </p:nvSpPr>
         <p:spPr>
           <a:xfrm>
-            <a:off x="857250" y="4638675"/>
+            <a:off x="857250" y="4533900"/>
             <a:ext cx="2724150" cy="198120"/>
           </a:xfrm>
           <a:prstGeom prst="rect">
@@ -14089,7 +14089,7 @@
         </p:nvSpPr>
         <p:spPr>
           <a:xfrm>
-            <a:off x="4162425" y="2809875"/>
+            <a:off x="4162425" y="2705100"/>
             <a:ext cx="1143000" cy="1504950"/>
           </a:xfrm>
           <a:prstGeom prst="roundRect">
@@ -14138,7 +14138,7 @@
         </p:nvSpPr>
         <p:spPr>
           <a:xfrm>
-            <a:off x="4295775" y="3476625"/>
+            <a:off x="4295775" y="3371850"/>
             <a:ext cx="876300" cy="247650"/>
           </a:xfrm>
           <a:prstGeom prst="roundRect">
@@ -14186,7 +14186,7 @@
         </p:nvSpPr>
         <p:spPr>
           <a:xfrm>
-            <a:off x="4295775" y="3533775"/>
+            <a:off x="4295775" y="3429000"/>
             <a:ext cx="876300" cy="198120"/>
           </a:xfrm>
           <a:prstGeom prst="rect">
@@ -14225,7 +14225,7 @@
         </p:nvSpPr>
         <p:spPr>
           <a:xfrm>
-            <a:off x="5495925" y="2809875"/>
+            <a:off x="5495925" y="2705100"/>
             <a:ext cx="1390650" cy="1504950"/>
           </a:xfrm>
           <a:prstGeom prst="roundRect">
@@ -14274,7 +14274,7 @@
         </p:nvSpPr>
         <p:spPr>
           <a:xfrm>
-            <a:off x="5562600" y="3028950"/>
+            <a:off x="5562600" y="2924175"/>
             <a:ext cx="1257300" cy="781050"/>
           </a:xfrm>
           <a:prstGeom prst="roundRect">
@@ -14322,7 +14322,7 @@
         </p:nvSpPr>
         <p:spPr>
           <a:xfrm>
-            <a:off x="5591175" y="3143250"/>
+            <a:off x="5591175" y="3038475"/>
             <a:ext cx="1200150" cy="182880"/>
           </a:xfrm>
           <a:prstGeom prst="rect">
@@ -14361,7 +14361,7 @@
         </p:nvSpPr>
         <p:spPr>
           <a:xfrm>
-            <a:off x="5591175" y="3371850"/>
+            <a:off x="5591175" y="3267075"/>
             <a:ext cx="1200150" cy="182880"/>
           </a:xfrm>
           <a:prstGeom prst="rect">
@@ -14400,7 +14400,7 @@
         </p:nvSpPr>
         <p:spPr>
           <a:xfrm>
-            <a:off x="5591175" y="3600450"/>
+            <a:off x="5591175" y="3495675"/>
             <a:ext cx="1200150" cy="182880"/>
           </a:xfrm>
           <a:prstGeom prst="rect">
@@ -14439,7 +14439,7 @@
         </p:nvSpPr>
         <p:spPr>
           <a:xfrm>
-            <a:off x="5629275" y="3867150"/>
+            <a:off x="5629275" y="3762375"/>
             <a:ext cx="1123950" cy="247650"/>
           </a:xfrm>
           <a:prstGeom prst="roundRect">
@@ -14487,7 +14487,7 @@
         </p:nvSpPr>
         <p:spPr>
           <a:xfrm>
-            <a:off x="5629275" y="3924300"/>
+            <a:off x="5629275" y="3819525"/>
             <a:ext cx="1123950" cy="182880"/>
           </a:xfrm>
           <a:prstGeom prst="rect">
@@ -14526,7 +14526,7 @@
         </p:nvSpPr>
         <p:spPr>
           <a:xfrm>
-            <a:off x="4162425" y="4429125"/>
+            <a:off x="4162425" y="4324350"/>
             <a:ext cx="2724150" cy="228600"/>
           </a:xfrm>
           <a:prstGeom prst="rect">
@@ -14565,7 +14565,7 @@
         </p:nvSpPr>
         <p:spPr>
           <a:xfrm>
-            <a:off x="4162425" y="4638675"/>
+            <a:off x="4162425" y="4533900"/>
             <a:ext cx="2724150" cy="198120"/>
           </a:xfrm>
           <a:prstGeom prst="rect">
@@ -14604,7 +14604,7 @@
         </p:nvSpPr>
         <p:spPr>
           <a:xfrm>
-            <a:off x="7239000" y="2809875"/>
+            <a:off x="7239000" y="2705100"/>
             <a:ext cx="838200" cy="1504950"/>
           </a:xfrm>
           <a:prstGeom prst="roundRect">
@@ -14653,7 +14653,7 @@
         </p:nvSpPr>
         <p:spPr>
           <a:xfrm>
-            <a:off x="7353300" y="3476625"/>
+            <a:off x="7353300" y="3371850"/>
             <a:ext cx="609600" cy="247650"/>
           </a:xfrm>
           <a:prstGeom prst="roundRect">
@@ -14701,7 +14701,7 @@
         </p:nvSpPr>
         <p:spPr>
           <a:xfrm>
-            <a:off x="7353300" y="3533775"/>
+            <a:off x="7353300" y="3429000"/>
             <a:ext cx="609600" cy="182880"/>
           </a:xfrm>
           <a:prstGeom prst="rect">
@@ -14740,7 +14740,7 @@
         </p:nvSpPr>
         <p:spPr>
           <a:xfrm>
-            <a:off x="8305800" y="2809875"/>
+            <a:off x="8305800" y="2705100"/>
             <a:ext cx="1619250" cy="1504950"/>
           </a:xfrm>
           <a:prstGeom prst="roundRect">
@@ -14789,7 +14789,7 @@
         </p:nvSpPr>
         <p:spPr>
           <a:xfrm>
-            <a:off x="8420100" y="3171825"/>
+            <a:off x="8420100" y="3067050"/>
             <a:ext cx="1390650" cy="781050"/>
           </a:xfrm>
           <a:prstGeom prst="roundRect">
@@ -14837,7 +14837,7 @@
         </p:nvSpPr>
         <p:spPr>
           <a:xfrm>
-            <a:off x="8448675" y="3286125"/>
+            <a:off x="8448675" y="3181350"/>
             <a:ext cx="1333500" cy="182880"/>
           </a:xfrm>
           <a:prstGeom prst="rect">
@@ -14876,7 +14876,7 @@
         </p:nvSpPr>
         <p:spPr>
           <a:xfrm>
-            <a:off x="8448675" y="3514725"/>
+            <a:off x="8448675" y="3409950"/>
             <a:ext cx="1333500" cy="182880"/>
           </a:xfrm>
           <a:prstGeom prst="rect">
@@ -14915,7 +14915,7 @@
         </p:nvSpPr>
         <p:spPr>
           <a:xfrm>
-            <a:off x="8448675" y="3743325"/>
+            <a:off x="8448675" y="3638550"/>
             <a:ext cx="1333500" cy="182880"/>
           </a:xfrm>
           <a:prstGeom prst="rect">
@@ -14954,7 +14954,7 @@
         </p:nvSpPr>
         <p:spPr>
           <a:xfrm>
-            <a:off x="10153650" y="2809875"/>
+            <a:off x="10153650" y="2705100"/>
             <a:ext cx="838200" cy="1504950"/>
           </a:xfrm>
           <a:prstGeom prst="roundRect">
@@ -15003,7 +15003,7 @@
         </p:nvSpPr>
         <p:spPr>
           <a:xfrm>
-            <a:off x="10267950" y="3476625"/>
+            <a:off x="10267950" y="3371850"/>
             <a:ext cx="609600" cy="247650"/>
           </a:xfrm>
           <a:prstGeom prst="roundRect">
@@ -15051,7 +15051,7 @@
         </p:nvSpPr>
         <p:spPr>
           <a:xfrm>
-            <a:off x="10267950" y="3533775"/>
+            <a:off x="10267950" y="3429000"/>
             <a:ext cx="609600" cy="182880"/>
           </a:xfrm>
           <a:prstGeom prst="rect">
@@ -15090,7 +15090,7 @@
         </p:nvSpPr>
         <p:spPr>
           <a:xfrm>
-            <a:off x="7239000" y="4429125"/>
+            <a:off x="7239000" y="4324350"/>
             <a:ext cx="3752850" cy="228600"/>
           </a:xfrm>
           <a:prstGeom prst="rect">
@@ -15129,7 +15129,7 @@
         </p:nvSpPr>
         <p:spPr>
           <a:xfrm>
-            <a:off x="7239000" y="4638675"/>
+            <a:off x="7239000" y="4533900"/>
             <a:ext cx="3752850" cy="198120"/>
           </a:xfrm>
           <a:prstGeom prst="rect">
@@ -15168,8 +15168,8 @@
         </p:nvSpPr>
         <p:spPr>
           <a:xfrm>
-            <a:off x="685800" y="5638800"/>
-            <a:ext cx="28575" cy="641223"/>
+            <a:off x="685800" y="5428381"/>
+            <a:ext cx="28575" cy="705719"/>
           </a:xfrm>
           <a:prstGeom prst="rect">
             <a:avLst/>
@@ -15212,8 +15212,8 @@
         </p:nvSpPr>
         <p:spPr>
           <a:xfrm>
-            <a:off x="876300" y="5619750"/>
-            <a:ext cx="10629900" cy="571500"/>
+            <a:off x="876300" y="5409331"/>
+            <a:ext cx="10629900" cy="839069"/>
           </a:xfrm>
           <a:prstGeom prst="rect">
             <a:avLst/>
@@ -19190,7 +19190,7 @@
                 </a:solidFill>
                 <a:latin typeface="Roboto"/>
               </a:rPr>
-              <a:t>Uma regra escrita na wiki depende de alguém revisar. A mesma regra na topologia é verificada pela estrutura, o que reduz a degradação arquitetural da Aula 02.</a:t>
+              <a:t>Uma regra escrita na wiki depende de alguém revisar. A mesma regra na topologia é verificada pela estrutura, o que reduz a degradação arquitetural.</a:t>
             </a:r>
           </a:p>
         </p:txBody>
@@ -22492,7 +22492,7 @@
                 </a:solidFill>
                 <a:latin typeface="Roboto"/>
               </a:rPr>
-              <a:t>O que saiu foi o adaptador embutido que falava com o Docker Engine, não o formato das imagens. Como imagem é OCI, nada quebrou. É um caso real de substituição por compatibilidade de interface, no vocabulário da Aula 05.</a:t>
+              <a:t>O que saiu foi o adaptador embutido que falava com o Docker Engine, não o formato das imagens. Como imagem é OCI, nada quebrou. É um caso real de substituição por compatibilidade de interface.</a:t>
             </a:r>
           </a:p>
         </p:txBody>
@@ -26359,7 +26359,7 @@
                 </a:solidFill>
                 <a:latin typeface="Roboto"/>
               </a:rPr>
-              <a:t>Efeito nos atributos da Aula 03</a:t>
+              <a:t>Efeito nos atributos</a:t>
             </a:r>
           </a:p>
           <a:p>
@@ -26375,7 +26375,7 @@
                 </a:solidFill>
                 <a:latin typeface="Roboto"/>
               </a:rPr>
-              <a:t>e das Questões Norteadoras</a:t>
+              <a:t>de qualidade do projeto</a:t>
             </a:r>
           </a:p>
         </p:txBody>
@@ -26388,7 +26388,7 @@
         </p:nvSpPr>
         <p:spPr>
           <a:xfrm>
-            <a:off x="685800" y="2117598"/>
+            <a:off x="685800" y="2010346"/>
             <a:ext cx="5143500" cy="182880"/>
           </a:xfrm>
           <a:prstGeom prst="rect">
@@ -26427,7 +26427,7 @@
         </p:nvSpPr>
         <p:spPr>
           <a:xfrm>
-            <a:off x="685800" y="2327148"/>
+            <a:off x="685800" y="2219896"/>
             <a:ext cx="419100" cy="28575"/>
           </a:xfrm>
           <a:prstGeom prst="rect">
@@ -26471,7 +26471,7 @@
         </p:nvSpPr>
         <p:spPr>
           <a:xfrm>
-            <a:off x="704850" y="2702052"/>
+            <a:off x="704850" y="2599754"/>
             <a:ext cx="57150" cy="57150"/>
           </a:xfrm>
           <a:prstGeom prst="rect">
@@ -26515,7 +26515,7 @@
         </p:nvSpPr>
         <p:spPr>
           <a:xfrm>
-            <a:off x="971550" y="2612898"/>
+            <a:off x="971550" y="2505646"/>
             <a:ext cx="4857750" cy="95250"/>
           </a:xfrm>
           <a:prstGeom prst="rect">
@@ -26535,13 +26535,13 @@
               </a:lnSpc>
             </a:pPr>
             <a:r>
-              <a:rPr sz="1350" b="0" i="0">
+              <a:rPr sz="1420" b="0" i="0">
                 <a:solidFill>
                   <a:srgbClr val="1A1A1E"/>
                 </a:solidFill>
                 <a:latin typeface="Roboto"/>
               </a:rPr>
-              <a:t>Cada imagem tem uma responsabilidade e uma fronteira declarada, que é a modularidade e a reusabilidade da Aula 03.</a:t>
+              <a:t>Cada imagem tem uma responsabilidade e uma fronteira declarada, que é modularidade e reusabilidade.</a:t>
             </a:r>
           </a:p>
         </p:txBody>
@@ -26554,7 +26554,7 @@
         </p:nvSpPr>
         <p:spPr>
           <a:xfrm>
-            <a:off x="704850" y="3590544"/>
+            <a:off x="704850" y="3306128"/>
             <a:ext cx="57150" cy="57150"/>
           </a:xfrm>
           <a:prstGeom prst="rect">
@@ -26598,7 +26598,7 @@
         </p:nvSpPr>
         <p:spPr>
           <a:xfrm>
-            <a:off x="971550" y="3501390"/>
+            <a:off x="971550" y="3212021"/>
             <a:ext cx="4857750" cy="95250"/>
           </a:xfrm>
           <a:prstGeom prst="rect">
@@ -26618,7 +26618,7 @@
               </a:lnSpc>
             </a:pPr>
             <a:r>
-              <a:rPr sz="1350" b="0" i="0">
+              <a:rPr sz="1420" b="0" i="0">
                 <a:solidFill>
                   <a:srgbClr val="1A1A1E"/>
                 </a:solidFill>
@@ -26637,7 +26637,7 @@
         </p:nvSpPr>
         <p:spPr>
           <a:xfrm>
-            <a:off x="704850" y="4252722"/>
+            <a:off x="704850" y="4012502"/>
             <a:ext cx="57150" cy="57150"/>
           </a:xfrm>
           <a:prstGeom prst="rect">
@@ -26681,7 +26681,7 @@
         </p:nvSpPr>
         <p:spPr>
           <a:xfrm>
-            <a:off x="971550" y="4163568"/>
+            <a:off x="971550" y="3918394"/>
             <a:ext cx="4857750" cy="95250"/>
           </a:xfrm>
           <a:prstGeom prst="rect">
@@ -26701,7 +26701,7 @@
               </a:lnSpc>
             </a:pPr>
             <a:r>
-              <a:rPr sz="1350" b="0" i="0">
+              <a:rPr sz="1420" b="0" i="0">
                 <a:solidFill>
                   <a:srgbClr val="1A1A1E"/>
                 </a:solidFill>
@@ -26720,7 +26720,7 @@
         </p:nvSpPr>
         <p:spPr>
           <a:xfrm>
-            <a:off x="704850" y="4914900"/>
+            <a:off x="704850" y="4718876"/>
             <a:ext cx="57150" cy="57150"/>
           </a:xfrm>
           <a:prstGeom prst="rect">
@@ -26764,7 +26764,7 @@
         </p:nvSpPr>
         <p:spPr>
           <a:xfrm>
-            <a:off x="971550" y="4825746"/>
+            <a:off x="971550" y="4624768"/>
             <a:ext cx="4857750" cy="95250"/>
           </a:xfrm>
           <a:prstGeom prst="rect">
@@ -26784,7 +26784,7 @@
               </a:lnSpc>
             </a:pPr>
             <a:r>
-              <a:rPr sz="1350" b="0" i="0">
+              <a:rPr sz="1420" b="0" i="0">
                 <a:solidFill>
                   <a:srgbClr val="1A1A1E"/>
                 </a:solidFill>
@@ -26803,7 +26803,7 @@
         </p:nvSpPr>
         <p:spPr>
           <a:xfrm>
-            <a:off x="704850" y="5577078"/>
+            <a:off x="704850" y="5664136"/>
             <a:ext cx="57150" cy="57150"/>
           </a:xfrm>
           <a:prstGeom prst="rect">
@@ -26847,7 +26847,7 @@
         </p:nvSpPr>
         <p:spPr>
           <a:xfrm>
-            <a:off x="971550" y="5487924"/>
+            <a:off x="971550" y="5570030"/>
             <a:ext cx="4857750" cy="95250"/>
           </a:xfrm>
           <a:prstGeom prst="rect">
@@ -26867,7 +26867,7 @@
               </a:lnSpc>
             </a:pPr>
             <a:r>
-              <a:rPr sz="1350" b="0" i="0">
+              <a:rPr sz="1420" b="0" i="0">
                 <a:solidFill>
                   <a:srgbClr val="1A1A1E"/>
                 </a:solidFill>
@@ -26886,7 +26886,7 @@
         </p:nvSpPr>
         <p:spPr>
           <a:xfrm>
-            <a:off x="6362700" y="2117598"/>
+            <a:off x="6362700" y="2010346"/>
             <a:ext cx="5143500" cy="182880"/>
           </a:xfrm>
           <a:prstGeom prst="rect">
@@ -26925,7 +26925,7 @@
         </p:nvSpPr>
         <p:spPr>
           <a:xfrm>
-            <a:off x="6362700" y="2327148"/>
+            <a:off x="6362700" y="2219896"/>
             <a:ext cx="419100" cy="28575"/>
           </a:xfrm>
           <a:prstGeom prst="rect">
@@ -26969,7 +26969,7 @@
         </p:nvSpPr>
         <p:spPr>
           <a:xfrm>
-            <a:off x="6381750" y="2702052"/>
+            <a:off x="6381750" y="2599754"/>
             <a:ext cx="57150" cy="57150"/>
           </a:xfrm>
           <a:prstGeom prst="rect">
@@ -27013,7 +27013,7 @@
         </p:nvSpPr>
         <p:spPr>
           <a:xfrm>
-            <a:off x="6648450" y="2612898"/>
+            <a:off x="6648450" y="2505646"/>
             <a:ext cx="4857750" cy="95250"/>
           </a:xfrm>
           <a:prstGeom prst="rect">
@@ -27033,7 +27033,7 @@
               </a:lnSpc>
             </a:pPr>
             <a:r>
-              <a:rPr sz="1350" b="0" i="0">
+              <a:rPr sz="1420" b="0" i="0">
                 <a:solidFill>
                   <a:srgbClr val="1A1A1E"/>
                 </a:solidFill>
@@ -27052,7 +27052,7 @@
         </p:nvSpPr>
         <p:spPr>
           <a:xfrm>
-            <a:off x="6381750" y="3364230"/>
+            <a:off x="6381750" y="3306128"/>
             <a:ext cx="57150" cy="57150"/>
           </a:xfrm>
           <a:prstGeom prst="rect">
@@ -27096,7 +27096,7 @@
         </p:nvSpPr>
         <p:spPr>
           <a:xfrm>
-            <a:off x="6648450" y="3275076"/>
+            <a:off x="6648450" y="3212021"/>
             <a:ext cx="4857750" cy="95250"/>
           </a:xfrm>
           <a:prstGeom prst="rect">
@@ -27116,7 +27116,7 @@
               </a:lnSpc>
             </a:pPr>
             <a:r>
-              <a:rPr sz="1350" b="0" i="0">
+              <a:rPr sz="1420" b="0" i="0">
                 <a:solidFill>
                   <a:srgbClr val="1A1A1E"/>
                 </a:solidFill>
@@ -34265,7 +34265,7 @@
         </p:nvSpPr>
         <p:spPr>
           <a:xfrm>
-            <a:off x="857250" y="2343150"/>
+            <a:off x="857250" y="2362200"/>
             <a:ext cx="4381500" cy="167640"/>
           </a:xfrm>
           <a:prstGeom prst="rect">
@@ -34304,7 +34304,7 @@
         </p:nvSpPr>
         <p:spPr>
           <a:xfrm>
-            <a:off x="857250" y="4057650"/>
+            <a:off x="857250" y="4076700"/>
             <a:ext cx="3429000" cy="438150"/>
           </a:xfrm>
           <a:prstGeom prst="roundRect">
@@ -34352,7 +34352,7 @@
         </p:nvSpPr>
         <p:spPr>
           <a:xfrm>
-            <a:off x="1047750" y="4191000"/>
+            <a:off x="1047750" y="4210050"/>
             <a:ext cx="3048000" cy="213360"/>
           </a:xfrm>
           <a:prstGeom prst="rect">
@@ -34391,7 +34391,7 @@
         </p:nvSpPr>
         <p:spPr>
           <a:xfrm>
-            <a:off x="857250" y="3562350"/>
+            <a:off x="857250" y="3581400"/>
             <a:ext cx="3429000" cy="438150"/>
           </a:xfrm>
           <a:prstGeom prst="roundRect">
@@ -34439,7 +34439,7 @@
         </p:nvSpPr>
         <p:spPr>
           <a:xfrm>
-            <a:off x="1047750" y="3695700"/>
+            <a:off x="1047750" y="3714750"/>
             <a:ext cx="3048000" cy="213360"/>
           </a:xfrm>
           <a:prstGeom prst="rect">
@@ -34478,7 +34478,7 @@
         </p:nvSpPr>
         <p:spPr>
           <a:xfrm>
-            <a:off x="857250" y="3067050"/>
+            <a:off x="857250" y="3086100"/>
             <a:ext cx="3429000" cy="438150"/>
           </a:xfrm>
           <a:prstGeom prst="roundRect">
@@ -34526,7 +34526,7 @@
         </p:nvSpPr>
         <p:spPr>
           <a:xfrm>
-            <a:off x="1047750" y="3200400"/>
+            <a:off x="1047750" y="3219450"/>
             <a:ext cx="3048000" cy="213360"/>
           </a:xfrm>
           <a:prstGeom prst="rect">
@@ -34565,7 +34565,7 @@
         </p:nvSpPr>
         <p:spPr>
           <a:xfrm>
-            <a:off x="4400550" y="3067050"/>
+            <a:off x="4400550" y="3086100"/>
             <a:ext cx="28575" cy="1428750"/>
           </a:xfrm>
           <a:prstGeom prst="rect">
@@ -34609,7 +34609,7 @@
         </p:nvSpPr>
         <p:spPr>
           <a:xfrm>
-            <a:off x="742950" y="4629150"/>
+            <a:off x="742950" y="4648200"/>
             <a:ext cx="3657600" cy="381000"/>
           </a:xfrm>
           <a:prstGeom prst="rect">
@@ -34648,7 +34648,7 @@
         </p:nvSpPr>
         <p:spPr>
           <a:xfrm>
-            <a:off x="857250" y="2514600"/>
+            <a:off x="857250" y="2533650"/>
             <a:ext cx="3429000" cy="495300"/>
           </a:xfrm>
           <a:prstGeom prst="roundRect">
@@ -34697,7 +34697,7 @@
         </p:nvSpPr>
         <p:spPr>
           <a:xfrm>
-            <a:off x="1047750" y="2609850"/>
+            <a:off x="1047750" y="2628900"/>
             <a:ext cx="3048000" cy="213360"/>
           </a:xfrm>
           <a:prstGeom prst="rect">
@@ -34736,7 +34736,7 @@
         </p:nvSpPr>
         <p:spPr>
           <a:xfrm>
-            <a:off x="1047750" y="2790825"/>
+            <a:off x="1047750" y="2809875"/>
             <a:ext cx="3048000" cy="182880"/>
           </a:xfrm>
           <a:prstGeom prst="rect">
@@ -34775,7 +34775,7 @@
         </p:nvCxnSpPr>
         <p:spPr>
           <a:xfrm>
-            <a:off x="4857750" y="2457450"/>
+            <a:off x="4857750" y="2476500"/>
             <a:ext cx="0" cy="2152650"/>
           </a:xfrm>
           <a:prstGeom prst="line">
@@ -34810,7 +34810,7 @@
         </p:nvSpPr>
         <p:spPr>
           <a:xfrm>
-            <a:off x="5257800" y="2914650"/>
+            <a:off x="5257800" y="2933700"/>
             <a:ext cx="3619500" cy="243840"/>
           </a:xfrm>
           <a:prstGeom prst="rect">
@@ -34849,7 +34849,7 @@
         </p:nvSpPr>
         <p:spPr>
           <a:xfrm>
-            <a:off x="5257800" y="3181350"/>
+            <a:off x="5257800" y="3200400"/>
             <a:ext cx="3810000" cy="666750"/>
           </a:xfrm>
           <a:prstGeom prst="rect">
@@ -34888,7 +34888,7 @@
         </p:nvSpPr>
         <p:spPr>
           <a:xfrm>
-            <a:off x="5257800" y="3752850"/>
+            <a:off x="5257800" y="3771900"/>
             <a:ext cx="3619500" cy="243840"/>
           </a:xfrm>
           <a:prstGeom prst="rect">
@@ -34927,7 +34927,7 @@
         </p:nvSpPr>
         <p:spPr>
           <a:xfrm>
-            <a:off x="5257800" y="4019550"/>
+            <a:off x="5257800" y="4038600"/>
             <a:ext cx="3810000" cy="666750"/>
           </a:xfrm>
           <a:prstGeom prst="rect">
@@ -34966,8 +34966,8 @@
         </p:nvSpPr>
         <p:spPr>
           <a:xfrm>
-            <a:off x="685800" y="5638800"/>
-            <a:ext cx="28575" cy="427482"/>
+            <a:off x="685800" y="5676321"/>
+            <a:ext cx="28575" cy="457779"/>
           </a:xfrm>
           <a:prstGeom prst="rect">
             <a:avLst/>
@@ -35010,8 +35010,8 @@
         </p:nvSpPr>
         <p:spPr>
           <a:xfrm>
-            <a:off x="876300" y="5619750"/>
-            <a:ext cx="10629900" cy="571500"/>
+            <a:off x="876300" y="5657271"/>
+            <a:ext cx="10629900" cy="591129"/>
           </a:xfrm>
           <a:prstGeom prst="rect">
             <a:avLst/>
@@ -36223,7 +36223,7 @@
                 </a:solidFill>
                 <a:latin typeface="Roboto"/>
               </a:rPr>
-              <a:t>Cada peça tem uma responsabilidade e pode ser trocada. É a substituibilidade da Aula 05, aplicada ao próprio Docker.</a:t>
+              <a:t>Cada peça tem uma responsabilidade e pode ser trocada por outra que respeite a mesma interface.</a:t>
             </a:r>
           </a:p>
         </p:txBody>

</xml_diff>

<commit_message>
docs: troca os numeros de work item pelo nome do artefato nos slides do T1
</commit_message>
<xml_diff>
--- a/trabalhos/T1-Docker-Invite-People.pptx
+++ b/trabalhos/T1-Docker-Invite-People.pptx
@@ -15238,7 +15238,7 @@
                 </a:solidFill>
                 <a:latin typeface="Roboto"/>
               </a:rPr>
-              <a:t>Nenhuma das três muda uma linha do projeto lógico. Todas mudam o empacotamento, e essa escolha é entrada do ADR #63, o documento de decisões arquiteturais da Sprint 2. Cuidado com o vocabulário: Docker usa </a:t>
+              <a:t>Nenhuma das três muda uma linha do projeto lógico. Todas mudam o empacotamento, e essa escolha é entrada do ADR, o documento de decisões arquiteturais da Sprint 2. Cuidado com o vocabulário: Docker usa </a:t>
             </a:r>
             <a:r>
               <a:rPr sz="1280" b="0" i="1">
@@ -16183,7 +16183,7 @@
                 </a:solidFill>
                 <a:latin typeface="Roboto"/>
               </a:rPr>
-              <a:t>RASCUNHOS DOS ITENS #59 E #60</a:t>
+              <a:t>RASCUNHOS DOS DOIS DIAGRAMAS</a:t>
             </a:r>
           </a:p>
         </p:txBody>
@@ -16277,7 +16277,7 @@
                 </a:solidFill>
                 <a:latin typeface="Roboto"/>
               </a:rPr>
-              <a:t>RASCUNHO #59, DIAGRAMA DE COMPONENTES</a:t>
+              <a:t>RASCUNHO DO DIAGRAMA DE COMPONENTES</a:t>
             </a:r>
           </a:p>
         </p:txBody>
@@ -16814,8 +16814,8 @@
         </p:nvSpPr>
         <p:spPr>
           <a:xfrm>
-            <a:off x="4953000" y="3886200"/>
-            <a:ext cx="952500" cy="198120"/>
+            <a:off x="4667250" y="3867150"/>
+            <a:ext cx="1524000" cy="198120"/>
           </a:xfrm>
           <a:prstGeom prst="rect">
             <a:avLst/>
@@ -16840,7 +16840,7 @@
                 </a:solidFill>
                 <a:latin typeface="Roboto"/>
               </a:rPr>
-              <a:t>#72</a:t>
+              <a:t>mapeamento</a:t>
             </a:r>
           </a:p>
         </p:txBody>
@@ -16879,7 +16879,7 @@
                 </a:solidFill>
                 <a:latin typeface="Roboto"/>
               </a:rPr>
-              <a:t>RASCUNHO #60, DIAGRAMA DE IMPLANTAÇÃO</a:t>
+              <a:t>RASCUNHO DO DIAGRAMA DE IMPLANTAÇÃO</a:t>
             </a:r>
           </a:p>
         </p:txBody>
@@ -17486,7 +17486,7 @@
                 </a:solidFill>
                 <a:latin typeface="Roboto"/>
               </a:rPr>
-              <a:t>rede nomeada, resolução por nome de serviço  ·  #75</a:t>
+              <a:t>rede nomeada, com resolução por nome de serviço</a:t>
             </a:r>
           </a:p>
         </p:txBody>
@@ -17500,7 +17500,7 @@
         <p:spPr>
           <a:xfrm>
             <a:off x="6381750" y="4762500"/>
-            <a:ext cx="3619500" cy="175260"/>
+            <a:ext cx="3810000" cy="182880"/>
           </a:xfrm>
           <a:prstGeom prst="rect">
             <a:avLst/>
@@ -17519,13 +17519,13 @@
               </a:lnSpc>
             </a:pPr>
             <a:r>
-              <a:rPr sz="860" b="0" i="0">
+              <a:rPr sz="900" b="0" i="0">
                 <a:solidFill>
                   <a:srgbClr val="6B6B78"/>
                 </a:solidFill>
                 <a:latin typeface="Roboto"/>
               </a:rPr>
-              <a:t>#71 nós  ·  #73 imagem por tag e digest  ·  #74, #76 e #77 são passos de processo</a:t>
+              <a:t>Cada nó vira um serviço no arquivo de compose, com a imagem por tag e digest.</a:t>
             </a:r>
           </a:p>
         </p:txBody>
@@ -18553,7 +18553,7 @@
                 </a:solidFill>
                 <a:latin typeface="Roboto"/>
               </a:rPr>
-              <a:t>As imagens do arquivo são exemplo. A stack ainda não foi decidida e é assunto do ADR #63.</a:t>
+              <a:t>As imagens do arquivo são exemplo. A stack ainda não foi decidida e é assunto do ADR.</a:t>
             </a:r>
           </a:p>
         </p:txBody>
@@ -20007,7 +20007,7 @@
         <p:spPr>
           <a:xfrm>
             <a:off x="9124950" y="3180207"/>
-            <a:ext cx="38100" cy="1033272"/>
+            <a:ext cx="38100" cy="1234440"/>
           </a:xfrm>
           <a:prstGeom prst="rect">
             <a:avLst/>
@@ -20051,7 +20051,7 @@
         <p:spPr>
           <a:xfrm>
             <a:off x="9334500" y="3180207"/>
-            <a:ext cx="2171700" cy="1604772"/>
+            <a:ext cx="2171700" cy="1805940"/>
           </a:xfrm>
           <a:prstGeom prst="rect">
             <a:avLst/>
@@ -20117,7 +20117,7 @@
                 </a:solidFill>
                 <a:latin typeface="Roboto"/>
               </a:rPr>
-              <a:t>Entrada direta para o #59 e o #60. Ainda não decidida.</a:t>
+              <a:t>Entrada direta para os dois diagramas da Sprint 2. Ainda não decidida.</a:t>
             </a:r>
           </a:p>
         </p:txBody>
@@ -23478,7 +23478,7 @@
         </p:nvSpPr>
         <p:spPr>
           <a:xfrm>
-            <a:off x="685800" y="2061210"/>
+            <a:off x="685800" y="2193226"/>
             <a:ext cx="5143500" cy="182880"/>
           </a:xfrm>
           <a:prstGeom prst="rect">
@@ -23517,7 +23517,7 @@
         </p:nvSpPr>
         <p:spPr>
           <a:xfrm>
-            <a:off x="685800" y="2270760"/>
+            <a:off x="685800" y="2402776"/>
             <a:ext cx="419100" cy="28575"/>
           </a:xfrm>
           <a:prstGeom prst="rect">
@@ -23561,7 +23561,7 @@
         </p:nvSpPr>
         <p:spPr>
           <a:xfrm>
-            <a:off x="704850" y="2660523"/>
+            <a:off x="704850" y="2792540"/>
             <a:ext cx="57150" cy="57150"/>
           </a:xfrm>
           <a:prstGeom prst="rect">
@@ -23605,7 +23605,7 @@
         </p:nvSpPr>
         <p:spPr>
           <a:xfrm>
-            <a:off x="971550" y="2556510"/>
+            <a:off x="971550" y="2688526"/>
             <a:ext cx="4857750" cy="95250"/>
           </a:xfrm>
           <a:prstGeom prst="rect">
@@ -23644,7 +23644,7 @@
         </p:nvSpPr>
         <p:spPr>
           <a:xfrm>
-            <a:off x="704850" y="3191256"/>
+            <a:off x="704850" y="3323273"/>
             <a:ext cx="57150" cy="57150"/>
           </a:xfrm>
           <a:prstGeom prst="rect">
@@ -23688,7 +23688,7 @@
         </p:nvSpPr>
         <p:spPr>
           <a:xfrm>
-            <a:off x="971550" y="3087243"/>
+            <a:off x="971550" y="3219260"/>
             <a:ext cx="4857750" cy="95250"/>
           </a:xfrm>
           <a:prstGeom prst="rect">
@@ -23727,7 +23727,7 @@
         </p:nvSpPr>
         <p:spPr>
           <a:xfrm>
-            <a:off x="704850" y="3986022"/>
+            <a:off x="704850" y="4118039"/>
             <a:ext cx="57150" cy="57150"/>
           </a:xfrm>
           <a:prstGeom prst="rect">
@@ -23771,7 +23771,7 @@
         </p:nvSpPr>
         <p:spPr>
           <a:xfrm>
-            <a:off x="971550" y="3882009"/>
+            <a:off x="971550" y="4014026"/>
             <a:ext cx="4857750" cy="95250"/>
           </a:xfrm>
           <a:prstGeom prst="rect">
@@ -23810,7 +23810,7 @@
         </p:nvSpPr>
         <p:spPr>
           <a:xfrm>
-            <a:off x="6362700" y="2061210"/>
+            <a:off x="6362700" y="2193226"/>
             <a:ext cx="5143500" cy="182880"/>
           </a:xfrm>
           <a:prstGeom prst="rect">
@@ -23849,7 +23849,7 @@
         </p:nvSpPr>
         <p:spPr>
           <a:xfrm>
-            <a:off x="6362700" y="2270760"/>
+            <a:off x="6362700" y="2402776"/>
             <a:ext cx="419100" cy="28575"/>
           </a:xfrm>
           <a:prstGeom prst="rect">
@@ -23893,7 +23893,7 @@
         </p:nvSpPr>
         <p:spPr>
           <a:xfrm>
-            <a:off x="6381750" y="2660523"/>
+            <a:off x="6381750" y="2792540"/>
             <a:ext cx="57150" cy="57150"/>
           </a:xfrm>
           <a:prstGeom prst="rect">
@@ -23937,7 +23937,7 @@
         </p:nvSpPr>
         <p:spPr>
           <a:xfrm>
-            <a:off x="6648450" y="2556510"/>
+            <a:off x="6648450" y="2688526"/>
             <a:ext cx="4857750" cy="95250"/>
           </a:xfrm>
           <a:prstGeom prst="rect">
@@ -23976,7 +23976,7 @@
         </p:nvSpPr>
         <p:spPr>
           <a:xfrm>
-            <a:off x="6381750" y="3191256"/>
+            <a:off x="6381750" y="3323273"/>
             <a:ext cx="57150" cy="57150"/>
           </a:xfrm>
           <a:prstGeom prst="rect">
@@ -24020,7 +24020,7 @@
         </p:nvSpPr>
         <p:spPr>
           <a:xfrm>
-            <a:off x="6648450" y="3087243"/>
+            <a:off x="6648450" y="3219260"/>
             <a:ext cx="4857750" cy="95250"/>
           </a:xfrm>
           <a:prstGeom prst="rect">
@@ -24059,7 +24059,7 @@
         </p:nvSpPr>
         <p:spPr>
           <a:xfrm>
-            <a:off x="6381750" y="4250055"/>
+            <a:off x="6381750" y="4382072"/>
             <a:ext cx="57150" cy="57150"/>
           </a:xfrm>
           <a:prstGeom prst="rect">
@@ -24103,7 +24103,7 @@
         </p:nvSpPr>
         <p:spPr>
           <a:xfrm>
-            <a:off x="6648450" y="4146042"/>
+            <a:off x="6648450" y="4278058"/>
             <a:ext cx="4857750" cy="95250"/>
           </a:xfrm>
           <a:prstGeom prst="rect">
@@ -24142,7 +24142,7 @@
         </p:nvSpPr>
         <p:spPr>
           <a:xfrm>
-            <a:off x="6381750" y="5308854"/>
+            <a:off x="6381750" y="5440870"/>
             <a:ext cx="57150" cy="57150"/>
           </a:xfrm>
           <a:prstGeom prst="rect">
@@ -24186,7 +24186,7 @@
         </p:nvSpPr>
         <p:spPr>
           <a:xfrm>
-            <a:off x="6648450" y="5204841"/>
+            <a:off x="6648450" y="5336858"/>
             <a:ext cx="4857750" cy="95250"/>
           </a:xfrm>
           <a:prstGeom prst="rect">
@@ -24212,7 +24212,7 @@
                 </a:solidFill>
                 <a:latin typeface="Roboto"/>
               </a:rPr>
-              <a:t>Por isso o ADR #63 precisa registrar que container não dá o mesmo isolamento de uma máquina virtual.</a:t>
+              <a:t>Por isso o ADR precisa registrar que container não dá o mesmo isolamento de uma máquina virtual.</a:t>
             </a:r>
           </a:p>
         </p:txBody>
@@ -27289,7 +27289,7 @@
                 </a:solidFill>
                 <a:latin typeface="Roboto"/>
               </a:rPr>
-              <a:t>ENTRADA PARA O ADR #63</a:t>
+              <a:t>ENTRADA PARA O ADR</a:t>
             </a:r>
           </a:p>
         </p:txBody>
@@ -27341,7 +27341,7 @@
         </p:nvSpPr>
         <p:spPr>
           <a:xfrm>
-            <a:off x="704850" y="3141726"/>
+            <a:off x="704850" y="3003423"/>
             <a:ext cx="57150" cy="57150"/>
           </a:xfrm>
           <a:prstGeom prst="rect">
@@ -27385,7 +27385,7 @@
         </p:nvSpPr>
         <p:spPr>
           <a:xfrm>
-            <a:off x="971550" y="3032760"/>
+            <a:off x="971550" y="2894457"/>
             <a:ext cx="7677150" cy="95250"/>
           </a:xfrm>
           <a:prstGeom prst="rect">
@@ -27424,7 +27424,7 @@
         </p:nvSpPr>
         <p:spPr>
           <a:xfrm>
-            <a:off x="704850" y="3980688"/>
+            <a:off x="704850" y="3842385"/>
             <a:ext cx="57150" cy="57150"/>
           </a:xfrm>
           <a:prstGeom prst="rect">
@@ -27468,7 +27468,7 @@
         </p:nvSpPr>
         <p:spPr>
           <a:xfrm>
-            <a:off x="971550" y="3871722"/>
+            <a:off x="971550" y="3733419"/>
             <a:ext cx="7677150" cy="95250"/>
           </a:xfrm>
           <a:prstGeom prst="rect">
@@ -27494,7 +27494,7 @@
                 </a:solidFill>
                 <a:latin typeface="Roboto"/>
               </a:rPr>
-              <a:t>O #60 deixa de ser caixa genérica e passa a ter um arquivo correspondente que roda, e esse arquivo vira artefato do repositório.</a:t>
+              <a:t>O diagrama de implantação deixa de ser caixa genérica e passa a ter um arquivo correspondente que roda, e esse arquivo vira artefato do repositório.</a:t>
             </a:r>
           </a:p>
         </p:txBody>
@@ -27507,7 +27507,7 @@
         </p:nvSpPr>
         <p:spPr>
           <a:xfrm>
-            <a:off x="704850" y="4819650"/>
+            <a:off x="704850" y="4957953"/>
             <a:ext cx="57150" cy="57150"/>
           </a:xfrm>
           <a:prstGeom prst="rect">
@@ -27551,7 +27551,7 @@
         </p:nvSpPr>
         <p:spPr>
           <a:xfrm>
-            <a:off x="971550" y="4710684"/>
+            <a:off x="971550" y="4848987"/>
             <a:ext cx="7677150" cy="95250"/>
           </a:xfrm>
           <a:prstGeom prst="rect">
@@ -27590,7 +27590,7 @@
         </p:nvSpPr>
         <p:spPr>
           <a:xfrm>
-            <a:off x="9124950" y="3042285"/>
+            <a:off x="9124950" y="2903982"/>
             <a:ext cx="142875" cy="123825"/>
           </a:xfrm>
           <a:prstGeom prst="chevron">
@@ -27634,7 +27634,7 @@
         </p:nvSpPr>
         <p:spPr>
           <a:xfrm>
-            <a:off x="9372600" y="3042285"/>
+            <a:off x="9372600" y="2903982"/>
             <a:ext cx="2133600" cy="182880"/>
           </a:xfrm>
           <a:prstGeom prst="rect">
@@ -27673,7 +27673,7 @@
         </p:nvSpPr>
         <p:spPr>
           <a:xfrm>
-            <a:off x="9124950" y="3318510"/>
+            <a:off x="9124950" y="3180207"/>
             <a:ext cx="38100" cy="1005840"/>
           </a:xfrm>
           <a:prstGeom prst="rect">
@@ -27717,7 +27717,7 @@
         </p:nvSpPr>
         <p:spPr>
           <a:xfrm>
-            <a:off x="9334500" y="3318510"/>
+            <a:off x="9334500" y="3180207"/>
             <a:ext cx="2171700" cy="1577340"/>
           </a:xfrm>
           <a:prstGeom prst="rect">
@@ -28466,7 +28466,7 @@
                 </a:solidFill>
                 <a:latin typeface="Roboto"/>
               </a:rPr>
-              <a:t>Esse mesmo arquivo é o que vira o diagrama de implantação do item #60.</a:t>
+              <a:t>Esse mesmo arquivo é o que vira o diagrama de implantação da Sprint 2.</a:t>
             </a:r>
           </a:p>
         </p:txBody>
@@ -28755,7 +28755,7 @@
                 </a:solidFill>
                 <a:latin typeface="Roboto"/>
               </a:rPr>
-              <a:t>Os itens #58 a #63 da Sprint 2 estão em To Do. Isto é insumo desses itens, não relato de item concluído.</a:t>
+              <a:t>Os seis itens de modelagem da Sprint 2, do #58 ao #63, estão em To Do. Isto é insumo desses itens, não relato de item concluído.</a:t>
             </a:r>
           </a:p>
         </p:txBody>
@@ -28838,7 +28838,7 @@
                 </a:solidFill>
                 <a:latin typeface="Roboto"/>
               </a:rPr>
-              <a:t>O #63, onde a stack será decidida, ainda não foi escrito.</a:t>
+              <a:t>O ADR #63, onde a stack será decidida, ainda não foi escrito.</a:t>
             </a:r>
           </a:p>
         </p:txBody>
@@ -32196,7 +32196,7 @@
                 </a:solidFill>
                 <a:latin typeface="Roboto"/>
               </a:rPr>
-              <a:t>São essas duas definições que decidem o desenho do item #60, com a imagem entrando como artefato e o container como nó.</a:t>
+              <a:t>São essas duas definições que decidem o desenho do diagrama de implantação, com a imagem entrando como artefato e o container como nó.</a:t>
             </a:r>
           </a:p>
         </p:txBody>

</xml_diff>

<commit_message>
docs: fecha as lacunas de Dockerfile, registry, rede interna e WSL2 nos slides do T1
</commit_message>
<xml_diff>
--- a/trabalhos/T1-Docker-Invite-People.pptx
+++ b/trabalhos/T1-Docker-Invite-People.pptx
@@ -18788,7 +18788,7 @@
         </p:nvSpPr>
         <p:spPr>
           <a:xfrm>
-            <a:off x="685800" y="2061210"/>
+            <a:off x="685800" y="2026920"/>
             <a:ext cx="5143500" cy="182880"/>
           </a:xfrm>
           <a:prstGeom prst="rect">
@@ -18827,7 +18827,7 @@
         </p:nvSpPr>
         <p:spPr>
           <a:xfrm>
-            <a:off x="685800" y="2270760"/>
+            <a:off x="685800" y="2236470"/>
             <a:ext cx="419100" cy="28575"/>
           </a:xfrm>
           <a:prstGeom prst="rect">
@@ -18871,7 +18871,7 @@
         </p:nvSpPr>
         <p:spPr>
           <a:xfrm>
-            <a:off x="704850" y="2660523"/>
+            <a:off x="704850" y="2621280"/>
             <a:ext cx="57150" cy="57150"/>
           </a:xfrm>
           <a:prstGeom prst="rect">
@@ -18915,7 +18915,7 @@
         </p:nvSpPr>
         <p:spPr>
           <a:xfrm>
-            <a:off x="971550" y="2556510"/>
+            <a:off x="971550" y="2522220"/>
             <a:ext cx="4857750" cy="95250"/>
           </a:xfrm>
           <a:prstGeom prst="rect">
@@ -18935,7 +18935,7 @@
               </a:lnSpc>
             </a:pPr>
             <a:r>
-              <a:rPr sz="1580" b="0" i="0">
+              <a:rPr sz="1500" b="0" i="0">
                 <a:solidFill>
                   <a:srgbClr val="1A1A1E"/>
                 </a:solidFill>
@@ -18954,7 +18954,7 @@
         </p:nvSpPr>
         <p:spPr>
           <a:xfrm>
-            <a:off x="704850" y="3455289"/>
+            <a:off x="704850" y="3371850"/>
             <a:ext cx="57150" cy="57150"/>
           </a:xfrm>
           <a:prstGeom prst="rect">
@@ -18998,7 +18998,7 @@
         </p:nvSpPr>
         <p:spPr>
           <a:xfrm>
-            <a:off x="971550" y="3351276"/>
+            <a:off x="971550" y="3272790"/>
             <a:ext cx="4857750" cy="95250"/>
           </a:xfrm>
           <a:prstGeom prst="rect">
@@ -19018,7 +19018,7 @@
               </a:lnSpc>
             </a:pPr>
             <a:r>
-              <a:rPr sz="1580" b="0" i="0">
+              <a:rPr sz="1500" b="0" i="0">
                 <a:solidFill>
                   <a:srgbClr val="1A1A1E"/>
                 </a:solidFill>
@@ -19037,7 +19037,7 @@
         </p:nvSpPr>
         <p:spPr>
           <a:xfrm>
-            <a:off x="704850" y="4250055"/>
+            <a:off x="704850" y="4122420"/>
             <a:ext cx="57150" cy="57150"/>
           </a:xfrm>
           <a:prstGeom prst="rect">
@@ -19081,7 +19081,7 @@
         </p:nvSpPr>
         <p:spPr>
           <a:xfrm>
-            <a:off x="971550" y="4146042"/>
+            <a:off x="971550" y="4023360"/>
             <a:ext cx="4857750" cy="95250"/>
           </a:xfrm>
           <a:prstGeom prst="rect">
@@ -19101,13 +19101,13 @@
               </a:lnSpc>
             </a:pPr>
             <a:r>
-              <a:rPr sz="1580" b="0" i="0">
+              <a:rPr sz="1500" b="0" i="0">
                 <a:solidFill>
                   <a:srgbClr val="1A1A1E"/>
                 </a:solidFill>
                 <a:latin typeface="Roboto"/>
               </a:rPr>
-              <a:t>Só o serviço de fronteira publica porta, e o banco fica na rede interna sem mapeamento nenhum.</a:t>
+              <a:t>Os serviços conversam por uma rede interna, onde cada um é achado pelo nome. Só o de fronteira publica porta para fora, e o banco fica sem mapeamento nenhum.</a:t>
             </a:r>
           </a:p>
         </p:txBody>
@@ -19120,7 +19120,7 @@
         </p:nvSpPr>
         <p:spPr>
           <a:xfrm>
-            <a:off x="704850" y="5044821"/>
+            <a:off x="704850" y="5375910"/>
             <a:ext cx="57150" cy="57150"/>
           </a:xfrm>
           <a:prstGeom prst="rect">
@@ -19164,7 +19164,7 @@
         </p:nvSpPr>
         <p:spPr>
           <a:xfrm>
-            <a:off x="971550" y="4940808"/>
+            <a:off x="971550" y="5276850"/>
             <a:ext cx="4857750" cy="95250"/>
           </a:xfrm>
           <a:prstGeom prst="rect">
@@ -19184,7 +19184,7 @@
               </a:lnSpc>
             </a:pPr>
             <a:r>
-              <a:rPr sz="1580" b="0" i="0">
+              <a:rPr sz="1500" b="0" i="0">
                 <a:solidFill>
                   <a:srgbClr val="1A1A1E"/>
                 </a:solidFill>
@@ -19203,7 +19203,7 @@
         </p:nvSpPr>
         <p:spPr>
           <a:xfrm>
-            <a:off x="6362700" y="2061210"/>
+            <a:off x="6362700" y="2026920"/>
             <a:ext cx="5143500" cy="182880"/>
           </a:xfrm>
           <a:prstGeom prst="rect">
@@ -19242,7 +19242,7 @@
         </p:nvSpPr>
         <p:spPr>
           <a:xfrm>
-            <a:off x="6362700" y="2270760"/>
+            <a:off x="6362700" y="2236470"/>
             <a:ext cx="419100" cy="28575"/>
           </a:xfrm>
           <a:prstGeom prst="rect">
@@ -19286,7 +19286,7 @@
         </p:nvSpPr>
         <p:spPr>
           <a:xfrm>
-            <a:off x="6381750" y="2660523"/>
+            <a:off x="6381750" y="2621280"/>
             <a:ext cx="57150" cy="57150"/>
           </a:xfrm>
           <a:prstGeom prst="rect">
@@ -19330,7 +19330,7 @@
         </p:nvSpPr>
         <p:spPr>
           <a:xfrm>
-            <a:off x="6648450" y="2556510"/>
+            <a:off x="6648450" y="2522220"/>
             <a:ext cx="4857750" cy="95250"/>
           </a:xfrm>
           <a:prstGeom prst="rect">
@@ -19350,7 +19350,7 @@
               </a:lnSpc>
             </a:pPr>
             <a:r>
-              <a:rPr sz="1580" b="0" i="0">
+              <a:rPr sz="1500" b="0" i="0">
                 <a:solidFill>
                   <a:srgbClr val="1A1A1E"/>
                 </a:solidFill>
@@ -19369,7 +19369,7 @@
         </p:nvSpPr>
         <p:spPr>
           <a:xfrm>
-            <a:off x="6381750" y="3719322"/>
+            <a:off x="6381750" y="3623310"/>
             <a:ext cx="57150" cy="57150"/>
           </a:xfrm>
           <a:prstGeom prst="rect">
@@ -19413,7 +19413,7 @@
         </p:nvSpPr>
         <p:spPr>
           <a:xfrm>
-            <a:off x="6648450" y="3615309"/>
+            <a:off x="6648450" y="3524250"/>
             <a:ext cx="4857750" cy="95250"/>
           </a:xfrm>
           <a:prstGeom prst="rect">
@@ -19433,7 +19433,7 @@
               </a:lnSpc>
             </a:pPr>
             <a:r>
-              <a:rPr sz="1580" b="0" i="0">
+              <a:rPr sz="1500" b="0" i="0">
                 <a:solidFill>
                   <a:srgbClr val="1A1A1E"/>
                 </a:solidFill>
@@ -32431,7 +32431,7 @@
         </p:nvSpPr>
         <p:spPr>
           <a:xfrm>
-            <a:off x="685800" y="2083118"/>
+            <a:off x="685800" y="1988820"/>
             <a:ext cx="10820400" cy="3286125"/>
           </a:xfrm>
           <a:prstGeom prst="roundRect">
@@ -32477,7 +32477,7 @@
         </p:nvSpPr>
         <p:spPr>
           <a:xfrm>
-            <a:off x="952500" y="2292668"/>
+            <a:off x="952500" y="2198370"/>
             <a:ext cx="323850" cy="28575"/>
           </a:xfrm>
           <a:prstGeom prst="roundRect">
@@ -32523,7 +32523,7 @@
         </p:nvSpPr>
         <p:spPr>
           <a:xfrm>
-            <a:off x="1371600" y="2235518"/>
+            <a:off x="1371600" y="2141220"/>
             <a:ext cx="1905000" cy="167640"/>
           </a:xfrm>
           <a:prstGeom prst="rect">
@@ -32562,7 +32562,7 @@
         </p:nvSpPr>
         <p:spPr>
           <a:xfrm>
-            <a:off x="952500" y="2578418"/>
+            <a:off x="952500" y="2484120"/>
             <a:ext cx="10287000" cy="228600"/>
           </a:xfrm>
           <a:prstGeom prst="rect">
@@ -32601,7 +32601,7 @@
         </p:nvSpPr>
         <p:spPr>
           <a:xfrm>
-            <a:off x="952500" y="2816542"/>
+            <a:off x="952500" y="2722245"/>
             <a:ext cx="10287000" cy="228600"/>
           </a:xfrm>
           <a:prstGeom prst="rect">
@@ -32640,7 +32640,7 @@
         </p:nvSpPr>
         <p:spPr>
           <a:xfrm>
-            <a:off x="952500" y="3054668"/>
+            <a:off x="952500" y="2960370"/>
             <a:ext cx="10287000" cy="228600"/>
           </a:xfrm>
           <a:prstGeom prst="rect">
@@ -32679,7 +32679,7 @@
         </p:nvSpPr>
         <p:spPr>
           <a:xfrm>
-            <a:off x="952500" y="3292792"/>
+            <a:off x="952500" y="3198495"/>
             <a:ext cx="10287000" cy="228600"/>
           </a:xfrm>
           <a:prstGeom prst="rect">
@@ -32718,7 +32718,7 @@
         </p:nvSpPr>
         <p:spPr>
           <a:xfrm>
-            <a:off x="952500" y="3530918"/>
+            <a:off x="952500" y="3436620"/>
             <a:ext cx="10287000" cy="228600"/>
           </a:xfrm>
           <a:prstGeom prst="rect">
@@ -32757,7 +32757,7 @@
         </p:nvSpPr>
         <p:spPr>
           <a:xfrm>
-            <a:off x="952500" y="3769042"/>
+            <a:off x="952500" y="3674745"/>
             <a:ext cx="10287000" cy="228600"/>
           </a:xfrm>
           <a:prstGeom prst="rect">
@@ -32796,7 +32796,7 @@
         </p:nvSpPr>
         <p:spPr>
           <a:xfrm>
-            <a:off x="952500" y="4007168"/>
+            <a:off x="952500" y="3912870"/>
             <a:ext cx="10287000" cy="228600"/>
           </a:xfrm>
           <a:prstGeom prst="rect">
@@ -32835,7 +32835,7 @@
         </p:nvSpPr>
         <p:spPr>
           <a:xfrm>
-            <a:off x="952500" y="4245292"/>
+            <a:off x="952500" y="4150995"/>
             <a:ext cx="10287000" cy="228600"/>
           </a:xfrm>
           <a:prstGeom prst="rect">
@@ -32874,7 +32874,7 @@
         </p:nvSpPr>
         <p:spPr>
           <a:xfrm>
-            <a:off x="952500" y="4483418"/>
+            <a:off x="952500" y="4389120"/>
             <a:ext cx="10287000" cy="228600"/>
           </a:xfrm>
           <a:prstGeom prst="rect">
@@ -32913,7 +32913,7 @@
         </p:nvSpPr>
         <p:spPr>
           <a:xfrm>
-            <a:off x="952500" y="4721542"/>
+            <a:off x="952500" y="4627245"/>
             <a:ext cx="10287000" cy="228600"/>
           </a:xfrm>
           <a:prstGeom prst="rect">
@@ -32952,7 +32952,7 @@
         </p:nvSpPr>
         <p:spPr>
           <a:xfrm>
-            <a:off x="952500" y="4959668"/>
+            <a:off x="952500" y="4865370"/>
             <a:ext cx="10287000" cy="228600"/>
           </a:xfrm>
           <a:prstGeom prst="rect">
@@ -32991,8 +32991,8 @@
         </p:nvSpPr>
         <p:spPr>
           <a:xfrm>
-            <a:off x="685800" y="5597842"/>
-            <a:ext cx="28575" cy="377190"/>
+            <a:off x="685800" y="5503545"/>
+            <a:ext cx="28575" cy="565785"/>
           </a:xfrm>
           <a:prstGeom prst="rect">
             <a:avLst/>
@@ -33035,7 +33035,7 @@
         </p:nvSpPr>
         <p:spPr>
           <a:xfrm>
-            <a:off x="876300" y="5578792"/>
+            <a:off x="876300" y="5484495"/>
             <a:ext cx="10629900" cy="666750"/>
           </a:xfrm>
           <a:prstGeom prst="rect">
@@ -33061,7 +33061,7 @@
                 </a:solidFill>
                 <a:latin typeface="Roboto"/>
               </a:rPr>
-              <a:t>Saída da distro docker-desktop do WSL. O mesmo processo tem PID 1 dentro do container e outro PID no host, que é o que o namespace de PID faz. É por isso que no nosso diagrama de implantação o container aparece dentro do host, e não como máquina separada.</a:t>
+              <a:t>Namespaces e cgroups são recursos do kernel Linux, então no Windows o Docker Desktop roda o engine sobre o WSL2, que fornece um kernel Linux real numa máquina virtual leve. Esta saída é dessa distro. O mesmo processo tem PID 1 dentro do container e outro PID no host, que é o que o namespace de PID faz. É por isso que no nosso diagrama de implantação o container aparece dentro do host, e não como máquina separada.</a:t>
             </a:r>
           </a:p>
         </p:txBody>
@@ -34265,7 +34265,7 @@
         </p:nvSpPr>
         <p:spPr>
           <a:xfrm>
-            <a:off x="857250" y="2362200"/>
+            <a:off x="857250" y="2257425"/>
             <a:ext cx="4381500" cy="167640"/>
           </a:xfrm>
           <a:prstGeom prst="rect">
@@ -34304,7 +34304,7 @@
         </p:nvSpPr>
         <p:spPr>
           <a:xfrm>
-            <a:off x="857250" y="4076700"/>
+            <a:off x="857250" y="3971925"/>
             <a:ext cx="3429000" cy="438150"/>
           </a:xfrm>
           <a:prstGeom prst="roundRect">
@@ -34352,7 +34352,7 @@
         </p:nvSpPr>
         <p:spPr>
           <a:xfrm>
-            <a:off x="1047750" y="4210050"/>
+            <a:off x="1047750" y="4105275"/>
             <a:ext cx="3048000" cy="213360"/>
           </a:xfrm>
           <a:prstGeom prst="rect">
@@ -34391,7 +34391,7 @@
         </p:nvSpPr>
         <p:spPr>
           <a:xfrm>
-            <a:off x="857250" y="3581400"/>
+            <a:off x="857250" y="3476625"/>
             <a:ext cx="3429000" cy="438150"/>
           </a:xfrm>
           <a:prstGeom prst="roundRect">
@@ -34439,7 +34439,7 @@
         </p:nvSpPr>
         <p:spPr>
           <a:xfrm>
-            <a:off x="1047750" y="3714750"/>
+            <a:off x="1047750" y="3609975"/>
             <a:ext cx="3048000" cy="213360"/>
           </a:xfrm>
           <a:prstGeom prst="rect">
@@ -34478,7 +34478,7 @@
         </p:nvSpPr>
         <p:spPr>
           <a:xfrm>
-            <a:off x="857250" y="3086100"/>
+            <a:off x="857250" y="2981325"/>
             <a:ext cx="3429000" cy="438150"/>
           </a:xfrm>
           <a:prstGeom prst="roundRect">
@@ -34526,7 +34526,7 @@
         </p:nvSpPr>
         <p:spPr>
           <a:xfrm>
-            <a:off x="1047750" y="3219450"/>
+            <a:off x="1047750" y="3114675"/>
             <a:ext cx="3048000" cy="213360"/>
           </a:xfrm>
           <a:prstGeom prst="rect">
@@ -34565,7 +34565,7 @@
         </p:nvSpPr>
         <p:spPr>
           <a:xfrm>
-            <a:off x="4400550" y="3086100"/>
+            <a:off x="4400550" y="2981325"/>
             <a:ext cx="28575" cy="1428750"/>
           </a:xfrm>
           <a:prstGeom prst="rect">
@@ -34609,7 +34609,7 @@
         </p:nvSpPr>
         <p:spPr>
           <a:xfrm>
-            <a:off x="742950" y="4648200"/>
+            <a:off x="742950" y="4543425"/>
             <a:ext cx="3657600" cy="381000"/>
           </a:xfrm>
           <a:prstGeom prst="rect">
@@ -34648,7 +34648,7 @@
         </p:nvSpPr>
         <p:spPr>
           <a:xfrm>
-            <a:off x="857250" y="2533650"/>
+            <a:off x="857250" y="2428875"/>
             <a:ext cx="3429000" cy="495300"/>
           </a:xfrm>
           <a:prstGeom prst="roundRect">
@@ -34697,7 +34697,7 @@
         </p:nvSpPr>
         <p:spPr>
           <a:xfrm>
-            <a:off x="1047750" y="2628900"/>
+            <a:off x="1047750" y="2524125"/>
             <a:ext cx="3048000" cy="213360"/>
           </a:xfrm>
           <a:prstGeom prst="rect">
@@ -34736,7 +34736,7 @@
         </p:nvSpPr>
         <p:spPr>
           <a:xfrm>
-            <a:off x="1047750" y="2809875"/>
+            <a:off x="1047750" y="2705100"/>
             <a:ext cx="3048000" cy="182880"/>
           </a:xfrm>
           <a:prstGeom prst="rect">
@@ -34775,7 +34775,7 @@
         </p:nvCxnSpPr>
         <p:spPr>
           <a:xfrm>
-            <a:off x="4857750" y="2476500"/>
+            <a:off x="4857750" y="2371725"/>
             <a:ext cx="0" cy="2152650"/>
           </a:xfrm>
           <a:prstGeom prst="line">
@@ -34810,7 +34810,7 @@
         </p:nvSpPr>
         <p:spPr>
           <a:xfrm>
-            <a:off x="5257800" y="2933700"/>
+            <a:off x="5257800" y="2828925"/>
             <a:ext cx="3619500" cy="243840"/>
           </a:xfrm>
           <a:prstGeom prst="rect">
@@ -34849,7 +34849,7 @@
         </p:nvSpPr>
         <p:spPr>
           <a:xfrm>
-            <a:off x="5257800" y="3200400"/>
+            <a:off x="5257800" y="3095625"/>
             <a:ext cx="3810000" cy="666750"/>
           </a:xfrm>
           <a:prstGeom prst="rect">
@@ -34888,7 +34888,7 @@
         </p:nvSpPr>
         <p:spPr>
           <a:xfrm>
-            <a:off x="5257800" y="3771900"/>
+            <a:off x="5257800" y="3667125"/>
             <a:ext cx="3619500" cy="243840"/>
           </a:xfrm>
           <a:prstGeom prst="rect">
@@ -34927,7 +34927,7 @@
         </p:nvSpPr>
         <p:spPr>
           <a:xfrm>
-            <a:off x="5257800" y="4038600"/>
+            <a:off x="5257800" y="3933825"/>
             <a:ext cx="3810000" cy="666750"/>
           </a:xfrm>
           <a:prstGeom prst="rect">
@@ -34966,8 +34966,8 @@
         </p:nvSpPr>
         <p:spPr>
           <a:xfrm>
-            <a:off x="685800" y="5676321"/>
-            <a:ext cx="28575" cy="457779"/>
+            <a:off x="685800" y="5472135"/>
+            <a:ext cx="28575" cy="661965"/>
           </a:xfrm>
           <a:prstGeom prst="rect">
             <a:avLst/>
@@ -35010,8 +35010,8 @@
         </p:nvSpPr>
         <p:spPr>
           <a:xfrm>
-            <a:off x="876300" y="5657271"/>
-            <a:ext cx="10629900" cy="591129"/>
+            <a:off x="876300" y="5453085"/>
+            <a:ext cx="10629900" cy="795315"/>
           </a:xfrm>
           <a:prstGeom prst="rect">
             <a:avLst/>
@@ -35030,13 +35030,13 @@
               </a:lnSpc>
             </a:pPr>
             <a:r>
-              <a:rPr sz="1280" b="0" i="0">
+              <a:rPr sz="1200" b="0" i="0">
                 <a:solidFill>
                   <a:srgbClr val="3A3A44"/>
                 </a:solidFill>
                 <a:latin typeface="Roboto"/>
               </a:rPr>
-              <a:t>Um Dockerfile que copia um .env e faz RUN rm na instrução seguinte produz uma imagem em que o segredo continua legível. No nosso caso o segredo seria a senha do banco e o segredo de sessão do login do anfitrião, o UC001.</a:t>
+              <a:t>A imagem é construída a partir de um Dockerfile, o arquivo de texto que declara a base e os passos, e circula entre máquinas por um registry. Cada instrução vira uma camada, e por isso um Dockerfile que copia um .env e faz RUN rm na instrução seguinte produz uma imagem em que o segredo continua legível. No nosso caso o segredo seria a senha do banco e o segredo de sessão do login do anfitrião, o UC001.</a:t>
             </a:r>
           </a:p>
         </p:txBody>

</xml_diff>

<commit_message>
docs: reescreve os textos do slide 13, que diziam a mesma ideia em tres construcoes
</commit_message>
<xml_diff>
--- a/trabalhos/T1-Docker-Invite-People.pptx
+++ b/trabalhos/T1-Docker-Invite-People.pptx
@@ -13555,7 +13555,7 @@
                 </a:solidFill>
                 <a:latin typeface="Roboto"/>
               </a:rPr>
-              <a:t>As mesmas três camadas lógicas,</a:t>
+              <a:t>O sistema inteiro em um,</a:t>
             </a:r>
           </a:p>
           <a:p>
@@ -13571,7 +13571,7 @@
                 </a:solidFill>
                 <a:latin typeface="Roboto"/>
               </a:rPr>
-              <a:t>empacotadas de três jeitos</a:t>
+              <a:t>dois ou três containers</a:t>
             </a:r>
           </a:p>
         </p:txBody>
@@ -13610,7 +13610,7 @@
                 </a:solidFill>
                 <a:latin typeface="Roboto"/>
               </a:rPr>
-              <a:t>AS TRÊS CAMADAS LÓGICAS FICAM SEMPRE NA MESMA IMAGEM. O QUE MUDA É ONDE O FRONT-END E O BANCO RODAM.</a:t>
+              <a:t>AS TRÊS CAMADAS DO BACK-END FICAM NA MESMA IMAGEM NOS TRÊS DESENHOS.</a:t>
             </a:r>
           </a:p>
         </p:txBody>
@@ -15238,7 +15238,7 @@
                 </a:solidFill>
                 <a:latin typeface="Roboto"/>
               </a:rPr>
-              <a:t>Nenhuma das três muda uma linha do projeto lógico. Todas mudam o empacotamento, e essa escolha é entrada do ADR, o documento de decisões arquiteturais da Sprint 2. Cuidado com o vocabulário: Docker usa </a:t>
+              <a:t>O projeto lógico é o mesmo nas três opções, e a escolha entre elas entra no ADR, o documento de decisões arquiteturais da Sprint 2. O Docker também usa a palavra </a:t>
             </a:r>
             <a:r>
               <a:rPr sz="1280" b="0" i="1">
@@ -15256,7 +15256,7 @@
                 </a:solidFill>
                 <a:latin typeface="Roboto"/>
               </a:rPr>
-              <a:t> para o empilhamento do sistema de arquivos da imagem, que não tem relação com a camada lógica da Aula 03.</a:t>
+              <a:t>, mas para o empilhamento do sistema de arquivos da imagem, que é outra coisa e não tem relação com a camada lógica da Aula 03.</a:t>
             </a:r>
           </a:p>
         </p:txBody>

</xml_diff>

<commit_message>
docs: tira dos slides do T1 as clausulas que classificam o proprio fato
</commit_message>
<xml_diff>
--- a/trabalhos/T1-Docker-Invite-People.pptx
+++ b/trabalhos/T1-Docker-Invite-People.pptx
@@ -18788,7 +18788,7 @@
         </p:nvSpPr>
         <p:spPr>
           <a:xfrm>
-            <a:off x="685800" y="2026920"/>
+            <a:off x="685800" y="2061210"/>
             <a:ext cx="5143500" cy="182880"/>
           </a:xfrm>
           <a:prstGeom prst="rect">
@@ -18827,7 +18827,7 @@
         </p:nvSpPr>
         <p:spPr>
           <a:xfrm>
-            <a:off x="685800" y="2236470"/>
+            <a:off x="685800" y="2270760"/>
             <a:ext cx="419100" cy="28575"/>
           </a:xfrm>
           <a:prstGeom prst="rect">
@@ -18871,7 +18871,7 @@
         </p:nvSpPr>
         <p:spPr>
           <a:xfrm>
-            <a:off x="704850" y="2621280"/>
+            <a:off x="704850" y="2660523"/>
             <a:ext cx="57150" cy="57150"/>
           </a:xfrm>
           <a:prstGeom prst="rect">
@@ -18915,7 +18915,7 @@
         </p:nvSpPr>
         <p:spPr>
           <a:xfrm>
-            <a:off x="971550" y="2522220"/>
+            <a:off x="971550" y="2556510"/>
             <a:ext cx="4857750" cy="95250"/>
           </a:xfrm>
           <a:prstGeom prst="rect">
@@ -18935,13 +18935,13 @@
               </a:lnSpc>
             </a:pPr>
             <a:r>
-              <a:rPr sz="1500" b="0" i="0">
+              <a:rPr sz="1580" b="0" i="0">
                 <a:solidFill>
                   <a:srgbClr val="1A1A1E"/>
                 </a:solidFill>
                 <a:latin typeface="Roboto"/>
               </a:rPr>
-              <a:t>A imagem passa a ter uma responsabilidade só, que é mais coesão.</a:t>
+              <a:t>A imagem passa a ter uma responsabilidade só.</a:t>
             </a:r>
           </a:p>
         </p:txBody>
@@ -18954,7 +18954,7 @@
         </p:nvSpPr>
         <p:spPr>
           <a:xfrm>
-            <a:off x="704850" y="3371850"/>
+            <a:off x="704850" y="3191256"/>
             <a:ext cx="57150" cy="57150"/>
           </a:xfrm>
           <a:prstGeom prst="rect">
@@ -18998,7 +18998,7 @@
         </p:nvSpPr>
         <p:spPr>
           <a:xfrm>
-            <a:off x="971550" y="3272790"/>
+            <a:off x="971550" y="3087243"/>
             <a:ext cx="4857750" cy="95250"/>
           </a:xfrm>
           <a:prstGeom prst="rect">
@@ -19018,7 +19018,7 @@
               </a:lnSpc>
             </a:pPr>
             <a:r>
-              <a:rPr sz="1500" b="0" i="0">
+              <a:rPr sz="1580" b="0" i="0">
                 <a:solidFill>
                   <a:srgbClr val="1A1A1E"/>
                 </a:solidFill>
@@ -19037,7 +19037,7 @@
         </p:nvSpPr>
         <p:spPr>
           <a:xfrm>
-            <a:off x="704850" y="4122420"/>
+            <a:off x="704850" y="3986022"/>
             <a:ext cx="57150" cy="57150"/>
           </a:xfrm>
           <a:prstGeom prst="rect">
@@ -19081,7 +19081,7 @@
         </p:nvSpPr>
         <p:spPr>
           <a:xfrm>
-            <a:off x="971550" y="4023360"/>
+            <a:off x="971550" y="3882009"/>
             <a:ext cx="4857750" cy="95250"/>
           </a:xfrm>
           <a:prstGeom prst="rect">
@@ -19101,7 +19101,7 @@
               </a:lnSpc>
             </a:pPr>
             <a:r>
-              <a:rPr sz="1500" b="0" i="0">
+              <a:rPr sz="1580" b="0" i="0">
                 <a:solidFill>
                   <a:srgbClr val="1A1A1E"/>
                 </a:solidFill>
@@ -19120,7 +19120,7 @@
         </p:nvSpPr>
         <p:spPr>
           <a:xfrm>
-            <a:off x="704850" y="5375910"/>
+            <a:off x="704850" y="5308854"/>
             <a:ext cx="57150" cy="57150"/>
           </a:xfrm>
           <a:prstGeom prst="rect">
@@ -19164,7 +19164,7 @@
         </p:nvSpPr>
         <p:spPr>
           <a:xfrm>
-            <a:off x="971550" y="5276850"/>
+            <a:off x="971550" y="5204841"/>
             <a:ext cx="4857750" cy="95250"/>
           </a:xfrm>
           <a:prstGeom prst="rect">
@@ -19184,13 +19184,13 @@
               </a:lnSpc>
             </a:pPr>
             <a:r>
-              <a:rPr sz="1500" b="0" i="0">
+              <a:rPr sz="1580" b="0" i="0">
                 <a:solidFill>
                   <a:srgbClr val="1A1A1E"/>
                 </a:solidFill>
                 <a:latin typeface="Roboto"/>
               </a:rPr>
-              <a:t>Uma regra escrita na wiki depende de alguém revisar. A mesma regra na topologia é verificada pela estrutura, o que reduz a degradação arquitetural.</a:t>
+              <a:t>Uma regra escrita na wiki depende de alguém revisar. A mesma regra na topologia é verificada pela estrutura.</a:t>
             </a:r>
           </a:p>
         </p:txBody>
@@ -19203,7 +19203,7 @@
         </p:nvSpPr>
         <p:spPr>
           <a:xfrm>
-            <a:off x="6362700" y="2026920"/>
+            <a:off x="6362700" y="2061210"/>
             <a:ext cx="5143500" cy="182880"/>
           </a:xfrm>
           <a:prstGeom prst="rect">
@@ -19242,7 +19242,7 @@
         </p:nvSpPr>
         <p:spPr>
           <a:xfrm>
-            <a:off x="6362700" y="2236470"/>
+            <a:off x="6362700" y="2270760"/>
             <a:ext cx="419100" cy="28575"/>
           </a:xfrm>
           <a:prstGeom prst="rect">
@@ -19286,7 +19286,7 @@
         </p:nvSpPr>
         <p:spPr>
           <a:xfrm>
-            <a:off x="6381750" y="2621280"/>
+            <a:off x="6381750" y="2660523"/>
             <a:ext cx="57150" cy="57150"/>
           </a:xfrm>
           <a:prstGeom prst="rect">
@@ -19330,7 +19330,7 @@
         </p:nvSpPr>
         <p:spPr>
           <a:xfrm>
-            <a:off x="6648450" y="2522220"/>
+            <a:off x="6648450" y="2556510"/>
             <a:ext cx="4857750" cy="95250"/>
           </a:xfrm>
           <a:prstGeom prst="rect">
@@ -19350,7 +19350,7 @@
               </a:lnSpc>
             </a:pPr>
             <a:r>
-              <a:rPr sz="1500" b="0" i="0">
+              <a:rPr sz="1580" b="0" i="0">
                 <a:solidFill>
                   <a:srgbClr val="1A1A1E"/>
                 </a:solidFill>
@@ -19369,7 +19369,7 @@
         </p:nvSpPr>
         <p:spPr>
           <a:xfrm>
-            <a:off x="6381750" y="3623310"/>
+            <a:off x="6381750" y="3719322"/>
             <a:ext cx="57150" cy="57150"/>
           </a:xfrm>
           <a:prstGeom prst="rect">
@@ -19413,7 +19413,7 @@
         </p:nvSpPr>
         <p:spPr>
           <a:xfrm>
-            <a:off x="6648450" y="3524250"/>
+            <a:off x="6648450" y="3615309"/>
             <a:ext cx="4857750" cy="95250"/>
           </a:xfrm>
           <a:prstGeom prst="rect">
@@ -19433,7 +19433,7 @@
               </a:lnSpc>
             </a:pPr>
             <a:r>
-              <a:rPr sz="1500" b="0" i="0">
+              <a:rPr sz="1580" b="0" i="0">
                 <a:solidFill>
                   <a:srgbClr val="1A1A1E"/>
                 </a:solidFill>
@@ -20757,7 +20757,7 @@
         </p:nvSpPr>
         <p:spPr>
           <a:xfrm>
-            <a:off x="704850" y="2445639"/>
+            <a:off x="704850" y="2583942"/>
             <a:ext cx="57150" cy="57150"/>
           </a:xfrm>
           <a:prstGeom prst="rect">
@@ -20801,7 +20801,7 @@
         </p:nvSpPr>
         <p:spPr>
           <a:xfrm>
-            <a:off x="971550" y="2336673"/>
+            <a:off x="971550" y="2474976"/>
             <a:ext cx="7677150" cy="95250"/>
           </a:xfrm>
           <a:prstGeom prst="rect">
@@ -20840,7 +20840,7 @@
         </p:nvSpPr>
         <p:spPr>
           <a:xfrm>
-            <a:off x="704850" y="3284601"/>
+            <a:off x="704850" y="3422904"/>
             <a:ext cx="57150" cy="57150"/>
           </a:xfrm>
           <a:prstGeom prst="rect">
@@ -20884,7 +20884,7 @@
         </p:nvSpPr>
         <p:spPr>
           <a:xfrm>
-            <a:off x="971550" y="3175635"/>
+            <a:off x="971550" y="3313938"/>
             <a:ext cx="7677150" cy="95250"/>
           </a:xfrm>
           <a:prstGeom prst="rect">
@@ -20923,7 +20923,7 @@
         </p:nvSpPr>
         <p:spPr>
           <a:xfrm>
-            <a:off x="704850" y="4123563"/>
+            <a:off x="704850" y="4261866"/>
             <a:ext cx="57150" cy="57150"/>
           </a:xfrm>
           <a:prstGeom prst="rect">
@@ -20967,7 +20967,7 @@
         </p:nvSpPr>
         <p:spPr>
           <a:xfrm>
-            <a:off x="971550" y="4014597"/>
+            <a:off x="971550" y="4152900"/>
             <a:ext cx="7677150" cy="95250"/>
           </a:xfrm>
           <a:prstGeom prst="rect">
@@ -21006,7 +21006,7 @@
         </p:nvSpPr>
         <p:spPr>
           <a:xfrm>
-            <a:off x="704850" y="4962525"/>
+            <a:off x="704850" y="5100828"/>
             <a:ext cx="57150" cy="57150"/>
           </a:xfrm>
           <a:prstGeom prst="rect">
@@ -21050,7 +21050,7 @@
         </p:nvSpPr>
         <p:spPr>
           <a:xfrm>
-            <a:off x="971550" y="4853559"/>
+            <a:off x="971550" y="4991862"/>
             <a:ext cx="7677150" cy="95250"/>
           </a:xfrm>
           <a:prstGeom prst="rect">
@@ -21076,7 +21076,7 @@
                 </a:solidFill>
                 <a:latin typeface="Roboto"/>
               </a:rPr>
-              <a:t>A Questão Norteadora da Sprint 2, que é a pergunta que a sprint precisa responder, é como os componentes serão distribuídos e implantados no ambiente de execução.</a:t>
+              <a:t>A Sprint 2 tem uma Questão Norteadora a responder: como os componentes serão distribuídos e implantados no ambiente de execução.</a:t>
             </a:r>
           </a:p>
         </p:txBody>
@@ -21089,7 +21089,7 @@
         </p:nvSpPr>
         <p:spPr>
           <a:xfrm>
-            <a:off x="9124950" y="2336673"/>
+            <a:off x="9124950" y="2474976"/>
             <a:ext cx="142875" cy="142875"/>
           </a:xfrm>
           <a:prstGeom prst="donut">
@@ -21133,7 +21133,7 @@
         </p:nvSpPr>
         <p:spPr>
           <a:xfrm>
-            <a:off x="9372600" y="2346198"/>
+            <a:off x="9372600" y="2484501"/>
             <a:ext cx="2133600" cy="182880"/>
           </a:xfrm>
           <a:prstGeom prst="rect">
@@ -21172,7 +21172,7 @@
         </p:nvSpPr>
         <p:spPr>
           <a:xfrm>
-            <a:off x="9124950" y="2622423"/>
+            <a:off x="9124950" y="2760726"/>
             <a:ext cx="38100" cy="1033272"/>
           </a:xfrm>
           <a:prstGeom prst="rect">
@@ -21216,7 +21216,7 @@
         </p:nvSpPr>
         <p:spPr>
           <a:xfrm>
-            <a:off x="9334500" y="2622423"/>
+            <a:off x="9334500" y="2760726"/>
             <a:ext cx="2171700" cy="1604772"/>
           </a:xfrm>
           <a:prstGeom prst="rect">
@@ -22711,7 +22711,7 @@
         </p:nvSpPr>
         <p:spPr>
           <a:xfrm>
-            <a:off x="704850" y="2583942"/>
+            <a:off x="704850" y="2722245"/>
             <a:ext cx="57150" cy="57150"/>
           </a:xfrm>
           <a:prstGeom prst="rect">
@@ -22755,7 +22755,7 @@
         </p:nvSpPr>
         <p:spPr>
           <a:xfrm>
-            <a:off x="971550" y="2474976"/>
+            <a:off x="971550" y="2613279"/>
             <a:ext cx="7772400" cy="95250"/>
           </a:xfrm>
           <a:prstGeom prst="rect">
@@ -22794,7 +22794,7 @@
         </p:nvSpPr>
         <p:spPr>
           <a:xfrm>
-            <a:off x="704850" y="3422904"/>
+            <a:off x="704850" y="3561207"/>
             <a:ext cx="57150" cy="57150"/>
           </a:xfrm>
           <a:prstGeom prst="rect">
@@ -22838,7 +22838,7 @@
         </p:nvSpPr>
         <p:spPr>
           <a:xfrm>
-            <a:off x="971550" y="3313938"/>
+            <a:off x="971550" y="3452241"/>
             <a:ext cx="7772400" cy="95250"/>
           </a:xfrm>
           <a:prstGeom prst="rect">
@@ -22877,7 +22877,7 @@
         </p:nvSpPr>
         <p:spPr>
           <a:xfrm>
-            <a:off x="704850" y="4261866"/>
+            <a:off x="704850" y="4400169"/>
             <a:ext cx="57150" cy="57150"/>
           </a:xfrm>
           <a:prstGeom prst="rect">
@@ -22921,7 +22921,7 @@
         </p:nvSpPr>
         <p:spPr>
           <a:xfrm>
-            <a:off x="971550" y="4152900"/>
+            <a:off x="971550" y="4291203"/>
             <a:ext cx="7772400" cy="95250"/>
           </a:xfrm>
           <a:prstGeom prst="rect">
@@ -22960,7 +22960,7 @@
         </p:nvSpPr>
         <p:spPr>
           <a:xfrm>
-            <a:off x="704850" y="5100828"/>
+            <a:off x="704850" y="5239131"/>
             <a:ext cx="57150" cy="57150"/>
           </a:xfrm>
           <a:prstGeom prst="rect">
@@ -23004,7 +23004,7 @@
         </p:nvSpPr>
         <p:spPr>
           <a:xfrm>
-            <a:off x="971550" y="4991862"/>
+            <a:off x="971550" y="5130165"/>
             <a:ext cx="7772400" cy="95250"/>
           </a:xfrm>
           <a:prstGeom prst="rect">
@@ -23030,7 +23030,7 @@
                 </a:solidFill>
                 <a:latin typeface="Roboto"/>
               </a:rPr>
-              <a:t>O Docker Desktop é pago para empresa acima de certo porte, o que afeta quem for usar isto fora da faculdade.</a:t>
+              <a:t>O Docker Desktop é pago para empresa acima de certo porte.</a:t>
             </a:r>
           </a:p>
         </p:txBody>
@@ -23043,7 +23043,7 @@
         </p:nvSpPr>
         <p:spPr>
           <a:xfrm>
-            <a:off x="9124950" y="2474976"/>
+            <a:off x="9124950" y="2613279"/>
             <a:ext cx="152400" cy="133350"/>
           </a:xfrm>
           <a:prstGeom prst="triangle">
@@ -23087,7 +23087,7 @@
         </p:nvSpPr>
         <p:spPr>
           <a:xfrm>
-            <a:off x="9193530" y="2532126"/>
+            <a:off x="9193530" y="2670429"/>
             <a:ext cx="15240" cy="38100"/>
           </a:xfrm>
           <a:prstGeom prst="rect">
@@ -23131,7 +23131,7 @@
         </p:nvSpPr>
         <p:spPr>
           <a:xfrm>
-            <a:off x="9372600" y="2484501"/>
+            <a:off x="9372600" y="2622804"/>
             <a:ext cx="2133600" cy="182880"/>
           </a:xfrm>
           <a:prstGeom prst="rect">
@@ -23170,7 +23170,7 @@
         </p:nvSpPr>
         <p:spPr>
           <a:xfrm>
-            <a:off x="9124950" y="2760726"/>
+            <a:off x="9124950" y="2899029"/>
             <a:ext cx="38100" cy="1005840"/>
           </a:xfrm>
           <a:prstGeom prst="rect">
@@ -23214,7 +23214,7 @@
         </p:nvSpPr>
         <p:spPr>
           <a:xfrm>
-            <a:off x="9334500" y="2760726"/>
+            <a:off x="9334500" y="2899029"/>
             <a:ext cx="2171700" cy="1577340"/>
           </a:xfrm>
           <a:prstGeom prst="rect">
@@ -26388,7 +26388,7 @@
         </p:nvSpPr>
         <p:spPr>
           <a:xfrm>
-            <a:off x="685800" y="2010346"/>
+            <a:off x="685800" y="2028825"/>
             <a:ext cx="5143500" cy="182880"/>
           </a:xfrm>
           <a:prstGeom prst="rect">
@@ -26427,7 +26427,7 @@
         </p:nvSpPr>
         <p:spPr>
           <a:xfrm>
-            <a:off x="685800" y="2219896"/>
+            <a:off x="685800" y="2238375"/>
             <a:ext cx="419100" cy="28575"/>
           </a:xfrm>
           <a:prstGeom prst="rect">
@@ -26471,7 +26471,7 @@
         </p:nvSpPr>
         <p:spPr>
           <a:xfrm>
-            <a:off x="704850" y="2599754"/>
+            <a:off x="704850" y="2623185"/>
             <a:ext cx="57150" cy="57150"/>
           </a:xfrm>
           <a:prstGeom prst="rect">
@@ -26515,7 +26515,7 @@
         </p:nvSpPr>
         <p:spPr>
           <a:xfrm>
-            <a:off x="971550" y="2505646"/>
+            <a:off x="971550" y="2524125"/>
             <a:ext cx="4857750" cy="95250"/>
           </a:xfrm>
           <a:prstGeom prst="rect">
@@ -26535,13 +26535,13 @@
               </a:lnSpc>
             </a:pPr>
             <a:r>
-              <a:rPr sz="1420" b="0" i="0">
+              <a:rPr sz="1500" b="0" i="0">
                 <a:solidFill>
                   <a:srgbClr val="1A1A1E"/>
                 </a:solidFill>
                 <a:latin typeface="Roboto"/>
               </a:rPr>
-              <a:t>Cada imagem tem uma responsabilidade e uma fronteira declarada, que é modularidade e reusabilidade.</a:t>
+              <a:t>Uma responsabilidade por imagem, com a fronteira declarada.</a:t>
             </a:r>
           </a:p>
         </p:txBody>
@@ -26554,7 +26554,7 @@
         </p:nvSpPr>
         <p:spPr>
           <a:xfrm>
-            <a:off x="704850" y="3306128"/>
+            <a:off x="704850" y="3373755"/>
             <a:ext cx="57150" cy="57150"/>
           </a:xfrm>
           <a:prstGeom prst="rect">
@@ -26598,7 +26598,7 @@
         </p:nvSpPr>
         <p:spPr>
           <a:xfrm>
-            <a:off x="971550" y="3212021"/>
+            <a:off x="971550" y="3274695"/>
             <a:ext cx="4857750" cy="95250"/>
           </a:xfrm>
           <a:prstGeom prst="rect">
@@ -26618,13 +26618,13 @@
               </a:lnSpc>
             </a:pPr>
             <a:r>
-              <a:rPr sz="1420" b="0" i="0">
+              <a:rPr sz="1500" b="0" i="0">
                 <a:solidFill>
                   <a:srgbClr val="1A1A1E"/>
                 </a:solidFill>
                 <a:latin typeface="Roboto"/>
               </a:rPr>
-              <a:t>O ambiente vira arquivo legível, versionado junto com o código, e com isso ganha compreensibilidade.</a:t>
+              <a:t>O ambiente vira arquivo legível, versionado junto com o código.</a:t>
             </a:r>
           </a:p>
         </p:txBody>
@@ -26637,7 +26637,7 @@
         </p:nvSpPr>
         <p:spPr>
           <a:xfrm>
-            <a:off x="704850" y="4012502"/>
+            <a:off x="704850" y="4124325"/>
             <a:ext cx="57150" cy="57150"/>
           </a:xfrm>
           <a:prstGeom prst="rect">
@@ -26681,7 +26681,7 @@
         </p:nvSpPr>
         <p:spPr>
           <a:xfrm>
-            <a:off x="971550" y="3918394"/>
+            <a:off x="971550" y="4025265"/>
             <a:ext cx="4857750" cy="95250"/>
           </a:xfrm>
           <a:prstGeom prst="rect">
@@ -26701,13 +26701,13 @@
               </a:lnSpc>
             </a:pPr>
             <a:r>
-              <a:rPr sz="1420" b="0" i="0">
+              <a:rPr sz="1500" b="0" i="0">
                 <a:solidFill>
                   <a:srgbClr val="1A1A1E"/>
                 </a:solidFill>
                 <a:latin typeface="Roboto"/>
               </a:rPr>
-              <a:t>Extensibilidade sai barata, porque trocar runtime ou banco é editar uma linha de arquivo.</a:t>
+              <a:t>Trocar runtime ou banco passa a ser editar uma linha de arquivo.</a:t>
             </a:r>
           </a:p>
         </p:txBody>
@@ -26720,7 +26720,7 @@
         </p:nvSpPr>
         <p:spPr>
           <a:xfrm>
-            <a:off x="704850" y="4718876"/>
+            <a:off x="704850" y="4874895"/>
             <a:ext cx="57150" cy="57150"/>
           </a:xfrm>
           <a:prstGeom prst="rect">
@@ -26764,7 +26764,7 @@
         </p:nvSpPr>
         <p:spPr>
           <a:xfrm>
-            <a:off x="971550" y="4624768"/>
+            <a:off x="971550" y="4775835"/>
             <a:ext cx="4857750" cy="95250"/>
           </a:xfrm>
           <a:prstGeom prst="rect">
@@ -26784,13 +26784,13 @@
               </a:lnSpc>
             </a:pPr>
             <a:r>
-              <a:rPr sz="1420" b="0" i="0">
+              <a:rPr sz="1500" b="0" i="0">
                 <a:solidFill>
                   <a:srgbClr val="1A1A1E"/>
                 </a:solidFill>
                 <a:latin typeface="Roboto"/>
               </a:rPr>
-              <a:t>A mesma imagem atravessa notebook, pipeline e a demonstração funcional do T3, o que ajuda a manutenibilidade.</a:t>
+              <a:t>A mesma imagem atravessa notebook, pipeline e a demonstração do T3.</a:t>
             </a:r>
           </a:p>
         </p:txBody>
@@ -26803,7 +26803,7 @@
         </p:nvSpPr>
         <p:spPr>
           <a:xfrm>
-            <a:off x="704850" y="5664136"/>
+            <a:off x="704850" y="5625465"/>
             <a:ext cx="57150" cy="57150"/>
           </a:xfrm>
           <a:prstGeom prst="rect">
@@ -26847,7 +26847,7 @@
         </p:nvSpPr>
         <p:spPr>
           <a:xfrm>
-            <a:off x="971550" y="5570030"/>
+            <a:off x="971550" y="5526405"/>
             <a:ext cx="4857750" cy="95250"/>
           </a:xfrm>
           <a:prstGeom prst="rect">
@@ -26867,13 +26867,13 @@
               </a:lnSpc>
             </a:pPr>
             <a:r>
-              <a:rPr sz="1420" b="0" i="0">
+              <a:rPr sz="1500" b="0" i="0">
                 <a:solidFill>
                   <a:srgbClr val="1A1A1E"/>
                 </a:solidFill>
                 <a:latin typeface="Roboto"/>
               </a:rPr>
-              <a:t>A escalabilidade fica seletiva, e só vale se a aplicação for mesmo sem estado.</a:t>
+              <a:t>Dá para escalar só o serviço público, se a aplicação for mesmo sem estado.</a:t>
             </a:r>
           </a:p>
         </p:txBody>
@@ -26886,7 +26886,7 @@
         </p:nvSpPr>
         <p:spPr>
           <a:xfrm>
-            <a:off x="6362700" y="2010346"/>
+            <a:off x="6362700" y="2028825"/>
             <a:ext cx="5143500" cy="182880"/>
           </a:xfrm>
           <a:prstGeom prst="rect">
@@ -26925,7 +26925,7 @@
         </p:nvSpPr>
         <p:spPr>
           <a:xfrm>
-            <a:off x="6362700" y="2219896"/>
+            <a:off x="6362700" y="2238375"/>
             <a:ext cx="419100" cy="28575"/>
           </a:xfrm>
           <a:prstGeom prst="rect">
@@ -26969,7 +26969,7 @@
         </p:nvSpPr>
         <p:spPr>
           <a:xfrm>
-            <a:off x="6381750" y="2599754"/>
+            <a:off x="6381750" y="2623185"/>
             <a:ext cx="57150" cy="57150"/>
           </a:xfrm>
           <a:prstGeom prst="rect">
@@ -27013,7 +27013,7 @@
         </p:nvSpPr>
         <p:spPr>
           <a:xfrm>
-            <a:off x="6648450" y="2505646"/>
+            <a:off x="6648450" y="2524125"/>
             <a:ext cx="4857750" cy="95250"/>
           </a:xfrm>
           <a:prstGeom prst="rect">
@@ -27033,13 +27033,13 @@
               </a:lnSpc>
             </a:pPr>
             <a:r>
-              <a:rPr sz="1420" b="0" i="0">
+              <a:rPr sz="1500" b="0" i="0">
                 <a:solidFill>
                   <a:srgbClr val="1A1A1E"/>
                 </a:solidFill>
                 <a:latin typeface="Roboto"/>
               </a:rPr>
-              <a:t>Segurança ganha isolamento e herda uma superfície nova, que é a imagem base e o privilégio de execução.</a:t>
+              <a:t>Uma superfície de ataque nova, na imagem base e no privilégio de execução.</a:t>
             </a:r>
           </a:p>
         </p:txBody>
@@ -27052,7 +27052,7 @@
         </p:nvSpPr>
         <p:spPr>
           <a:xfrm>
-            <a:off x="6381750" y="3306128"/>
+            <a:off x="6381750" y="3373755"/>
             <a:ext cx="57150" cy="57150"/>
           </a:xfrm>
           <a:prstGeom prst="rect">
@@ -27096,7 +27096,7 @@
         </p:nvSpPr>
         <p:spPr>
           <a:xfrm>
-            <a:off x="6648450" y="3212021"/>
+            <a:off x="6648450" y="3274695"/>
             <a:ext cx="4857750" cy="95250"/>
           </a:xfrm>
           <a:prstGeom prst="rect">
@@ -27116,13 +27116,13 @@
               </a:lnSpc>
             </a:pPr>
             <a:r>
-              <a:rPr sz="1420" b="0" i="0">
+              <a:rPr sz="1500" b="0" i="0">
                 <a:solidFill>
                   <a:srgbClr val="1A1A1E"/>
                 </a:solidFill>
                 <a:latin typeface="Roboto"/>
               </a:rPr>
-              <a:t>Desempenho custa, principalmente I/O nas máquinas Windows, e a Aula 03 já avisa que camada extra prejudica desempenho.</a:t>
+              <a:t>I/O mais lento, principalmente nas máquinas Windows. A Aula 03 já avisa que camada extra prejudica desempenho.</a:t>
             </a:r>
           </a:p>
         </p:txBody>
@@ -31794,7 +31794,7 @@
         </p:nvSpPr>
         <p:spPr>
           <a:xfrm>
-            <a:off x="685800" y="2723960"/>
+            <a:off x="685800" y="2855976"/>
             <a:ext cx="5143500" cy="182880"/>
           </a:xfrm>
           <a:prstGeom prst="rect">
@@ -31833,7 +31833,7 @@
         </p:nvSpPr>
         <p:spPr>
           <a:xfrm>
-            <a:off x="685800" y="2933510"/>
+            <a:off x="685800" y="3065526"/>
             <a:ext cx="419100" cy="28575"/>
           </a:xfrm>
           <a:prstGeom prst="rect">
@@ -31877,7 +31877,7 @@
         </p:nvSpPr>
         <p:spPr>
           <a:xfrm>
-            <a:off x="704850" y="3323273"/>
+            <a:off x="704850" y="3455289"/>
             <a:ext cx="57150" cy="57150"/>
           </a:xfrm>
           <a:prstGeom prst="rect">
@@ -31921,7 +31921,7 @@
         </p:nvSpPr>
         <p:spPr>
           <a:xfrm>
-            <a:off x="971550" y="3219260"/>
+            <a:off x="971550" y="3351276"/>
             <a:ext cx="4857750" cy="95250"/>
           </a:xfrm>
           <a:prstGeom prst="rect">
@@ -31960,7 +31960,7 @@
         </p:nvSpPr>
         <p:spPr>
           <a:xfrm>
-            <a:off x="6362700" y="2723960"/>
+            <a:off x="6362700" y="2855976"/>
             <a:ext cx="5143500" cy="182880"/>
           </a:xfrm>
           <a:prstGeom prst="rect">
@@ -31999,7 +31999,7 @@
         </p:nvSpPr>
         <p:spPr>
           <a:xfrm>
-            <a:off x="6362700" y="2933510"/>
+            <a:off x="6362700" y="3065526"/>
             <a:ext cx="419100" cy="28575"/>
           </a:xfrm>
           <a:prstGeom prst="rect">
@@ -32043,7 +32043,7 @@
         </p:nvSpPr>
         <p:spPr>
           <a:xfrm>
-            <a:off x="6381750" y="3323273"/>
+            <a:off x="6381750" y="3455289"/>
             <a:ext cx="57150" cy="57150"/>
           </a:xfrm>
           <a:prstGeom prst="rect">
@@ -32087,7 +32087,7 @@
         </p:nvSpPr>
         <p:spPr>
           <a:xfrm>
-            <a:off x="6648450" y="3219260"/>
+            <a:off x="6648450" y="3351276"/>
             <a:ext cx="4857750" cy="95250"/>
           </a:xfrm>
           <a:prstGeom prst="rect">
@@ -32113,7 +32113,7 @@
                 </a:solidFill>
                 <a:latin typeface="Roboto"/>
               </a:rPr>
-              <a:t>Conjunto ordenado de camadas de sistema de arquivos mais a configuração de execução, identificado por um digest, que é o hash do próprio conteúdo.</a:t>
+              <a:t>Conjunto ordenado de camadas de sistema de arquivos mais a configuração de execução, identificado por um digest, o hash do próprio conteúdo.</a:t>
             </a:r>
           </a:p>
         </p:txBody>
@@ -32126,7 +32126,7 @@
         </p:nvSpPr>
         <p:spPr>
           <a:xfrm>
-            <a:off x="6381750" y="4646104"/>
+            <a:off x="6381750" y="4514088"/>
             <a:ext cx="57150" cy="57150"/>
           </a:xfrm>
           <a:prstGeom prst="rect">
@@ -32170,7 +32170,7 @@
         </p:nvSpPr>
         <p:spPr>
           <a:xfrm>
-            <a:off x="6648450" y="4542092"/>
+            <a:off x="6648450" y="4410075"/>
             <a:ext cx="4857750" cy="95250"/>
           </a:xfrm>
           <a:prstGeom prst="rect">
@@ -33296,7 +33296,7 @@
         </p:nvSpPr>
         <p:spPr>
           <a:xfrm>
-            <a:off x="685800" y="2061210"/>
+            <a:off x="685800" y="2193226"/>
             <a:ext cx="5143500" cy="182880"/>
           </a:xfrm>
           <a:prstGeom prst="rect">
@@ -33335,7 +33335,7 @@
         </p:nvSpPr>
         <p:spPr>
           <a:xfrm>
-            <a:off x="685800" y="2270760"/>
+            <a:off x="685800" y="2402776"/>
             <a:ext cx="419100" cy="28575"/>
           </a:xfrm>
           <a:prstGeom prst="rect">
@@ -33379,7 +33379,7 @@
         </p:nvSpPr>
         <p:spPr>
           <a:xfrm>
-            <a:off x="704850" y="2660523"/>
+            <a:off x="704850" y="2792540"/>
             <a:ext cx="57150" cy="57150"/>
           </a:xfrm>
           <a:prstGeom prst="rect">
@@ -33423,7 +33423,7 @@
         </p:nvSpPr>
         <p:spPr>
           <a:xfrm>
-            <a:off x="971550" y="2556510"/>
+            <a:off x="971550" y="2688526"/>
             <a:ext cx="4857750" cy="95250"/>
           </a:xfrm>
           <a:prstGeom prst="rect">
@@ -33462,7 +33462,7 @@
         </p:nvSpPr>
         <p:spPr>
           <a:xfrm>
-            <a:off x="704850" y="3455289"/>
+            <a:off x="704850" y="3587306"/>
             <a:ext cx="57150" cy="57150"/>
           </a:xfrm>
           <a:prstGeom prst="rect">
@@ -33506,7 +33506,7 @@
         </p:nvSpPr>
         <p:spPr>
           <a:xfrm>
-            <a:off x="971550" y="3351276"/>
+            <a:off x="971550" y="3483292"/>
             <a:ext cx="4857750" cy="95250"/>
           </a:xfrm>
           <a:prstGeom prst="rect">
@@ -33545,7 +33545,7 @@
         </p:nvSpPr>
         <p:spPr>
           <a:xfrm>
-            <a:off x="704850" y="4250055"/>
+            <a:off x="704850" y="4382072"/>
             <a:ext cx="57150" cy="57150"/>
           </a:xfrm>
           <a:prstGeom prst="rect">
@@ -33589,7 +33589,7 @@
         </p:nvSpPr>
         <p:spPr>
           <a:xfrm>
-            <a:off x="971550" y="4146042"/>
+            <a:off x="971550" y="4278058"/>
             <a:ext cx="4857750" cy="95250"/>
           </a:xfrm>
           <a:prstGeom prst="rect">
@@ -33615,7 +33615,7 @@
                 </a:solidFill>
                 <a:latin typeface="Roboto"/>
               </a:rPr>
-              <a:t>O namespace net dá uma pilha de rede própria, e é por isso que dois containers conseguem escutar na mesma porta.</a:t>
+              <a:t>O namespace net dá uma pilha de rede própria. Dois containers conseguem escutar na mesma porta.</a:t>
             </a:r>
           </a:p>
         </p:txBody>
@@ -33628,7 +33628,7 @@
         </p:nvSpPr>
         <p:spPr>
           <a:xfrm>
-            <a:off x="704850" y="5308854"/>
+            <a:off x="704850" y="5176837"/>
             <a:ext cx="57150" cy="57150"/>
           </a:xfrm>
           <a:prstGeom prst="rect">
@@ -33672,7 +33672,7 @@
         </p:nvSpPr>
         <p:spPr>
           <a:xfrm>
-            <a:off x="971550" y="5204841"/>
+            <a:off x="971550" y="5072824"/>
             <a:ext cx="4857750" cy="95250"/>
           </a:xfrm>
           <a:prstGeom prst="rect">
@@ -33711,7 +33711,7 @@
         </p:nvSpPr>
         <p:spPr>
           <a:xfrm>
-            <a:off x="6362700" y="2061210"/>
+            <a:off x="6362700" y="2193226"/>
             <a:ext cx="5143500" cy="182880"/>
           </a:xfrm>
           <a:prstGeom prst="rect">
@@ -33750,7 +33750,7 @@
         </p:nvSpPr>
         <p:spPr>
           <a:xfrm>
-            <a:off x="6362700" y="2270760"/>
+            <a:off x="6362700" y="2402776"/>
             <a:ext cx="419100" cy="28575"/>
           </a:xfrm>
           <a:prstGeom prst="rect">
@@ -33794,7 +33794,7 @@
         </p:nvSpPr>
         <p:spPr>
           <a:xfrm>
-            <a:off x="6381750" y="2660523"/>
+            <a:off x="6381750" y="2792540"/>
             <a:ext cx="57150" cy="57150"/>
           </a:xfrm>
           <a:prstGeom prst="rect">
@@ -33838,7 +33838,7 @@
         </p:nvSpPr>
         <p:spPr>
           <a:xfrm>
-            <a:off x="6648450" y="2556510"/>
+            <a:off x="6648450" y="2688526"/>
             <a:ext cx="4857750" cy="95250"/>
           </a:xfrm>
           <a:prstGeom prst="rect">
@@ -33877,7 +33877,7 @@
         </p:nvSpPr>
         <p:spPr>
           <a:xfrm>
-            <a:off x="6381750" y="3455289"/>
+            <a:off x="6381750" y="3587306"/>
             <a:ext cx="57150" cy="57150"/>
           </a:xfrm>
           <a:prstGeom prst="rect">
@@ -33921,7 +33921,7 @@
         </p:nvSpPr>
         <p:spPr>
           <a:xfrm>
-            <a:off x="6648450" y="3351276"/>
+            <a:off x="6648450" y="3483292"/>
             <a:ext cx="4857750" cy="95250"/>
           </a:xfrm>
           <a:prstGeom prst="rect">
@@ -33960,7 +33960,7 @@
         </p:nvSpPr>
         <p:spPr>
           <a:xfrm>
-            <a:off x="6381750" y="4250055"/>
+            <a:off x="6381750" y="4382072"/>
             <a:ext cx="57150" cy="57150"/>
           </a:xfrm>
           <a:prstGeom prst="rect">
@@ -34004,7 +34004,7 @@
         </p:nvSpPr>
         <p:spPr>
           <a:xfrm>
-            <a:off x="6648450" y="4146042"/>
+            <a:off x="6648450" y="4278058"/>
             <a:ext cx="4857750" cy="95250"/>
           </a:xfrm>
           <a:prstGeom prst="rect">
@@ -34030,7 +34030,7 @@
                 </a:solidFill>
                 <a:latin typeface="Roboto"/>
               </a:rPr>
-              <a:t>O limite de CPU não mata, ele freia o processo, o que piora as requisições mais lentas e quase não mexe na média, por isso é mais difícil de perceber.</a:t>
+              <a:t>O limite de CPU não mata, freia. Piora as requisições mais lentas e quase não mexe na média, por isso passa despercebido.</a:t>
             </a:r>
           </a:p>
         </p:txBody>

</xml_diff>

<commit_message>
docs: corrige colisao de texto, transbordo do slide 15 e tira jargao e referencias de sprint
</commit_message>
<xml_diff>
--- a/trabalhos/T1-Docker-Invite-People.pptx
+++ b/trabalhos/T1-Docker-Invite-People.pptx
@@ -12378,102 +12378,14 @@
       </p:sp>
       <p:sp>
         <p:nvSpPr>
-          <p:cNvPr id="10" name="Isosceles Triangle 9"/>
-          <p:cNvSpPr/>
-          <p:nvPr/>
-        </p:nvSpPr>
-        <p:spPr>
-          <a:xfrm>
-            <a:off x="9124950" y="2894457"/>
-            <a:ext cx="152400" cy="133350"/>
-          </a:xfrm>
-          <a:prstGeom prst="triangle">
-            <a:avLst/>
-          </a:prstGeom>
-          <a:noFill/>
-          <a:ln w="19050">
-            <a:solidFill>
-              <a:srgbClr val="E94D1C"/>
-            </a:solidFill>
-          </a:ln>
-          <a:effectLst/>
-        </p:spPr>
-        <p:style>
-          <a:lnRef idx="1">
-            <a:schemeClr val="accent1"/>
-          </a:lnRef>
-          <a:fillRef idx="3">
-            <a:schemeClr val="accent1"/>
-          </a:fillRef>
-          <a:effectRef idx="2">
-            <a:schemeClr val="accent1"/>
-          </a:effectRef>
-          <a:fontRef idx="minor">
-            <a:schemeClr val="lt1"/>
-          </a:fontRef>
-        </p:style>
-        <p:txBody>
-          <a:bodyPr rtlCol="0" anchor="ctr"/>
-          <a:lstStyle/>
-          <a:p>
-            <a:pPr algn="ctr"/>
-          </a:p>
-        </p:txBody>
-      </p:sp>
-      <p:sp>
-        <p:nvSpPr>
-          <p:cNvPr id="11" name="Rectangle 10"/>
-          <p:cNvSpPr/>
-          <p:nvPr/>
-        </p:nvSpPr>
-        <p:spPr>
-          <a:xfrm>
-            <a:off x="9193530" y="2951607"/>
-            <a:ext cx="15240" cy="38100"/>
-          </a:xfrm>
-          <a:prstGeom prst="rect">
-            <a:avLst/>
-          </a:prstGeom>
-          <a:solidFill>
-            <a:srgbClr val="E94D1C"/>
-          </a:solidFill>
-          <a:ln>
-            <a:noFill/>
-          </a:ln>
-          <a:effectLst/>
-        </p:spPr>
-        <p:style>
-          <a:lnRef idx="1">
-            <a:schemeClr val="accent1"/>
-          </a:lnRef>
-          <a:fillRef idx="3">
-            <a:schemeClr val="accent1"/>
-          </a:fillRef>
-          <a:effectRef idx="2">
-            <a:schemeClr val="accent1"/>
-          </a:effectRef>
-          <a:fontRef idx="minor">
-            <a:schemeClr val="lt1"/>
-          </a:fontRef>
-        </p:style>
-        <p:txBody>
-          <a:bodyPr rtlCol="0" anchor="ctr"/>
-          <a:lstStyle/>
-          <a:p>
-            <a:pPr algn="ctr"/>
-          </a:p>
-        </p:txBody>
-      </p:sp>
-      <p:sp>
-        <p:nvSpPr>
-          <p:cNvPr id="12" name="TextBox 11"/>
+          <p:cNvPr id="10" name="TextBox 9"/>
           <p:cNvSpPr txBox="1"/>
           <p:nvPr/>
         </p:nvSpPr>
         <p:spPr>
           <a:xfrm>
-            <a:off x="9372600" y="2903982"/>
-            <a:ext cx="2133600" cy="182880"/>
+            <a:off x="685800" y="6324600"/>
+            <a:ext cx="6667500" cy="182880"/>
           </a:xfrm>
           <a:prstGeom prst="rect">
             <a:avLst/>
@@ -12492,137 +12404,12 @@
               </a:lnSpc>
             </a:pPr>
             <a:r>
-              <a:rPr sz="900" b="1" i="0" spc="120">
-                <a:solidFill>
-                  <a:srgbClr val="E94D1C"/>
+              <a:rPr sz="900" b="0" i="0">
+                <a:solidFill>
+                  <a:srgbClr val="6B6B78"/>
                 </a:solidFill>
                 <a:latin typeface="Roboto"/>
               </a:rPr>
-              <a:t>CUIDADO</a:t>
-            </a:r>
-          </a:p>
-        </p:txBody>
-      </p:sp>
-      <p:sp>
-        <p:nvSpPr>
-          <p:cNvPr id="13" name="Rectangle 12"/>
-          <p:cNvSpPr/>
-          <p:nvPr/>
-        </p:nvSpPr>
-        <p:spPr>
-          <a:xfrm>
-            <a:off x="9124950" y="3180207"/>
-            <a:ext cx="38100" cy="603504"/>
-          </a:xfrm>
-          <a:prstGeom prst="rect">
-            <a:avLst/>
-          </a:prstGeom>
-          <a:solidFill>
-            <a:srgbClr val="E94D1C"/>
-          </a:solidFill>
-          <a:ln>
-            <a:noFill/>
-          </a:ln>
-          <a:effectLst/>
-        </p:spPr>
-        <p:style>
-          <a:lnRef idx="1">
-            <a:schemeClr val="accent1"/>
-          </a:lnRef>
-          <a:fillRef idx="3">
-            <a:schemeClr val="accent1"/>
-          </a:fillRef>
-          <a:effectRef idx="2">
-            <a:schemeClr val="accent1"/>
-          </a:effectRef>
-          <a:fontRef idx="minor">
-            <a:schemeClr val="lt1"/>
-          </a:fontRef>
-        </p:style>
-        <p:txBody>
-          <a:bodyPr rtlCol="0" anchor="ctr" wrap="square" lIns="0" rIns="0" tIns="0" bIns="0"/>
-          <a:lstStyle/>
-          <a:p>
-            <a:pPr algn="ctr"/>
-          </a:p>
-        </p:txBody>
-      </p:sp>
-      <p:sp>
-        <p:nvSpPr>
-          <p:cNvPr id="14" name="TextBox 13"/>
-          <p:cNvSpPr txBox="1"/>
-          <p:nvPr/>
-        </p:nvSpPr>
-        <p:spPr>
-          <a:xfrm>
-            <a:off x="9334500" y="3180207"/>
-            <a:ext cx="2171700" cy="1175004"/>
-          </a:xfrm>
-          <a:prstGeom prst="rect">
-            <a:avLst/>
-          </a:prstGeom>
-          <a:noFill/>
-        </p:spPr>
-        <p:txBody>
-          <a:bodyPr wrap="square" lIns="0" rIns="0" tIns="0" bIns="0" anchor="t">
-            <a:spAutoFit/>
-          </a:bodyPr>
-          <a:lstStyle/>
-          <a:p>
-            <a:pPr algn="l">
-              <a:lnSpc>
-                <a:spcPct val="140000"/>
-              </a:lnSpc>
-              <a:spcAft>
-                <a:spcPts val="600"/>
-              </a:spcAft>
-            </a:pPr>
-            <a:r>
-              <a:rPr sz="1200" b="0" i="0">
-                <a:solidFill>
-                  <a:srgbClr val="3A3A44"/>
-                </a:solidFill>
-                <a:latin typeface="Roboto"/>
-              </a:rPr>
-              <a:t>A opção --privileged devolve tudo de uma vez e ainda desliga o seccomp.</a:t>
-            </a:r>
-          </a:p>
-        </p:txBody>
-      </p:sp>
-      <p:sp>
-        <p:nvSpPr>
-          <p:cNvPr id="15" name="TextBox 14"/>
-          <p:cNvSpPr txBox="1"/>
-          <p:nvPr/>
-        </p:nvSpPr>
-        <p:spPr>
-          <a:xfrm>
-            <a:off x="685800" y="6324600"/>
-            <a:ext cx="6667500" cy="182880"/>
-          </a:xfrm>
-          <a:prstGeom prst="rect">
-            <a:avLst/>
-          </a:prstGeom>
-          <a:noFill/>
-        </p:spPr>
-        <p:txBody>
-          <a:bodyPr wrap="square" lIns="0" rIns="0" tIns="0" bIns="0" anchor="t">
-            <a:spAutoFit/>
-          </a:bodyPr>
-          <a:lstStyle/>
-          <a:p>
-            <a:pPr algn="l">
-              <a:lnSpc>
-                <a:spcPct val="120000"/>
-              </a:lnSpc>
-            </a:pPr>
-            <a:r>
-              <a:rPr sz="900" b="0" i="0">
-                <a:solidFill>
-                  <a:srgbClr val="6B6B78"/>
-                </a:solidFill>
-                <a:latin typeface="Roboto"/>
-              </a:rPr>
               <a:t>01 · Arquitetura</a:t>
             </a:r>
           </a:p>
@@ -12630,7 +12417,7 @@
       </p:sp>
       <p:sp>
         <p:nvSpPr>
-          <p:cNvPr id="16" name="TextBox 15"/>
+          <p:cNvPr id="11" name="TextBox 10"/>
           <p:cNvSpPr txBox="1"/>
           <p:nvPr/>
         </p:nvSpPr>
@@ -13310,7 +13097,7 @@
                 </a:solidFill>
                 <a:latin typeface="Roboto"/>
               </a:rPr>
-              <a:t>Mapeamento entre os diagramas da Sprint 2 e o arquivo de compose, com o número de cada task.</a:t>
+              <a:t>Mapeamento entre os diagramas de arquitetura e o arquivo de compose.</a:t>
             </a:r>
           </a:p>
         </p:txBody>
@@ -15144,7 +14931,7 @@
                 </a:solidFill>
                 <a:latin typeface="Roboto"/>
               </a:rPr>
-              <a:t>O projeto lógico é o mesmo nas três opções, e a escolha entre elas entra no ADR, o documento de decisões arquiteturais da Sprint 2. O Docker também usa a palavra </a:t>
+              <a:t>O projeto lógico é o mesmo nas três opções, e a escolha entre elas entra no ADR, o documento de decisões arquiteturais do projeto. O Docker também usa a palavra </a:t>
             </a:r>
             <a:r>
               <a:rPr sz="1280" b="0" i="1">
@@ -16063,7 +15850,7 @@
         </p:nvSpPr>
         <p:spPr>
           <a:xfrm>
-            <a:off x="857250" y="3028950"/>
+            <a:off x="857250" y="2990850"/>
             <a:ext cx="3810000" cy="167640"/>
           </a:xfrm>
           <a:prstGeom prst="rect">
@@ -16102,7 +15889,7 @@
         </p:nvSpPr>
         <p:spPr>
           <a:xfrm>
-            <a:off x="857250" y="3200400"/>
+            <a:off x="857250" y="3162300"/>
             <a:ext cx="3810000" cy="1866900"/>
           </a:xfrm>
           <a:prstGeom prst="rect">
@@ -16146,7 +15933,7 @@
         </p:nvSpPr>
         <p:spPr>
           <a:xfrm>
-            <a:off x="1123950" y="3448050"/>
+            <a:off x="1123950" y="3409950"/>
             <a:ext cx="1428750" cy="457200"/>
           </a:xfrm>
           <a:prstGeom prst="roundRect">
@@ -16192,7 +15979,7 @@
         </p:nvSpPr>
         <p:spPr>
           <a:xfrm>
-            <a:off x="1123950" y="3600450"/>
+            <a:off x="1123950" y="3562350"/>
             <a:ext cx="1428750" cy="198120"/>
           </a:xfrm>
           <a:prstGeom prst="rect">
@@ -16231,7 +16018,7 @@
         </p:nvSpPr>
         <p:spPr>
           <a:xfrm>
-            <a:off x="2971800" y="3448050"/>
+            <a:off x="2971800" y="3409950"/>
             <a:ext cx="1428750" cy="457200"/>
           </a:xfrm>
           <a:prstGeom prst="roundRect">
@@ -16277,7 +16064,7 @@
         </p:nvSpPr>
         <p:spPr>
           <a:xfrm>
-            <a:off x="2971800" y="3600450"/>
+            <a:off x="2971800" y="3562350"/>
             <a:ext cx="1428750" cy="198120"/>
           </a:xfrm>
           <a:prstGeom prst="rect">
@@ -16316,7 +16103,7 @@
         </p:nvSpPr>
         <p:spPr>
           <a:xfrm>
-            <a:off x="2047875" y="4114800"/>
+            <a:off x="2047875" y="4076700"/>
             <a:ext cx="1428750" cy="419100"/>
           </a:xfrm>
           <a:prstGeom prst="roundRect">
@@ -16362,7 +16149,7 @@
         </p:nvSpPr>
         <p:spPr>
           <a:xfrm>
-            <a:off x="2047875" y="4248150"/>
+            <a:off x="2047875" y="4210050"/>
             <a:ext cx="1428750" cy="198120"/>
           </a:xfrm>
           <a:prstGeom prst="rect">
@@ -16401,7 +16188,7 @@
         </p:nvSpPr>
         <p:spPr>
           <a:xfrm>
-            <a:off x="2047875" y="4667250"/>
+            <a:off x="2047875" y="4629150"/>
             <a:ext cx="1428750" cy="285750"/>
           </a:xfrm>
           <a:prstGeom prst="roundRect">
@@ -16447,7 +16234,7 @@
         </p:nvSpPr>
         <p:spPr>
           <a:xfrm>
-            <a:off x="2047875" y="4733925"/>
+            <a:off x="2047875" y="4695825"/>
             <a:ext cx="1428750" cy="182880"/>
           </a:xfrm>
           <a:prstGeom prst="rect">
@@ -16486,7 +16273,7 @@
         </p:nvCxnSpPr>
         <p:spPr>
           <a:xfrm>
-            <a:off x="1838325" y="3905250"/>
+            <a:off x="1838325" y="3867150"/>
             <a:ext cx="733425" cy="209550"/>
           </a:xfrm>
           <a:prstGeom prst="line">
@@ -16521,7 +16308,7 @@
         </p:nvCxnSpPr>
         <p:spPr>
           <a:xfrm flipH="1">
-            <a:off x="2952750" y="3905250"/>
+            <a:off x="2952750" y="3867150"/>
             <a:ext cx="733425" cy="209550"/>
           </a:xfrm>
           <a:prstGeom prst="line">
@@ -16556,7 +16343,7 @@
         </p:nvCxnSpPr>
         <p:spPr>
           <a:xfrm>
-            <a:off x="2762250" y="4533900"/>
+            <a:off x="2762250" y="4495800"/>
             <a:ext cx="0" cy="133350"/>
           </a:xfrm>
           <a:prstGeom prst="line">
@@ -16591,7 +16378,7 @@
         </p:nvCxnSpPr>
         <p:spPr>
           <a:xfrm>
-            <a:off x="4667250" y="4133850"/>
+            <a:off x="4667250" y="4095750"/>
             <a:ext cx="1524000" cy="0"/>
           </a:xfrm>
           <a:prstGeom prst="line">
@@ -16626,7 +16413,7 @@
         </p:nvSpPr>
         <p:spPr>
           <a:xfrm>
-            <a:off x="4667250" y="3867150"/>
+            <a:off x="4667250" y="3829050"/>
             <a:ext cx="1524000" cy="198120"/>
           </a:xfrm>
           <a:prstGeom prst="rect">
@@ -16665,7 +16452,7 @@
         </p:nvSpPr>
         <p:spPr>
           <a:xfrm>
-            <a:off x="6191250" y="3028950"/>
+            <a:off x="6191250" y="2990850"/>
             <a:ext cx="4000500" cy="167640"/>
           </a:xfrm>
           <a:prstGeom prst="rect">
@@ -16704,7 +16491,7 @@
         </p:nvSpPr>
         <p:spPr>
           <a:xfrm>
-            <a:off x="6191250" y="3200400"/>
+            <a:off x="6191250" y="3162300"/>
             <a:ext cx="3810000" cy="1866900"/>
           </a:xfrm>
           <a:prstGeom prst="rect">
@@ -16748,7 +16535,7 @@
         </p:nvSpPr>
         <p:spPr>
           <a:xfrm>
-            <a:off x="6381750" y="3314700"/>
+            <a:off x="6381750" y="3276600"/>
             <a:ext cx="1905000" cy="167640"/>
           </a:xfrm>
           <a:prstGeom prst="rect">
@@ -16787,7 +16574,7 @@
         </p:nvSpPr>
         <p:spPr>
           <a:xfrm>
-            <a:off x="6381750" y="3543300"/>
+            <a:off x="6381750" y="3505200"/>
             <a:ext cx="1066800" cy="495300"/>
           </a:xfrm>
           <a:prstGeom prst="rect">
@@ -16831,7 +16618,7 @@
         </p:nvSpPr>
         <p:spPr>
           <a:xfrm>
-            <a:off x="6400800" y="3619500"/>
+            <a:off x="6400800" y="3581400"/>
             <a:ext cx="1028700" cy="175260"/>
           </a:xfrm>
           <a:prstGeom prst="rect">
@@ -16870,7 +16657,7 @@
         </p:nvSpPr>
         <p:spPr>
           <a:xfrm>
-            <a:off x="6400800" y="3790950"/>
+            <a:off x="6400800" y="3752850"/>
             <a:ext cx="1028700" cy="167640"/>
           </a:xfrm>
           <a:prstGeom prst="rect">
@@ -16909,7 +16696,7 @@
         </p:nvSpPr>
         <p:spPr>
           <a:xfrm>
-            <a:off x="7562850" y="3543300"/>
+            <a:off x="7562850" y="3505200"/>
             <a:ext cx="1066800" cy="495300"/>
           </a:xfrm>
           <a:prstGeom prst="rect">
@@ -16953,7 +16740,7 @@
         </p:nvSpPr>
         <p:spPr>
           <a:xfrm>
-            <a:off x="7581900" y="3619500"/>
+            <a:off x="7581900" y="3581400"/>
             <a:ext cx="1028700" cy="175260"/>
           </a:xfrm>
           <a:prstGeom prst="rect">
@@ -16992,7 +16779,7 @@
         </p:nvSpPr>
         <p:spPr>
           <a:xfrm>
-            <a:off x="7581900" y="3790950"/>
+            <a:off x="7581900" y="3752850"/>
             <a:ext cx="1028700" cy="167640"/>
           </a:xfrm>
           <a:prstGeom prst="rect">
@@ -17031,7 +16818,7 @@
         </p:nvCxnSpPr>
         <p:spPr>
           <a:xfrm>
-            <a:off x="7448550" y="3790950"/>
+            <a:off x="7448550" y="3752850"/>
             <a:ext cx="114300" cy="0"/>
           </a:xfrm>
           <a:prstGeom prst="line">
@@ -17066,7 +16853,7 @@
         </p:nvSpPr>
         <p:spPr>
           <a:xfrm>
-            <a:off x="8743950" y="3543300"/>
+            <a:off x="8743950" y="3505200"/>
             <a:ext cx="1066800" cy="495300"/>
           </a:xfrm>
           <a:prstGeom prst="rect">
@@ -17110,7 +16897,7 @@
         </p:nvSpPr>
         <p:spPr>
           <a:xfrm>
-            <a:off x="8763000" y="3619500"/>
+            <a:off x="8763000" y="3581400"/>
             <a:ext cx="1028700" cy="175260"/>
           </a:xfrm>
           <a:prstGeom prst="rect">
@@ -17149,7 +16936,7 @@
         </p:nvSpPr>
         <p:spPr>
           <a:xfrm>
-            <a:off x="8763000" y="3790950"/>
+            <a:off x="8763000" y="3752850"/>
             <a:ext cx="1028700" cy="167640"/>
           </a:xfrm>
           <a:prstGeom prst="rect">
@@ -17188,7 +16975,7 @@
         </p:nvCxnSpPr>
         <p:spPr>
           <a:xfrm>
-            <a:off x="8629650" y="3790950"/>
+            <a:off x="8629650" y="3752850"/>
             <a:ext cx="114300" cy="0"/>
           </a:xfrm>
           <a:prstGeom prst="line">
@@ -17223,7 +17010,7 @@
         </p:nvSpPr>
         <p:spPr>
           <a:xfrm>
-            <a:off x="6381750" y="4267200"/>
+            <a:off x="6381750" y="4229100"/>
             <a:ext cx="3429000" cy="323850"/>
           </a:xfrm>
           <a:prstGeom prst="roundRect">
@@ -17272,7 +17059,7 @@
         </p:nvSpPr>
         <p:spPr>
           <a:xfrm>
-            <a:off x="6381750" y="4362450"/>
+            <a:off x="6381750" y="4324350"/>
             <a:ext cx="3429000" cy="182880"/>
           </a:xfrm>
           <a:prstGeom prst="rect">
@@ -17311,8 +17098,8 @@
         </p:nvSpPr>
         <p:spPr>
           <a:xfrm>
-            <a:off x="6381750" y="4762500"/>
-            <a:ext cx="3810000" cy="182880"/>
+            <a:off x="6381750" y="4667250"/>
+            <a:ext cx="3390900" cy="438150"/>
           </a:xfrm>
           <a:prstGeom prst="rect">
             <a:avLst/>
@@ -17327,7 +17114,7 @@
           <a:p>
             <a:pPr algn="l">
               <a:lnSpc>
-                <a:spcPct val="120000"/>
+                <a:spcPct val="140000"/>
               </a:lnSpc>
             </a:pPr>
             <a:r>
@@ -18043,7 +17830,7 @@
                 </a:solidFill>
                 <a:latin typeface="Roboto"/>
               </a:rPr>
-              <a:t>, o pirulito da UML.</a:t>
+              <a:t> da UML.</a:t>
             </a:r>
           </a:p>
         </p:txBody>
@@ -18144,7 +17931,7 @@
                 </a:solidFill>
                 <a:latin typeface="Roboto"/>
               </a:rPr>
-              <a:t>, o soquete.</a:t>
+              <a:t>.</a:t>
             </a:r>
           </a:p>
         </p:txBody>
@@ -19780,7 +19567,7 @@
                 </a:solidFill>
                 <a:latin typeface="Roboto"/>
               </a:rPr>
-              <a:t>Entrada direta para os dois diagramas da Sprint 2. Ainda não decidida.</a:t>
+              <a:t>Entrada direta para os dois diagramas de arquitetura. Ainda não decidida.</a:t>
             </a:r>
           </a:p>
         </p:txBody>
@@ -23202,7 +22989,7 @@
         </p:nvSpPr>
         <p:spPr>
           <a:xfrm>
-            <a:off x="704850" y="4118039"/>
+            <a:off x="704850" y="3854006"/>
             <a:ext cx="57150" cy="57150"/>
           </a:xfrm>
           <a:prstGeom prst="rect">
@@ -23246,7 +23033,7 @@
         </p:nvSpPr>
         <p:spPr>
           <a:xfrm>
-            <a:off x="971550" y="4014026"/>
+            <a:off x="971550" y="3749993"/>
             <a:ext cx="4857750" cy="95250"/>
           </a:xfrm>
           <a:prstGeom prst="rect">
@@ -26448,7 +26235,7 @@
                 </a:solidFill>
                 <a:latin typeface="Roboto"/>
               </a:rPr>
-              <a:t>I/O mais lento, principalmente nas máquinas Windows. A Aula 03 já avisa que camada extra prejudica desempenho.</a:t>
+              <a:t>I/O mais lento, principalmente nas máquinas Windows.</a:t>
             </a:r>
           </a:p>
         </p:txBody>
@@ -26628,7 +26415,7 @@
         </p:nvSpPr>
         <p:spPr>
           <a:xfrm>
-            <a:off x="704850" y="3003423"/>
+            <a:off x="704850" y="3141726"/>
             <a:ext cx="57150" cy="57150"/>
           </a:xfrm>
           <a:prstGeom prst="rect">
@@ -26672,7 +26459,7 @@
         </p:nvSpPr>
         <p:spPr>
           <a:xfrm>
-            <a:off x="971550" y="2894457"/>
+            <a:off x="971550" y="3032760"/>
             <a:ext cx="7677150" cy="95250"/>
           </a:xfrm>
           <a:prstGeom prst="rect">
@@ -26711,7 +26498,7 @@
         </p:nvSpPr>
         <p:spPr>
           <a:xfrm>
-            <a:off x="704850" y="3842385"/>
+            <a:off x="704850" y="3980688"/>
             <a:ext cx="57150" cy="57150"/>
           </a:xfrm>
           <a:prstGeom prst="rect">
@@ -26755,7 +26542,7 @@
         </p:nvSpPr>
         <p:spPr>
           <a:xfrm>
-            <a:off x="971550" y="3733419"/>
+            <a:off x="971550" y="3871722"/>
             <a:ext cx="7677150" cy="95250"/>
           </a:xfrm>
           <a:prstGeom prst="rect">
@@ -26794,7 +26581,7 @@
         </p:nvSpPr>
         <p:spPr>
           <a:xfrm>
-            <a:off x="704850" y="4957953"/>
+            <a:off x="704850" y="4819650"/>
             <a:ext cx="57150" cy="57150"/>
           </a:xfrm>
           <a:prstGeom prst="rect">
@@ -26838,7 +26625,7 @@
         </p:nvSpPr>
         <p:spPr>
           <a:xfrm>
-            <a:off x="971550" y="4848987"/>
+            <a:off x="971550" y="4710684"/>
             <a:ext cx="7677150" cy="95250"/>
           </a:xfrm>
           <a:prstGeom prst="rect">
@@ -26877,7 +26664,7 @@
         </p:nvSpPr>
         <p:spPr>
           <a:xfrm>
-            <a:off x="9124950" y="2903982"/>
+            <a:off x="9124950" y="3042285"/>
             <a:ext cx="142875" cy="123825"/>
           </a:xfrm>
           <a:prstGeom prst="chevron">
@@ -26921,7 +26708,7 @@
         </p:nvSpPr>
         <p:spPr>
           <a:xfrm>
-            <a:off x="9372600" y="2903982"/>
+            <a:off x="9372600" y="3042285"/>
             <a:ext cx="2133600" cy="182880"/>
           </a:xfrm>
           <a:prstGeom prst="rect">
@@ -26960,8 +26747,8 @@
         </p:nvSpPr>
         <p:spPr>
           <a:xfrm>
-            <a:off x="9124950" y="3180207"/>
-            <a:ext cx="38100" cy="1005840"/>
+            <a:off x="9124950" y="3318510"/>
+            <a:ext cx="38100" cy="804672"/>
           </a:xfrm>
           <a:prstGeom prst="rect">
             <a:avLst/>
@@ -27004,8 +26791,8 @@
         </p:nvSpPr>
         <p:spPr>
           <a:xfrm>
-            <a:off x="9334500" y="3180207"/>
-            <a:ext cx="2171700" cy="1577340"/>
+            <a:off x="9334500" y="3318510"/>
+            <a:ext cx="2171700" cy="1376172"/>
           </a:xfrm>
           <a:prstGeom prst="rect">
             <a:avLst/>
@@ -27033,7 +26820,7 @@
                 </a:solidFill>
                 <a:latin typeface="Roboto"/>
               </a:rPr>
-              <a:t>Insumo direto da Sprint 3, que começa no dia 15 e tem como objetivo declarado definir as tecnologias e os mecanismos da implementação.</a:t>
+              <a:t>Insumo direto da próxima sprint, que vai definir as tecnologias e os mecanismos da implementação.</a:t>
             </a:r>
           </a:p>
         </p:txBody>
@@ -27628,7 +27415,7 @@
         </p:nvSpPr>
         <p:spPr>
           <a:xfrm>
-            <a:off x="6381750" y="4646104"/>
+            <a:off x="6381750" y="4382072"/>
             <a:ext cx="57150" cy="57150"/>
           </a:xfrm>
           <a:prstGeom prst="rect">
@@ -27672,7 +27459,7 @@
         </p:nvSpPr>
         <p:spPr>
           <a:xfrm>
-            <a:off x="6648450" y="4542092"/>
+            <a:off x="6648450" y="4278058"/>
             <a:ext cx="4857750" cy="95250"/>
           </a:xfrm>
           <a:prstGeom prst="rect">
@@ -27698,7 +27485,7 @@
                 </a:solidFill>
                 <a:latin typeface="Roboto"/>
               </a:rPr>
-              <a:t>Esse mesmo arquivo é o que vira o diagrama de implantação da Sprint 2.</a:t>
+              <a:t>Esse mesmo arquivo é o que vira o diagrama de implantação do projeto.</a:t>
             </a:r>
           </a:p>
         </p:txBody>
@@ -28877,7 +28664,7 @@
         </p:nvSpPr>
         <p:spPr>
           <a:xfrm>
-            <a:off x="704850" y="2347341"/>
+            <a:off x="704850" y="2229040"/>
             <a:ext cx="57150" cy="57150"/>
           </a:xfrm>
           <a:prstGeom prst="rect">
@@ -28921,7 +28708,7 @@
         </p:nvSpPr>
         <p:spPr>
           <a:xfrm>
-            <a:off x="971550" y="2258187"/>
+            <a:off x="971550" y="2134934"/>
             <a:ext cx="9677400" cy="95250"/>
           </a:xfrm>
           <a:prstGeom prst="rect">
@@ -28941,7 +28728,7 @@
               </a:lnSpc>
             </a:pPr>
             <a:r>
-              <a:rPr sz="1350" b="0" i="0">
+              <a:rPr sz="1420" b="0" i="0">
                 <a:solidFill>
                   <a:srgbClr val="1A1A1E"/>
                 </a:solidFill>
@@ -28960,7 +28747,7 @@
         </p:nvSpPr>
         <p:spPr>
           <a:xfrm>
-            <a:off x="704850" y="2783205"/>
+            <a:off x="704850" y="2696528"/>
             <a:ext cx="57150" cy="57150"/>
           </a:xfrm>
           <a:prstGeom prst="rect">
@@ -29004,7 +28791,7 @@
         </p:nvSpPr>
         <p:spPr>
           <a:xfrm>
-            <a:off x="971550" y="2694051"/>
+            <a:off x="971550" y="2602421"/>
             <a:ext cx="9677400" cy="95250"/>
           </a:xfrm>
           <a:prstGeom prst="rect">
@@ -29024,7 +28811,7 @@
               </a:lnSpc>
             </a:pPr>
             <a:r>
-              <a:rPr sz="1350" b="0" i="0">
+              <a:rPr sz="1420" b="0" i="0">
                 <a:solidFill>
                   <a:srgbClr val="1A1A1E"/>
                 </a:solidFill>
@@ -29043,7 +28830,7 @@
         </p:nvSpPr>
         <p:spPr>
           <a:xfrm>
-            <a:off x="704850" y="3219069"/>
+            <a:off x="704850" y="3164014"/>
             <a:ext cx="57150" cy="57150"/>
           </a:xfrm>
           <a:prstGeom prst="rect">
@@ -29087,7 +28874,7 @@
         </p:nvSpPr>
         <p:spPr>
           <a:xfrm>
-            <a:off x="971550" y="3129915"/>
+            <a:off x="971550" y="3069908"/>
             <a:ext cx="9677400" cy="95250"/>
           </a:xfrm>
           <a:prstGeom prst="rect">
@@ -29107,7 +28894,7 @@
               </a:lnSpc>
             </a:pPr>
             <a:r>
-              <a:rPr sz="1350" b="0" i="0">
+              <a:rPr sz="1420" b="0" i="0">
                 <a:solidFill>
                   <a:srgbClr val="1A1A1E"/>
                 </a:solidFill>
@@ -29126,7 +28913,7 @@
         </p:nvSpPr>
         <p:spPr>
           <a:xfrm>
-            <a:off x="704850" y="3881247"/>
+            <a:off x="704850" y="3870389"/>
             <a:ext cx="57150" cy="57150"/>
           </a:xfrm>
           <a:prstGeom prst="rect">
@@ -29170,7 +28957,7 @@
         </p:nvSpPr>
         <p:spPr>
           <a:xfrm>
-            <a:off x="971550" y="3792093"/>
+            <a:off x="971550" y="3776282"/>
             <a:ext cx="9677400" cy="95250"/>
           </a:xfrm>
           <a:prstGeom prst="rect">
@@ -29190,7 +28977,7 @@
               </a:lnSpc>
             </a:pPr>
             <a:r>
-              <a:rPr sz="1350" b="0" i="0">
+              <a:rPr sz="1420" b="0" i="0">
                 <a:solidFill>
                   <a:srgbClr val="1A1A1E"/>
                 </a:solidFill>
@@ -29209,7 +28996,7 @@
         </p:nvSpPr>
         <p:spPr>
           <a:xfrm>
-            <a:off x="704850" y="4317111"/>
+            <a:off x="704850" y="4337876"/>
             <a:ext cx="57150" cy="57150"/>
           </a:xfrm>
           <a:prstGeom prst="rect">
@@ -29253,7 +29040,7 @@
         </p:nvSpPr>
         <p:spPr>
           <a:xfrm>
-            <a:off x="971550" y="4227957"/>
+            <a:off x="971550" y="4243768"/>
             <a:ext cx="9677400" cy="95250"/>
           </a:xfrm>
           <a:prstGeom prst="rect">
@@ -29273,7 +29060,7 @@
               </a:lnSpc>
             </a:pPr>
             <a:r>
-              <a:rPr sz="1350" b="0" i="0">
+              <a:rPr sz="1420" b="0" i="0">
                 <a:solidFill>
                   <a:srgbClr val="1A1A1E"/>
                 </a:solidFill>
@@ -29292,7 +29079,7 @@
         </p:nvSpPr>
         <p:spPr>
           <a:xfrm>
-            <a:off x="704850" y="4752975"/>
+            <a:off x="704850" y="4805362"/>
             <a:ext cx="57150" cy="57150"/>
           </a:xfrm>
           <a:prstGeom prst="rect">
@@ -29336,7 +29123,7 @@
         </p:nvSpPr>
         <p:spPr>
           <a:xfrm>
-            <a:off x="971550" y="4663821"/>
+            <a:off x="971550" y="4711256"/>
             <a:ext cx="9677400" cy="95250"/>
           </a:xfrm>
           <a:prstGeom prst="rect">
@@ -29356,7 +29143,7 @@
               </a:lnSpc>
             </a:pPr>
             <a:r>
-              <a:rPr sz="1350" b="0" i="0">
+              <a:rPr sz="1420" b="0" i="0">
                 <a:solidFill>
                   <a:srgbClr val="1A1A1E"/>
                 </a:solidFill>
@@ -29375,7 +29162,7 @@
         </p:nvSpPr>
         <p:spPr>
           <a:xfrm>
-            <a:off x="704850" y="5188839"/>
+            <a:off x="704850" y="5272850"/>
             <a:ext cx="57150" cy="57150"/>
           </a:xfrm>
           <a:prstGeom prst="rect">
@@ -29419,7 +29206,7 @@
         </p:nvSpPr>
         <p:spPr>
           <a:xfrm>
-            <a:off x="971550" y="5099685"/>
+            <a:off x="971550" y="5178742"/>
             <a:ext cx="9677400" cy="95250"/>
           </a:xfrm>
           <a:prstGeom prst="rect">
@@ -29439,7 +29226,7 @@
               </a:lnSpc>
             </a:pPr>
             <a:r>
-              <a:rPr sz="1350" b="0" i="0">
+              <a:rPr sz="1420" b="0" i="0">
                 <a:solidFill>
                   <a:srgbClr val="1A1A1E"/>
                 </a:solidFill>
@@ -29458,7 +29245,7 @@
         </p:nvSpPr>
         <p:spPr>
           <a:xfrm>
-            <a:off x="704850" y="5624703"/>
+            <a:off x="704850" y="5740337"/>
             <a:ext cx="57150" cy="57150"/>
           </a:xfrm>
           <a:prstGeom prst="rect">
@@ -29502,7 +29289,7 @@
         </p:nvSpPr>
         <p:spPr>
           <a:xfrm>
-            <a:off x="971550" y="5535549"/>
+            <a:off x="971550" y="5646230"/>
             <a:ext cx="9677400" cy="95250"/>
           </a:xfrm>
           <a:prstGeom prst="rect">
@@ -29522,7 +29309,7 @@
               </a:lnSpc>
             </a:pPr>
             <a:r>
-              <a:rPr sz="1350" b="0" i="0">
+              <a:rPr sz="1420" b="0" i="0">
                 <a:solidFill>
                   <a:srgbClr val="1A1A1E"/>
                 </a:solidFill>
@@ -30621,7 +30408,7 @@
         <p:spPr>
           <a:xfrm>
             <a:off x="685800" y="4629150"/>
-            <a:ext cx="28575" cy="477774"/>
+            <a:ext cx="28575" cy="238887"/>
           </a:xfrm>
           <a:prstGeom prst="rect">
             <a:avLst/>
@@ -30870,7 +30657,7 @@
         </p:nvSpPr>
         <p:spPr>
           <a:xfrm>
-            <a:off x="685800" y="2855976"/>
+            <a:off x="685800" y="2723960"/>
             <a:ext cx="5143500" cy="182880"/>
           </a:xfrm>
           <a:prstGeom prst="rect">
@@ -30909,7 +30696,7 @@
         </p:nvSpPr>
         <p:spPr>
           <a:xfrm>
-            <a:off x="685800" y="3065526"/>
+            <a:off x="685800" y="2933510"/>
             <a:ext cx="419100" cy="28575"/>
           </a:xfrm>
           <a:prstGeom prst="rect">
@@ -30953,7 +30740,7 @@
         </p:nvSpPr>
         <p:spPr>
           <a:xfrm>
-            <a:off x="704850" y="3455289"/>
+            <a:off x="704850" y="3323273"/>
             <a:ext cx="57150" cy="57150"/>
           </a:xfrm>
           <a:prstGeom prst="rect">
@@ -30997,7 +30784,7 @@
         </p:nvSpPr>
         <p:spPr>
           <a:xfrm>
-            <a:off x="971550" y="3351276"/>
+            <a:off x="971550" y="3219260"/>
             <a:ext cx="4857750" cy="95250"/>
           </a:xfrm>
           <a:prstGeom prst="rect">
@@ -31036,7 +30823,7 @@
         </p:nvSpPr>
         <p:spPr>
           <a:xfrm>
-            <a:off x="6362700" y="2855976"/>
+            <a:off x="6362700" y="2723960"/>
             <a:ext cx="5143500" cy="182880"/>
           </a:xfrm>
           <a:prstGeom prst="rect">
@@ -31075,7 +30862,7 @@
         </p:nvSpPr>
         <p:spPr>
           <a:xfrm>
-            <a:off x="6362700" y="3065526"/>
+            <a:off x="6362700" y="2933510"/>
             <a:ext cx="419100" cy="28575"/>
           </a:xfrm>
           <a:prstGeom prst="rect">
@@ -31119,7 +30906,7 @@
         </p:nvSpPr>
         <p:spPr>
           <a:xfrm>
-            <a:off x="6381750" y="3455289"/>
+            <a:off x="6381750" y="3323273"/>
             <a:ext cx="57150" cy="57150"/>
           </a:xfrm>
           <a:prstGeom prst="rect">
@@ -31163,7 +30950,7 @@
         </p:nvSpPr>
         <p:spPr>
           <a:xfrm>
-            <a:off x="6648450" y="3351276"/>
+            <a:off x="6648450" y="3219260"/>
             <a:ext cx="4857750" cy="95250"/>
           </a:xfrm>
           <a:prstGeom prst="rect">
@@ -31202,7 +30989,7 @@
         </p:nvSpPr>
         <p:spPr>
           <a:xfrm>
-            <a:off x="6381750" y="4514088"/>
+            <a:off x="6381750" y="4646104"/>
             <a:ext cx="57150" cy="57150"/>
           </a:xfrm>
           <a:prstGeom prst="rect">
@@ -31246,7 +31033,7 @@
         </p:nvSpPr>
         <p:spPr>
           <a:xfrm>
-            <a:off x="6648450" y="4410075"/>
+            <a:off x="6648450" y="4542092"/>
             <a:ext cx="4857750" cy="95250"/>
           </a:xfrm>
           <a:prstGeom prst="rect">
@@ -33208,7 +32995,7 @@
         </p:nvSpPr>
         <p:spPr>
           <a:xfrm>
-            <a:off x="857250" y="2257425"/>
+            <a:off x="857250" y="2238375"/>
             <a:ext cx="4381500" cy="167640"/>
           </a:xfrm>
           <a:prstGeom prst="rect">
@@ -33247,7 +33034,7 @@
         </p:nvSpPr>
         <p:spPr>
           <a:xfrm>
-            <a:off x="857250" y="3971925"/>
+            <a:off x="857250" y="3952875"/>
             <a:ext cx="3429000" cy="438150"/>
           </a:xfrm>
           <a:prstGeom prst="roundRect">
@@ -33295,7 +33082,7 @@
         </p:nvSpPr>
         <p:spPr>
           <a:xfrm>
-            <a:off x="1047750" y="4105275"/>
+            <a:off x="1047750" y="4086225"/>
             <a:ext cx="3048000" cy="213360"/>
           </a:xfrm>
           <a:prstGeom prst="rect">
@@ -33334,7 +33121,7 @@
         </p:nvSpPr>
         <p:spPr>
           <a:xfrm>
-            <a:off x="857250" y="3476625"/>
+            <a:off x="857250" y="3457575"/>
             <a:ext cx="3429000" cy="438150"/>
           </a:xfrm>
           <a:prstGeom prst="roundRect">
@@ -33382,7 +33169,7 @@
         </p:nvSpPr>
         <p:spPr>
           <a:xfrm>
-            <a:off x="1047750" y="3609975"/>
+            <a:off x="1047750" y="3590925"/>
             <a:ext cx="3048000" cy="213360"/>
           </a:xfrm>
           <a:prstGeom prst="rect">
@@ -33421,7 +33208,7 @@
         </p:nvSpPr>
         <p:spPr>
           <a:xfrm>
-            <a:off x="857250" y="2981325"/>
+            <a:off x="857250" y="2962275"/>
             <a:ext cx="3429000" cy="438150"/>
           </a:xfrm>
           <a:prstGeom prst="roundRect">
@@ -33469,7 +33256,7 @@
         </p:nvSpPr>
         <p:spPr>
           <a:xfrm>
-            <a:off x="1047750" y="3114675"/>
+            <a:off x="1047750" y="3095625"/>
             <a:ext cx="3048000" cy="213360"/>
           </a:xfrm>
           <a:prstGeom prst="rect">
@@ -33508,7 +33295,7 @@
         </p:nvSpPr>
         <p:spPr>
           <a:xfrm>
-            <a:off x="4400550" y="2981325"/>
+            <a:off x="4400550" y="2962275"/>
             <a:ext cx="28575" cy="1428750"/>
           </a:xfrm>
           <a:prstGeom prst="rect">
@@ -33552,7 +33339,7 @@
         </p:nvSpPr>
         <p:spPr>
           <a:xfrm>
-            <a:off x="742950" y="4543425"/>
+            <a:off x="742950" y="4524375"/>
             <a:ext cx="3657600" cy="381000"/>
           </a:xfrm>
           <a:prstGeom prst="rect">
@@ -33591,7 +33378,7 @@
         </p:nvSpPr>
         <p:spPr>
           <a:xfrm>
-            <a:off x="857250" y="2428875"/>
+            <a:off x="857250" y="2409825"/>
             <a:ext cx="3429000" cy="495300"/>
           </a:xfrm>
           <a:prstGeom prst="roundRect">
@@ -33640,7 +33427,7 @@
         </p:nvSpPr>
         <p:spPr>
           <a:xfrm>
-            <a:off x="1047750" y="2524125"/>
+            <a:off x="1047750" y="2505075"/>
             <a:ext cx="3048000" cy="213360"/>
           </a:xfrm>
           <a:prstGeom prst="rect">
@@ -33679,7 +33466,7 @@
         </p:nvSpPr>
         <p:spPr>
           <a:xfrm>
-            <a:off x="1047750" y="2705100"/>
+            <a:off x="1047750" y="2686050"/>
             <a:ext cx="3048000" cy="182880"/>
           </a:xfrm>
           <a:prstGeom prst="rect">
@@ -33718,7 +33505,7 @@
         </p:nvCxnSpPr>
         <p:spPr>
           <a:xfrm>
-            <a:off x="4857750" y="2371725"/>
+            <a:off x="4857750" y="2352675"/>
             <a:ext cx="0" cy="2152650"/>
           </a:xfrm>
           <a:prstGeom prst="line">
@@ -33753,7 +33540,7 @@
         </p:nvSpPr>
         <p:spPr>
           <a:xfrm>
-            <a:off x="5257800" y="2828925"/>
+            <a:off x="5257800" y="2809875"/>
             <a:ext cx="3619500" cy="243840"/>
           </a:xfrm>
           <a:prstGeom prst="rect">
@@ -33792,7 +33579,7 @@
         </p:nvSpPr>
         <p:spPr>
           <a:xfrm>
-            <a:off x="5257800" y="3095625"/>
+            <a:off x="5257800" y="3076575"/>
             <a:ext cx="3810000" cy="666750"/>
           </a:xfrm>
           <a:prstGeom prst="rect">
@@ -33831,7 +33618,7 @@
         </p:nvSpPr>
         <p:spPr>
           <a:xfrm>
-            <a:off x="5257800" y="3667125"/>
+            <a:off x="5257800" y="3648075"/>
             <a:ext cx="3619500" cy="243840"/>
           </a:xfrm>
           <a:prstGeom prst="rect">
@@ -33870,7 +33657,7 @@
         </p:nvSpPr>
         <p:spPr>
           <a:xfrm>
-            <a:off x="5257800" y="3933825"/>
+            <a:off x="5257800" y="3914775"/>
             <a:ext cx="3810000" cy="666750"/>
           </a:xfrm>
           <a:prstGeom prst="rect">
@@ -33909,8 +33696,8 @@
         </p:nvSpPr>
         <p:spPr>
           <a:xfrm>
-            <a:off x="685800" y="5472135"/>
-            <a:ext cx="28575" cy="661965"/>
+            <a:off x="685800" y="5428381"/>
+            <a:ext cx="28575" cy="705719"/>
           </a:xfrm>
           <a:prstGeom prst="rect">
             <a:avLst/>
@@ -33953,8 +33740,8 @@
         </p:nvSpPr>
         <p:spPr>
           <a:xfrm>
-            <a:off x="876300" y="5453085"/>
-            <a:ext cx="10629900" cy="795315"/>
+            <a:off x="876300" y="5409331"/>
+            <a:ext cx="10629900" cy="839069"/>
           </a:xfrm>
           <a:prstGeom prst="rect">
             <a:avLst/>
@@ -33973,7 +33760,7 @@
               </a:lnSpc>
             </a:pPr>
             <a:r>
-              <a:rPr sz="1200" b="0" i="0">
+              <a:rPr sz="1280" b="0" i="0">
                 <a:solidFill>
                   <a:srgbClr val="3A3A44"/>
                 </a:solidFill>

</xml_diff>

<commit_message>
docs: remove os identificadores internos restantes dos slides e adiciona um verificador
</commit_message>
<xml_diff>
--- a/trabalhos/T1-Docker-Invite-People.pptx
+++ b/trabalhos/T1-Docker-Invite-People.pptx
@@ -14949,7 +14949,7 @@
                 </a:solidFill>
                 <a:latin typeface="Roboto"/>
               </a:rPr>
-              <a:t>, mas para o empilhamento do sistema de arquivos da imagem, que é outra coisa e não tem relação com a camada lógica da Aula 03.</a:t>
+              <a:t>, mas para o empilhamento do sistema de arquivos da imagem, que é outra coisa e não tem relação com a camada lógica da arquitetura em camadas.</a:t>
             </a:r>
           </a:p>
         </p:txBody>
@@ -25903,7 +25903,7 @@
                 </a:solidFill>
                 <a:latin typeface="Roboto"/>
               </a:rPr>
-              <a:t>A mesma imagem atravessa notebook, pipeline e a demonstração do T3.</a:t>
+              <a:t>A mesma imagem atravessa notebook, pipeline e a apresentação do projeto mais adiante.</a:t>
             </a:r>
           </a:p>
         </p:txBody>
@@ -26651,7 +26651,7 @@
                 </a:solidFill>
                 <a:latin typeface="Roboto"/>
               </a:rPr>
-              <a:t>A stack ainda não está decidida, e o ADR #63 é onde ela será registrada.</a:t>
+              <a:t>A stack ainda não está decidida, e o ADR é onde ela será registrada.</a:t>
             </a:r>
           </a:p>
         </p:txBody>
@@ -27735,7 +27735,7 @@
                 </a:solidFill>
                 <a:latin typeface="Roboto"/>
               </a:rPr>
-              <a:t>Os seis itens de modelagem da Sprint 2, do #58 ao #63, estão em To Do. Isto é insumo desses itens, não relato de item concluído.</a:t>
+              <a:t>Os seis itens de modelagem da arquitetura estão em To Do. Isto é insumo desses itens, não relato de item concluído.</a:t>
             </a:r>
           </a:p>
         </p:txBody>
@@ -27818,7 +27818,7 @@
                 </a:solidFill>
                 <a:latin typeface="Roboto"/>
               </a:rPr>
-              <a:t>O ADR #63, onde a stack será decidida, ainda não foi escrito.</a:t>
+              <a:t>O ADR, onde a stack será decidida, ainda não foi escrito.</a:t>
             </a:r>
           </a:p>
         </p:txBody>
@@ -33766,7 +33766,7 @@
                 </a:solidFill>
                 <a:latin typeface="Roboto"/>
               </a:rPr>
-              <a:t>A imagem é construída a partir de um Dockerfile, o arquivo de texto que declara a base e os passos, e circula entre máquinas por um registry. Cada instrução vira uma camada, e por isso um Dockerfile que copia um .env e faz RUN rm na instrução seguinte produz uma imagem em que o segredo continua legível. No nosso caso o segredo seria a senha do banco e o segredo de sessão do login do anfitrião, o UC001.</a:t>
+              <a:t>A imagem é construída a partir de um Dockerfile, o arquivo de texto que declara a base e os passos, e circula entre máquinas por um registry. Cada instrução vira uma camada, e por isso um Dockerfile que copia um .env e faz RUN rm na instrução seguinte produz uma imagem em que o segredo continua legível. No nosso caso o segredo seria a senha do banco e o segredo de sessão do login do anfitrião.</a:t>
             </a:r>
           </a:p>
         </p:txBody>

</xml_diff>

<commit_message>
docs: tira os nomes de artefato interno dos slides e amplia o verificador
</commit_message>
<xml_diff>
--- a/trabalhos/T1-Docker-Invite-People.pptx
+++ b/trabalhos/T1-Docker-Invite-People.pptx
@@ -18679,7 +18679,7 @@
                 </a:solidFill>
                 <a:latin typeface="Roboto"/>
               </a:rPr>
-              <a:t>Uma regra escrita na wiki depende de alguém revisar. A mesma regra na topologia é verificada pela estrutura.</a:t>
+              <a:t>Uma regra que só existe escrita depende de alguém lembrar de aplicar. Na topologia ela é garantida pela estrutura.</a:t>
             </a:r>
           </a:p>
         </p:txBody>
@@ -19194,7 +19194,7 @@
                 </a:solidFill>
                 <a:latin typeface="Roboto"/>
               </a:rPr>
-              <a:t>Marina é a persona da anfitriã, e a jornada dela descreve o link caindo no grupo da família. Isso é pico no convite público, onde o convidado confirma presença, e uma pessoa só no painel, onde a anfitriã vê a lista.</a:t>
+              <a:t>A jornada da anfitriã descreve o link caindo no grupo da família. Isso é pico no convite público, onde o convidado confirma presença, e uma pessoa só no painel, onde a anfitriã vê a lista.</a:t>
             </a:r>
           </a:p>
         </p:txBody>
@@ -20404,7 +20404,7 @@
                 </a:solidFill>
                 <a:latin typeface="Roboto"/>
               </a:rPr>
-              <a:t>A arquitetura já está registrada no Guia da Arquitetura, com MVC no front-end e três camadas no back-end.</a:t>
+              <a:t>A arquitetura já está registrada na documentação do projeto, com MVC no front-end e três camadas no back-end.</a:t>
             </a:r>
           </a:p>
         </p:txBody>
@@ -27735,7 +27735,7 @@
                 </a:solidFill>
                 <a:latin typeface="Roboto"/>
               </a:rPr>
-              <a:t>Os seis itens de modelagem da arquitetura estão em To Do. Isto é insumo desses itens, não relato de item concluído.</a:t>
+              <a:t>Os seis itens de modelagem da arquitetura seguem em aberto. Isto é insumo desses itens, não relato de item concluído.</a:t>
             </a:r>
           </a:p>
         </p:txBody>

</xml_diff>

<commit_message>
docs: aplica a regra de identificador tambem a sprint, questao norteadora e ADR
</commit_message>
<xml_diff>
--- a/trabalhos/T1-Docker-Invite-People.pptx
+++ b/trabalhos/T1-Docker-Invite-People.pptx
@@ -14931,7 +14931,7 @@
                 </a:solidFill>
                 <a:latin typeface="Roboto"/>
               </a:rPr>
-              <a:t>O projeto lógico é o mesmo nas três opções, e a escolha entre elas entra no ADR, o documento de decisões arquiteturais do projeto. O Docker também usa a palavra </a:t>
+              <a:t>O projeto lógico é o mesmo nas três opções, e a escolha entre elas entra no documento de decisões arquiteturais do projeto. O Docker também usa a palavra </a:t>
             </a:r>
             <a:r>
               <a:rPr sz="1280" b="0" i="1">
@@ -18097,7 +18097,7 @@
                 </a:solidFill>
                 <a:latin typeface="Roboto"/>
               </a:rPr>
-              <a:t>As imagens do arquivo são exemplo. A stack ainda não foi decidida e é assunto do ADR.</a:t>
+              <a:t>As imagens do arquivo são exemplo. A stack ainda não foi decidida e é assunto do documento de decisões arquiteturais.</a:t>
             </a:r>
           </a:p>
         </p:txBody>
@@ -19988,7 +19988,7 @@
                 </a:solidFill>
                 <a:latin typeface="Roboto"/>
               </a:rPr>
-              <a:t>A demonstração é do ambiente e da topologia, não do produto. A implementação começa na Sprint 4.</a:t>
+              <a:t>A demonstração é do ambiente e da topologia, não do produto. A implementação do produto começa em outubro.</a:t>
             </a:r>
           </a:p>
         </p:txBody>
@@ -20487,7 +20487,7 @@
                 </a:solidFill>
                 <a:latin typeface="Roboto"/>
               </a:rPr>
-              <a:t>A Sprint 2 tem uma Questão Norteadora a responder: como os componentes serão distribuídos e implantados no ambiente de execução.</a:t>
+              <a:t>O projeto ainda não decidiu como os componentes serão distribuídos e implantados no ambiente de execução.</a:t>
             </a:r>
           </a:p>
         </p:txBody>
@@ -22740,7 +22740,7 @@
         </p:nvSpPr>
         <p:spPr>
           <a:xfrm>
-            <a:off x="685800" y="2193226"/>
+            <a:off x="685800" y="2061210"/>
             <a:ext cx="5143500" cy="182880"/>
           </a:xfrm>
           <a:prstGeom prst="rect">
@@ -22779,7 +22779,7 @@
         </p:nvSpPr>
         <p:spPr>
           <a:xfrm>
-            <a:off x="685800" y="2402776"/>
+            <a:off x="685800" y="2270760"/>
             <a:ext cx="419100" cy="28575"/>
           </a:xfrm>
           <a:prstGeom prst="rect">
@@ -22823,7 +22823,7 @@
         </p:nvSpPr>
         <p:spPr>
           <a:xfrm>
-            <a:off x="704850" y="2792540"/>
+            <a:off x="704850" y="2660523"/>
             <a:ext cx="57150" cy="57150"/>
           </a:xfrm>
           <a:prstGeom prst="rect">
@@ -22867,7 +22867,7 @@
         </p:nvSpPr>
         <p:spPr>
           <a:xfrm>
-            <a:off x="971550" y="2688526"/>
+            <a:off x="971550" y="2556510"/>
             <a:ext cx="4857750" cy="95250"/>
           </a:xfrm>
           <a:prstGeom prst="rect">
@@ -22906,7 +22906,7 @@
         </p:nvSpPr>
         <p:spPr>
           <a:xfrm>
-            <a:off x="704850" y="3323273"/>
+            <a:off x="704850" y="3191256"/>
             <a:ext cx="57150" cy="57150"/>
           </a:xfrm>
           <a:prstGeom prst="rect">
@@ -22950,7 +22950,7 @@
         </p:nvSpPr>
         <p:spPr>
           <a:xfrm>
-            <a:off x="971550" y="3219260"/>
+            <a:off x="971550" y="3087243"/>
             <a:ext cx="4857750" cy="95250"/>
           </a:xfrm>
           <a:prstGeom prst="rect">
@@ -22989,7 +22989,7 @@
         </p:nvSpPr>
         <p:spPr>
           <a:xfrm>
-            <a:off x="704850" y="3854006"/>
+            <a:off x="704850" y="3721989"/>
             <a:ext cx="57150" cy="57150"/>
           </a:xfrm>
           <a:prstGeom prst="rect">
@@ -23033,7 +23033,7 @@
         </p:nvSpPr>
         <p:spPr>
           <a:xfrm>
-            <a:off x="971550" y="3749993"/>
+            <a:off x="971550" y="3617976"/>
             <a:ext cx="4857750" cy="95250"/>
           </a:xfrm>
           <a:prstGeom prst="rect">
@@ -23072,7 +23072,7 @@
         </p:nvSpPr>
         <p:spPr>
           <a:xfrm>
-            <a:off x="6362700" y="2193226"/>
+            <a:off x="6362700" y="2061210"/>
             <a:ext cx="5143500" cy="182880"/>
           </a:xfrm>
           <a:prstGeom prst="rect">
@@ -23111,7 +23111,7 @@
         </p:nvSpPr>
         <p:spPr>
           <a:xfrm>
-            <a:off x="6362700" y="2402776"/>
+            <a:off x="6362700" y="2270760"/>
             <a:ext cx="419100" cy="28575"/>
           </a:xfrm>
           <a:prstGeom prst="rect">
@@ -23155,7 +23155,7 @@
         </p:nvSpPr>
         <p:spPr>
           <a:xfrm>
-            <a:off x="6381750" y="2792540"/>
+            <a:off x="6381750" y="2660523"/>
             <a:ext cx="57150" cy="57150"/>
           </a:xfrm>
           <a:prstGeom prst="rect">
@@ -23199,7 +23199,7 @@
         </p:nvSpPr>
         <p:spPr>
           <a:xfrm>
-            <a:off x="6648450" y="2688526"/>
+            <a:off x="6648450" y="2556510"/>
             <a:ext cx="4857750" cy="95250"/>
           </a:xfrm>
           <a:prstGeom prst="rect">
@@ -23238,7 +23238,7 @@
         </p:nvSpPr>
         <p:spPr>
           <a:xfrm>
-            <a:off x="6381750" y="3323273"/>
+            <a:off x="6381750" y="3191256"/>
             <a:ext cx="57150" cy="57150"/>
           </a:xfrm>
           <a:prstGeom prst="rect">
@@ -23282,7 +23282,7 @@
         </p:nvSpPr>
         <p:spPr>
           <a:xfrm>
-            <a:off x="6648450" y="3219260"/>
+            <a:off x="6648450" y="3087243"/>
             <a:ext cx="4857750" cy="95250"/>
           </a:xfrm>
           <a:prstGeom prst="rect">
@@ -23321,7 +23321,7 @@
         </p:nvSpPr>
         <p:spPr>
           <a:xfrm>
-            <a:off x="6381750" y="4382072"/>
+            <a:off x="6381750" y="4250055"/>
             <a:ext cx="57150" cy="57150"/>
           </a:xfrm>
           <a:prstGeom prst="rect">
@@ -23365,7 +23365,7 @@
         </p:nvSpPr>
         <p:spPr>
           <a:xfrm>
-            <a:off x="6648450" y="4278058"/>
+            <a:off x="6648450" y="4146042"/>
             <a:ext cx="4857750" cy="95250"/>
           </a:xfrm>
           <a:prstGeom prst="rect">
@@ -23404,7 +23404,7 @@
         </p:nvSpPr>
         <p:spPr>
           <a:xfrm>
-            <a:off x="6381750" y="5440870"/>
+            <a:off x="6381750" y="5308854"/>
             <a:ext cx="57150" cy="57150"/>
           </a:xfrm>
           <a:prstGeom prst="rect">
@@ -23448,7 +23448,7 @@
         </p:nvSpPr>
         <p:spPr>
           <a:xfrm>
-            <a:off x="6648450" y="5336858"/>
+            <a:off x="6648450" y="5204841"/>
             <a:ext cx="4857750" cy="95250"/>
           </a:xfrm>
           <a:prstGeom prst="rect">
@@ -23474,7 +23474,7 @@
                 </a:solidFill>
                 <a:latin typeface="Roboto"/>
               </a:rPr>
-              <a:t>Por isso o ADR precisa registrar que container não dá o mesmo isolamento de uma máquina virtual.</a:t>
+              <a:t>Por isso o documento de decisões arquiteturais precisa registrar que container não dá o mesmo isolamento de uma máquina virtual.</a:t>
             </a:r>
           </a:p>
         </p:txBody>
@@ -26415,7 +26415,7 @@
         </p:nvSpPr>
         <p:spPr>
           <a:xfrm>
-            <a:off x="704850" y="3141726"/>
+            <a:off x="704850" y="3003423"/>
             <a:ext cx="57150" cy="57150"/>
           </a:xfrm>
           <a:prstGeom prst="rect">
@@ -26459,7 +26459,7 @@
         </p:nvSpPr>
         <p:spPr>
           <a:xfrm>
-            <a:off x="971550" y="3032760"/>
+            <a:off x="971550" y="2894457"/>
             <a:ext cx="7677150" cy="95250"/>
           </a:xfrm>
           <a:prstGeom prst="rect">
@@ -26498,7 +26498,7 @@
         </p:nvSpPr>
         <p:spPr>
           <a:xfrm>
-            <a:off x="704850" y="3980688"/>
+            <a:off x="704850" y="3842385"/>
             <a:ext cx="57150" cy="57150"/>
           </a:xfrm>
           <a:prstGeom prst="rect">
@@ -26542,7 +26542,7 @@
         </p:nvSpPr>
         <p:spPr>
           <a:xfrm>
-            <a:off x="971550" y="3871722"/>
+            <a:off x="971550" y="3733419"/>
             <a:ext cx="7677150" cy="95250"/>
           </a:xfrm>
           <a:prstGeom prst="rect">
@@ -26581,7 +26581,7 @@
         </p:nvSpPr>
         <p:spPr>
           <a:xfrm>
-            <a:off x="704850" y="4819650"/>
+            <a:off x="704850" y="4681347"/>
             <a:ext cx="57150" cy="57150"/>
           </a:xfrm>
           <a:prstGeom prst="rect">
@@ -26625,7 +26625,7 @@
         </p:nvSpPr>
         <p:spPr>
           <a:xfrm>
-            <a:off x="971550" y="4710684"/>
+            <a:off x="971550" y="4572381"/>
             <a:ext cx="7677150" cy="95250"/>
           </a:xfrm>
           <a:prstGeom prst="rect">
@@ -26651,7 +26651,7 @@
                 </a:solidFill>
                 <a:latin typeface="Roboto"/>
               </a:rPr>
-              <a:t>A stack ainda não está decidida, e o ADR é onde ela será registrada.</a:t>
+              <a:t>A stack ainda não está decidida, e é o documento de decisões arquiteturais que vai registrar isso.</a:t>
             </a:r>
           </a:p>
         </p:txBody>
@@ -26664,7 +26664,7 @@
         </p:nvSpPr>
         <p:spPr>
           <a:xfrm>
-            <a:off x="9124950" y="3042285"/>
+            <a:off x="9124950" y="2903982"/>
             <a:ext cx="142875" cy="123825"/>
           </a:xfrm>
           <a:prstGeom prst="chevron">
@@ -26708,7 +26708,7 @@
         </p:nvSpPr>
         <p:spPr>
           <a:xfrm>
-            <a:off x="9372600" y="3042285"/>
+            <a:off x="9372600" y="2903982"/>
             <a:ext cx="2133600" cy="182880"/>
           </a:xfrm>
           <a:prstGeom prst="rect">
@@ -26747,7 +26747,7 @@
         </p:nvSpPr>
         <p:spPr>
           <a:xfrm>
-            <a:off x="9124950" y="3318510"/>
+            <a:off x="9124950" y="3180207"/>
             <a:ext cx="38100" cy="804672"/>
           </a:xfrm>
           <a:prstGeom prst="rect">
@@ -26791,7 +26791,7 @@
         </p:nvSpPr>
         <p:spPr>
           <a:xfrm>
-            <a:off x="9334500" y="3318510"/>
+            <a:off x="9334500" y="3180207"/>
             <a:ext cx="2171700" cy="1376172"/>
           </a:xfrm>
           <a:prstGeom prst="rect">
@@ -27665,7 +27665,7 @@
         </p:nvSpPr>
         <p:spPr>
           <a:xfrm>
-            <a:off x="704850" y="3561207"/>
+            <a:off x="704850" y="3422904"/>
             <a:ext cx="57150" cy="57150"/>
           </a:xfrm>
           <a:prstGeom prst="rect">
@@ -27709,7 +27709,7 @@
         </p:nvSpPr>
         <p:spPr>
           <a:xfrm>
-            <a:off x="971550" y="3452241"/>
+            <a:off x="971550" y="3313938"/>
             <a:ext cx="7486650" cy="95250"/>
           </a:xfrm>
           <a:prstGeom prst="rect">
@@ -27748,7 +27748,7 @@
         </p:nvSpPr>
         <p:spPr>
           <a:xfrm>
-            <a:off x="704850" y="4400169"/>
+            <a:off x="704850" y="4261866"/>
             <a:ext cx="57150" cy="57150"/>
           </a:xfrm>
           <a:prstGeom prst="rect">
@@ -27792,7 +27792,7 @@
         </p:nvSpPr>
         <p:spPr>
           <a:xfrm>
-            <a:off x="971550" y="4291203"/>
+            <a:off x="971550" y="4152900"/>
             <a:ext cx="7486650" cy="95250"/>
           </a:xfrm>
           <a:prstGeom prst="rect">
@@ -27818,7 +27818,7 @@
                 </a:solidFill>
                 <a:latin typeface="Roboto"/>
               </a:rPr>
-              <a:t>O ADR, onde a stack será decidida, ainda não foi escrito.</a:t>
+              <a:t>O documento de decisões arquiteturais, onde a stack será decidida, ainda não foi escrito.</a:t>
             </a:r>
           </a:p>
         </p:txBody>
@@ -27831,7 +27831,7 @@
         </p:nvSpPr>
         <p:spPr>
           <a:xfrm>
-            <a:off x="9124950" y="3452241"/>
+            <a:off x="9124950" y="3313938"/>
             <a:ext cx="142875" cy="133350"/>
           </a:xfrm>
           <a:prstGeom prst="flowChartDocument">
@@ -27875,7 +27875,7 @@
         </p:nvSpPr>
         <p:spPr>
           <a:xfrm>
-            <a:off x="9372600" y="3461766"/>
+            <a:off x="9372600" y="3323463"/>
             <a:ext cx="2133600" cy="182880"/>
           </a:xfrm>
           <a:prstGeom prst="rect">
@@ -27914,7 +27914,7 @@
         </p:nvSpPr>
         <p:spPr>
           <a:xfrm>
-            <a:off x="9124950" y="3737991"/>
+            <a:off x="9124950" y="3599688"/>
             <a:ext cx="38100" cy="1664208"/>
           </a:xfrm>
           <a:prstGeom prst="rect">
@@ -27958,7 +27958,7 @@
         </p:nvSpPr>
         <p:spPr>
           <a:xfrm>
-            <a:off x="9334500" y="3737991"/>
+            <a:off x="9334500" y="3599688"/>
             <a:ext cx="2171700" cy="2235708"/>
           </a:xfrm>
           <a:prstGeom prst="rect">

</xml_diff>

<commit_message>
docs: ordena a capa e faz o slide de recomendacao dizer para que o Docker sera usado
</commit_message>
<xml_diff>
--- a/trabalhos/T1-Docker-Invite-People.pptx
+++ b/trabalhos/T1-Docker-Invite-People.pptx
@@ -11829,7 +11829,7 @@
                 </a:solidFill>
                 <a:latin typeface="Roboto"/>
               </a:rPr>
-              <a:t>Tiago Passos · Guilherme Toebe</a:t>
+              <a:t>Andreas Grings · Gabriel Tomasi</a:t>
             </a:r>
           </a:p>
           <a:p>
@@ -11845,7 +11845,7 @@
                 </a:solidFill>
                 <a:latin typeface="Roboto"/>
               </a:rPr>
-              <a:t>Andreas Grings · Gabriel Tomasi</a:t>
+              <a:t>Guilherme Toebe · Tiago Passos</a:t>
             </a:r>
           </a:p>
         </p:txBody>
@@ -11940,100 +11940,6 @@
                 <a:latin typeface="Roboto"/>
               </a:rPr>
               <a:t>Prof. Kleinner Farias</a:t>
-            </a:r>
-          </a:p>
-        </p:txBody>
-      </p:sp>
-      <p:sp>
-        <p:nvSpPr>
-          <p:cNvPr id="11" name="TextBox 10"/>
-          <p:cNvSpPr txBox="1"/>
-          <p:nvPr/>
-        </p:nvSpPr>
-        <p:spPr>
-          <a:xfrm>
-            <a:off x="7924800" y="5391150"/>
-            <a:ext cx="2667000" cy="152400"/>
-          </a:xfrm>
-          <a:prstGeom prst="rect">
-            <a:avLst/>
-          </a:prstGeom>
-          <a:noFill/>
-        </p:spPr>
-        <p:txBody>
-          <a:bodyPr wrap="square" lIns="0" rIns="0" tIns="0" bIns="0" anchor="t">
-            <a:spAutoFit/>
-          </a:bodyPr>
-          <a:lstStyle/>
-          <a:p>
-            <a:pPr algn="l">
-              <a:lnSpc>
-                <a:spcPct val="120000"/>
-              </a:lnSpc>
-            </a:pPr>
-            <a:r>
-              <a:rPr sz="750" b="0" i="0" spc="140">
-                <a:solidFill>
-                  <a:srgbClr val="9C90D4"/>
-                </a:solidFill>
-                <a:latin typeface="Roboto"/>
-              </a:rPr>
-              <a:t>DATA</a:t>
-            </a:r>
-          </a:p>
-        </p:txBody>
-      </p:sp>
-      <p:sp>
-        <p:nvSpPr>
-          <p:cNvPr id="12" name="TextBox 11"/>
-          <p:cNvSpPr txBox="1"/>
-          <p:nvPr/>
-        </p:nvSpPr>
-        <p:spPr>
-          <a:xfrm>
-            <a:off x="7924800" y="5581650"/>
-            <a:ext cx="2667000" cy="666750"/>
-          </a:xfrm>
-          <a:prstGeom prst="rect">
-            <a:avLst/>
-          </a:prstGeom>
-          <a:noFill/>
-        </p:spPr>
-        <p:txBody>
-          <a:bodyPr wrap="square" lIns="0" rIns="0" tIns="0" bIns="0" anchor="t">
-            <a:spAutoFit/>
-          </a:bodyPr>
-          <a:lstStyle/>
-          <a:p>
-            <a:pPr algn="l">
-              <a:lnSpc>
-                <a:spcPct val="140000"/>
-              </a:lnSpc>
-            </a:pPr>
-            <a:r>
-              <a:rPr sz="980" b="0" i="0">
-                <a:solidFill>
-                  <a:srgbClr val="E0DBF2"/>
-                </a:solidFill>
-                <a:latin typeface="Roboto"/>
-              </a:rPr>
-              <a:t>08 de setembro</a:t>
-            </a:r>
-          </a:p>
-          <a:p>
-            <a:pPr>
-              <a:lnSpc>
-                <a:spcPct val="140000"/>
-              </a:lnSpc>
-            </a:pPr>
-            <a:r>
-              <a:rPr sz="980" b="0" i="0">
-                <a:solidFill>
-                  <a:srgbClr val="E0DBF2"/>
-                </a:solidFill>
-                <a:latin typeface="Roboto"/>
-              </a:rPr>
-              <a:t>de 2026</a:t>
             </a:r>
           </a:p>
         </p:txBody>
@@ -26402,7 +26308,7 @@
                 </a:solidFill>
                 <a:latin typeface="Roboto"/>
               </a:rPr>
-              <a:t>Recomendação do grupo</a:t>
+              <a:t>Para que o grupo vai usar</a:t>
             </a:r>
           </a:p>
         </p:txBody>
@@ -26415,7 +26321,7 @@
         </p:nvSpPr>
         <p:spPr>
           <a:xfrm>
-            <a:off x="704850" y="3003423"/>
+            <a:off x="704850" y="2164461"/>
             <a:ext cx="57150" cy="57150"/>
           </a:xfrm>
           <a:prstGeom prst="rect">
@@ -26459,7 +26365,7 @@
         </p:nvSpPr>
         <p:spPr>
           <a:xfrm>
-            <a:off x="971550" y="2894457"/>
+            <a:off x="971550" y="2055495"/>
             <a:ext cx="7677150" cy="95250"/>
           </a:xfrm>
           <a:prstGeom prst="rect">
@@ -26485,7 +26391,7 @@
                 </a:solidFill>
                 <a:latin typeface="Roboto"/>
               </a:rPr>
-              <a:t>O grupo recomenda adotar conteinerização como estratégia de empacotamento e de ambiente de desenvolvimento, com o custo declarado junto.</a:t>
+              <a:t>Ambiente de desenvolvimento igual para os quatro, com o banco rodando sem ninguém instalar nada na própria máquina.</a:t>
             </a:r>
           </a:p>
         </p:txBody>
@@ -26498,7 +26404,7 @@
         </p:nvSpPr>
         <p:spPr>
           <a:xfrm>
-            <a:off x="704850" y="3842385"/>
+            <a:off x="704850" y="3003423"/>
             <a:ext cx="57150" cy="57150"/>
           </a:xfrm>
           <a:prstGeom prst="rect">
@@ -26542,7 +26448,7 @@
         </p:nvSpPr>
         <p:spPr>
           <a:xfrm>
-            <a:off x="971550" y="3733419"/>
+            <a:off x="971550" y="2894457"/>
             <a:ext cx="7677150" cy="95250"/>
           </a:xfrm>
           <a:prstGeom prst="rect">
@@ -26568,7 +26474,7 @@
                 </a:solidFill>
                 <a:latin typeface="Roboto"/>
               </a:rPr>
-              <a:t>O diagrama de implantação deixa de ser caixa genérica e passa a ter um arquivo correspondente que roda, e esse arquivo vira artefato do repositório.</a:t>
+              <a:t>Um arquivo no repositório que descreve esse ambiente inteiro, versionado junto com o código, e que qualquer um sobe com um comando.</a:t>
             </a:r>
           </a:p>
         </p:txBody>
@@ -26581,7 +26487,7 @@
         </p:nvSpPr>
         <p:spPr>
           <a:xfrm>
-            <a:off x="704850" y="4681347"/>
+            <a:off x="704850" y="3842385"/>
             <a:ext cx="57150" cy="57150"/>
           </a:xfrm>
           <a:prstGeom prst="rect">
@@ -26625,7 +26531,7 @@
         </p:nvSpPr>
         <p:spPr>
           <a:xfrm>
-            <a:off x="971550" y="4572381"/>
+            <a:off x="971550" y="3733419"/>
             <a:ext cx="7677150" cy="95250"/>
           </a:xfrm>
           <a:prstGeom prst="rect">
@@ -26651,23 +26557,23 @@
                 </a:solidFill>
                 <a:latin typeface="Roboto"/>
               </a:rPr>
-              <a:t>A stack ainda não está decidida, e é o documento de decisões arquiteturais que vai registrar isso.</a:t>
-            </a:r>
-          </a:p>
-        </p:txBody>
-      </p:sp>
-      <p:sp>
-        <p:nvSpPr>
-          <p:cNvPr id="10" name="Chevron 9"/>
+              <a:t>Na entrega e na apresentação do produto, a mesma imagem que rodou no desenvolvimento, sem reconfigurar máquina.</a:t>
+            </a:r>
+          </a:p>
+        </p:txBody>
+      </p:sp>
+      <p:sp>
+        <p:nvSpPr>
+          <p:cNvPr id="10" name="Rectangle 9"/>
           <p:cNvSpPr/>
           <p:nvPr/>
         </p:nvSpPr>
         <p:spPr>
           <a:xfrm>
-            <a:off x="9124950" y="2903982"/>
-            <a:ext cx="142875" cy="123825"/>
-          </a:xfrm>
-          <a:prstGeom prst="chevron">
+            <a:off x="704850" y="4681347"/>
+            <a:ext cx="57150" cy="57150"/>
+          </a:xfrm>
+          <a:prstGeom prst="rect">
             <a:avLst/>
           </a:prstGeom>
           <a:solidFill>
@@ -26693,7 +26599,7 @@
           </a:fontRef>
         </p:style>
         <p:txBody>
-          <a:bodyPr rtlCol="0" anchor="ctr"/>
+          <a:bodyPr rtlCol="0" anchor="ctr" wrap="square" lIns="0" rIns="0" tIns="0" bIns="0"/>
           <a:lstStyle/>
           <a:p>
             <a:pPr algn="ctr"/>
@@ -26708,8 +26614,8 @@
         </p:nvSpPr>
         <p:spPr>
           <a:xfrm>
-            <a:off x="9372600" y="2903982"/>
-            <a:ext cx="2133600" cy="182880"/>
+            <a:off x="971550" y="4572381"/>
+            <a:ext cx="7677150" cy="95250"/>
           </a:xfrm>
           <a:prstGeom prst="rect">
             <a:avLst/>
@@ -26724,17 +26630,17 @@
           <a:p>
             <a:pPr algn="l">
               <a:lnSpc>
-                <a:spcPct val="120000"/>
-              </a:lnSpc>
-            </a:pPr>
-            <a:r>
-              <a:rPr sz="900" b="1" i="0" spc="120">
-                <a:solidFill>
-                  <a:srgbClr val="E94D1C"/>
+                <a:spcPct val="130000"/>
+              </a:lnSpc>
+            </a:pPr>
+            <a:r>
+              <a:rPr sz="1650" b="0" i="0">
+                <a:solidFill>
+                  <a:srgbClr val="1A1A1E"/>
                 </a:solidFill>
                 <a:latin typeface="Roboto"/>
               </a:rPr>
-              <a:t>PRÓXIMO PASSO</a:t>
+              <a:t>O diagrama de implantação deixa de ser caixa genérica e passa a ter um arquivo correspondente que roda.</a:t>
             </a:r>
           </a:p>
         </p:txBody>
@@ -26747,8 +26653,8 @@
         </p:nvSpPr>
         <p:spPr>
           <a:xfrm>
-            <a:off x="9124950" y="3180207"/>
-            <a:ext cx="38100" cy="804672"/>
+            <a:off x="704850" y="5520309"/>
+            <a:ext cx="57150" cy="57150"/>
           </a:xfrm>
           <a:prstGeom prst="rect">
             <a:avLst/>
@@ -26791,8 +26697,8 @@
         </p:nvSpPr>
         <p:spPr>
           <a:xfrm>
-            <a:off x="9334500" y="3180207"/>
-            <a:ext cx="2171700" cy="1376172"/>
+            <a:off x="971550" y="5411343"/>
+            <a:ext cx="7677150" cy="95250"/>
           </a:xfrm>
           <a:prstGeom prst="rect">
             <a:avLst/>
@@ -26807,6 +26713,172 @@
           <a:p>
             <a:pPr algn="l">
               <a:lnSpc>
+                <a:spcPct val="130000"/>
+              </a:lnSpc>
+            </a:pPr>
+            <a:r>
+              <a:rPr sz="1650" b="0" i="0">
+                <a:solidFill>
+                  <a:srgbClr val="1A1A1E"/>
+                </a:solidFill>
+                <a:latin typeface="Roboto"/>
+              </a:rPr>
+              <a:t>A stack ainda não está decidida, e é o documento de decisões arquiteturais que vai registrar isso.</a:t>
+            </a:r>
+          </a:p>
+        </p:txBody>
+      </p:sp>
+      <p:sp>
+        <p:nvSpPr>
+          <p:cNvPr id="14" name="Chevron 13"/>
+          <p:cNvSpPr/>
+          <p:nvPr/>
+        </p:nvSpPr>
+        <p:spPr>
+          <a:xfrm>
+            <a:off x="9124950" y="2065020"/>
+            <a:ext cx="142875" cy="123825"/>
+          </a:xfrm>
+          <a:prstGeom prst="chevron">
+            <a:avLst/>
+          </a:prstGeom>
+          <a:solidFill>
+            <a:srgbClr val="E94D1C"/>
+          </a:solidFill>
+          <a:ln>
+            <a:noFill/>
+          </a:ln>
+          <a:effectLst/>
+        </p:spPr>
+        <p:style>
+          <a:lnRef idx="1">
+            <a:schemeClr val="accent1"/>
+          </a:lnRef>
+          <a:fillRef idx="3">
+            <a:schemeClr val="accent1"/>
+          </a:fillRef>
+          <a:effectRef idx="2">
+            <a:schemeClr val="accent1"/>
+          </a:effectRef>
+          <a:fontRef idx="minor">
+            <a:schemeClr val="lt1"/>
+          </a:fontRef>
+        </p:style>
+        <p:txBody>
+          <a:bodyPr rtlCol="0" anchor="ctr"/>
+          <a:lstStyle/>
+          <a:p>
+            <a:pPr algn="ctr"/>
+          </a:p>
+        </p:txBody>
+      </p:sp>
+      <p:sp>
+        <p:nvSpPr>
+          <p:cNvPr id="15" name="TextBox 14"/>
+          <p:cNvSpPr txBox="1"/>
+          <p:nvPr/>
+        </p:nvSpPr>
+        <p:spPr>
+          <a:xfrm>
+            <a:off x="9372600" y="2065020"/>
+            <a:ext cx="2133600" cy="182880"/>
+          </a:xfrm>
+          <a:prstGeom prst="rect">
+            <a:avLst/>
+          </a:prstGeom>
+          <a:noFill/>
+        </p:spPr>
+        <p:txBody>
+          <a:bodyPr wrap="square" lIns="0" rIns="0" tIns="0" bIns="0" anchor="t">
+            <a:spAutoFit/>
+          </a:bodyPr>
+          <a:lstStyle/>
+          <a:p>
+            <a:pPr algn="l">
+              <a:lnSpc>
+                <a:spcPct val="120000"/>
+              </a:lnSpc>
+            </a:pPr>
+            <a:r>
+              <a:rPr sz="900" b="1" i="0" spc="120">
+                <a:solidFill>
+                  <a:srgbClr val="E94D1C"/>
+                </a:solidFill>
+                <a:latin typeface="Roboto"/>
+              </a:rPr>
+              <a:t>PRÓXIMO PASSO</a:t>
+            </a:r>
+          </a:p>
+        </p:txBody>
+      </p:sp>
+      <p:sp>
+        <p:nvSpPr>
+          <p:cNvPr id="16" name="Rectangle 15"/>
+          <p:cNvSpPr/>
+          <p:nvPr/>
+        </p:nvSpPr>
+        <p:spPr>
+          <a:xfrm>
+            <a:off x="9124950" y="2341245"/>
+            <a:ext cx="38100" cy="804672"/>
+          </a:xfrm>
+          <a:prstGeom prst="rect">
+            <a:avLst/>
+          </a:prstGeom>
+          <a:solidFill>
+            <a:srgbClr val="E94D1C"/>
+          </a:solidFill>
+          <a:ln>
+            <a:noFill/>
+          </a:ln>
+          <a:effectLst/>
+        </p:spPr>
+        <p:style>
+          <a:lnRef idx="1">
+            <a:schemeClr val="accent1"/>
+          </a:lnRef>
+          <a:fillRef idx="3">
+            <a:schemeClr val="accent1"/>
+          </a:fillRef>
+          <a:effectRef idx="2">
+            <a:schemeClr val="accent1"/>
+          </a:effectRef>
+          <a:fontRef idx="minor">
+            <a:schemeClr val="lt1"/>
+          </a:fontRef>
+        </p:style>
+        <p:txBody>
+          <a:bodyPr rtlCol="0" anchor="ctr" wrap="square" lIns="0" rIns="0" tIns="0" bIns="0"/>
+          <a:lstStyle/>
+          <a:p>
+            <a:pPr algn="ctr"/>
+          </a:p>
+        </p:txBody>
+      </p:sp>
+      <p:sp>
+        <p:nvSpPr>
+          <p:cNvPr id="17" name="TextBox 16"/>
+          <p:cNvSpPr txBox="1"/>
+          <p:nvPr/>
+        </p:nvSpPr>
+        <p:spPr>
+          <a:xfrm>
+            <a:off x="9334500" y="2341245"/>
+            <a:ext cx="2171700" cy="1376172"/>
+          </a:xfrm>
+          <a:prstGeom prst="rect">
+            <a:avLst/>
+          </a:prstGeom>
+          <a:noFill/>
+        </p:spPr>
+        <p:txBody>
+          <a:bodyPr wrap="square" lIns="0" rIns="0" tIns="0" bIns="0" anchor="t">
+            <a:spAutoFit/>
+          </a:bodyPr>
+          <a:lstStyle/>
+          <a:p>
+            <a:pPr algn="l">
+              <a:lnSpc>
                 <a:spcPct val="140000"/>
               </a:lnSpc>
               <a:spcAft>
@@ -26827,7 +26899,7 @@
       </p:sp>
       <p:sp>
         <p:nvSpPr>
-          <p:cNvPr id="14" name="TextBox 13"/>
+          <p:cNvPr id="18" name="TextBox 17"/>
           <p:cNvSpPr txBox="1"/>
           <p:nvPr/>
         </p:nvSpPr>
@@ -26866,7 +26938,7 @@
       </p:sp>
       <p:sp>
         <p:nvSpPr>
-          <p:cNvPr id="15" name="TextBox 14"/>
+          <p:cNvPr id="19" name="TextBox 18"/>
           <p:cNvSpPr txBox="1"/>
           <p:nvPr/>
         </p:nvSpPr>

</xml_diff>

<commit_message>
docs: adiciona os logos oficiais do Docker, da OCI e do Kubernetes aos slides do T1
</commit_message>
<xml_diff>
--- a/trabalhos/T1-Docker-Invite-People.pptx
+++ b/trabalhos/T1-Docker-Invite-People.pptx
@@ -11756,9 +11756,33 @@
           </a:p>
         </p:txBody>
       </p:sp>
-      <p:sp>
-        <p:nvSpPr>
-          <p:cNvPr id="7" name="TextBox 6"/>
+      <p:pic>
+        <p:nvPicPr>
+          <p:cNvPr id="7" name="Picture 6" descr="docker.png"/>
+          <p:cNvPicPr>
+            <a:picLocks noChangeAspect="1"/>
+          </p:cNvPicPr>
+          <p:nvPr/>
+        </p:nvPicPr>
+        <p:blipFill>
+          <a:blip r:embed="rId3"/>
+          <a:stretch>
+            <a:fillRect/>
+          </a:stretch>
+        </p:blipFill>
+        <p:spPr>
+          <a:xfrm>
+            <a:off x="8572500" y="2038350"/>
+            <a:ext cx="2667000" cy="1912607"/>
+          </a:xfrm>
+          <a:prstGeom prst="rect">
+            <a:avLst/>
+          </a:prstGeom>
+        </p:spPr>
+      </p:pic>
+      <p:sp>
+        <p:nvSpPr>
+          <p:cNvPr id="8" name="TextBox 7"/>
           <p:cNvSpPr txBox="1"/>
           <p:nvPr/>
         </p:nvSpPr>
@@ -11797,7 +11821,7 @@
       </p:sp>
       <p:sp>
         <p:nvSpPr>
-          <p:cNvPr id="8" name="TextBox 7"/>
+          <p:cNvPr id="9" name="TextBox 8"/>
           <p:cNvSpPr txBox="1"/>
           <p:nvPr/>
         </p:nvSpPr>
@@ -11852,7 +11876,7 @@
       </p:sp>
       <p:sp>
         <p:nvSpPr>
-          <p:cNvPr id="9" name="TextBox 8"/>
+          <p:cNvPr id="10" name="TextBox 9"/>
           <p:cNvSpPr txBox="1"/>
           <p:nvPr/>
         </p:nvSpPr>
@@ -11891,7 +11915,7 @@
       </p:sp>
       <p:sp>
         <p:nvSpPr>
-          <p:cNvPr id="10" name="TextBox 9"/>
+          <p:cNvPr id="11" name="TextBox 10"/>
           <p:cNvSpPr txBox="1"/>
           <p:nvPr/>
         </p:nvSpPr>
@@ -13542,16 +13566,40 @@
           </a:prstGeom>
         </p:spPr>
       </p:pic>
-      <p:sp>
-        <p:nvSpPr>
-          <p:cNvPr id="3" name="TextBox 2"/>
+      <p:pic>
+        <p:nvPicPr>
+          <p:cNvPr id="3" name="Picture 2" descr="oci-branco.png"/>
+          <p:cNvPicPr>
+            <a:picLocks noChangeAspect="1"/>
+          </p:cNvPicPr>
+          <p:nvPr/>
+        </p:nvPicPr>
+        <p:blipFill>
+          <a:blip r:embed="rId3"/>
+          <a:stretch>
+            <a:fillRect/>
+          </a:stretch>
+        </p:blipFill>
+        <p:spPr>
+          <a:xfrm>
+            <a:off x="7810500" y="1962150"/>
+            <a:ext cx="3048000" cy="839090"/>
+          </a:xfrm>
+          <a:prstGeom prst="rect">
+            <a:avLst/>
+          </a:prstGeom>
+        </p:spPr>
+      </p:pic>
+      <p:sp>
+        <p:nvSpPr>
+          <p:cNvPr id="4" name="TextBox 3"/>
           <p:cNvSpPr txBox="1"/>
           <p:nvPr/>
         </p:nvSpPr>
         <p:spPr>
           <a:xfrm>
             <a:off x="914400" y="1866900"/>
-            <a:ext cx="9715500" cy="1905000"/>
+            <a:ext cx="6667500" cy="1905000"/>
           </a:xfrm>
           <a:prstGeom prst="rect">
             <a:avLst/>
@@ -13599,7 +13647,7 @@
       </p:sp>
       <p:sp>
         <p:nvSpPr>
-          <p:cNvPr id="4" name="TextBox 3"/>
+          <p:cNvPr id="5" name="TextBox 4"/>
           <p:cNvSpPr txBox="1"/>
           <p:nvPr/>
         </p:nvSpPr>
@@ -13638,7 +13686,7 @@
       </p:sp>
       <p:sp>
         <p:nvSpPr>
-          <p:cNvPr id="5" name="TextBox 4"/>
+          <p:cNvPr id="6" name="TextBox 5"/>
           <p:cNvSpPr txBox="1"/>
           <p:nvPr/>
         </p:nvSpPr>
@@ -13677,7 +13725,7 @@
       </p:sp>
       <p:sp>
         <p:nvSpPr>
-          <p:cNvPr id="6" name="TextBox 5"/>
+          <p:cNvPr id="7" name="TextBox 6"/>
           <p:cNvSpPr txBox="1"/>
           <p:nvPr/>
         </p:nvSpPr>
@@ -22631,16 +22679,40 @@
           </a:prstGeom>
         </p:spPr>
       </p:pic>
-      <p:sp>
-        <p:nvSpPr>
-          <p:cNvPr id="3" name="TextBox 2"/>
+      <p:pic>
+        <p:nvPicPr>
+          <p:cNvPr id="3" name="Picture 2" descr="kubernetes-branco.png"/>
+          <p:cNvPicPr>
+            <a:picLocks noChangeAspect="1"/>
+          </p:cNvPicPr>
+          <p:nvPr/>
+        </p:nvPicPr>
+        <p:blipFill>
+          <a:blip r:embed="rId3"/>
+          <a:stretch>
+            <a:fillRect/>
+          </a:stretch>
+        </p:blipFill>
+        <p:spPr>
+          <a:xfrm>
+            <a:off x="9144000" y="1676400"/>
+            <a:ext cx="1809750" cy="1809750"/>
+          </a:xfrm>
+          <a:prstGeom prst="rect">
+            <a:avLst/>
+          </a:prstGeom>
+        </p:spPr>
+      </p:pic>
+      <p:sp>
+        <p:nvSpPr>
+          <p:cNvPr id="4" name="TextBox 3"/>
           <p:cNvSpPr txBox="1"/>
           <p:nvPr/>
         </p:nvSpPr>
         <p:spPr>
           <a:xfrm>
             <a:off x="914400" y="1866900"/>
-            <a:ext cx="9715500" cy="1905000"/>
+            <a:ext cx="6667500" cy="1905000"/>
           </a:xfrm>
           <a:prstGeom prst="rect">
             <a:avLst/>
@@ -22688,7 +22760,7 @@
       </p:sp>
       <p:sp>
         <p:nvSpPr>
-          <p:cNvPr id="4" name="TextBox 3"/>
+          <p:cNvPr id="5" name="TextBox 4"/>
           <p:cNvSpPr txBox="1"/>
           <p:nvPr/>
         </p:nvSpPr>
@@ -22727,7 +22799,7 @@
       </p:sp>
       <p:sp>
         <p:nvSpPr>
-          <p:cNvPr id="5" name="TextBox 4"/>
+          <p:cNvPr id="6" name="TextBox 5"/>
           <p:cNvSpPr txBox="1"/>
           <p:nvPr/>
         </p:nvSpPr>
@@ -22766,7 +22838,7 @@
       </p:sp>
       <p:sp>
         <p:nvSpPr>
-          <p:cNvPr id="6" name="TextBox 5"/>
+          <p:cNvPr id="7" name="TextBox 6"/>
           <p:cNvSpPr txBox="1"/>
           <p:nvPr/>
         </p:nvSpPr>
@@ -31434,141 +31506,33 @@
           </a:prstGeom>
         </p:spPr>
       </p:pic>
-      <p:sp>
-        <p:nvSpPr>
-          <p:cNvPr id="4" name="Rounded Rectangle 3"/>
-          <p:cNvSpPr/>
-          <p:nvPr/>
-        </p:nvSpPr>
-        <p:spPr>
-          <a:xfrm>
-            <a:off x="8953500" y="3448050"/>
-            <a:ext cx="1676400" cy="247650"/>
-          </a:xfrm>
-          <a:prstGeom prst="roundRect">
-            <a:avLst/>
-          </a:prstGeom>
-          <a:solidFill>
-            <a:srgbClr val="8A3A24"/>
-          </a:solidFill>
-          <a:ln>
-            <a:noFill/>
-          </a:ln>
-          <a:effectLst/>
-        </p:spPr>
-        <p:style>
-          <a:lnRef idx="1">
-            <a:schemeClr val="accent1"/>
-          </a:lnRef>
-          <a:fillRef idx="3">
-            <a:schemeClr val="accent1"/>
-          </a:fillRef>
-          <a:effectRef idx="2">
-            <a:schemeClr val="accent1"/>
-          </a:effectRef>
-          <a:fontRef idx="minor">
-            <a:schemeClr val="lt1"/>
-          </a:fontRef>
-        </p:style>
-        <p:txBody>
-          <a:bodyPr rtlCol="0" anchor="ctr"/>
-          <a:lstStyle/>
-          <a:p>
-            <a:pPr algn="ctr"/>
-          </a:p>
-        </p:txBody>
-      </p:sp>
-      <p:sp>
-        <p:nvSpPr>
-          <p:cNvPr id="5" name="Rounded Rectangle 4"/>
-          <p:cNvSpPr/>
-          <p:nvPr/>
-        </p:nvSpPr>
-        <p:spPr>
-          <a:xfrm>
-            <a:off x="8953500" y="3143250"/>
-            <a:ext cx="1676400" cy="247650"/>
-          </a:xfrm>
-          <a:prstGeom prst="roundRect">
-            <a:avLst/>
-          </a:prstGeom>
-          <a:solidFill>
-            <a:srgbClr val="C04420"/>
-          </a:solidFill>
-          <a:ln>
-            <a:noFill/>
-          </a:ln>
-          <a:effectLst/>
-        </p:spPr>
-        <p:style>
-          <a:lnRef idx="1">
-            <a:schemeClr val="accent1"/>
-          </a:lnRef>
-          <a:fillRef idx="3">
-            <a:schemeClr val="accent1"/>
-          </a:fillRef>
-          <a:effectRef idx="2">
-            <a:schemeClr val="accent1"/>
-          </a:effectRef>
-          <a:fontRef idx="minor">
-            <a:schemeClr val="lt1"/>
-          </a:fontRef>
-        </p:style>
-        <p:txBody>
-          <a:bodyPr rtlCol="0" anchor="ctr"/>
-          <a:lstStyle/>
-          <a:p>
-            <a:pPr algn="ctr"/>
-          </a:p>
-        </p:txBody>
-      </p:sp>
-      <p:sp>
-        <p:nvSpPr>
-          <p:cNvPr id="6" name="Rounded Rectangle 5"/>
-          <p:cNvSpPr/>
-          <p:nvPr/>
-        </p:nvSpPr>
-        <p:spPr>
-          <a:xfrm>
-            <a:off x="8953500" y="2838450"/>
-            <a:ext cx="1676400" cy="247650"/>
-          </a:xfrm>
-          <a:prstGeom prst="roundRect">
-            <a:avLst/>
-          </a:prstGeom>
-          <a:solidFill>
-            <a:srgbClr val="E94D1C"/>
-          </a:solidFill>
-          <a:ln>
-            <a:noFill/>
-          </a:ln>
-          <a:effectLst/>
-        </p:spPr>
-        <p:style>
-          <a:lnRef idx="1">
-            <a:schemeClr val="accent1"/>
-          </a:lnRef>
-          <a:fillRef idx="3">
-            <a:schemeClr val="accent1"/>
-          </a:fillRef>
-          <a:effectRef idx="2">
-            <a:schemeClr val="accent1"/>
-          </a:effectRef>
-          <a:fontRef idx="minor">
-            <a:schemeClr val="lt1"/>
-          </a:fontRef>
-        </p:style>
-        <p:txBody>
-          <a:bodyPr rtlCol="0" anchor="ctr"/>
-          <a:lstStyle/>
-          <a:p>
-            <a:pPr algn="ctr"/>
-          </a:p>
-        </p:txBody>
-      </p:sp>
-      <p:sp>
-        <p:nvSpPr>
-          <p:cNvPr id="7" name="TextBox 6"/>
+      <p:pic>
+        <p:nvPicPr>
+          <p:cNvPr id="4" name="Picture 3" descr="docker.png"/>
+          <p:cNvPicPr>
+            <a:picLocks noChangeAspect="1"/>
+          </p:cNvPicPr>
+          <p:nvPr/>
+        </p:nvPicPr>
+        <p:blipFill>
+          <a:blip r:embed="rId3"/>
+          <a:stretch>
+            <a:fillRect/>
+          </a:stretch>
+        </p:blipFill>
+        <p:spPr>
+          <a:xfrm>
+            <a:off x="8763000" y="2381250"/>
+            <a:ext cx="2476500" cy="1775993"/>
+          </a:xfrm>
+          <a:prstGeom prst="rect">
+            <a:avLst/>
+          </a:prstGeom>
+        </p:spPr>
+      </p:pic>
+      <p:sp>
+        <p:nvSpPr>
+          <p:cNvPr id="5" name="TextBox 4"/>
           <p:cNvSpPr txBox="1"/>
           <p:nvPr/>
         </p:nvSpPr>
@@ -31607,7 +31571,7 @@
       </p:sp>
       <p:sp>
         <p:nvSpPr>
-          <p:cNvPr id="8" name="TextBox 7"/>
+          <p:cNvPr id="6" name="TextBox 5"/>
           <p:cNvSpPr txBox="1"/>
           <p:nvPr/>
         </p:nvSpPr>
@@ -31646,7 +31610,7 @@
       </p:sp>
       <p:sp>
         <p:nvSpPr>
-          <p:cNvPr id="9" name="TextBox 8"/>
+          <p:cNvPr id="7" name="TextBox 6"/>
           <p:cNvSpPr txBox="1"/>
           <p:nvPr/>
         </p:nvSpPr>
@@ -31685,7 +31649,7 @@
       </p:sp>
       <p:sp>
         <p:nvSpPr>
-          <p:cNvPr id="10" name="TextBox 9"/>
+          <p:cNvPr id="8" name="TextBox 7"/>
           <p:cNvSpPr txBox="1"/>
           <p:nvPr/>
         </p:nvSpPr>
@@ -31724,7 +31688,7 @@
       </p:sp>
       <p:sp>
         <p:nvSpPr>
-          <p:cNvPr id="11" name="TextBox 10"/>
+          <p:cNvPr id="9" name="TextBox 8"/>
           <p:cNvSpPr txBox="1"/>
           <p:nvPr/>
         </p:nvSpPr>

</xml_diff>

<commit_message>
docs: tira dos slides do T1 as notas de pendencia e a linguagem de item em aberto
</commit_message>
<xml_diff>
--- a/trabalhos/T1-Docker-Invite-People.pptx
+++ b/trabalhos/T1-Docker-Invite-People.pptx
@@ -19100,7 +19100,7 @@
                 </a:solidFill>
                 <a:latin typeface="Roboto"/>
               </a:rPr>
-              <a:t>As imagens do arquivo são exemplo. A stack ainda não foi decidida e é assunto do documento de decisões arquiteturais.</a:t>
+              <a:t>As imagens do arquivo são exemplo. A stack é decisão do documento de decisões arquiteturais.</a:t>
             </a:r>
           </a:p>
         </p:txBody>
@@ -20127,7 +20127,7 @@
         </p:nvSpPr>
         <p:spPr>
           <a:xfrm>
-            <a:off x="704850" y="2860548"/>
+            <a:off x="704850" y="2998851"/>
             <a:ext cx="57150" cy="57150"/>
           </a:xfrm>
           <a:prstGeom prst="rect">
@@ -20171,8 +20171,8 @@
         </p:nvSpPr>
         <p:spPr>
           <a:xfrm>
-            <a:off x="971550" y="2751582"/>
-            <a:ext cx="7581900" cy="95250"/>
+            <a:off x="971550" y="2889885"/>
+            <a:ext cx="9677400" cy="95250"/>
           </a:xfrm>
           <a:prstGeom prst="rect">
             <a:avLst/>
@@ -20210,7 +20210,7 @@
         </p:nvSpPr>
         <p:spPr>
           <a:xfrm>
-            <a:off x="704850" y="3976116"/>
+            <a:off x="704850" y="3837813"/>
             <a:ext cx="57150" cy="57150"/>
           </a:xfrm>
           <a:prstGeom prst="rect">
@@ -20254,8 +20254,8 @@
         </p:nvSpPr>
         <p:spPr>
           <a:xfrm>
-            <a:off x="971550" y="3867150"/>
-            <a:ext cx="7581900" cy="95250"/>
+            <a:off x="971550" y="3728847"/>
+            <a:ext cx="9677400" cy="95250"/>
           </a:xfrm>
           <a:prstGeom prst="rect">
             <a:avLst/>
@@ -20293,7 +20293,7 @@
         </p:nvSpPr>
         <p:spPr>
           <a:xfrm>
-            <a:off x="704850" y="4538472"/>
+            <a:off x="704850" y="4400169"/>
             <a:ext cx="57150" cy="57150"/>
           </a:xfrm>
           <a:prstGeom prst="rect">
@@ -20337,8 +20337,8 @@
         </p:nvSpPr>
         <p:spPr>
           <a:xfrm>
-            <a:off x="971550" y="4429506"/>
-            <a:ext cx="7581900" cy="95250"/>
+            <a:off x="971550" y="4291203"/>
+            <a:ext cx="9677400" cy="95250"/>
           </a:xfrm>
           <a:prstGeom prst="rect">
             <a:avLst/>
@@ -20370,58 +20370,14 @@
       </p:sp>
       <p:sp>
         <p:nvSpPr>
-          <p:cNvPr id="10" name="Donut 9"/>
-          <p:cNvSpPr/>
-          <p:nvPr/>
-        </p:nvSpPr>
-        <p:spPr>
-          <a:xfrm>
-            <a:off x="9124950" y="2751582"/>
-            <a:ext cx="142875" cy="142875"/>
-          </a:xfrm>
-          <a:prstGeom prst="donut">
-            <a:avLst/>
-          </a:prstGeom>
-          <a:solidFill>
-            <a:srgbClr val="E94D1C"/>
-          </a:solidFill>
-          <a:ln>
-            <a:noFill/>
-          </a:ln>
-          <a:effectLst/>
-        </p:spPr>
-        <p:style>
-          <a:lnRef idx="1">
-            <a:schemeClr val="accent1"/>
-          </a:lnRef>
-          <a:fillRef idx="3">
-            <a:schemeClr val="accent1"/>
-          </a:fillRef>
-          <a:effectRef idx="2">
-            <a:schemeClr val="accent1"/>
-          </a:effectRef>
-          <a:fontRef idx="minor">
-            <a:schemeClr val="lt1"/>
-          </a:fontRef>
-        </p:style>
-        <p:txBody>
-          <a:bodyPr rtlCol="0" anchor="ctr"/>
-          <a:lstStyle/>
-          <a:p>
-            <a:pPr algn="ctr"/>
-          </a:p>
-        </p:txBody>
-      </p:sp>
-      <p:sp>
-        <p:nvSpPr>
-          <p:cNvPr id="11" name="TextBox 10"/>
+          <p:cNvPr id="10" name="TextBox 9"/>
           <p:cNvSpPr txBox="1"/>
           <p:nvPr/>
         </p:nvSpPr>
         <p:spPr>
           <a:xfrm>
-            <a:off x="9372600" y="2761107"/>
-            <a:ext cx="2133600" cy="182880"/>
+            <a:off x="685800" y="6324600"/>
+            <a:ext cx="6667500" cy="182880"/>
           </a:xfrm>
           <a:prstGeom prst="rect">
             <a:avLst/>
@@ -20440,175 +20396,12 @@
               </a:lnSpc>
             </a:pPr>
             <a:r>
-              <a:rPr sz="900" b="1" i="0" spc="120">
-                <a:solidFill>
-                  <a:srgbClr val="E94D1C"/>
+              <a:rPr sz="900" b="0" i="0">
+                <a:solidFill>
+                  <a:srgbClr val="6B6B78"/>
                 </a:solidFill>
                 <a:latin typeface="Roboto"/>
               </a:rPr>
-              <a:t>EM ABERTO</a:t>
-            </a:r>
-          </a:p>
-        </p:txBody>
-      </p:sp>
-      <p:sp>
-        <p:nvSpPr>
-          <p:cNvPr id="12" name="Rectangle 11"/>
-          <p:cNvSpPr/>
-          <p:nvPr/>
-        </p:nvSpPr>
-        <p:spPr>
-          <a:xfrm>
-            <a:off x="9124950" y="3037332"/>
-            <a:ext cx="38100" cy="1234440"/>
-          </a:xfrm>
-          <a:prstGeom prst="rect">
-            <a:avLst/>
-          </a:prstGeom>
-          <a:solidFill>
-            <a:srgbClr val="E94D1C"/>
-          </a:solidFill>
-          <a:ln>
-            <a:noFill/>
-          </a:ln>
-          <a:effectLst/>
-        </p:spPr>
-        <p:style>
-          <a:lnRef idx="1">
-            <a:schemeClr val="accent1"/>
-          </a:lnRef>
-          <a:fillRef idx="3">
-            <a:schemeClr val="accent1"/>
-          </a:fillRef>
-          <a:effectRef idx="2">
-            <a:schemeClr val="accent1"/>
-          </a:effectRef>
-          <a:fontRef idx="minor">
-            <a:schemeClr val="lt1"/>
-          </a:fontRef>
-        </p:style>
-        <p:txBody>
-          <a:bodyPr rtlCol="0" anchor="ctr" wrap="square" lIns="0" rIns="0" tIns="0" bIns="0"/>
-          <a:lstStyle/>
-          <a:p>
-            <a:pPr algn="ctr"/>
-          </a:p>
-        </p:txBody>
-      </p:sp>
-      <p:sp>
-        <p:nvSpPr>
-          <p:cNvPr id="13" name="TextBox 12"/>
-          <p:cNvSpPr txBox="1"/>
-          <p:nvPr/>
-        </p:nvSpPr>
-        <p:spPr>
-          <a:xfrm>
-            <a:off x="9334500" y="3037332"/>
-            <a:ext cx="2171700" cy="1805940"/>
-          </a:xfrm>
-          <a:prstGeom prst="rect">
-            <a:avLst/>
-          </a:prstGeom>
-          <a:noFill/>
-        </p:spPr>
-        <p:txBody>
-          <a:bodyPr wrap="square" lIns="0" rIns="0" tIns="0" bIns="0" anchor="t">
-            <a:spAutoFit/>
-          </a:bodyPr>
-          <a:lstStyle/>
-          <a:p>
-            <a:pPr algn="l">
-              <a:lnSpc>
-                <a:spcPct val="140000"/>
-              </a:lnSpc>
-              <a:spcAft>
-                <a:spcPts val="600"/>
-              </a:spcAft>
-            </a:pPr>
-            <a:r>
-              <a:rPr sz="1200" b="0" i="0">
-                <a:solidFill>
-                  <a:srgbClr val="3A3A44"/>
-                </a:solidFill>
-                <a:latin typeface="Roboto"/>
-              </a:rPr>
-              <a:t>Mesma imagem de front-end ou imagens separadas?</a:t>
-            </a:r>
-          </a:p>
-          <a:p>
-            <a:pPr>
-              <a:lnSpc>
-                <a:spcPct val="140000"/>
-              </a:lnSpc>
-              <a:spcAft>
-                <a:spcPts val="600"/>
-              </a:spcAft>
-            </a:pPr>
-            <a:r>
-              <a:rPr sz="1200" b="0" i="0">
-                <a:solidFill>
-                  <a:srgbClr val="3A3A44"/>
-                </a:solidFill>
-                <a:latin typeface="Roboto"/>
-              </a:rPr>
-              <a:t/>
-            </a:r>
-          </a:p>
-          <a:p>
-            <a:pPr>
-              <a:lnSpc>
-                <a:spcPct val="140000"/>
-              </a:lnSpc>
-              <a:spcAft>
-                <a:spcPts val="600"/>
-              </a:spcAft>
-            </a:pPr>
-            <a:r>
-              <a:rPr sz="1200" b="0" i="0">
-                <a:solidFill>
-                  <a:srgbClr val="3A3A44"/>
-                </a:solidFill>
-                <a:latin typeface="Roboto"/>
-              </a:rPr>
-              <a:t>Entrada direta para os dois diagramas de arquitetura. Ainda não decidida.</a:t>
-            </a:r>
-          </a:p>
-        </p:txBody>
-      </p:sp>
-      <p:sp>
-        <p:nvSpPr>
-          <p:cNvPr id="14" name="TextBox 13"/>
-          <p:cNvSpPr txBox="1"/>
-          <p:nvPr/>
-        </p:nvSpPr>
-        <p:spPr>
-          <a:xfrm>
-            <a:off x="685800" y="6324600"/>
-            <a:ext cx="6667500" cy="182880"/>
-          </a:xfrm>
-          <a:prstGeom prst="rect">
-            <a:avLst/>
-          </a:prstGeom>
-          <a:noFill/>
-        </p:spPr>
-        <p:txBody>
-          <a:bodyPr wrap="square" lIns="0" rIns="0" tIns="0" bIns="0" anchor="t">
-            <a:spAutoFit/>
-          </a:bodyPr>
-          <a:lstStyle/>
-          <a:p>
-            <a:pPr algn="l">
-              <a:lnSpc>
-                <a:spcPct val="120000"/>
-              </a:lnSpc>
-            </a:pPr>
-            <a:r>
-              <a:rPr sz="900" b="0" i="0">
-                <a:solidFill>
-                  <a:srgbClr val="6B6B78"/>
-                </a:solidFill>
-                <a:latin typeface="Roboto"/>
-              </a:rPr>
               <a:t>02 · Aplicação no projeto</a:t>
             </a:r>
           </a:p>
@@ -20616,7 +20409,7 @@
       </p:sp>
       <p:sp>
         <p:nvSpPr>
-          <p:cNvPr id="15" name="TextBox 14"/>
+          <p:cNvPr id="11" name="TextBox 10"/>
           <p:cNvSpPr txBox="1"/>
           <p:nvPr/>
         </p:nvSpPr>
@@ -21069,23 +20862,67 @@
                 </a:solidFill>
                 <a:latin typeface="Roboto"/>
               </a:rPr>
-              <a:t>O projeto ainda não decidiu como os componentes serão distribuídos e implantados no ambiente de execução.</a:t>
-            </a:r>
-          </a:p>
-        </p:txBody>
-      </p:sp>
-      <p:sp>
-        <p:nvSpPr>
-          <p:cNvPr id="12" name="Donut 11"/>
+              <a:t>A pergunta desta apresentação é como esses componentes serão distribuídos e implantados no ambiente de execução.</a:t>
+            </a:r>
+          </a:p>
+        </p:txBody>
+      </p:sp>
+      <p:sp>
+        <p:nvSpPr>
+          <p:cNvPr id="12" name="Isosceles Triangle 11"/>
           <p:cNvSpPr/>
           <p:nvPr/>
         </p:nvSpPr>
         <p:spPr>
           <a:xfrm>
             <a:off x="9124950" y="2332101"/>
-            <a:ext cx="142875" cy="142875"/>
-          </a:xfrm>
-          <a:prstGeom prst="donut">
+            <a:ext cx="152400" cy="133350"/>
+          </a:xfrm>
+          <a:prstGeom prst="triangle">
+            <a:avLst/>
+          </a:prstGeom>
+          <a:noFill/>
+          <a:ln w="19050">
+            <a:solidFill>
+              <a:srgbClr val="E94D1C"/>
+            </a:solidFill>
+          </a:ln>
+          <a:effectLst/>
+        </p:spPr>
+        <p:style>
+          <a:lnRef idx="1">
+            <a:schemeClr val="accent1"/>
+          </a:lnRef>
+          <a:fillRef idx="3">
+            <a:schemeClr val="accent1"/>
+          </a:fillRef>
+          <a:effectRef idx="2">
+            <a:schemeClr val="accent1"/>
+          </a:effectRef>
+          <a:fontRef idx="minor">
+            <a:schemeClr val="lt1"/>
+          </a:fontRef>
+        </p:style>
+        <p:txBody>
+          <a:bodyPr rtlCol="0" anchor="ctr"/>
+          <a:lstStyle/>
+          <a:p>
+            <a:pPr algn="ctr"/>
+          </a:p>
+        </p:txBody>
+      </p:sp>
+      <p:sp>
+        <p:nvSpPr>
+          <p:cNvPr id="13" name="Rectangle 12"/>
+          <p:cNvSpPr/>
+          <p:nvPr/>
+        </p:nvSpPr>
+        <p:spPr>
+          <a:xfrm>
+            <a:off x="9193530" y="2389251"/>
+            <a:ext cx="15240" cy="38100"/>
+          </a:xfrm>
+          <a:prstGeom prst="rect">
             <a:avLst/>
           </a:prstGeom>
           <a:solidFill>
@@ -21120,7 +20957,7 @@
       </p:sp>
       <p:sp>
         <p:nvSpPr>
-          <p:cNvPr id="13" name="TextBox 12"/>
+          <p:cNvPr id="14" name="TextBox 13"/>
           <p:cNvSpPr txBox="1"/>
           <p:nvPr/>
         </p:nvSpPr>
@@ -21152,14 +20989,14 @@
                 </a:solidFill>
                 <a:latin typeface="Roboto"/>
               </a:rPr>
-              <a:t>ONDE ESTAMOS HOJE</a:t>
-            </a:r>
-          </a:p>
-        </p:txBody>
-      </p:sp>
-      <p:sp>
-        <p:nvSpPr>
-          <p:cNvPr id="14" name="Rectangle 13"/>
+              <a:t>PONTO DE PARTIDA</a:t>
+            </a:r>
+          </a:p>
+        </p:txBody>
+      </p:sp>
+      <p:sp>
+        <p:nvSpPr>
+          <p:cNvPr id="15" name="Rectangle 14"/>
           <p:cNvSpPr/>
           <p:nvPr/>
         </p:nvSpPr>
@@ -21203,7 +21040,7 @@
       </p:sp>
       <p:sp>
         <p:nvSpPr>
-          <p:cNvPr id="15" name="TextBox 14"/>
+          <p:cNvPr id="16" name="TextBox 15"/>
           <p:cNvSpPr txBox="1"/>
           <p:nvPr/>
         </p:nvSpPr>
@@ -21238,7 +21075,7 @@
                 </a:solidFill>
                 <a:latin typeface="Roboto"/>
               </a:rPr>
-              <a:t>As três camadas do back-end já estão decididas.</a:t>
+              <a:t>Três camadas lógicas no back-end.</a:t>
             </a:r>
           </a:p>
           <a:p>
@@ -21276,14 +21113,14 @@
                 </a:solidFill>
                 <a:latin typeface="Roboto"/>
               </a:rPr>
-              <a:t>Falta decidir em quantos processos separados elas vão rodar.</a:t>
-            </a:r>
-          </a:p>
-        </p:txBody>
-      </p:sp>
-      <p:sp>
-        <p:nvSpPr>
-          <p:cNvPr id="16" name="TextBox 15"/>
+              <a:t>A decisão em jogo é em quantos processos separados elas rodam.</a:t>
+            </a:r>
+          </a:p>
+        </p:txBody>
+      </p:sp>
+      <p:sp>
+        <p:nvSpPr>
+          <p:cNvPr id="17" name="TextBox 16"/>
           <p:cNvSpPr txBox="1"/>
           <p:nvPr/>
         </p:nvSpPr>
@@ -21322,7 +21159,7 @@
       </p:sp>
       <p:sp>
         <p:nvSpPr>
-          <p:cNvPr id="17" name="TextBox 16"/>
+          <p:cNvPr id="18" name="TextBox 17"/>
           <p:cNvSpPr txBox="1"/>
           <p:nvPr/>
         </p:nvSpPr>
@@ -30094,7 +29931,7 @@
         <p:spPr>
           <a:xfrm>
             <a:off x="971550" y="2751582"/>
-            <a:ext cx="7581900" cy="95250"/>
+            <a:ext cx="9677400" cy="95250"/>
           </a:xfrm>
           <a:prstGeom prst="rect">
             <a:avLst/>
@@ -30177,7 +30014,7 @@
         <p:spPr>
           <a:xfrm>
             <a:off x="971550" y="3590544"/>
-            <a:ext cx="7581900" cy="95250"/>
+            <a:ext cx="9677400" cy="95250"/>
           </a:xfrm>
           <a:prstGeom prst="rect">
             <a:avLst/>
@@ -30260,7 +30097,7 @@
         <p:spPr>
           <a:xfrm>
             <a:off x="971550" y="4429506"/>
-            <a:ext cx="7581900" cy="95250"/>
+            <a:ext cx="9677400" cy="95250"/>
           </a:xfrm>
           <a:prstGeom prst="rect">
             <a:avLst/>
@@ -30292,102 +30129,14 @@
       </p:sp>
       <p:sp>
         <p:nvSpPr>
-          <p:cNvPr id="10" name="Isosceles Triangle 9"/>
-          <p:cNvSpPr/>
-          <p:nvPr/>
-        </p:nvSpPr>
-        <p:spPr>
-          <a:xfrm>
-            <a:off x="9124950" y="2751582"/>
-            <a:ext cx="152400" cy="133350"/>
-          </a:xfrm>
-          <a:prstGeom prst="triangle">
-            <a:avLst/>
-          </a:prstGeom>
-          <a:noFill/>
-          <a:ln w="19050">
-            <a:solidFill>
-              <a:srgbClr val="E94D1C"/>
-            </a:solidFill>
-          </a:ln>
-          <a:effectLst/>
-        </p:spPr>
-        <p:style>
-          <a:lnRef idx="1">
-            <a:schemeClr val="accent1"/>
-          </a:lnRef>
-          <a:fillRef idx="3">
-            <a:schemeClr val="accent1"/>
-          </a:fillRef>
-          <a:effectRef idx="2">
-            <a:schemeClr val="accent1"/>
-          </a:effectRef>
-          <a:fontRef idx="minor">
-            <a:schemeClr val="lt1"/>
-          </a:fontRef>
-        </p:style>
-        <p:txBody>
-          <a:bodyPr rtlCol="0" anchor="ctr"/>
-          <a:lstStyle/>
-          <a:p>
-            <a:pPr algn="ctr"/>
-          </a:p>
-        </p:txBody>
-      </p:sp>
-      <p:sp>
-        <p:nvSpPr>
-          <p:cNvPr id="11" name="Rectangle 10"/>
-          <p:cNvSpPr/>
-          <p:nvPr/>
-        </p:nvSpPr>
-        <p:spPr>
-          <a:xfrm>
-            <a:off x="9193530" y="2808732"/>
-            <a:ext cx="15240" cy="38100"/>
-          </a:xfrm>
-          <a:prstGeom prst="rect">
-            <a:avLst/>
-          </a:prstGeom>
-          <a:solidFill>
-            <a:srgbClr val="E94D1C"/>
-          </a:solidFill>
-          <a:ln>
-            <a:noFill/>
-          </a:ln>
-          <a:effectLst/>
-        </p:spPr>
-        <p:style>
-          <a:lnRef idx="1">
-            <a:schemeClr val="accent1"/>
-          </a:lnRef>
-          <a:fillRef idx="3">
-            <a:schemeClr val="accent1"/>
-          </a:fillRef>
-          <a:effectRef idx="2">
-            <a:schemeClr val="accent1"/>
-          </a:effectRef>
-          <a:fontRef idx="minor">
-            <a:schemeClr val="lt1"/>
-          </a:fontRef>
-        </p:style>
-        <p:txBody>
-          <a:bodyPr rtlCol="0" anchor="ctr"/>
-          <a:lstStyle/>
-          <a:p>
-            <a:pPr algn="ctr"/>
-          </a:p>
-        </p:txBody>
-      </p:sp>
-      <p:sp>
-        <p:nvSpPr>
-          <p:cNvPr id="12" name="TextBox 11"/>
+          <p:cNvPr id="10" name="TextBox 9"/>
           <p:cNvSpPr txBox="1"/>
           <p:nvPr/>
         </p:nvSpPr>
         <p:spPr>
           <a:xfrm>
-            <a:off x="9372600" y="2761107"/>
-            <a:ext cx="2133600" cy="182880"/>
+            <a:off x="685800" y="6324600"/>
+            <a:ext cx="6667500" cy="182880"/>
           </a:xfrm>
           <a:prstGeom prst="rect">
             <a:avLst/>
@@ -30406,137 +30155,12 @@
               </a:lnSpc>
             </a:pPr>
             <a:r>
-              <a:rPr sz="900" b="1" i="0" spc="120">
-                <a:solidFill>
-                  <a:srgbClr val="E94D1C"/>
+              <a:rPr sz="900" b="0" i="0">
+                <a:solidFill>
+                  <a:srgbClr val="6B6B78"/>
                 </a:solidFill>
                 <a:latin typeface="Roboto"/>
               </a:rPr>
-              <a:t>AINDA É PROPOSTA</a:t>
-            </a:r>
-          </a:p>
-        </p:txBody>
-      </p:sp>
-      <p:sp>
-        <p:nvSpPr>
-          <p:cNvPr id="13" name="Rectangle 12"/>
-          <p:cNvSpPr/>
-          <p:nvPr/>
-        </p:nvSpPr>
-        <p:spPr>
-          <a:xfrm>
-            <a:off x="9124950" y="3037332"/>
-            <a:ext cx="38100" cy="804672"/>
-          </a:xfrm>
-          <a:prstGeom prst="rect">
-            <a:avLst/>
-          </a:prstGeom>
-          <a:solidFill>
-            <a:srgbClr val="E94D1C"/>
-          </a:solidFill>
-          <a:ln>
-            <a:noFill/>
-          </a:ln>
-          <a:effectLst/>
-        </p:spPr>
-        <p:style>
-          <a:lnRef idx="1">
-            <a:schemeClr val="accent1"/>
-          </a:lnRef>
-          <a:fillRef idx="3">
-            <a:schemeClr val="accent1"/>
-          </a:fillRef>
-          <a:effectRef idx="2">
-            <a:schemeClr val="accent1"/>
-          </a:effectRef>
-          <a:fontRef idx="minor">
-            <a:schemeClr val="lt1"/>
-          </a:fontRef>
-        </p:style>
-        <p:txBody>
-          <a:bodyPr rtlCol="0" anchor="ctr" wrap="square" lIns="0" rIns="0" tIns="0" bIns="0"/>
-          <a:lstStyle/>
-          <a:p>
-            <a:pPr algn="ctr"/>
-          </a:p>
-        </p:txBody>
-      </p:sp>
-      <p:sp>
-        <p:nvSpPr>
-          <p:cNvPr id="14" name="TextBox 13"/>
-          <p:cNvSpPr txBox="1"/>
-          <p:nvPr/>
-        </p:nvSpPr>
-        <p:spPr>
-          <a:xfrm>
-            <a:off x="9334500" y="3037332"/>
-            <a:ext cx="2171700" cy="1376172"/>
-          </a:xfrm>
-          <a:prstGeom prst="rect">
-            <a:avLst/>
-          </a:prstGeom>
-          <a:noFill/>
-        </p:spPr>
-        <p:txBody>
-          <a:bodyPr wrap="square" lIns="0" rIns="0" tIns="0" bIns="0" anchor="t">
-            <a:spAutoFit/>
-          </a:bodyPr>
-          <a:lstStyle/>
-          <a:p>
-            <a:pPr algn="l">
-              <a:lnSpc>
-                <a:spcPct val="140000"/>
-              </a:lnSpc>
-              <a:spcAft>
-                <a:spcPts val="600"/>
-              </a:spcAft>
-            </a:pPr>
-            <a:r>
-              <a:rPr sz="1200" b="0" i="0">
-                <a:solidFill>
-                  <a:srgbClr val="3A3A44"/>
-                </a:solidFill>
-                <a:latin typeface="Roboto"/>
-              </a:rPr>
-              <a:t>Nada disso está feito. É o que o grupo quer testar, e o resto da apresentação é o exame dessa ideia.</a:t>
-            </a:r>
-          </a:p>
-        </p:txBody>
-      </p:sp>
-      <p:sp>
-        <p:nvSpPr>
-          <p:cNvPr id="15" name="TextBox 14"/>
-          <p:cNvSpPr txBox="1"/>
-          <p:nvPr/>
-        </p:nvSpPr>
-        <p:spPr>
-          <a:xfrm>
-            <a:off x="685800" y="6324600"/>
-            <a:ext cx="6667500" cy="182880"/>
-          </a:xfrm>
-          <a:prstGeom prst="rect">
-            <a:avLst/>
-          </a:prstGeom>
-          <a:noFill/>
-        </p:spPr>
-        <p:txBody>
-          <a:bodyPr wrap="square" lIns="0" rIns="0" tIns="0" bIns="0" anchor="t">
-            <a:spAutoFit/>
-          </a:bodyPr>
-          <a:lstStyle/>
-          <a:p>
-            <a:pPr algn="l">
-              <a:lnSpc>
-                <a:spcPct val="120000"/>
-              </a:lnSpc>
-            </a:pPr>
-            <a:r>
-              <a:rPr sz="900" b="0" i="0">
-                <a:solidFill>
-                  <a:srgbClr val="6B6B78"/>
-                </a:solidFill>
-                <a:latin typeface="Roboto"/>
-              </a:rPr>
               <a:t>Introdução</a:t>
             </a:r>
           </a:p>
@@ -30544,7 +30168,7 @@
       </p:sp>
       <p:sp>
         <p:nvSpPr>
-          <p:cNvPr id="16" name="TextBox 15"/>
+          <p:cNvPr id="11" name="TextBox 10"/>
           <p:cNvSpPr txBox="1"/>
           <p:nvPr/>
         </p:nvSpPr>

</xml_diff>

<commit_message>
docs: usa o fundo institucional esmaecido nos slides azuis do T1 em vez do azul chapado
</commit_message>
<xml_diff>
--- a/trabalhos/T1-Docker-Invite-People.pptx
+++ b/trabalhos/T1-Docker-Invite-People.pptx
@@ -11538,14 +11538,6 @@
 <file path=ppt/slides/slide1.xml><?xml version="1.0" encoding="utf-8"?>
 <p:sld xmlns:a="http://schemas.openxmlformats.org/drawingml/2006/main" xmlns:p="http://schemas.openxmlformats.org/presentationml/2006/main" xmlns:r="http://schemas.openxmlformats.org/officeDocument/2006/relationships">
   <p:cSld>
-    <p:bg>
-      <p:bgPr>
-        <a:solidFill>
-          <a:srgbClr val="21049A"/>
-        </a:solidFill>
-        <a:effectLst/>
-      </p:bgPr>
-    </p:bg>
     <p:spTree>
       <p:nvGrpSpPr>
         <p:cNvPr id="1" name=""/>
@@ -11555,7 +11547,7 @@
       <p:grpSpPr/>
       <p:pic>
         <p:nvPicPr>
-          <p:cNvPr id="2" name="Picture 1" descr="lockup-branco.png"/>
+          <p:cNvPr id="2" name="Picture 1" descr="fundo-capa.jpg"/>
           <p:cNvPicPr>
             <a:picLocks noChangeAspect="1"/>
           </p:cNvPicPr>
@@ -11569,6 +11561,30 @@
         </p:blipFill>
         <p:spPr>
           <a:xfrm>
+            <a:off x="0" y="0"/>
+            <a:ext cx="12192000" cy="6858000"/>
+          </a:xfrm>
+          <a:prstGeom prst="rect">
+            <a:avLst/>
+          </a:prstGeom>
+        </p:spPr>
+      </p:pic>
+      <p:pic>
+        <p:nvPicPr>
+          <p:cNvPr id="3" name="Picture 2" descr="lockup-branco.png"/>
+          <p:cNvPicPr>
+            <a:picLocks noChangeAspect="1"/>
+          </p:cNvPicPr>
+          <p:nvPr/>
+        </p:nvPicPr>
+        <p:blipFill>
+          <a:blip r:embed="rId3"/>
+          <a:stretch>
+            <a:fillRect/>
+          </a:stretch>
+        </p:blipFill>
+        <p:spPr>
+          <a:xfrm>
             <a:off x="685800" y="552450"/>
             <a:ext cx="2038350" cy="701063"/>
           </a:xfrm>
@@ -11579,7 +11595,7 @@
       </p:pic>
       <p:sp>
         <p:nvSpPr>
-          <p:cNvPr id="3" name="TextBox 2"/>
+          <p:cNvPr id="4" name="TextBox 3"/>
           <p:cNvSpPr txBox="1"/>
           <p:nvPr/>
         </p:nvSpPr>
@@ -11618,7 +11634,7 @@
       </p:sp>
       <p:sp>
         <p:nvSpPr>
-          <p:cNvPr id="4" name="TextBox 3"/>
+          <p:cNvPr id="5" name="TextBox 4"/>
           <p:cNvSpPr txBox="1"/>
           <p:nvPr/>
         </p:nvSpPr>
@@ -11673,7 +11689,7 @@
       </p:sp>
       <p:sp>
         <p:nvSpPr>
-          <p:cNvPr id="5" name="Rounded Rectangle 4"/>
+          <p:cNvPr id="6" name="Rounded Rectangle 5"/>
           <p:cNvSpPr/>
           <p:nvPr/>
         </p:nvSpPr>
@@ -11719,7 +11735,7 @@
       </p:sp>
       <p:sp>
         <p:nvSpPr>
-          <p:cNvPr id="6" name="TextBox 5"/>
+          <p:cNvPr id="7" name="TextBox 6"/>
           <p:cNvSpPr txBox="1"/>
           <p:nvPr/>
         </p:nvSpPr>
@@ -11758,14 +11774,14 @@
       </p:sp>
       <p:pic>
         <p:nvPicPr>
-          <p:cNvPr id="7" name="Picture 6" descr="docker.png"/>
+          <p:cNvPr id="8" name="Picture 7" descr="docker.png"/>
           <p:cNvPicPr>
             <a:picLocks noChangeAspect="1"/>
           </p:cNvPicPr>
           <p:nvPr/>
         </p:nvPicPr>
         <p:blipFill>
-          <a:blip r:embed="rId3"/>
+          <a:blip r:embed="rId4"/>
           <a:stretch>
             <a:fillRect/>
           </a:stretch>
@@ -11782,7 +11798,7 @@
       </p:pic>
       <p:sp>
         <p:nvSpPr>
-          <p:cNvPr id="8" name="TextBox 7"/>
+          <p:cNvPr id="9" name="TextBox 8"/>
           <p:cNvSpPr txBox="1"/>
           <p:nvPr/>
         </p:nvSpPr>
@@ -11821,7 +11837,7 @@
       </p:sp>
       <p:sp>
         <p:nvSpPr>
-          <p:cNvPr id="9" name="TextBox 8"/>
+          <p:cNvPr id="10" name="TextBox 9"/>
           <p:cNvSpPr txBox="1"/>
           <p:nvPr/>
         </p:nvSpPr>
@@ -11876,7 +11892,7 @@
       </p:sp>
       <p:sp>
         <p:nvSpPr>
-          <p:cNvPr id="10" name="TextBox 9"/>
+          <p:cNvPr id="11" name="TextBox 10"/>
           <p:cNvSpPr txBox="1"/>
           <p:nvPr/>
         </p:nvSpPr>
@@ -11915,7 +11931,7 @@
       </p:sp>
       <p:sp>
         <p:nvSpPr>
-          <p:cNvPr id="11" name="TextBox 10"/>
+          <p:cNvPr id="12" name="TextBox 11"/>
           <p:cNvSpPr txBox="1"/>
           <p:nvPr/>
         </p:nvSpPr>
@@ -13527,14 +13543,6 @@
 <file path=ppt/slides/slide12.xml><?xml version="1.0" encoding="utf-8"?>
 <p:sld xmlns:a="http://schemas.openxmlformats.org/drawingml/2006/main" xmlns:p="http://schemas.openxmlformats.org/presentationml/2006/main" xmlns:r="http://schemas.openxmlformats.org/officeDocument/2006/relationships">
   <p:cSld>
-    <p:bg>
-      <p:bgPr>
-        <a:solidFill>
-          <a:srgbClr val="21049A"/>
-        </a:solidFill>
-        <a:effectLst/>
-      </p:bgPr>
-    </p:bg>
     <p:spTree>
       <p:nvGrpSpPr>
         <p:cNvPr id="1" name=""/>
@@ -13544,7 +13552,7 @@
       <p:grpSpPr/>
       <p:pic>
         <p:nvPicPr>
-          <p:cNvPr id="2" name="Picture 1" descr="u-branco.png"/>
+          <p:cNvPr id="2" name="Picture 1" descr="fundo-secao.jpg"/>
           <p:cNvPicPr>
             <a:picLocks noChangeAspect="1"/>
           </p:cNvPicPr>
@@ -13558,8 +13566,8 @@
         </p:blipFill>
         <p:spPr>
           <a:xfrm>
-            <a:off x="10744200" y="457200"/>
-            <a:ext cx="342900" cy="342900"/>
+            <a:off x="0" y="0"/>
+            <a:ext cx="12192000" cy="6858000"/>
           </a:xfrm>
           <a:prstGeom prst="rect">
             <a:avLst/>
@@ -13568,7 +13576,7 @@
       </p:pic>
       <p:pic>
         <p:nvPicPr>
-          <p:cNvPr id="3" name="Picture 2" descr="oci-branco.png"/>
+          <p:cNvPr id="3" name="Picture 2" descr="u-branco.png"/>
           <p:cNvPicPr>
             <a:picLocks noChangeAspect="1"/>
           </p:cNvPicPr>
@@ -13582,6 +13590,30 @@
         </p:blipFill>
         <p:spPr>
           <a:xfrm>
+            <a:off x="10744200" y="457200"/>
+            <a:ext cx="342900" cy="342900"/>
+          </a:xfrm>
+          <a:prstGeom prst="rect">
+            <a:avLst/>
+          </a:prstGeom>
+        </p:spPr>
+      </p:pic>
+      <p:pic>
+        <p:nvPicPr>
+          <p:cNvPr id="4" name="Picture 3" descr="oci-branco.png"/>
+          <p:cNvPicPr>
+            <a:picLocks noChangeAspect="1"/>
+          </p:cNvPicPr>
+          <p:nvPr/>
+        </p:nvPicPr>
+        <p:blipFill>
+          <a:blip r:embed="rId4"/>
+          <a:stretch>
+            <a:fillRect/>
+          </a:stretch>
+        </p:blipFill>
+        <p:spPr>
+          <a:xfrm>
             <a:off x="7810500" y="1962150"/>
             <a:ext cx="3048000" cy="839090"/>
           </a:xfrm>
@@ -13592,7 +13624,7 @@
       </p:pic>
       <p:sp>
         <p:nvSpPr>
-          <p:cNvPr id="4" name="TextBox 3"/>
+          <p:cNvPr id="5" name="TextBox 4"/>
           <p:cNvSpPr txBox="1"/>
           <p:nvPr/>
         </p:nvSpPr>
@@ -13647,7 +13679,7 @@
       </p:sp>
       <p:sp>
         <p:nvSpPr>
-          <p:cNvPr id="5" name="TextBox 4"/>
+          <p:cNvPr id="6" name="TextBox 5"/>
           <p:cNvSpPr txBox="1"/>
           <p:nvPr/>
         </p:nvSpPr>
@@ -13686,7 +13718,7 @@
       </p:sp>
       <p:sp>
         <p:nvSpPr>
-          <p:cNvPr id="6" name="TextBox 5"/>
+          <p:cNvPr id="7" name="TextBox 6"/>
           <p:cNvSpPr txBox="1"/>
           <p:nvPr/>
         </p:nvSpPr>
@@ -13725,7 +13757,7 @@
       </p:sp>
       <p:sp>
         <p:nvSpPr>
-          <p:cNvPr id="7" name="TextBox 6"/>
+          <p:cNvPr id="8" name="TextBox 7"/>
           <p:cNvSpPr txBox="1"/>
           <p:nvPr/>
         </p:nvSpPr>
@@ -13773,14 +13805,6 @@
 <file path=ppt/slides/slide13.xml><?xml version="1.0" encoding="utf-8"?>
 <p:sld xmlns:a="http://schemas.openxmlformats.org/drawingml/2006/main" xmlns:p="http://schemas.openxmlformats.org/presentationml/2006/main" xmlns:r="http://schemas.openxmlformats.org/officeDocument/2006/relationships">
   <p:cSld>
-    <p:bg>
-      <p:bgPr>
-        <a:solidFill>
-          <a:srgbClr val="21049A"/>
-        </a:solidFill>
-        <a:effectLst/>
-      </p:bgPr>
-    </p:bg>
     <p:spTree>
       <p:nvGrpSpPr>
         <p:cNvPr id="1" name=""/>
@@ -13788,9 +13812,33 @@
         <p:nvPr/>
       </p:nvGrpSpPr>
       <p:grpSpPr/>
-      <p:sp>
-        <p:nvSpPr>
-          <p:cNvPr id="2" name="Rectangle 1"/>
+      <p:pic>
+        <p:nvPicPr>
+          <p:cNvPr id="2" name="Picture 1" descr="fundo-secao.jpg"/>
+          <p:cNvPicPr>
+            <a:picLocks noChangeAspect="1"/>
+          </p:cNvPicPr>
+          <p:nvPr/>
+        </p:nvPicPr>
+        <p:blipFill>
+          <a:blip r:embed="rId2"/>
+          <a:stretch>
+            <a:fillRect/>
+          </a:stretch>
+        </p:blipFill>
+        <p:spPr>
+          <a:xfrm>
+            <a:off x="0" y="0"/>
+            <a:ext cx="12192000" cy="6858000"/>
+          </a:xfrm>
+          <a:prstGeom prst="rect">
+            <a:avLst/>
+          </a:prstGeom>
+        </p:spPr>
+      </p:pic>
+      <p:sp>
+        <p:nvSpPr>
+          <p:cNvPr id="3" name="Rectangle 2"/>
           <p:cNvSpPr/>
           <p:nvPr/>
         </p:nvSpPr>
@@ -13834,14 +13882,14 @@
       </p:sp>
       <p:pic>
         <p:nvPicPr>
-          <p:cNvPr id="3" name="Picture 2" descr="u-branco.png"/>
+          <p:cNvPr id="4" name="Picture 3" descr="u-branco.png"/>
           <p:cNvPicPr>
             <a:picLocks noChangeAspect="1"/>
           </p:cNvPicPr>
           <p:nvPr/>
         </p:nvPicPr>
         <p:blipFill>
-          <a:blip r:embed="rId2"/>
+          <a:blip r:embed="rId3"/>
           <a:stretch>
             <a:fillRect/>
           </a:stretch>
@@ -13858,7 +13906,7 @@
       </p:pic>
       <p:sp>
         <p:nvSpPr>
-          <p:cNvPr id="4" name="Rounded Rectangle 3"/>
+          <p:cNvPr id="5" name="Rounded Rectangle 4"/>
           <p:cNvSpPr/>
           <p:nvPr/>
         </p:nvSpPr>
@@ -13902,7 +13950,7 @@
       </p:sp>
       <p:sp>
         <p:nvSpPr>
-          <p:cNvPr id="5" name="Right Arrow 4"/>
+          <p:cNvPr id="6" name="Right Arrow 5"/>
           <p:cNvSpPr/>
           <p:nvPr/>
         </p:nvSpPr>
@@ -13946,7 +13994,7 @@
       </p:sp>
       <p:sp>
         <p:nvSpPr>
-          <p:cNvPr id="6" name="Rounded Rectangle 5"/>
+          <p:cNvPr id="7" name="Rounded Rectangle 6"/>
           <p:cNvSpPr/>
           <p:nvPr/>
         </p:nvSpPr>
@@ -13990,7 +14038,7 @@
       </p:sp>
       <p:sp>
         <p:nvSpPr>
-          <p:cNvPr id="7" name="TextBox 6"/>
+          <p:cNvPr id="8" name="TextBox 7"/>
           <p:cNvSpPr txBox="1"/>
           <p:nvPr/>
         </p:nvSpPr>
@@ -14029,7 +14077,7 @@
       </p:sp>
       <p:sp>
         <p:nvSpPr>
-          <p:cNvPr id="8" name="TextBox 7"/>
+          <p:cNvPr id="9" name="TextBox 8"/>
           <p:cNvSpPr txBox="1"/>
           <p:nvPr/>
         </p:nvSpPr>
@@ -14068,7 +14116,7 @@
       </p:sp>
       <p:sp>
         <p:nvSpPr>
-          <p:cNvPr id="9" name="TextBox 8"/>
+          <p:cNvPr id="10" name="TextBox 9"/>
           <p:cNvSpPr txBox="1"/>
           <p:nvPr/>
         </p:nvSpPr>
@@ -14107,7 +14155,7 @@
       </p:sp>
       <p:sp>
         <p:nvSpPr>
-          <p:cNvPr id="10" name="TextBox 9"/>
+          <p:cNvPr id="11" name="TextBox 10"/>
           <p:cNvSpPr txBox="1"/>
           <p:nvPr/>
         </p:nvSpPr>
@@ -14146,7 +14194,7 @@
       </p:sp>
       <p:sp>
         <p:nvSpPr>
-          <p:cNvPr id="11" name="TextBox 10"/>
+          <p:cNvPr id="12" name="TextBox 11"/>
           <p:cNvSpPr txBox="1"/>
           <p:nvPr/>
         </p:nvSpPr>
@@ -21207,14 +21255,6 @@
 <file path=ppt/slides/slide20.xml><?xml version="1.0" encoding="utf-8"?>
 <p:sld xmlns:a="http://schemas.openxmlformats.org/drawingml/2006/main" xmlns:p="http://schemas.openxmlformats.org/presentationml/2006/main" xmlns:r="http://schemas.openxmlformats.org/officeDocument/2006/relationships">
   <p:cSld>
-    <p:bg>
-      <p:bgPr>
-        <a:solidFill>
-          <a:srgbClr val="21049A"/>
-        </a:solidFill>
-        <a:effectLst/>
-      </p:bgPr>
-    </p:bg>
     <p:spTree>
       <p:nvGrpSpPr>
         <p:cNvPr id="1" name=""/>
@@ -21222,9 +21262,33 @@
         <p:nvPr/>
       </p:nvGrpSpPr>
       <p:grpSpPr/>
-      <p:sp>
-        <p:nvSpPr>
-          <p:cNvPr id="2" name="Rectangle 1"/>
+      <p:pic>
+        <p:nvPicPr>
+          <p:cNvPr id="2" name="Picture 1" descr="fundo-secao.jpg"/>
+          <p:cNvPicPr>
+            <a:picLocks noChangeAspect="1"/>
+          </p:cNvPicPr>
+          <p:nvPr/>
+        </p:nvPicPr>
+        <p:blipFill>
+          <a:blip r:embed="rId2"/>
+          <a:stretch>
+            <a:fillRect/>
+          </a:stretch>
+        </p:blipFill>
+        <p:spPr>
+          <a:xfrm>
+            <a:off x="0" y="0"/>
+            <a:ext cx="12192000" cy="6858000"/>
+          </a:xfrm>
+          <a:prstGeom prst="rect">
+            <a:avLst/>
+          </a:prstGeom>
+        </p:spPr>
+      </p:pic>
+      <p:sp>
+        <p:nvSpPr>
+          <p:cNvPr id="3" name="Rectangle 2"/>
           <p:cNvSpPr/>
           <p:nvPr/>
         </p:nvSpPr>
@@ -21268,14 +21332,14 @@
       </p:sp>
       <p:pic>
         <p:nvPicPr>
-          <p:cNvPr id="3" name="Picture 2" descr="u-branco.png"/>
+          <p:cNvPr id="4" name="Picture 3" descr="u-branco.png"/>
           <p:cNvPicPr>
             <a:picLocks noChangeAspect="1"/>
           </p:cNvPicPr>
           <p:nvPr/>
         </p:nvPicPr>
         <p:blipFill>
-          <a:blip r:embed="rId2"/>
+          <a:blip r:embed="rId3"/>
           <a:stretch>
             <a:fillRect/>
           </a:stretch>
@@ -21292,7 +21356,7 @@
       </p:pic>
       <p:sp>
         <p:nvSpPr>
-          <p:cNvPr id="4" name="Rounded Rectangle 3"/>
+          <p:cNvPr id="5" name="Rounded Rectangle 4"/>
           <p:cNvSpPr/>
           <p:nvPr/>
         </p:nvSpPr>
@@ -21336,7 +21400,7 @@
       </p:sp>
       <p:sp>
         <p:nvSpPr>
-          <p:cNvPr id="5" name="Rounded Rectangle 4"/>
+          <p:cNvPr id="6" name="Rounded Rectangle 5"/>
           <p:cNvSpPr/>
           <p:nvPr/>
         </p:nvSpPr>
@@ -21380,7 +21444,7 @@
       </p:sp>
       <p:sp>
         <p:nvSpPr>
-          <p:cNvPr id="6" name="Rectangle 5"/>
+          <p:cNvPr id="7" name="Rectangle 6"/>
           <p:cNvSpPr/>
           <p:nvPr/>
         </p:nvSpPr>
@@ -21424,7 +21488,7 @@
       </p:sp>
       <p:sp>
         <p:nvSpPr>
-          <p:cNvPr id="7" name="TextBox 6"/>
+          <p:cNvPr id="8" name="TextBox 7"/>
           <p:cNvSpPr txBox="1"/>
           <p:nvPr/>
         </p:nvSpPr>
@@ -21463,7 +21527,7 @@
       </p:sp>
       <p:sp>
         <p:nvSpPr>
-          <p:cNvPr id="8" name="TextBox 7"/>
+          <p:cNvPr id="9" name="TextBox 8"/>
           <p:cNvSpPr txBox="1"/>
           <p:nvPr/>
         </p:nvSpPr>
@@ -21502,7 +21566,7 @@
       </p:sp>
       <p:sp>
         <p:nvSpPr>
-          <p:cNvPr id="9" name="TextBox 8"/>
+          <p:cNvPr id="10" name="TextBox 9"/>
           <p:cNvSpPr txBox="1"/>
           <p:nvPr/>
         </p:nvSpPr>
@@ -21541,7 +21605,7 @@
       </p:sp>
       <p:sp>
         <p:nvSpPr>
-          <p:cNvPr id="10" name="TextBox 9"/>
+          <p:cNvPr id="11" name="TextBox 10"/>
           <p:cNvSpPr txBox="1"/>
           <p:nvPr/>
         </p:nvSpPr>
@@ -21580,7 +21644,7 @@
       </p:sp>
       <p:sp>
         <p:nvSpPr>
-          <p:cNvPr id="11" name="TextBox 10"/>
+          <p:cNvPr id="12" name="TextBox 11"/>
           <p:cNvSpPr txBox="1"/>
           <p:nvPr/>
         </p:nvSpPr>
@@ -22477,14 +22541,6 @@
 <file path=ppt/slides/slide22.xml><?xml version="1.0" encoding="utf-8"?>
 <p:sld xmlns:a="http://schemas.openxmlformats.org/drawingml/2006/main" xmlns:p="http://schemas.openxmlformats.org/presentationml/2006/main" xmlns:r="http://schemas.openxmlformats.org/officeDocument/2006/relationships">
   <p:cSld>
-    <p:bg>
-      <p:bgPr>
-        <a:solidFill>
-          <a:srgbClr val="21049A"/>
-        </a:solidFill>
-        <a:effectLst/>
-      </p:bgPr>
-    </p:bg>
     <p:spTree>
       <p:nvGrpSpPr>
         <p:cNvPr id="1" name=""/>
@@ -22494,7 +22550,7 @@
       <p:grpSpPr/>
       <p:pic>
         <p:nvPicPr>
-          <p:cNvPr id="2" name="Picture 1" descr="u-branco.png"/>
+          <p:cNvPr id="2" name="Picture 1" descr="fundo-secao.jpg"/>
           <p:cNvPicPr>
             <a:picLocks noChangeAspect="1"/>
           </p:cNvPicPr>
@@ -22508,8 +22564,8 @@
         </p:blipFill>
         <p:spPr>
           <a:xfrm>
-            <a:off x="10744200" y="457200"/>
-            <a:ext cx="342900" cy="342900"/>
+            <a:off x="0" y="0"/>
+            <a:ext cx="12192000" cy="6858000"/>
           </a:xfrm>
           <a:prstGeom prst="rect">
             <a:avLst/>
@@ -22518,7 +22574,7 @@
       </p:pic>
       <p:pic>
         <p:nvPicPr>
-          <p:cNvPr id="3" name="Picture 2" descr="kubernetes-branco.png"/>
+          <p:cNvPr id="3" name="Picture 2" descr="u-branco.png"/>
           <p:cNvPicPr>
             <a:picLocks noChangeAspect="1"/>
           </p:cNvPicPr>
@@ -22532,6 +22588,30 @@
         </p:blipFill>
         <p:spPr>
           <a:xfrm>
+            <a:off x="10744200" y="457200"/>
+            <a:ext cx="342900" cy="342900"/>
+          </a:xfrm>
+          <a:prstGeom prst="rect">
+            <a:avLst/>
+          </a:prstGeom>
+        </p:spPr>
+      </p:pic>
+      <p:pic>
+        <p:nvPicPr>
+          <p:cNvPr id="4" name="Picture 3" descr="kubernetes-branco.png"/>
+          <p:cNvPicPr>
+            <a:picLocks noChangeAspect="1"/>
+          </p:cNvPicPr>
+          <p:nvPr/>
+        </p:nvPicPr>
+        <p:blipFill>
+          <a:blip r:embed="rId4"/>
+          <a:stretch>
+            <a:fillRect/>
+          </a:stretch>
+        </p:blipFill>
+        <p:spPr>
+          <a:xfrm>
             <a:off x="9144000" y="1676400"/>
             <a:ext cx="1809750" cy="1809750"/>
           </a:xfrm>
@@ -22542,7 +22622,7 @@
       </p:pic>
       <p:sp>
         <p:nvSpPr>
-          <p:cNvPr id="4" name="TextBox 3"/>
+          <p:cNvPr id="5" name="TextBox 4"/>
           <p:cNvSpPr txBox="1"/>
           <p:nvPr/>
         </p:nvSpPr>
@@ -22597,7 +22677,7 @@
       </p:sp>
       <p:sp>
         <p:nvSpPr>
-          <p:cNvPr id="5" name="TextBox 4"/>
+          <p:cNvPr id="6" name="TextBox 5"/>
           <p:cNvSpPr txBox="1"/>
           <p:nvPr/>
         </p:nvSpPr>
@@ -22636,7 +22716,7 @@
       </p:sp>
       <p:sp>
         <p:nvSpPr>
-          <p:cNvPr id="6" name="TextBox 5"/>
+          <p:cNvPr id="7" name="TextBox 6"/>
           <p:cNvSpPr txBox="1"/>
           <p:nvPr/>
         </p:nvSpPr>
@@ -22675,7 +22755,7 @@
       </p:sp>
       <p:sp>
         <p:nvSpPr>
-          <p:cNvPr id="7" name="TextBox 6"/>
+          <p:cNvPr id="8" name="TextBox 7"/>
           <p:cNvSpPr txBox="1"/>
           <p:nvPr/>
         </p:nvSpPr>
@@ -31047,14 +31127,6 @@
 <file path=ppt/slides/slide4.xml><?xml version="1.0" encoding="utf-8"?>
 <p:sld xmlns:a="http://schemas.openxmlformats.org/drawingml/2006/main" xmlns:p="http://schemas.openxmlformats.org/presentationml/2006/main" xmlns:r="http://schemas.openxmlformats.org/officeDocument/2006/relationships">
   <p:cSld>
-    <p:bg>
-      <p:bgPr>
-        <a:solidFill>
-          <a:srgbClr val="21049A"/>
-        </a:solidFill>
-        <a:effectLst/>
-      </p:bgPr>
-    </p:bg>
     <p:spTree>
       <p:nvGrpSpPr>
         <p:cNvPr id="1" name=""/>
@@ -31062,9 +31134,33 @@
         <p:nvPr/>
       </p:nvGrpSpPr>
       <p:grpSpPr/>
-      <p:sp>
-        <p:nvSpPr>
-          <p:cNvPr id="2" name="Rectangle 1"/>
+      <p:pic>
+        <p:nvPicPr>
+          <p:cNvPr id="2" name="Picture 1" descr="fundo-secao.jpg"/>
+          <p:cNvPicPr>
+            <a:picLocks noChangeAspect="1"/>
+          </p:cNvPicPr>
+          <p:nvPr/>
+        </p:nvPicPr>
+        <p:blipFill>
+          <a:blip r:embed="rId2"/>
+          <a:stretch>
+            <a:fillRect/>
+          </a:stretch>
+        </p:blipFill>
+        <p:spPr>
+          <a:xfrm>
+            <a:off x="0" y="0"/>
+            <a:ext cx="12192000" cy="6858000"/>
+          </a:xfrm>
+          <a:prstGeom prst="rect">
+            <a:avLst/>
+          </a:prstGeom>
+        </p:spPr>
+      </p:pic>
+      <p:sp>
+        <p:nvSpPr>
+          <p:cNvPr id="3" name="Rectangle 2"/>
           <p:cNvSpPr/>
           <p:nvPr/>
         </p:nvSpPr>
@@ -31108,31 +31204,7 @@
       </p:sp>
       <p:pic>
         <p:nvPicPr>
-          <p:cNvPr id="3" name="Picture 2" descr="u-branco.png"/>
-          <p:cNvPicPr>
-            <a:picLocks noChangeAspect="1"/>
-          </p:cNvPicPr>
-          <p:nvPr/>
-        </p:nvPicPr>
-        <p:blipFill>
-          <a:blip r:embed="rId2"/>
-          <a:stretch>
-            <a:fillRect/>
-          </a:stretch>
-        </p:blipFill>
-        <p:spPr>
-          <a:xfrm>
-            <a:off x="10744200" y="457200"/>
-            <a:ext cx="342900" cy="342900"/>
-          </a:xfrm>
-          <a:prstGeom prst="rect">
-            <a:avLst/>
-          </a:prstGeom>
-        </p:spPr>
-      </p:pic>
-      <p:pic>
-        <p:nvPicPr>
-          <p:cNvPr id="4" name="Picture 3" descr="docker.png"/>
+          <p:cNvPr id="4" name="Picture 3" descr="u-branco.png"/>
           <p:cNvPicPr>
             <a:picLocks noChangeAspect="1"/>
           </p:cNvPicPr>
@@ -31146,6 +31218,30 @@
         </p:blipFill>
         <p:spPr>
           <a:xfrm>
+            <a:off x="10744200" y="457200"/>
+            <a:ext cx="342900" cy="342900"/>
+          </a:xfrm>
+          <a:prstGeom prst="rect">
+            <a:avLst/>
+          </a:prstGeom>
+        </p:spPr>
+      </p:pic>
+      <p:pic>
+        <p:nvPicPr>
+          <p:cNvPr id="5" name="Picture 4" descr="docker.png"/>
+          <p:cNvPicPr>
+            <a:picLocks noChangeAspect="1"/>
+          </p:cNvPicPr>
+          <p:nvPr/>
+        </p:nvPicPr>
+        <p:blipFill>
+          <a:blip r:embed="rId4"/>
+          <a:stretch>
+            <a:fillRect/>
+          </a:stretch>
+        </p:blipFill>
+        <p:spPr>
+          <a:xfrm>
             <a:off x="8763000" y="2381250"/>
             <a:ext cx="2476500" cy="1775993"/>
           </a:xfrm>
@@ -31156,7 +31252,7 @@
       </p:pic>
       <p:sp>
         <p:nvSpPr>
-          <p:cNvPr id="5" name="TextBox 4"/>
+          <p:cNvPr id="6" name="TextBox 5"/>
           <p:cNvSpPr txBox="1"/>
           <p:nvPr/>
         </p:nvSpPr>
@@ -31195,7 +31291,7 @@
       </p:sp>
       <p:sp>
         <p:nvSpPr>
-          <p:cNvPr id="6" name="TextBox 5"/>
+          <p:cNvPr id="7" name="TextBox 6"/>
           <p:cNvSpPr txBox="1"/>
           <p:nvPr/>
         </p:nvSpPr>
@@ -31234,7 +31330,7 @@
       </p:sp>
       <p:sp>
         <p:nvSpPr>
-          <p:cNvPr id="7" name="TextBox 6"/>
+          <p:cNvPr id="8" name="TextBox 7"/>
           <p:cNvSpPr txBox="1"/>
           <p:nvPr/>
         </p:nvSpPr>
@@ -31273,7 +31369,7 @@
       </p:sp>
       <p:sp>
         <p:nvSpPr>
-          <p:cNvPr id="8" name="TextBox 7"/>
+          <p:cNvPr id="9" name="TextBox 8"/>
           <p:cNvSpPr txBox="1"/>
           <p:nvPr/>
         </p:nvSpPr>
@@ -31312,7 +31408,7 @@
       </p:sp>
       <p:sp>
         <p:nvSpPr>
-          <p:cNvPr id="9" name="TextBox 8"/>
+          <p:cNvPr id="10" name="TextBox 9"/>
           <p:cNvSpPr txBox="1"/>
           <p:nvPr/>
         </p:nvSpPr>

</xml_diff>

<commit_message>
docs: remove o slide de resumo final do T1, que repetia tres titulos anteriores
</commit_message>
<xml_diff>
--- a/trabalhos/T1-Docker-Invite-People.pptx
+++ b/trabalhos/T1-Docker-Invite-People.pptx
@@ -37,7 +37,6 @@
     <p:sldId id="282" r:id="rId37"/>
     <p:sldId id="283" r:id="rId38"/>
     <p:sldId id="284" r:id="rId39"/>
-    <p:sldId id="285" r:id="rId40"/>
   </p:sldIdLst>
   <p:sldSz cx="12192000" cy="6858000"/>
   <p:notesSz cx="6858000" cy="9144000"/>
@@ -29537,7 +29536,7 @@
                 </a:solidFill>
                 <a:latin typeface="Roboto"/>
               </a:rPr>
-              <a:t>Três coisas para lembrar</a:t>
+              <a:t>Referências</a:t>
             </a:r>
           </a:p>
         </p:txBody>
@@ -29550,7 +29549,7 @@
         </p:nvSpPr>
         <p:spPr>
           <a:xfrm>
-            <a:off x="704850" y="2939796"/>
+            <a:off x="704850" y="2086166"/>
             <a:ext cx="57150" cy="57150"/>
           </a:xfrm>
           <a:prstGeom prst="rect">
@@ -29594,7 +29593,7 @@
         </p:nvSpPr>
         <p:spPr>
           <a:xfrm>
-            <a:off x="971550" y="2801112"/>
+            <a:off x="971550" y="1992059"/>
             <a:ext cx="9677400" cy="95250"/>
           </a:xfrm>
           <a:prstGeom prst="rect">
@@ -29614,13 +29613,13 @@
               </a:lnSpc>
             </a:pPr>
             <a:r>
-              <a:rPr sz="2100" b="0" i="0">
+              <a:rPr sz="1420" b="0" i="0">
                 <a:solidFill>
                   <a:srgbClr val="1A1A1E"/>
                 </a:solidFill>
                 <a:latin typeface="Roboto"/>
               </a:rPr>
-              <a:t>Container é um processo comum, isolado por mecanismos do kernel.</a:t>
+              <a:t>Open Container Initiative. Runtime Spec, Image Spec e Distribution Spec. Linux Foundation, fundada em 2015.</a:t>
             </a:r>
           </a:p>
         </p:txBody>
@@ -29633,7 +29632,7 @@
         </p:nvSpPr>
         <p:spPr>
           <a:xfrm>
-            <a:off x="704850" y="3653790"/>
+            <a:off x="704850" y="2553652"/>
             <a:ext cx="57150" cy="57150"/>
           </a:xfrm>
           <a:prstGeom prst="rect">
@@ -29677,7 +29676,7 @@
         </p:nvSpPr>
         <p:spPr>
           <a:xfrm>
-            <a:off x="971550" y="3515106"/>
+            <a:off x="971550" y="2459546"/>
             <a:ext cx="9677400" cy="95250"/>
           </a:xfrm>
           <a:prstGeom prst="rect">
@@ -29697,13 +29696,13 @@
               </a:lnSpc>
             </a:pPr>
             <a:r>
-              <a:rPr sz="2100" b="0" i="0">
+              <a:rPr sz="1420" b="0" i="0">
                 <a:solidFill>
                   <a:srgbClr val="1A1A1E"/>
                 </a:solidFill>
                 <a:latin typeface="Roboto"/>
               </a:rPr>
-              <a:t>Imagem é o artefato. Container é o ambiente de execução que roda a imagem.</a:t>
+              <a:t>WIGGINS, A. The Twelve-Factor App, 2011.</a:t>
             </a:r>
           </a:p>
         </p:txBody>
@@ -29716,7 +29715,7 @@
         </p:nvSpPr>
         <p:spPr>
           <a:xfrm>
-            <a:off x="704850" y="4367784"/>
+            <a:off x="704850" y="3021140"/>
             <a:ext cx="57150" cy="57150"/>
           </a:xfrm>
           <a:prstGeom prst="rect">
@@ -29760,7 +29759,7 @@
         </p:nvSpPr>
         <p:spPr>
           <a:xfrm>
-            <a:off x="971550" y="4229100"/>
+            <a:off x="971550" y="2927032"/>
             <a:ext cx="9677400" cy="95250"/>
           </a:xfrm>
           <a:prstGeom prst="rect">
@@ -29780,27 +29779,71 @@
               </a:lnSpc>
             </a:pPr>
             <a:r>
-              <a:rPr sz="2100" b="0" i="0">
+              <a:rPr sz="1420" b="0" i="0">
                 <a:solidFill>
                   <a:srgbClr val="1A1A1E"/>
                 </a:solidFill>
                 <a:latin typeface="Roboto"/>
               </a:rPr>
-              <a:t>A decisão de arquitetura é em quantos processos separados o sistema vai rodar.</a:t>
-            </a:r>
-          </a:p>
-        </p:txBody>
-      </p:sp>
-      <p:sp>
-        <p:nvSpPr>
-          <p:cNvPr id="10" name="TextBox 9"/>
+              <a:t>FELTER, W. et al. An updated performance comparison of virtual machines and Linux containers. IBM Research Report, 2015.</a:t>
+            </a:r>
+          </a:p>
+        </p:txBody>
+      </p:sp>
+      <p:sp>
+        <p:nvSpPr>
+          <p:cNvPr id="10" name="Rectangle 9"/>
+          <p:cNvSpPr/>
+          <p:nvPr/>
+        </p:nvSpPr>
+        <p:spPr>
+          <a:xfrm>
+            <a:off x="704850" y="3727514"/>
+            <a:ext cx="57150" cy="57150"/>
+          </a:xfrm>
+          <a:prstGeom prst="rect">
+            <a:avLst/>
+          </a:prstGeom>
+          <a:solidFill>
+            <a:srgbClr val="E94D1C"/>
+          </a:solidFill>
+          <a:ln>
+            <a:noFill/>
+          </a:ln>
+          <a:effectLst/>
+        </p:spPr>
+        <p:style>
+          <a:lnRef idx="1">
+            <a:schemeClr val="accent1"/>
+          </a:lnRef>
+          <a:fillRef idx="3">
+            <a:schemeClr val="accent1"/>
+          </a:fillRef>
+          <a:effectRef idx="2">
+            <a:schemeClr val="accent1"/>
+          </a:effectRef>
+          <a:fontRef idx="minor">
+            <a:schemeClr val="lt1"/>
+          </a:fontRef>
+        </p:style>
+        <p:txBody>
+          <a:bodyPr rtlCol="0" anchor="ctr" wrap="square" lIns="0" rIns="0" tIns="0" bIns="0"/>
+          <a:lstStyle/>
+          <a:p>
+            <a:pPr algn="ctr"/>
+          </a:p>
+        </p:txBody>
+      </p:sp>
+      <p:sp>
+        <p:nvSpPr>
+          <p:cNvPr id="11" name="TextBox 10"/>
           <p:cNvSpPr txBox="1"/>
           <p:nvPr/>
         </p:nvSpPr>
         <p:spPr>
           <a:xfrm>
-            <a:off x="685800" y="6324600"/>
-            <a:ext cx="6667500" cy="182880"/>
+            <a:off x="971550" y="3633407"/>
+            <a:ext cx="9677400" cy="95250"/>
           </a:xfrm>
           <a:prstGeom prst="rect">
             <a:avLst/>
@@ -29815,6 +29858,377 @@
           <a:p>
             <a:pPr algn="l">
               <a:lnSpc>
+                <a:spcPct val="130000"/>
+              </a:lnSpc>
+            </a:pPr>
+            <a:r>
+              <a:rPr sz="1420" b="0" i="0">
+                <a:solidFill>
+                  <a:srgbClr val="1A1A1E"/>
+                </a:solidFill>
+                <a:latin typeface="Roboto"/>
+              </a:rPr>
+              <a:t>MERKEL, D. Docker: lightweight Linux containers for consistent development and deployment. Linux Journal, 2014.</a:t>
+            </a:r>
+          </a:p>
+        </p:txBody>
+      </p:sp>
+      <p:sp>
+        <p:nvSpPr>
+          <p:cNvPr id="12" name="Rectangle 11"/>
+          <p:cNvSpPr/>
+          <p:nvPr/>
+        </p:nvSpPr>
+        <p:spPr>
+          <a:xfrm>
+            <a:off x="704850" y="4195000"/>
+            <a:ext cx="57150" cy="57150"/>
+          </a:xfrm>
+          <a:prstGeom prst="rect">
+            <a:avLst/>
+          </a:prstGeom>
+          <a:solidFill>
+            <a:srgbClr val="E94D1C"/>
+          </a:solidFill>
+          <a:ln>
+            <a:noFill/>
+          </a:ln>
+          <a:effectLst/>
+        </p:spPr>
+        <p:style>
+          <a:lnRef idx="1">
+            <a:schemeClr val="accent1"/>
+          </a:lnRef>
+          <a:fillRef idx="3">
+            <a:schemeClr val="accent1"/>
+          </a:fillRef>
+          <a:effectRef idx="2">
+            <a:schemeClr val="accent1"/>
+          </a:effectRef>
+          <a:fontRef idx="minor">
+            <a:schemeClr val="lt1"/>
+          </a:fontRef>
+        </p:style>
+        <p:txBody>
+          <a:bodyPr rtlCol="0" anchor="ctr" wrap="square" lIns="0" rIns="0" tIns="0" bIns="0"/>
+          <a:lstStyle/>
+          <a:p>
+            <a:pPr algn="ctr"/>
+          </a:p>
+        </p:txBody>
+      </p:sp>
+      <p:sp>
+        <p:nvSpPr>
+          <p:cNvPr id="13" name="TextBox 12"/>
+          <p:cNvSpPr txBox="1"/>
+          <p:nvPr/>
+        </p:nvSpPr>
+        <p:spPr>
+          <a:xfrm>
+            <a:off x="971550" y="4100894"/>
+            <a:ext cx="9677400" cy="95250"/>
+          </a:xfrm>
+          <a:prstGeom prst="rect">
+            <a:avLst/>
+          </a:prstGeom>
+          <a:noFill/>
+        </p:spPr>
+        <p:txBody>
+          <a:bodyPr wrap="square" lIns="0" rIns="0" tIns="0" bIns="0" anchor="t">
+            <a:spAutoFit/>
+          </a:bodyPr>
+          <a:lstStyle/>
+          <a:p>
+            <a:pPr algn="l">
+              <a:lnSpc>
+                <a:spcPct val="130000"/>
+              </a:lnSpc>
+            </a:pPr>
+            <a:r>
+              <a:rPr sz="1420" b="0" i="0">
+                <a:solidFill>
+                  <a:srgbClr val="1A1A1E"/>
+                </a:solidFill>
+                <a:latin typeface="Roboto"/>
+              </a:rPr>
+              <a:t>NIST SP 800-190. Application Container Security Guide.</a:t>
+            </a:r>
+          </a:p>
+        </p:txBody>
+      </p:sp>
+      <p:sp>
+        <p:nvSpPr>
+          <p:cNvPr id="14" name="Rectangle 13"/>
+          <p:cNvSpPr/>
+          <p:nvPr/>
+        </p:nvSpPr>
+        <p:spPr>
+          <a:xfrm>
+            <a:off x="704850" y="4662488"/>
+            <a:ext cx="57150" cy="57150"/>
+          </a:xfrm>
+          <a:prstGeom prst="rect">
+            <a:avLst/>
+          </a:prstGeom>
+          <a:solidFill>
+            <a:srgbClr val="E94D1C"/>
+          </a:solidFill>
+          <a:ln>
+            <a:noFill/>
+          </a:ln>
+          <a:effectLst/>
+        </p:spPr>
+        <p:style>
+          <a:lnRef idx="1">
+            <a:schemeClr val="accent1"/>
+          </a:lnRef>
+          <a:fillRef idx="3">
+            <a:schemeClr val="accent1"/>
+          </a:fillRef>
+          <a:effectRef idx="2">
+            <a:schemeClr val="accent1"/>
+          </a:effectRef>
+          <a:fontRef idx="minor">
+            <a:schemeClr val="lt1"/>
+          </a:fontRef>
+        </p:style>
+        <p:txBody>
+          <a:bodyPr rtlCol="0" anchor="ctr" wrap="square" lIns="0" rIns="0" tIns="0" bIns="0"/>
+          <a:lstStyle/>
+          <a:p>
+            <a:pPr algn="ctr"/>
+          </a:p>
+        </p:txBody>
+      </p:sp>
+      <p:sp>
+        <p:nvSpPr>
+          <p:cNvPr id="15" name="TextBox 14"/>
+          <p:cNvSpPr txBox="1"/>
+          <p:nvPr/>
+        </p:nvSpPr>
+        <p:spPr>
+          <a:xfrm>
+            <a:off x="971550" y="4568380"/>
+            <a:ext cx="9677400" cy="95250"/>
+          </a:xfrm>
+          <a:prstGeom prst="rect">
+            <a:avLst/>
+          </a:prstGeom>
+          <a:noFill/>
+        </p:spPr>
+        <p:txBody>
+          <a:bodyPr wrap="square" lIns="0" rIns="0" tIns="0" bIns="0" anchor="t">
+            <a:spAutoFit/>
+          </a:bodyPr>
+          <a:lstStyle/>
+          <a:p>
+            <a:pPr algn="l">
+              <a:lnSpc>
+                <a:spcPct val="130000"/>
+              </a:lnSpc>
+            </a:pPr>
+            <a:r>
+              <a:rPr sz="1420" b="0" i="0">
+                <a:solidFill>
+                  <a:srgbClr val="1A1A1E"/>
+                </a:solidFill>
+                <a:latin typeface="Roboto"/>
+              </a:rPr>
+              <a:t>SOMMERVILLE, I. Engenharia de Software. 6. ed. Addison Wesley, 2004.</a:t>
+            </a:r>
+          </a:p>
+        </p:txBody>
+      </p:sp>
+      <p:sp>
+        <p:nvSpPr>
+          <p:cNvPr id="16" name="Rectangle 15"/>
+          <p:cNvSpPr/>
+          <p:nvPr/>
+        </p:nvSpPr>
+        <p:spPr>
+          <a:xfrm>
+            <a:off x="704850" y="5129974"/>
+            <a:ext cx="57150" cy="57150"/>
+          </a:xfrm>
+          <a:prstGeom prst="rect">
+            <a:avLst/>
+          </a:prstGeom>
+          <a:solidFill>
+            <a:srgbClr val="E94D1C"/>
+          </a:solidFill>
+          <a:ln>
+            <a:noFill/>
+          </a:ln>
+          <a:effectLst/>
+        </p:spPr>
+        <p:style>
+          <a:lnRef idx="1">
+            <a:schemeClr val="accent1"/>
+          </a:lnRef>
+          <a:fillRef idx="3">
+            <a:schemeClr val="accent1"/>
+          </a:fillRef>
+          <a:effectRef idx="2">
+            <a:schemeClr val="accent1"/>
+          </a:effectRef>
+          <a:fontRef idx="minor">
+            <a:schemeClr val="lt1"/>
+          </a:fontRef>
+        </p:style>
+        <p:txBody>
+          <a:bodyPr rtlCol="0" anchor="ctr" wrap="square" lIns="0" rIns="0" tIns="0" bIns="0"/>
+          <a:lstStyle/>
+          <a:p>
+            <a:pPr algn="ctr"/>
+          </a:p>
+        </p:txBody>
+      </p:sp>
+      <p:sp>
+        <p:nvSpPr>
+          <p:cNvPr id="17" name="TextBox 16"/>
+          <p:cNvSpPr txBox="1"/>
+          <p:nvPr/>
+        </p:nvSpPr>
+        <p:spPr>
+          <a:xfrm>
+            <a:off x="971550" y="5035868"/>
+            <a:ext cx="9677400" cy="95250"/>
+          </a:xfrm>
+          <a:prstGeom prst="rect">
+            <a:avLst/>
+          </a:prstGeom>
+          <a:noFill/>
+        </p:spPr>
+        <p:txBody>
+          <a:bodyPr wrap="square" lIns="0" rIns="0" tIns="0" bIns="0" anchor="t">
+            <a:spAutoFit/>
+          </a:bodyPr>
+          <a:lstStyle/>
+          <a:p>
+            <a:pPr algn="l">
+              <a:lnSpc>
+                <a:spcPct val="130000"/>
+              </a:lnSpc>
+            </a:pPr>
+            <a:r>
+              <a:rPr sz="1420" b="0" i="0">
+                <a:solidFill>
+                  <a:srgbClr val="1A1A1E"/>
+                </a:solidFill>
+                <a:latin typeface="Roboto"/>
+              </a:rPr>
+              <a:t>FOWLER, M. Patterns of Enterprise Application Architecture. Addison Wesley, 2002.</a:t>
+            </a:r>
+          </a:p>
+        </p:txBody>
+      </p:sp>
+      <p:sp>
+        <p:nvSpPr>
+          <p:cNvPr id="18" name="Rectangle 17"/>
+          <p:cNvSpPr/>
+          <p:nvPr/>
+        </p:nvSpPr>
+        <p:spPr>
+          <a:xfrm>
+            <a:off x="704850" y="5597462"/>
+            <a:ext cx="57150" cy="57150"/>
+          </a:xfrm>
+          <a:prstGeom prst="rect">
+            <a:avLst/>
+          </a:prstGeom>
+          <a:solidFill>
+            <a:srgbClr val="E94D1C"/>
+          </a:solidFill>
+          <a:ln>
+            <a:noFill/>
+          </a:ln>
+          <a:effectLst/>
+        </p:spPr>
+        <p:style>
+          <a:lnRef idx="1">
+            <a:schemeClr val="accent1"/>
+          </a:lnRef>
+          <a:fillRef idx="3">
+            <a:schemeClr val="accent1"/>
+          </a:fillRef>
+          <a:effectRef idx="2">
+            <a:schemeClr val="accent1"/>
+          </a:effectRef>
+          <a:fontRef idx="minor">
+            <a:schemeClr val="lt1"/>
+          </a:fontRef>
+        </p:style>
+        <p:txBody>
+          <a:bodyPr rtlCol="0" anchor="ctr" wrap="square" lIns="0" rIns="0" tIns="0" bIns="0"/>
+          <a:lstStyle/>
+          <a:p>
+            <a:pPr algn="ctr"/>
+          </a:p>
+        </p:txBody>
+      </p:sp>
+      <p:sp>
+        <p:nvSpPr>
+          <p:cNvPr id="19" name="TextBox 18"/>
+          <p:cNvSpPr txBox="1"/>
+          <p:nvPr/>
+        </p:nvSpPr>
+        <p:spPr>
+          <a:xfrm>
+            <a:off x="971550" y="5503355"/>
+            <a:ext cx="9677400" cy="95250"/>
+          </a:xfrm>
+          <a:prstGeom prst="rect">
+            <a:avLst/>
+          </a:prstGeom>
+          <a:noFill/>
+        </p:spPr>
+        <p:txBody>
+          <a:bodyPr wrap="square" lIns="0" rIns="0" tIns="0" bIns="0" anchor="t">
+            <a:spAutoFit/>
+          </a:bodyPr>
+          <a:lstStyle/>
+          <a:p>
+            <a:pPr algn="l">
+              <a:lnSpc>
+                <a:spcPct val="130000"/>
+              </a:lnSpc>
+            </a:pPr>
+            <a:r>
+              <a:rPr sz="1420" b="0" i="0">
+                <a:solidFill>
+                  <a:srgbClr val="1A1A1E"/>
+                </a:solidFill>
+                <a:latin typeface="Roboto"/>
+              </a:rPr>
+              <a:t>FARIAS, K. Aula 03, Arquiteturas em Camadas. Aula 05, Arquiteturas Baseadas em Componentes.</a:t>
+            </a:r>
+          </a:p>
+        </p:txBody>
+      </p:sp>
+      <p:sp>
+        <p:nvSpPr>
+          <p:cNvPr id="20" name="TextBox 19"/>
+          <p:cNvSpPr txBox="1"/>
+          <p:nvPr/>
+        </p:nvSpPr>
+        <p:spPr>
+          <a:xfrm>
+            <a:off x="685800" y="6324600"/>
+            <a:ext cx="6667500" cy="182880"/>
+          </a:xfrm>
+          <a:prstGeom prst="rect">
+            <a:avLst/>
+          </a:prstGeom>
+          <a:noFill/>
+        </p:spPr>
+        <p:txBody>
+          <a:bodyPr wrap="square" lIns="0" rIns="0" tIns="0" bIns="0" anchor="t">
+            <a:spAutoFit/>
+          </a:bodyPr>
+          <a:lstStyle/>
+          <a:p>
+            <a:pPr algn="l">
+              <a:lnSpc>
                 <a:spcPct val="120000"/>
               </a:lnSpc>
             </a:pPr>
@@ -29825,14 +30239,14 @@
                 </a:solidFill>
                 <a:latin typeface="Roboto"/>
               </a:rPr>
-              <a:t>Considerações finais</a:t>
-            </a:r>
-          </a:p>
-        </p:txBody>
-      </p:sp>
-      <p:sp>
-        <p:nvSpPr>
-          <p:cNvPr id="11" name="TextBox 10"/>
+              <a:t>Referências</a:t>
+            </a:r>
+          </a:p>
+        </p:txBody>
+      </p:sp>
+      <p:sp>
+        <p:nvSpPr>
+          <p:cNvPr id="21" name="TextBox 20"/>
           <p:cNvSpPr txBox="1"/>
           <p:nvPr/>
         </p:nvSpPr>
@@ -30281,837 +30695,6 @@
                 <a:latin typeface="Roboto"/>
               </a:rPr>
               <a:t>03</a:t>
-            </a:r>
-          </a:p>
-        </p:txBody>
-      </p:sp>
-    </p:spTree>
-  </p:cSld>
-  <p:clrMapOvr>
-    <a:masterClrMapping/>
-  </p:clrMapOvr>
-</p:sld>
-</file>
-
-<file path=ppt/slides/slide30.xml><?xml version="1.0" encoding="utf-8"?>
-<p:sld xmlns:a="http://schemas.openxmlformats.org/drawingml/2006/main" xmlns:p="http://schemas.openxmlformats.org/presentationml/2006/main" xmlns:r="http://schemas.openxmlformats.org/officeDocument/2006/relationships">
-  <p:cSld>
-    <p:bg>
-      <p:bgPr>
-        <a:solidFill>
-          <a:srgbClr val="FFFFFF"/>
-        </a:solidFill>
-        <a:effectLst/>
-      </p:bgPr>
-    </p:bg>
-    <p:spTree>
-      <p:nvGrpSpPr>
-        <p:cNvPr id="1" name=""/>
-        <p:cNvGrpSpPr/>
-        <p:nvPr/>
-      </p:nvGrpSpPr>
-      <p:grpSpPr/>
-      <p:pic>
-        <p:nvPicPr>
-          <p:cNvPr id="2" name="Picture 1" descr="u-azul.png"/>
-          <p:cNvPicPr>
-            <a:picLocks noChangeAspect="1"/>
-          </p:cNvPicPr>
-          <p:nvPr/>
-        </p:nvPicPr>
-        <p:blipFill>
-          <a:blip r:embed="rId2"/>
-          <a:stretch>
-            <a:fillRect/>
-          </a:stretch>
-        </p:blipFill>
-        <p:spPr>
-          <a:xfrm>
-            <a:off x="10744200" y="457200"/>
-            <a:ext cx="342900" cy="342900"/>
-          </a:xfrm>
-          <a:prstGeom prst="rect">
-            <a:avLst/>
-          </a:prstGeom>
-        </p:spPr>
-      </p:pic>
-      <p:sp>
-        <p:nvSpPr>
-          <p:cNvPr id="3" name="TextBox 2"/>
-          <p:cNvSpPr txBox="1"/>
-          <p:nvPr/>
-        </p:nvSpPr>
-        <p:spPr>
-          <a:xfrm>
-            <a:off x="685800" y="685800"/>
-            <a:ext cx="9620250" cy="1524000"/>
-          </a:xfrm>
-          <a:prstGeom prst="rect">
-            <a:avLst/>
-          </a:prstGeom>
-          <a:noFill/>
-        </p:spPr>
-        <p:txBody>
-          <a:bodyPr wrap="square" lIns="0" rIns="0" tIns="0" bIns="0" anchor="t">
-            <a:spAutoFit/>
-          </a:bodyPr>
-          <a:lstStyle/>
-          <a:p>
-            <a:pPr algn="l">
-              <a:lnSpc>
-                <a:spcPct val="104000"/>
-              </a:lnSpc>
-            </a:pPr>
-            <a:r>
-              <a:rPr sz="3000" b="1" i="0">
-                <a:solidFill>
-                  <a:srgbClr val="21049A"/>
-                </a:solidFill>
-                <a:latin typeface="Roboto"/>
-              </a:rPr>
-              <a:t>Referências</a:t>
-            </a:r>
-          </a:p>
-        </p:txBody>
-      </p:sp>
-      <p:sp>
-        <p:nvSpPr>
-          <p:cNvPr id="4" name="Rectangle 3"/>
-          <p:cNvSpPr/>
-          <p:nvPr/>
-        </p:nvSpPr>
-        <p:spPr>
-          <a:xfrm>
-            <a:off x="704850" y="2086166"/>
-            <a:ext cx="57150" cy="57150"/>
-          </a:xfrm>
-          <a:prstGeom prst="rect">
-            <a:avLst/>
-          </a:prstGeom>
-          <a:solidFill>
-            <a:srgbClr val="E94D1C"/>
-          </a:solidFill>
-          <a:ln>
-            <a:noFill/>
-          </a:ln>
-          <a:effectLst/>
-        </p:spPr>
-        <p:style>
-          <a:lnRef idx="1">
-            <a:schemeClr val="accent1"/>
-          </a:lnRef>
-          <a:fillRef idx="3">
-            <a:schemeClr val="accent1"/>
-          </a:fillRef>
-          <a:effectRef idx="2">
-            <a:schemeClr val="accent1"/>
-          </a:effectRef>
-          <a:fontRef idx="minor">
-            <a:schemeClr val="lt1"/>
-          </a:fontRef>
-        </p:style>
-        <p:txBody>
-          <a:bodyPr rtlCol="0" anchor="ctr" wrap="square" lIns="0" rIns="0" tIns="0" bIns="0"/>
-          <a:lstStyle/>
-          <a:p>
-            <a:pPr algn="ctr"/>
-          </a:p>
-        </p:txBody>
-      </p:sp>
-      <p:sp>
-        <p:nvSpPr>
-          <p:cNvPr id="5" name="TextBox 4"/>
-          <p:cNvSpPr txBox="1"/>
-          <p:nvPr/>
-        </p:nvSpPr>
-        <p:spPr>
-          <a:xfrm>
-            <a:off x="971550" y="1992059"/>
-            <a:ext cx="9677400" cy="95250"/>
-          </a:xfrm>
-          <a:prstGeom prst="rect">
-            <a:avLst/>
-          </a:prstGeom>
-          <a:noFill/>
-        </p:spPr>
-        <p:txBody>
-          <a:bodyPr wrap="square" lIns="0" rIns="0" tIns="0" bIns="0" anchor="t">
-            <a:spAutoFit/>
-          </a:bodyPr>
-          <a:lstStyle/>
-          <a:p>
-            <a:pPr algn="l">
-              <a:lnSpc>
-                <a:spcPct val="130000"/>
-              </a:lnSpc>
-            </a:pPr>
-            <a:r>
-              <a:rPr sz="1420" b="0" i="0">
-                <a:solidFill>
-                  <a:srgbClr val="1A1A1E"/>
-                </a:solidFill>
-                <a:latin typeface="Roboto"/>
-              </a:rPr>
-              <a:t>Open Container Initiative. Runtime Spec, Image Spec e Distribution Spec. Linux Foundation, fundada em 2015.</a:t>
-            </a:r>
-          </a:p>
-        </p:txBody>
-      </p:sp>
-      <p:sp>
-        <p:nvSpPr>
-          <p:cNvPr id="6" name="Rectangle 5"/>
-          <p:cNvSpPr/>
-          <p:nvPr/>
-        </p:nvSpPr>
-        <p:spPr>
-          <a:xfrm>
-            <a:off x="704850" y="2553652"/>
-            <a:ext cx="57150" cy="57150"/>
-          </a:xfrm>
-          <a:prstGeom prst="rect">
-            <a:avLst/>
-          </a:prstGeom>
-          <a:solidFill>
-            <a:srgbClr val="E94D1C"/>
-          </a:solidFill>
-          <a:ln>
-            <a:noFill/>
-          </a:ln>
-          <a:effectLst/>
-        </p:spPr>
-        <p:style>
-          <a:lnRef idx="1">
-            <a:schemeClr val="accent1"/>
-          </a:lnRef>
-          <a:fillRef idx="3">
-            <a:schemeClr val="accent1"/>
-          </a:fillRef>
-          <a:effectRef idx="2">
-            <a:schemeClr val="accent1"/>
-          </a:effectRef>
-          <a:fontRef idx="minor">
-            <a:schemeClr val="lt1"/>
-          </a:fontRef>
-        </p:style>
-        <p:txBody>
-          <a:bodyPr rtlCol="0" anchor="ctr" wrap="square" lIns="0" rIns="0" tIns="0" bIns="0"/>
-          <a:lstStyle/>
-          <a:p>
-            <a:pPr algn="ctr"/>
-          </a:p>
-        </p:txBody>
-      </p:sp>
-      <p:sp>
-        <p:nvSpPr>
-          <p:cNvPr id="7" name="TextBox 6"/>
-          <p:cNvSpPr txBox="1"/>
-          <p:nvPr/>
-        </p:nvSpPr>
-        <p:spPr>
-          <a:xfrm>
-            <a:off x="971550" y="2459546"/>
-            <a:ext cx="9677400" cy="95250"/>
-          </a:xfrm>
-          <a:prstGeom prst="rect">
-            <a:avLst/>
-          </a:prstGeom>
-          <a:noFill/>
-        </p:spPr>
-        <p:txBody>
-          <a:bodyPr wrap="square" lIns="0" rIns="0" tIns="0" bIns="0" anchor="t">
-            <a:spAutoFit/>
-          </a:bodyPr>
-          <a:lstStyle/>
-          <a:p>
-            <a:pPr algn="l">
-              <a:lnSpc>
-                <a:spcPct val="130000"/>
-              </a:lnSpc>
-            </a:pPr>
-            <a:r>
-              <a:rPr sz="1420" b="0" i="0">
-                <a:solidFill>
-                  <a:srgbClr val="1A1A1E"/>
-                </a:solidFill>
-                <a:latin typeface="Roboto"/>
-              </a:rPr>
-              <a:t>WIGGINS, A. The Twelve-Factor App, 2011.</a:t>
-            </a:r>
-          </a:p>
-        </p:txBody>
-      </p:sp>
-      <p:sp>
-        <p:nvSpPr>
-          <p:cNvPr id="8" name="Rectangle 7"/>
-          <p:cNvSpPr/>
-          <p:nvPr/>
-        </p:nvSpPr>
-        <p:spPr>
-          <a:xfrm>
-            <a:off x="704850" y="3021140"/>
-            <a:ext cx="57150" cy="57150"/>
-          </a:xfrm>
-          <a:prstGeom prst="rect">
-            <a:avLst/>
-          </a:prstGeom>
-          <a:solidFill>
-            <a:srgbClr val="E94D1C"/>
-          </a:solidFill>
-          <a:ln>
-            <a:noFill/>
-          </a:ln>
-          <a:effectLst/>
-        </p:spPr>
-        <p:style>
-          <a:lnRef idx="1">
-            <a:schemeClr val="accent1"/>
-          </a:lnRef>
-          <a:fillRef idx="3">
-            <a:schemeClr val="accent1"/>
-          </a:fillRef>
-          <a:effectRef idx="2">
-            <a:schemeClr val="accent1"/>
-          </a:effectRef>
-          <a:fontRef idx="minor">
-            <a:schemeClr val="lt1"/>
-          </a:fontRef>
-        </p:style>
-        <p:txBody>
-          <a:bodyPr rtlCol="0" anchor="ctr" wrap="square" lIns="0" rIns="0" tIns="0" bIns="0"/>
-          <a:lstStyle/>
-          <a:p>
-            <a:pPr algn="ctr"/>
-          </a:p>
-        </p:txBody>
-      </p:sp>
-      <p:sp>
-        <p:nvSpPr>
-          <p:cNvPr id="9" name="TextBox 8"/>
-          <p:cNvSpPr txBox="1"/>
-          <p:nvPr/>
-        </p:nvSpPr>
-        <p:spPr>
-          <a:xfrm>
-            <a:off x="971550" y="2927032"/>
-            <a:ext cx="9677400" cy="95250"/>
-          </a:xfrm>
-          <a:prstGeom prst="rect">
-            <a:avLst/>
-          </a:prstGeom>
-          <a:noFill/>
-        </p:spPr>
-        <p:txBody>
-          <a:bodyPr wrap="square" lIns="0" rIns="0" tIns="0" bIns="0" anchor="t">
-            <a:spAutoFit/>
-          </a:bodyPr>
-          <a:lstStyle/>
-          <a:p>
-            <a:pPr algn="l">
-              <a:lnSpc>
-                <a:spcPct val="130000"/>
-              </a:lnSpc>
-            </a:pPr>
-            <a:r>
-              <a:rPr sz="1420" b="0" i="0">
-                <a:solidFill>
-                  <a:srgbClr val="1A1A1E"/>
-                </a:solidFill>
-                <a:latin typeface="Roboto"/>
-              </a:rPr>
-              <a:t>FELTER, W. et al. An updated performance comparison of virtual machines and Linux containers. IBM Research Report, 2015.</a:t>
-            </a:r>
-          </a:p>
-        </p:txBody>
-      </p:sp>
-      <p:sp>
-        <p:nvSpPr>
-          <p:cNvPr id="10" name="Rectangle 9"/>
-          <p:cNvSpPr/>
-          <p:nvPr/>
-        </p:nvSpPr>
-        <p:spPr>
-          <a:xfrm>
-            <a:off x="704850" y="3727514"/>
-            <a:ext cx="57150" cy="57150"/>
-          </a:xfrm>
-          <a:prstGeom prst="rect">
-            <a:avLst/>
-          </a:prstGeom>
-          <a:solidFill>
-            <a:srgbClr val="E94D1C"/>
-          </a:solidFill>
-          <a:ln>
-            <a:noFill/>
-          </a:ln>
-          <a:effectLst/>
-        </p:spPr>
-        <p:style>
-          <a:lnRef idx="1">
-            <a:schemeClr val="accent1"/>
-          </a:lnRef>
-          <a:fillRef idx="3">
-            <a:schemeClr val="accent1"/>
-          </a:fillRef>
-          <a:effectRef idx="2">
-            <a:schemeClr val="accent1"/>
-          </a:effectRef>
-          <a:fontRef idx="minor">
-            <a:schemeClr val="lt1"/>
-          </a:fontRef>
-        </p:style>
-        <p:txBody>
-          <a:bodyPr rtlCol="0" anchor="ctr" wrap="square" lIns="0" rIns="0" tIns="0" bIns="0"/>
-          <a:lstStyle/>
-          <a:p>
-            <a:pPr algn="ctr"/>
-          </a:p>
-        </p:txBody>
-      </p:sp>
-      <p:sp>
-        <p:nvSpPr>
-          <p:cNvPr id="11" name="TextBox 10"/>
-          <p:cNvSpPr txBox="1"/>
-          <p:nvPr/>
-        </p:nvSpPr>
-        <p:spPr>
-          <a:xfrm>
-            <a:off x="971550" y="3633407"/>
-            <a:ext cx="9677400" cy="95250"/>
-          </a:xfrm>
-          <a:prstGeom prst="rect">
-            <a:avLst/>
-          </a:prstGeom>
-          <a:noFill/>
-        </p:spPr>
-        <p:txBody>
-          <a:bodyPr wrap="square" lIns="0" rIns="0" tIns="0" bIns="0" anchor="t">
-            <a:spAutoFit/>
-          </a:bodyPr>
-          <a:lstStyle/>
-          <a:p>
-            <a:pPr algn="l">
-              <a:lnSpc>
-                <a:spcPct val="130000"/>
-              </a:lnSpc>
-            </a:pPr>
-            <a:r>
-              <a:rPr sz="1420" b="0" i="0">
-                <a:solidFill>
-                  <a:srgbClr val="1A1A1E"/>
-                </a:solidFill>
-                <a:latin typeface="Roboto"/>
-              </a:rPr>
-              <a:t>MERKEL, D. Docker: lightweight Linux containers for consistent development and deployment. Linux Journal, 2014.</a:t>
-            </a:r>
-          </a:p>
-        </p:txBody>
-      </p:sp>
-      <p:sp>
-        <p:nvSpPr>
-          <p:cNvPr id="12" name="Rectangle 11"/>
-          <p:cNvSpPr/>
-          <p:nvPr/>
-        </p:nvSpPr>
-        <p:spPr>
-          <a:xfrm>
-            <a:off x="704850" y="4195000"/>
-            <a:ext cx="57150" cy="57150"/>
-          </a:xfrm>
-          <a:prstGeom prst="rect">
-            <a:avLst/>
-          </a:prstGeom>
-          <a:solidFill>
-            <a:srgbClr val="E94D1C"/>
-          </a:solidFill>
-          <a:ln>
-            <a:noFill/>
-          </a:ln>
-          <a:effectLst/>
-        </p:spPr>
-        <p:style>
-          <a:lnRef idx="1">
-            <a:schemeClr val="accent1"/>
-          </a:lnRef>
-          <a:fillRef idx="3">
-            <a:schemeClr val="accent1"/>
-          </a:fillRef>
-          <a:effectRef idx="2">
-            <a:schemeClr val="accent1"/>
-          </a:effectRef>
-          <a:fontRef idx="minor">
-            <a:schemeClr val="lt1"/>
-          </a:fontRef>
-        </p:style>
-        <p:txBody>
-          <a:bodyPr rtlCol="0" anchor="ctr" wrap="square" lIns="0" rIns="0" tIns="0" bIns="0"/>
-          <a:lstStyle/>
-          <a:p>
-            <a:pPr algn="ctr"/>
-          </a:p>
-        </p:txBody>
-      </p:sp>
-      <p:sp>
-        <p:nvSpPr>
-          <p:cNvPr id="13" name="TextBox 12"/>
-          <p:cNvSpPr txBox="1"/>
-          <p:nvPr/>
-        </p:nvSpPr>
-        <p:spPr>
-          <a:xfrm>
-            <a:off x="971550" y="4100894"/>
-            <a:ext cx="9677400" cy="95250"/>
-          </a:xfrm>
-          <a:prstGeom prst="rect">
-            <a:avLst/>
-          </a:prstGeom>
-          <a:noFill/>
-        </p:spPr>
-        <p:txBody>
-          <a:bodyPr wrap="square" lIns="0" rIns="0" tIns="0" bIns="0" anchor="t">
-            <a:spAutoFit/>
-          </a:bodyPr>
-          <a:lstStyle/>
-          <a:p>
-            <a:pPr algn="l">
-              <a:lnSpc>
-                <a:spcPct val="130000"/>
-              </a:lnSpc>
-            </a:pPr>
-            <a:r>
-              <a:rPr sz="1420" b="0" i="0">
-                <a:solidFill>
-                  <a:srgbClr val="1A1A1E"/>
-                </a:solidFill>
-                <a:latin typeface="Roboto"/>
-              </a:rPr>
-              <a:t>NIST SP 800-190. Application Container Security Guide.</a:t>
-            </a:r>
-          </a:p>
-        </p:txBody>
-      </p:sp>
-      <p:sp>
-        <p:nvSpPr>
-          <p:cNvPr id="14" name="Rectangle 13"/>
-          <p:cNvSpPr/>
-          <p:nvPr/>
-        </p:nvSpPr>
-        <p:spPr>
-          <a:xfrm>
-            <a:off x="704850" y="4662488"/>
-            <a:ext cx="57150" cy="57150"/>
-          </a:xfrm>
-          <a:prstGeom prst="rect">
-            <a:avLst/>
-          </a:prstGeom>
-          <a:solidFill>
-            <a:srgbClr val="E94D1C"/>
-          </a:solidFill>
-          <a:ln>
-            <a:noFill/>
-          </a:ln>
-          <a:effectLst/>
-        </p:spPr>
-        <p:style>
-          <a:lnRef idx="1">
-            <a:schemeClr val="accent1"/>
-          </a:lnRef>
-          <a:fillRef idx="3">
-            <a:schemeClr val="accent1"/>
-          </a:fillRef>
-          <a:effectRef idx="2">
-            <a:schemeClr val="accent1"/>
-          </a:effectRef>
-          <a:fontRef idx="minor">
-            <a:schemeClr val="lt1"/>
-          </a:fontRef>
-        </p:style>
-        <p:txBody>
-          <a:bodyPr rtlCol="0" anchor="ctr" wrap="square" lIns="0" rIns="0" tIns="0" bIns="0"/>
-          <a:lstStyle/>
-          <a:p>
-            <a:pPr algn="ctr"/>
-          </a:p>
-        </p:txBody>
-      </p:sp>
-      <p:sp>
-        <p:nvSpPr>
-          <p:cNvPr id="15" name="TextBox 14"/>
-          <p:cNvSpPr txBox="1"/>
-          <p:nvPr/>
-        </p:nvSpPr>
-        <p:spPr>
-          <a:xfrm>
-            <a:off x="971550" y="4568380"/>
-            <a:ext cx="9677400" cy="95250"/>
-          </a:xfrm>
-          <a:prstGeom prst="rect">
-            <a:avLst/>
-          </a:prstGeom>
-          <a:noFill/>
-        </p:spPr>
-        <p:txBody>
-          <a:bodyPr wrap="square" lIns="0" rIns="0" tIns="0" bIns="0" anchor="t">
-            <a:spAutoFit/>
-          </a:bodyPr>
-          <a:lstStyle/>
-          <a:p>
-            <a:pPr algn="l">
-              <a:lnSpc>
-                <a:spcPct val="130000"/>
-              </a:lnSpc>
-            </a:pPr>
-            <a:r>
-              <a:rPr sz="1420" b="0" i="0">
-                <a:solidFill>
-                  <a:srgbClr val="1A1A1E"/>
-                </a:solidFill>
-                <a:latin typeface="Roboto"/>
-              </a:rPr>
-              <a:t>SOMMERVILLE, I. Engenharia de Software. 6. ed. Addison Wesley, 2004.</a:t>
-            </a:r>
-          </a:p>
-        </p:txBody>
-      </p:sp>
-      <p:sp>
-        <p:nvSpPr>
-          <p:cNvPr id="16" name="Rectangle 15"/>
-          <p:cNvSpPr/>
-          <p:nvPr/>
-        </p:nvSpPr>
-        <p:spPr>
-          <a:xfrm>
-            <a:off x="704850" y="5129974"/>
-            <a:ext cx="57150" cy="57150"/>
-          </a:xfrm>
-          <a:prstGeom prst="rect">
-            <a:avLst/>
-          </a:prstGeom>
-          <a:solidFill>
-            <a:srgbClr val="E94D1C"/>
-          </a:solidFill>
-          <a:ln>
-            <a:noFill/>
-          </a:ln>
-          <a:effectLst/>
-        </p:spPr>
-        <p:style>
-          <a:lnRef idx="1">
-            <a:schemeClr val="accent1"/>
-          </a:lnRef>
-          <a:fillRef idx="3">
-            <a:schemeClr val="accent1"/>
-          </a:fillRef>
-          <a:effectRef idx="2">
-            <a:schemeClr val="accent1"/>
-          </a:effectRef>
-          <a:fontRef idx="minor">
-            <a:schemeClr val="lt1"/>
-          </a:fontRef>
-        </p:style>
-        <p:txBody>
-          <a:bodyPr rtlCol="0" anchor="ctr" wrap="square" lIns="0" rIns="0" tIns="0" bIns="0"/>
-          <a:lstStyle/>
-          <a:p>
-            <a:pPr algn="ctr"/>
-          </a:p>
-        </p:txBody>
-      </p:sp>
-      <p:sp>
-        <p:nvSpPr>
-          <p:cNvPr id="17" name="TextBox 16"/>
-          <p:cNvSpPr txBox="1"/>
-          <p:nvPr/>
-        </p:nvSpPr>
-        <p:spPr>
-          <a:xfrm>
-            <a:off x="971550" y="5035868"/>
-            <a:ext cx="9677400" cy="95250"/>
-          </a:xfrm>
-          <a:prstGeom prst="rect">
-            <a:avLst/>
-          </a:prstGeom>
-          <a:noFill/>
-        </p:spPr>
-        <p:txBody>
-          <a:bodyPr wrap="square" lIns="0" rIns="0" tIns="0" bIns="0" anchor="t">
-            <a:spAutoFit/>
-          </a:bodyPr>
-          <a:lstStyle/>
-          <a:p>
-            <a:pPr algn="l">
-              <a:lnSpc>
-                <a:spcPct val="130000"/>
-              </a:lnSpc>
-            </a:pPr>
-            <a:r>
-              <a:rPr sz="1420" b="0" i="0">
-                <a:solidFill>
-                  <a:srgbClr val="1A1A1E"/>
-                </a:solidFill>
-                <a:latin typeface="Roboto"/>
-              </a:rPr>
-              <a:t>FOWLER, M. Patterns of Enterprise Application Architecture. Addison Wesley, 2002.</a:t>
-            </a:r>
-          </a:p>
-        </p:txBody>
-      </p:sp>
-      <p:sp>
-        <p:nvSpPr>
-          <p:cNvPr id="18" name="Rectangle 17"/>
-          <p:cNvSpPr/>
-          <p:nvPr/>
-        </p:nvSpPr>
-        <p:spPr>
-          <a:xfrm>
-            <a:off x="704850" y="5597462"/>
-            <a:ext cx="57150" cy="57150"/>
-          </a:xfrm>
-          <a:prstGeom prst="rect">
-            <a:avLst/>
-          </a:prstGeom>
-          <a:solidFill>
-            <a:srgbClr val="E94D1C"/>
-          </a:solidFill>
-          <a:ln>
-            <a:noFill/>
-          </a:ln>
-          <a:effectLst/>
-        </p:spPr>
-        <p:style>
-          <a:lnRef idx="1">
-            <a:schemeClr val="accent1"/>
-          </a:lnRef>
-          <a:fillRef idx="3">
-            <a:schemeClr val="accent1"/>
-          </a:fillRef>
-          <a:effectRef idx="2">
-            <a:schemeClr val="accent1"/>
-          </a:effectRef>
-          <a:fontRef idx="minor">
-            <a:schemeClr val="lt1"/>
-          </a:fontRef>
-        </p:style>
-        <p:txBody>
-          <a:bodyPr rtlCol="0" anchor="ctr" wrap="square" lIns="0" rIns="0" tIns="0" bIns="0"/>
-          <a:lstStyle/>
-          <a:p>
-            <a:pPr algn="ctr"/>
-          </a:p>
-        </p:txBody>
-      </p:sp>
-      <p:sp>
-        <p:nvSpPr>
-          <p:cNvPr id="19" name="TextBox 18"/>
-          <p:cNvSpPr txBox="1"/>
-          <p:nvPr/>
-        </p:nvSpPr>
-        <p:spPr>
-          <a:xfrm>
-            <a:off x="971550" y="5503355"/>
-            <a:ext cx="9677400" cy="95250"/>
-          </a:xfrm>
-          <a:prstGeom prst="rect">
-            <a:avLst/>
-          </a:prstGeom>
-          <a:noFill/>
-        </p:spPr>
-        <p:txBody>
-          <a:bodyPr wrap="square" lIns="0" rIns="0" tIns="0" bIns="0" anchor="t">
-            <a:spAutoFit/>
-          </a:bodyPr>
-          <a:lstStyle/>
-          <a:p>
-            <a:pPr algn="l">
-              <a:lnSpc>
-                <a:spcPct val="130000"/>
-              </a:lnSpc>
-            </a:pPr>
-            <a:r>
-              <a:rPr sz="1420" b="0" i="0">
-                <a:solidFill>
-                  <a:srgbClr val="1A1A1E"/>
-                </a:solidFill>
-                <a:latin typeface="Roboto"/>
-              </a:rPr>
-              <a:t>FARIAS, K. Aula 03, Arquiteturas em Camadas. Aula 05, Arquiteturas Baseadas em Componentes.</a:t>
-            </a:r>
-          </a:p>
-        </p:txBody>
-      </p:sp>
-      <p:sp>
-        <p:nvSpPr>
-          <p:cNvPr id="20" name="TextBox 19"/>
-          <p:cNvSpPr txBox="1"/>
-          <p:nvPr/>
-        </p:nvSpPr>
-        <p:spPr>
-          <a:xfrm>
-            <a:off x="685800" y="6324600"/>
-            <a:ext cx="6667500" cy="182880"/>
-          </a:xfrm>
-          <a:prstGeom prst="rect">
-            <a:avLst/>
-          </a:prstGeom>
-          <a:noFill/>
-        </p:spPr>
-        <p:txBody>
-          <a:bodyPr wrap="square" lIns="0" rIns="0" tIns="0" bIns="0" anchor="t">
-            <a:spAutoFit/>
-          </a:bodyPr>
-          <a:lstStyle/>
-          <a:p>
-            <a:pPr algn="l">
-              <a:lnSpc>
-                <a:spcPct val="120000"/>
-              </a:lnSpc>
-            </a:pPr>
-            <a:r>
-              <a:rPr sz="900" b="0" i="0">
-                <a:solidFill>
-                  <a:srgbClr val="6B6B78"/>
-                </a:solidFill>
-                <a:latin typeface="Roboto"/>
-              </a:rPr>
-              <a:t>Referências</a:t>
-            </a:r>
-          </a:p>
-        </p:txBody>
-      </p:sp>
-      <p:sp>
-        <p:nvSpPr>
-          <p:cNvPr id="21" name="TextBox 20"/>
-          <p:cNvSpPr txBox="1"/>
-          <p:nvPr/>
-        </p:nvSpPr>
-        <p:spPr>
-          <a:xfrm>
-            <a:off x="10477500" y="6324600"/>
-            <a:ext cx="1028700" cy="182880"/>
-          </a:xfrm>
-          <a:prstGeom prst="rect">
-            <a:avLst/>
-          </a:prstGeom>
-          <a:noFill/>
-        </p:spPr>
-        <p:txBody>
-          <a:bodyPr wrap="square" lIns="0" rIns="0" tIns="0" bIns="0" anchor="t">
-            <a:spAutoFit/>
-          </a:bodyPr>
-          <a:lstStyle/>
-          <a:p>
-            <a:pPr algn="r">
-              <a:lnSpc>
-                <a:spcPct val="120000"/>
-              </a:lnSpc>
-            </a:pPr>
-            <a:r>
-              <a:rPr sz="900" b="1" i="0">
-                <a:solidFill>
-                  <a:srgbClr val="21049A"/>
-                </a:solidFill>
-                <a:latin typeface="Roboto"/>
-              </a:rPr>
-              <a:t>30</a:t>
             </a:r>
           </a:p>
         </p:txBody>

</xml_diff>

<commit_message>
docs: troca figura de linguagem por frase direta nos topicos do T1
</commit_message>
<xml_diff>
--- a/trabalhos/T1-Docker-Invite-People.pptx
+++ b/trabalhos/T1-Docker-Invite-People.pptx
@@ -12080,7 +12080,7 @@
         </p:nvSpPr>
         <p:spPr>
           <a:xfrm>
-            <a:off x="857250" y="3219450"/>
+            <a:off x="857250" y="3324225"/>
             <a:ext cx="1771650" cy="628650"/>
           </a:xfrm>
           <a:prstGeom prst="roundRect">
@@ -12126,7 +12126,7 @@
         </p:nvSpPr>
         <p:spPr>
           <a:xfrm>
-            <a:off x="857250" y="3333750"/>
+            <a:off x="857250" y="3438525"/>
             <a:ext cx="1771650" cy="228600"/>
           </a:xfrm>
           <a:prstGeom prst="rect">
@@ -12165,7 +12165,7 @@
         </p:nvSpPr>
         <p:spPr>
           <a:xfrm>
-            <a:off x="914400" y="3543300"/>
+            <a:off x="914400" y="3648075"/>
             <a:ext cx="1657350" cy="175260"/>
           </a:xfrm>
           <a:prstGeom prst="rect">
@@ -12204,7 +12204,7 @@
         </p:nvSpPr>
         <p:spPr>
           <a:xfrm>
-            <a:off x="2952750" y="3219450"/>
+            <a:off x="2952750" y="3324225"/>
             <a:ext cx="1771650" cy="628650"/>
           </a:xfrm>
           <a:prstGeom prst="roundRect">
@@ -12250,7 +12250,7 @@
         </p:nvSpPr>
         <p:spPr>
           <a:xfrm>
-            <a:off x="2952750" y="3333750"/>
+            <a:off x="2952750" y="3438525"/>
             <a:ext cx="1771650" cy="228600"/>
           </a:xfrm>
           <a:prstGeom prst="rect">
@@ -12289,7 +12289,7 @@
         </p:nvSpPr>
         <p:spPr>
           <a:xfrm>
-            <a:off x="3009900" y="3543300"/>
+            <a:off x="3009900" y="3648075"/>
             <a:ext cx="1657350" cy="175260"/>
           </a:xfrm>
           <a:prstGeom prst="rect">
@@ -12328,7 +12328,7 @@
         </p:nvCxnSpPr>
         <p:spPr>
           <a:xfrm>
-            <a:off x="2628900" y="3533775"/>
+            <a:off x="2628900" y="3638550"/>
             <a:ext cx="323850" cy="0"/>
           </a:xfrm>
           <a:prstGeom prst="line">
@@ -12363,7 +12363,7 @@
         </p:nvSpPr>
         <p:spPr>
           <a:xfrm>
-            <a:off x="5048250" y="3219450"/>
+            <a:off x="5048250" y="3324225"/>
             <a:ext cx="1771650" cy="628650"/>
           </a:xfrm>
           <a:prstGeom prst="roundRect">
@@ -12409,7 +12409,7 @@
         </p:nvSpPr>
         <p:spPr>
           <a:xfrm>
-            <a:off x="5048250" y="3333750"/>
+            <a:off x="5048250" y="3438525"/>
             <a:ext cx="1771650" cy="228600"/>
           </a:xfrm>
           <a:prstGeom prst="rect">
@@ -12448,7 +12448,7 @@
         </p:nvSpPr>
         <p:spPr>
           <a:xfrm>
-            <a:off x="5105400" y="3543300"/>
+            <a:off x="5105400" y="3648075"/>
             <a:ext cx="1657350" cy="175260"/>
           </a:xfrm>
           <a:prstGeom prst="rect">
@@ -12487,7 +12487,7 @@
         </p:nvCxnSpPr>
         <p:spPr>
           <a:xfrm>
-            <a:off x="4724400" y="3533775"/>
+            <a:off x="4724400" y="3638550"/>
             <a:ext cx="323850" cy="0"/>
           </a:xfrm>
           <a:prstGeom prst="line">
@@ -12522,7 +12522,7 @@
         </p:nvSpPr>
         <p:spPr>
           <a:xfrm>
-            <a:off x="7143750" y="3219450"/>
+            <a:off x="7143750" y="3324225"/>
             <a:ext cx="1771650" cy="628650"/>
           </a:xfrm>
           <a:prstGeom prst="roundRect">
@@ -12568,7 +12568,7 @@
         </p:nvSpPr>
         <p:spPr>
           <a:xfrm>
-            <a:off x="7143750" y="3333750"/>
+            <a:off x="7143750" y="3438525"/>
             <a:ext cx="1771650" cy="228600"/>
           </a:xfrm>
           <a:prstGeom prst="rect">
@@ -12607,7 +12607,7 @@
         </p:nvSpPr>
         <p:spPr>
           <a:xfrm>
-            <a:off x="7200900" y="3543300"/>
+            <a:off x="7200900" y="3648075"/>
             <a:ext cx="1657350" cy="175260"/>
           </a:xfrm>
           <a:prstGeom prst="rect">
@@ -12646,7 +12646,7 @@
         </p:nvCxnSpPr>
         <p:spPr>
           <a:xfrm>
-            <a:off x="6819900" y="3533775"/>
+            <a:off x="6819900" y="3638550"/>
             <a:ext cx="323850" cy="0"/>
           </a:xfrm>
           <a:prstGeom prst="line">
@@ -12681,7 +12681,7 @@
         </p:nvSpPr>
         <p:spPr>
           <a:xfrm>
-            <a:off x="9239250" y="3219450"/>
+            <a:off x="9239250" y="3324225"/>
             <a:ext cx="1771650" cy="628650"/>
           </a:xfrm>
           <a:prstGeom prst="roundRect">
@@ -12727,7 +12727,7 @@
         </p:nvSpPr>
         <p:spPr>
           <a:xfrm>
-            <a:off x="9239250" y="3333750"/>
+            <a:off x="9239250" y="3438525"/>
             <a:ext cx="1771650" cy="228600"/>
           </a:xfrm>
           <a:prstGeom prst="rect">
@@ -12766,7 +12766,7 @@
         </p:nvSpPr>
         <p:spPr>
           <a:xfrm>
-            <a:off x="9296400" y="3543300"/>
+            <a:off x="9296400" y="3648075"/>
             <a:ext cx="1657350" cy="175260"/>
           </a:xfrm>
           <a:prstGeom prst="rect">
@@ -12805,7 +12805,7 @@
         </p:nvCxnSpPr>
         <p:spPr>
           <a:xfrm>
-            <a:off x="8915400" y="3533775"/>
+            <a:off x="8915400" y="3638550"/>
             <a:ext cx="323850" cy="0"/>
           </a:xfrm>
           <a:prstGeom prst="line">
@@ -12840,7 +12840,7 @@
         </p:nvSpPr>
         <p:spPr>
           <a:xfrm>
-            <a:off x="4667250" y="2971800"/>
+            <a:off x="4667250" y="3076575"/>
             <a:ext cx="857250" cy="198120"/>
           </a:xfrm>
           <a:prstGeom prst="rect">
@@ -12879,7 +12879,7 @@
         </p:nvSpPr>
         <p:spPr>
           <a:xfrm>
-            <a:off x="876300" y="4313301"/>
+            <a:off x="876300" y="4418076"/>
             <a:ext cx="57150" cy="57150"/>
           </a:xfrm>
           <a:prstGeom prst="rect">
@@ -12923,7 +12923,7 @@
         </p:nvSpPr>
         <p:spPr>
           <a:xfrm>
-            <a:off x="1143000" y="4229100"/>
+            <a:off x="1143000" y="4333875"/>
             <a:ext cx="9620250" cy="95250"/>
           </a:xfrm>
           <a:prstGeom prst="rect">
@@ -12949,7 +12949,7 @@
                 </a:solidFill>
                 <a:latin typeface="Roboto"/>
               </a:rPr>
-              <a:t>O shim é pai do container e não filho do daemon. Foi esse desenho que fez reiniciar o daemon deixar de matar os containers em execução.</a:t>
+              <a:t>O shim é o processo pai do container, não o daemon. Reiniciar o daemon não encerra os containers.</a:t>
             </a:r>
           </a:p>
         </p:txBody>
@@ -12962,7 +12962,7 @@
         </p:nvSpPr>
         <p:spPr>
           <a:xfrm>
-            <a:off x="876300" y="4931283"/>
+            <a:off x="876300" y="4822317"/>
             <a:ext cx="57150" cy="57150"/>
           </a:xfrm>
           <a:prstGeom prst="rect">
@@ -13006,7 +13006,7 @@
         </p:nvSpPr>
         <p:spPr>
           <a:xfrm>
-            <a:off x="1143000" y="4847082"/>
+            <a:off x="1143000" y="4738116"/>
             <a:ext cx="9620250" cy="95250"/>
           </a:xfrm>
           <a:prstGeom prst="rect">
@@ -13282,7 +13282,7 @@
                 </a:solidFill>
                 <a:latin typeface="Roboto"/>
               </a:rPr>
-              <a:t>Capabilities fatiam o root do POSIX em privilégios independentes, que podem ser derrubados e devolvidos um a um.</a:t>
+              <a:t>Capabilities dividem os privilégios de root em unidades independentes, removidas uma a uma.</a:t>
             </a:r>
           </a:p>
         </p:txBody>
@@ -13448,7 +13448,7 @@
                 </a:solidFill>
                 <a:latin typeface="Roboto"/>
               </a:rPr>
-              <a:t>AppArmor ou SELinux entram por cima de tudo, pelo módulo de segurança do próprio kernel.</a:t>
+              <a:t>AppArmor ou SELinux aplicam uma restrição adicional pelo módulo de segurança do kernel.</a:t>
             </a:r>
           </a:p>
         </p:txBody>
@@ -14327,7 +14327,7 @@
         </p:nvSpPr>
         <p:spPr>
           <a:xfrm>
-            <a:off x="857250" y="2295525"/>
+            <a:off x="857250" y="2419350"/>
             <a:ext cx="10001250" cy="182880"/>
           </a:xfrm>
           <a:prstGeom prst="rect">
@@ -14366,7 +14366,7 @@
         </p:nvSpPr>
         <p:spPr>
           <a:xfrm>
-            <a:off x="857250" y="2543175"/>
+            <a:off x="857250" y="2667000"/>
             <a:ext cx="2724150" cy="1504950"/>
           </a:xfrm>
           <a:prstGeom prst="roundRect">
@@ -14415,7 +14415,7 @@
         </p:nvSpPr>
         <p:spPr>
           <a:xfrm>
-            <a:off x="1009650" y="2619375"/>
+            <a:off x="1009650" y="2743200"/>
             <a:ext cx="2419350" cy="247650"/>
           </a:xfrm>
           <a:prstGeom prst="roundRect">
@@ -14463,7 +14463,7 @@
         </p:nvSpPr>
         <p:spPr>
           <a:xfrm>
-            <a:off x="1009650" y="2676525"/>
+            <a:off x="1009650" y="2800350"/>
             <a:ext cx="2419350" cy="198120"/>
           </a:xfrm>
           <a:prstGeom prst="rect">
@@ -14502,7 +14502,7 @@
         </p:nvSpPr>
         <p:spPr>
           <a:xfrm>
-            <a:off x="1009650" y="2905125"/>
+            <a:off x="1009650" y="3028950"/>
             <a:ext cx="2419350" cy="781050"/>
           </a:xfrm>
           <a:prstGeom prst="roundRect">
@@ -14550,7 +14550,7 @@
         </p:nvSpPr>
         <p:spPr>
           <a:xfrm>
-            <a:off x="1038225" y="3019425"/>
+            <a:off x="1038225" y="3143250"/>
             <a:ext cx="2362200" cy="182880"/>
           </a:xfrm>
           <a:prstGeom prst="rect">
@@ -14589,7 +14589,7 @@
         </p:nvSpPr>
         <p:spPr>
           <a:xfrm>
-            <a:off x="1038225" y="3248025"/>
+            <a:off x="1038225" y="3371850"/>
             <a:ext cx="2362200" cy="182880"/>
           </a:xfrm>
           <a:prstGeom prst="rect">
@@ -14628,7 +14628,7 @@
         </p:nvSpPr>
         <p:spPr>
           <a:xfrm>
-            <a:off x="1038225" y="3476625"/>
+            <a:off x="1038225" y="3600450"/>
             <a:ext cx="2362200" cy="182880"/>
           </a:xfrm>
           <a:prstGeom prst="rect">
@@ -14667,7 +14667,7 @@
         </p:nvSpPr>
         <p:spPr>
           <a:xfrm>
-            <a:off x="1009650" y="3724275"/>
+            <a:off x="1009650" y="3848100"/>
             <a:ext cx="2419350" cy="247650"/>
           </a:xfrm>
           <a:prstGeom prst="roundRect">
@@ -14715,7 +14715,7 @@
         </p:nvSpPr>
         <p:spPr>
           <a:xfrm>
-            <a:off x="1009650" y="3781425"/>
+            <a:off x="1009650" y="3905250"/>
             <a:ext cx="2419350" cy="198120"/>
           </a:xfrm>
           <a:prstGeom prst="rect">
@@ -14754,7 +14754,7 @@
         </p:nvSpPr>
         <p:spPr>
           <a:xfrm>
-            <a:off x="857250" y="4162425"/>
+            <a:off x="857250" y="4286250"/>
             <a:ext cx="2724150" cy="228600"/>
           </a:xfrm>
           <a:prstGeom prst="rect">
@@ -14793,7 +14793,7 @@
         </p:nvSpPr>
         <p:spPr>
           <a:xfrm>
-            <a:off x="857250" y="4371975"/>
+            <a:off x="857250" y="4495800"/>
             <a:ext cx="2724150" cy="198120"/>
           </a:xfrm>
           <a:prstGeom prst="rect">
@@ -14832,7 +14832,7 @@
         </p:nvSpPr>
         <p:spPr>
           <a:xfrm>
-            <a:off x="4162425" y="2543175"/>
+            <a:off x="4162425" y="2667000"/>
             <a:ext cx="1143000" cy="1504950"/>
           </a:xfrm>
           <a:prstGeom prst="roundRect">
@@ -14881,7 +14881,7 @@
         </p:nvSpPr>
         <p:spPr>
           <a:xfrm>
-            <a:off x="4295775" y="3209925"/>
+            <a:off x="4295775" y="3333750"/>
             <a:ext cx="876300" cy="247650"/>
           </a:xfrm>
           <a:prstGeom prst="roundRect">
@@ -14929,7 +14929,7 @@
         </p:nvSpPr>
         <p:spPr>
           <a:xfrm>
-            <a:off x="4295775" y="3267075"/>
+            <a:off x="4295775" y="3390900"/>
             <a:ext cx="876300" cy="198120"/>
           </a:xfrm>
           <a:prstGeom prst="rect">
@@ -14968,7 +14968,7 @@
         </p:nvSpPr>
         <p:spPr>
           <a:xfrm>
-            <a:off x="5495925" y="2543175"/>
+            <a:off x="5495925" y="2667000"/>
             <a:ext cx="1390650" cy="1504950"/>
           </a:xfrm>
           <a:prstGeom prst="roundRect">
@@ -15017,7 +15017,7 @@
         </p:nvSpPr>
         <p:spPr>
           <a:xfrm>
-            <a:off x="5562600" y="2762250"/>
+            <a:off x="5562600" y="2886075"/>
             <a:ext cx="1257300" cy="781050"/>
           </a:xfrm>
           <a:prstGeom prst="roundRect">
@@ -15065,7 +15065,7 @@
         </p:nvSpPr>
         <p:spPr>
           <a:xfrm>
-            <a:off x="5591175" y="2876550"/>
+            <a:off x="5591175" y="3000375"/>
             <a:ext cx="1200150" cy="182880"/>
           </a:xfrm>
           <a:prstGeom prst="rect">
@@ -15104,7 +15104,7 @@
         </p:nvSpPr>
         <p:spPr>
           <a:xfrm>
-            <a:off x="5591175" y="3105150"/>
+            <a:off x="5591175" y="3228975"/>
             <a:ext cx="1200150" cy="182880"/>
           </a:xfrm>
           <a:prstGeom prst="rect">
@@ -15143,7 +15143,7 @@
         </p:nvSpPr>
         <p:spPr>
           <a:xfrm>
-            <a:off x="5591175" y="3333750"/>
+            <a:off x="5591175" y="3457575"/>
             <a:ext cx="1200150" cy="182880"/>
           </a:xfrm>
           <a:prstGeom prst="rect">
@@ -15182,7 +15182,7 @@
         </p:nvSpPr>
         <p:spPr>
           <a:xfrm>
-            <a:off x="5629275" y="3600450"/>
+            <a:off x="5629275" y="3724275"/>
             <a:ext cx="1123950" cy="247650"/>
           </a:xfrm>
           <a:prstGeom prst="roundRect">
@@ -15230,7 +15230,7 @@
         </p:nvSpPr>
         <p:spPr>
           <a:xfrm>
-            <a:off x="5629275" y="3657600"/>
+            <a:off x="5629275" y="3781425"/>
             <a:ext cx="1123950" cy="182880"/>
           </a:xfrm>
           <a:prstGeom prst="rect">
@@ -15269,7 +15269,7 @@
         </p:nvSpPr>
         <p:spPr>
           <a:xfrm>
-            <a:off x="4162425" y="4162425"/>
+            <a:off x="4162425" y="4286250"/>
             <a:ext cx="2724150" cy="228600"/>
           </a:xfrm>
           <a:prstGeom prst="rect">
@@ -15308,7 +15308,7 @@
         </p:nvSpPr>
         <p:spPr>
           <a:xfrm>
-            <a:off x="4162425" y="4371975"/>
+            <a:off x="4162425" y="4495800"/>
             <a:ext cx="2724150" cy="198120"/>
           </a:xfrm>
           <a:prstGeom prst="rect">
@@ -15347,7 +15347,7 @@
         </p:nvSpPr>
         <p:spPr>
           <a:xfrm>
-            <a:off x="7239000" y="2543175"/>
+            <a:off x="7239000" y="2667000"/>
             <a:ext cx="838200" cy="1504950"/>
           </a:xfrm>
           <a:prstGeom prst="roundRect">
@@ -15396,7 +15396,7 @@
         </p:nvSpPr>
         <p:spPr>
           <a:xfrm>
-            <a:off x="7353300" y="3209925"/>
+            <a:off x="7353300" y="3333750"/>
             <a:ext cx="609600" cy="247650"/>
           </a:xfrm>
           <a:prstGeom prst="roundRect">
@@ -15444,7 +15444,7 @@
         </p:nvSpPr>
         <p:spPr>
           <a:xfrm>
-            <a:off x="7353300" y="3267075"/>
+            <a:off x="7353300" y="3390900"/>
             <a:ext cx="609600" cy="182880"/>
           </a:xfrm>
           <a:prstGeom prst="rect">
@@ -15483,7 +15483,7 @@
         </p:nvSpPr>
         <p:spPr>
           <a:xfrm>
-            <a:off x="8305800" y="2543175"/>
+            <a:off x="8305800" y="2667000"/>
             <a:ext cx="1619250" cy="1504950"/>
           </a:xfrm>
           <a:prstGeom prst="roundRect">
@@ -15532,7 +15532,7 @@
         </p:nvSpPr>
         <p:spPr>
           <a:xfrm>
-            <a:off x="8420100" y="2905125"/>
+            <a:off x="8420100" y="3028950"/>
             <a:ext cx="1390650" cy="781050"/>
           </a:xfrm>
           <a:prstGeom prst="roundRect">
@@ -15580,7 +15580,7 @@
         </p:nvSpPr>
         <p:spPr>
           <a:xfrm>
-            <a:off x="8448675" y="3019425"/>
+            <a:off x="8448675" y="3143250"/>
             <a:ext cx="1333500" cy="182880"/>
           </a:xfrm>
           <a:prstGeom prst="rect">
@@ -15619,7 +15619,7 @@
         </p:nvSpPr>
         <p:spPr>
           <a:xfrm>
-            <a:off x="8448675" y="3248025"/>
+            <a:off x="8448675" y="3371850"/>
             <a:ext cx="1333500" cy="182880"/>
           </a:xfrm>
           <a:prstGeom prst="rect">
@@ -15658,7 +15658,7 @@
         </p:nvSpPr>
         <p:spPr>
           <a:xfrm>
-            <a:off x="8448675" y="3476625"/>
+            <a:off x="8448675" y="3600450"/>
             <a:ext cx="1333500" cy="182880"/>
           </a:xfrm>
           <a:prstGeom prst="rect">
@@ -15697,7 +15697,7 @@
         </p:nvSpPr>
         <p:spPr>
           <a:xfrm>
-            <a:off x="10153650" y="2543175"/>
+            <a:off x="10153650" y="2667000"/>
             <a:ext cx="838200" cy="1504950"/>
           </a:xfrm>
           <a:prstGeom prst="roundRect">
@@ -15746,7 +15746,7 @@
         </p:nvSpPr>
         <p:spPr>
           <a:xfrm>
-            <a:off x="10267950" y="3209925"/>
+            <a:off x="10267950" y="3333750"/>
             <a:ext cx="609600" cy="247650"/>
           </a:xfrm>
           <a:prstGeom prst="roundRect">
@@ -15794,7 +15794,7 @@
         </p:nvSpPr>
         <p:spPr>
           <a:xfrm>
-            <a:off x="10267950" y="3267075"/>
+            <a:off x="10267950" y="3390900"/>
             <a:ext cx="609600" cy="182880"/>
           </a:xfrm>
           <a:prstGeom prst="rect">
@@ -15833,7 +15833,7 @@
         </p:nvSpPr>
         <p:spPr>
           <a:xfrm>
-            <a:off x="7239000" y="4162425"/>
+            <a:off x="7239000" y="4286250"/>
             <a:ext cx="3752850" cy="228600"/>
           </a:xfrm>
           <a:prstGeom prst="rect">
@@ -15872,7 +15872,7 @@
         </p:nvSpPr>
         <p:spPr>
           <a:xfrm>
-            <a:off x="7239000" y="4371975"/>
+            <a:off x="7239000" y="4495800"/>
             <a:ext cx="3752850" cy="198120"/>
           </a:xfrm>
           <a:prstGeom prst="rect">
@@ -15911,8 +15911,8 @@
         </p:nvSpPr>
         <p:spPr>
           <a:xfrm>
-            <a:off x="685800" y="5428381"/>
-            <a:ext cx="28575" cy="705719"/>
+            <a:off x="685800" y="5676321"/>
+            <a:ext cx="28575" cy="457779"/>
           </a:xfrm>
           <a:prstGeom prst="rect">
             <a:avLst/>
@@ -15955,8 +15955,8 @@
         </p:nvSpPr>
         <p:spPr>
           <a:xfrm>
-            <a:off x="876300" y="5409331"/>
-            <a:ext cx="10629900" cy="839069"/>
+            <a:off x="876300" y="5657271"/>
+            <a:ext cx="10629900" cy="591129"/>
           </a:xfrm>
           <a:prstGeom prst="rect">
             <a:avLst/>
@@ -15981,7 +15981,7 @@
                 </a:solidFill>
                 <a:latin typeface="Roboto"/>
               </a:rPr>
-              <a:t>O projeto lógico é o mesmo nas três opções, e a escolha entre elas entra no documento de decisões arquiteturais do projeto. O Docker também usa a palavra </a:t>
+              <a:t>O projeto lógico é o mesmo nas três opções, e a escolha entre elas é registrada no documento de decisões arquiteturais. No Docker, </a:t>
             </a:r>
             <a:r>
               <a:rPr sz="1280" b="0" i="1">
@@ -15999,7 +15999,7 @@
                 </a:solidFill>
                 <a:latin typeface="Roboto"/>
               </a:rPr>
-              <a:t>, mas para o empilhamento do sistema de arquivos da imagem, que é outra coisa e não tem relação com a camada lógica da arquitetura em camadas.</a:t>
+              <a:t> se refere às camadas do sistema de arquivos da imagem, não às camadas lógicas da arquitetura.</a:t>
             </a:r>
           </a:p>
         </p:txBody>
@@ -16646,7 +16646,7 @@
                 </a:solidFill>
                 <a:latin typeface="Roboto"/>
               </a:rPr>
-              <a:t>Por isso nunca dizer que container não é nó. O modelo fiel é o container aninhado no host, com a imagem implantada dentro dele.</a:t>
+              <a:t>Container é um nó aninhado no host, com a imagem implantada dentro dele.</a:t>
             </a:r>
           </a:p>
         </p:txBody>
@@ -16720,7 +16720,7 @@
                 </a:solidFill>
                 <a:latin typeface="Roboto"/>
               </a:rPr>
-              <a:t>Máquina virtual, essa sim, é um nó novo, com sistema operacional próprio.</a:t>
+              <a:t>Máquina virtual é um nó separado, com sistema operacional próprio.</a:t>
             </a:r>
           </a:p>
         </p:txBody>
@@ -18174,7 +18174,7 @@
                 </a:solidFill>
                 <a:latin typeface="Roboto"/>
               </a:rPr>
-              <a:t>Cada nó vira um serviço no arquivo de compose, com a imagem por tag e digest.</a:t>
+              <a:t>Cada nó corresponde a um serviço no arquivo de compose, com a imagem por tag e digest.</a:t>
             </a:r>
           </a:p>
         </p:txBody>
@@ -19064,7 +19064,7 @@
                 </a:solidFill>
                 <a:latin typeface="Roboto"/>
               </a:rPr>
-              <a:t>A porta da UML é literalmente a porta do container, com o mesmo desenho e o mesmo nome.</a:t>
+              <a:t>A porta da UML corresponde à porta publicada do container.</a:t>
             </a:r>
           </a:p>
         </p:txBody>
@@ -19327,7 +19327,7 @@
         </p:nvSpPr>
         <p:spPr>
           <a:xfrm>
-            <a:off x="685800" y="1899285"/>
+            <a:off x="685800" y="2031302"/>
             <a:ext cx="5143500" cy="182880"/>
           </a:xfrm>
           <a:prstGeom prst="rect">
@@ -19366,7 +19366,7 @@
         </p:nvSpPr>
         <p:spPr>
           <a:xfrm>
-            <a:off x="685800" y="2108835"/>
+            <a:off x="685800" y="2240852"/>
             <a:ext cx="419100" cy="28575"/>
           </a:xfrm>
           <a:prstGeom prst="rect">
@@ -19410,7 +19410,7 @@
         </p:nvSpPr>
         <p:spPr>
           <a:xfrm>
-            <a:off x="704850" y="2498598"/>
+            <a:off x="704850" y="2630614"/>
             <a:ext cx="57150" cy="57150"/>
           </a:xfrm>
           <a:prstGeom prst="rect">
@@ -19454,7 +19454,7 @@
         </p:nvSpPr>
         <p:spPr>
           <a:xfrm>
-            <a:off x="971550" y="2394585"/>
+            <a:off x="971550" y="2526602"/>
             <a:ext cx="4857750" cy="95250"/>
           </a:xfrm>
           <a:prstGeom prst="rect">
@@ -19480,7 +19480,7 @@
                 </a:solidFill>
                 <a:latin typeface="Roboto"/>
               </a:rPr>
-              <a:t>A imagem passa a ter uma responsabilidade só.</a:t>
+              <a:t>Cada imagem tem uma responsabilidade.</a:t>
             </a:r>
           </a:p>
         </p:txBody>
@@ -19493,7 +19493,7 @@
         </p:nvSpPr>
         <p:spPr>
           <a:xfrm>
-            <a:off x="704850" y="3029331"/>
+            <a:off x="704850" y="3161348"/>
             <a:ext cx="57150" cy="57150"/>
           </a:xfrm>
           <a:prstGeom prst="rect">
@@ -19537,7 +19537,7 @@
         </p:nvSpPr>
         <p:spPr>
           <a:xfrm>
-            <a:off x="971550" y="2925318"/>
+            <a:off x="971550" y="3057334"/>
             <a:ext cx="4857750" cy="95250"/>
           </a:xfrm>
           <a:prstGeom prst="rect">
@@ -19563,7 +19563,7 @@
                 </a:solidFill>
                 <a:latin typeface="Roboto"/>
               </a:rPr>
-              <a:t>O código do front-end não está na imagem da API, então a API não depende dele nem por acidente.</a:t>
+              <a:t>O código do front-end não está na imagem da API, então a API não depende dele.</a:t>
             </a:r>
           </a:p>
         </p:txBody>
@@ -19576,7 +19576,7 @@
         </p:nvSpPr>
         <p:spPr>
           <a:xfrm>
-            <a:off x="704850" y="3824097"/>
+            <a:off x="704850" y="3956114"/>
             <a:ext cx="57150" cy="57150"/>
           </a:xfrm>
           <a:prstGeom prst="rect">
@@ -19620,7 +19620,7 @@
         </p:nvSpPr>
         <p:spPr>
           <a:xfrm>
-            <a:off x="971550" y="3720084"/>
+            <a:off x="971550" y="3852100"/>
             <a:ext cx="4857750" cy="95250"/>
           </a:xfrm>
           <a:prstGeom prst="rect">
@@ -19659,7 +19659,7 @@
         </p:nvSpPr>
         <p:spPr>
           <a:xfrm>
-            <a:off x="704850" y="5146929"/>
+            <a:off x="704850" y="5278945"/>
             <a:ext cx="57150" cy="57150"/>
           </a:xfrm>
           <a:prstGeom prst="rect">
@@ -19703,7 +19703,7 @@
         </p:nvSpPr>
         <p:spPr>
           <a:xfrm>
-            <a:off x="971550" y="5042916"/>
+            <a:off x="971550" y="5174932"/>
             <a:ext cx="4857750" cy="95250"/>
           </a:xfrm>
           <a:prstGeom prst="rect">
@@ -19729,7 +19729,7 @@
                 </a:solidFill>
                 <a:latin typeface="Roboto"/>
               </a:rPr>
-              <a:t>Uma regra que só existe escrita depende de alguém lembrar de aplicar. Na topologia ela é garantida pela estrutura.</a:t>
+              <a:t>Uma regra só documentada depende de revisão manual. Na topologia ela é imposta pela estrutura.</a:t>
             </a:r>
           </a:p>
         </p:txBody>
@@ -19742,7 +19742,7 @@
         </p:nvSpPr>
         <p:spPr>
           <a:xfrm>
-            <a:off x="6362700" y="1899285"/>
+            <a:off x="6362700" y="2031302"/>
             <a:ext cx="5143500" cy="182880"/>
           </a:xfrm>
           <a:prstGeom prst="rect">
@@ -19781,7 +19781,7 @@
         </p:nvSpPr>
         <p:spPr>
           <a:xfrm>
-            <a:off x="6362700" y="2108835"/>
+            <a:off x="6362700" y="2240852"/>
             <a:ext cx="419100" cy="28575"/>
           </a:xfrm>
           <a:prstGeom prst="rect">
@@ -19825,7 +19825,7 @@
         </p:nvSpPr>
         <p:spPr>
           <a:xfrm>
-            <a:off x="6381750" y="2498598"/>
+            <a:off x="6381750" y="2630614"/>
             <a:ext cx="57150" cy="57150"/>
           </a:xfrm>
           <a:prstGeom prst="rect">
@@ -19869,7 +19869,7 @@
         </p:nvSpPr>
         <p:spPr>
           <a:xfrm>
-            <a:off x="6648450" y="2394585"/>
+            <a:off x="6648450" y="2526602"/>
             <a:ext cx="4857750" cy="95250"/>
           </a:xfrm>
           <a:prstGeom prst="rect">
@@ -19908,7 +19908,7 @@
         </p:nvSpPr>
         <p:spPr>
           <a:xfrm>
-            <a:off x="6381750" y="3557397"/>
+            <a:off x="6381750" y="3689414"/>
             <a:ext cx="57150" cy="57150"/>
           </a:xfrm>
           <a:prstGeom prst="rect">
@@ -19952,7 +19952,7 @@
         </p:nvSpPr>
         <p:spPr>
           <a:xfrm>
-            <a:off x="6648450" y="3453384"/>
+            <a:off x="6648450" y="3585400"/>
             <a:ext cx="4857750" cy="95250"/>
           </a:xfrm>
           <a:prstGeom prst="rect">
@@ -19978,7 +19978,7 @@
                 </a:solidFill>
                 <a:latin typeface="Roboto"/>
               </a:rPr>
-              <a:t>Onde há separação, o acoplamento não some, muda de forma e passa a ter latência, falha parcial e ordem de subida.</a:t>
+              <a:t>Onde há separação, o acoplamento continua, agora com latência, falha parcial e ordem de subida.</a:t>
             </a:r>
           </a:p>
         </p:txBody>
@@ -20327,7 +20327,7 @@
                 </a:solidFill>
                 <a:latin typeface="Roboto"/>
               </a:rPr>
-              <a:t>Replicar só o serviço público faz sentido, e replicar o painel não faz.</a:t>
+              <a:t>Só o serviço público precisa de réplicas. O painel não.</a:t>
             </a:r>
           </a:p>
         </p:txBody>
@@ -20909,7 +20909,7 @@
                 </a:solidFill>
                 <a:latin typeface="Roboto"/>
               </a:rPr>
-              <a:t>A pergunta desta apresentação é como esses componentes serão distribuídos e implantados no ambiente de execução.</a:t>
+              <a:t>Como esses componentes serão distribuídos e implantados no ambiente de execução.</a:t>
             </a:r>
           </a:p>
         </p:txBody>
@@ -21160,7 +21160,7 @@
                 </a:solidFill>
                 <a:latin typeface="Roboto"/>
               </a:rPr>
-              <a:t>A decisão em jogo é em quantos processos separados elas rodam.</a:t>
+              <a:t>A decisão é em quantos processos separados elas rodam.</a:t>
             </a:r>
           </a:p>
         </p:txBody>
@@ -22446,7 +22446,7 @@
                 </a:solidFill>
                 <a:latin typeface="Roboto"/>
               </a:rPr>
-              <a:t>A imagem de fundo que a anfitriã envia ao personalizar o convite e o CSV de restrições alimentares que ela exporta não podem morrer junto com o container. A decisão de implantação volta como restrição de projeto para as camadas de cima.</a:t>
+              <a:t>A imagem de fundo que a anfitriã envia ao personalizar o convite e o CSV de restrições alimentares que ela exporta não podem ser perdidos quando o container é removido. A decisão de implantação impõe uma restrição às camadas superiores.</a:t>
             </a:r>
           </a:p>
         </p:txBody>
@@ -23124,7 +23124,7 @@
                 </a:solidFill>
                 <a:latin typeface="Roboto"/>
               </a:rPr>
-              <a:t>Container com estado traz junto o problema de backup e o de upgrade de versão maior do banco, que não somem por estar em imagem.</a:t>
+              <a:t>Container com estado exige backup e upgrade de versão maior do banco. Estar em imagem não resolve isso.</a:t>
             </a:r>
           </a:p>
         </p:txBody>
@@ -25633,7 +25633,7 @@
                 </a:solidFill>
                 <a:latin typeface="Roboto"/>
               </a:rPr>
-              <a:t>A CVE-2019-5736 mostrou o risco na prática: o processo de dentro conseguia sobrescrever o binário do runtime. Por isso o documento de decisões arquiteturais precisa registrar que container não dá o mesmo isolamento de uma máquina virtual.</a:t>
+              <a:t>A CVE-2019-5736 confirmou o risco: o processo de dentro conseguia sobrescrever o binário do runtime. Por isso o documento de decisões arquiteturais precisa registrar que container não dá o mesmo isolamento de uma máquina virtual.</a:t>
             </a:r>
           </a:p>
         </p:txBody>
@@ -27065,7 +27065,7 @@
                 </a:solidFill>
                 <a:latin typeface="Roboto"/>
               </a:rPr>
-              <a:t>O segundo é o time sem integração contínua, que só ganha um passo de build a mais.</a:t>
+              <a:t>O segundo é o time sem integração contínua, que só acrescenta um passo de build.</a:t>
             </a:r>
           </a:p>
         </p:txBody>
@@ -27480,7 +27480,7 @@
                 </a:solidFill>
                 <a:latin typeface="Roboto"/>
               </a:rPr>
-              <a:t>O que resta é o motivo que abriu a apresentação: o ambiente igual para os quatro antes da primeira linha de código.</a:t>
+              <a:t>O motivo que se aplica é o ambiente igual para os quatro antes da primeira linha de código.</a:t>
             </a:r>
           </a:p>
         </p:txBody>
@@ -27660,7 +27660,7 @@
         </p:nvSpPr>
         <p:spPr>
           <a:xfrm>
-            <a:off x="685800" y="1866900"/>
+            <a:off x="685800" y="1992630"/>
             <a:ext cx="5143500" cy="182880"/>
           </a:xfrm>
           <a:prstGeom prst="rect">
@@ -27686,7 +27686,7 @@
                 </a:solidFill>
                 <a:latin typeface="Roboto"/>
               </a:rPr>
-              <a:t>GANHA</a:t>
+              <a:t>VANTAGENS</a:t>
             </a:r>
           </a:p>
         </p:txBody>
@@ -27699,7 +27699,7 @@
         </p:nvSpPr>
         <p:spPr>
           <a:xfrm>
-            <a:off x="685800" y="2076450"/>
+            <a:off x="685800" y="2202180"/>
             <a:ext cx="419100" cy="28575"/>
           </a:xfrm>
           <a:prstGeom prst="rect">
@@ -27743,7 +27743,7 @@
         </p:nvSpPr>
         <p:spPr>
           <a:xfrm>
-            <a:off x="704850" y="2461260"/>
+            <a:off x="704850" y="2586990"/>
             <a:ext cx="57150" cy="57150"/>
           </a:xfrm>
           <a:prstGeom prst="rect">
@@ -27787,7 +27787,7 @@
         </p:nvSpPr>
         <p:spPr>
           <a:xfrm>
-            <a:off x="971550" y="2362200"/>
+            <a:off x="971550" y="2487930"/>
             <a:ext cx="4857750" cy="95250"/>
           </a:xfrm>
           <a:prstGeom prst="rect">
@@ -27826,7 +27826,7 @@
         </p:nvSpPr>
         <p:spPr>
           <a:xfrm>
-            <a:off x="704850" y="3211830"/>
+            <a:off x="704850" y="3337560"/>
             <a:ext cx="57150" cy="57150"/>
           </a:xfrm>
           <a:prstGeom prst="rect">
@@ -27870,7 +27870,7 @@
         </p:nvSpPr>
         <p:spPr>
           <a:xfrm>
-            <a:off x="971550" y="3112770"/>
+            <a:off x="971550" y="3238500"/>
             <a:ext cx="4857750" cy="95250"/>
           </a:xfrm>
           <a:prstGeom prst="rect">
@@ -27896,7 +27896,7 @@
                 </a:solidFill>
                 <a:latin typeface="Roboto"/>
               </a:rPr>
-              <a:t>O ambiente vira arquivo legível, versionado junto com o código.</a:t>
+              <a:t>O ambiente fica descrito num arquivo legível, versionado junto com o código.</a:t>
             </a:r>
           </a:p>
         </p:txBody>
@@ -27909,7 +27909,7 @@
         </p:nvSpPr>
         <p:spPr>
           <a:xfrm>
-            <a:off x="704850" y="3962400"/>
+            <a:off x="704850" y="4088130"/>
             <a:ext cx="57150" cy="57150"/>
           </a:xfrm>
           <a:prstGeom prst="rect">
@@ -27953,7 +27953,7 @@
         </p:nvSpPr>
         <p:spPr>
           <a:xfrm>
-            <a:off x="971550" y="3863340"/>
+            <a:off x="971550" y="3989070"/>
             <a:ext cx="4857750" cy="95250"/>
           </a:xfrm>
           <a:prstGeom prst="rect">
@@ -27979,7 +27979,7 @@
                 </a:solidFill>
                 <a:latin typeface="Roboto"/>
               </a:rPr>
-              <a:t>Trocar runtime ou banco passa a ser editar uma linha de arquivo.</a:t>
+              <a:t>Trocar runtime ou banco é editar uma linha do arquivo.</a:t>
             </a:r>
           </a:p>
         </p:txBody>
@@ -27992,7 +27992,7 @@
         </p:nvSpPr>
         <p:spPr>
           <a:xfrm>
-            <a:off x="704850" y="4712970"/>
+            <a:off x="704850" y="4587240"/>
             <a:ext cx="57150" cy="57150"/>
           </a:xfrm>
           <a:prstGeom prst="rect">
@@ -28036,7 +28036,7 @@
         </p:nvSpPr>
         <p:spPr>
           <a:xfrm>
-            <a:off x="971550" y="4613910"/>
+            <a:off x="971550" y="4488180"/>
             <a:ext cx="4857750" cy="95250"/>
           </a:xfrm>
           <a:prstGeom prst="rect">
@@ -28062,7 +28062,7 @@
                 </a:solidFill>
                 <a:latin typeface="Roboto"/>
               </a:rPr>
-              <a:t>A mesma imagem atravessa notebook, pipeline e a apresentação do projeto mais adiante.</a:t>
+              <a:t>A mesma imagem roda no notebook, no pipeline e na apresentação do produto.</a:t>
             </a:r>
           </a:p>
         </p:txBody>
@@ -28075,7 +28075,7 @@
         </p:nvSpPr>
         <p:spPr>
           <a:xfrm>
-            <a:off x="704850" y="5463540"/>
+            <a:off x="704850" y="5337810"/>
             <a:ext cx="57150" cy="57150"/>
           </a:xfrm>
           <a:prstGeom prst="rect">
@@ -28119,7 +28119,7 @@
         </p:nvSpPr>
         <p:spPr>
           <a:xfrm>
-            <a:off x="971550" y="5364480"/>
+            <a:off x="971550" y="5238750"/>
             <a:ext cx="4857750" cy="95250"/>
           </a:xfrm>
           <a:prstGeom prst="rect">
@@ -28158,7 +28158,7 @@
         </p:nvSpPr>
         <p:spPr>
           <a:xfrm>
-            <a:off x="6362700" y="1866900"/>
+            <a:off x="6362700" y="1992630"/>
             <a:ext cx="5143500" cy="182880"/>
           </a:xfrm>
           <a:prstGeom prst="rect">
@@ -28184,7 +28184,7 @@
                 </a:solidFill>
                 <a:latin typeface="Roboto"/>
               </a:rPr>
-              <a:t>CUSTA</a:t>
+              <a:t>CUSTOS</a:t>
             </a:r>
           </a:p>
         </p:txBody>
@@ -28197,7 +28197,7 @@
         </p:nvSpPr>
         <p:spPr>
           <a:xfrm>
-            <a:off x="6362700" y="2076450"/>
+            <a:off x="6362700" y="2202180"/>
             <a:ext cx="419100" cy="28575"/>
           </a:xfrm>
           <a:prstGeom prst="rect">
@@ -28241,7 +28241,7 @@
         </p:nvSpPr>
         <p:spPr>
           <a:xfrm>
-            <a:off x="6381750" y="2461260"/>
+            <a:off x="6381750" y="2586990"/>
             <a:ext cx="57150" cy="57150"/>
           </a:xfrm>
           <a:prstGeom prst="rect">
@@ -28285,7 +28285,7 @@
         </p:nvSpPr>
         <p:spPr>
           <a:xfrm>
-            <a:off x="6648450" y="2362200"/>
+            <a:off x="6648450" y="2487930"/>
             <a:ext cx="4857750" cy="95250"/>
           </a:xfrm>
           <a:prstGeom prst="rect">
@@ -28324,7 +28324,7 @@
         </p:nvSpPr>
         <p:spPr>
           <a:xfrm>
-            <a:off x="6381750" y="3211830"/>
+            <a:off x="6381750" y="3337560"/>
             <a:ext cx="57150" cy="57150"/>
           </a:xfrm>
           <a:prstGeom prst="rect">
@@ -28368,7 +28368,7 @@
         </p:nvSpPr>
         <p:spPr>
           <a:xfrm>
-            <a:off x="6648450" y="3112770"/>
+            <a:off x="6648450" y="3238500"/>
             <a:ext cx="4857750" cy="95250"/>
           </a:xfrm>
           <a:prstGeom prst="rect">
@@ -28965,7 +28965,7 @@
                 </a:solidFill>
                 <a:latin typeface="Roboto"/>
               </a:rPr>
-              <a:t>Uma linha no repositório, porque sem ela o Git Bash quebra no Windows. Os ambientes do time já divergiam antes da primeira linha de código do produto.</a:t>
+              <a:t>Uma linha no repositório, necessária porque o Git Bash falha no Windows sem ela. Os ambientes do time já divergiam antes do primeiro código do produto.</a:t>
             </a:r>
           </a:p>
         </p:txBody>
@@ -29369,7 +29369,7 @@
                 </a:solidFill>
                 <a:latin typeface="Roboto"/>
               </a:rPr>
-              <a:t>Um arquivo que descreve o ambiente inteiro e que qualquer um dos quatro sobe com um comando. É ele que vira o diagrama de implantação.</a:t>
+              <a:t>Um arquivo que descreve o ambiente inteiro e que qualquer um dos quatro sobe com um comando. Esse arquivo é a base do diagrama de implantação.</a:t>
             </a:r>
           </a:p>
         </p:txBody>
@@ -30380,7 +30380,7 @@
         </p:nvSpPr>
         <p:spPr>
           <a:xfrm>
-            <a:off x="704850" y="2860548"/>
+            <a:off x="704850" y="2998851"/>
             <a:ext cx="57150" cy="57150"/>
           </a:xfrm>
           <a:prstGeom prst="rect">
@@ -30424,7 +30424,7 @@
         </p:nvSpPr>
         <p:spPr>
           <a:xfrm>
-            <a:off x="971550" y="2751582"/>
+            <a:off x="971550" y="2889885"/>
             <a:ext cx="9677400" cy="95250"/>
           </a:xfrm>
           <a:prstGeom prst="rect">
@@ -30463,7 +30463,7 @@
         </p:nvSpPr>
         <p:spPr>
           <a:xfrm>
-            <a:off x="704850" y="3699510"/>
+            <a:off x="704850" y="3837813"/>
             <a:ext cx="57150" cy="57150"/>
           </a:xfrm>
           <a:prstGeom prst="rect">
@@ -30507,7 +30507,7 @@
         </p:nvSpPr>
         <p:spPr>
           <a:xfrm>
-            <a:off x="971550" y="3590544"/>
+            <a:off x="971550" y="3728847"/>
             <a:ext cx="9677400" cy="95250"/>
           </a:xfrm>
           <a:prstGeom prst="rect">
@@ -30546,7 +30546,7 @@
         </p:nvSpPr>
         <p:spPr>
           <a:xfrm>
-            <a:off x="704850" y="4538472"/>
+            <a:off x="704850" y="4676775"/>
             <a:ext cx="57150" cy="57150"/>
           </a:xfrm>
           <a:prstGeom prst="rect">
@@ -30590,7 +30590,7 @@
         </p:nvSpPr>
         <p:spPr>
           <a:xfrm>
-            <a:off x="971550" y="4429506"/>
+            <a:off x="971550" y="4567809"/>
             <a:ext cx="9677400" cy="95250"/>
           </a:xfrm>
           <a:prstGeom prst="rect">
@@ -30616,7 +30616,7 @@
                 </a:solidFill>
                 <a:latin typeface="Roboto"/>
               </a:rPr>
-              <a:t>Mais adiante, o mesmo ambiente que rodou no desenvolvimento também na entrega e na apresentação do produto.</a:t>
+              <a:t>Na entrega e na apresentação do produto, o mesmo ambiente do desenvolvimento.</a:t>
             </a:r>
           </a:p>
         </p:txBody>
@@ -32107,7 +32107,7 @@
                 </a:solidFill>
                 <a:latin typeface="Roboto"/>
               </a:rPr>
-              <a:t>O isolamento de processos existe desde 1979. O que é recente é a padronização da cadeia de execução, a partir de 2015.</a:t>
+              <a:t>O isolamento de processos existe desde 1979. A padronização da cadeia de execução é de 2015.</a:t>
             </a:r>
           </a:p>
         </p:txBody>
@@ -32287,7 +32287,7 @@
         </p:nvSpPr>
         <p:spPr>
           <a:xfrm>
-            <a:off x="685800" y="2562034"/>
+            <a:off x="685800" y="2694051"/>
             <a:ext cx="5143500" cy="182880"/>
           </a:xfrm>
           <a:prstGeom prst="rect">
@@ -32326,7 +32326,7 @@
         </p:nvSpPr>
         <p:spPr>
           <a:xfrm>
-            <a:off x="685800" y="2771584"/>
+            <a:off x="685800" y="2903601"/>
             <a:ext cx="419100" cy="28575"/>
           </a:xfrm>
           <a:prstGeom prst="rect">
@@ -32370,7 +32370,7 @@
         </p:nvSpPr>
         <p:spPr>
           <a:xfrm>
-            <a:off x="704850" y="3161348"/>
+            <a:off x="704850" y="3293364"/>
             <a:ext cx="57150" cy="57150"/>
           </a:xfrm>
           <a:prstGeom prst="rect">
@@ -32414,7 +32414,7 @@
         </p:nvSpPr>
         <p:spPr>
           <a:xfrm>
-            <a:off x="971550" y="3057334"/>
+            <a:off x="971550" y="3189351"/>
             <a:ext cx="4857750" cy="95250"/>
           </a:xfrm>
           <a:prstGeom prst="rect">
@@ -32453,7 +32453,7 @@
         </p:nvSpPr>
         <p:spPr>
           <a:xfrm>
-            <a:off x="6362700" y="2562034"/>
+            <a:off x="6362700" y="2694051"/>
             <a:ext cx="5143500" cy="182880"/>
           </a:xfrm>
           <a:prstGeom prst="rect">
@@ -32492,7 +32492,7 @@
         </p:nvSpPr>
         <p:spPr>
           <a:xfrm>
-            <a:off x="6362700" y="2771584"/>
+            <a:off x="6362700" y="2903601"/>
             <a:ext cx="419100" cy="28575"/>
           </a:xfrm>
           <a:prstGeom prst="rect">
@@ -32536,7 +32536,7 @@
         </p:nvSpPr>
         <p:spPr>
           <a:xfrm>
-            <a:off x="6381750" y="3161348"/>
+            <a:off x="6381750" y="3293364"/>
             <a:ext cx="57150" cy="57150"/>
           </a:xfrm>
           <a:prstGeom prst="rect">
@@ -32580,7 +32580,7 @@
         </p:nvSpPr>
         <p:spPr>
           <a:xfrm>
-            <a:off x="6648450" y="3057334"/>
+            <a:off x="6648450" y="3189351"/>
             <a:ext cx="4857750" cy="95250"/>
           </a:xfrm>
           <a:prstGeom prst="rect">
@@ -32619,7 +32619,7 @@
         </p:nvSpPr>
         <p:spPr>
           <a:xfrm>
-            <a:off x="6381750" y="4484180"/>
+            <a:off x="6381750" y="4616196"/>
             <a:ext cx="57150" cy="57150"/>
           </a:xfrm>
           <a:prstGeom prst="rect">
@@ -32663,7 +32663,7 @@
         </p:nvSpPr>
         <p:spPr>
           <a:xfrm>
-            <a:off x="6648450" y="4380166"/>
+            <a:off x="6648450" y="4512183"/>
             <a:ext cx="4857750" cy="95250"/>
           </a:xfrm>
           <a:prstGeom prst="rect">
@@ -32689,7 +32689,7 @@
                 </a:solidFill>
                 <a:latin typeface="Roboto"/>
               </a:rPr>
-              <a:t>São essas duas definições que decidem o desenho do diagrama de implantação, com a imagem entrando como artefato e o container como nó.</a:t>
+              <a:t>No diagrama de implantação, a imagem é artefato e o container é nó.</a:t>
             </a:r>
           </a:p>
         </p:txBody>
@@ -32885,7 +32885,7 @@
         </p:nvSpPr>
         <p:spPr>
           <a:xfrm>
-            <a:off x="685800" y="1845945"/>
+            <a:off x="685800" y="1940242"/>
             <a:ext cx="10820400" cy="3286125"/>
           </a:xfrm>
           <a:prstGeom prst="roundRect">
@@ -32931,7 +32931,7 @@
         </p:nvSpPr>
         <p:spPr>
           <a:xfrm>
-            <a:off x="952500" y="2055495"/>
+            <a:off x="952500" y="2149792"/>
             <a:ext cx="323850" cy="28575"/>
           </a:xfrm>
           <a:prstGeom prst="roundRect">
@@ -32977,7 +32977,7 @@
         </p:nvSpPr>
         <p:spPr>
           <a:xfrm>
-            <a:off x="1371600" y="1998345"/>
+            <a:off x="1371600" y="2092642"/>
             <a:ext cx="1905000" cy="167640"/>
           </a:xfrm>
           <a:prstGeom prst="rect">
@@ -33016,7 +33016,7 @@
         </p:nvSpPr>
         <p:spPr>
           <a:xfrm>
-            <a:off x="952500" y="2341245"/>
+            <a:off x="952500" y="2435542"/>
             <a:ext cx="10287000" cy="228600"/>
           </a:xfrm>
           <a:prstGeom prst="rect">
@@ -33055,7 +33055,7 @@
         </p:nvSpPr>
         <p:spPr>
           <a:xfrm>
-            <a:off x="952500" y="2579370"/>
+            <a:off x="952500" y="2673668"/>
             <a:ext cx="10287000" cy="228600"/>
           </a:xfrm>
           <a:prstGeom prst="rect">
@@ -33094,7 +33094,7 @@
         </p:nvSpPr>
         <p:spPr>
           <a:xfrm>
-            <a:off x="952500" y="2817495"/>
+            <a:off x="952500" y="2911792"/>
             <a:ext cx="10287000" cy="228600"/>
           </a:xfrm>
           <a:prstGeom prst="rect">
@@ -33133,7 +33133,7 @@
         </p:nvSpPr>
         <p:spPr>
           <a:xfrm>
-            <a:off x="952500" y="3055620"/>
+            <a:off x="952500" y="3149918"/>
             <a:ext cx="10287000" cy="228600"/>
           </a:xfrm>
           <a:prstGeom prst="rect">
@@ -33172,7 +33172,7 @@
         </p:nvSpPr>
         <p:spPr>
           <a:xfrm>
-            <a:off x="952500" y="3293745"/>
+            <a:off x="952500" y="3388042"/>
             <a:ext cx="10287000" cy="228600"/>
           </a:xfrm>
           <a:prstGeom prst="rect">
@@ -33211,7 +33211,7 @@
         </p:nvSpPr>
         <p:spPr>
           <a:xfrm>
-            <a:off x="952500" y="3531870"/>
+            <a:off x="952500" y="3626168"/>
             <a:ext cx="10287000" cy="228600"/>
           </a:xfrm>
           <a:prstGeom prst="rect">
@@ -33250,7 +33250,7 @@
         </p:nvSpPr>
         <p:spPr>
           <a:xfrm>
-            <a:off x="952500" y="3769995"/>
+            <a:off x="952500" y="3864292"/>
             <a:ext cx="10287000" cy="228600"/>
           </a:xfrm>
           <a:prstGeom prst="rect">
@@ -33289,7 +33289,7 @@
         </p:nvSpPr>
         <p:spPr>
           <a:xfrm>
-            <a:off x="952500" y="4008120"/>
+            <a:off x="952500" y="4102418"/>
             <a:ext cx="10287000" cy="228600"/>
           </a:xfrm>
           <a:prstGeom prst="rect">
@@ -33328,7 +33328,7 @@
         </p:nvSpPr>
         <p:spPr>
           <a:xfrm>
-            <a:off x="952500" y="4246245"/>
+            <a:off x="952500" y="4340542"/>
             <a:ext cx="10287000" cy="228600"/>
           </a:xfrm>
           <a:prstGeom prst="rect">
@@ -33367,7 +33367,7 @@
         </p:nvSpPr>
         <p:spPr>
           <a:xfrm>
-            <a:off x="952500" y="4484370"/>
+            <a:off x="952500" y="4578668"/>
             <a:ext cx="10287000" cy="228600"/>
           </a:xfrm>
           <a:prstGeom prst="rect">
@@ -33406,7 +33406,7 @@
         </p:nvSpPr>
         <p:spPr>
           <a:xfrm>
-            <a:off x="952500" y="4722495"/>
+            <a:off x="952500" y="4816792"/>
             <a:ext cx="10287000" cy="228600"/>
           </a:xfrm>
           <a:prstGeom prst="rect">
@@ -33445,8 +33445,8 @@
         </p:nvSpPr>
         <p:spPr>
           <a:xfrm>
-            <a:off x="685800" y="5360670"/>
-            <a:ext cx="28575" cy="565785"/>
+            <a:off x="685800" y="5454968"/>
+            <a:ext cx="28575" cy="377190"/>
           </a:xfrm>
           <a:prstGeom prst="rect">
             <a:avLst/>
@@ -33489,7 +33489,7 @@
         </p:nvSpPr>
         <p:spPr>
           <a:xfrm>
-            <a:off x="876300" y="5341620"/>
+            <a:off x="876300" y="5435918"/>
             <a:ext cx="10629900" cy="666750"/>
           </a:xfrm>
           <a:prstGeom prst="rect">
@@ -33515,7 +33515,7 @@
                 </a:solidFill>
                 <a:latin typeface="Roboto"/>
               </a:rPr>
-              <a:t>Namespaces e cgroups são recursos do kernel Linux, então no Windows o Docker Desktop roda o engine sobre o WSL2, que fornece um kernel Linux real numa máquina virtual leve. Esta saída é dessa distro. O mesmo processo tem PID 1 dentro do container e outro PID no host, que é o que o namespace de PID faz. É por isso que no nosso diagrama de implantação o container aparece dentro do host, e não como máquina separada.</a:t>
+              <a:t>Namespaces e cgroups são recursos do kernel Linux. No Windows, o Docker Desktop roda o engine sobre o WSL2, uma máquina virtual leve com kernel Linux. O mesmo processo tem PID 1 dentro do container e outro PID no host. Por isso, no diagrama de implantação, o container fica dentro do nó do host.</a:t>
             </a:r>
           </a:p>
         </p:txBody>
@@ -34362,7 +34362,7 @@
                 </a:solidFill>
                 <a:latin typeface="Roboto"/>
               </a:rPr>
-              <a:t>Quando o processo estoura o limite de memória ele não fica lento, o kernel mata ele.</a:t>
+              <a:t>Estourar o limite de memória encerra o processo. Ele não fica lento.</a:t>
             </a:r>
           </a:p>
         </p:txBody>
@@ -34445,7 +34445,7 @@
                 </a:solidFill>
                 <a:latin typeface="Roboto"/>
               </a:rPr>
-              <a:t>O limite de CPU não mata, freia. Piora as requisições mais lentas e quase não mexe na média, por isso passa despercebido.</a:t>
+              <a:t>O limite de CPU só reduz a velocidade. As requisições mais lentas pioram e a média quase não muda.</a:t>
             </a:r>
           </a:p>
         </p:txBody>
@@ -34625,7 +34625,7 @@
         </p:nvSpPr>
         <p:spPr>
           <a:xfrm>
-            <a:off x="857250" y="2076450"/>
+            <a:off x="857250" y="2200275"/>
             <a:ext cx="4381500" cy="167640"/>
           </a:xfrm>
           <a:prstGeom prst="rect">
@@ -34664,7 +34664,7 @@
         </p:nvSpPr>
         <p:spPr>
           <a:xfrm>
-            <a:off x="857250" y="3790950"/>
+            <a:off x="857250" y="3914775"/>
             <a:ext cx="3429000" cy="438150"/>
           </a:xfrm>
           <a:prstGeom prst="roundRect">
@@ -34712,7 +34712,7 @@
         </p:nvSpPr>
         <p:spPr>
           <a:xfrm>
-            <a:off x="1047750" y="3924300"/>
+            <a:off x="1047750" y="4048125"/>
             <a:ext cx="3048000" cy="213360"/>
           </a:xfrm>
           <a:prstGeom prst="rect">
@@ -34751,7 +34751,7 @@
         </p:nvSpPr>
         <p:spPr>
           <a:xfrm>
-            <a:off x="857250" y="3295650"/>
+            <a:off x="857250" y="3419475"/>
             <a:ext cx="3429000" cy="438150"/>
           </a:xfrm>
           <a:prstGeom prst="roundRect">
@@ -34799,7 +34799,7 @@
         </p:nvSpPr>
         <p:spPr>
           <a:xfrm>
-            <a:off x="1047750" y="3429000"/>
+            <a:off x="1047750" y="3552825"/>
             <a:ext cx="3048000" cy="213360"/>
           </a:xfrm>
           <a:prstGeom prst="rect">
@@ -34838,7 +34838,7 @@
         </p:nvSpPr>
         <p:spPr>
           <a:xfrm>
-            <a:off x="857250" y="2800350"/>
+            <a:off x="857250" y="2924175"/>
             <a:ext cx="3429000" cy="438150"/>
           </a:xfrm>
           <a:prstGeom prst="roundRect">
@@ -34886,7 +34886,7 @@
         </p:nvSpPr>
         <p:spPr>
           <a:xfrm>
-            <a:off x="1047750" y="2933700"/>
+            <a:off x="1047750" y="3057525"/>
             <a:ext cx="3048000" cy="213360"/>
           </a:xfrm>
           <a:prstGeom prst="rect">
@@ -34925,7 +34925,7 @@
         </p:nvSpPr>
         <p:spPr>
           <a:xfrm>
-            <a:off x="4400550" y="2800350"/>
+            <a:off x="4400550" y="2924175"/>
             <a:ext cx="28575" cy="1428750"/>
           </a:xfrm>
           <a:prstGeom prst="rect">
@@ -34969,7 +34969,7 @@
         </p:nvSpPr>
         <p:spPr>
           <a:xfrm>
-            <a:off x="742950" y="4362450"/>
+            <a:off x="742950" y="4486275"/>
             <a:ext cx="3657600" cy="381000"/>
           </a:xfrm>
           <a:prstGeom prst="rect">
@@ -35008,7 +35008,7 @@
         </p:nvSpPr>
         <p:spPr>
           <a:xfrm>
-            <a:off x="857250" y="2247900"/>
+            <a:off x="857250" y="2371725"/>
             <a:ext cx="3429000" cy="495300"/>
           </a:xfrm>
           <a:prstGeom prst="roundRect">
@@ -35057,7 +35057,7 @@
         </p:nvSpPr>
         <p:spPr>
           <a:xfrm>
-            <a:off x="1047750" y="2343150"/>
+            <a:off x="1047750" y="2466975"/>
             <a:ext cx="3048000" cy="213360"/>
           </a:xfrm>
           <a:prstGeom prst="rect">
@@ -35096,7 +35096,7 @@
         </p:nvSpPr>
         <p:spPr>
           <a:xfrm>
-            <a:off x="1047750" y="2524125"/>
+            <a:off x="1047750" y="2647950"/>
             <a:ext cx="3048000" cy="182880"/>
           </a:xfrm>
           <a:prstGeom prst="rect">
@@ -35122,7 +35122,7 @@
                 </a:solidFill>
                 <a:latin typeface="Roboto"/>
               </a:rPr>
-              <a:t>criada pelo container, morre com ele</a:t>
+              <a:t>criada pelo container, removida com ele</a:t>
             </a:r>
           </a:p>
         </p:txBody>
@@ -35135,7 +35135,7 @@
         </p:nvCxnSpPr>
         <p:spPr>
           <a:xfrm>
-            <a:off x="4857750" y="2190750"/>
+            <a:off x="4857750" y="2314575"/>
             <a:ext cx="0" cy="2152650"/>
           </a:xfrm>
           <a:prstGeom prst="line">
@@ -35170,7 +35170,7 @@
         </p:nvSpPr>
         <p:spPr>
           <a:xfrm>
-            <a:off x="5257800" y="2647950"/>
+            <a:off x="5257800" y="2771775"/>
             <a:ext cx="3619500" cy="243840"/>
           </a:xfrm>
           <a:prstGeom prst="rect">
@@ -35209,7 +35209,7 @@
         </p:nvSpPr>
         <p:spPr>
           <a:xfrm>
-            <a:off x="5257800" y="2914650"/>
+            <a:off x="5257800" y="3038475"/>
             <a:ext cx="3810000" cy="666750"/>
           </a:xfrm>
           <a:prstGeom prst="rect">
@@ -35248,7 +35248,7 @@
         </p:nvSpPr>
         <p:spPr>
           <a:xfrm>
-            <a:off x="5257800" y="3486150"/>
+            <a:off x="5257800" y="3609975"/>
             <a:ext cx="3619500" cy="243840"/>
           </a:xfrm>
           <a:prstGeom prst="rect">
@@ -35287,7 +35287,7 @@
         </p:nvSpPr>
         <p:spPr>
           <a:xfrm>
-            <a:off x="5257800" y="3752850"/>
+            <a:off x="5257800" y="3876675"/>
             <a:ext cx="3810000" cy="666750"/>
           </a:xfrm>
           <a:prstGeom prst="rect">
@@ -35326,8 +35326,8 @@
         </p:nvSpPr>
         <p:spPr>
           <a:xfrm>
-            <a:off x="685800" y="5428381"/>
-            <a:ext cx="28575" cy="705719"/>
+            <a:off x="685800" y="5676321"/>
+            <a:ext cx="28575" cy="457779"/>
           </a:xfrm>
           <a:prstGeom prst="rect">
             <a:avLst/>
@@ -35370,8 +35370,8 @@
         </p:nvSpPr>
         <p:spPr>
           <a:xfrm>
-            <a:off x="876300" y="5409331"/>
-            <a:ext cx="10629900" cy="839069"/>
+            <a:off x="876300" y="5657271"/>
+            <a:ext cx="10629900" cy="591129"/>
           </a:xfrm>
           <a:prstGeom prst="rect">
             <a:avLst/>
@@ -35396,7 +35396,7 @@
                 </a:solidFill>
                 <a:latin typeface="Roboto"/>
               </a:rPr>
-              <a:t>A imagem é construída a partir de um Dockerfile, o arquivo de texto que declara a base e os passos, e circula entre máquinas por um registry. Cada instrução vira uma camada, e por isso um Dockerfile que copia um .env e faz RUN rm na instrução seguinte produz uma imagem em que o segredo continua legível. No nosso caso o segredo seria a senha do banco e o segredo de sessão do login do anfitrião.</a:t>
+              <a:t>A imagem é construída a partir de um Dockerfile e distribuída por um registry. Cada instrução gera uma camada. Um Dockerfile que copia um .env e o apaga na instrução seguinte deixa o segredo legível na camada anterior. No nosso caso, a senha do banco e o segredo de sessão do anfitrião.</a:t>
             </a:r>
           </a:p>
         </p:txBody>

</xml_diff>

<commit_message>
docs: passada do humanizer nos textos de tela do T1
</commit_message>
<xml_diff>
--- a/trabalhos/T1-Docker-Invite-People.pptx
+++ b/trabalhos/T1-Docker-Invite-People.pptx
@@ -12949,7 +12949,7 @@
                 </a:solidFill>
                 <a:latin typeface="Roboto"/>
               </a:rPr>
-              <a:t>O shim é o processo pai do container, não o daemon. Reiniciar o daemon não encerra os containers.</a:t>
+              <a:t>O processo pai do container é o shim. Reiniciar o daemon não encerra os containers.</a:t>
             </a:r>
           </a:p>
         </p:txBody>
@@ -13710,7 +13710,7 @@
                 </a:solidFill>
                 <a:latin typeface="Roboto"/>
               </a:rPr>
-              <a:t>Fundada em 2015 sob a Linux Foundation, com a Runtime Spec, a Image Spec e a Distribution Spec. O runc é trocável por crun, gVisor ou Kata. O engine é trocável por Podman. É substituibilidade por compatibilidade de interface, e a seção 03 traz um caso real disso.</a:t>
+              <a:t>Fundada em 2015 sob a Linux Foundation, com a Runtime Spec, a Image Spec e a Distribution Spec. O runc pode ser trocado por crun, gVisor ou Kata, e o engine por Podman. É substituibilidade por compatibilidade de interface, e a seção 03 traz um caso real disso.</a:t>
             </a:r>
           </a:p>
         </p:txBody>
@@ -15999,7 +15999,7 @@
                 </a:solidFill>
                 <a:latin typeface="Roboto"/>
               </a:rPr>
-              <a:t> se refere às camadas do sistema de arquivos da imagem, não às camadas lógicas da arquitetura.</a:t>
+              <a:t> se refere às camadas do sistema de arquivos da imagem. A camada lógica da arquitetura é outro conceito.</a:t>
             </a:r>
           </a:p>
         </p:txBody>
@@ -18862,25 +18862,7 @@
                 </a:solidFill>
                 <a:latin typeface="Roboto"/>
               </a:rPr>
-              <a:t>A porta publicada mais o contrato HTTP é a </a:t>
-            </a:r>
-            <a:r>
-              <a:rPr sz="1280" b="1" i="0">
-                <a:solidFill>
-                  <a:srgbClr val="1A1A1E"/>
-                </a:solidFill>
-                <a:latin typeface="Roboto"/>
-              </a:rPr>
-              <a:t>interface provida</a:t>
-            </a:r>
-            <a:r>
-              <a:rPr sz="1280" b="0" i="0">
-                <a:solidFill>
-                  <a:srgbClr val="1A1A1E"/>
-                </a:solidFill>
-                <a:latin typeface="Roboto"/>
-              </a:rPr>
-              <a:t> da UML.</a:t>
+              <a:t>A porta publicada mais o contrato HTTP é a interface provida da UML.</a:t>
             </a:r>
           </a:p>
         </p:txBody>
@@ -18963,25 +18945,7 @@
                 </a:solidFill>
                 <a:latin typeface="Roboto"/>
               </a:rPr>
-              <a:t>A variável de conexão mais a dependência declarada é a </a:t>
-            </a:r>
-            <a:r>
-              <a:rPr sz="1280" b="1" i="0">
-                <a:solidFill>
-                  <a:srgbClr val="1A1A1E"/>
-                </a:solidFill>
-                <a:latin typeface="Roboto"/>
-              </a:rPr>
-              <a:t>interface requerida</a:t>
-            </a:r>
-            <a:r>
-              <a:rPr sz="1280" b="0" i="0">
-                <a:solidFill>
-                  <a:srgbClr val="1A1A1E"/>
-                </a:solidFill>
-                <a:latin typeface="Roboto"/>
-              </a:rPr>
-              <a:t>.</a:t>
+              <a:t>A variável de conexão mais a dependência declarada é a interface requerida.</a:t>
             </a:r>
           </a:p>
         </p:txBody>
@@ -20327,7 +20291,7 @@
                 </a:solidFill>
                 <a:latin typeface="Roboto"/>
               </a:rPr>
-              <a:t>Só o serviço público precisa de réplicas. O painel não.</a:t>
+              <a:t>Só o serviço público precisa de réplicas.</a:t>
             </a:r>
           </a:p>
         </p:txBody>
@@ -21597,7 +21561,7 @@
                 </a:solidFill>
                 <a:latin typeface="Roboto"/>
               </a:rPr>
-              <a:t>A demonstração é do ambiente e da topologia, não do produto. A implementação do produto começa em outubro.</a:t>
+              <a:t>A demonstração mostra o ambiente e a topologia. A implementação do produto começa em outubro.</a:t>
             </a:r>
           </a:p>
         </p:txBody>
@@ -22708,7 +22672,7 @@
                 </a:solidFill>
                 <a:latin typeface="Roboto"/>
               </a:rPr>
-              <a:t>O que saiu foi o adaptador embutido que falava com o Docker Engine, não o formato das imagens. Como imagem é OCI, nada quebrou. É um caso real de substituição por compatibilidade de interface.</a:t>
+              <a:t>Saiu o adaptador embutido que falava com o Docker Engine. O formato das imagens é o da OCI e continuou funcionando. É um caso real de substituição por compatibilidade de interface.</a:t>
             </a:r>
           </a:p>
         </p:txBody>
@@ -23041,7 +23005,7 @@
                 </a:solidFill>
                 <a:latin typeface="Roboto"/>
               </a:rPr>
-              <a:t>A regra de rede que o Docker escreve passa na frente da do administrador, então um deny de firewall na porta publicada não bloqueia nada.</a:t>
+              <a:t>A regra de rede que o Docker escreve é aplicada antes das regras do administrador, então um bloqueio de firewall na porta publicada não tem efeito.</a:t>
             </a:r>
           </a:p>
         </p:txBody>
@@ -23124,7 +23088,7 @@
                 </a:solidFill>
                 <a:latin typeface="Roboto"/>
               </a:rPr>
-              <a:t>Container com estado exige backup e upgrade de versão maior do banco. Estar em imagem não resolve isso.</a:t>
+              <a:t>Container com estado continua exigindo backup e upgrade de versão maior do banco.</a:t>
             </a:r>
           </a:p>
         </p:txBody>
@@ -26829,7 +26793,7 @@
         </p:nvSpPr>
         <p:spPr>
           <a:xfrm>
-            <a:off x="685800" y="2295334"/>
+            <a:off x="685800" y="2559368"/>
             <a:ext cx="5143500" cy="182880"/>
           </a:xfrm>
           <a:prstGeom prst="rect">
@@ -26868,7 +26832,7 @@
         </p:nvSpPr>
         <p:spPr>
           <a:xfrm>
-            <a:off x="685800" y="2504884"/>
+            <a:off x="685800" y="2768918"/>
             <a:ext cx="419100" cy="28575"/>
           </a:xfrm>
           <a:prstGeom prst="rect">
@@ -26912,7 +26876,7 @@
         </p:nvSpPr>
         <p:spPr>
           <a:xfrm>
-            <a:off x="704850" y="2894648"/>
+            <a:off x="704850" y="3158680"/>
             <a:ext cx="57150" cy="57150"/>
           </a:xfrm>
           <a:prstGeom prst="rect">
@@ -26956,7 +26920,7 @@
         </p:nvSpPr>
         <p:spPr>
           <a:xfrm>
-            <a:off x="971550" y="2790634"/>
+            <a:off x="971550" y="3054668"/>
             <a:ext cx="4857750" cy="95250"/>
           </a:xfrm>
           <a:prstGeom prst="rect">
@@ -26982,7 +26946,7 @@
                 </a:solidFill>
                 <a:latin typeface="Roboto"/>
               </a:rPr>
-              <a:t>O primeiro é o monolito que roda num servidor só e nunca vai escalar.</a:t>
+              <a:t>Um monolito num servidor só, que nunca vai escalar.</a:t>
             </a:r>
           </a:p>
         </p:txBody>
@@ -26995,7 +26959,7 @@
         </p:nvSpPr>
         <p:spPr>
           <a:xfrm>
-            <a:off x="704850" y="3689414"/>
+            <a:off x="704850" y="3689413"/>
             <a:ext cx="57150" cy="57150"/>
           </a:xfrm>
           <a:prstGeom prst="rect">
@@ -27065,7 +27029,7 @@
                 </a:solidFill>
                 <a:latin typeface="Roboto"/>
               </a:rPr>
-              <a:t>O segundo é o time sem integração contínua, que só acrescenta um passo de build.</a:t>
+              <a:t>Um time sem integração contínua, para quem é só um passo de build a mais.</a:t>
             </a:r>
           </a:p>
         </p:txBody>
@@ -27148,7 +27112,7 @@
                 </a:solidFill>
                 <a:latin typeface="Roboto"/>
               </a:rPr>
-              <a:t>O terceiro é a aplicação sensível a latência de cauda.</a:t>
+              <a:t>Uma aplicação sensível a latência de cauda.</a:t>
             </a:r>
           </a:p>
         </p:txBody>
@@ -27161,7 +27125,7 @@
         </p:nvSpPr>
         <p:spPr>
           <a:xfrm>
-            <a:off x="704850" y="5278945"/>
+            <a:off x="704850" y="5014912"/>
             <a:ext cx="57150" cy="57150"/>
           </a:xfrm>
           <a:prstGeom prst="rect">
@@ -27205,7 +27169,7 @@
         </p:nvSpPr>
         <p:spPr>
           <a:xfrm>
-            <a:off x="971550" y="5174932"/>
+            <a:off x="971550" y="4910899"/>
             <a:ext cx="4857750" cy="95250"/>
           </a:xfrm>
           <a:prstGeom prst="rect">
@@ -27231,7 +27195,7 @@
                 </a:solidFill>
                 <a:latin typeface="Roboto"/>
               </a:rPr>
-              <a:t>O quarto é o sistema dominado por estado.</a:t>
+              <a:t>Um sistema dominado por estado.</a:t>
             </a:r>
           </a:p>
         </p:txBody>
@@ -27244,7 +27208,7 @@
         </p:nvSpPr>
         <p:spPr>
           <a:xfrm>
-            <a:off x="6362700" y="2295334"/>
+            <a:off x="6362700" y="2559368"/>
             <a:ext cx="5143500" cy="182880"/>
           </a:xfrm>
           <a:prstGeom prst="rect">
@@ -27283,7 +27247,7 @@
         </p:nvSpPr>
         <p:spPr>
           <a:xfrm>
-            <a:off x="6362700" y="2504884"/>
+            <a:off x="6362700" y="2768918"/>
             <a:ext cx="419100" cy="28575"/>
           </a:xfrm>
           <a:prstGeom prst="rect">
@@ -27327,7 +27291,7 @@
         </p:nvSpPr>
         <p:spPr>
           <a:xfrm>
-            <a:off x="6381750" y="2894648"/>
+            <a:off x="6381750" y="3158680"/>
             <a:ext cx="57150" cy="57150"/>
           </a:xfrm>
           <a:prstGeom prst="rect">
@@ -27371,7 +27335,7 @@
         </p:nvSpPr>
         <p:spPr>
           <a:xfrm>
-            <a:off x="6648450" y="2790634"/>
+            <a:off x="6648450" y="3054668"/>
             <a:ext cx="4857750" cy="95250"/>
           </a:xfrm>
           <a:prstGeom prst="rect">
@@ -27410,7 +27374,7 @@
         </p:nvSpPr>
         <p:spPr>
           <a:xfrm>
-            <a:off x="6381750" y="3953447"/>
+            <a:off x="6381750" y="4217480"/>
             <a:ext cx="57150" cy="57150"/>
           </a:xfrm>
           <a:prstGeom prst="rect">
@@ -27454,7 +27418,7 @@
         </p:nvSpPr>
         <p:spPr>
           <a:xfrm>
-            <a:off x="6648450" y="3849434"/>
+            <a:off x="6648450" y="4113466"/>
             <a:ext cx="4857750" cy="95250"/>
           </a:xfrm>
           <a:prstGeom prst="rect">
@@ -27480,7 +27444,7 @@
                 </a:solidFill>
                 <a:latin typeface="Roboto"/>
               </a:rPr>
-              <a:t>O motivo que se aplica é o ambiente igual para os quatro antes da primeira linha de código.</a:t>
+              <a:t>O motivo para adotar é o ambiente igual para os quatro antes da primeira linha de código.</a:t>
             </a:r>
           </a:p>
         </p:txBody>
@@ -34279,7 +34243,7 @@
                 </a:solidFill>
                 <a:latin typeface="Roboto"/>
               </a:rPr>
-              <a:t>Os cgroups não isolam nada, eles contabilizam e limitam o consumo de recursos.</a:t>
+              <a:t>Os cgroups contabilizam e limitam o consumo de recursos, sem isolar nada.</a:t>
             </a:r>
           </a:p>
         </p:txBody>
@@ -34362,7 +34326,7 @@
                 </a:solidFill>
                 <a:latin typeface="Roboto"/>
               </a:rPr>
-              <a:t>Estourar o limite de memória encerra o processo. Ele não fica lento.</a:t>
+              <a:t>Estourar o limite de memória encerra o processo, sem degradação gradual.</a:t>
             </a:r>
           </a:p>
         </p:txBody>

</xml_diff>

<commit_message>
docs: da folga a legenda do diagrama de mapeamento no slide 16 do T1
</commit_message>
<xml_diff>
--- a/trabalhos/T1-Docker-Invite-People.pptx
+++ b/trabalhos/T1-Docker-Invite-People.pptx
@@ -16900,7 +16900,7 @@
         </p:nvSpPr>
         <p:spPr>
           <a:xfrm>
-            <a:off x="857250" y="2828925"/>
+            <a:off x="857250" y="2771775"/>
             <a:ext cx="3810000" cy="167640"/>
           </a:xfrm>
           <a:prstGeom prst="rect">
@@ -16939,8 +16939,8 @@
         </p:nvSpPr>
         <p:spPr>
           <a:xfrm>
-            <a:off x="857250" y="3000375"/>
-            <a:ext cx="3810000" cy="1866900"/>
+            <a:off x="857250" y="2943225"/>
+            <a:ext cx="3810000" cy="2057400"/>
           </a:xfrm>
           <a:prstGeom prst="rect">
             <a:avLst/>
@@ -16983,7 +16983,7 @@
         </p:nvSpPr>
         <p:spPr>
           <a:xfrm>
-            <a:off x="1123950" y="3248025"/>
+            <a:off x="1123950" y="3190875"/>
             <a:ext cx="1428750" cy="457200"/>
           </a:xfrm>
           <a:prstGeom prst="roundRect">
@@ -17029,7 +17029,7 @@
         </p:nvSpPr>
         <p:spPr>
           <a:xfrm>
-            <a:off x="1123950" y="3400425"/>
+            <a:off x="1123950" y="3343275"/>
             <a:ext cx="1428750" cy="198120"/>
           </a:xfrm>
           <a:prstGeom prst="rect">
@@ -17068,7 +17068,7 @@
         </p:nvSpPr>
         <p:spPr>
           <a:xfrm>
-            <a:off x="2971800" y="3248025"/>
+            <a:off x="2971800" y="3190875"/>
             <a:ext cx="1428750" cy="457200"/>
           </a:xfrm>
           <a:prstGeom prst="roundRect">
@@ -17114,7 +17114,7 @@
         </p:nvSpPr>
         <p:spPr>
           <a:xfrm>
-            <a:off x="2971800" y="3400425"/>
+            <a:off x="2971800" y="3343275"/>
             <a:ext cx="1428750" cy="198120"/>
           </a:xfrm>
           <a:prstGeom prst="rect">
@@ -17153,7 +17153,7 @@
         </p:nvSpPr>
         <p:spPr>
           <a:xfrm>
-            <a:off x="2047875" y="3914775"/>
+            <a:off x="2047875" y="3857625"/>
             <a:ext cx="1428750" cy="419100"/>
           </a:xfrm>
           <a:prstGeom prst="roundRect">
@@ -17199,7 +17199,7 @@
         </p:nvSpPr>
         <p:spPr>
           <a:xfrm>
-            <a:off x="2047875" y="4048125"/>
+            <a:off x="2047875" y="3990975"/>
             <a:ext cx="1428750" cy="198120"/>
           </a:xfrm>
           <a:prstGeom prst="rect">
@@ -17238,7 +17238,7 @@
         </p:nvSpPr>
         <p:spPr>
           <a:xfrm>
-            <a:off x="2047875" y="4467225"/>
+            <a:off x="2047875" y="4410075"/>
             <a:ext cx="1428750" cy="285750"/>
           </a:xfrm>
           <a:prstGeom prst="roundRect">
@@ -17284,7 +17284,7 @@
         </p:nvSpPr>
         <p:spPr>
           <a:xfrm>
-            <a:off x="2047875" y="4533900"/>
+            <a:off x="2047875" y="4476750"/>
             <a:ext cx="1428750" cy="182880"/>
           </a:xfrm>
           <a:prstGeom prst="rect">
@@ -17323,7 +17323,7 @@
         </p:nvCxnSpPr>
         <p:spPr>
           <a:xfrm>
-            <a:off x="1838325" y="3705225"/>
+            <a:off x="1838325" y="3648075"/>
             <a:ext cx="733425" cy="209550"/>
           </a:xfrm>
           <a:prstGeom prst="line">
@@ -17358,7 +17358,7 @@
         </p:nvCxnSpPr>
         <p:spPr>
           <a:xfrm flipH="1">
-            <a:off x="2952750" y="3705225"/>
+            <a:off x="2952750" y="3648075"/>
             <a:ext cx="733425" cy="209550"/>
           </a:xfrm>
           <a:prstGeom prst="line">
@@ -17393,7 +17393,7 @@
         </p:nvCxnSpPr>
         <p:spPr>
           <a:xfrm>
-            <a:off x="2762250" y="4333875"/>
+            <a:off x="2762250" y="4276725"/>
             <a:ext cx="0" cy="133350"/>
           </a:xfrm>
           <a:prstGeom prst="line">
@@ -17428,7 +17428,7 @@
         </p:nvCxnSpPr>
         <p:spPr>
           <a:xfrm>
-            <a:off x="4667250" y="3933825"/>
+            <a:off x="4667250" y="3876675"/>
             <a:ext cx="1524000" cy="0"/>
           </a:xfrm>
           <a:prstGeom prst="line">
@@ -17463,7 +17463,7 @@
         </p:nvSpPr>
         <p:spPr>
           <a:xfrm>
-            <a:off x="4667250" y="3667125"/>
+            <a:off x="4667250" y="3609975"/>
             <a:ext cx="1524000" cy="198120"/>
           </a:xfrm>
           <a:prstGeom prst="rect">
@@ -17502,7 +17502,7 @@
         </p:nvSpPr>
         <p:spPr>
           <a:xfrm>
-            <a:off x="6191250" y="2828925"/>
+            <a:off x="6191250" y="2771775"/>
             <a:ext cx="4000500" cy="167640"/>
           </a:xfrm>
           <a:prstGeom prst="rect">
@@ -17541,8 +17541,8 @@
         </p:nvSpPr>
         <p:spPr>
           <a:xfrm>
-            <a:off x="6191250" y="3000375"/>
-            <a:ext cx="3810000" cy="1866900"/>
+            <a:off x="6191250" y="2943225"/>
+            <a:ext cx="3810000" cy="2057400"/>
           </a:xfrm>
           <a:prstGeom prst="rect">
             <a:avLst/>
@@ -17585,7 +17585,7 @@
         </p:nvSpPr>
         <p:spPr>
           <a:xfrm>
-            <a:off x="6381750" y="3114675"/>
+            <a:off x="6381750" y="3057525"/>
             <a:ext cx="1905000" cy="167640"/>
           </a:xfrm>
           <a:prstGeom prst="rect">
@@ -17624,7 +17624,7 @@
         </p:nvSpPr>
         <p:spPr>
           <a:xfrm>
-            <a:off x="6381750" y="3343275"/>
+            <a:off x="6381750" y="3286125"/>
             <a:ext cx="1066800" cy="495300"/>
           </a:xfrm>
           <a:prstGeom prst="rect">
@@ -17668,7 +17668,7 @@
         </p:nvSpPr>
         <p:spPr>
           <a:xfrm>
-            <a:off x="6400800" y="3419475"/>
+            <a:off x="6400800" y="3362325"/>
             <a:ext cx="1028700" cy="175260"/>
           </a:xfrm>
           <a:prstGeom prst="rect">
@@ -17707,7 +17707,7 @@
         </p:nvSpPr>
         <p:spPr>
           <a:xfrm>
-            <a:off x="6400800" y="3590925"/>
+            <a:off x="6400800" y="3533775"/>
             <a:ext cx="1028700" cy="167640"/>
           </a:xfrm>
           <a:prstGeom prst="rect">
@@ -17746,7 +17746,7 @@
         </p:nvSpPr>
         <p:spPr>
           <a:xfrm>
-            <a:off x="7562850" y="3343275"/>
+            <a:off x="7562850" y="3286125"/>
             <a:ext cx="1066800" cy="495300"/>
           </a:xfrm>
           <a:prstGeom prst="rect">
@@ -17790,7 +17790,7 @@
         </p:nvSpPr>
         <p:spPr>
           <a:xfrm>
-            <a:off x="7581900" y="3419475"/>
+            <a:off x="7581900" y="3362325"/>
             <a:ext cx="1028700" cy="175260"/>
           </a:xfrm>
           <a:prstGeom prst="rect">
@@ -17829,7 +17829,7 @@
         </p:nvSpPr>
         <p:spPr>
           <a:xfrm>
-            <a:off x="7581900" y="3590925"/>
+            <a:off x="7581900" y="3533775"/>
             <a:ext cx="1028700" cy="167640"/>
           </a:xfrm>
           <a:prstGeom prst="rect">
@@ -17868,7 +17868,7 @@
         </p:nvCxnSpPr>
         <p:spPr>
           <a:xfrm>
-            <a:off x="7448550" y="3590925"/>
+            <a:off x="7448550" y="3533775"/>
             <a:ext cx="114300" cy="0"/>
           </a:xfrm>
           <a:prstGeom prst="line">
@@ -17903,7 +17903,7 @@
         </p:nvSpPr>
         <p:spPr>
           <a:xfrm>
-            <a:off x="8743950" y="3343275"/>
+            <a:off x="8743950" y="3286125"/>
             <a:ext cx="1066800" cy="495300"/>
           </a:xfrm>
           <a:prstGeom prst="rect">
@@ -17947,7 +17947,7 @@
         </p:nvSpPr>
         <p:spPr>
           <a:xfrm>
-            <a:off x="8763000" y="3419475"/>
+            <a:off x="8763000" y="3362325"/>
             <a:ext cx="1028700" cy="175260"/>
           </a:xfrm>
           <a:prstGeom prst="rect">
@@ -17986,7 +17986,7 @@
         </p:nvSpPr>
         <p:spPr>
           <a:xfrm>
-            <a:off x="8763000" y="3590925"/>
+            <a:off x="8763000" y="3533775"/>
             <a:ext cx="1028700" cy="167640"/>
           </a:xfrm>
           <a:prstGeom prst="rect">
@@ -18025,7 +18025,7 @@
         </p:nvCxnSpPr>
         <p:spPr>
           <a:xfrm>
-            <a:off x="8629650" y="3590925"/>
+            <a:off x="8629650" y="3533775"/>
             <a:ext cx="114300" cy="0"/>
           </a:xfrm>
           <a:prstGeom prst="line">
@@ -18060,7 +18060,7 @@
         </p:nvSpPr>
         <p:spPr>
           <a:xfrm>
-            <a:off x="6381750" y="4067175"/>
+            <a:off x="6381750" y="4010025"/>
             <a:ext cx="3429000" cy="323850"/>
           </a:xfrm>
           <a:prstGeom prst="roundRect">
@@ -18109,7 +18109,7 @@
         </p:nvSpPr>
         <p:spPr>
           <a:xfrm>
-            <a:off x="6381750" y="4162425"/>
+            <a:off x="6381750" y="4105275"/>
             <a:ext cx="3429000" cy="182880"/>
           </a:xfrm>
           <a:prstGeom prst="rect">
@@ -18148,8 +18148,8 @@
         </p:nvSpPr>
         <p:spPr>
           <a:xfrm>
-            <a:off x="6381750" y="4505325"/>
-            <a:ext cx="3390900" cy="438150"/>
+            <a:off x="6381750" y="4429125"/>
+            <a:ext cx="3390900" cy="381000"/>
           </a:xfrm>
           <a:prstGeom prst="rect">
             <a:avLst/>
@@ -18164,7 +18164,7 @@
           <a:p>
             <a:pPr algn="l">
               <a:lnSpc>
-                <a:spcPct val="140000"/>
+                <a:spcPct val="130000"/>
               </a:lnSpc>
             </a:pPr>
             <a:r>

</xml_diff>

<commit_message>
docs: alinha compose, replicacao e legenda de tiers no T1 para os slides pararem de se contradizer
</commit_message>
<xml_diff>
--- a/trabalhos/T1-Docker-Invite-People.pptx
+++ b/trabalhos/T1-Docker-Invite-People.pptx
@@ -15980,7 +15980,7 @@
                 </a:solidFill>
                 <a:latin typeface="Roboto"/>
               </a:rPr>
-              <a:t>O projeto lógico é o mesmo nas três opções, e a escolha entre elas é registrada no documento de decisões arquiteturais. No Docker, </a:t>
+              <a:t>O projeto lógico é o mesmo nas três opções. Os rascunhos dos próximos slides seguem a de três, e a escolha final é registrada no documento de decisões arquiteturais. No Docker, </a:t>
             </a:r>
             <a:r>
               <a:rPr sz="1280" b="0" i="1">
@@ -18353,12 +18353,12 @@
         </p:nvSpPr>
         <p:spPr>
           <a:xfrm>
-            <a:off x="685800" y="2343150"/>
-            <a:ext cx="5905500" cy="2895600"/>
+            <a:off x="685800" y="2095500"/>
+            <a:ext cx="5905500" cy="3390900"/>
           </a:xfrm>
           <a:prstGeom prst="roundRect">
             <a:avLst>
-              <a:gd name="adj" fmla="val 2631"/>
+              <a:gd name="adj" fmla="val 2247"/>
             </a:avLst>
           </a:prstGeom>
           <a:solidFill>
@@ -18401,7 +18401,7 @@
         </p:nvSpPr>
         <p:spPr>
           <a:xfrm>
-            <a:off x="933450" y="2552700"/>
+            <a:off x="933450" y="2305050"/>
             <a:ext cx="5524500" cy="213360"/>
           </a:xfrm>
           <a:prstGeom prst="rect">
@@ -18440,7 +18440,7 @@
         </p:nvSpPr>
         <p:spPr>
           <a:xfrm>
-            <a:off x="933450" y="2800350"/>
+            <a:off x="933450" y="2552700"/>
             <a:ext cx="5524500" cy="213360"/>
           </a:xfrm>
           <a:prstGeom prst="rect">
@@ -18466,7 +18466,7 @@
                 </a:solidFill>
                 <a:latin typeface="Roboto Mono"/>
               </a:rPr>
-              <a:t>  api:</a:t>
+              <a:t>  front:</a:t>
             </a:r>
           </a:p>
         </p:txBody>
@@ -18479,7 +18479,7 @@
         </p:nvSpPr>
         <p:spPr>
           <a:xfrm>
-            <a:off x="933450" y="3048000"/>
+            <a:off x="933450" y="2800350"/>
             <a:ext cx="5524500" cy="213360"/>
           </a:xfrm>
           <a:prstGeom prst="rect">
@@ -18505,7 +18505,7 @@
                 </a:solidFill>
                 <a:latin typeface="Roboto Mono"/>
               </a:rPr>
-              <a:t>    image: node:22-alpine</a:t>
+              <a:t>    image: nginx:alpine</a:t>
             </a:r>
           </a:p>
         </p:txBody>
@@ -18518,7 +18518,7 @@
         </p:nvSpPr>
         <p:spPr>
           <a:xfrm>
-            <a:off x="933450" y="3295650"/>
+            <a:off x="933450" y="3048000"/>
             <a:ext cx="5524500" cy="213360"/>
           </a:xfrm>
           <a:prstGeom prst="rect">
@@ -18544,7 +18544,7 @@
                 </a:solidFill>
                 <a:latin typeface="Roboto Mono"/>
               </a:rPr>
-              <a:t>    ports:</a:t>
+              <a:t>    ports: ["8080:80"]</a:t>
             </a:r>
           </a:p>
         </p:txBody>
@@ -18557,7 +18557,7 @@
         </p:nvSpPr>
         <p:spPr>
           <a:xfrm>
-            <a:off x="933450" y="3543300"/>
+            <a:off x="933450" y="3295650"/>
             <a:ext cx="5524500" cy="213360"/>
           </a:xfrm>
           <a:prstGeom prst="rect">
@@ -18583,7 +18583,7 @@
                 </a:solidFill>
                 <a:latin typeface="Roboto Mono"/>
               </a:rPr>
-              <a:t>      - "3000:3000"        # interface provida</a:t>
+              <a:t>  api:</a:t>
             </a:r>
           </a:p>
         </p:txBody>
@@ -18596,7 +18596,7 @@
         </p:nvSpPr>
         <p:spPr>
           <a:xfrm>
-            <a:off x="933450" y="3790950"/>
+            <a:off x="933450" y="3543300"/>
             <a:ext cx="5524500" cy="213360"/>
           </a:xfrm>
           <a:prstGeom prst="rect">
@@ -18622,7 +18622,7 @@
                 </a:solidFill>
                 <a:latin typeface="Roboto Mono"/>
               </a:rPr>
-              <a:t>    environment:</a:t>
+              <a:t>    image: node:22-alpine</a:t>
             </a:r>
           </a:p>
         </p:txBody>
@@ -18635,7 +18635,7 @@
         </p:nvSpPr>
         <p:spPr>
           <a:xfrm>
-            <a:off x="933450" y="4038600"/>
+            <a:off x="933450" y="3790950"/>
             <a:ext cx="5524500" cy="213360"/>
           </a:xfrm>
           <a:prstGeom prst="rect">
@@ -18661,7 +18661,7 @@
                 </a:solidFill>
                 <a:latin typeface="Roboto Mono"/>
               </a:rPr>
-              <a:t>      DATABASE_URL: ...    # interface requerida</a:t>
+              <a:t>    ports: ["3000:3000"]     # interface provida</a:t>
             </a:r>
           </a:p>
         </p:txBody>
@@ -18674,7 +18674,7 @@
         </p:nvSpPr>
         <p:spPr>
           <a:xfrm>
-            <a:off x="933450" y="4286250"/>
+            <a:off x="933450" y="4038600"/>
             <a:ext cx="5524500" cy="213360"/>
           </a:xfrm>
           <a:prstGeom prst="rect">
@@ -18700,7 +18700,7 @@
                 </a:solidFill>
                 <a:latin typeface="Roboto Mono"/>
               </a:rPr>
-              <a:t>    depends_on: [db]</a:t>
+              <a:t>    environment:</a:t>
             </a:r>
           </a:p>
         </p:txBody>
@@ -18713,7 +18713,7 @@
         </p:nvSpPr>
         <p:spPr>
           <a:xfrm>
-            <a:off x="933450" y="4533900"/>
+            <a:off x="933450" y="4286250"/>
             <a:ext cx="5524500" cy="213360"/>
           </a:xfrm>
           <a:prstGeom prst="rect">
@@ -18739,7 +18739,7 @@
                 </a:solidFill>
                 <a:latin typeface="Roboto Mono"/>
               </a:rPr>
-              <a:t>  db:</a:t>
+              <a:t>      DATABASE_URL: ...      # interface requerida</a:t>
             </a:r>
           </a:p>
         </p:txBody>
@@ -18752,7 +18752,7 @@
         </p:nvSpPr>
         <p:spPr>
           <a:xfrm>
-            <a:off x="933450" y="4781550"/>
+            <a:off x="933450" y="4533900"/>
             <a:ext cx="5524500" cy="213360"/>
           </a:xfrm>
           <a:prstGeom prst="rect">
@@ -18778,6 +18778,84 @@
                 </a:solidFill>
                 <a:latin typeface="Roboto Mono"/>
               </a:rPr>
+              <a:t>    depends_on: [db]</a:t>
+            </a:r>
+          </a:p>
+        </p:txBody>
+      </p:sp>
+      <p:sp>
+        <p:nvSpPr>
+          <p:cNvPr id="15" name="TextBox 14"/>
+          <p:cNvSpPr txBox="1"/>
+          <p:nvPr/>
+        </p:nvSpPr>
+        <p:spPr>
+          <a:xfrm>
+            <a:off x="933450" y="4781550"/>
+            <a:ext cx="5524500" cy="213360"/>
+          </a:xfrm>
+          <a:prstGeom prst="rect">
+            <a:avLst/>
+          </a:prstGeom>
+          <a:noFill/>
+        </p:spPr>
+        <p:txBody>
+          <a:bodyPr wrap="square" lIns="0" rIns="0" tIns="0" bIns="0" anchor="t">
+            <a:spAutoFit/>
+          </a:bodyPr>
+          <a:lstStyle/>
+          <a:p>
+            <a:pPr algn="l">
+              <a:lnSpc>
+                <a:spcPct val="120000"/>
+              </a:lnSpc>
+            </a:pPr>
+            <a:r>
+              <a:rPr sz="1050" b="0" i="0">
+                <a:solidFill>
+                  <a:srgbClr val="1A1A1E"/>
+                </a:solidFill>
+                <a:latin typeface="Roboto Mono"/>
+              </a:rPr>
+              <a:t>  db:</a:t>
+            </a:r>
+          </a:p>
+        </p:txBody>
+      </p:sp>
+      <p:sp>
+        <p:nvSpPr>
+          <p:cNvPr id="16" name="TextBox 15"/>
+          <p:cNvSpPr txBox="1"/>
+          <p:nvPr/>
+        </p:nvSpPr>
+        <p:spPr>
+          <a:xfrm>
+            <a:off x="933450" y="5029200"/>
+            <a:ext cx="5524500" cy="213360"/>
+          </a:xfrm>
+          <a:prstGeom prst="rect">
+            <a:avLst/>
+          </a:prstGeom>
+          <a:noFill/>
+        </p:spPr>
+        <p:txBody>
+          <a:bodyPr wrap="square" lIns="0" rIns="0" tIns="0" bIns="0" anchor="t">
+            <a:spAutoFit/>
+          </a:bodyPr>
+          <a:lstStyle/>
+          <a:p>
+            <a:pPr algn="l">
+              <a:lnSpc>
+                <a:spcPct val="120000"/>
+              </a:lnSpc>
+            </a:pPr>
+            <a:r>
+              <a:rPr sz="1050" b="0" i="0">
+                <a:solidFill>
+                  <a:srgbClr val="1A1A1E"/>
+                </a:solidFill>
+                <a:latin typeface="Roboto Mono"/>
+              </a:rPr>
               <a:t>    image: postgres:16</a:t>
             </a:r>
           </a:p>
@@ -18785,13 +18863,13 @@
       </p:sp>
       <p:sp>
         <p:nvSpPr>
-          <p:cNvPr id="15" name="Rectangle 14"/>
+          <p:cNvPr id="17" name="Rectangle 16"/>
           <p:cNvSpPr/>
           <p:nvPr/>
         </p:nvSpPr>
         <p:spPr>
           <a:xfrm>
-            <a:off x="7067550" y="2427351"/>
+            <a:off x="7067550" y="2179701"/>
             <a:ext cx="57150" cy="57150"/>
           </a:xfrm>
           <a:prstGeom prst="rect">
@@ -18829,13 +18907,13 @@
       </p:sp>
       <p:sp>
         <p:nvSpPr>
-          <p:cNvPr id="16" name="TextBox 15"/>
+          <p:cNvPr id="18" name="TextBox 17"/>
           <p:cNvSpPr txBox="1"/>
           <p:nvPr/>
         </p:nvSpPr>
         <p:spPr>
           <a:xfrm>
-            <a:off x="7334250" y="2343150"/>
+            <a:off x="7334250" y="2095500"/>
             <a:ext cx="4171950" cy="95250"/>
           </a:xfrm>
           <a:prstGeom prst="rect">
@@ -18868,13 +18946,13 @@
       </p:sp>
       <p:sp>
         <p:nvSpPr>
-          <p:cNvPr id="17" name="Rectangle 16"/>
+          <p:cNvPr id="19" name="Rectangle 18"/>
           <p:cNvSpPr/>
           <p:nvPr/>
         </p:nvSpPr>
         <p:spPr>
           <a:xfrm>
-            <a:off x="7067550" y="3007233"/>
+            <a:off x="7067550" y="2759583"/>
             <a:ext cx="57150" cy="57150"/>
           </a:xfrm>
           <a:prstGeom prst="rect">
@@ -18912,13 +18990,13 @@
       </p:sp>
       <p:sp>
         <p:nvSpPr>
-          <p:cNvPr id="18" name="TextBox 17"/>
+          <p:cNvPr id="20" name="TextBox 19"/>
           <p:cNvSpPr txBox="1"/>
           <p:nvPr/>
         </p:nvSpPr>
         <p:spPr>
           <a:xfrm>
-            <a:off x="7334250" y="2923032"/>
+            <a:off x="7334250" y="2675382"/>
             <a:ext cx="4171950" cy="95250"/>
           </a:xfrm>
           <a:prstGeom prst="rect">
@@ -18951,13 +19029,13 @@
       </p:sp>
       <p:sp>
         <p:nvSpPr>
-          <p:cNvPr id="19" name="Rectangle 18"/>
+          <p:cNvPr id="21" name="Rectangle 20"/>
           <p:cNvSpPr/>
           <p:nvPr/>
         </p:nvSpPr>
         <p:spPr>
           <a:xfrm>
-            <a:off x="7067550" y="3587115"/>
+            <a:off x="7067550" y="3339465"/>
             <a:ext cx="57150" cy="57150"/>
           </a:xfrm>
           <a:prstGeom prst="rect">
@@ -18995,13 +19073,13 @@
       </p:sp>
       <p:sp>
         <p:nvSpPr>
-          <p:cNvPr id="20" name="TextBox 19"/>
+          <p:cNvPr id="22" name="TextBox 21"/>
           <p:cNvSpPr txBox="1"/>
           <p:nvPr/>
         </p:nvSpPr>
         <p:spPr>
           <a:xfrm>
-            <a:off x="7334250" y="3502914"/>
+            <a:off x="7334250" y="3255264"/>
             <a:ext cx="4171950" cy="95250"/>
           </a:xfrm>
           <a:prstGeom prst="rect">
@@ -19034,13 +19112,13 @@
       </p:sp>
       <p:sp>
         <p:nvSpPr>
-          <p:cNvPr id="21" name="Rectangle 20"/>
+          <p:cNvPr id="23" name="Rectangle 22"/>
           <p:cNvSpPr/>
           <p:nvPr/>
         </p:nvSpPr>
         <p:spPr>
           <a:xfrm>
-            <a:off x="7067550" y="4166997"/>
+            <a:off x="7067550" y="3919347"/>
             <a:ext cx="57150" cy="57150"/>
           </a:xfrm>
           <a:prstGeom prst="rect">
@@ -19078,13 +19156,13 @@
       </p:sp>
       <p:sp>
         <p:nvSpPr>
-          <p:cNvPr id="22" name="TextBox 21"/>
+          <p:cNvPr id="24" name="TextBox 23"/>
           <p:cNvSpPr txBox="1"/>
           <p:nvPr/>
         </p:nvSpPr>
         <p:spPr>
           <a:xfrm>
-            <a:off x="7334250" y="4082796"/>
+            <a:off x="7334250" y="3835146"/>
             <a:ext cx="4171950" cy="95250"/>
           </a:xfrm>
           <a:prstGeom prst="rect">
@@ -19117,7 +19195,7 @@
       </p:sp>
       <p:sp>
         <p:nvSpPr>
-          <p:cNvPr id="23" name="TextBox 22"/>
+          <p:cNvPr id="25" name="TextBox 24"/>
           <p:cNvSpPr txBox="1"/>
           <p:nvPr/>
         </p:nvSpPr>
@@ -19156,7 +19234,7 @@
       </p:sp>
       <p:sp>
         <p:nvSpPr>
-          <p:cNvPr id="24" name="TextBox 23"/>
+          <p:cNvPr id="26" name="TextBox 25"/>
           <p:cNvSpPr txBox="1"/>
           <p:nvPr/>
         </p:nvSpPr>
@@ -19609,7 +19687,7 @@
                 </a:solidFill>
                 <a:latin typeface="Roboto"/>
               </a:rPr>
-              <a:t>Os serviços conversam por uma rede interna, onde cada um é achado pelo nome. Só o de fronteira publica porta para fora, e o banco fica sem mapeamento nenhum.</a:t>
+              <a:t>Os serviços conversam por uma rede interna, onde cada um é achado pelo nome. Só os serviços de fronteira publicam porta para fora. O banco fica sem mapeamento nenhum.</a:t>
             </a:r>
           </a:p>
         </p:txBody>
@@ -20290,7 +20368,7 @@
                 </a:solidFill>
                 <a:latin typeface="Roboto"/>
               </a:rPr>
-              <a:t>Só o serviço público precisa de réplicas.</a:t>
+              <a:t>Réplicas só do container da API, por causa do convite público. O painel sozinho não justificaria.</a:t>
             </a:r>
           </a:p>
         </p:txBody>
@@ -27846,7 +27924,7 @@
                 </a:solidFill>
                 <a:latin typeface="Roboto"/>
               </a:rPr>
-              <a:t>Dá para escalar só o serviço público, se a aplicação for mesmo sem estado.</a:t>
+              <a:t>Dá para replicar só a API, se o caminho do convite público for mesmo sem estado.</a:t>
             </a:r>
           </a:p>
         </p:txBody>

</xml_diff>

<commit_message>
docs: atualiza o binario do T1 com o slide das duas areas
</commit_message>
<xml_diff>
--- a/trabalhos/T1-Docker-Invite-People.pptx
+++ b/trabalhos/T1-Docker-Invite-People.pptx
@@ -20186,36 +20186,103 @@
                 </a:solidFill>
                 <a:latin typeface="Roboto"/>
               </a:rPr>
-              <a:t>O convite público e o painel</a:t>
-            </a:r>
-          </a:p>
-          <a:p>
-            <a:pPr>
-              <a:lnSpc>
-                <a:spcPct val="104000"/>
-              </a:lnSpc>
-            </a:pPr>
-            <a:r>
-              <a:rPr sz="3000" b="1" i="0">
+              <a:t>Área pública e área com login</a:t>
+            </a:r>
+          </a:p>
+        </p:txBody>
+      </p:sp>
+      <p:sp>
+        <p:nvSpPr>
+          <p:cNvPr id="4" name="TextBox 3"/>
+          <p:cNvSpPr txBox="1"/>
+          <p:nvPr/>
+        </p:nvSpPr>
+        <p:spPr>
+          <a:xfrm>
+            <a:off x="685800" y="2560701"/>
+            <a:ext cx="5143500" cy="182880"/>
+          </a:xfrm>
+          <a:prstGeom prst="rect">
+            <a:avLst/>
+          </a:prstGeom>
+          <a:noFill/>
+        </p:spPr>
+        <p:txBody>
+          <a:bodyPr wrap="square" lIns="0" rIns="0" tIns="0" bIns="0" anchor="t">
+            <a:spAutoFit/>
+          </a:bodyPr>
+          <a:lstStyle/>
+          <a:p>
+            <a:pPr algn="l">
+              <a:lnSpc>
+                <a:spcPct val="120000"/>
+              </a:lnSpc>
+            </a:pPr>
+            <a:r>
+              <a:rPr sz="900" b="1" i="0" spc="120">
                 <a:solidFill>
                   <a:srgbClr val="21049A"/>
                 </a:solidFill>
                 <a:latin typeface="Roboto"/>
               </a:rPr>
-              <a:t>têm cargas diferentes</a:t>
-            </a:r>
-          </a:p>
-        </p:txBody>
-      </p:sp>
-      <p:sp>
-        <p:nvSpPr>
-          <p:cNvPr id="4" name="Rectangle 3"/>
+              <a:t>CONVITE PÚBLICO, SEM LOGIN</a:t>
+            </a:r>
+          </a:p>
+        </p:txBody>
+      </p:sp>
+      <p:sp>
+        <p:nvSpPr>
+          <p:cNvPr id="5" name="Rectangle 4"/>
           <p:cNvSpPr/>
           <p:nvPr/>
         </p:nvSpPr>
         <p:spPr>
           <a:xfrm>
-            <a:off x="704850" y="2998851"/>
+            <a:off x="685800" y="2770251"/>
+            <a:ext cx="419100" cy="28575"/>
+          </a:xfrm>
+          <a:prstGeom prst="rect">
+            <a:avLst/>
+          </a:prstGeom>
+          <a:solidFill>
+            <a:srgbClr val="21049A"/>
+          </a:solidFill>
+          <a:ln>
+            <a:noFill/>
+          </a:ln>
+          <a:effectLst/>
+        </p:spPr>
+        <p:style>
+          <a:lnRef idx="1">
+            <a:schemeClr val="accent1"/>
+          </a:lnRef>
+          <a:fillRef idx="3">
+            <a:schemeClr val="accent1"/>
+          </a:fillRef>
+          <a:effectRef idx="2">
+            <a:schemeClr val="accent1"/>
+          </a:effectRef>
+          <a:fontRef idx="minor">
+            <a:schemeClr val="lt1"/>
+          </a:fontRef>
+        </p:style>
+        <p:txBody>
+          <a:bodyPr rtlCol="0" anchor="ctr" wrap="square" lIns="0" rIns="0" tIns="0" bIns="0"/>
+          <a:lstStyle/>
+          <a:p>
+            <a:pPr algn="ctr"/>
+          </a:p>
+        </p:txBody>
+      </p:sp>
+      <p:sp>
+        <p:nvSpPr>
+          <p:cNvPr id="6" name="Rectangle 5"/>
+          <p:cNvSpPr/>
+          <p:nvPr/>
+        </p:nvSpPr>
+        <p:spPr>
+          <a:xfrm>
+            <a:off x="704850" y="3160014"/>
             <a:ext cx="57150" cy="57150"/>
           </a:xfrm>
           <a:prstGeom prst="rect">
@@ -20253,14 +20320,14 @@
       </p:sp>
       <p:sp>
         <p:nvSpPr>
-          <p:cNvPr id="5" name="TextBox 4"/>
+          <p:cNvPr id="7" name="TextBox 6"/>
           <p:cNvSpPr txBox="1"/>
           <p:nvPr/>
         </p:nvSpPr>
         <p:spPr>
           <a:xfrm>
-            <a:off x="971550" y="2889885"/>
-            <a:ext cx="9677400" cy="95250"/>
+            <a:off x="971550" y="3056001"/>
+            <a:ext cx="4857750" cy="95250"/>
           </a:xfrm>
           <a:prstGeom prst="rect">
             <a:avLst/>
@@ -20279,26 +20346,26 @@
               </a:lnSpc>
             </a:pPr>
             <a:r>
-              <a:rPr sz="1650" b="0" i="0">
+              <a:rPr sz="1580" b="0" i="0">
                 <a:solidFill>
                   <a:srgbClr val="1A1A1E"/>
                 </a:solidFill>
                 <a:latin typeface="Roboto"/>
               </a:rPr>
-              <a:t>A jornada da anfitriã descreve o link caindo no grupo da família. Isso é pico no convite público, onde o convidado confirma presença, e uma pessoa só no painel, onde a anfitriã vê a lista.</a:t>
-            </a:r>
-          </a:p>
-        </p:txBody>
-      </p:sp>
-      <p:sp>
-        <p:nvSpPr>
-          <p:cNvPr id="6" name="Rectangle 5"/>
+              <a:t>Qualquer pessoa com o link acessa.</a:t>
+            </a:r>
+          </a:p>
+        </p:txBody>
+      </p:sp>
+      <p:sp>
+        <p:nvSpPr>
+          <p:cNvPr id="8" name="Rectangle 7"/>
           <p:cNvSpPr/>
           <p:nvPr/>
         </p:nvSpPr>
         <p:spPr>
           <a:xfrm>
-            <a:off x="704850" y="3837813"/>
+            <a:off x="704850" y="3690747"/>
             <a:ext cx="57150" cy="57150"/>
           </a:xfrm>
           <a:prstGeom prst="rect">
@@ -20336,14 +20403,14 @@
       </p:sp>
       <p:sp>
         <p:nvSpPr>
-          <p:cNvPr id="7" name="TextBox 6"/>
+          <p:cNvPr id="9" name="TextBox 8"/>
           <p:cNvSpPr txBox="1"/>
           <p:nvPr/>
         </p:nvSpPr>
         <p:spPr>
           <a:xfrm>
-            <a:off x="971550" y="3728847"/>
-            <a:ext cx="9677400" cy="95250"/>
+            <a:off x="971550" y="3586734"/>
+            <a:ext cx="4857750" cy="95250"/>
           </a:xfrm>
           <a:prstGeom prst="rect">
             <a:avLst/>
@@ -20362,26 +20429,26 @@
               </a:lnSpc>
             </a:pPr>
             <a:r>
-              <a:rPr sz="1650" b="0" i="0">
+              <a:rPr sz="1580" b="0" i="0">
                 <a:solidFill>
                   <a:srgbClr val="1A1A1E"/>
                 </a:solidFill>
                 <a:latin typeface="Roboto"/>
               </a:rPr>
-              <a:t>Réplicas só do container da API, por causa do convite público. O painel sozinho não justificaria.</a:t>
-            </a:r>
-          </a:p>
-        </p:txBody>
-      </p:sp>
-      <p:sp>
-        <p:nvSpPr>
-          <p:cNvPr id="8" name="Rectangle 7"/>
+              <a:t>O link é compartilhado no grupo da família e as confirmações de presença chegam em pico.</a:t>
+            </a:r>
+          </a:p>
+        </p:txBody>
+      </p:sp>
+      <p:sp>
+        <p:nvSpPr>
+          <p:cNvPr id="10" name="Rectangle 9"/>
           <p:cNvSpPr/>
           <p:nvPr/>
         </p:nvSpPr>
         <p:spPr>
           <a:xfrm>
-            <a:off x="704850" y="4400169"/>
+            <a:off x="704850" y="4485513"/>
             <a:ext cx="57150" cy="57150"/>
           </a:xfrm>
           <a:prstGeom prst="rect">
@@ -20419,14 +20486,14 @@
       </p:sp>
       <p:sp>
         <p:nvSpPr>
-          <p:cNvPr id="9" name="TextBox 8"/>
+          <p:cNvPr id="11" name="TextBox 10"/>
           <p:cNvSpPr txBox="1"/>
           <p:nvPr/>
         </p:nvSpPr>
         <p:spPr>
           <a:xfrm>
-            <a:off x="971550" y="4291203"/>
-            <a:ext cx="9677400" cy="95250"/>
+            <a:off x="971550" y="4381500"/>
+            <a:ext cx="4857750" cy="95250"/>
           </a:xfrm>
           <a:prstGeom prst="rect">
             <a:avLst/>
@@ -20445,27 +20512,27 @@
               </a:lnSpc>
             </a:pPr>
             <a:r>
-              <a:rPr sz="1650" b="0" i="0">
+              <a:rPr sz="1580" b="0" i="0">
                 <a:solidFill>
                   <a:srgbClr val="1A1A1E"/>
                 </a:solidFill>
                 <a:latin typeface="Roboto"/>
               </a:rPr>
-              <a:t>Para isso valer, o convite público não pode guardar sessão em memória nem gravar upload em disco local.</a:t>
-            </a:r>
-          </a:p>
-        </p:txBody>
-      </p:sp>
-      <p:sp>
-        <p:nvSpPr>
-          <p:cNvPr id="10" name="TextBox 9"/>
+              <a:t>É por esta área que o container da API ganha réplicas, e para isso ela não pode guardar sessão em memória nem gravar upload em disco local.</a:t>
+            </a:r>
+          </a:p>
+        </p:txBody>
+      </p:sp>
+      <p:sp>
+        <p:nvSpPr>
+          <p:cNvPr id="12" name="TextBox 11"/>
           <p:cNvSpPr txBox="1"/>
           <p:nvPr/>
         </p:nvSpPr>
         <p:spPr>
           <a:xfrm>
-            <a:off x="685800" y="6324600"/>
-            <a:ext cx="6667500" cy="182880"/>
+            <a:off x="6362700" y="2560701"/>
+            <a:ext cx="5143500" cy="182880"/>
           </a:xfrm>
           <a:prstGeom prst="rect">
             <a:avLst/>
@@ -20484,6 +20551,255 @@
               </a:lnSpc>
             </a:pPr>
             <a:r>
+              <a:rPr sz="900" b="1" i="0" spc="120">
+                <a:solidFill>
+                  <a:srgbClr val="E94D1C"/>
+                </a:solidFill>
+                <a:latin typeface="Roboto"/>
+              </a:rPr>
+              <a:t>PAINEL DO ANFITRIÃO, COM LOGIN</a:t>
+            </a:r>
+          </a:p>
+        </p:txBody>
+      </p:sp>
+      <p:sp>
+        <p:nvSpPr>
+          <p:cNvPr id="13" name="Rectangle 12"/>
+          <p:cNvSpPr/>
+          <p:nvPr/>
+        </p:nvSpPr>
+        <p:spPr>
+          <a:xfrm>
+            <a:off x="6362700" y="2770251"/>
+            <a:ext cx="419100" cy="28575"/>
+          </a:xfrm>
+          <a:prstGeom prst="rect">
+            <a:avLst/>
+          </a:prstGeom>
+          <a:solidFill>
+            <a:srgbClr val="E94D1C"/>
+          </a:solidFill>
+          <a:ln>
+            <a:noFill/>
+          </a:ln>
+          <a:effectLst/>
+        </p:spPr>
+        <p:style>
+          <a:lnRef idx="1">
+            <a:schemeClr val="accent1"/>
+          </a:lnRef>
+          <a:fillRef idx="3">
+            <a:schemeClr val="accent1"/>
+          </a:fillRef>
+          <a:effectRef idx="2">
+            <a:schemeClr val="accent1"/>
+          </a:effectRef>
+          <a:fontRef idx="minor">
+            <a:schemeClr val="lt1"/>
+          </a:fontRef>
+        </p:style>
+        <p:txBody>
+          <a:bodyPr rtlCol="0" anchor="ctr" wrap="square" lIns="0" rIns="0" tIns="0" bIns="0"/>
+          <a:lstStyle/>
+          <a:p>
+            <a:pPr algn="ctr"/>
+          </a:p>
+        </p:txBody>
+      </p:sp>
+      <p:sp>
+        <p:nvSpPr>
+          <p:cNvPr id="14" name="Rectangle 13"/>
+          <p:cNvSpPr/>
+          <p:nvPr/>
+        </p:nvSpPr>
+        <p:spPr>
+          <a:xfrm>
+            <a:off x="6381750" y="3160014"/>
+            <a:ext cx="57150" cy="57150"/>
+          </a:xfrm>
+          <a:prstGeom prst="rect">
+            <a:avLst/>
+          </a:prstGeom>
+          <a:solidFill>
+            <a:srgbClr val="E94D1C"/>
+          </a:solidFill>
+          <a:ln>
+            <a:noFill/>
+          </a:ln>
+          <a:effectLst/>
+        </p:spPr>
+        <p:style>
+          <a:lnRef idx="1">
+            <a:schemeClr val="accent1"/>
+          </a:lnRef>
+          <a:fillRef idx="3">
+            <a:schemeClr val="accent1"/>
+          </a:fillRef>
+          <a:effectRef idx="2">
+            <a:schemeClr val="accent1"/>
+          </a:effectRef>
+          <a:fontRef idx="minor">
+            <a:schemeClr val="lt1"/>
+          </a:fontRef>
+        </p:style>
+        <p:txBody>
+          <a:bodyPr rtlCol="0" anchor="ctr" wrap="square" lIns="0" rIns="0" tIns="0" bIns="0"/>
+          <a:lstStyle/>
+          <a:p>
+            <a:pPr algn="ctr"/>
+          </a:p>
+        </p:txBody>
+      </p:sp>
+      <p:sp>
+        <p:nvSpPr>
+          <p:cNvPr id="15" name="TextBox 14"/>
+          <p:cNvSpPr txBox="1"/>
+          <p:nvPr/>
+        </p:nvSpPr>
+        <p:spPr>
+          <a:xfrm>
+            <a:off x="6648450" y="3056001"/>
+            <a:ext cx="4857750" cy="95250"/>
+          </a:xfrm>
+          <a:prstGeom prst="rect">
+            <a:avLst/>
+          </a:prstGeom>
+          <a:noFill/>
+        </p:spPr>
+        <p:txBody>
+          <a:bodyPr wrap="square" lIns="0" rIns="0" tIns="0" bIns="0" anchor="t">
+            <a:spAutoFit/>
+          </a:bodyPr>
+          <a:lstStyle/>
+          <a:p>
+            <a:pPr algn="l">
+              <a:lnSpc>
+                <a:spcPct val="130000"/>
+              </a:lnSpc>
+            </a:pPr>
+            <a:r>
+              <a:rPr sz="1580" b="0" i="0">
+                <a:solidFill>
+                  <a:srgbClr val="1A1A1E"/>
+                </a:solidFill>
+                <a:latin typeface="Roboto"/>
+              </a:rPr>
+              <a:t>Só a anfitriã acessa.</a:t>
+            </a:r>
+          </a:p>
+        </p:txBody>
+      </p:sp>
+      <p:sp>
+        <p:nvSpPr>
+          <p:cNvPr id="16" name="Rectangle 15"/>
+          <p:cNvSpPr/>
+          <p:nvPr/>
+        </p:nvSpPr>
+        <p:spPr>
+          <a:xfrm>
+            <a:off x="6381750" y="3690747"/>
+            <a:ext cx="57150" cy="57150"/>
+          </a:xfrm>
+          <a:prstGeom prst="rect">
+            <a:avLst/>
+          </a:prstGeom>
+          <a:solidFill>
+            <a:srgbClr val="E94D1C"/>
+          </a:solidFill>
+          <a:ln>
+            <a:noFill/>
+          </a:ln>
+          <a:effectLst/>
+        </p:spPr>
+        <p:style>
+          <a:lnRef idx="1">
+            <a:schemeClr val="accent1"/>
+          </a:lnRef>
+          <a:fillRef idx="3">
+            <a:schemeClr val="accent1"/>
+          </a:fillRef>
+          <a:effectRef idx="2">
+            <a:schemeClr val="accent1"/>
+          </a:effectRef>
+          <a:fontRef idx="minor">
+            <a:schemeClr val="lt1"/>
+          </a:fontRef>
+        </p:style>
+        <p:txBody>
+          <a:bodyPr rtlCol="0" anchor="ctr" wrap="square" lIns="0" rIns="0" tIns="0" bIns="0"/>
+          <a:lstStyle/>
+          <a:p>
+            <a:pPr algn="ctr"/>
+          </a:p>
+        </p:txBody>
+      </p:sp>
+      <p:sp>
+        <p:nvSpPr>
+          <p:cNvPr id="17" name="TextBox 16"/>
+          <p:cNvSpPr txBox="1"/>
+          <p:nvPr/>
+        </p:nvSpPr>
+        <p:spPr>
+          <a:xfrm>
+            <a:off x="6648450" y="3586734"/>
+            <a:ext cx="4857750" cy="95250"/>
+          </a:xfrm>
+          <a:prstGeom prst="rect">
+            <a:avLst/>
+          </a:prstGeom>
+          <a:noFill/>
+        </p:spPr>
+        <p:txBody>
+          <a:bodyPr wrap="square" lIns="0" rIns="0" tIns="0" bIns="0" anchor="t">
+            <a:spAutoFit/>
+          </a:bodyPr>
+          <a:lstStyle/>
+          <a:p>
+            <a:pPr algn="l">
+              <a:lnSpc>
+                <a:spcPct val="130000"/>
+              </a:lnSpc>
+            </a:pPr>
+            <a:r>
+              <a:rPr sz="1580" b="0" i="0">
+                <a:solidFill>
+                  <a:srgbClr val="1A1A1E"/>
+                </a:solidFill>
+                <a:latin typeface="Roboto"/>
+              </a:rPr>
+              <a:t>Uma pessoa por evento, carga baixa, sem necessidade de réplica.</a:t>
+            </a:r>
+          </a:p>
+        </p:txBody>
+      </p:sp>
+      <p:sp>
+        <p:nvSpPr>
+          <p:cNvPr id="18" name="TextBox 17"/>
+          <p:cNvSpPr txBox="1"/>
+          <p:nvPr/>
+        </p:nvSpPr>
+        <p:spPr>
+          <a:xfrm>
+            <a:off x="685800" y="6324600"/>
+            <a:ext cx="6667500" cy="182880"/>
+          </a:xfrm>
+          <a:prstGeom prst="rect">
+            <a:avLst/>
+          </a:prstGeom>
+          <a:noFill/>
+        </p:spPr>
+        <p:txBody>
+          <a:bodyPr wrap="square" lIns="0" rIns="0" tIns="0" bIns="0" anchor="t">
+            <a:spAutoFit/>
+          </a:bodyPr>
+          <a:lstStyle/>
+          <a:p>
+            <a:pPr algn="l">
+              <a:lnSpc>
+                <a:spcPct val="120000"/>
+              </a:lnSpc>
+            </a:pPr>
+            <a:r>
               <a:rPr sz="900" b="0" i="0">
                 <a:solidFill>
                   <a:srgbClr val="6B6B78"/>
@@ -20497,7 +20813,7 @@
       </p:sp>
       <p:sp>
         <p:nvSpPr>
-          <p:cNvPr id="11" name="TextBox 10"/>
+          <p:cNvPr id="19" name="TextBox 18"/>
           <p:cNvSpPr txBox="1"/>
           <p:nvPr/>
         </p:nvSpPr>

</xml_diff>

<commit_message>
docs: alinha a demonstracao do T1 aos tres servicos do compose
</commit_message>
<xml_diff>
--- a/trabalhos/T1-Docker-Invite-People.pptx
+++ b/trabalhos/T1-Docker-Invite-People.pptx
@@ -22134,12 +22134,12 @@
         </p:nvSpPr>
         <p:spPr>
           <a:xfrm>
-            <a:off x="685800" y="1821180"/>
-            <a:ext cx="10820400" cy="3524250"/>
+            <a:off x="685800" y="1702118"/>
+            <a:ext cx="10820400" cy="3762375"/>
           </a:xfrm>
           <a:prstGeom prst="roundRect">
             <a:avLst>
-              <a:gd name="adj" fmla="val 2162"/>
+              <a:gd name="adj" fmla="val 2025"/>
             </a:avLst>
           </a:prstGeom>
           <a:solidFill>
@@ -22180,7 +22180,7 @@
         </p:nvSpPr>
         <p:spPr>
           <a:xfrm>
-            <a:off x="952500" y="2030730"/>
+            <a:off x="952500" y="1911668"/>
             <a:ext cx="323850" cy="28575"/>
           </a:xfrm>
           <a:prstGeom prst="roundRect">
@@ -22226,7 +22226,7 @@
         </p:nvSpPr>
         <p:spPr>
           <a:xfrm>
-            <a:off x="1371600" y="1973580"/>
+            <a:off x="1371600" y="1854518"/>
             <a:ext cx="1905000" cy="167640"/>
           </a:xfrm>
           <a:prstGeom prst="rect">
@@ -22265,7 +22265,7 @@
         </p:nvSpPr>
         <p:spPr>
           <a:xfrm>
-            <a:off x="952500" y="2316480"/>
+            <a:off x="952500" y="2197418"/>
             <a:ext cx="10287000" cy="228600"/>
           </a:xfrm>
           <a:prstGeom prst="rect">
@@ -22304,7 +22304,7 @@
         </p:nvSpPr>
         <p:spPr>
           <a:xfrm>
-            <a:off x="952500" y="2554605"/>
+            <a:off x="952500" y="2435542"/>
             <a:ext cx="10287000" cy="228600"/>
           </a:xfrm>
           <a:prstGeom prst="rect">
@@ -22343,7 +22343,7 @@
         </p:nvSpPr>
         <p:spPr>
           <a:xfrm>
-            <a:off x="952500" y="2792730"/>
+            <a:off x="952500" y="2673668"/>
             <a:ext cx="10287000" cy="228600"/>
           </a:xfrm>
           <a:prstGeom prst="rect">
@@ -22369,7 +22369,7 @@
                 </a:solidFill>
                 <a:latin typeface="Roboto Mono"/>
               </a:rPr>
-              <a:t>NAME   IMAGE          STATUS</a:t>
+              <a:t>NAME    IMAGE             STATUS</a:t>
             </a:r>
           </a:p>
         </p:txBody>
@@ -22382,7 +22382,7 @@
         </p:nvSpPr>
         <p:spPr>
           <a:xfrm>
-            <a:off x="952500" y="3030855"/>
+            <a:off x="952500" y="2911792"/>
             <a:ext cx="10287000" cy="228600"/>
           </a:xfrm>
           <a:prstGeom prst="rect">
@@ -22408,7 +22408,7 @@
                 </a:solidFill>
                 <a:latin typeface="Roboto Mono"/>
               </a:rPr>
-              <a:t>web    nginx:alpine   Up</a:t>
+              <a:t>front   nginx:alpine      Up</a:t>
             </a:r>
           </a:p>
         </p:txBody>
@@ -22421,7 +22421,7 @@
         </p:nvSpPr>
         <p:spPr>
           <a:xfrm>
-            <a:off x="952500" y="3268980"/>
+            <a:off x="952500" y="3149918"/>
             <a:ext cx="10287000" cy="228600"/>
           </a:xfrm>
           <a:prstGeom prst="rect">
@@ -22447,7 +22447,7 @@
                 </a:solidFill>
                 <a:latin typeface="Roboto Mono"/>
               </a:rPr>
-              <a:t>db     postgres:16    Up (healthy)</a:t>
+              <a:t>api     node:22-alpine    Up</a:t>
             </a:r>
           </a:p>
         </p:txBody>
@@ -22460,7 +22460,7 @@
         </p:nvSpPr>
         <p:spPr>
           <a:xfrm>
-            <a:off x="952500" y="3507105"/>
+            <a:off x="952500" y="3388042"/>
             <a:ext cx="10287000" cy="228600"/>
           </a:xfrm>
           <a:prstGeom prst="rect">
@@ -22486,7 +22486,7 @@
                 </a:solidFill>
                 <a:latin typeface="Roboto Mono"/>
               </a:rPr>
-              <a:t> </a:t>
+              <a:t>db      postgres:16       Up (healthy)</a:t>
             </a:r>
           </a:p>
         </p:txBody>
@@ -22499,7 +22499,7 @@
         </p:nvSpPr>
         <p:spPr>
           <a:xfrm>
-            <a:off x="952500" y="3745230"/>
+            <a:off x="952500" y="3626168"/>
             <a:ext cx="10287000" cy="228600"/>
           </a:xfrm>
           <a:prstGeom prst="rect">
@@ -22521,11 +22521,11 @@
             <a:r>
               <a:rPr sz="1120" b="0" i="0">
                 <a:solidFill>
-                  <a:srgbClr val="7FE3A1"/>
+                  <a:srgbClr val="E4E4EC"/>
                 </a:solidFill>
                 <a:latin typeface="Roboto Mono"/>
               </a:rPr>
-              <a:t>$ docker compose run --rm client psql -h db -c "create table t(); "</a:t>
+              <a:t> </a:t>
             </a:r>
           </a:p>
         </p:txBody>
@@ -22538,7 +22538,7 @@
         </p:nvSpPr>
         <p:spPr>
           <a:xfrm>
-            <a:off x="952500" y="3983355"/>
+            <a:off x="952500" y="3864292"/>
             <a:ext cx="10287000" cy="228600"/>
           </a:xfrm>
           <a:prstGeom prst="rect">
@@ -22564,7 +22564,7 @@
                 </a:solidFill>
                 <a:latin typeface="Roboto Mono"/>
               </a:rPr>
-              <a:t>$ docker compose down &amp;&amp; docker compose up -d</a:t>
+              <a:t>$ docker compose exec db psql -U app -c "create table t()"</a:t>
             </a:r>
           </a:p>
         </p:txBody>
@@ -22577,7 +22577,7 @@
         </p:nvSpPr>
         <p:spPr>
           <a:xfrm>
-            <a:off x="952500" y="4221480"/>
+            <a:off x="952500" y="4102418"/>
             <a:ext cx="10287000" cy="228600"/>
           </a:xfrm>
           <a:prstGeom prst="rect">
@@ -22599,11 +22599,11 @@
             <a:r>
               <a:rPr sz="1120" b="0" i="0">
                 <a:solidFill>
-                  <a:srgbClr val="8A8A9A"/>
+                  <a:srgbClr val="7FE3A1"/>
                 </a:solidFill>
                 <a:latin typeface="Roboto Mono"/>
               </a:rPr>
-              <a:t># a tabela continua lá, o volume sobreviveu</a:t>
+              <a:t>$ docker compose down &amp;&amp; docker compose up -d</a:t>
             </a:r>
           </a:p>
         </p:txBody>
@@ -22616,7 +22616,7 @@
         </p:nvSpPr>
         <p:spPr>
           <a:xfrm>
-            <a:off x="952500" y="4459605"/>
+            <a:off x="952500" y="4340542"/>
             <a:ext cx="10287000" cy="228600"/>
           </a:xfrm>
           <a:prstGeom prst="rect">
@@ -22638,11 +22638,11 @@
             <a:r>
               <a:rPr sz="1120" b="0" i="0">
                 <a:solidFill>
-                  <a:srgbClr val="E4E4EC"/>
+                  <a:srgbClr val="8A8A9A"/>
                 </a:solidFill>
                 <a:latin typeface="Roboto Mono"/>
               </a:rPr>
-              <a:t> </a:t>
+              <a:t># a tabela continua lá, o volume sobreviveu</a:t>
             </a:r>
           </a:p>
         </p:txBody>
@@ -22655,7 +22655,7 @@
         </p:nvSpPr>
         <p:spPr>
           <a:xfrm>
-            <a:off x="952500" y="4697730"/>
+            <a:off x="952500" y="4578668"/>
             <a:ext cx="10287000" cy="228600"/>
           </a:xfrm>
           <a:prstGeom prst="rect">
@@ -22677,11 +22677,11 @@
             <a:r>
               <a:rPr sz="1120" b="0" i="0">
                 <a:solidFill>
-                  <a:srgbClr val="7FE3A1"/>
+                  <a:srgbClr val="E4E4EC"/>
                 </a:solidFill>
                 <a:latin typeface="Roboto Mono"/>
               </a:rPr>
-              <a:t>$ docker compose down -v</a:t>
+              <a:t> </a:t>
             </a:r>
           </a:p>
         </p:txBody>
@@ -22694,7 +22694,7 @@
         </p:nvSpPr>
         <p:spPr>
           <a:xfrm>
-            <a:off x="952500" y="4935855"/>
+            <a:off x="952500" y="4816792"/>
             <a:ext cx="10287000" cy="228600"/>
           </a:xfrm>
           <a:prstGeom prst="rect">
@@ -22716,6 +22716,45 @@
             <a:r>
               <a:rPr sz="1120" b="0" i="0">
                 <a:solidFill>
+                  <a:srgbClr val="7FE3A1"/>
+                </a:solidFill>
+                <a:latin typeface="Roboto Mono"/>
+              </a:rPr>
+              <a:t>$ docker compose down -v</a:t>
+            </a:r>
+          </a:p>
+        </p:txBody>
+      </p:sp>
+      <p:sp>
+        <p:nvSpPr>
+          <p:cNvPr id="19" name="TextBox 18"/>
+          <p:cNvSpPr txBox="1"/>
+          <p:nvPr/>
+        </p:nvSpPr>
+        <p:spPr>
+          <a:xfrm>
+            <a:off x="952500" y="5054918"/>
+            <a:ext cx="10287000" cy="228600"/>
+          </a:xfrm>
+          <a:prstGeom prst="rect">
+            <a:avLst/>
+          </a:prstGeom>
+          <a:noFill/>
+        </p:spPr>
+        <p:txBody>
+          <a:bodyPr wrap="square" lIns="0" rIns="0" tIns="0" bIns="0" anchor="t">
+            <a:spAutoFit/>
+          </a:bodyPr>
+          <a:lstStyle/>
+          <a:p>
+            <a:pPr algn="l">
+              <a:lnSpc>
+                <a:spcPct val="120000"/>
+              </a:lnSpc>
+            </a:pPr>
+            <a:r>
+              <a:rPr sz="1120" b="0" i="0">
+                <a:solidFill>
                   <a:srgbClr val="8A8A9A"/>
                 </a:solidFill>
                 <a:latin typeface="Roboto Mono"/>
@@ -22727,13 +22766,13 @@
       </p:sp>
       <p:sp>
         <p:nvSpPr>
-          <p:cNvPr id="19" name="Rectangle 18"/>
+          <p:cNvPr id="20" name="Rectangle 19"/>
           <p:cNvSpPr/>
           <p:nvPr/>
         </p:nvSpPr>
         <p:spPr>
           <a:xfrm>
-            <a:off x="685800" y="5574030"/>
+            <a:off x="685800" y="5693092"/>
             <a:ext cx="28575" cy="377190"/>
           </a:xfrm>
           <a:prstGeom prst="rect">
@@ -22771,13 +22810,13 @@
       </p:sp>
       <p:sp>
         <p:nvSpPr>
-          <p:cNvPr id="20" name="TextBox 19"/>
+          <p:cNvPr id="21" name="TextBox 20"/>
           <p:cNvSpPr txBox="1"/>
           <p:nvPr/>
         </p:nvSpPr>
         <p:spPr>
           <a:xfrm>
-            <a:off x="876300" y="5554980"/>
+            <a:off x="876300" y="5674042"/>
             <a:ext cx="10629900" cy="666750"/>
           </a:xfrm>
           <a:prstGeom prst="rect">
@@ -22810,7 +22849,7 @@
       </p:sp>
       <p:sp>
         <p:nvSpPr>
-          <p:cNvPr id="21" name="TextBox 20"/>
+          <p:cNvPr id="22" name="TextBox 21"/>
           <p:cNvSpPr txBox="1"/>
           <p:nvPr/>
         </p:nvSpPr>
@@ -22849,7 +22888,7 @@
       </p:sp>
       <p:sp>
         <p:nvSpPr>
-          <p:cNvPr id="22" name="TextBox 21"/>
+          <p:cNvPr id="23" name="TextBox 22"/>
           <p:cNvSpPr txBox="1"/>
           <p:nvPr/>
         </p:nvSpPr>

</xml_diff>

<commit_message>
docs: nome do servico de front-end por extenso no compose e na demonstracao do T1
</commit_message>
<xml_diff>
--- a/trabalhos/T1-Docker-Invite-People.pptx
+++ b/trabalhos/T1-Docker-Invite-People.pptx
@@ -18466,7 +18466,7 @@
                 </a:solidFill>
                 <a:latin typeface="Roboto Mono"/>
               </a:rPr>
-              <a:t>  front:</a:t>
+              <a:t>  front-end:</a:t>
             </a:r>
           </a:p>
         </p:txBody>
@@ -22369,7 +22369,7 @@
                 </a:solidFill>
                 <a:latin typeface="Roboto Mono"/>
               </a:rPr>
-              <a:t>NAME    IMAGE             STATUS</a:t>
+              <a:t>NAME        IMAGE             STATUS</a:t>
             </a:r>
           </a:p>
         </p:txBody>
@@ -22408,7 +22408,7 @@
                 </a:solidFill>
                 <a:latin typeface="Roboto Mono"/>
               </a:rPr>
-              <a:t>front   nginx:alpine      Up</a:t>
+              <a:t>front-end   nginx:alpine      Up</a:t>
             </a:r>
           </a:p>
         </p:txBody>
@@ -22447,7 +22447,7 @@
                 </a:solidFill>
                 <a:latin typeface="Roboto Mono"/>
               </a:rPr>
-              <a:t>api     node:22-alpine    Up</a:t>
+              <a:t>api         node:22-alpine    Up</a:t>
             </a:r>
           </a:p>
         </p:txBody>
@@ -22486,7 +22486,7 @@
                 </a:solidFill>
                 <a:latin typeface="Roboto Mono"/>
               </a:rPr>
-              <a:t>db      postgres:16       Up (healthy)</a:t>
+              <a:t>db          postgres:16       Up (healthy)</a:t>
             </a:r>
           </a:p>
         </p:txBody>

</xml_diff>

<commit_message>
docs: compose do slide de antes e agora com os tres servicos
</commit_message>
<xml_diff>
--- a/trabalhos/T1-Docker-Invite-People.pptx
+++ b/trabalhos/T1-Docker-Invite-People.pptx
@@ -28161,7 +28161,7 @@
         </p:nvSpPr>
         <p:spPr>
           <a:xfrm>
-            <a:off x="857250" y="2409825"/>
+            <a:off x="857250" y="2181225"/>
             <a:ext cx="4762500" cy="182880"/>
           </a:xfrm>
           <a:prstGeom prst="rect">
@@ -28200,7 +28200,7 @@
         </p:nvSpPr>
         <p:spPr>
           <a:xfrm>
-            <a:off x="857250" y="2619375"/>
+            <a:off x="857250" y="2390775"/>
             <a:ext cx="419100" cy="28575"/>
           </a:xfrm>
           <a:prstGeom prst="rect">
@@ -28244,12 +28244,12 @@
         </p:nvSpPr>
         <p:spPr>
           <a:xfrm>
-            <a:off x="857250" y="2790825"/>
-            <a:ext cx="4762500" cy="1752600"/>
+            <a:off x="857250" y="2562225"/>
+            <a:ext cx="4762500" cy="2209800"/>
           </a:xfrm>
           <a:prstGeom prst="roundRect">
             <a:avLst>
-              <a:gd name="adj" fmla="val 3260"/>
+              <a:gd name="adj" fmla="val 2586"/>
             </a:avLst>
           </a:prstGeom>
           <a:solidFill>
@@ -28292,7 +28292,7 @@
         </p:nvSpPr>
         <p:spPr>
           <a:xfrm>
-            <a:off x="1066800" y="2962275"/>
+            <a:off x="1066800" y="2733675"/>
             <a:ext cx="4381500" cy="213360"/>
           </a:xfrm>
           <a:prstGeom prst="rect">
@@ -28331,7 +28331,7 @@
         </p:nvSpPr>
         <p:spPr>
           <a:xfrm>
-            <a:off x="1066800" y="3190875"/>
+            <a:off x="1066800" y="2962275"/>
             <a:ext cx="4381500" cy="213360"/>
           </a:xfrm>
           <a:prstGeom prst="rect">
@@ -28370,7 +28370,7 @@
         </p:nvSpPr>
         <p:spPr>
           <a:xfrm>
-            <a:off x="1066800" y="3419475"/>
+            <a:off x="1066800" y="3190875"/>
             <a:ext cx="4381500" cy="213360"/>
           </a:xfrm>
           <a:prstGeom prst="rect">
@@ -28409,7 +28409,7 @@
         </p:nvSpPr>
         <p:spPr>
           <a:xfrm>
-            <a:off x="1066800" y="3648075"/>
+            <a:off x="1066800" y="3419475"/>
             <a:ext cx="4381500" cy="213360"/>
           </a:xfrm>
           <a:prstGeom prst="rect">
@@ -28448,7 +28448,7 @@
         </p:nvSpPr>
         <p:spPr>
           <a:xfrm>
-            <a:off x="1066800" y="3876675"/>
+            <a:off x="1066800" y="3648075"/>
             <a:ext cx="4381500" cy="213360"/>
           </a:xfrm>
           <a:prstGeom prst="rect">
@@ -28487,7 +28487,7 @@
         </p:nvSpPr>
         <p:spPr>
           <a:xfrm>
-            <a:off x="1066800" y="4105275"/>
+            <a:off x="1066800" y="3876675"/>
             <a:ext cx="4381500" cy="213360"/>
           </a:xfrm>
           <a:prstGeom prst="rect">
@@ -28526,8 +28526,8 @@
         </p:nvSpPr>
         <p:spPr>
           <a:xfrm>
-            <a:off x="857250" y="4695825"/>
-            <a:ext cx="4762500" cy="666750"/>
+            <a:off x="1066800" y="4105275"/>
+            <a:ext cx="4381500" cy="213360"/>
           </a:xfrm>
           <a:prstGeom prst="rect">
             <a:avLst/>
@@ -28542,17 +28542,17 @@
           <a:p>
             <a:pPr algn="l">
               <a:lnSpc>
-                <a:spcPct val="145000"/>
-              </a:lnSpc>
-            </a:pPr>
-            <a:r>
-              <a:rPr sz="1120" b="0" i="0">
-                <a:solidFill>
-                  <a:srgbClr val="3A3A44"/>
-                </a:solidFill>
-                <a:latin typeface="Roboto"/>
-              </a:rPr>
-              <a:t>Uma linha no repositório, necessária porque o Git Bash falha no Windows sem ela. Os ambientes do time já divergiam antes do primeiro código do produto.</a:t>
+                <a:spcPct val="120000"/>
+              </a:lnSpc>
+            </a:pPr>
+            <a:r>
+              <a:rPr sz="1050" b="0" i="0">
+                <a:solidFill>
+                  <a:srgbClr val="1A1A1E"/>
+                </a:solidFill>
+                <a:latin typeface="Roboto Mono"/>
+              </a:rPr>
+              <a:t/>
             </a:r>
           </a:p>
         </p:txBody>
@@ -28565,8 +28565,8 @@
         </p:nvSpPr>
         <p:spPr>
           <a:xfrm>
-            <a:off x="6572250" y="2409825"/>
-            <a:ext cx="4762500" cy="182880"/>
+            <a:off x="1066800" y="4333875"/>
+            <a:ext cx="4381500" cy="213360"/>
           </a:xfrm>
           <a:prstGeom prst="rect">
             <a:avLst/>
@@ -28585,6 +28585,84 @@
               </a:lnSpc>
             </a:pPr>
             <a:r>
+              <a:rPr sz="1050" b="0" i="0">
+                <a:solidFill>
+                  <a:srgbClr val="1A1A1E"/>
+                </a:solidFill>
+                <a:latin typeface="Roboto Mono"/>
+              </a:rPr>
+              <a:t/>
+            </a:r>
+          </a:p>
+        </p:txBody>
+      </p:sp>
+      <p:sp>
+        <p:nvSpPr>
+          <p:cNvPr id="15" name="TextBox 14"/>
+          <p:cNvSpPr txBox="1"/>
+          <p:nvPr/>
+        </p:nvSpPr>
+        <p:spPr>
+          <a:xfrm>
+            <a:off x="857250" y="4924425"/>
+            <a:ext cx="4762500" cy="666750"/>
+          </a:xfrm>
+          <a:prstGeom prst="rect">
+            <a:avLst/>
+          </a:prstGeom>
+          <a:noFill/>
+        </p:spPr>
+        <p:txBody>
+          <a:bodyPr wrap="square" lIns="0" rIns="0" tIns="0" bIns="0" anchor="t">
+            <a:spAutoFit/>
+          </a:bodyPr>
+          <a:lstStyle/>
+          <a:p>
+            <a:pPr algn="l">
+              <a:lnSpc>
+                <a:spcPct val="145000"/>
+              </a:lnSpc>
+            </a:pPr>
+            <a:r>
+              <a:rPr sz="1120" b="0" i="0">
+                <a:solidFill>
+                  <a:srgbClr val="3A3A44"/>
+                </a:solidFill>
+                <a:latin typeface="Roboto"/>
+              </a:rPr>
+              <a:t>Uma linha no repositório, necessária porque o Git Bash falha no Windows sem ela. Os ambientes do time já divergiam antes do primeiro código do produto.</a:t>
+            </a:r>
+          </a:p>
+        </p:txBody>
+      </p:sp>
+      <p:sp>
+        <p:nvSpPr>
+          <p:cNvPr id="16" name="TextBox 15"/>
+          <p:cNvSpPr txBox="1"/>
+          <p:nvPr/>
+        </p:nvSpPr>
+        <p:spPr>
+          <a:xfrm>
+            <a:off x="6572250" y="2181225"/>
+            <a:ext cx="4762500" cy="182880"/>
+          </a:xfrm>
+          <a:prstGeom prst="rect">
+            <a:avLst/>
+          </a:prstGeom>
+          <a:noFill/>
+        </p:spPr>
+        <p:txBody>
+          <a:bodyPr wrap="square" lIns="0" rIns="0" tIns="0" bIns="0" anchor="t">
+            <a:spAutoFit/>
+          </a:bodyPr>
+          <a:lstStyle/>
+          <a:p>
+            <a:pPr algn="l">
+              <a:lnSpc>
+                <a:spcPct val="120000"/>
+              </a:lnSpc>
+            </a:pPr>
+            <a:r>
               <a:rPr sz="900" b="1" i="0" spc="140">
                 <a:solidFill>
                   <a:srgbClr val="E94D1C"/>
@@ -28598,13 +28676,13 @@
       </p:sp>
       <p:sp>
         <p:nvSpPr>
-          <p:cNvPr id="15" name="Rectangle 14"/>
+          <p:cNvPr id="17" name="Rectangle 16"/>
           <p:cNvSpPr/>
           <p:nvPr/>
         </p:nvSpPr>
         <p:spPr>
           <a:xfrm>
-            <a:off x="6572250" y="2619375"/>
+            <a:off x="6572250" y="2390775"/>
             <a:ext cx="419100" cy="28575"/>
           </a:xfrm>
           <a:prstGeom prst="rect">
@@ -28642,18 +28720,18 @@
       </p:sp>
       <p:sp>
         <p:nvSpPr>
-          <p:cNvPr id="16" name="Rounded Rectangle 15"/>
+          <p:cNvPr id="18" name="Rounded Rectangle 17"/>
           <p:cNvSpPr/>
           <p:nvPr/>
         </p:nvSpPr>
         <p:spPr>
           <a:xfrm>
-            <a:off x="6572250" y="2790825"/>
-            <a:ext cx="4762500" cy="1752600"/>
+            <a:off x="6572250" y="2562225"/>
+            <a:ext cx="4762500" cy="2209800"/>
           </a:xfrm>
           <a:prstGeom prst="roundRect">
             <a:avLst>
-              <a:gd name="adj" fmla="val 3260"/>
+              <a:gd name="adj" fmla="val 2586"/>
             </a:avLst>
           </a:prstGeom>
           <a:solidFill>
@@ -28690,13 +28768,13 @@
       </p:sp>
       <p:sp>
         <p:nvSpPr>
-          <p:cNvPr id="17" name="TextBox 16"/>
+          <p:cNvPr id="19" name="TextBox 18"/>
           <p:cNvSpPr txBox="1"/>
           <p:nvPr/>
         </p:nvSpPr>
         <p:spPr>
           <a:xfrm>
-            <a:off x="6781800" y="2962275"/>
+            <a:off x="6781800" y="2733675"/>
             <a:ext cx="4381500" cy="213360"/>
           </a:xfrm>
           <a:prstGeom prst="rect">
@@ -28729,13 +28807,13 @@
       </p:sp>
       <p:sp>
         <p:nvSpPr>
-          <p:cNvPr id="18" name="TextBox 17"/>
+          <p:cNvPr id="20" name="TextBox 19"/>
           <p:cNvSpPr txBox="1"/>
           <p:nvPr/>
         </p:nvSpPr>
         <p:spPr>
           <a:xfrm>
-            <a:off x="6781800" y="3190875"/>
+            <a:off x="6781800" y="2962275"/>
             <a:ext cx="4381500" cy="213360"/>
           </a:xfrm>
           <a:prstGeom prst="rect">
@@ -28768,13 +28846,13 @@
       </p:sp>
       <p:sp>
         <p:nvSpPr>
-          <p:cNvPr id="19" name="TextBox 18"/>
+          <p:cNvPr id="21" name="TextBox 20"/>
           <p:cNvSpPr txBox="1"/>
           <p:nvPr/>
         </p:nvSpPr>
         <p:spPr>
           <a:xfrm>
-            <a:off x="6781800" y="3419475"/>
+            <a:off x="6781800" y="3190875"/>
             <a:ext cx="4381500" cy="213360"/>
           </a:xfrm>
           <a:prstGeom prst="rect">
@@ -28800,20 +28878,20 @@
                 </a:solidFill>
                 <a:latin typeface="Roboto Mono"/>
               </a:rPr>
-              <a:t>  api:</a:t>
-            </a:r>
-          </a:p>
-        </p:txBody>
-      </p:sp>
-      <p:sp>
-        <p:nvSpPr>
-          <p:cNvPr id="20" name="TextBox 19"/>
+              <a:t>  front-end:</a:t>
+            </a:r>
+          </a:p>
+        </p:txBody>
+      </p:sp>
+      <p:sp>
+        <p:nvSpPr>
+          <p:cNvPr id="22" name="TextBox 21"/>
           <p:cNvSpPr txBox="1"/>
           <p:nvPr/>
         </p:nvSpPr>
         <p:spPr>
           <a:xfrm>
-            <a:off x="6781800" y="3648075"/>
+            <a:off x="6781800" y="3419475"/>
             <a:ext cx="4381500" cy="213360"/>
           </a:xfrm>
           <a:prstGeom prst="rect">
@@ -28839,20 +28917,20 @@
                 </a:solidFill>
                 <a:latin typeface="Roboto Mono"/>
               </a:rPr>
-              <a:t>    image: node:22-alpine</a:t>
-            </a:r>
-          </a:p>
-        </p:txBody>
-      </p:sp>
-      <p:sp>
-        <p:nvSpPr>
-          <p:cNvPr id="21" name="TextBox 20"/>
+              <a:t>    image: nginx:alpine</a:t>
+            </a:r>
+          </a:p>
+        </p:txBody>
+      </p:sp>
+      <p:sp>
+        <p:nvSpPr>
+          <p:cNvPr id="23" name="TextBox 22"/>
           <p:cNvSpPr txBox="1"/>
           <p:nvPr/>
         </p:nvSpPr>
         <p:spPr>
           <a:xfrm>
-            <a:off x="6781800" y="3876675"/>
+            <a:off x="6781800" y="3648075"/>
             <a:ext cx="4381500" cy="213360"/>
           </a:xfrm>
           <a:prstGeom prst="rect">
@@ -28878,20 +28956,20 @@
                 </a:solidFill>
                 <a:latin typeface="Roboto Mono"/>
               </a:rPr>
-              <a:t>  db:</a:t>
-            </a:r>
-          </a:p>
-        </p:txBody>
-      </p:sp>
-      <p:sp>
-        <p:nvSpPr>
-          <p:cNvPr id="22" name="TextBox 21"/>
+              <a:t>  api:</a:t>
+            </a:r>
+          </a:p>
+        </p:txBody>
+      </p:sp>
+      <p:sp>
+        <p:nvSpPr>
+          <p:cNvPr id="24" name="TextBox 23"/>
           <p:cNvSpPr txBox="1"/>
           <p:nvPr/>
         </p:nvSpPr>
         <p:spPr>
           <a:xfrm>
-            <a:off x="6781800" y="4105275"/>
+            <a:off x="6781800" y="3876675"/>
             <a:ext cx="4381500" cy="213360"/>
           </a:xfrm>
           <a:prstGeom prst="rect">
@@ -28917,21 +28995,21 @@
                 </a:solidFill>
                 <a:latin typeface="Roboto Mono"/>
               </a:rPr>
-              <a:t>    image: postgres:16</a:t>
-            </a:r>
-          </a:p>
-        </p:txBody>
-      </p:sp>
-      <p:sp>
-        <p:nvSpPr>
-          <p:cNvPr id="23" name="TextBox 22"/>
+              <a:t>    image: node:22-alpine</a:t>
+            </a:r>
+          </a:p>
+        </p:txBody>
+      </p:sp>
+      <p:sp>
+        <p:nvSpPr>
+          <p:cNvPr id="25" name="TextBox 24"/>
           <p:cNvSpPr txBox="1"/>
           <p:nvPr/>
         </p:nvSpPr>
         <p:spPr>
           <a:xfrm>
-            <a:off x="6572250" y="4695825"/>
-            <a:ext cx="4762500" cy="666750"/>
+            <a:off x="6781800" y="4105275"/>
+            <a:ext cx="4381500" cy="213360"/>
           </a:xfrm>
           <a:prstGeom prst="rect">
             <a:avLst/>
@@ -28946,31 +29024,31 @@
           <a:p>
             <a:pPr algn="l">
               <a:lnSpc>
-                <a:spcPct val="145000"/>
-              </a:lnSpc>
-            </a:pPr>
-            <a:r>
-              <a:rPr sz="1120" b="0" i="0">
-                <a:solidFill>
-                  <a:srgbClr val="3A3A44"/>
-                </a:solidFill>
-                <a:latin typeface="Roboto"/>
-              </a:rPr>
-              <a:t>Um arquivo que descreve o ambiente inteiro e que qualquer um dos quatro sobe com um comando. Esse arquivo é a base do diagrama de implantação.</a:t>
-            </a:r>
-          </a:p>
-        </p:txBody>
-      </p:sp>
-      <p:sp>
-        <p:nvSpPr>
-          <p:cNvPr id="24" name="TextBox 23"/>
+                <a:spcPct val="120000"/>
+              </a:lnSpc>
+            </a:pPr>
+            <a:r>
+              <a:rPr sz="1050" b="0" i="0">
+                <a:solidFill>
+                  <a:srgbClr val="1A1A1E"/>
+                </a:solidFill>
+                <a:latin typeface="Roboto Mono"/>
+              </a:rPr>
+              <a:t>  db:</a:t>
+            </a:r>
+          </a:p>
+        </p:txBody>
+      </p:sp>
+      <p:sp>
+        <p:nvSpPr>
+          <p:cNvPr id="26" name="TextBox 25"/>
           <p:cNvSpPr txBox="1"/>
           <p:nvPr/>
         </p:nvSpPr>
         <p:spPr>
           <a:xfrm>
-            <a:off x="685800" y="6324600"/>
-            <a:ext cx="6667500" cy="182880"/>
+            <a:off x="6781800" y="4333875"/>
+            <a:ext cx="4381500" cy="213360"/>
           </a:xfrm>
           <a:prstGeom prst="rect">
             <a:avLst/>
@@ -28989,6 +29067,84 @@
               </a:lnSpc>
             </a:pPr>
             <a:r>
+              <a:rPr sz="1050" b="0" i="0">
+                <a:solidFill>
+                  <a:srgbClr val="1A1A1E"/>
+                </a:solidFill>
+                <a:latin typeface="Roboto Mono"/>
+              </a:rPr>
+              <a:t>    image: postgres:16</a:t>
+            </a:r>
+          </a:p>
+        </p:txBody>
+      </p:sp>
+      <p:sp>
+        <p:nvSpPr>
+          <p:cNvPr id="27" name="TextBox 26"/>
+          <p:cNvSpPr txBox="1"/>
+          <p:nvPr/>
+        </p:nvSpPr>
+        <p:spPr>
+          <a:xfrm>
+            <a:off x="6572250" y="4924425"/>
+            <a:ext cx="4762500" cy="666750"/>
+          </a:xfrm>
+          <a:prstGeom prst="rect">
+            <a:avLst/>
+          </a:prstGeom>
+          <a:noFill/>
+        </p:spPr>
+        <p:txBody>
+          <a:bodyPr wrap="square" lIns="0" rIns="0" tIns="0" bIns="0" anchor="t">
+            <a:spAutoFit/>
+          </a:bodyPr>
+          <a:lstStyle/>
+          <a:p>
+            <a:pPr algn="l">
+              <a:lnSpc>
+                <a:spcPct val="145000"/>
+              </a:lnSpc>
+            </a:pPr>
+            <a:r>
+              <a:rPr sz="1120" b="0" i="0">
+                <a:solidFill>
+                  <a:srgbClr val="3A3A44"/>
+                </a:solidFill>
+                <a:latin typeface="Roboto"/>
+              </a:rPr>
+              <a:t>Um arquivo que descreve o ambiente inteiro e que qualquer um dos quatro sobe com um comando. Esse arquivo é a base do diagrama de implantação.</a:t>
+            </a:r>
+          </a:p>
+        </p:txBody>
+      </p:sp>
+      <p:sp>
+        <p:nvSpPr>
+          <p:cNvPr id="28" name="TextBox 27"/>
+          <p:cNvSpPr txBox="1"/>
+          <p:nvPr/>
+        </p:nvSpPr>
+        <p:spPr>
+          <a:xfrm>
+            <a:off x="685800" y="6324600"/>
+            <a:ext cx="6667500" cy="182880"/>
+          </a:xfrm>
+          <a:prstGeom prst="rect">
+            <a:avLst/>
+          </a:prstGeom>
+          <a:noFill/>
+        </p:spPr>
+        <p:txBody>
+          <a:bodyPr wrap="square" lIns="0" rIns="0" tIns="0" bIns="0" anchor="t">
+            <a:spAutoFit/>
+          </a:bodyPr>
+          <a:lstStyle/>
+          <a:p>
+            <a:pPr algn="l">
+              <a:lnSpc>
+                <a:spcPct val="120000"/>
+              </a:lnSpc>
+            </a:pPr>
+            <a:r>
               <a:rPr sz="900" b="0" i="0">
                 <a:solidFill>
                   <a:srgbClr val="6B6B78"/>
@@ -29002,7 +29158,7 @@
       </p:sp>
       <p:sp>
         <p:nvSpPr>
-          <p:cNvPr id="25" name="TextBox 24"/>
+          <p:cNvPr id="29" name="TextBox 28"/>
           <p:cNvSpPr txBox="1"/>
           <p:nvPr/>
         </p:nvSpPr>

</xml_diff>

<commit_message>
docs: remove o slide de antes e agora do T1 e fecha no balanco de vantagens e limitacoes
</commit_message>
<xml_diff>
--- a/trabalhos/T1-Docker-Invite-People.pptx
+++ b/trabalhos/T1-Docker-Invite-People.pptx
@@ -34,7 +34,6 @@
     <p:sldId id="279" r:id="rId34"/>
     <p:sldId id="280" r:id="rId35"/>
     <p:sldId id="281" r:id="rId36"/>
-    <p:sldId id="282" r:id="rId37"/>
   </p:sldIdLst>
   <p:sldSz cx="12192000" cy="6858000"/>
   <p:notesSz cx="6858000" cy="9144000"/>
@@ -28148,542 +28147,21 @@
                 </a:solidFill>
                 <a:latin typeface="Roboto"/>
               </a:rPr>
-              <a:t>O que mudou no ambiente do time</a:t>
-            </a:r>
-          </a:p>
-        </p:txBody>
-      </p:sp>
-      <p:sp>
-        <p:nvSpPr>
-          <p:cNvPr id="4" name="TextBox 3"/>
-          <p:cNvSpPr txBox="1"/>
-          <p:nvPr/>
-        </p:nvSpPr>
-        <p:spPr>
-          <a:xfrm>
-            <a:off x="857250" y="2181225"/>
-            <a:ext cx="4762500" cy="182880"/>
-          </a:xfrm>
-          <a:prstGeom prst="rect">
-            <a:avLst/>
-          </a:prstGeom>
-          <a:noFill/>
-        </p:spPr>
-        <p:txBody>
-          <a:bodyPr wrap="square" lIns="0" rIns="0" tIns="0" bIns="0" anchor="t">
-            <a:spAutoFit/>
-          </a:bodyPr>
-          <a:lstStyle/>
-          <a:p>
-            <a:pPr algn="l">
-              <a:lnSpc>
-                <a:spcPct val="120000"/>
-              </a:lnSpc>
-            </a:pPr>
-            <a:r>
-              <a:rPr sz="900" b="1" i="0" spc="140">
-                <a:solidFill>
-                  <a:srgbClr val="21049A"/>
-                </a:solidFill>
-                <a:latin typeface="Roboto"/>
-              </a:rPr>
-              <a:t>NO COMEÇO DO PROJETO</a:t>
-            </a:r>
-          </a:p>
-        </p:txBody>
-      </p:sp>
-      <p:sp>
-        <p:nvSpPr>
-          <p:cNvPr id="5" name="Rectangle 4"/>
+              <a:t>Referências</a:t>
+            </a:r>
+          </a:p>
+        </p:txBody>
+      </p:sp>
+      <p:sp>
+        <p:nvSpPr>
+          <p:cNvPr id="4" name="Rectangle 3"/>
           <p:cNvSpPr/>
           <p:nvPr/>
         </p:nvSpPr>
         <p:spPr>
           <a:xfrm>
-            <a:off x="857250" y="2390775"/>
-            <a:ext cx="419100" cy="28575"/>
-          </a:xfrm>
-          <a:prstGeom prst="rect">
-            <a:avLst/>
-          </a:prstGeom>
-          <a:solidFill>
-            <a:srgbClr val="21049A"/>
-          </a:solidFill>
-          <a:ln>
-            <a:noFill/>
-          </a:ln>
-          <a:effectLst/>
-        </p:spPr>
-        <p:style>
-          <a:lnRef idx="1">
-            <a:schemeClr val="accent1"/>
-          </a:lnRef>
-          <a:fillRef idx="3">
-            <a:schemeClr val="accent1"/>
-          </a:fillRef>
-          <a:effectRef idx="2">
-            <a:schemeClr val="accent1"/>
-          </a:effectRef>
-          <a:fontRef idx="minor">
-            <a:schemeClr val="lt1"/>
-          </a:fontRef>
-        </p:style>
-        <p:txBody>
-          <a:bodyPr rtlCol="0" anchor="ctr" wrap="square" lIns="0" rIns="0" tIns="0" bIns="0"/>
-          <a:lstStyle/>
-          <a:p>
-            <a:pPr algn="ctr"/>
-          </a:p>
-        </p:txBody>
-      </p:sp>
-      <p:sp>
-        <p:nvSpPr>
-          <p:cNvPr id="6" name="Rounded Rectangle 5"/>
-          <p:cNvSpPr/>
-          <p:nvPr/>
-        </p:nvSpPr>
-        <p:spPr>
-          <a:xfrm>
-            <a:off x="857250" y="2562225"/>
-            <a:ext cx="4762500" cy="2209800"/>
-          </a:xfrm>
-          <a:prstGeom prst="roundRect">
-            <a:avLst>
-              <a:gd name="adj" fmla="val 2586"/>
-            </a:avLst>
-          </a:prstGeom>
-          <a:solidFill>
-            <a:srgbClr val="F2F2F5"/>
-          </a:solidFill>
-          <a:ln w="12700">
-            <a:solidFill>
-              <a:srgbClr val="D9D9D9"/>
-            </a:solidFill>
-          </a:ln>
-          <a:effectLst/>
-        </p:spPr>
-        <p:style>
-          <a:lnRef idx="1">
-            <a:schemeClr val="accent1"/>
-          </a:lnRef>
-          <a:fillRef idx="3">
-            <a:schemeClr val="accent1"/>
-          </a:fillRef>
-          <a:effectRef idx="2">
-            <a:schemeClr val="accent1"/>
-          </a:effectRef>
-          <a:fontRef idx="minor">
-            <a:schemeClr val="lt1"/>
-          </a:fontRef>
-        </p:style>
-        <p:txBody>
-          <a:bodyPr rtlCol="0" anchor="ctr" wrap="square" lIns="0" rIns="0" tIns="0" bIns="0"/>
-          <a:lstStyle/>
-          <a:p>
-            <a:pPr algn="ctr"/>
-          </a:p>
-        </p:txBody>
-      </p:sp>
-      <p:sp>
-        <p:nvSpPr>
-          <p:cNvPr id="7" name="TextBox 6"/>
-          <p:cNvSpPr txBox="1"/>
-          <p:nvPr/>
-        </p:nvSpPr>
-        <p:spPr>
-          <a:xfrm>
-            <a:off x="1066800" y="2733675"/>
-            <a:ext cx="4381500" cy="213360"/>
-          </a:xfrm>
-          <a:prstGeom prst="rect">
-            <a:avLst/>
-          </a:prstGeom>
-          <a:noFill/>
-        </p:spPr>
-        <p:txBody>
-          <a:bodyPr wrap="square" lIns="0" rIns="0" tIns="0" bIns="0" anchor="t">
-            <a:spAutoFit/>
-          </a:bodyPr>
-          <a:lstStyle/>
-          <a:p>
-            <a:pPr algn="l">
-              <a:lnSpc>
-                <a:spcPct val="120000"/>
-              </a:lnSpc>
-            </a:pPr>
-            <a:r>
-              <a:rPr sz="1050" b="0" i="0">
-                <a:solidFill>
-                  <a:srgbClr val="6B6B78"/>
-                </a:solidFill>
-                <a:latin typeface="Roboto Mono"/>
-              </a:rPr>
-              <a:t># .gitattributes</a:t>
-            </a:r>
-          </a:p>
-        </p:txBody>
-      </p:sp>
-      <p:sp>
-        <p:nvSpPr>
-          <p:cNvPr id="8" name="TextBox 7"/>
-          <p:cNvSpPr txBox="1"/>
-          <p:nvPr/>
-        </p:nvSpPr>
-        <p:spPr>
-          <a:xfrm>
-            <a:off x="1066800" y="2962275"/>
-            <a:ext cx="4381500" cy="213360"/>
-          </a:xfrm>
-          <a:prstGeom prst="rect">
-            <a:avLst/>
-          </a:prstGeom>
-          <a:noFill/>
-        </p:spPr>
-        <p:txBody>
-          <a:bodyPr wrap="square" lIns="0" rIns="0" tIns="0" bIns="0" anchor="t">
-            <a:spAutoFit/>
-          </a:bodyPr>
-          <a:lstStyle/>
-          <a:p>
-            <a:pPr algn="l">
-              <a:lnSpc>
-                <a:spcPct val="120000"/>
-              </a:lnSpc>
-            </a:pPr>
-            <a:r>
-              <a:rPr sz="1050" b="0" i="0">
-                <a:solidFill>
-                  <a:srgbClr val="1A1A1E"/>
-                </a:solidFill>
-                <a:latin typeface="Roboto Mono"/>
-              </a:rPr>
-              <a:t>*.sh text eol=lf</a:t>
-            </a:r>
-          </a:p>
-        </p:txBody>
-      </p:sp>
-      <p:sp>
-        <p:nvSpPr>
-          <p:cNvPr id="9" name="TextBox 8"/>
-          <p:cNvSpPr txBox="1"/>
-          <p:nvPr/>
-        </p:nvSpPr>
-        <p:spPr>
-          <a:xfrm>
-            <a:off x="1066800" y="3190875"/>
-            <a:ext cx="4381500" cy="213360"/>
-          </a:xfrm>
-          <a:prstGeom prst="rect">
-            <a:avLst/>
-          </a:prstGeom>
-          <a:noFill/>
-        </p:spPr>
-        <p:txBody>
-          <a:bodyPr wrap="square" lIns="0" rIns="0" tIns="0" bIns="0" anchor="t">
-            <a:spAutoFit/>
-          </a:bodyPr>
-          <a:lstStyle/>
-          <a:p>
-            <a:pPr algn="l">
-              <a:lnSpc>
-                <a:spcPct val="120000"/>
-              </a:lnSpc>
-            </a:pPr>
-            <a:r>
-              <a:rPr sz="1050" b="0" i="0">
-                <a:solidFill>
-                  <a:srgbClr val="1A1A1E"/>
-                </a:solidFill>
-                <a:latin typeface="Roboto Mono"/>
-              </a:rPr>
-              <a:t/>
-            </a:r>
-          </a:p>
-        </p:txBody>
-      </p:sp>
-      <p:sp>
-        <p:nvSpPr>
-          <p:cNvPr id="10" name="TextBox 9"/>
-          <p:cNvSpPr txBox="1"/>
-          <p:nvPr/>
-        </p:nvSpPr>
-        <p:spPr>
-          <a:xfrm>
-            <a:off x="1066800" y="3419475"/>
-            <a:ext cx="4381500" cy="213360"/>
-          </a:xfrm>
-          <a:prstGeom prst="rect">
-            <a:avLst/>
-          </a:prstGeom>
-          <a:noFill/>
-        </p:spPr>
-        <p:txBody>
-          <a:bodyPr wrap="square" lIns="0" rIns="0" tIns="0" bIns="0" anchor="t">
-            <a:spAutoFit/>
-          </a:bodyPr>
-          <a:lstStyle/>
-          <a:p>
-            <a:pPr algn="l">
-              <a:lnSpc>
-                <a:spcPct val="120000"/>
-              </a:lnSpc>
-            </a:pPr>
-            <a:r>
-              <a:rPr sz="1050" b="0" i="0">
-                <a:solidFill>
-                  <a:srgbClr val="1A1A1E"/>
-                </a:solidFill>
-                <a:latin typeface="Roboto Mono"/>
-              </a:rPr>
-              <a:t/>
-            </a:r>
-          </a:p>
-        </p:txBody>
-      </p:sp>
-      <p:sp>
-        <p:nvSpPr>
-          <p:cNvPr id="11" name="TextBox 10"/>
-          <p:cNvSpPr txBox="1"/>
-          <p:nvPr/>
-        </p:nvSpPr>
-        <p:spPr>
-          <a:xfrm>
-            <a:off x="1066800" y="3648075"/>
-            <a:ext cx="4381500" cy="213360"/>
-          </a:xfrm>
-          <a:prstGeom prst="rect">
-            <a:avLst/>
-          </a:prstGeom>
-          <a:noFill/>
-        </p:spPr>
-        <p:txBody>
-          <a:bodyPr wrap="square" lIns="0" rIns="0" tIns="0" bIns="0" anchor="t">
-            <a:spAutoFit/>
-          </a:bodyPr>
-          <a:lstStyle/>
-          <a:p>
-            <a:pPr algn="l">
-              <a:lnSpc>
-                <a:spcPct val="120000"/>
-              </a:lnSpc>
-            </a:pPr>
-            <a:r>
-              <a:rPr sz="1050" b="0" i="0">
-                <a:solidFill>
-                  <a:srgbClr val="1A1A1E"/>
-                </a:solidFill>
-                <a:latin typeface="Roboto Mono"/>
-              </a:rPr>
-              <a:t/>
-            </a:r>
-          </a:p>
-        </p:txBody>
-      </p:sp>
-      <p:sp>
-        <p:nvSpPr>
-          <p:cNvPr id="12" name="TextBox 11"/>
-          <p:cNvSpPr txBox="1"/>
-          <p:nvPr/>
-        </p:nvSpPr>
-        <p:spPr>
-          <a:xfrm>
-            <a:off x="1066800" y="3876675"/>
-            <a:ext cx="4381500" cy="213360"/>
-          </a:xfrm>
-          <a:prstGeom prst="rect">
-            <a:avLst/>
-          </a:prstGeom>
-          <a:noFill/>
-        </p:spPr>
-        <p:txBody>
-          <a:bodyPr wrap="square" lIns="0" rIns="0" tIns="0" bIns="0" anchor="t">
-            <a:spAutoFit/>
-          </a:bodyPr>
-          <a:lstStyle/>
-          <a:p>
-            <a:pPr algn="l">
-              <a:lnSpc>
-                <a:spcPct val="120000"/>
-              </a:lnSpc>
-            </a:pPr>
-            <a:r>
-              <a:rPr sz="1050" b="0" i="0">
-                <a:solidFill>
-                  <a:srgbClr val="1A1A1E"/>
-                </a:solidFill>
-                <a:latin typeface="Roboto Mono"/>
-              </a:rPr>
-              <a:t/>
-            </a:r>
-          </a:p>
-        </p:txBody>
-      </p:sp>
-      <p:sp>
-        <p:nvSpPr>
-          <p:cNvPr id="13" name="TextBox 12"/>
-          <p:cNvSpPr txBox="1"/>
-          <p:nvPr/>
-        </p:nvSpPr>
-        <p:spPr>
-          <a:xfrm>
-            <a:off x="1066800" y="4105275"/>
-            <a:ext cx="4381500" cy="213360"/>
-          </a:xfrm>
-          <a:prstGeom prst="rect">
-            <a:avLst/>
-          </a:prstGeom>
-          <a:noFill/>
-        </p:spPr>
-        <p:txBody>
-          <a:bodyPr wrap="square" lIns="0" rIns="0" tIns="0" bIns="0" anchor="t">
-            <a:spAutoFit/>
-          </a:bodyPr>
-          <a:lstStyle/>
-          <a:p>
-            <a:pPr algn="l">
-              <a:lnSpc>
-                <a:spcPct val="120000"/>
-              </a:lnSpc>
-            </a:pPr>
-            <a:r>
-              <a:rPr sz="1050" b="0" i="0">
-                <a:solidFill>
-                  <a:srgbClr val="1A1A1E"/>
-                </a:solidFill>
-                <a:latin typeface="Roboto Mono"/>
-              </a:rPr>
-              <a:t/>
-            </a:r>
-          </a:p>
-        </p:txBody>
-      </p:sp>
-      <p:sp>
-        <p:nvSpPr>
-          <p:cNvPr id="14" name="TextBox 13"/>
-          <p:cNvSpPr txBox="1"/>
-          <p:nvPr/>
-        </p:nvSpPr>
-        <p:spPr>
-          <a:xfrm>
-            <a:off x="1066800" y="4333875"/>
-            <a:ext cx="4381500" cy="213360"/>
-          </a:xfrm>
-          <a:prstGeom prst="rect">
-            <a:avLst/>
-          </a:prstGeom>
-          <a:noFill/>
-        </p:spPr>
-        <p:txBody>
-          <a:bodyPr wrap="square" lIns="0" rIns="0" tIns="0" bIns="0" anchor="t">
-            <a:spAutoFit/>
-          </a:bodyPr>
-          <a:lstStyle/>
-          <a:p>
-            <a:pPr algn="l">
-              <a:lnSpc>
-                <a:spcPct val="120000"/>
-              </a:lnSpc>
-            </a:pPr>
-            <a:r>
-              <a:rPr sz="1050" b="0" i="0">
-                <a:solidFill>
-                  <a:srgbClr val="1A1A1E"/>
-                </a:solidFill>
-                <a:latin typeface="Roboto Mono"/>
-              </a:rPr>
-              <a:t/>
-            </a:r>
-          </a:p>
-        </p:txBody>
-      </p:sp>
-      <p:sp>
-        <p:nvSpPr>
-          <p:cNvPr id="15" name="TextBox 14"/>
-          <p:cNvSpPr txBox="1"/>
-          <p:nvPr/>
-        </p:nvSpPr>
-        <p:spPr>
-          <a:xfrm>
-            <a:off x="857250" y="4924425"/>
-            <a:ext cx="4762500" cy="666750"/>
-          </a:xfrm>
-          <a:prstGeom prst="rect">
-            <a:avLst/>
-          </a:prstGeom>
-          <a:noFill/>
-        </p:spPr>
-        <p:txBody>
-          <a:bodyPr wrap="square" lIns="0" rIns="0" tIns="0" bIns="0" anchor="t">
-            <a:spAutoFit/>
-          </a:bodyPr>
-          <a:lstStyle/>
-          <a:p>
-            <a:pPr algn="l">
-              <a:lnSpc>
-                <a:spcPct val="145000"/>
-              </a:lnSpc>
-            </a:pPr>
-            <a:r>
-              <a:rPr sz="1120" b="0" i="0">
-                <a:solidFill>
-                  <a:srgbClr val="3A3A44"/>
-                </a:solidFill>
-                <a:latin typeface="Roboto"/>
-              </a:rPr>
-              <a:t>Uma linha no repositório, necessária porque o Git Bash falha no Windows sem ela. Os ambientes do time já divergiam antes do primeiro código do produto.</a:t>
-            </a:r>
-          </a:p>
-        </p:txBody>
-      </p:sp>
-      <p:sp>
-        <p:nvSpPr>
-          <p:cNvPr id="16" name="TextBox 15"/>
-          <p:cNvSpPr txBox="1"/>
-          <p:nvPr/>
-        </p:nvSpPr>
-        <p:spPr>
-          <a:xfrm>
-            <a:off x="6572250" y="2181225"/>
-            <a:ext cx="4762500" cy="182880"/>
-          </a:xfrm>
-          <a:prstGeom prst="rect">
-            <a:avLst/>
-          </a:prstGeom>
-          <a:noFill/>
-        </p:spPr>
-        <p:txBody>
-          <a:bodyPr wrap="square" lIns="0" rIns="0" tIns="0" bIns="0" anchor="t">
-            <a:spAutoFit/>
-          </a:bodyPr>
-          <a:lstStyle/>
-          <a:p>
-            <a:pPr algn="l">
-              <a:lnSpc>
-                <a:spcPct val="120000"/>
-              </a:lnSpc>
-            </a:pPr>
-            <a:r>
-              <a:rPr sz="900" b="1" i="0" spc="140">
-                <a:solidFill>
-                  <a:srgbClr val="E94D1C"/>
-                </a:solidFill>
-                <a:latin typeface="Roboto"/>
-              </a:rPr>
-              <a:t>AGORA</a:t>
-            </a:r>
-          </a:p>
-        </p:txBody>
-      </p:sp>
-      <p:sp>
-        <p:nvSpPr>
-          <p:cNvPr id="17" name="Rectangle 16"/>
-          <p:cNvSpPr/>
-          <p:nvPr/>
-        </p:nvSpPr>
-        <p:spPr>
-          <a:xfrm>
-            <a:off x="6572250" y="2390775"/>
-            <a:ext cx="419100" cy="28575"/>
+            <a:off x="704850" y="2086166"/>
+            <a:ext cx="57150" cy="57150"/>
           </a:xfrm>
           <a:prstGeom prst="rect">
             <a:avLst/>
@@ -28720,62 +28198,14 @@
       </p:sp>
       <p:sp>
         <p:nvSpPr>
-          <p:cNvPr id="18" name="Rounded Rectangle 17"/>
-          <p:cNvSpPr/>
-          <p:nvPr/>
-        </p:nvSpPr>
-        <p:spPr>
-          <a:xfrm>
-            <a:off x="6572250" y="2562225"/>
-            <a:ext cx="4762500" cy="2209800"/>
-          </a:xfrm>
-          <a:prstGeom prst="roundRect">
-            <a:avLst>
-              <a:gd name="adj" fmla="val 2586"/>
-            </a:avLst>
-          </a:prstGeom>
-          <a:solidFill>
-            <a:srgbClr val="F2F2F5"/>
-          </a:solidFill>
-          <a:ln w="12700">
-            <a:solidFill>
-              <a:srgbClr val="D9D9D9"/>
-            </a:solidFill>
-          </a:ln>
-          <a:effectLst/>
-        </p:spPr>
-        <p:style>
-          <a:lnRef idx="1">
-            <a:schemeClr val="accent1"/>
-          </a:lnRef>
-          <a:fillRef idx="3">
-            <a:schemeClr val="accent1"/>
-          </a:fillRef>
-          <a:effectRef idx="2">
-            <a:schemeClr val="accent1"/>
-          </a:effectRef>
-          <a:fontRef idx="minor">
-            <a:schemeClr val="lt1"/>
-          </a:fontRef>
-        </p:style>
-        <p:txBody>
-          <a:bodyPr rtlCol="0" anchor="ctr" wrap="square" lIns="0" rIns="0" tIns="0" bIns="0"/>
-          <a:lstStyle/>
-          <a:p>
-            <a:pPr algn="ctr"/>
-          </a:p>
-        </p:txBody>
-      </p:sp>
-      <p:sp>
-        <p:nvSpPr>
-          <p:cNvPr id="19" name="TextBox 18"/>
+          <p:cNvPr id="5" name="TextBox 4"/>
           <p:cNvSpPr txBox="1"/>
           <p:nvPr/>
         </p:nvSpPr>
         <p:spPr>
           <a:xfrm>
-            <a:off x="6781800" y="2733675"/>
-            <a:ext cx="4381500" cy="213360"/>
+            <a:off x="971550" y="1992059"/>
+            <a:ext cx="9677400" cy="95250"/>
           </a:xfrm>
           <a:prstGeom prst="rect">
             <a:avLst/>
@@ -28790,509 +28220,30 @@
           <a:p>
             <a:pPr algn="l">
               <a:lnSpc>
-                <a:spcPct val="120000"/>
+                <a:spcPct val="130000"/>
               </a:lnSpc>
             </a:pPr>
             <a:r>
-              <a:rPr sz="1050" b="0" i="0">
-                <a:solidFill>
-                  <a:srgbClr val="6B6B78"/>
-                </a:solidFill>
-                <a:latin typeface="Roboto Mono"/>
-              </a:rPr>
-              <a:t># docker-compose.yml</a:t>
-            </a:r>
-          </a:p>
-        </p:txBody>
-      </p:sp>
-      <p:sp>
-        <p:nvSpPr>
-          <p:cNvPr id="20" name="TextBox 19"/>
-          <p:cNvSpPr txBox="1"/>
-          <p:nvPr/>
-        </p:nvSpPr>
-        <p:spPr>
-          <a:xfrm>
-            <a:off x="6781800" y="2962275"/>
-            <a:ext cx="4381500" cy="213360"/>
-          </a:xfrm>
-          <a:prstGeom prst="rect">
-            <a:avLst/>
-          </a:prstGeom>
-          <a:noFill/>
-        </p:spPr>
-        <p:txBody>
-          <a:bodyPr wrap="square" lIns="0" rIns="0" tIns="0" bIns="0" anchor="t">
-            <a:spAutoFit/>
-          </a:bodyPr>
-          <a:lstStyle/>
-          <a:p>
-            <a:pPr algn="l">
-              <a:lnSpc>
-                <a:spcPct val="120000"/>
-              </a:lnSpc>
-            </a:pPr>
-            <a:r>
-              <a:rPr sz="1050" b="0" i="0">
+              <a:rPr sz="1420" b="0" i="0">
                 <a:solidFill>
                   <a:srgbClr val="1A1A1E"/>
-                </a:solidFill>
-                <a:latin typeface="Roboto Mono"/>
-              </a:rPr>
-              <a:t>services:</a:t>
-            </a:r>
-          </a:p>
-        </p:txBody>
-      </p:sp>
-      <p:sp>
-        <p:nvSpPr>
-          <p:cNvPr id="21" name="TextBox 20"/>
-          <p:cNvSpPr txBox="1"/>
-          <p:nvPr/>
-        </p:nvSpPr>
-        <p:spPr>
-          <a:xfrm>
-            <a:off x="6781800" y="3190875"/>
-            <a:ext cx="4381500" cy="213360"/>
-          </a:xfrm>
-          <a:prstGeom prst="rect">
-            <a:avLst/>
-          </a:prstGeom>
-          <a:noFill/>
-        </p:spPr>
-        <p:txBody>
-          <a:bodyPr wrap="square" lIns="0" rIns="0" tIns="0" bIns="0" anchor="t">
-            <a:spAutoFit/>
-          </a:bodyPr>
-          <a:lstStyle/>
-          <a:p>
-            <a:pPr algn="l">
-              <a:lnSpc>
-                <a:spcPct val="120000"/>
-              </a:lnSpc>
-            </a:pPr>
-            <a:r>
-              <a:rPr sz="1050" b="0" i="0">
-                <a:solidFill>
-                  <a:srgbClr val="1A1A1E"/>
-                </a:solidFill>
-                <a:latin typeface="Roboto Mono"/>
-              </a:rPr>
-              <a:t>  front-end:</a:t>
-            </a:r>
-          </a:p>
-        </p:txBody>
-      </p:sp>
-      <p:sp>
-        <p:nvSpPr>
-          <p:cNvPr id="22" name="TextBox 21"/>
-          <p:cNvSpPr txBox="1"/>
-          <p:nvPr/>
-        </p:nvSpPr>
-        <p:spPr>
-          <a:xfrm>
-            <a:off x="6781800" y="3419475"/>
-            <a:ext cx="4381500" cy="213360"/>
-          </a:xfrm>
-          <a:prstGeom prst="rect">
-            <a:avLst/>
-          </a:prstGeom>
-          <a:noFill/>
-        </p:spPr>
-        <p:txBody>
-          <a:bodyPr wrap="square" lIns="0" rIns="0" tIns="0" bIns="0" anchor="t">
-            <a:spAutoFit/>
-          </a:bodyPr>
-          <a:lstStyle/>
-          <a:p>
-            <a:pPr algn="l">
-              <a:lnSpc>
-                <a:spcPct val="120000"/>
-              </a:lnSpc>
-            </a:pPr>
-            <a:r>
-              <a:rPr sz="1050" b="0" i="0">
-                <a:solidFill>
-                  <a:srgbClr val="1A1A1E"/>
-                </a:solidFill>
-                <a:latin typeface="Roboto Mono"/>
-              </a:rPr>
-              <a:t>    image: nginx:alpine</a:t>
-            </a:r>
-          </a:p>
-        </p:txBody>
-      </p:sp>
-      <p:sp>
-        <p:nvSpPr>
-          <p:cNvPr id="23" name="TextBox 22"/>
-          <p:cNvSpPr txBox="1"/>
-          <p:nvPr/>
-        </p:nvSpPr>
-        <p:spPr>
-          <a:xfrm>
-            <a:off x="6781800" y="3648075"/>
-            <a:ext cx="4381500" cy="213360"/>
-          </a:xfrm>
-          <a:prstGeom prst="rect">
-            <a:avLst/>
-          </a:prstGeom>
-          <a:noFill/>
-        </p:spPr>
-        <p:txBody>
-          <a:bodyPr wrap="square" lIns="0" rIns="0" tIns="0" bIns="0" anchor="t">
-            <a:spAutoFit/>
-          </a:bodyPr>
-          <a:lstStyle/>
-          <a:p>
-            <a:pPr algn="l">
-              <a:lnSpc>
-                <a:spcPct val="120000"/>
-              </a:lnSpc>
-            </a:pPr>
-            <a:r>
-              <a:rPr sz="1050" b="0" i="0">
-                <a:solidFill>
-                  <a:srgbClr val="1A1A1E"/>
-                </a:solidFill>
-                <a:latin typeface="Roboto Mono"/>
-              </a:rPr>
-              <a:t>  api:</a:t>
-            </a:r>
-          </a:p>
-        </p:txBody>
-      </p:sp>
-      <p:sp>
-        <p:nvSpPr>
-          <p:cNvPr id="24" name="TextBox 23"/>
-          <p:cNvSpPr txBox="1"/>
-          <p:nvPr/>
-        </p:nvSpPr>
-        <p:spPr>
-          <a:xfrm>
-            <a:off x="6781800" y="3876675"/>
-            <a:ext cx="4381500" cy="213360"/>
-          </a:xfrm>
-          <a:prstGeom prst="rect">
-            <a:avLst/>
-          </a:prstGeom>
-          <a:noFill/>
-        </p:spPr>
-        <p:txBody>
-          <a:bodyPr wrap="square" lIns="0" rIns="0" tIns="0" bIns="0" anchor="t">
-            <a:spAutoFit/>
-          </a:bodyPr>
-          <a:lstStyle/>
-          <a:p>
-            <a:pPr algn="l">
-              <a:lnSpc>
-                <a:spcPct val="120000"/>
-              </a:lnSpc>
-            </a:pPr>
-            <a:r>
-              <a:rPr sz="1050" b="0" i="0">
-                <a:solidFill>
-                  <a:srgbClr val="1A1A1E"/>
-                </a:solidFill>
-                <a:latin typeface="Roboto Mono"/>
-              </a:rPr>
-              <a:t>    image: node:22-alpine</a:t>
-            </a:r>
-          </a:p>
-        </p:txBody>
-      </p:sp>
-      <p:sp>
-        <p:nvSpPr>
-          <p:cNvPr id="25" name="TextBox 24"/>
-          <p:cNvSpPr txBox="1"/>
-          <p:nvPr/>
-        </p:nvSpPr>
-        <p:spPr>
-          <a:xfrm>
-            <a:off x="6781800" y="4105275"/>
-            <a:ext cx="4381500" cy="213360"/>
-          </a:xfrm>
-          <a:prstGeom prst="rect">
-            <a:avLst/>
-          </a:prstGeom>
-          <a:noFill/>
-        </p:spPr>
-        <p:txBody>
-          <a:bodyPr wrap="square" lIns="0" rIns="0" tIns="0" bIns="0" anchor="t">
-            <a:spAutoFit/>
-          </a:bodyPr>
-          <a:lstStyle/>
-          <a:p>
-            <a:pPr algn="l">
-              <a:lnSpc>
-                <a:spcPct val="120000"/>
-              </a:lnSpc>
-            </a:pPr>
-            <a:r>
-              <a:rPr sz="1050" b="0" i="0">
-                <a:solidFill>
-                  <a:srgbClr val="1A1A1E"/>
-                </a:solidFill>
-                <a:latin typeface="Roboto Mono"/>
-              </a:rPr>
-              <a:t>  db:</a:t>
-            </a:r>
-          </a:p>
-        </p:txBody>
-      </p:sp>
-      <p:sp>
-        <p:nvSpPr>
-          <p:cNvPr id="26" name="TextBox 25"/>
-          <p:cNvSpPr txBox="1"/>
-          <p:nvPr/>
-        </p:nvSpPr>
-        <p:spPr>
-          <a:xfrm>
-            <a:off x="6781800" y="4333875"/>
-            <a:ext cx="4381500" cy="213360"/>
-          </a:xfrm>
-          <a:prstGeom prst="rect">
-            <a:avLst/>
-          </a:prstGeom>
-          <a:noFill/>
-        </p:spPr>
-        <p:txBody>
-          <a:bodyPr wrap="square" lIns="0" rIns="0" tIns="0" bIns="0" anchor="t">
-            <a:spAutoFit/>
-          </a:bodyPr>
-          <a:lstStyle/>
-          <a:p>
-            <a:pPr algn="l">
-              <a:lnSpc>
-                <a:spcPct val="120000"/>
-              </a:lnSpc>
-            </a:pPr>
-            <a:r>
-              <a:rPr sz="1050" b="0" i="0">
-                <a:solidFill>
-                  <a:srgbClr val="1A1A1E"/>
-                </a:solidFill>
-                <a:latin typeface="Roboto Mono"/>
-              </a:rPr>
-              <a:t>    image: postgres:16</a:t>
-            </a:r>
-          </a:p>
-        </p:txBody>
-      </p:sp>
-      <p:sp>
-        <p:nvSpPr>
-          <p:cNvPr id="27" name="TextBox 26"/>
-          <p:cNvSpPr txBox="1"/>
-          <p:nvPr/>
-        </p:nvSpPr>
-        <p:spPr>
-          <a:xfrm>
-            <a:off x="6572250" y="4924425"/>
-            <a:ext cx="4762500" cy="666750"/>
-          </a:xfrm>
-          <a:prstGeom prst="rect">
-            <a:avLst/>
-          </a:prstGeom>
-          <a:noFill/>
-        </p:spPr>
-        <p:txBody>
-          <a:bodyPr wrap="square" lIns="0" rIns="0" tIns="0" bIns="0" anchor="t">
-            <a:spAutoFit/>
-          </a:bodyPr>
-          <a:lstStyle/>
-          <a:p>
-            <a:pPr algn="l">
-              <a:lnSpc>
-                <a:spcPct val="145000"/>
-              </a:lnSpc>
-            </a:pPr>
-            <a:r>
-              <a:rPr sz="1120" b="0" i="0">
-                <a:solidFill>
-                  <a:srgbClr val="3A3A44"/>
                 </a:solidFill>
                 <a:latin typeface="Roboto"/>
               </a:rPr>
-              <a:t>Um arquivo que descreve o ambiente inteiro e que qualquer um dos quatro sobe com um comando. Esse arquivo é a base do diagrama de implantação.</a:t>
-            </a:r>
-          </a:p>
-        </p:txBody>
-      </p:sp>
-      <p:sp>
-        <p:nvSpPr>
-          <p:cNvPr id="28" name="TextBox 27"/>
-          <p:cNvSpPr txBox="1"/>
-          <p:nvPr/>
-        </p:nvSpPr>
-        <p:spPr>
-          <a:xfrm>
-            <a:off x="685800" y="6324600"/>
-            <a:ext cx="6667500" cy="182880"/>
-          </a:xfrm>
-          <a:prstGeom prst="rect">
-            <a:avLst/>
-          </a:prstGeom>
-          <a:noFill/>
-        </p:spPr>
-        <p:txBody>
-          <a:bodyPr wrap="square" lIns="0" rIns="0" tIns="0" bIns="0" anchor="t">
-            <a:spAutoFit/>
-          </a:bodyPr>
-          <a:lstStyle/>
-          <a:p>
-            <a:pPr algn="l">
-              <a:lnSpc>
-                <a:spcPct val="120000"/>
-              </a:lnSpc>
-            </a:pPr>
-            <a:r>
-              <a:rPr sz="900" b="0" i="0">
-                <a:solidFill>
-                  <a:srgbClr val="6B6B78"/>
-                </a:solidFill>
-                <a:latin typeface="Roboto"/>
-              </a:rPr>
-              <a:t>Considerações finais</a:t>
-            </a:r>
-          </a:p>
-        </p:txBody>
-      </p:sp>
-      <p:sp>
-        <p:nvSpPr>
-          <p:cNvPr id="29" name="TextBox 28"/>
-          <p:cNvSpPr txBox="1"/>
-          <p:nvPr/>
-        </p:nvSpPr>
-        <p:spPr>
-          <a:xfrm>
-            <a:off x="10477500" y="6324600"/>
-            <a:ext cx="1028700" cy="182880"/>
-          </a:xfrm>
-          <a:prstGeom prst="rect">
-            <a:avLst/>
-          </a:prstGeom>
-          <a:noFill/>
-        </p:spPr>
-        <p:txBody>
-          <a:bodyPr wrap="square" lIns="0" rIns="0" tIns="0" bIns="0" anchor="t">
-            <a:spAutoFit/>
-          </a:bodyPr>
-          <a:lstStyle/>
-          <a:p>
-            <a:pPr algn="r">
-              <a:lnSpc>
-                <a:spcPct val="120000"/>
-              </a:lnSpc>
-            </a:pPr>
-            <a:r>
-              <a:rPr sz="900" b="1" i="0">
-                <a:solidFill>
-                  <a:srgbClr val="21049A"/>
-                </a:solidFill>
-                <a:latin typeface="Roboto"/>
-              </a:rPr>
-              <a:t>26</a:t>
-            </a:r>
-          </a:p>
-        </p:txBody>
-      </p:sp>
-    </p:spTree>
-  </p:cSld>
-  <p:clrMapOvr>
-    <a:masterClrMapping/>
-  </p:clrMapOvr>
-</p:sld>
-</file>
-
-<file path=ppt/slides/slide27.xml><?xml version="1.0" encoding="utf-8"?>
-<p:sld xmlns:a="http://schemas.openxmlformats.org/drawingml/2006/main" xmlns:p="http://schemas.openxmlformats.org/presentationml/2006/main" xmlns:r="http://schemas.openxmlformats.org/officeDocument/2006/relationships">
-  <p:cSld>
-    <p:bg>
-      <p:bgPr>
-        <a:solidFill>
-          <a:srgbClr val="FFFFFF"/>
-        </a:solidFill>
-        <a:effectLst/>
-      </p:bgPr>
-    </p:bg>
-    <p:spTree>
-      <p:nvGrpSpPr>
-        <p:cNvPr id="1" name=""/>
-        <p:cNvGrpSpPr/>
-        <p:nvPr/>
-      </p:nvGrpSpPr>
-      <p:grpSpPr/>
-      <p:pic>
-        <p:nvPicPr>
-          <p:cNvPr id="2" name="Picture 1" descr="u-azul.png"/>
-          <p:cNvPicPr>
-            <a:picLocks noChangeAspect="1"/>
-          </p:cNvPicPr>
-          <p:nvPr/>
-        </p:nvPicPr>
-        <p:blipFill>
-          <a:blip r:embed="rId2"/>
-          <a:stretch>
-            <a:fillRect/>
-          </a:stretch>
-        </p:blipFill>
-        <p:spPr>
-          <a:xfrm>
-            <a:off x="10744200" y="457200"/>
-            <a:ext cx="342900" cy="342900"/>
-          </a:xfrm>
-          <a:prstGeom prst="rect">
-            <a:avLst/>
-          </a:prstGeom>
-        </p:spPr>
-      </p:pic>
-      <p:sp>
-        <p:nvSpPr>
-          <p:cNvPr id="3" name="TextBox 2"/>
-          <p:cNvSpPr txBox="1"/>
-          <p:nvPr/>
-        </p:nvSpPr>
-        <p:spPr>
-          <a:xfrm>
-            <a:off x="685800" y="685800"/>
-            <a:ext cx="9620250" cy="1524000"/>
-          </a:xfrm>
-          <a:prstGeom prst="rect">
-            <a:avLst/>
-          </a:prstGeom>
-          <a:noFill/>
-        </p:spPr>
-        <p:txBody>
-          <a:bodyPr wrap="square" lIns="0" rIns="0" tIns="0" bIns="0" anchor="t">
-            <a:spAutoFit/>
-          </a:bodyPr>
-          <a:lstStyle/>
-          <a:p>
-            <a:pPr algn="l">
-              <a:lnSpc>
-                <a:spcPct val="104000"/>
-              </a:lnSpc>
-            </a:pPr>
-            <a:r>
-              <a:rPr sz="3000" b="1" i="0">
-                <a:solidFill>
-                  <a:srgbClr val="21049A"/>
-                </a:solidFill>
-                <a:latin typeface="Roboto"/>
-              </a:rPr>
-              <a:t>Referências</a:t>
-            </a:r>
-          </a:p>
-        </p:txBody>
-      </p:sp>
-      <p:sp>
-        <p:nvSpPr>
-          <p:cNvPr id="4" name="Rectangle 3"/>
+              <a:t>Open Container Initiative. Runtime Spec, Image Spec e Distribution Spec. Linux Foundation, fundada em 2015.</a:t>
+            </a:r>
+          </a:p>
+        </p:txBody>
+      </p:sp>
+      <p:sp>
+        <p:nvSpPr>
+          <p:cNvPr id="6" name="Rectangle 5"/>
           <p:cNvSpPr/>
           <p:nvPr/>
         </p:nvSpPr>
         <p:spPr>
           <a:xfrm>
-            <a:off x="704850" y="2086166"/>
+            <a:off x="704850" y="2553652"/>
             <a:ext cx="57150" cy="57150"/>
           </a:xfrm>
           <a:prstGeom prst="rect">
@@ -29330,13 +28281,13 @@
       </p:sp>
       <p:sp>
         <p:nvSpPr>
-          <p:cNvPr id="5" name="TextBox 4"/>
+          <p:cNvPr id="7" name="TextBox 6"/>
           <p:cNvSpPr txBox="1"/>
           <p:nvPr/>
         </p:nvSpPr>
         <p:spPr>
           <a:xfrm>
-            <a:off x="971550" y="1992059"/>
+            <a:off x="971550" y="2459546"/>
             <a:ext cx="9677400" cy="95250"/>
           </a:xfrm>
           <a:prstGeom prst="rect">
@@ -29362,20 +28313,20 @@
                 </a:solidFill>
                 <a:latin typeface="Roboto"/>
               </a:rPr>
-              <a:t>Open Container Initiative. Runtime Spec, Image Spec e Distribution Spec. Linux Foundation, fundada em 2015.</a:t>
-            </a:r>
-          </a:p>
-        </p:txBody>
-      </p:sp>
-      <p:sp>
-        <p:nvSpPr>
-          <p:cNvPr id="6" name="Rectangle 5"/>
+              <a:t>WIGGINS, A. The Twelve-Factor App, 2011.</a:t>
+            </a:r>
+          </a:p>
+        </p:txBody>
+      </p:sp>
+      <p:sp>
+        <p:nvSpPr>
+          <p:cNvPr id="8" name="Rectangle 7"/>
           <p:cNvSpPr/>
           <p:nvPr/>
         </p:nvSpPr>
         <p:spPr>
           <a:xfrm>
-            <a:off x="704850" y="2553652"/>
+            <a:off x="704850" y="3021140"/>
             <a:ext cx="57150" cy="57150"/>
           </a:xfrm>
           <a:prstGeom prst="rect">
@@ -29413,13 +28364,13 @@
       </p:sp>
       <p:sp>
         <p:nvSpPr>
-          <p:cNvPr id="7" name="TextBox 6"/>
+          <p:cNvPr id="9" name="TextBox 8"/>
           <p:cNvSpPr txBox="1"/>
           <p:nvPr/>
         </p:nvSpPr>
         <p:spPr>
           <a:xfrm>
-            <a:off x="971550" y="2459546"/>
+            <a:off x="971550" y="2927032"/>
             <a:ext cx="9677400" cy="95250"/>
           </a:xfrm>
           <a:prstGeom prst="rect">
@@ -29445,20 +28396,20 @@
                 </a:solidFill>
                 <a:latin typeface="Roboto"/>
               </a:rPr>
-              <a:t>WIGGINS, A. The Twelve-Factor App, 2011.</a:t>
-            </a:r>
-          </a:p>
-        </p:txBody>
-      </p:sp>
-      <p:sp>
-        <p:nvSpPr>
-          <p:cNvPr id="8" name="Rectangle 7"/>
+              <a:t>FELTER, W. et al. An updated performance comparison of virtual machines and Linux containers. IBM Research Report, 2015.</a:t>
+            </a:r>
+          </a:p>
+        </p:txBody>
+      </p:sp>
+      <p:sp>
+        <p:nvSpPr>
+          <p:cNvPr id="10" name="Rectangle 9"/>
           <p:cNvSpPr/>
           <p:nvPr/>
         </p:nvSpPr>
         <p:spPr>
           <a:xfrm>
-            <a:off x="704850" y="3021140"/>
+            <a:off x="704850" y="3727514"/>
             <a:ext cx="57150" cy="57150"/>
           </a:xfrm>
           <a:prstGeom prst="rect">
@@ -29496,13 +28447,13 @@
       </p:sp>
       <p:sp>
         <p:nvSpPr>
-          <p:cNvPr id="9" name="TextBox 8"/>
+          <p:cNvPr id="11" name="TextBox 10"/>
           <p:cNvSpPr txBox="1"/>
           <p:nvPr/>
         </p:nvSpPr>
         <p:spPr>
           <a:xfrm>
-            <a:off x="971550" y="2927032"/>
+            <a:off x="971550" y="3633407"/>
             <a:ext cx="9677400" cy="95250"/>
           </a:xfrm>
           <a:prstGeom prst="rect">
@@ -29528,20 +28479,20 @@
                 </a:solidFill>
                 <a:latin typeface="Roboto"/>
               </a:rPr>
-              <a:t>FELTER, W. et al. An updated performance comparison of virtual machines and Linux containers. IBM Research Report, 2015.</a:t>
-            </a:r>
-          </a:p>
-        </p:txBody>
-      </p:sp>
-      <p:sp>
-        <p:nvSpPr>
-          <p:cNvPr id="10" name="Rectangle 9"/>
+              <a:t>MERKEL, D. Docker: lightweight Linux containers for consistent development and deployment. Linux Journal, 2014.</a:t>
+            </a:r>
+          </a:p>
+        </p:txBody>
+      </p:sp>
+      <p:sp>
+        <p:nvSpPr>
+          <p:cNvPr id="12" name="Rectangle 11"/>
           <p:cNvSpPr/>
           <p:nvPr/>
         </p:nvSpPr>
         <p:spPr>
           <a:xfrm>
-            <a:off x="704850" y="3727514"/>
+            <a:off x="704850" y="4195000"/>
             <a:ext cx="57150" cy="57150"/>
           </a:xfrm>
           <a:prstGeom prst="rect">
@@ -29579,13 +28530,13 @@
       </p:sp>
       <p:sp>
         <p:nvSpPr>
-          <p:cNvPr id="11" name="TextBox 10"/>
+          <p:cNvPr id="13" name="TextBox 12"/>
           <p:cNvSpPr txBox="1"/>
           <p:nvPr/>
         </p:nvSpPr>
         <p:spPr>
           <a:xfrm>
-            <a:off x="971550" y="3633407"/>
+            <a:off x="971550" y="4100894"/>
             <a:ext cx="9677400" cy="95250"/>
           </a:xfrm>
           <a:prstGeom prst="rect">
@@ -29611,20 +28562,20 @@
                 </a:solidFill>
                 <a:latin typeface="Roboto"/>
               </a:rPr>
-              <a:t>MERKEL, D. Docker: lightweight Linux containers for consistent development and deployment. Linux Journal, 2014.</a:t>
-            </a:r>
-          </a:p>
-        </p:txBody>
-      </p:sp>
-      <p:sp>
-        <p:nvSpPr>
-          <p:cNvPr id="12" name="Rectangle 11"/>
+              <a:t>NIST SP 800-190. Application Container Security Guide.</a:t>
+            </a:r>
+          </a:p>
+        </p:txBody>
+      </p:sp>
+      <p:sp>
+        <p:nvSpPr>
+          <p:cNvPr id="14" name="Rectangle 13"/>
           <p:cNvSpPr/>
           <p:nvPr/>
         </p:nvSpPr>
         <p:spPr>
           <a:xfrm>
-            <a:off x="704850" y="4195000"/>
+            <a:off x="704850" y="4662488"/>
             <a:ext cx="57150" cy="57150"/>
           </a:xfrm>
           <a:prstGeom prst="rect">
@@ -29662,13 +28613,13 @@
       </p:sp>
       <p:sp>
         <p:nvSpPr>
-          <p:cNvPr id="13" name="TextBox 12"/>
+          <p:cNvPr id="15" name="TextBox 14"/>
           <p:cNvSpPr txBox="1"/>
           <p:nvPr/>
         </p:nvSpPr>
         <p:spPr>
           <a:xfrm>
-            <a:off x="971550" y="4100894"/>
+            <a:off x="971550" y="4568380"/>
             <a:ext cx="9677400" cy="95250"/>
           </a:xfrm>
           <a:prstGeom prst="rect">
@@ -29694,20 +28645,20 @@
                 </a:solidFill>
                 <a:latin typeface="Roboto"/>
               </a:rPr>
-              <a:t>NIST SP 800-190. Application Container Security Guide.</a:t>
-            </a:r>
-          </a:p>
-        </p:txBody>
-      </p:sp>
-      <p:sp>
-        <p:nvSpPr>
-          <p:cNvPr id="14" name="Rectangle 13"/>
+              <a:t>SOMMERVILLE, I. Engenharia de Software. 6. ed. Addison Wesley, 2004.</a:t>
+            </a:r>
+          </a:p>
+        </p:txBody>
+      </p:sp>
+      <p:sp>
+        <p:nvSpPr>
+          <p:cNvPr id="16" name="Rectangle 15"/>
           <p:cNvSpPr/>
           <p:nvPr/>
         </p:nvSpPr>
         <p:spPr>
           <a:xfrm>
-            <a:off x="704850" y="4662488"/>
+            <a:off x="704850" y="5129974"/>
             <a:ext cx="57150" cy="57150"/>
           </a:xfrm>
           <a:prstGeom prst="rect">
@@ -29745,13 +28696,13 @@
       </p:sp>
       <p:sp>
         <p:nvSpPr>
-          <p:cNvPr id="15" name="TextBox 14"/>
+          <p:cNvPr id="17" name="TextBox 16"/>
           <p:cNvSpPr txBox="1"/>
           <p:nvPr/>
         </p:nvSpPr>
         <p:spPr>
           <a:xfrm>
-            <a:off x="971550" y="4568380"/>
+            <a:off x="971550" y="5035868"/>
             <a:ext cx="9677400" cy="95250"/>
           </a:xfrm>
           <a:prstGeom prst="rect">
@@ -29777,20 +28728,20 @@
                 </a:solidFill>
                 <a:latin typeface="Roboto"/>
               </a:rPr>
-              <a:t>SOMMERVILLE, I. Engenharia de Software. 6. ed. Addison Wesley, 2004.</a:t>
-            </a:r>
-          </a:p>
-        </p:txBody>
-      </p:sp>
-      <p:sp>
-        <p:nvSpPr>
-          <p:cNvPr id="16" name="Rectangle 15"/>
+              <a:t>FOWLER, M. Patterns of Enterprise Application Architecture. Addison Wesley, 2002.</a:t>
+            </a:r>
+          </a:p>
+        </p:txBody>
+      </p:sp>
+      <p:sp>
+        <p:nvSpPr>
+          <p:cNvPr id="18" name="Rectangle 17"/>
           <p:cNvSpPr/>
           <p:nvPr/>
         </p:nvSpPr>
         <p:spPr>
           <a:xfrm>
-            <a:off x="704850" y="5129974"/>
+            <a:off x="704850" y="5597462"/>
             <a:ext cx="57150" cy="57150"/>
           </a:xfrm>
           <a:prstGeom prst="rect">
@@ -29828,13 +28779,13 @@
       </p:sp>
       <p:sp>
         <p:nvSpPr>
-          <p:cNvPr id="17" name="TextBox 16"/>
+          <p:cNvPr id="19" name="TextBox 18"/>
           <p:cNvSpPr txBox="1"/>
           <p:nvPr/>
         </p:nvSpPr>
         <p:spPr>
           <a:xfrm>
-            <a:off x="971550" y="5035868"/>
+            <a:off x="971550" y="5503355"/>
             <a:ext cx="9677400" cy="95250"/>
           </a:xfrm>
           <a:prstGeom prst="rect">
@@ -29860,65 +28811,21 @@
                 </a:solidFill>
                 <a:latin typeface="Roboto"/>
               </a:rPr>
-              <a:t>FOWLER, M. Patterns of Enterprise Application Architecture. Addison Wesley, 2002.</a:t>
-            </a:r>
-          </a:p>
-        </p:txBody>
-      </p:sp>
-      <p:sp>
-        <p:nvSpPr>
-          <p:cNvPr id="18" name="Rectangle 17"/>
-          <p:cNvSpPr/>
-          <p:nvPr/>
-        </p:nvSpPr>
-        <p:spPr>
-          <a:xfrm>
-            <a:off x="704850" y="5597462"/>
-            <a:ext cx="57150" cy="57150"/>
-          </a:xfrm>
-          <a:prstGeom prst="rect">
-            <a:avLst/>
-          </a:prstGeom>
-          <a:solidFill>
-            <a:srgbClr val="E94D1C"/>
-          </a:solidFill>
-          <a:ln>
-            <a:noFill/>
-          </a:ln>
-          <a:effectLst/>
-        </p:spPr>
-        <p:style>
-          <a:lnRef idx="1">
-            <a:schemeClr val="accent1"/>
-          </a:lnRef>
-          <a:fillRef idx="3">
-            <a:schemeClr val="accent1"/>
-          </a:fillRef>
-          <a:effectRef idx="2">
-            <a:schemeClr val="accent1"/>
-          </a:effectRef>
-          <a:fontRef idx="minor">
-            <a:schemeClr val="lt1"/>
-          </a:fontRef>
-        </p:style>
-        <p:txBody>
-          <a:bodyPr rtlCol="0" anchor="ctr" wrap="square" lIns="0" rIns="0" tIns="0" bIns="0"/>
-          <a:lstStyle/>
-          <a:p>
-            <a:pPr algn="ctr"/>
-          </a:p>
-        </p:txBody>
-      </p:sp>
-      <p:sp>
-        <p:nvSpPr>
-          <p:cNvPr id="19" name="TextBox 18"/>
+              <a:t>FARIAS, K. Aula 03, Arquiteturas em Camadas. Aula 05, Arquiteturas Baseadas em Componentes.</a:t>
+            </a:r>
+          </a:p>
+        </p:txBody>
+      </p:sp>
+      <p:sp>
+        <p:nvSpPr>
+          <p:cNvPr id="20" name="TextBox 19"/>
           <p:cNvSpPr txBox="1"/>
           <p:nvPr/>
         </p:nvSpPr>
         <p:spPr>
           <a:xfrm>
-            <a:off x="971550" y="5503355"/>
-            <a:ext cx="9677400" cy="95250"/>
+            <a:off x="685800" y="6324600"/>
+            <a:ext cx="6667500" cy="182880"/>
           </a:xfrm>
           <a:prstGeom prst="rect">
             <a:avLst/>
@@ -29933,31 +28840,31 @@
           <a:p>
             <a:pPr algn="l">
               <a:lnSpc>
-                <a:spcPct val="130000"/>
+                <a:spcPct val="120000"/>
               </a:lnSpc>
             </a:pPr>
             <a:r>
-              <a:rPr sz="1420" b="0" i="0">
-                <a:solidFill>
-                  <a:srgbClr val="1A1A1E"/>
+              <a:rPr sz="900" b="0" i="0">
+                <a:solidFill>
+                  <a:srgbClr val="6B6B78"/>
                 </a:solidFill>
                 <a:latin typeface="Roboto"/>
               </a:rPr>
-              <a:t>FARIAS, K. Aula 03, Arquiteturas em Camadas. Aula 05, Arquiteturas Baseadas em Componentes.</a:t>
-            </a:r>
-          </a:p>
-        </p:txBody>
-      </p:sp>
-      <p:sp>
-        <p:nvSpPr>
-          <p:cNvPr id="20" name="TextBox 19"/>
+              <a:t>Referências</a:t>
+            </a:r>
+          </a:p>
+        </p:txBody>
+      </p:sp>
+      <p:sp>
+        <p:nvSpPr>
+          <p:cNvPr id="21" name="TextBox 20"/>
           <p:cNvSpPr txBox="1"/>
           <p:nvPr/>
         </p:nvSpPr>
         <p:spPr>
           <a:xfrm>
-            <a:off x="685800" y="6324600"/>
-            <a:ext cx="6667500" cy="182880"/>
+            <a:off x="10477500" y="6324600"/>
+            <a:ext cx="1028700" cy="182880"/>
           </a:xfrm>
           <a:prstGeom prst="rect">
             <a:avLst/>
@@ -29970,58 +28877,19 @@
           </a:bodyPr>
           <a:lstStyle/>
           <a:p>
-            <a:pPr algn="l">
+            <a:pPr algn="r">
               <a:lnSpc>
                 <a:spcPct val="120000"/>
               </a:lnSpc>
             </a:pPr>
             <a:r>
-              <a:rPr sz="900" b="0" i="0">
-                <a:solidFill>
-                  <a:srgbClr val="6B6B78"/>
+              <a:rPr sz="900" b="1" i="0">
+                <a:solidFill>
+                  <a:srgbClr val="21049A"/>
                 </a:solidFill>
                 <a:latin typeface="Roboto"/>
               </a:rPr>
-              <a:t>Referências</a:t>
-            </a:r>
-          </a:p>
-        </p:txBody>
-      </p:sp>
-      <p:sp>
-        <p:nvSpPr>
-          <p:cNvPr id="21" name="TextBox 20"/>
-          <p:cNvSpPr txBox="1"/>
-          <p:nvPr/>
-        </p:nvSpPr>
-        <p:spPr>
-          <a:xfrm>
-            <a:off x="10477500" y="6324600"/>
-            <a:ext cx="1028700" cy="182880"/>
-          </a:xfrm>
-          <a:prstGeom prst="rect">
-            <a:avLst/>
-          </a:prstGeom>
-          <a:noFill/>
-        </p:spPr>
-        <p:txBody>
-          <a:bodyPr wrap="square" lIns="0" rIns="0" tIns="0" bIns="0" anchor="t">
-            <a:spAutoFit/>
-          </a:bodyPr>
-          <a:lstStyle/>
-          <a:p>
-            <a:pPr algn="r">
-              <a:lnSpc>
-                <a:spcPct val="120000"/>
-              </a:lnSpc>
-            </a:pPr>
-            <a:r>
-              <a:rPr sz="900" b="1" i="0">
-                <a:solidFill>
-                  <a:srgbClr val="21049A"/>
-                </a:solidFill>
-                <a:latin typeface="Roboto"/>
-              </a:rPr>
-              <a:t>27</a:t>
+              <a:t>26</a:t>
             </a:r>
           </a:p>
         </p:txBody>

</xml_diff>